<commit_message>
Diapositiva 5: nuevo título sin suponer cero cédulas renovadas
Co-Authored-By: Claude Opus 5.5 <noreply@anthropic.com>
Claude-Session: https://claude.ai/code/session_01RrEJtrwRidXxzgveZEVQjf
</commit_message>
<xml_diff>
--- a/presentaciones/Plan_Estrategico_Pennsylvania_2028.pptx
+++ b/presentaciones/Plan_Estrategico_Pennsylvania_2028.pptx
@@ -116,27 +116,27 @@
   <p:extLst>
     <p:ext uri="{521415D9-36F7-43E2-AB2F-B90AF26B5E84}">
       <p14:sectionLst xmlns:p14="http://schemas.microsoft.com/office/powerpoint/2010/main">
-        <p14:section name="Diagnóstico" id="{d66b2256-4229-aa05-8082-cb69ff7fbe17}">
+        <p14:section name="Diagnóstico" id="{919cf088-f5c0-42e7-0f4e-535f43dfa251}">
           <p14:sldIdLst>
             <p14:sldId id="256"/>
             <p14:sldId id="257"/>
             <p14:sldId id="258"/>
           </p14:sldIdLst>
         </p14:section>
-        <p14:section name="Desafíos" id="{5905bb9d-b6a6-a375-7fa0-a35017e3eebc}">
+        <p14:section name="Desafíos" id="{2cfc1398-48d4-d350-576f-0345f826ec8e}">
           <p14:sldIdLst>
             <p14:sldId id="259"/>
             <p14:sldId id="260"/>
           </p14:sldIdLst>
         </p14:section>
-        <p14:section name="Escenarios y meta" id="{7c6b90c5-94c4-5724-6e08-5bb8b0ec7da0}">
+        <p14:section name="Escenarios y meta" id="{32c8c99f-f9c2-6c2a-4377-10e17fdab2ee}">
           <p14:sldIdLst>
             <p14:sldId id="261"/>
             <p14:sldId id="262"/>
             <p14:sldId id="263"/>
           </p14:sldIdLst>
         </p14:section>
-        <p14:section name="Plan y recomendación" id="{7030b1b4-d143-b86d-531e-c158e3514ca6}">
+        <p14:section name="Plan y recomendación" id="{b1969fd8-4de2-1a86-7be0-f2dafc8e96d5}">
           <p14:sldIdLst>
             <p14:sldId id="264"/>
             <p14:sldId id="265"/>
@@ -2093,7 +2093,7 @@
           <a:p>
             <a:r>
               <a:rPr lang="en-US" dirty="0"/>
-              <a:t>Ritmo: 47,529 electores entre ~65 semanas = unas 730 renovaciones semanales. Escenarios de habilitación: proyección propia sobre el padrón de la seccional. La JCE ya hizo operativos de empadronamiento en Lancaster y Lebanon en 2023; la entrega en el exterior se ampliará a más locales cuando los consulados obtengan autorización del Departamento de Estado.</a:t>
+              <a:t>No hay cifra pública de cédulas renovadas en Pennsylvania; a nivel nacional la JCE reporta 4,009,576 entregadas (45.9 % de 8,730,372) al 13 de octubre de 2026. Pedir el dato a la JCE y a los consulados de Filadelfia y Allentown y medirlo en la red 1+10. Escenarios de habilitación: proyección propia sobre el padrón de la seccional. La JCE ya hizo operativos de empadronamiento en Lancaster y Lebanon en 2023; la entrega en el exterior se ampliará a más locales cuando los consulados obtengan autorización del Departamento de Estado.</a:t>
             </a:r>
             <a:endParaRPr lang="en-US" dirty="0"/>
           </a:p>
@@ -6865,7 +6865,7 @@
                   <a:schemeClr val="tx2"/>
                 </a:solidFill>
               </a:rPr>
-              <a:t>Cada elector sin cédula nueva es un voto perdido: quedan 15 meses para habilitar a 47,529 personas</a:t>
+              <a:t>Cada elector sin cédula nueva es un voto perdido: la renovación en el exterior cierra en enero de 2028</a:t>
             </a:r>
             <a:endParaRPr lang="en-US" sz="2800" dirty="0"/>
           </a:p>
@@ -8133,7 +8133,7 @@
                   <a:schemeClr val="accent2"/>
                 </a:solidFill>
               </a:rPr>
-              <a:t>≈ 730 renovaciones por semana</a:t>
+              <a:t>Primer paso: medir el avance</a:t>
             </a:r>
             <a:endParaRPr lang="en-US" sz="2200" dirty="0"/>
           </a:p>
@@ -8147,7 +8147,7 @@
                   <a:schemeClr val="tx1"/>
                 </a:solidFill>
               </a:rPr>
-              <a:t>ritmo necesario hasta enero de 2028</a:t>
+              <a:t>No hay cifra pública de cuántos ya renovaron en PA. En todo el país va el 46 %.</a:t>
             </a:r>
             <a:endParaRPr lang="en-US" sz="2200" dirty="0"/>
           </a:p>
@@ -8179,7 +8179,7 @@
                   <a:schemeClr val="tx1"/>
                 </a:solidFill>
               </a:rPr>
-              <a:t>Pedir a la JCE operativos móviles en Hazleton, Reading y Lancaster</a:t>
+              <a:t>Pedir a la JCE y a los consulados el número de cédulas entregadas en PA</a:t>
             </a:r>
             <a:endParaRPr lang="en-US" sz="2200" dirty="0"/>
           </a:p>
@@ -8194,7 +8194,7 @@
                   <a:schemeClr val="tx1"/>
                 </a:solidFill>
               </a:rPr>
-              <a:t>Viajes en grupo con cita previa a Allentown y Philadelphia</a:t>
+              <a:t>Operativos móviles en Hazleton, Reading y Lancaster y viajes en grupo con cita</a:t>
             </a:r>
             <a:endParaRPr lang="en-US" sz="2200" dirty="0"/>
           </a:p>

</xml_diff>

<commit_message>
8 zonas y 8 coordinadores; diapositiva 8 más clara
Co-Authored-By: Claude Opus 5.5 <noreply@anthropic.com>
Claude-Session: https://claude.ai/code/session_01RrEJtrwRidXxzgveZEVQjf
</commit_message>
<xml_diff>
--- a/presentaciones/Plan_Estrategico_Pennsylvania_2028.pptx
+++ b/presentaciones/Plan_Estrategico_Pennsylvania_2028.pptx
@@ -116,27 +116,27 @@
   <p:extLst>
     <p:ext uri="{521415D9-36F7-43E2-AB2F-B90AF26B5E84}">
       <p14:sectionLst xmlns:p14="http://schemas.microsoft.com/office/powerpoint/2010/main">
-        <p14:section name="Diagnóstico" id="{919cf088-f5c0-42e7-0f4e-535f43dfa251}">
+        <p14:section name="Diagnóstico" id="{7a212d97-991f-be2b-58a4-5b468da9dfd3}">
           <p14:sldIdLst>
             <p14:sldId id="256"/>
             <p14:sldId id="257"/>
             <p14:sldId id="258"/>
           </p14:sldIdLst>
         </p14:section>
-        <p14:section name="Desafíos" id="{2cfc1398-48d4-d350-576f-0345f826ec8e}">
+        <p14:section name="Desafíos" id="{89861157-e670-38b2-3715-43d88a15551f}">
           <p14:sldIdLst>
             <p14:sldId id="259"/>
             <p14:sldId id="260"/>
           </p14:sldIdLst>
         </p14:section>
-        <p14:section name="Escenarios y meta" id="{32c8c99f-f9c2-6c2a-4377-10e17fdab2ee}">
+        <p14:section name="Escenarios y meta" id="{fb0d0a2c-8c75-ca6d-dce3-a68b3c69921c}">
           <p14:sldIdLst>
             <p14:sldId id="261"/>
             <p14:sldId id="262"/>
             <p14:sldId id="263"/>
           </p14:sldIdLst>
         </p14:section>
-        <p14:section name="Plan y recomendación" id="{b1969fd8-4de2-1a86-7be0-f2dafc8e96d5}">
+        <p14:section name="Plan y recomendación" id="{247711b7-f2cc-b41a-6d0f-040c2afb5d97}">
           <p14:sldIdLst>
             <p14:sldId id="264"/>
             <p14:sldId id="265"/>
@@ -2357,7 +2357,7 @@
           <a:p>
             <a:r>
               <a:rPr lang="en-US" dirty="0"/>
-              <a:t>Meta 1+10 de la seccional (CAD): 362 comités = 3,982 personas, calculada como 40 % de los votos emitidos por colegio, redondeado al comité completo. El reparto por zona es proporcional a los electores porque no hay votos por recinto; con los votos JCE por colegio se puede afinar. La agrupación en 6 zonas es una propuesta: ajustar si la seccional usa otra división.</a:t>
+              <a:t>Meta 1+10 de la seccional (CAD): 362 comités = 3,982 personas, calculada como 40 % de los votos emitidos por colegio, redondeado al comité completo. El reparto por zona es proporcional a los electores porque no hay votos por recinto; con los votos JCE por colegio se puede afinar. La agrupación en 8 zonas es una propuesta: ajustar si la seccional usa otra división.</a:t>
             </a:r>
             <a:endParaRPr lang="en-US" dirty="0"/>
           </a:p>
@@ -4011,7 +4011,7 @@
                   <a:schemeClr val="accent4"/>
                 </a:solidFill>
               </a:rPr>
-              <a:t>Consulados, remesas, vivienda e inversión; validarla en 6 encuentros de escucha</a:t>
+              <a:t>Consulados, remesas, vivienda e inversión; validarla en 8 encuentros de escucha</a:t>
             </a:r>
             <a:endParaRPr lang="en-US" sz="1600" dirty="0"/>
           </a:p>
@@ -4583,7 +4583,7 @@
                   <a:schemeClr val="tx2"/>
                 </a:solidFill>
               </a:rPr>
-              <a:t>Aprobar el plan, nombrar a los 6 coordinadores de zona e iniciar la Etapa 1 en noviembre.</a:t>
+              <a:t>Aprobar el plan, nombrar a los 8 coordinadores de zona e iniciar la Etapa 1 en noviembre.</a:t>
             </a:r>
             <a:endParaRPr lang="en-US" sz="1600" dirty="0"/>
           </a:p>
@@ -8931,7 +8931,7 @@
                 <a:gridCol w="1417320"/>
                 <a:gridCol w="1463040"/>
               </a:tblGrid>
-              <a:tr h="475488">
+              <a:tr h="411480">
                 <a:tc>
                   <a:txBody>
                     <a:bodyPr/>
@@ -9299,7 +9299,7 @@
                   </a:tcPr>
                 </a:tc>
               </a:tr>
-              <a:tr h="475488">
+              <a:tr h="411480">
                 <a:tc>
                   <a:txBody>
                     <a:bodyPr/>
@@ -9314,7 +9314,7 @@
                             <a:schemeClr val="tx1"/>
                           </a:solidFill>
                         </a:rPr>
-                        <a:t>Philadelphia</a:t>
+                        <a:t>Philadelphia Noreste</a:t>
                       </a:r>
                       <a:endParaRPr lang="en-US" sz="1300" dirty="0"/>
                     </a:p>
@@ -9372,7 +9372,7 @@
                             <a:schemeClr val="tx1"/>
                           </a:solidFill>
                         </a:rPr>
-                        <a:t>16,237</a:t>
+                        <a:t>9,649</a:t>
                       </a:r>
                       <a:endParaRPr lang="en-US" sz="1300" dirty="0"/>
                     </a:p>
@@ -9430,7 +9430,7 @@
                             <a:schemeClr val="tx1"/>
                           </a:solidFill>
                         </a:rPr>
-                        <a:t>2,984</a:t>
+                        <a:t>1,773</a:t>
                       </a:r>
                       <a:endParaRPr lang="en-US" sz="1300" dirty="0"/>
                     </a:p>
@@ -9546,7 +9546,7 @@
                             <a:schemeClr val="tx1"/>
                           </a:solidFill>
                         </a:rPr>
-                        <a:t>3,572 (+588)</a:t>
+                        <a:t>2,123 (+350)</a:t>
                       </a:r>
                       <a:endParaRPr lang="en-US" sz="1300" dirty="0"/>
                     </a:p>
@@ -9604,7 +9604,7 @@
                             <a:schemeClr val="tx1"/>
                           </a:solidFill>
                         </a:rPr>
-                        <a:t>4,059 (+1,075)</a:t>
+                        <a:t>2,412 (+639)</a:t>
                       </a:r>
                       <a:endParaRPr lang="en-US" sz="1300" dirty="0"/>
                     </a:p>
@@ -9649,7 +9649,357 @@
                   </a:tcPr>
                 </a:tc>
               </a:tr>
-              <a:tr h="475488">
+              <a:tr h="411480">
+                <a:tc>
+                  <a:txBody>
+                    <a:bodyPr/>
+                    <a:lstStyle/>
+                    <a:p>
+                      <a:pPr algn="l" indent="0" marL="0">
+                        <a:buNone/>
+                      </a:pPr>
+                      <a:r>
+                        <a:rPr lang="en-US" sz="1300" dirty="0">
+                          <a:solidFill>
+                            <a:schemeClr val="tx1"/>
+                          </a:solidFill>
+                        </a:rPr>
+                        <a:t>Philadelphia Kensington</a:t>
+                      </a:r>
+                      <a:endParaRPr lang="en-US" sz="1300" dirty="0"/>
+                    </a:p>
+                  </a:txBody>
+                  <a:tcPr marL="73152" marR="73152" marT="0" marB="0" anchor="ctr">
+                    <a:lnL w="9525" cap="flat" cmpd="sng" algn="ctr">
+                      <a:solidFill>
+                        <a:srgbClr val="EEF2F8"/>
+                      </a:solidFill>
+                      <a:prstDash val="solid"/>
+                      <a:round/>
+                      <a:headEnd type="none" w="med" len="med"/>
+                      <a:tailEnd type="none" w="med" len="med"/>
+                    </a:lnL>
+                    <a:lnR w="9525" cap="flat" cmpd="sng" algn="ctr">
+                      <a:solidFill>
+                        <a:srgbClr val="EEF2F8"/>
+                      </a:solidFill>
+                      <a:prstDash val="solid"/>
+                      <a:round/>
+                      <a:headEnd type="none" w="med" len="med"/>
+                      <a:tailEnd type="none" w="med" len="med"/>
+                    </a:lnR>
+                    <a:lnT w="9525" cap="flat" cmpd="sng" algn="ctr">
+                      <a:solidFill>
+                        <a:srgbClr val="EEF2F8"/>
+                      </a:solidFill>
+                      <a:prstDash val="solid"/>
+                      <a:round/>
+                      <a:headEnd type="none" w="med" len="med"/>
+                      <a:tailEnd type="none" w="med" len="med"/>
+                    </a:lnT>
+                    <a:lnB w="9525" cap="flat" cmpd="sng" algn="ctr">
+                      <a:solidFill>
+                        <a:srgbClr val="EEF2F8"/>
+                      </a:solidFill>
+                      <a:prstDash val="solid"/>
+                      <a:round/>
+                      <a:headEnd type="none" w="med" len="med"/>
+                      <a:tailEnd type="none" w="med" len="med"/>
+                    </a:lnB>
+                  </a:tcPr>
+                </a:tc>
+                <a:tc>
+                  <a:txBody>
+                    <a:bodyPr/>
+                    <a:lstStyle/>
+                    <a:p>
+                      <a:pPr algn="r" indent="0" marL="0">
+                        <a:buNone/>
+                      </a:pPr>
+                      <a:r>
+                        <a:rPr lang="en-US" sz="1300" dirty="0">
+                          <a:solidFill>
+                            <a:schemeClr val="tx1"/>
+                          </a:solidFill>
+                        </a:rPr>
+                        <a:t>6,588</a:t>
+                      </a:r>
+                      <a:endParaRPr lang="en-US" sz="1300" dirty="0"/>
+                    </a:p>
+                  </a:txBody>
+                  <a:tcPr marL="73152" marR="73152" marT="0" marB="0" anchor="ctr">
+                    <a:lnL w="9525" cap="flat" cmpd="sng" algn="ctr">
+                      <a:solidFill>
+                        <a:srgbClr val="EEF2F8"/>
+                      </a:solidFill>
+                      <a:prstDash val="solid"/>
+                      <a:round/>
+                      <a:headEnd type="none" w="med" len="med"/>
+                      <a:tailEnd type="none" w="med" len="med"/>
+                    </a:lnL>
+                    <a:lnR w="9525" cap="flat" cmpd="sng" algn="ctr">
+                      <a:solidFill>
+                        <a:srgbClr val="EEF2F8"/>
+                      </a:solidFill>
+                      <a:prstDash val="solid"/>
+                      <a:round/>
+                      <a:headEnd type="none" w="med" len="med"/>
+                      <a:tailEnd type="none" w="med" len="med"/>
+                    </a:lnR>
+                    <a:lnT w="9525" cap="flat" cmpd="sng" algn="ctr">
+                      <a:solidFill>
+                        <a:srgbClr val="EEF2F8"/>
+                      </a:solidFill>
+                      <a:prstDash val="solid"/>
+                      <a:round/>
+                      <a:headEnd type="none" w="med" len="med"/>
+                      <a:tailEnd type="none" w="med" len="med"/>
+                    </a:lnT>
+                    <a:lnB w="9525" cap="flat" cmpd="sng" algn="ctr">
+                      <a:solidFill>
+                        <a:srgbClr val="EEF2F8"/>
+                      </a:solidFill>
+                      <a:prstDash val="solid"/>
+                      <a:round/>
+                      <a:headEnd type="none" w="med" len="med"/>
+                      <a:tailEnd type="none" w="med" len="med"/>
+                    </a:lnB>
+                  </a:tcPr>
+                </a:tc>
+                <a:tc>
+                  <a:txBody>
+                    <a:bodyPr/>
+                    <a:lstStyle/>
+                    <a:p>
+                      <a:pPr algn="r" indent="0" marL="0">
+                        <a:buNone/>
+                      </a:pPr>
+                      <a:r>
+                        <a:rPr lang="en-US" sz="1300" dirty="0">
+                          <a:solidFill>
+                            <a:schemeClr val="tx1"/>
+                          </a:solidFill>
+                        </a:rPr>
+                        <a:t>1,210</a:t>
+                      </a:r>
+                      <a:endParaRPr lang="en-US" sz="1300" dirty="0"/>
+                    </a:p>
+                  </a:txBody>
+                  <a:tcPr marL="73152" marR="73152" marT="0" marB="0" anchor="ctr">
+                    <a:lnL w="9525" cap="flat" cmpd="sng" algn="ctr">
+                      <a:solidFill>
+                        <a:srgbClr val="EEF2F8"/>
+                      </a:solidFill>
+                      <a:prstDash val="solid"/>
+                      <a:round/>
+                      <a:headEnd type="none" w="med" len="med"/>
+                      <a:tailEnd type="none" w="med" len="med"/>
+                    </a:lnL>
+                    <a:lnR w="9525" cap="flat" cmpd="sng" algn="ctr">
+                      <a:solidFill>
+                        <a:srgbClr val="EEF2F8"/>
+                      </a:solidFill>
+                      <a:prstDash val="solid"/>
+                      <a:round/>
+                      <a:headEnd type="none" w="med" len="med"/>
+                      <a:tailEnd type="none" w="med" len="med"/>
+                    </a:lnR>
+                    <a:lnT w="9525" cap="flat" cmpd="sng" algn="ctr">
+                      <a:solidFill>
+                        <a:srgbClr val="EEF2F8"/>
+                      </a:solidFill>
+                      <a:prstDash val="solid"/>
+                      <a:round/>
+                      <a:headEnd type="none" w="med" len="med"/>
+                      <a:tailEnd type="none" w="med" len="med"/>
+                    </a:lnT>
+                    <a:lnB w="9525" cap="flat" cmpd="sng" algn="ctr">
+                      <a:solidFill>
+                        <a:srgbClr val="EEF2F8"/>
+                      </a:solidFill>
+                      <a:prstDash val="solid"/>
+                      <a:round/>
+                      <a:headEnd type="none" w="med" len="med"/>
+                      <a:tailEnd type="none" w="med" len="med"/>
+                    </a:lnB>
+                  </a:tcPr>
+                </a:tc>
+                <a:tc>
+                  <a:txBody>
+                    <a:bodyPr/>
+                    <a:lstStyle/>
+                    <a:p>
+                      <a:pPr algn="r" indent="0" marL="0">
+                        <a:buNone/>
+                      </a:pPr>
+                      <a:r>
+                        <a:rPr lang="en-US" sz="1300" dirty="0">
+                          <a:solidFill>
+                            <a:schemeClr val="tx1"/>
+                          </a:solidFill>
+                        </a:rPr>
+                        <a:t>81.6 %</a:t>
+                      </a:r>
+                      <a:endParaRPr lang="en-US" sz="1300" dirty="0"/>
+                    </a:p>
+                  </a:txBody>
+                  <a:tcPr marL="73152" marR="73152" marT="0" marB="0" anchor="ctr">
+                    <a:lnL w="9525" cap="flat" cmpd="sng" algn="ctr">
+                      <a:solidFill>
+                        <a:srgbClr val="EEF2F8"/>
+                      </a:solidFill>
+                      <a:prstDash val="solid"/>
+                      <a:round/>
+                      <a:headEnd type="none" w="med" len="med"/>
+                      <a:tailEnd type="none" w="med" len="med"/>
+                    </a:lnL>
+                    <a:lnR w="9525" cap="flat" cmpd="sng" algn="ctr">
+                      <a:solidFill>
+                        <a:srgbClr val="EEF2F8"/>
+                      </a:solidFill>
+                      <a:prstDash val="solid"/>
+                      <a:round/>
+                      <a:headEnd type="none" w="med" len="med"/>
+                      <a:tailEnd type="none" w="med" len="med"/>
+                    </a:lnR>
+                    <a:lnT w="9525" cap="flat" cmpd="sng" algn="ctr">
+                      <a:solidFill>
+                        <a:srgbClr val="EEF2F8"/>
+                      </a:solidFill>
+                      <a:prstDash val="solid"/>
+                      <a:round/>
+                      <a:headEnd type="none" w="med" len="med"/>
+                      <a:tailEnd type="none" w="med" len="med"/>
+                    </a:lnT>
+                    <a:lnB w="9525" cap="flat" cmpd="sng" algn="ctr">
+                      <a:solidFill>
+                        <a:srgbClr val="EEF2F8"/>
+                      </a:solidFill>
+                      <a:prstDash val="solid"/>
+                      <a:round/>
+                      <a:headEnd type="none" w="med" len="med"/>
+                      <a:tailEnd type="none" w="med" len="med"/>
+                    </a:lnB>
+                  </a:tcPr>
+                </a:tc>
+                <a:tc>
+                  <a:txBody>
+                    <a:bodyPr/>
+                    <a:lstStyle/>
+                    <a:p>
+                      <a:pPr algn="r" indent="0" marL="0">
+                        <a:buNone/>
+                      </a:pPr>
+                      <a:r>
+                        <a:rPr lang="en-US" sz="1300" dirty="0">
+                          <a:solidFill>
+                            <a:schemeClr val="tx1"/>
+                          </a:solidFill>
+                        </a:rPr>
+                        <a:t>1,449 (+239)</a:t>
+                      </a:r>
+                      <a:endParaRPr lang="en-US" sz="1300" dirty="0"/>
+                    </a:p>
+                  </a:txBody>
+                  <a:tcPr marL="73152" marR="73152" marT="0" marB="0" anchor="ctr">
+                    <a:lnL w="9525" cap="flat" cmpd="sng" algn="ctr">
+                      <a:solidFill>
+                        <a:srgbClr val="EEF2F8"/>
+                      </a:solidFill>
+                      <a:prstDash val="solid"/>
+                      <a:round/>
+                      <a:headEnd type="none" w="med" len="med"/>
+                      <a:tailEnd type="none" w="med" len="med"/>
+                    </a:lnL>
+                    <a:lnR w="9525" cap="flat" cmpd="sng" algn="ctr">
+                      <a:solidFill>
+                        <a:srgbClr val="EEF2F8"/>
+                      </a:solidFill>
+                      <a:prstDash val="solid"/>
+                      <a:round/>
+                      <a:headEnd type="none" w="med" len="med"/>
+                      <a:tailEnd type="none" w="med" len="med"/>
+                    </a:lnR>
+                    <a:lnT w="9525" cap="flat" cmpd="sng" algn="ctr">
+                      <a:solidFill>
+                        <a:srgbClr val="EEF2F8"/>
+                      </a:solidFill>
+                      <a:prstDash val="solid"/>
+                      <a:round/>
+                      <a:headEnd type="none" w="med" len="med"/>
+                      <a:tailEnd type="none" w="med" len="med"/>
+                    </a:lnT>
+                    <a:lnB w="9525" cap="flat" cmpd="sng" algn="ctr">
+                      <a:solidFill>
+                        <a:srgbClr val="EEF2F8"/>
+                      </a:solidFill>
+                      <a:prstDash val="solid"/>
+                      <a:round/>
+                      <a:headEnd type="none" w="med" len="med"/>
+                      <a:tailEnd type="none" w="med" len="med"/>
+                    </a:lnB>
+                  </a:tcPr>
+                </a:tc>
+                <a:tc>
+                  <a:txBody>
+                    <a:bodyPr/>
+                    <a:lstStyle/>
+                    <a:p>
+                      <a:pPr algn="r" indent="0" marL="0">
+                        <a:buNone/>
+                      </a:pPr>
+                      <a:r>
+                        <a:rPr lang="en-US" sz="1300" dirty="0">
+                          <a:solidFill>
+                            <a:schemeClr val="tx1"/>
+                          </a:solidFill>
+                        </a:rPr>
+                        <a:t>1,647 (+437)</a:t>
+                      </a:r>
+                      <a:endParaRPr lang="en-US" sz="1300" dirty="0"/>
+                    </a:p>
+                  </a:txBody>
+                  <a:tcPr marL="73152" marR="73152" marT="0" marB="0" anchor="ctr">
+                    <a:lnL w="9525" cap="flat" cmpd="sng" algn="ctr">
+                      <a:solidFill>
+                        <a:srgbClr val="EEF2F8"/>
+                      </a:solidFill>
+                      <a:prstDash val="solid"/>
+                      <a:round/>
+                      <a:headEnd type="none" w="med" len="med"/>
+                      <a:tailEnd type="none" w="med" len="med"/>
+                    </a:lnL>
+                    <a:lnR w="9525" cap="flat" cmpd="sng" algn="ctr">
+                      <a:solidFill>
+                        <a:srgbClr val="EEF2F8"/>
+                      </a:solidFill>
+                      <a:prstDash val="solid"/>
+                      <a:round/>
+                      <a:headEnd type="none" w="med" len="med"/>
+                      <a:tailEnd type="none" w="med" len="med"/>
+                    </a:lnR>
+                    <a:lnT w="9525" cap="flat" cmpd="sng" algn="ctr">
+                      <a:solidFill>
+                        <a:srgbClr val="EEF2F8"/>
+                      </a:solidFill>
+                      <a:prstDash val="solid"/>
+                      <a:round/>
+                      <a:headEnd type="none" w="med" len="med"/>
+                      <a:tailEnd type="none" w="med" len="med"/>
+                    </a:lnT>
+                    <a:lnB w="9525" cap="flat" cmpd="sng" algn="ctr">
+                      <a:solidFill>
+                        <a:srgbClr val="EEF2F8"/>
+                      </a:solidFill>
+                      <a:prstDash val="solid"/>
+                      <a:round/>
+                      <a:headEnd type="none" w="med" len="med"/>
+                      <a:tailEnd type="none" w="med" len="med"/>
+                    </a:lnB>
+                  </a:tcPr>
+                </a:tc>
+              </a:tr>
+              <a:tr h="411480">
                 <a:tc>
                   <a:txBody>
                     <a:bodyPr/>
@@ -9999,7 +10349,7 @@
                   </a:tcPr>
                 </a:tc>
               </a:tr>
-              <a:tr h="475488">
+              <a:tr h="411480">
                 <a:tc>
                   <a:txBody>
                     <a:bodyPr/>
@@ -10014,7 +10364,7 @@
                             <a:schemeClr val="tx1"/>
                           </a:solidFill>
                         </a:rPr>
-                        <a:t>Noreste</a:t>
+                        <a:t>Lehigh Valley (Allentown)</a:t>
                       </a:r>
                       <a:endParaRPr lang="en-US" sz="1300" dirty="0"/>
                     </a:p>
@@ -10072,7 +10422,7 @@
                             <a:schemeClr val="tx1"/>
                           </a:solidFill>
                         </a:rPr>
-                        <a:t>8,287</a:t>
+                        <a:t>8,183</a:t>
                       </a:r>
                       <a:endParaRPr lang="en-US" sz="1300" dirty="0"/>
                     </a:p>
@@ -10130,7 +10480,7 @@
                             <a:schemeClr val="tx1"/>
                           </a:solidFill>
                         </a:rPr>
-                        <a:t>1,522</a:t>
+                        <a:t>1,503</a:t>
                       </a:r>
                       <a:endParaRPr lang="en-US" sz="1300" dirty="0"/>
                     </a:p>
@@ -10246,7 +10596,7 @@
                             <a:schemeClr val="tx1"/>
                           </a:solidFill>
                         </a:rPr>
-                        <a:t>1,823 (+301)</a:t>
+                        <a:t>1,800 (+297)</a:t>
                       </a:r>
                       <a:endParaRPr lang="en-US" sz="1300" dirty="0"/>
                     </a:p>
@@ -10304,7 +10654,7 @@
                             <a:schemeClr val="tx1"/>
                           </a:solidFill>
                         </a:rPr>
-                        <a:t>2,072 (+550)</a:t>
+                        <a:t>2,046 (+543)</a:t>
                       </a:r>
                       <a:endParaRPr lang="en-US" sz="1300" dirty="0"/>
                     </a:p>
@@ -10349,7 +10699,7 @@
                   </a:tcPr>
                 </a:tc>
               </a:tr>
-              <a:tr h="475488">
+              <a:tr h="411480">
                 <a:tc>
                   <a:txBody>
                     <a:bodyPr/>
@@ -10364,7 +10714,7 @@
                             <a:schemeClr val="tx1"/>
                           </a:solidFill>
                         </a:rPr>
-                        <a:t>Lehigh Valley (Allentown)</a:t>
+                        <a:t>Hazleton</a:t>
                       </a:r>
                       <a:endParaRPr lang="en-US" sz="1300" dirty="0"/>
                     </a:p>
@@ -10422,7 +10772,7 @@
                             <a:schemeClr val="tx1"/>
                           </a:solidFill>
                         </a:rPr>
-                        <a:t>8,183</a:t>
+                        <a:t>6,520</a:t>
                       </a:r>
                       <a:endParaRPr lang="en-US" sz="1300" dirty="0"/>
                     </a:p>
@@ -10480,7 +10830,7 @@
                             <a:schemeClr val="tx1"/>
                           </a:solidFill>
                         </a:rPr>
-                        <a:t>1,503</a:t>
+                        <a:t>1,198</a:t>
                       </a:r>
                       <a:endParaRPr lang="en-US" sz="1300" dirty="0"/>
                     </a:p>
@@ -10596,7 +10946,7 @@
                             <a:schemeClr val="tx1"/>
                           </a:solidFill>
                         </a:rPr>
-                        <a:t>1,800 (+297)</a:t>
+                        <a:t>1,434 (+236)</a:t>
                       </a:r>
                       <a:endParaRPr lang="en-US" sz="1300" dirty="0"/>
                     </a:p>
@@ -10654,7 +11004,7 @@
                             <a:schemeClr val="tx1"/>
                           </a:solidFill>
                         </a:rPr>
-                        <a:t>2,046 (+543)</a:t>
+                        <a:t>1,630 (+432)</a:t>
                       </a:r>
                       <a:endParaRPr lang="en-US" sz="1300" dirty="0"/>
                     </a:p>
@@ -10699,7 +11049,357 @@
                   </a:tcPr>
                 </a:tc>
               </a:tr>
-              <a:tr h="475488">
+              <a:tr h="411480">
+                <a:tc>
+                  <a:txBody>
+                    <a:bodyPr/>
+                    <a:lstStyle/>
+                    <a:p>
+                      <a:pPr algn="l" indent="0" marL="0">
+                        <a:buNone/>
+                      </a:pPr>
+                      <a:r>
+                        <a:rPr lang="en-US" sz="1300" dirty="0">
+                          <a:solidFill>
+                            <a:schemeClr val="tx1"/>
+                          </a:solidFill>
+                        </a:rPr>
+                        <a:t>Wilkes-Barre y Scranton</a:t>
+                      </a:r>
+                      <a:endParaRPr lang="en-US" sz="1300" dirty="0"/>
+                    </a:p>
+                  </a:txBody>
+                  <a:tcPr marL="73152" marR="73152" marT="0" marB="0" anchor="ctr">
+                    <a:lnL w="9525" cap="flat" cmpd="sng" algn="ctr">
+                      <a:solidFill>
+                        <a:srgbClr val="EEF2F8"/>
+                      </a:solidFill>
+                      <a:prstDash val="solid"/>
+                      <a:round/>
+                      <a:headEnd type="none" w="med" len="med"/>
+                      <a:tailEnd type="none" w="med" len="med"/>
+                    </a:lnL>
+                    <a:lnR w="9525" cap="flat" cmpd="sng" algn="ctr">
+                      <a:solidFill>
+                        <a:srgbClr val="EEF2F8"/>
+                      </a:solidFill>
+                      <a:prstDash val="solid"/>
+                      <a:round/>
+                      <a:headEnd type="none" w="med" len="med"/>
+                      <a:tailEnd type="none" w="med" len="med"/>
+                    </a:lnR>
+                    <a:lnT w="9525" cap="flat" cmpd="sng" algn="ctr">
+                      <a:solidFill>
+                        <a:srgbClr val="EEF2F8"/>
+                      </a:solidFill>
+                      <a:prstDash val="solid"/>
+                      <a:round/>
+                      <a:headEnd type="none" w="med" len="med"/>
+                      <a:tailEnd type="none" w="med" len="med"/>
+                    </a:lnT>
+                    <a:lnB w="9525" cap="flat" cmpd="sng" algn="ctr">
+                      <a:solidFill>
+                        <a:srgbClr val="EEF2F8"/>
+                      </a:solidFill>
+                      <a:prstDash val="solid"/>
+                      <a:round/>
+                      <a:headEnd type="none" w="med" len="med"/>
+                      <a:tailEnd type="none" w="med" len="med"/>
+                    </a:lnB>
+                  </a:tcPr>
+                </a:tc>
+                <a:tc>
+                  <a:txBody>
+                    <a:bodyPr/>
+                    <a:lstStyle/>
+                    <a:p>
+                      <a:pPr algn="r" indent="0" marL="0">
+                        <a:buNone/>
+                      </a:pPr>
+                      <a:r>
+                        <a:rPr lang="en-US" sz="1300" dirty="0">
+                          <a:solidFill>
+                            <a:schemeClr val="tx1"/>
+                          </a:solidFill>
+                        </a:rPr>
+                        <a:t>1,767</a:t>
+                      </a:r>
+                      <a:endParaRPr lang="en-US" sz="1300" dirty="0"/>
+                    </a:p>
+                  </a:txBody>
+                  <a:tcPr marL="73152" marR="73152" marT="0" marB="0" anchor="ctr">
+                    <a:lnL w="9525" cap="flat" cmpd="sng" algn="ctr">
+                      <a:solidFill>
+                        <a:srgbClr val="EEF2F8"/>
+                      </a:solidFill>
+                      <a:prstDash val="solid"/>
+                      <a:round/>
+                      <a:headEnd type="none" w="med" len="med"/>
+                      <a:tailEnd type="none" w="med" len="med"/>
+                    </a:lnL>
+                    <a:lnR w="9525" cap="flat" cmpd="sng" algn="ctr">
+                      <a:solidFill>
+                        <a:srgbClr val="EEF2F8"/>
+                      </a:solidFill>
+                      <a:prstDash val="solid"/>
+                      <a:round/>
+                      <a:headEnd type="none" w="med" len="med"/>
+                      <a:tailEnd type="none" w="med" len="med"/>
+                    </a:lnR>
+                    <a:lnT w="9525" cap="flat" cmpd="sng" algn="ctr">
+                      <a:solidFill>
+                        <a:srgbClr val="EEF2F8"/>
+                      </a:solidFill>
+                      <a:prstDash val="solid"/>
+                      <a:round/>
+                      <a:headEnd type="none" w="med" len="med"/>
+                      <a:tailEnd type="none" w="med" len="med"/>
+                    </a:lnT>
+                    <a:lnB w="9525" cap="flat" cmpd="sng" algn="ctr">
+                      <a:solidFill>
+                        <a:srgbClr val="EEF2F8"/>
+                      </a:solidFill>
+                      <a:prstDash val="solid"/>
+                      <a:round/>
+                      <a:headEnd type="none" w="med" len="med"/>
+                      <a:tailEnd type="none" w="med" len="med"/>
+                    </a:lnB>
+                  </a:tcPr>
+                </a:tc>
+                <a:tc>
+                  <a:txBody>
+                    <a:bodyPr/>
+                    <a:lstStyle/>
+                    <a:p>
+                      <a:pPr algn="r" indent="0" marL="0">
+                        <a:buNone/>
+                      </a:pPr>
+                      <a:r>
+                        <a:rPr lang="en-US" sz="1300" dirty="0">
+                          <a:solidFill>
+                            <a:schemeClr val="tx1"/>
+                          </a:solidFill>
+                        </a:rPr>
+                        <a:t>325</a:t>
+                      </a:r>
+                      <a:endParaRPr lang="en-US" sz="1300" dirty="0"/>
+                    </a:p>
+                  </a:txBody>
+                  <a:tcPr marL="73152" marR="73152" marT="0" marB="0" anchor="ctr">
+                    <a:lnL w="9525" cap="flat" cmpd="sng" algn="ctr">
+                      <a:solidFill>
+                        <a:srgbClr val="EEF2F8"/>
+                      </a:solidFill>
+                      <a:prstDash val="solid"/>
+                      <a:round/>
+                      <a:headEnd type="none" w="med" len="med"/>
+                      <a:tailEnd type="none" w="med" len="med"/>
+                    </a:lnL>
+                    <a:lnR w="9525" cap="flat" cmpd="sng" algn="ctr">
+                      <a:solidFill>
+                        <a:srgbClr val="EEF2F8"/>
+                      </a:solidFill>
+                      <a:prstDash val="solid"/>
+                      <a:round/>
+                      <a:headEnd type="none" w="med" len="med"/>
+                      <a:tailEnd type="none" w="med" len="med"/>
+                    </a:lnR>
+                    <a:lnT w="9525" cap="flat" cmpd="sng" algn="ctr">
+                      <a:solidFill>
+                        <a:srgbClr val="EEF2F8"/>
+                      </a:solidFill>
+                      <a:prstDash val="solid"/>
+                      <a:round/>
+                      <a:headEnd type="none" w="med" len="med"/>
+                      <a:tailEnd type="none" w="med" len="med"/>
+                    </a:lnT>
+                    <a:lnB w="9525" cap="flat" cmpd="sng" algn="ctr">
+                      <a:solidFill>
+                        <a:srgbClr val="EEF2F8"/>
+                      </a:solidFill>
+                      <a:prstDash val="solid"/>
+                      <a:round/>
+                      <a:headEnd type="none" w="med" len="med"/>
+                      <a:tailEnd type="none" w="med" len="med"/>
+                    </a:lnB>
+                  </a:tcPr>
+                </a:tc>
+                <a:tc>
+                  <a:txBody>
+                    <a:bodyPr/>
+                    <a:lstStyle/>
+                    <a:p>
+                      <a:pPr algn="r" indent="0" marL="0">
+                        <a:buNone/>
+                      </a:pPr>
+                      <a:r>
+                        <a:rPr lang="en-US" sz="1300" dirty="0">
+                          <a:solidFill>
+                            <a:schemeClr val="tx1"/>
+                          </a:solidFill>
+                        </a:rPr>
+                        <a:t>81.6 %</a:t>
+                      </a:r>
+                      <a:endParaRPr lang="en-US" sz="1300" dirty="0"/>
+                    </a:p>
+                  </a:txBody>
+                  <a:tcPr marL="73152" marR="73152" marT="0" marB="0" anchor="ctr">
+                    <a:lnL w="9525" cap="flat" cmpd="sng" algn="ctr">
+                      <a:solidFill>
+                        <a:srgbClr val="EEF2F8"/>
+                      </a:solidFill>
+                      <a:prstDash val="solid"/>
+                      <a:round/>
+                      <a:headEnd type="none" w="med" len="med"/>
+                      <a:tailEnd type="none" w="med" len="med"/>
+                    </a:lnL>
+                    <a:lnR w="9525" cap="flat" cmpd="sng" algn="ctr">
+                      <a:solidFill>
+                        <a:srgbClr val="EEF2F8"/>
+                      </a:solidFill>
+                      <a:prstDash val="solid"/>
+                      <a:round/>
+                      <a:headEnd type="none" w="med" len="med"/>
+                      <a:tailEnd type="none" w="med" len="med"/>
+                    </a:lnR>
+                    <a:lnT w="9525" cap="flat" cmpd="sng" algn="ctr">
+                      <a:solidFill>
+                        <a:srgbClr val="EEF2F8"/>
+                      </a:solidFill>
+                      <a:prstDash val="solid"/>
+                      <a:round/>
+                      <a:headEnd type="none" w="med" len="med"/>
+                      <a:tailEnd type="none" w="med" len="med"/>
+                    </a:lnT>
+                    <a:lnB w="9525" cap="flat" cmpd="sng" algn="ctr">
+                      <a:solidFill>
+                        <a:srgbClr val="EEF2F8"/>
+                      </a:solidFill>
+                      <a:prstDash val="solid"/>
+                      <a:round/>
+                      <a:headEnd type="none" w="med" len="med"/>
+                      <a:tailEnd type="none" w="med" len="med"/>
+                    </a:lnB>
+                  </a:tcPr>
+                </a:tc>
+                <a:tc>
+                  <a:txBody>
+                    <a:bodyPr/>
+                    <a:lstStyle/>
+                    <a:p>
+                      <a:pPr algn="r" indent="0" marL="0">
+                        <a:buNone/>
+                      </a:pPr>
+                      <a:r>
+                        <a:rPr lang="en-US" sz="1300" dirty="0">
+                          <a:solidFill>
+                            <a:schemeClr val="tx1"/>
+                          </a:solidFill>
+                        </a:rPr>
+                        <a:t>389 (+64)</a:t>
+                      </a:r>
+                      <a:endParaRPr lang="en-US" sz="1300" dirty="0"/>
+                    </a:p>
+                  </a:txBody>
+                  <a:tcPr marL="73152" marR="73152" marT="0" marB="0" anchor="ctr">
+                    <a:lnL w="9525" cap="flat" cmpd="sng" algn="ctr">
+                      <a:solidFill>
+                        <a:srgbClr val="EEF2F8"/>
+                      </a:solidFill>
+                      <a:prstDash val="solid"/>
+                      <a:round/>
+                      <a:headEnd type="none" w="med" len="med"/>
+                      <a:tailEnd type="none" w="med" len="med"/>
+                    </a:lnL>
+                    <a:lnR w="9525" cap="flat" cmpd="sng" algn="ctr">
+                      <a:solidFill>
+                        <a:srgbClr val="EEF2F8"/>
+                      </a:solidFill>
+                      <a:prstDash val="solid"/>
+                      <a:round/>
+                      <a:headEnd type="none" w="med" len="med"/>
+                      <a:tailEnd type="none" w="med" len="med"/>
+                    </a:lnR>
+                    <a:lnT w="9525" cap="flat" cmpd="sng" algn="ctr">
+                      <a:solidFill>
+                        <a:srgbClr val="EEF2F8"/>
+                      </a:solidFill>
+                      <a:prstDash val="solid"/>
+                      <a:round/>
+                      <a:headEnd type="none" w="med" len="med"/>
+                      <a:tailEnd type="none" w="med" len="med"/>
+                    </a:lnT>
+                    <a:lnB w="9525" cap="flat" cmpd="sng" algn="ctr">
+                      <a:solidFill>
+                        <a:srgbClr val="EEF2F8"/>
+                      </a:solidFill>
+                      <a:prstDash val="solid"/>
+                      <a:round/>
+                      <a:headEnd type="none" w="med" len="med"/>
+                      <a:tailEnd type="none" w="med" len="med"/>
+                    </a:lnB>
+                  </a:tcPr>
+                </a:tc>
+                <a:tc>
+                  <a:txBody>
+                    <a:bodyPr/>
+                    <a:lstStyle/>
+                    <a:p>
+                      <a:pPr algn="r" indent="0" marL="0">
+                        <a:buNone/>
+                      </a:pPr>
+                      <a:r>
+                        <a:rPr lang="en-US" sz="1300" dirty="0">
+                          <a:solidFill>
+                            <a:schemeClr val="tx1"/>
+                          </a:solidFill>
+                        </a:rPr>
+                        <a:t>442 (+117)</a:t>
+                      </a:r>
+                      <a:endParaRPr lang="en-US" sz="1300" dirty="0"/>
+                    </a:p>
+                  </a:txBody>
+                  <a:tcPr marL="73152" marR="73152" marT="0" marB="0" anchor="ctr">
+                    <a:lnL w="9525" cap="flat" cmpd="sng" algn="ctr">
+                      <a:solidFill>
+                        <a:srgbClr val="EEF2F8"/>
+                      </a:solidFill>
+                      <a:prstDash val="solid"/>
+                      <a:round/>
+                      <a:headEnd type="none" w="med" len="med"/>
+                      <a:tailEnd type="none" w="med" len="med"/>
+                    </a:lnL>
+                    <a:lnR w="9525" cap="flat" cmpd="sng" algn="ctr">
+                      <a:solidFill>
+                        <a:srgbClr val="EEF2F8"/>
+                      </a:solidFill>
+                      <a:prstDash val="solid"/>
+                      <a:round/>
+                      <a:headEnd type="none" w="med" len="med"/>
+                      <a:tailEnd type="none" w="med" len="med"/>
+                    </a:lnR>
+                    <a:lnT w="9525" cap="flat" cmpd="sng" algn="ctr">
+                      <a:solidFill>
+                        <a:srgbClr val="EEF2F8"/>
+                      </a:solidFill>
+                      <a:prstDash val="solid"/>
+                      <a:round/>
+                      <a:headEnd type="none" w="med" len="med"/>
+                      <a:tailEnd type="none" w="med" len="med"/>
+                    </a:lnT>
+                    <a:lnB w="9525" cap="flat" cmpd="sng" algn="ctr">
+                      <a:solidFill>
+                        <a:srgbClr val="EEF2F8"/>
+                      </a:solidFill>
+                      <a:prstDash val="solid"/>
+                      <a:round/>
+                      <a:headEnd type="none" w="med" len="med"/>
+                      <a:tailEnd type="none" w="med" len="med"/>
+                    </a:lnB>
+                  </a:tcPr>
+                </a:tc>
+              </a:tr>
+              <a:tr h="411480">
                 <a:tc>
                   <a:txBody>
                     <a:bodyPr/>
@@ -11049,7 +11749,7 @@
                   </a:tcPr>
                 </a:tc>
               </a:tr>
-              <a:tr h="475488">
+              <a:tr h="411480">
                 <a:tc>
                   <a:txBody>
                     <a:bodyPr/>
@@ -11399,7 +12099,7 @@
                   </a:tcPr>
                 </a:tc>
               </a:tr>
-              <a:tr h="475488">
+              <a:tr h="411480">
                 <a:tc>
                   <a:txBody>
                     <a:bodyPr/>
@@ -12100,7 +12800,7 @@
                   <a:schemeClr val="tx2"/>
                 </a:solidFill>
               </a:rPr>
-              <a:t>3,982 personas en 362 comités: cada zona sabe cuántas personas debe organizar</a:t>
+              <a:t>Meta de organización: 362 equipos de 11 personas (3,982 en total) repartidos en 8 zonas</a:t>
             </a:r>
             <a:endParaRPr lang="en-US" sz="2800" dirty="0"/>
           </a:p>
@@ -12135,7 +12835,7 @@
                 <a:gridCol w="960120"/>
                 <a:gridCol w="1188720"/>
               </a:tblGrid>
-              <a:tr h="475488">
+              <a:tr h="411480">
                 <a:tc>
                   <a:txBody>
                     <a:bodyPr/>
@@ -12145,14 +12845,14 @@
                         <a:buNone/>
                       </a:pPr>
                       <a:r>
-                        <a:rPr lang="en-US" sz="1400" b="1" dirty="0">
+                        <a:rPr lang="en-US" sz="1300" b="1" dirty="0">
                           <a:solidFill>
                             <a:schemeClr val="bg1"/>
                           </a:solidFill>
                         </a:rPr>
                         <a:t>Zona</a:t>
                       </a:r>
-                      <a:endParaRPr lang="en-US" sz="1400" dirty="0"/>
+                      <a:endParaRPr lang="en-US" sz="1300" dirty="0"/>
                     </a:p>
                   </a:txBody>
                   <a:tcPr marL="91440" marR="91440" marT="0" marB="0" anchor="ctr">
@@ -12206,14 +12906,14 @@
                         <a:buNone/>
                       </a:pPr>
                       <a:r>
-                        <a:rPr lang="en-US" sz="1400" b="1" dirty="0">
+                        <a:rPr lang="en-US" sz="1300" b="1" dirty="0">
                           <a:solidFill>
                             <a:schemeClr val="bg1"/>
                           </a:solidFill>
                         </a:rPr>
                         <a:t>Mesas</a:t>
                       </a:r>
-                      <a:endParaRPr lang="en-US" sz="1400" dirty="0"/>
+                      <a:endParaRPr lang="en-US" sz="1300" dirty="0"/>
                     </a:p>
                   </a:txBody>
                   <a:tcPr marL="91440" marR="91440" marT="0" marB="0" anchor="ctr">
@@ -12267,14 +12967,14 @@
                         <a:buNone/>
                       </a:pPr>
                       <a:r>
-                        <a:rPr lang="en-US" sz="1400" b="1" dirty="0">
+                        <a:rPr lang="en-US" sz="1300" b="1" dirty="0">
                           <a:solidFill>
                             <a:schemeClr val="bg1"/>
                           </a:solidFill>
                         </a:rPr>
                         <a:t>Electores</a:t>
                       </a:r>
-                      <a:endParaRPr lang="en-US" sz="1400" dirty="0"/>
+                      <a:endParaRPr lang="en-US" sz="1300" dirty="0"/>
                     </a:p>
                   </a:txBody>
                   <a:tcPr marL="91440" marR="91440" marT="0" marB="0" anchor="ctr">
@@ -12328,14 +13028,14 @@
                         <a:buNone/>
                       </a:pPr>
                       <a:r>
-                        <a:rPr lang="en-US" sz="1400" b="1" dirty="0">
+                        <a:rPr lang="en-US" sz="1300" b="1" dirty="0">
                           <a:solidFill>
                             <a:schemeClr val="bg1"/>
                           </a:solidFill>
                         </a:rPr>
-                        <a:t>Comités</a:t>
+                        <a:t>Equipos 1+10</a:t>
                       </a:r>
-                      <a:endParaRPr lang="en-US" sz="1400" dirty="0"/>
+                      <a:endParaRPr lang="en-US" sz="1300" dirty="0"/>
                     </a:p>
                   </a:txBody>
                   <a:tcPr marL="91440" marR="91440" marT="0" marB="0" anchor="ctr">
@@ -12389,14 +13089,14 @@
                         <a:buNone/>
                       </a:pPr>
                       <a:r>
-                        <a:rPr lang="en-US" sz="1400" b="1" dirty="0">
+                        <a:rPr lang="en-US" sz="1300" b="1" dirty="0">
                           <a:solidFill>
                             <a:schemeClr val="bg1"/>
                           </a:solidFill>
                         </a:rPr>
-                        <a:t>Personas 1+10</a:t>
+                        <a:t>Personas</a:t>
                       </a:r>
-                      <a:endParaRPr lang="en-US" sz="1400" dirty="0"/>
+                      <a:endParaRPr lang="en-US" sz="1300" dirty="0"/>
                     </a:p>
                   </a:txBody>
                   <a:tcPr marL="91440" marR="91440" marT="0" marB="0" anchor="ctr">
@@ -12442,7 +13142,7 @@
                   </a:tcPr>
                 </a:tc>
               </a:tr>
-              <a:tr h="475488">
+              <a:tr h="411480">
                 <a:tc>
                   <a:txBody>
                     <a:bodyPr/>
@@ -12452,14 +13152,14 @@
                         <a:buNone/>
                       </a:pPr>
                       <a:r>
-                        <a:rPr lang="en-US" sz="1400" dirty="0">
+                        <a:rPr lang="en-US" sz="1300" dirty="0">
                           <a:solidFill>
                             <a:schemeClr val="tx1"/>
                           </a:solidFill>
                         </a:rPr>
-                        <a:t>Philadelphia</a:t>
+                        <a:t>Philadelphia Noreste (3 recintos)</a:t>
                       </a:r>
-                      <a:endParaRPr lang="en-US" sz="1400" dirty="0"/>
+                      <a:endParaRPr lang="en-US" sz="1300" dirty="0"/>
                     </a:p>
                   </a:txBody>
                   <a:tcPr marL="91440" marR="91440" marT="0" marB="0" anchor="ctr">
@@ -12510,14 +13210,14 @@
                         <a:buNone/>
                       </a:pPr>
                       <a:r>
-                        <a:rPr lang="en-US" sz="1400" dirty="0">
+                        <a:rPr lang="en-US" sz="1300" dirty="0">
                           <a:solidFill>
                             <a:schemeClr val="tx1"/>
                           </a:solidFill>
                         </a:rPr>
-                        <a:t>28</a:t>
+                        <a:t>17</a:t>
                       </a:r>
-                      <a:endParaRPr lang="en-US" sz="1400" dirty="0"/>
+                      <a:endParaRPr lang="en-US" sz="1300" dirty="0"/>
                     </a:p>
                   </a:txBody>
                   <a:tcPr marL="91440" marR="91440" marT="0" marB="0" anchor="ctr">
@@ -12568,14 +13268,14 @@
                         <a:buNone/>
                       </a:pPr>
                       <a:r>
-                        <a:rPr lang="en-US" sz="1400" dirty="0">
+                        <a:rPr lang="en-US" sz="1300" dirty="0">
                           <a:solidFill>
                             <a:schemeClr val="tx1"/>
                           </a:solidFill>
                         </a:rPr>
-                        <a:t>16,237</a:t>
+                        <a:t>9,649</a:t>
                       </a:r>
-                      <a:endParaRPr lang="en-US" sz="1400" dirty="0"/>
+                      <a:endParaRPr lang="en-US" sz="1300" dirty="0"/>
                     </a:p>
                   </a:txBody>
                   <a:tcPr marL="91440" marR="91440" marT="0" marB="0" anchor="ctr">
@@ -12626,14 +13326,14 @@
                         <a:buNone/>
                       </a:pPr>
                       <a:r>
-                        <a:rPr lang="en-US" sz="1400" dirty="0">
+                        <a:rPr lang="en-US" sz="1300" dirty="0">
                           <a:solidFill>
                             <a:schemeClr val="tx1"/>
                           </a:solidFill>
                         </a:rPr>
-                        <a:t>124</a:t>
+                        <a:t>73</a:t>
                       </a:r>
-                      <a:endParaRPr lang="en-US" sz="1400" dirty="0"/>
+                      <a:endParaRPr lang="en-US" sz="1300" dirty="0"/>
                     </a:p>
                   </a:txBody>
                   <a:tcPr marL="91440" marR="91440" marT="0" marB="0" anchor="ctr">
@@ -12684,14 +13384,14 @@
                         <a:buNone/>
                       </a:pPr>
                       <a:r>
-                        <a:rPr lang="en-US" sz="1400" dirty="0">
+                        <a:rPr lang="en-US" sz="1300" dirty="0">
                           <a:solidFill>
                             <a:schemeClr val="tx1"/>
                           </a:solidFill>
                         </a:rPr>
-                        <a:t>1,364</a:t>
+                        <a:t>803</a:t>
                       </a:r>
-                      <a:endParaRPr lang="en-US" sz="1400" dirty="0"/>
+                      <a:endParaRPr lang="en-US" sz="1300" dirty="0"/>
                     </a:p>
                   </a:txBody>
                   <a:tcPr marL="91440" marR="91440" marT="0" marB="0" anchor="ctr">
@@ -12734,7 +13434,7 @@
                   </a:tcPr>
                 </a:tc>
               </a:tr>
-              <a:tr h="475488">
+              <a:tr h="411480">
                 <a:tc>
                   <a:txBody>
                     <a:bodyPr/>
@@ -12744,14 +13444,14 @@
                         <a:buNone/>
                       </a:pPr>
                       <a:r>
-                        <a:rPr lang="en-US" sz="1400" dirty="0">
+                        <a:rPr lang="en-US" sz="1300" dirty="0">
                           <a:solidFill>
                             <a:schemeClr val="tx1"/>
                           </a:solidFill>
                         </a:rPr>
-                        <a:t>Berks (Reading)</a:t>
+                        <a:t>Philadelphia Kensington (2 recintos)</a:t>
                       </a:r>
-                      <a:endParaRPr lang="en-US" sz="1400" dirty="0"/>
+                      <a:endParaRPr lang="en-US" sz="1300" dirty="0"/>
                     </a:p>
                   </a:txBody>
                   <a:tcPr marL="91440" marR="91440" marT="0" marB="0" anchor="ctr">
@@ -12802,14 +13502,14 @@
                         <a:buNone/>
                       </a:pPr>
                       <a:r>
-                        <a:rPr lang="en-US" sz="1400" dirty="0">
+                        <a:rPr lang="en-US" sz="1300" dirty="0">
                           <a:solidFill>
                             <a:schemeClr val="tx1"/>
                           </a:solidFill>
                         </a:rPr>
-                        <a:t>15</a:t>
+                        <a:t>11</a:t>
                       </a:r>
-                      <a:endParaRPr lang="en-US" sz="1400" dirty="0"/>
+                      <a:endParaRPr lang="en-US" sz="1300" dirty="0"/>
                     </a:p>
                   </a:txBody>
                   <a:tcPr marL="91440" marR="91440" marT="0" marB="0" anchor="ctr">
@@ -12860,14 +13560,14 @@
                         <a:buNone/>
                       </a:pPr>
                       <a:r>
-                        <a:rPr lang="en-US" sz="1400" dirty="0">
+                        <a:rPr lang="en-US" sz="1300" dirty="0">
                           <a:solidFill>
                             <a:schemeClr val="tx1"/>
                           </a:solidFill>
                         </a:rPr>
-                        <a:t>8,368</a:t>
+                        <a:t>6,588</a:t>
                       </a:r>
-                      <a:endParaRPr lang="en-US" sz="1400" dirty="0"/>
+                      <a:endParaRPr lang="en-US" sz="1300" dirty="0"/>
                     </a:p>
                   </a:txBody>
                   <a:tcPr marL="91440" marR="91440" marT="0" marB="0" anchor="ctr">
@@ -12918,14 +13618,14 @@
                         <a:buNone/>
                       </a:pPr>
                       <a:r>
-                        <a:rPr lang="en-US" sz="1400" dirty="0">
+                        <a:rPr lang="en-US" sz="1300" dirty="0">
                           <a:solidFill>
                             <a:schemeClr val="tx1"/>
                           </a:solidFill>
                         </a:rPr>
-                        <a:t>64</a:t>
+                        <a:t>50</a:t>
                       </a:r>
-                      <a:endParaRPr lang="en-US" sz="1400" dirty="0"/>
+                      <a:endParaRPr lang="en-US" sz="1300" dirty="0"/>
                     </a:p>
                   </a:txBody>
                   <a:tcPr marL="91440" marR="91440" marT="0" marB="0" anchor="ctr">
@@ -12976,14 +13676,14 @@
                         <a:buNone/>
                       </a:pPr>
                       <a:r>
-                        <a:rPr lang="en-US" sz="1400" dirty="0">
+                        <a:rPr lang="en-US" sz="1300" dirty="0">
                           <a:solidFill>
                             <a:schemeClr val="tx1"/>
                           </a:solidFill>
                         </a:rPr>
-                        <a:t>704</a:t>
+                        <a:t>550</a:t>
                       </a:r>
-                      <a:endParaRPr lang="en-US" sz="1400" dirty="0"/>
+                      <a:endParaRPr lang="en-US" sz="1300" dirty="0"/>
                     </a:p>
                   </a:txBody>
                   <a:tcPr marL="91440" marR="91440" marT="0" marB="0" anchor="ctr">
@@ -13026,7 +13726,7 @@
                   </a:tcPr>
                 </a:tc>
               </a:tr>
-              <a:tr h="475488">
+              <a:tr h="411480">
                 <a:tc>
                   <a:txBody>
                     <a:bodyPr/>
@@ -13036,14 +13736,14 @@
                         <a:buNone/>
                       </a:pPr>
                       <a:r>
-                        <a:rPr lang="en-US" sz="1400" dirty="0">
+                        <a:rPr lang="en-US" sz="1300" dirty="0">
                           <a:solidFill>
                             <a:schemeClr val="tx1"/>
                           </a:solidFill>
                         </a:rPr>
-                        <a:t>Noreste (Hazleton, Wilkes-Barre, Scranton)</a:t>
+                        <a:t>Berks (Reading)</a:t>
                       </a:r>
-                      <a:endParaRPr lang="en-US" sz="1400" dirty="0"/>
+                      <a:endParaRPr lang="en-US" sz="1300" dirty="0"/>
                     </a:p>
                   </a:txBody>
                   <a:tcPr marL="91440" marR="91440" marT="0" marB="0" anchor="ctr">
@@ -13094,14 +13794,14 @@
                         <a:buNone/>
                       </a:pPr>
                       <a:r>
-                        <a:rPr lang="en-US" sz="1400" dirty="0">
+                        <a:rPr lang="en-US" sz="1300" dirty="0">
                           <a:solidFill>
                             <a:schemeClr val="tx1"/>
                           </a:solidFill>
                         </a:rPr>
                         <a:t>15</a:t>
                       </a:r>
-                      <a:endParaRPr lang="en-US" sz="1400" dirty="0"/>
+                      <a:endParaRPr lang="en-US" sz="1300" dirty="0"/>
                     </a:p>
                   </a:txBody>
                   <a:tcPr marL="91440" marR="91440" marT="0" marB="0" anchor="ctr">
@@ -13152,14 +13852,14 @@
                         <a:buNone/>
                       </a:pPr>
                       <a:r>
-                        <a:rPr lang="en-US" sz="1400" dirty="0">
+                        <a:rPr lang="en-US" sz="1300" dirty="0">
                           <a:solidFill>
                             <a:schemeClr val="tx1"/>
                           </a:solidFill>
                         </a:rPr>
-                        <a:t>8,287</a:t>
+                        <a:t>8,368</a:t>
                       </a:r>
-                      <a:endParaRPr lang="en-US" sz="1400" dirty="0"/>
+                      <a:endParaRPr lang="en-US" sz="1300" dirty="0"/>
                     </a:p>
                   </a:txBody>
                   <a:tcPr marL="91440" marR="91440" marT="0" marB="0" anchor="ctr">
@@ -13210,14 +13910,14 @@
                         <a:buNone/>
                       </a:pPr>
                       <a:r>
-                        <a:rPr lang="en-US" sz="1400" dirty="0">
+                        <a:rPr lang="en-US" sz="1300" dirty="0">
                           <a:solidFill>
                             <a:schemeClr val="tx1"/>
                           </a:solidFill>
                         </a:rPr>
-                        <a:t>63</a:t>
+                        <a:t>64</a:t>
                       </a:r>
-                      <a:endParaRPr lang="en-US" sz="1400" dirty="0"/>
+                      <a:endParaRPr lang="en-US" sz="1300" dirty="0"/>
                     </a:p>
                   </a:txBody>
                   <a:tcPr marL="91440" marR="91440" marT="0" marB="0" anchor="ctr">
@@ -13268,14 +13968,14 @@
                         <a:buNone/>
                       </a:pPr>
                       <a:r>
-                        <a:rPr lang="en-US" sz="1400" dirty="0">
+                        <a:rPr lang="en-US" sz="1300" dirty="0">
                           <a:solidFill>
                             <a:schemeClr val="tx1"/>
                           </a:solidFill>
                         </a:rPr>
-                        <a:t>693</a:t>
+                        <a:t>704</a:t>
                       </a:r>
-                      <a:endParaRPr lang="en-US" sz="1400" dirty="0"/>
+                      <a:endParaRPr lang="en-US" sz="1300" dirty="0"/>
                     </a:p>
                   </a:txBody>
                   <a:tcPr marL="91440" marR="91440" marT="0" marB="0" anchor="ctr">
@@ -13318,7 +14018,7 @@
                   </a:tcPr>
                 </a:tc>
               </a:tr>
-              <a:tr h="475488">
+              <a:tr h="411480">
                 <a:tc>
                   <a:txBody>
                     <a:bodyPr/>
@@ -13328,14 +14028,14 @@
                         <a:buNone/>
                       </a:pPr>
                       <a:r>
-                        <a:rPr lang="en-US" sz="1400" dirty="0">
+                        <a:rPr lang="en-US" sz="1300" dirty="0">
                           <a:solidFill>
                             <a:schemeClr val="tx1"/>
                           </a:solidFill>
                         </a:rPr>
                         <a:t>Lehigh Valley (Allentown)</a:t>
                       </a:r>
-                      <a:endParaRPr lang="en-US" sz="1400" dirty="0"/>
+                      <a:endParaRPr lang="en-US" sz="1300" dirty="0"/>
                     </a:p>
                   </a:txBody>
                   <a:tcPr marL="91440" marR="91440" marT="0" marB="0" anchor="ctr">
@@ -13386,14 +14086,14 @@
                         <a:buNone/>
                       </a:pPr>
                       <a:r>
-                        <a:rPr lang="en-US" sz="1400" dirty="0">
+                        <a:rPr lang="en-US" sz="1300" dirty="0">
                           <a:solidFill>
                             <a:schemeClr val="tx1"/>
                           </a:solidFill>
                         </a:rPr>
                         <a:t>14</a:t>
                       </a:r>
-                      <a:endParaRPr lang="en-US" sz="1400" dirty="0"/>
+                      <a:endParaRPr lang="en-US" sz="1300" dirty="0"/>
                     </a:p>
                   </a:txBody>
                   <a:tcPr marL="91440" marR="91440" marT="0" marB="0" anchor="ctr">
@@ -13444,14 +14144,14 @@
                         <a:buNone/>
                       </a:pPr>
                       <a:r>
-                        <a:rPr lang="en-US" sz="1400" dirty="0">
+                        <a:rPr lang="en-US" sz="1300" dirty="0">
                           <a:solidFill>
                             <a:schemeClr val="tx1"/>
                           </a:solidFill>
                         </a:rPr>
                         <a:t>8,183</a:t>
                       </a:r>
-                      <a:endParaRPr lang="en-US" sz="1400" dirty="0"/>
+                      <a:endParaRPr lang="en-US" sz="1300" dirty="0"/>
                     </a:p>
                   </a:txBody>
                   <a:tcPr marL="91440" marR="91440" marT="0" marB="0" anchor="ctr">
@@ -13502,14 +14202,14 @@
                         <a:buNone/>
                       </a:pPr>
                       <a:r>
-                        <a:rPr lang="en-US" sz="1400" dirty="0">
+                        <a:rPr lang="en-US" sz="1300" dirty="0">
                           <a:solidFill>
                             <a:schemeClr val="tx1"/>
                           </a:solidFill>
                         </a:rPr>
                         <a:t>62</a:t>
                       </a:r>
-                      <a:endParaRPr lang="en-US" sz="1400" dirty="0"/>
+                      <a:endParaRPr lang="en-US" sz="1300" dirty="0"/>
                     </a:p>
                   </a:txBody>
                   <a:tcPr marL="91440" marR="91440" marT="0" marB="0" anchor="ctr">
@@ -13560,14 +14260,14 @@
                         <a:buNone/>
                       </a:pPr>
                       <a:r>
-                        <a:rPr lang="en-US" sz="1400" dirty="0">
+                        <a:rPr lang="en-US" sz="1300" dirty="0">
                           <a:solidFill>
                             <a:schemeClr val="tx1"/>
                           </a:solidFill>
                         </a:rPr>
                         <a:t>682</a:t>
                       </a:r>
-                      <a:endParaRPr lang="en-US" sz="1400" dirty="0"/>
+                      <a:endParaRPr lang="en-US" sz="1300" dirty="0"/>
                     </a:p>
                   </a:txBody>
                   <a:tcPr marL="91440" marR="91440" marT="0" marB="0" anchor="ctr">
@@ -13610,7 +14310,7 @@
                   </a:tcPr>
                 </a:tc>
               </a:tr>
-              <a:tr h="475488">
+              <a:tr h="411480">
                 <a:tc>
                   <a:txBody>
                     <a:bodyPr/>
@@ -13620,14 +14320,14 @@
                         <a:buNone/>
                       </a:pPr>
                       <a:r>
-                        <a:rPr lang="en-US" sz="1400" dirty="0">
+                        <a:rPr lang="en-US" sz="1300" dirty="0">
                           <a:solidFill>
                             <a:schemeClr val="tx1"/>
                           </a:solidFill>
                         </a:rPr>
-                        <a:t>Centro-Sur (Harrisburg, Lancaster, York, Lebanon)</a:t>
+                        <a:t>Hazleton</a:t>
                       </a:r>
-                      <a:endParaRPr lang="en-US" sz="1400" dirty="0"/>
+                      <a:endParaRPr lang="en-US" sz="1300" dirty="0"/>
                     </a:p>
                   </a:txBody>
                   <a:tcPr marL="91440" marR="91440" marT="0" marB="0" anchor="ctr">
@@ -13678,14 +14378,14 @@
                         <a:buNone/>
                       </a:pPr>
                       <a:r>
-                        <a:rPr lang="en-US" sz="1400" dirty="0">
+                        <a:rPr lang="en-US" sz="1300" dirty="0">
                           <a:solidFill>
                             <a:schemeClr val="tx1"/>
                           </a:solidFill>
                         </a:rPr>
-                        <a:t>10</a:t>
+                        <a:t>11</a:t>
                       </a:r>
-                      <a:endParaRPr lang="en-US" sz="1400" dirty="0"/>
+                      <a:endParaRPr lang="en-US" sz="1300" dirty="0"/>
                     </a:p>
                   </a:txBody>
                   <a:tcPr marL="91440" marR="91440" marT="0" marB="0" anchor="ctr">
@@ -13736,14 +14436,14 @@
                         <a:buNone/>
                       </a:pPr>
                       <a:r>
-                        <a:rPr lang="en-US" sz="1400" dirty="0">
+                        <a:rPr lang="en-US" sz="1300" dirty="0">
                           <a:solidFill>
                             <a:schemeClr val="tx1"/>
                           </a:solidFill>
                         </a:rPr>
-                        <a:t>5,450</a:t>
+                        <a:t>6,520</a:t>
                       </a:r>
-                      <a:endParaRPr lang="en-US" sz="1400" dirty="0"/>
+                      <a:endParaRPr lang="en-US" sz="1300" dirty="0"/>
                     </a:p>
                   </a:txBody>
                   <a:tcPr marL="91440" marR="91440" marT="0" marB="0" anchor="ctr">
@@ -13794,14 +14494,14 @@
                         <a:buNone/>
                       </a:pPr>
                       <a:r>
-                        <a:rPr lang="en-US" sz="1400" dirty="0">
+                        <a:rPr lang="en-US" sz="1300" dirty="0">
                           <a:solidFill>
                             <a:schemeClr val="tx1"/>
                           </a:solidFill>
                         </a:rPr>
-                        <a:t>41</a:t>
+                        <a:t>50</a:t>
                       </a:r>
-                      <a:endParaRPr lang="en-US" sz="1400" dirty="0"/>
+                      <a:endParaRPr lang="en-US" sz="1300" dirty="0"/>
                     </a:p>
                   </a:txBody>
                   <a:tcPr marL="91440" marR="91440" marT="0" marB="0" anchor="ctr">
@@ -13852,14 +14552,14 @@
                         <a:buNone/>
                       </a:pPr>
                       <a:r>
-                        <a:rPr lang="en-US" sz="1400" dirty="0">
+                        <a:rPr lang="en-US" sz="1300" dirty="0">
                           <a:solidFill>
                             <a:schemeClr val="tx1"/>
                           </a:solidFill>
                         </a:rPr>
-                        <a:t>451</a:t>
+                        <a:t>550</a:t>
                       </a:r>
-                      <a:endParaRPr lang="en-US" sz="1400" dirty="0"/>
+                      <a:endParaRPr lang="en-US" sz="1300" dirty="0"/>
                     </a:p>
                   </a:txBody>
                   <a:tcPr marL="91440" marR="91440" marT="0" marB="0" anchor="ctr">
@@ -13902,7 +14602,7 @@
                   </a:tcPr>
                 </a:tc>
               </a:tr>
-              <a:tr h="475488">
+              <a:tr h="411480">
                 <a:tc>
                   <a:txBody>
                     <a:bodyPr/>
@@ -13912,14 +14612,14 @@
                         <a:buNone/>
                       </a:pPr>
                       <a:r>
-                        <a:rPr lang="en-US" sz="1400" dirty="0">
+                        <a:rPr lang="en-US" sz="1300" dirty="0">
                           <a:solidFill>
                             <a:schemeClr val="tx1"/>
                           </a:solidFill>
                         </a:rPr>
-                        <a:t>Delaware (Wilmington)</a:t>
+                        <a:t>Wilkes-Barre y Scranton</a:t>
                       </a:r>
-                      <a:endParaRPr lang="en-US" sz="1400" dirty="0"/>
+                      <a:endParaRPr lang="en-US" sz="1300" dirty="0"/>
                     </a:p>
                   </a:txBody>
                   <a:tcPr marL="91440" marR="91440" marT="0" marB="0" anchor="ctr">
@@ -13970,14 +14670,14 @@
                         <a:buNone/>
                       </a:pPr>
                       <a:r>
-                        <a:rPr lang="en-US" sz="1400" dirty="0">
+                        <a:rPr lang="en-US" sz="1300" dirty="0">
                           <a:solidFill>
                             <a:schemeClr val="tx1"/>
                           </a:solidFill>
                         </a:rPr>
-                        <a:t>2</a:t>
+                        <a:t>4</a:t>
                       </a:r>
-                      <a:endParaRPr lang="en-US" sz="1400" dirty="0"/>
+                      <a:endParaRPr lang="en-US" sz="1300" dirty="0"/>
                     </a:p>
                   </a:txBody>
                   <a:tcPr marL="91440" marR="91440" marT="0" marB="0" anchor="ctr">
@@ -14028,14 +14728,14 @@
                         <a:buNone/>
                       </a:pPr>
                       <a:r>
-                        <a:rPr lang="en-US" sz="1400" dirty="0">
+                        <a:rPr lang="en-US" sz="1300" dirty="0">
                           <a:solidFill>
                             <a:schemeClr val="tx1"/>
                           </a:solidFill>
                         </a:rPr>
-                        <a:t>1,004</a:t>
+                        <a:t>1,767</a:t>
                       </a:r>
-                      <a:endParaRPr lang="en-US" sz="1400" dirty="0"/>
+                      <a:endParaRPr lang="en-US" sz="1300" dirty="0"/>
                     </a:p>
                   </a:txBody>
                   <a:tcPr marL="91440" marR="91440" marT="0" marB="0" anchor="ctr">
@@ -14086,14 +14786,14 @@
                         <a:buNone/>
                       </a:pPr>
                       <a:r>
-                        <a:rPr lang="en-US" sz="1400" dirty="0">
+                        <a:rPr lang="en-US" sz="1300" dirty="0">
                           <a:solidFill>
                             <a:schemeClr val="tx1"/>
                           </a:solidFill>
                         </a:rPr>
-                        <a:t>8</a:t>
+                        <a:t>13</a:t>
                       </a:r>
-                      <a:endParaRPr lang="en-US" sz="1400" dirty="0"/>
+                      <a:endParaRPr lang="en-US" sz="1300" dirty="0"/>
                     </a:p>
                   </a:txBody>
                   <a:tcPr marL="91440" marR="91440" marT="0" marB="0" anchor="ctr">
@@ -14144,14 +14844,14 @@
                         <a:buNone/>
                       </a:pPr>
                       <a:r>
-                        <a:rPr lang="en-US" sz="1400" dirty="0">
+                        <a:rPr lang="en-US" sz="1300" dirty="0">
                           <a:solidFill>
                             <a:schemeClr val="tx1"/>
                           </a:solidFill>
                         </a:rPr>
-                        <a:t>88</a:t>
+                        <a:t>143</a:t>
                       </a:r>
-                      <a:endParaRPr lang="en-US" sz="1400" dirty="0"/>
+                      <a:endParaRPr lang="en-US" sz="1300" dirty="0"/>
                     </a:p>
                   </a:txBody>
                   <a:tcPr marL="91440" marR="91440" marT="0" marB="0" anchor="ctr">
@@ -14194,7 +14894,7 @@
                   </a:tcPr>
                 </a:tc>
               </a:tr>
-              <a:tr h="475488">
+              <a:tr h="411480">
                 <a:tc>
                   <a:txBody>
                     <a:bodyPr/>
@@ -14204,14 +14904,598 @@
                         <a:buNone/>
                       </a:pPr>
                       <a:r>
-                        <a:rPr lang="en-US" sz="1400" b="1" dirty="0">
+                        <a:rPr lang="en-US" sz="1300" dirty="0">
+                          <a:solidFill>
+                            <a:schemeClr val="tx1"/>
+                          </a:solidFill>
+                        </a:rPr>
+                        <a:t>Centro-Sur (Harrisburg, Lancaster, York, Lebanon)</a:t>
+                      </a:r>
+                      <a:endParaRPr lang="en-US" sz="1300" dirty="0"/>
+                    </a:p>
+                  </a:txBody>
+                  <a:tcPr marL="91440" marR="91440" marT="0" marB="0" anchor="ctr">
+                    <a:lnL w="9525" cap="flat" cmpd="sng" algn="ctr">
+                      <a:solidFill>
+                        <a:srgbClr val="EEF2F8"/>
+                      </a:solidFill>
+                      <a:prstDash val="solid"/>
+                      <a:round/>
+                      <a:headEnd type="none" w="med" len="med"/>
+                      <a:tailEnd type="none" w="med" len="med"/>
+                    </a:lnL>
+                    <a:lnR w="9525" cap="flat" cmpd="sng" algn="ctr">
+                      <a:solidFill>
+                        <a:srgbClr val="EEF2F8"/>
+                      </a:solidFill>
+                      <a:prstDash val="solid"/>
+                      <a:round/>
+                      <a:headEnd type="none" w="med" len="med"/>
+                      <a:tailEnd type="none" w="med" len="med"/>
+                    </a:lnR>
+                    <a:lnT w="9525" cap="flat" cmpd="sng" algn="ctr">
+                      <a:solidFill>
+                        <a:srgbClr val="EEF2F8"/>
+                      </a:solidFill>
+                      <a:prstDash val="solid"/>
+                      <a:round/>
+                      <a:headEnd type="none" w="med" len="med"/>
+                      <a:tailEnd type="none" w="med" len="med"/>
+                    </a:lnT>
+                    <a:lnB w="9525" cap="flat" cmpd="sng" algn="ctr">
+                      <a:solidFill>
+                        <a:srgbClr val="EEF2F8"/>
+                      </a:solidFill>
+                      <a:prstDash val="solid"/>
+                      <a:round/>
+                      <a:headEnd type="none" w="med" len="med"/>
+                      <a:tailEnd type="none" w="med" len="med"/>
+                    </a:lnB>
+                  </a:tcPr>
+                </a:tc>
+                <a:tc>
+                  <a:txBody>
+                    <a:bodyPr/>
+                    <a:lstStyle/>
+                    <a:p>
+                      <a:pPr algn="r" indent="0" marL="0">
+                        <a:buNone/>
+                      </a:pPr>
+                      <a:r>
+                        <a:rPr lang="en-US" sz="1300" dirty="0">
+                          <a:solidFill>
+                            <a:schemeClr val="tx1"/>
+                          </a:solidFill>
+                        </a:rPr>
+                        <a:t>10</a:t>
+                      </a:r>
+                      <a:endParaRPr lang="en-US" sz="1300" dirty="0"/>
+                    </a:p>
+                  </a:txBody>
+                  <a:tcPr marL="91440" marR="91440" marT="0" marB="0" anchor="ctr">
+                    <a:lnL w="9525" cap="flat" cmpd="sng" algn="ctr">
+                      <a:solidFill>
+                        <a:srgbClr val="EEF2F8"/>
+                      </a:solidFill>
+                      <a:prstDash val="solid"/>
+                      <a:round/>
+                      <a:headEnd type="none" w="med" len="med"/>
+                      <a:tailEnd type="none" w="med" len="med"/>
+                    </a:lnL>
+                    <a:lnR w="9525" cap="flat" cmpd="sng" algn="ctr">
+                      <a:solidFill>
+                        <a:srgbClr val="EEF2F8"/>
+                      </a:solidFill>
+                      <a:prstDash val="solid"/>
+                      <a:round/>
+                      <a:headEnd type="none" w="med" len="med"/>
+                      <a:tailEnd type="none" w="med" len="med"/>
+                    </a:lnR>
+                    <a:lnT w="9525" cap="flat" cmpd="sng" algn="ctr">
+                      <a:solidFill>
+                        <a:srgbClr val="EEF2F8"/>
+                      </a:solidFill>
+                      <a:prstDash val="solid"/>
+                      <a:round/>
+                      <a:headEnd type="none" w="med" len="med"/>
+                      <a:tailEnd type="none" w="med" len="med"/>
+                    </a:lnT>
+                    <a:lnB w="9525" cap="flat" cmpd="sng" algn="ctr">
+                      <a:solidFill>
+                        <a:srgbClr val="EEF2F8"/>
+                      </a:solidFill>
+                      <a:prstDash val="solid"/>
+                      <a:round/>
+                      <a:headEnd type="none" w="med" len="med"/>
+                      <a:tailEnd type="none" w="med" len="med"/>
+                    </a:lnB>
+                  </a:tcPr>
+                </a:tc>
+                <a:tc>
+                  <a:txBody>
+                    <a:bodyPr/>
+                    <a:lstStyle/>
+                    <a:p>
+                      <a:pPr algn="r" indent="0" marL="0">
+                        <a:buNone/>
+                      </a:pPr>
+                      <a:r>
+                        <a:rPr lang="en-US" sz="1300" dirty="0">
+                          <a:solidFill>
+                            <a:schemeClr val="tx1"/>
+                          </a:solidFill>
+                        </a:rPr>
+                        <a:t>5,450</a:t>
+                      </a:r>
+                      <a:endParaRPr lang="en-US" sz="1300" dirty="0"/>
+                    </a:p>
+                  </a:txBody>
+                  <a:tcPr marL="91440" marR="91440" marT="0" marB="0" anchor="ctr">
+                    <a:lnL w="9525" cap="flat" cmpd="sng" algn="ctr">
+                      <a:solidFill>
+                        <a:srgbClr val="EEF2F8"/>
+                      </a:solidFill>
+                      <a:prstDash val="solid"/>
+                      <a:round/>
+                      <a:headEnd type="none" w="med" len="med"/>
+                      <a:tailEnd type="none" w="med" len="med"/>
+                    </a:lnL>
+                    <a:lnR w="9525" cap="flat" cmpd="sng" algn="ctr">
+                      <a:solidFill>
+                        <a:srgbClr val="EEF2F8"/>
+                      </a:solidFill>
+                      <a:prstDash val="solid"/>
+                      <a:round/>
+                      <a:headEnd type="none" w="med" len="med"/>
+                      <a:tailEnd type="none" w="med" len="med"/>
+                    </a:lnR>
+                    <a:lnT w="9525" cap="flat" cmpd="sng" algn="ctr">
+                      <a:solidFill>
+                        <a:srgbClr val="EEF2F8"/>
+                      </a:solidFill>
+                      <a:prstDash val="solid"/>
+                      <a:round/>
+                      <a:headEnd type="none" w="med" len="med"/>
+                      <a:tailEnd type="none" w="med" len="med"/>
+                    </a:lnT>
+                    <a:lnB w="9525" cap="flat" cmpd="sng" algn="ctr">
+                      <a:solidFill>
+                        <a:srgbClr val="EEF2F8"/>
+                      </a:solidFill>
+                      <a:prstDash val="solid"/>
+                      <a:round/>
+                      <a:headEnd type="none" w="med" len="med"/>
+                      <a:tailEnd type="none" w="med" len="med"/>
+                    </a:lnB>
+                  </a:tcPr>
+                </a:tc>
+                <a:tc>
+                  <a:txBody>
+                    <a:bodyPr/>
+                    <a:lstStyle/>
+                    <a:p>
+                      <a:pPr algn="r" indent="0" marL="0">
+                        <a:buNone/>
+                      </a:pPr>
+                      <a:r>
+                        <a:rPr lang="en-US" sz="1300" dirty="0">
+                          <a:solidFill>
+                            <a:schemeClr val="tx1"/>
+                          </a:solidFill>
+                        </a:rPr>
+                        <a:t>42</a:t>
+                      </a:r>
+                      <a:endParaRPr lang="en-US" sz="1300" dirty="0"/>
+                    </a:p>
+                  </a:txBody>
+                  <a:tcPr marL="91440" marR="91440" marT="0" marB="0" anchor="ctr">
+                    <a:lnL w="9525" cap="flat" cmpd="sng" algn="ctr">
+                      <a:solidFill>
+                        <a:srgbClr val="EEF2F8"/>
+                      </a:solidFill>
+                      <a:prstDash val="solid"/>
+                      <a:round/>
+                      <a:headEnd type="none" w="med" len="med"/>
+                      <a:tailEnd type="none" w="med" len="med"/>
+                    </a:lnL>
+                    <a:lnR w="9525" cap="flat" cmpd="sng" algn="ctr">
+                      <a:solidFill>
+                        <a:srgbClr val="EEF2F8"/>
+                      </a:solidFill>
+                      <a:prstDash val="solid"/>
+                      <a:round/>
+                      <a:headEnd type="none" w="med" len="med"/>
+                      <a:tailEnd type="none" w="med" len="med"/>
+                    </a:lnR>
+                    <a:lnT w="9525" cap="flat" cmpd="sng" algn="ctr">
+                      <a:solidFill>
+                        <a:srgbClr val="EEF2F8"/>
+                      </a:solidFill>
+                      <a:prstDash val="solid"/>
+                      <a:round/>
+                      <a:headEnd type="none" w="med" len="med"/>
+                      <a:tailEnd type="none" w="med" len="med"/>
+                    </a:lnT>
+                    <a:lnB w="9525" cap="flat" cmpd="sng" algn="ctr">
+                      <a:solidFill>
+                        <a:srgbClr val="EEF2F8"/>
+                      </a:solidFill>
+                      <a:prstDash val="solid"/>
+                      <a:round/>
+                      <a:headEnd type="none" w="med" len="med"/>
+                      <a:tailEnd type="none" w="med" len="med"/>
+                    </a:lnB>
+                  </a:tcPr>
+                </a:tc>
+                <a:tc>
+                  <a:txBody>
+                    <a:bodyPr/>
+                    <a:lstStyle/>
+                    <a:p>
+                      <a:pPr algn="r" indent="0" marL="0">
+                        <a:buNone/>
+                      </a:pPr>
+                      <a:r>
+                        <a:rPr lang="en-US" sz="1300" dirty="0">
+                          <a:solidFill>
+                            <a:schemeClr val="tx1"/>
+                          </a:solidFill>
+                        </a:rPr>
+                        <a:t>462</a:t>
+                      </a:r>
+                      <a:endParaRPr lang="en-US" sz="1300" dirty="0"/>
+                    </a:p>
+                  </a:txBody>
+                  <a:tcPr marL="91440" marR="91440" marT="0" marB="0" anchor="ctr">
+                    <a:lnL w="9525" cap="flat" cmpd="sng" algn="ctr">
+                      <a:solidFill>
+                        <a:srgbClr val="EEF2F8"/>
+                      </a:solidFill>
+                      <a:prstDash val="solid"/>
+                      <a:round/>
+                      <a:headEnd type="none" w="med" len="med"/>
+                      <a:tailEnd type="none" w="med" len="med"/>
+                    </a:lnL>
+                    <a:lnR w="9525" cap="flat" cmpd="sng" algn="ctr">
+                      <a:solidFill>
+                        <a:srgbClr val="EEF2F8"/>
+                      </a:solidFill>
+                      <a:prstDash val="solid"/>
+                      <a:round/>
+                      <a:headEnd type="none" w="med" len="med"/>
+                      <a:tailEnd type="none" w="med" len="med"/>
+                    </a:lnR>
+                    <a:lnT w="9525" cap="flat" cmpd="sng" algn="ctr">
+                      <a:solidFill>
+                        <a:srgbClr val="EEF2F8"/>
+                      </a:solidFill>
+                      <a:prstDash val="solid"/>
+                      <a:round/>
+                      <a:headEnd type="none" w="med" len="med"/>
+                      <a:tailEnd type="none" w="med" len="med"/>
+                    </a:lnT>
+                    <a:lnB w="9525" cap="flat" cmpd="sng" algn="ctr">
+                      <a:solidFill>
+                        <a:srgbClr val="EEF2F8"/>
+                      </a:solidFill>
+                      <a:prstDash val="solid"/>
+                      <a:round/>
+                      <a:headEnd type="none" w="med" len="med"/>
+                      <a:tailEnd type="none" w="med" len="med"/>
+                    </a:lnB>
+                  </a:tcPr>
+                </a:tc>
+              </a:tr>
+              <a:tr h="411480">
+                <a:tc>
+                  <a:txBody>
+                    <a:bodyPr/>
+                    <a:lstStyle/>
+                    <a:p>
+                      <a:pPr algn="l" indent="0" marL="0">
+                        <a:buNone/>
+                      </a:pPr>
+                      <a:r>
+                        <a:rPr lang="en-US" sz="1300" dirty="0">
+                          <a:solidFill>
+                            <a:schemeClr val="tx1"/>
+                          </a:solidFill>
+                        </a:rPr>
+                        <a:t>Delaware (Wilmington)</a:t>
+                      </a:r>
+                      <a:endParaRPr lang="en-US" sz="1300" dirty="0"/>
+                    </a:p>
+                  </a:txBody>
+                  <a:tcPr marL="91440" marR="91440" marT="0" marB="0" anchor="ctr">
+                    <a:lnL w="9525" cap="flat" cmpd="sng" algn="ctr">
+                      <a:solidFill>
+                        <a:srgbClr val="EEF2F8"/>
+                      </a:solidFill>
+                      <a:prstDash val="solid"/>
+                      <a:round/>
+                      <a:headEnd type="none" w="med" len="med"/>
+                      <a:tailEnd type="none" w="med" len="med"/>
+                    </a:lnL>
+                    <a:lnR w="9525" cap="flat" cmpd="sng" algn="ctr">
+                      <a:solidFill>
+                        <a:srgbClr val="EEF2F8"/>
+                      </a:solidFill>
+                      <a:prstDash val="solid"/>
+                      <a:round/>
+                      <a:headEnd type="none" w="med" len="med"/>
+                      <a:tailEnd type="none" w="med" len="med"/>
+                    </a:lnR>
+                    <a:lnT w="9525" cap="flat" cmpd="sng" algn="ctr">
+                      <a:solidFill>
+                        <a:srgbClr val="EEF2F8"/>
+                      </a:solidFill>
+                      <a:prstDash val="solid"/>
+                      <a:round/>
+                      <a:headEnd type="none" w="med" len="med"/>
+                      <a:tailEnd type="none" w="med" len="med"/>
+                    </a:lnT>
+                    <a:lnB w="9525" cap="flat" cmpd="sng" algn="ctr">
+                      <a:solidFill>
+                        <a:srgbClr val="EEF2F8"/>
+                      </a:solidFill>
+                      <a:prstDash val="solid"/>
+                      <a:round/>
+                      <a:headEnd type="none" w="med" len="med"/>
+                      <a:tailEnd type="none" w="med" len="med"/>
+                    </a:lnB>
+                  </a:tcPr>
+                </a:tc>
+                <a:tc>
+                  <a:txBody>
+                    <a:bodyPr/>
+                    <a:lstStyle/>
+                    <a:p>
+                      <a:pPr algn="r" indent="0" marL="0">
+                        <a:buNone/>
+                      </a:pPr>
+                      <a:r>
+                        <a:rPr lang="en-US" sz="1300" dirty="0">
+                          <a:solidFill>
+                            <a:schemeClr val="tx1"/>
+                          </a:solidFill>
+                        </a:rPr>
+                        <a:t>2</a:t>
+                      </a:r>
+                      <a:endParaRPr lang="en-US" sz="1300" dirty="0"/>
+                    </a:p>
+                  </a:txBody>
+                  <a:tcPr marL="91440" marR="91440" marT="0" marB="0" anchor="ctr">
+                    <a:lnL w="9525" cap="flat" cmpd="sng" algn="ctr">
+                      <a:solidFill>
+                        <a:srgbClr val="EEF2F8"/>
+                      </a:solidFill>
+                      <a:prstDash val="solid"/>
+                      <a:round/>
+                      <a:headEnd type="none" w="med" len="med"/>
+                      <a:tailEnd type="none" w="med" len="med"/>
+                    </a:lnL>
+                    <a:lnR w="9525" cap="flat" cmpd="sng" algn="ctr">
+                      <a:solidFill>
+                        <a:srgbClr val="EEF2F8"/>
+                      </a:solidFill>
+                      <a:prstDash val="solid"/>
+                      <a:round/>
+                      <a:headEnd type="none" w="med" len="med"/>
+                      <a:tailEnd type="none" w="med" len="med"/>
+                    </a:lnR>
+                    <a:lnT w="9525" cap="flat" cmpd="sng" algn="ctr">
+                      <a:solidFill>
+                        <a:srgbClr val="EEF2F8"/>
+                      </a:solidFill>
+                      <a:prstDash val="solid"/>
+                      <a:round/>
+                      <a:headEnd type="none" w="med" len="med"/>
+                      <a:tailEnd type="none" w="med" len="med"/>
+                    </a:lnT>
+                    <a:lnB w="9525" cap="flat" cmpd="sng" algn="ctr">
+                      <a:solidFill>
+                        <a:srgbClr val="EEF2F8"/>
+                      </a:solidFill>
+                      <a:prstDash val="solid"/>
+                      <a:round/>
+                      <a:headEnd type="none" w="med" len="med"/>
+                      <a:tailEnd type="none" w="med" len="med"/>
+                    </a:lnB>
+                  </a:tcPr>
+                </a:tc>
+                <a:tc>
+                  <a:txBody>
+                    <a:bodyPr/>
+                    <a:lstStyle/>
+                    <a:p>
+                      <a:pPr algn="r" indent="0" marL="0">
+                        <a:buNone/>
+                      </a:pPr>
+                      <a:r>
+                        <a:rPr lang="en-US" sz="1300" dirty="0">
+                          <a:solidFill>
+                            <a:schemeClr val="tx1"/>
+                          </a:solidFill>
+                        </a:rPr>
+                        <a:t>1,004</a:t>
+                      </a:r>
+                      <a:endParaRPr lang="en-US" sz="1300" dirty="0"/>
+                    </a:p>
+                  </a:txBody>
+                  <a:tcPr marL="91440" marR="91440" marT="0" marB="0" anchor="ctr">
+                    <a:lnL w="9525" cap="flat" cmpd="sng" algn="ctr">
+                      <a:solidFill>
+                        <a:srgbClr val="EEF2F8"/>
+                      </a:solidFill>
+                      <a:prstDash val="solid"/>
+                      <a:round/>
+                      <a:headEnd type="none" w="med" len="med"/>
+                      <a:tailEnd type="none" w="med" len="med"/>
+                    </a:lnL>
+                    <a:lnR w="9525" cap="flat" cmpd="sng" algn="ctr">
+                      <a:solidFill>
+                        <a:srgbClr val="EEF2F8"/>
+                      </a:solidFill>
+                      <a:prstDash val="solid"/>
+                      <a:round/>
+                      <a:headEnd type="none" w="med" len="med"/>
+                      <a:tailEnd type="none" w="med" len="med"/>
+                    </a:lnR>
+                    <a:lnT w="9525" cap="flat" cmpd="sng" algn="ctr">
+                      <a:solidFill>
+                        <a:srgbClr val="EEF2F8"/>
+                      </a:solidFill>
+                      <a:prstDash val="solid"/>
+                      <a:round/>
+                      <a:headEnd type="none" w="med" len="med"/>
+                      <a:tailEnd type="none" w="med" len="med"/>
+                    </a:lnT>
+                    <a:lnB w="9525" cap="flat" cmpd="sng" algn="ctr">
+                      <a:solidFill>
+                        <a:srgbClr val="EEF2F8"/>
+                      </a:solidFill>
+                      <a:prstDash val="solid"/>
+                      <a:round/>
+                      <a:headEnd type="none" w="med" len="med"/>
+                      <a:tailEnd type="none" w="med" len="med"/>
+                    </a:lnB>
+                  </a:tcPr>
+                </a:tc>
+                <a:tc>
+                  <a:txBody>
+                    <a:bodyPr/>
+                    <a:lstStyle/>
+                    <a:p>
+                      <a:pPr algn="r" indent="0" marL="0">
+                        <a:buNone/>
+                      </a:pPr>
+                      <a:r>
+                        <a:rPr lang="en-US" sz="1300" dirty="0">
+                          <a:solidFill>
+                            <a:schemeClr val="tx1"/>
+                          </a:solidFill>
+                        </a:rPr>
+                        <a:t>8</a:t>
+                      </a:r>
+                      <a:endParaRPr lang="en-US" sz="1300" dirty="0"/>
+                    </a:p>
+                  </a:txBody>
+                  <a:tcPr marL="91440" marR="91440" marT="0" marB="0" anchor="ctr">
+                    <a:lnL w="9525" cap="flat" cmpd="sng" algn="ctr">
+                      <a:solidFill>
+                        <a:srgbClr val="EEF2F8"/>
+                      </a:solidFill>
+                      <a:prstDash val="solid"/>
+                      <a:round/>
+                      <a:headEnd type="none" w="med" len="med"/>
+                      <a:tailEnd type="none" w="med" len="med"/>
+                    </a:lnL>
+                    <a:lnR w="9525" cap="flat" cmpd="sng" algn="ctr">
+                      <a:solidFill>
+                        <a:srgbClr val="EEF2F8"/>
+                      </a:solidFill>
+                      <a:prstDash val="solid"/>
+                      <a:round/>
+                      <a:headEnd type="none" w="med" len="med"/>
+                      <a:tailEnd type="none" w="med" len="med"/>
+                    </a:lnR>
+                    <a:lnT w="9525" cap="flat" cmpd="sng" algn="ctr">
+                      <a:solidFill>
+                        <a:srgbClr val="EEF2F8"/>
+                      </a:solidFill>
+                      <a:prstDash val="solid"/>
+                      <a:round/>
+                      <a:headEnd type="none" w="med" len="med"/>
+                      <a:tailEnd type="none" w="med" len="med"/>
+                    </a:lnT>
+                    <a:lnB w="9525" cap="flat" cmpd="sng" algn="ctr">
+                      <a:solidFill>
+                        <a:srgbClr val="EEF2F8"/>
+                      </a:solidFill>
+                      <a:prstDash val="solid"/>
+                      <a:round/>
+                      <a:headEnd type="none" w="med" len="med"/>
+                      <a:tailEnd type="none" w="med" len="med"/>
+                    </a:lnB>
+                  </a:tcPr>
+                </a:tc>
+                <a:tc>
+                  <a:txBody>
+                    <a:bodyPr/>
+                    <a:lstStyle/>
+                    <a:p>
+                      <a:pPr algn="r" indent="0" marL="0">
+                        <a:buNone/>
+                      </a:pPr>
+                      <a:r>
+                        <a:rPr lang="en-US" sz="1300" dirty="0">
+                          <a:solidFill>
+                            <a:schemeClr val="tx1"/>
+                          </a:solidFill>
+                        </a:rPr>
+                        <a:t>88</a:t>
+                      </a:r>
+                      <a:endParaRPr lang="en-US" sz="1300" dirty="0"/>
+                    </a:p>
+                  </a:txBody>
+                  <a:tcPr marL="91440" marR="91440" marT="0" marB="0" anchor="ctr">
+                    <a:lnL w="9525" cap="flat" cmpd="sng" algn="ctr">
+                      <a:solidFill>
+                        <a:srgbClr val="EEF2F8"/>
+                      </a:solidFill>
+                      <a:prstDash val="solid"/>
+                      <a:round/>
+                      <a:headEnd type="none" w="med" len="med"/>
+                      <a:tailEnd type="none" w="med" len="med"/>
+                    </a:lnL>
+                    <a:lnR w="9525" cap="flat" cmpd="sng" algn="ctr">
+                      <a:solidFill>
+                        <a:srgbClr val="EEF2F8"/>
+                      </a:solidFill>
+                      <a:prstDash val="solid"/>
+                      <a:round/>
+                      <a:headEnd type="none" w="med" len="med"/>
+                      <a:tailEnd type="none" w="med" len="med"/>
+                    </a:lnR>
+                    <a:lnT w="9525" cap="flat" cmpd="sng" algn="ctr">
+                      <a:solidFill>
+                        <a:srgbClr val="EEF2F8"/>
+                      </a:solidFill>
+                      <a:prstDash val="solid"/>
+                      <a:round/>
+                      <a:headEnd type="none" w="med" len="med"/>
+                      <a:tailEnd type="none" w="med" len="med"/>
+                    </a:lnT>
+                    <a:lnB w="9525" cap="flat" cmpd="sng" algn="ctr">
+                      <a:solidFill>
+                        <a:srgbClr val="EEF2F8"/>
+                      </a:solidFill>
+                      <a:prstDash val="solid"/>
+                      <a:round/>
+                      <a:headEnd type="none" w="med" len="med"/>
+                      <a:tailEnd type="none" w="med" len="med"/>
+                    </a:lnB>
+                  </a:tcPr>
+                </a:tc>
+              </a:tr>
+              <a:tr h="411480">
+                <a:tc>
+                  <a:txBody>
+                    <a:bodyPr/>
+                    <a:lstStyle/>
+                    <a:p>
+                      <a:pPr algn="l" indent="0" marL="0">
+                        <a:buNone/>
+                      </a:pPr>
+                      <a:r>
+                        <a:rPr lang="en-US" sz="1300" b="1" dirty="0">
                           <a:solidFill>
                             <a:schemeClr val="tx2"/>
                           </a:solidFill>
                         </a:rPr>
                         <a:t>Total</a:t>
                       </a:r>
-                      <a:endParaRPr lang="en-US" sz="1400" dirty="0"/>
+                      <a:endParaRPr lang="en-US" sz="1300" dirty="0"/>
                     </a:p>
                   </a:txBody>
                   <a:tcPr marL="91440" marR="91440" marT="0" marB="0" anchor="ctr">
@@ -14265,14 +15549,14 @@
                         <a:buNone/>
                       </a:pPr>
                       <a:r>
-                        <a:rPr lang="en-US" sz="1400" b="1" dirty="0">
+                        <a:rPr lang="en-US" sz="1300" b="1" dirty="0">
                           <a:solidFill>
                             <a:schemeClr val="tx2"/>
                           </a:solidFill>
                         </a:rPr>
                         <a:t>84</a:t>
                       </a:r>
-                      <a:endParaRPr lang="en-US" sz="1400" dirty="0"/>
+                      <a:endParaRPr lang="en-US" sz="1300" dirty="0"/>
                     </a:p>
                   </a:txBody>
                   <a:tcPr marL="91440" marR="91440" marT="0" marB="0" anchor="ctr">
@@ -14326,14 +15610,14 @@
                         <a:buNone/>
                       </a:pPr>
                       <a:r>
-                        <a:rPr lang="en-US" sz="1400" b="1" dirty="0">
+                        <a:rPr lang="en-US" sz="1300" b="1" dirty="0">
                           <a:solidFill>
                             <a:schemeClr val="tx2"/>
                           </a:solidFill>
                         </a:rPr>
                         <a:t>47,529</a:t>
                       </a:r>
-                      <a:endParaRPr lang="en-US" sz="1400" dirty="0"/>
+                      <a:endParaRPr lang="en-US" sz="1300" dirty="0"/>
                     </a:p>
                   </a:txBody>
                   <a:tcPr marL="91440" marR="91440" marT="0" marB="0" anchor="ctr">
@@ -14387,14 +15671,14 @@
                         <a:buNone/>
                       </a:pPr>
                       <a:r>
-                        <a:rPr lang="en-US" sz="1400" b="1" dirty="0">
+                        <a:rPr lang="en-US" sz="1300" b="1" dirty="0">
                           <a:solidFill>
                             <a:schemeClr val="tx2"/>
                           </a:solidFill>
                         </a:rPr>
                         <a:t>362</a:t>
                       </a:r>
-                      <a:endParaRPr lang="en-US" sz="1400" dirty="0"/>
+                      <a:endParaRPr lang="en-US" sz="1300" dirty="0"/>
                     </a:p>
                   </a:txBody>
                   <a:tcPr marL="91440" marR="91440" marT="0" marB="0" anchor="ctr">
@@ -14448,14 +15732,14 @@
                         <a:buNone/>
                       </a:pPr>
                       <a:r>
-                        <a:rPr lang="en-US" sz="1400" b="1" dirty="0">
+                        <a:rPr lang="en-US" sz="1300" b="1" dirty="0">
                           <a:solidFill>
                             <a:schemeClr val="tx2"/>
                           </a:solidFill>
                         </a:rPr>
                         <a:t>3,982</a:t>
                       </a:r>
-                      <a:endParaRPr lang="en-US" sz="1400" dirty="0"/>
+                      <a:endParaRPr lang="en-US" sz="1300" dirty="0"/>
                     </a:p>
                   </a:txBody>
                   <a:tcPr marL="91440" marR="91440" marT="0" marB="0" anchor="ctr">
@@ -14507,7 +15791,7 @@
       </p:graphicFrame>
       <p:sp>
         <p:nvSpPr>
-          <p:cNvPr id="4" name="Regla nueva"/>
+          <p:cNvPr id="4" name="Como se lee"/>
           <p:cNvSpPr/>
           <p:nvPr/>
         </p:nvSpPr>
@@ -14562,7 +15846,7 @@
                   <a:schemeClr val="bg1"/>
                 </a:solidFill>
               </a:rPr>
-              <a:t>Regla nueva</a:t>
+              <a:t>Cómo se lee</a:t>
             </a:r>
             <a:endParaRPr lang="en-US" sz="1800" dirty="0"/>
           </a:p>
@@ -14576,7 +15860,7 @@
                   <a:schemeClr val="bg1"/>
                 </a:solidFill>
               </a:rPr>
-              <a:t>Un integrante cuenta como validado solo si tiene la cédula nueva.</a:t>
+              <a:t>Cada equipo = 1 dirigente + 10 personas que se comprometen a votar.</a:t>
             </a:r>
             <a:endParaRPr lang="en-US" sz="1800" dirty="0"/>
           </a:p>
@@ -14604,7 +15888,7 @@
                   <a:schemeClr val="accent4"/>
                 </a:solidFill>
               </a:rPr>
-              <a:t>La red 1+10 se convierte en el canal de renovación.</a:t>
+              <a:t>Ejemplo: Hazleton debe formar 50 equipos, es decir, 550 personas.</a:t>
             </a:r>
             <a:endParaRPr lang="en-US" sz="1800" dirty="0"/>
           </a:p>
@@ -14612,7 +15896,7 @@
       </p:sp>
       <p:sp>
         <p:nvSpPr>
-          <p:cNvPr id="6" name="Comites por mesa"/>
+          <p:cNvPr id="6" name="Regla cedula"/>
           <p:cNvSpPr/>
           <p:nvPr/>
         </p:nvSpPr>
@@ -14662,14 +15946,14 @@
               <a:buNone/>
             </a:pPr>
             <a:r>
-              <a:rPr lang="en-US" sz="3200" b="1" dirty="0">
+              <a:rPr lang="en-US" sz="1600" b="1" dirty="0">
                 <a:solidFill>
                   <a:schemeClr val="accent2"/>
                 </a:solidFill>
               </a:rPr>
-              <a:t>≈ 4.3</a:t>
+              <a:t>Regla</a:t>
             </a:r>
-            <a:endParaRPr lang="en-US" sz="3200" dirty="0"/>
+            <a:endParaRPr lang="en-US" sz="1600" dirty="0"/>
           </a:p>
           <a:p>
             <a:pPr indent="0" marL="0">
@@ -14681,9 +15965,9 @@
                   <a:schemeClr val="tx1"/>
                 </a:solidFill>
               </a:rPr>
-              <a:t>comités de 11 personas por mesa</a:t>
+              <a:t>Una persona cuenta solo si ya tiene la cédula nueva.</a:t>
             </a:r>
-            <a:endParaRPr lang="en-US" sz="3200" dirty="0"/>
+            <a:endParaRPr lang="en-US" sz="1600" dirty="0"/>
           </a:p>
         </p:txBody>
       </p:sp>
@@ -15003,7 +16287,7 @@
                   <a:schemeClr val="tx1"/>
                 </a:solidFill>
               </a:rPr>
-              <a:t>6 coordinadores de zona</a:t>
+              <a:t>8 coordinadores de zona</a:t>
             </a:r>
             <a:endParaRPr lang="en-US" sz="1400" dirty="0"/>
           </a:p>

</xml_diff>

<commit_message>
Comparación con el PRM 2024 y meta de +10 %
Co-Authored-By: Claude Opus 5.5 <noreply@anthropic.com>
Claude-Session: https://claude.ai/code/session_01RrEJtrwRidXxzgveZEVQjf
</commit_message>
<xml_diff>
--- a/presentaciones/Plan_Estrategico_Pennsylvania_2028.pptx
+++ b/presentaciones/Plan_Estrategico_Pennsylvania_2028.pptx
@@ -15,9 +15,10 @@
     <p:sldId id="263" r:id="rId9"/>
     <p:sldId id="264" r:id="rId10"/>
     <p:sldId id="265" r:id="rId11"/>
+    <p:sldId id="266" r:id="rId12"/>
   </p:sldIdLst>
   <p:notesMasterIdLst>
-    <p:notesMasterId r:id="rId12"/>
+    <p:notesMasterId r:id="rId13"/>
   </p:notesMasterIdLst>
   <p:sldSz cx="12192000" cy="6858000"/>
   <p:notesSz cx="6858000" cy="12192000"/>
@@ -116,30 +117,31 @@
   <p:extLst>
     <p:ext uri="{521415D9-36F7-43E2-AB2F-B90AF26B5E84}">
       <p14:sectionLst xmlns:p14="http://schemas.microsoft.com/office/powerpoint/2010/main">
-        <p14:section name="Diagnóstico" id="{7a212d97-991f-be2b-58a4-5b468da9dfd3}">
+        <p14:section name="Diagnóstico" id="{6949b90b-538a-956c-c232-cabb67d52ee0}">
           <p14:sldIdLst>
             <p14:sldId id="256"/>
             <p14:sldId id="257"/>
             <p14:sldId id="258"/>
           </p14:sldIdLst>
         </p14:section>
-        <p14:section name="Desafíos" id="{89861157-e670-38b2-3715-43d88a15551f}">
+        <p14:section name="Desafíos" id="{a621f767-cd5b-8945-6891-ddc85095b92a}">
           <p14:sldIdLst>
             <p14:sldId id="259"/>
             <p14:sldId id="260"/>
           </p14:sldIdLst>
         </p14:section>
-        <p14:section name="Escenarios y meta" id="{fb0d0a2c-8c75-ca6d-dce3-a68b3c69921c}">
+        <p14:section name="Escenarios y meta" id="{be5c0a65-75eb-6a25-3b04-b8e4ae1c578d}">
           <p14:sldIdLst>
             <p14:sldId id="261"/>
             <p14:sldId id="262"/>
             <p14:sldId id="263"/>
+            <p14:sldId id="264"/>
           </p14:sldIdLst>
         </p14:section>
-        <p14:section name="Plan y recomendación" id="{247711b7-f2cc-b41a-6d0f-040c2afb5d97}">
+        <p14:section name="Plan y recomendación" id="{04b4bd84-abad-7a36-e2e7-8a1287f1ab36}">
           <p14:sldIdLst>
-            <p14:sldId id="264"/>
             <p14:sldId id="265"/>
+            <p14:sldId id="266"/>
           </p14:sldIdLst>
         </p14:section>
       </p14:sectionLst>
@@ -1258,6 +1260,349 @@
 </c:chartSpace>
 </file>
 
+<file path=ppt/charts/chart5.xml><?xml version="1.0" encoding="utf-8"?>
+<c:chartSpace xmlns:c="http://schemas.openxmlformats.org/drawingml/2006/chart" xmlns:a="http://schemas.openxmlformats.org/drawingml/2006/main" xmlns:r="http://schemas.openxmlformats.org/officeDocument/2006/relationships">
+  <c:date1904 val="0"/>
+  <c:roundedCorners val="1"/>
+  <c:chart>
+    <c:title>
+      <c:tx>
+        <c:rich>
+          <a:bodyPr/>
+          <a:lstStyle/>
+          <a:p>
+            <a:pPr>
+              <a:defRPr sz="1400" b="0" i="0" u="none" strike="noStrike">
+                <a:solidFill>
+                  <a:srgbClr val="1B1F2A"/>
+                </a:solidFill>
+                <a:latin typeface="+mn-lt"/>
+              </a:defRPr>
+            </a:pPr>
+            <a:r>
+              <a:rPr sz="1400" b="0" i="0" u="none" strike="noStrike">
+                <a:solidFill>
+                  <a:srgbClr val="1B1F2A"/>
+                </a:solidFill>
+                <a:latin typeface="+mn-lt"/>
+              </a:rPr>
+              <a:t>Votos PRM en la seccional (con 60 % de apoyo)</a:t>
+            </a:r>
+          </a:p>
+        </c:rich>
+      </c:tx>
+      <c:layout/>
+      <c:overlay val="0"/>
+    </c:title>
+    <c:autoTitleDeleted val="0"/>
+    <c:plotArea>
+      <c:layout/>
+      <c:barChart>
+        <c:barDir val="col"/>
+        <c:grouping val="clustered"/>
+        <c:varyColors val="0"/>
+        <c:ser>
+          <c:idx val="0"/>
+          <c:order val="0"/>
+          <c:tx>
+            <c:strRef>
+              <c:f>Sheet1!$B$1</c:f>
+              <c:strCache>
+                <c:ptCount val="1"/>
+                <c:pt idx="0">
+                  <c:v>Votos PRM</c:v>
+                </c:pt>
+              </c:strCache>
+            </c:strRef>
+          </c:tx>
+          <c:spPr>
+            <a:solidFill>
+              <a:srgbClr val="9AA7BD"/>
+            </a:solidFill>
+            <a:effectLst/>
+          </c:spPr>
+          <c:invertIfNegative val="0"/>
+          <c:dLbls>
+            <c:numFmt formatCode="#,##0" sourceLinked="0"/>
+            <c:txPr>
+              <a:bodyPr/>
+              <a:lstStyle/>
+              <a:p>
+                <a:pPr>
+                  <a:defRPr b="0" i="0" strike="noStrike" sz="1400" u="none">
+                    <a:solidFill>
+                      <a:srgbClr val="1B1F2A"/>
+                    </a:solidFill>
+                    <a:latin typeface="+mn-lt"/>
+                  </a:defRPr>
+                </a:pPr>
+              </a:p>
+            </c:txPr>
+            <c:showLegendKey val="0"/>
+            <c:showVal val="1"/>
+            <c:showCatName val="0"/>
+            <c:showSerName val="0"/>
+            <c:showPercent val="0"/>
+            <c:showBubbleSize val="0"/>
+            <c:showLeaderLines val="0"/>
+          </c:dLbls>
+          <c:dPt>
+            <c:idx val="0"/>
+            <c:invertIfNegative val="0"/>
+            <c:bubble3D val="0"/>
+            <c:spPr>
+              <a:solidFill>
+                <a:srgbClr val="9AA7BD"/>
+              </a:solidFill>
+              <a:effectLst/>
+            </c:spPr>
+          </c:dPt>
+          <c:dPt>
+            <c:idx val="1"/>
+            <c:invertIfNegative val="0"/>
+            <c:bubble3D val="0"/>
+            <c:spPr>
+              <a:solidFill>
+                <a:srgbClr val="E9A23B"/>
+              </a:solidFill>
+              <a:effectLst/>
+            </c:spPr>
+          </c:dPt>
+          <c:dPt>
+            <c:idx val="2"/>
+            <c:invertIfNegative val="0"/>
+            <c:bubble3D val="0"/>
+            <c:spPr>
+              <a:solidFill>
+                <a:srgbClr val="DA1822"/>
+              </a:solidFill>
+              <a:effectLst/>
+            </c:spPr>
+          </c:dPt>
+          <c:dPt>
+            <c:idx val="3"/>
+            <c:invertIfNegative val="0"/>
+            <c:bubble3D val="0"/>
+            <c:spPr>
+              <a:solidFill>
+                <a:srgbClr val="4F75AE"/>
+              </a:solidFill>
+              <a:effectLst/>
+            </c:spPr>
+          </c:dPt>
+          <c:dPt>
+            <c:idx val="4"/>
+            <c:invertIfNegative val="0"/>
+            <c:bubble3D val="0"/>
+            <c:spPr>
+              <a:solidFill>
+                <a:srgbClr val="002B63"/>
+              </a:solidFill>
+              <a:effectLst/>
+            </c:spPr>
+          </c:dPt>
+          <c:dPt>
+            <c:idx val="5"/>
+            <c:invertIfNegative val="0"/>
+            <c:bubble3D val="0"/>
+            <c:spPr>
+              <a:solidFill>
+                <a:srgbClr val="002B63"/>
+              </a:solidFill>
+              <a:effectLst/>
+            </c:spPr>
+          </c:dPt>
+          <c:cat>
+            <c:multiLvlStrRef>
+              <c:f>Sheet1!$A$2:$A$7</c:f>
+              <c:multiLvlStrCache>
+                <c:ptCount val="6"/>
+                <c:lvl>
+                  <c:pt idx="0">
+                    <c:v>PRM 2024*</c:v>
+                  </c:pt>
+                  <c:pt idx="1">
+                    <c:v>Meta 2028 (+10 %)</c:v>
+                  </c:pt>
+                  <c:pt idx="2">
+                    <c:v>Adverso</c:v>
+                  </c:pt>
+                  <c:pt idx="3">
+                    <c:v>Inercial</c:v>
+                  </c:pt>
+                  <c:pt idx="4">
+                    <c:v>Realista (abst. 78 %)</c:v>
+                  </c:pt>
+                  <c:pt idx="5">
+                    <c:v>Favorable</c:v>
+                  </c:pt>
+                </c:lvl>
+              </c:multiLvlStrCache>
+            </c:multiLvlStrRef>
+          </c:cat>
+          <c:val>
+            <c:numRef>
+              <c:f>Sheet1!$B$2:$B$7</c:f>
+              <c:numCache>
+                <c:formatCode>General</c:formatCode>
+                <c:ptCount val="6"/>
+                <c:pt idx="0">
+                  <c:v>5239</c:v>
+                </c:pt>
+                <c:pt idx="1">
+                  <c:v>5763</c:v>
+                </c:pt>
+                <c:pt idx="2">
+                  <c:v>3422</c:v>
+                </c:pt>
+                <c:pt idx="3">
+                  <c:v>5247</c:v>
+                </c:pt>
+                <c:pt idx="4">
+                  <c:v>6274</c:v>
+                </c:pt>
+                <c:pt idx="5">
+                  <c:v>6930</c:v>
+                </c:pt>
+              </c:numCache>
+            </c:numRef>
+          </c:val>
+        </c:ser>
+        <c:dLbls>
+          <c:numFmt formatCode="#,##0" sourceLinked="0"/>
+          <c:txPr>
+            <a:bodyPr/>
+            <a:lstStyle/>
+            <a:p>
+              <a:pPr>
+                <a:defRPr b="0" i="0" strike="noStrike" sz="1400" u="none">
+                  <a:solidFill>
+                    <a:srgbClr val="1B1F2A"/>
+                  </a:solidFill>
+                  <a:latin typeface="+mn-lt"/>
+                </a:defRPr>
+              </a:pPr>
+            </a:p>
+          </c:txPr>
+          <c:showLegendKey val="0"/>
+          <c:showVal val="1"/>
+          <c:showCatName val="0"/>
+          <c:showSerName val="0"/>
+          <c:showPercent val="0"/>
+          <c:showBubbleSize val="0"/>
+          <c:showLeaderLines val="0"/>
+        </c:dLbls>
+        <c:gapWidth val="45"/>
+        <c:overlap val="0"/>
+        <c:axId val="2094734554"/>
+        <c:axId val="2094734552"/>
+        <c:axId val="2094734556"/>
+      </c:barChart>
+      <c:catAx>
+        <c:axId val="2094734554"/>
+        <c:scaling>
+          <c:orientation val="minMax"/>
+        </c:scaling>
+        <c:delete val="0"/>
+        <c:axPos val="b"/>
+        <c:numFmt formatCode="General" sourceLinked="1"/>
+        <c:majorTickMark val="out"/>
+        <c:minorTickMark val="none"/>
+        <c:tickLblPos val="low"/>
+        <c:spPr>
+          <a:ln w="12700" cap="flat">
+            <a:solidFill>
+              <a:srgbClr val="888888"/>
+            </a:solidFill>
+            <a:prstDash val="solid"/>
+            <a:round/>
+          </a:ln>
+        </c:spPr>
+        <c:txPr>
+          <a:bodyPr/>
+          <a:lstStyle/>
+          <a:p>
+            <a:pPr>
+              <a:defRPr sz="1200" b="0" i="0" u="none" strike="noStrike">
+                <a:solidFill>
+                  <a:srgbClr val="1B1F2A"/>
+                </a:solidFill>
+                <a:latin typeface="+mn-lt"/>
+              </a:defRPr>
+            </a:pPr>
+            <a:endParaRPr lang="en-US"/>
+          </a:p>
+        </c:txPr>
+        <c:crossAx val="2094734552"/>
+        <c:crosses val="autoZero"/>
+        <c:auto val="1"/>
+        <c:lblAlgn val="ctr"/>
+        <c:noMultiLvlLbl val="1"/>
+      </c:catAx>
+      <c:valAx>
+        <c:axId val="2094734552"/>
+        <c:scaling>
+          <c:orientation val="minMax"/>
+          <c:min val="0"/>
+        </c:scaling>
+        <c:delete val="1"/>
+        <c:axPos val="l"/>
+        <c:numFmt formatCode="General" sourceLinked="0"/>
+        <c:majorTickMark val="out"/>
+        <c:minorTickMark val="none"/>
+        <c:tickLblPos val="nextTo"/>
+        <c:spPr>
+          <a:ln w="12700" cap="flat">
+            <a:solidFill>
+              <a:srgbClr val="888888"/>
+            </a:solidFill>
+            <a:prstDash val="solid"/>
+            <a:round/>
+          </a:ln>
+        </c:spPr>
+        <c:txPr>
+          <a:bodyPr/>
+          <a:lstStyle/>
+          <a:p>
+            <a:pPr>
+              <a:defRPr sz="1200" b="0" i="0" u="none" strike="noStrike">
+                <a:solidFill>
+                  <a:srgbClr val="000000"/>
+                </a:solidFill>
+                <a:latin typeface="Arial"/>
+              </a:defRPr>
+            </a:pPr>
+            <a:endParaRPr lang="en-US"/>
+          </a:p>
+        </c:txPr>
+        <c:crossAx val="2094734554"/>
+        <c:crosses val="autoZero"/>
+        <c:crossBetween val="between"/>
+      </c:valAx>
+      <c:spPr>
+        <a:noFill/>
+        <a:ln>
+          <a:noFill/>
+        </a:ln>
+        <a:effectLst/>
+      </c:spPr>
+    </c:plotArea>
+    <c:plotVisOnly val="1"/>
+    <c:dispBlanksAs val="span"/>
+  </c:chart>
+  <c:spPr>
+    <a:noFill/>
+    <a:ln>
+      <a:noFill/>
+    </a:ln>
+    <a:effectLst/>
+  </c:spPr>
+  <c:externalData r:id="rId1">
+    <c:autoUpdate val="0"/>
+  </c:externalData>
+</c:chartSpace>
+</file>
+
 <file path=ppt/notesMasters/notesMaster1.xml><?xml version="1.0" encoding="utf-8"?>
 <p:notesMaster xmlns:a="http://schemas.openxmlformats.org/drawingml/2006/main" xmlns:r="http://schemas.openxmlformats.org/officeDocument/2006/relationships" xmlns:p="http://schemas.openxmlformats.org/presentationml/2006/main">
   <p:cSld>
@@ -1741,7 +2086,7 @@
           <a:p>
             <a:r>
               <a:rPr lang="en-US" dirty="0"/>
-              <a:t>Encuestas internas PRM: Markestrategia (2–4 oct. 2026) 48.8 %; RD Elige (sept. 2026) 66.5 % entre simpatizantes. Collado ha dicho que aún no inicia recorridos como aspirante. Respetar los plazos de precampaña y campaña (Ley 20-23 de Régimen Electoral y Ley 33-18 de Partidos), no usar recursos públicos y obtener consentimiento expreso para los datos personales.</a:t>
+              <a:t>Ritmo de la meta: 362 comités en ~13 semanas = 28 comités por semana. Semáforo semanal: verde 28 o más, amarillo 18–27, rojo menos de 18. La fecha del 3 de octubre de 2027 es la fecha legal para primarias; el método del PRM para escoger candidato presidencial aún no está aprobado formalmente.</a:t>
             </a:r>
             <a:endParaRPr lang="en-US" dirty="0"/>
           </a:p>
@@ -1765,6 +2110,94 @@
             <a:fld id="{F7021451-1387-4CA6-816F-3879F97B5CBC}" type="slidenum">
               <a:rPr lang="en-US"/>
               <a:t>10</a:t>
+            </a:fld>
+            <a:endParaRPr lang="en-US"/>
+          </a:p>
+        </p:txBody>
+      </p:sp>
+    </p:spTree>
+    <p:extLst>
+      <p:ext uri="{BB962C8B-B14F-4D97-AF65-F5344CB8AC3E}">
+        <p14:creationId xmlns:p14="http://schemas.microsoft.com/office/powerpoint/2010/main" val="1024086991"/>
+      </p:ext>
+    </p:extLst>
+  </p:cSld>
+  <p:clrMapOvr>
+    <a:masterClrMapping/>
+  </p:clrMapOvr>
+</p:notes>
+</file>
+
+<file path=ppt/notesSlides/notesSlide11.xml><?xml version="1.0" encoding="utf-8"?>
+<p:notes xmlns:a="http://schemas.openxmlformats.org/drawingml/2006/main" xmlns:r="http://schemas.openxmlformats.org/officeDocument/2006/relationships" xmlns:p="http://schemas.openxmlformats.org/presentationml/2006/main">
+  <p:cSld>
+    <p:spTree>
+      <p:nvGrpSpPr>
+        <p:cNvPr id="1" name=""/>
+        <p:cNvGrpSpPr/>
+        <p:nvPr/>
+      </p:nvGrpSpPr>
+      <p:grpSpPr>
+        <a:xfrm>
+          <a:off x="0" y="0"/>
+          <a:ext cx="0" cy="0"/>
+          <a:chOff x="0" y="0"/>
+          <a:chExt cx="0" cy="0"/>
+        </a:xfrm>
+      </p:grpSpPr>
+      <p:sp>
+        <p:nvSpPr>
+          <p:cNvPr id="2" name="Slide Image Placeholder 1"/>
+          <p:cNvSpPr>
+            <a:spLocks noGrp="1" noRot="1" noChangeAspect="1"/>
+          </p:cNvSpPr>
+          <p:nvPr>
+            <p:ph type="sldImg"/>
+          </p:nvPr>
+        </p:nvSpPr>
+        <p:spPr/>
+      </p:sp>
+      <p:sp>
+        <p:nvSpPr>
+          <p:cNvPr id="3" name="Notes Placeholder 2"/>
+          <p:cNvSpPr>
+            <a:spLocks noGrp="1"/>
+          </p:cNvSpPr>
+          <p:nvPr>
+            <p:ph type="body" idx="1"/>
+          </p:nvPr>
+        </p:nvSpPr>
+        <p:spPr/>
+        <p:txBody>
+          <a:bodyPr/>
+          <a:lstStyle/>
+          <a:p>
+            <a:r>
+              <a:rPr lang="en-US" dirty="0"/>
+              <a:t>Encuestas internas PRM: Markestrategia (2–4 oct. 2026) 48.8 %; RD Elige (sept. 2026) 66.5 % entre simpatizantes. Collado ha dicho que aún no inicia recorridos como aspirante. Respetar los plazos de precampaña y campaña (Ley 20-23 de Régimen Electoral y Ley 33-18 de Partidos), no usar recursos públicos y obtener consentimiento expreso para los datos personales.</a:t>
+            </a:r>
+            <a:endParaRPr lang="en-US" dirty="0"/>
+          </a:p>
+        </p:txBody>
+      </p:sp>
+      <p:sp>
+        <p:nvSpPr>
+          <p:cNvPr id="4" name="Slide Number Placeholder 3"/>
+          <p:cNvSpPr>
+            <a:spLocks noGrp="1"/>
+          </p:cNvSpPr>
+          <p:nvPr>
+            <p:ph type="sldNum" sz="quarter" idx="10"/>
+          </p:nvPr>
+        </p:nvSpPr>
+        <p:spPr/>
+        <p:txBody>
+          <a:bodyPr/>
+          <a:lstStyle/>
+          <a:p>
+            <a:fld id="{F7021451-1387-4CA6-816F-3879F97B5CBC}" type="slidenum">
+              <a:rPr lang="en-US"/>
+              <a:t>11</a:t>
             </a:fld>
             <a:endParaRPr lang="en-US"/>
           </a:p>
@@ -2269,7 +2702,7 @@
           <a:p>
             <a:r>
               <a:rPr lang="en-US" dirty="0"/>
-              <a:t>Votos 2024 por zona: estimados al repartir los 8,731 votos reales de la seccional en proporción a los electores; por eso la abstención aparece igual (81.6 %) en todas las zonas. Para medir la abstención real de cada zona hacen falta los votos por mesa: actas de los delegados del partido o la Relación de votación JCE (OCLEE 614). Meta realista: participación del 22 % (abstención 78 %), +1,725 votos (≈ 21 por mesa). Meta ambiciosa: 25 % (abstención 75 %), +3,151 votos (≈ 38 por mesa). Referencias: abstención en el exterior 51 % en 2016; Canadá 2024 con 29 % de participación.</a:t>
+              <a:t>No hay publicado un resultado presidencial o del PRM específico de la OCLEE Philadelphia. Referencias: en la Circunscripción 1, el PRM tenía entre 59.75 % y 60.22 % de los votos de diputados en los conteos preliminares (Diario Libre; Hoy, con 45 % de colegios); a nivel nacional Abinader obtuvo 57.44 %. Se usa 60 % sobre los 8,731 votos emitidos: unos 5,239 votos PRM en 2024 (estimado; los votos válidos son algo menos que los emitidos). Meta mínima 2028: +10 % = 5,763. Escenarios con 60 % de apoyo: Adverso 5,703 votos totales → 3,422; Inercial 8,745 → 5,247 (no alcanza); Realista (abstención 78 %) 10,456 → 6,274 (+20 %); Favorable 11,550 → 6,930 (+32 %). Dos caminos para el +10 %: 9,605 votos totales (participación 20.2 %) con 60 %, o 66 % de apoyo con 8,731 votantes. Red 1+10: 3,982 personas × 85 % = 3,385 votos, el 59 % de 5,763. Sustituir el estimado por el resultado real de las actas de la seccional.</a:t>
             </a:r>
             <a:endParaRPr lang="en-US" dirty="0"/>
           </a:p>
@@ -2357,7 +2790,7 @@
           <a:p>
             <a:r>
               <a:rPr lang="en-US" dirty="0"/>
-              <a:t>Meta 1+10 de la seccional (CAD): 362 comités = 3,982 personas, calculada como 40 % de los votos emitidos por colegio, redondeado al comité completo. El reparto por zona es proporcional a los electores porque no hay votos por recinto; con los votos JCE por colegio se puede afinar. La agrupación en 8 zonas es una propuesta: ajustar si la seccional usa otra división.</a:t>
+              <a:t>Votos 2024 por zona: estimados al repartir los 8,731 votos reales de la seccional en proporción a los electores; por eso la abstención aparece igual (81.6 %) en todas las zonas. Para medir la abstención real de cada zona hacen falta los votos por mesa: actas de los delegados del partido o la Relación de votación JCE (OCLEE 614). Meta realista: participación del 22 % (abstención 78 %), +1,725 votos (≈ 21 por mesa). Meta ambiciosa: 25 % (abstención 75 %), +3,151 votos (≈ 38 por mesa). Referencias: abstención en el exterior 51 % en 2016; Canadá 2024 con 29 % de participación.</a:t>
             </a:r>
             <a:endParaRPr lang="en-US" dirty="0"/>
           </a:p>
@@ -2445,7 +2878,7 @@
           <a:p>
             <a:r>
               <a:rPr lang="en-US" dirty="0"/>
-              <a:t>Ritmo de la meta: 362 comités en ~13 semanas = 28 comités por semana. Semáforo semanal: verde 28 o más, amarillo 18–27, rojo menos de 18. La fecha del 3 de octubre de 2027 es la fecha legal para primarias; el método del PRM para escoger candidato presidencial aún no está aprobado formalmente.</a:t>
+              <a:t>Meta 1+10 de la seccional (CAD): 362 comités = 3,982 personas, calculada como 40 % de los votos emitidos por colegio, redondeado al comité completo. El reparto por zona es proporcional a los electores porque no hay votos por recinto; con los votos JCE por colegio se puede afinar. La agrupación en 8 zonas es una propuesta: ajustar si la seccional usa otra división.</a:t>
             </a:r>
             <a:endParaRPr lang="en-US" dirty="0"/>
           </a:p>
@@ -3746,6 +4179,1037 @@
       </p:grpSpPr>
       <p:sp>
         <p:nvSpPr>
+          <p:cNvPr id="2" name="Text 1"/>
+          <p:cNvSpPr/>
+          <p:nvPr>
+            <p:ph idx="101" type="title" hasCustomPrompt="1"/>
+          </p:nvPr>
+        </p:nvSpPr>
+        <p:spPr>
+          <a:xfrm>
+            <a:off x="548640" y="320040"/>
+            <a:ext cx="11091672" cy="1051560"/>
+          </a:xfrm>
+          <a:prstGeom prst="rect">
+            <a:avLst/>
+          </a:prstGeom>
+          <a:noFill/>
+          <a:ln/>
+        </p:spPr>
+        <p:txBody>
+          <a:bodyPr wrap="square" lIns="0" tIns="0" rIns="0" bIns="0" rtlCol="0" anchor="ctr"/>
+          <a:lstStyle/>
+          <a:p>
+            <a:pPr algn="l" indent="0" marL="0">
+              <a:buNone/>
+            </a:pPr>
+            <a:r>
+              <a:rPr lang="en-US" sz="2800" b="1" dirty="0">
+                <a:solidFill>
+                  <a:schemeClr val="tx2"/>
+                </a:solidFill>
+              </a:rPr>
+              <a:t>Cuatro etapas hacia mayo de 2028: habilitar primero, movilizar al final</a:t>
+            </a:r>
+            <a:endParaRPr lang="en-US" sz="2800" dirty="0"/>
+          </a:p>
+        </p:txBody>
+      </p:sp>
+      <p:sp>
+        <p:nvSpPr>
+          <p:cNvPr id="3" name="Etapa 1"/>
+          <p:cNvSpPr/>
+          <p:nvPr/>
+        </p:nvSpPr>
+        <p:spPr>
+          <a:xfrm>
+            <a:off x="548640" y="1600200"/>
+            <a:ext cx="2606040" cy="3429000"/>
+          </a:xfrm>
+          <a:prstGeom prst="roundRect">
+            <a:avLst>
+              <a:gd name="adj" fmla="val 2807"/>
+            </a:avLst>
+          </a:prstGeom>
+          <a:solidFill>
+            <a:schemeClr val="bg2"/>
+          </a:solidFill>
+          <a:ln w="12700">
+            <a:solidFill>
+              <a:schemeClr val="bg2"/>
+            </a:solidFill>
+            <a:prstDash val="solid"/>
+          </a:ln>
+        </p:spPr>
+      </p:sp>
+      <p:sp>
+        <p:nvSpPr>
+          <p:cNvPr id="4" name="Shape 2"/>
+          <p:cNvSpPr/>
+          <p:nvPr/>
+        </p:nvSpPr>
+        <p:spPr>
+          <a:xfrm>
+            <a:off x="777240" y="1783080"/>
+            <a:ext cx="566928" cy="566928"/>
+          </a:xfrm>
+          <a:prstGeom prst="ellipse">
+            <a:avLst/>
+          </a:prstGeom>
+          <a:solidFill>
+            <a:schemeClr val="accent2"/>
+          </a:solidFill>
+          <a:ln w="12700">
+            <a:solidFill>
+              <a:schemeClr val="accent2"/>
+            </a:solidFill>
+            <a:prstDash val="solid"/>
+          </a:ln>
+        </p:spPr>
+      </p:sp>
+      <p:sp>
+        <p:nvSpPr>
+          <p:cNvPr id="5" name="Text 3"/>
+          <p:cNvSpPr txBox="1"/>
+          <p:nvPr/>
+        </p:nvSpPr>
+        <p:spPr>
+          <a:xfrm>
+            <a:off x="777240" y="1783080"/>
+            <a:ext cx="566928" cy="566928"/>
+          </a:xfrm>
+          <a:prstGeom prst="rect">
+            <a:avLst/>
+          </a:prstGeom>
+          <a:noFill/>
+          <a:ln/>
+        </p:spPr>
+        <p:txBody>
+          <a:bodyPr wrap="square" lIns="0" tIns="0" rIns="0" bIns="0" rtlCol="0" anchor="ctr"/>
+          <a:lstStyle/>
+          <a:p>
+            <a:pPr algn="ctr" indent="0" marL="0">
+              <a:buNone/>
+            </a:pPr>
+            <a:r>
+              <a:rPr lang="en-US" sz="2000" b="1" dirty="0">
+                <a:solidFill>
+                  <a:schemeClr val="bg1"/>
+                </a:solidFill>
+              </a:rPr>
+              <a:t>1</a:t>
+            </a:r>
+            <a:endParaRPr lang="en-US" sz="2000" dirty="0"/>
+          </a:p>
+        </p:txBody>
+      </p:sp>
+      <p:sp>
+        <p:nvSpPr>
+          <p:cNvPr id="6" name="Text 4"/>
+          <p:cNvSpPr txBox="1"/>
+          <p:nvPr/>
+        </p:nvSpPr>
+        <p:spPr>
+          <a:xfrm>
+            <a:off x="777240" y="2468880"/>
+            <a:ext cx="2194560" cy="731520"/>
+          </a:xfrm>
+          <a:prstGeom prst="rect">
+            <a:avLst/>
+          </a:prstGeom>
+          <a:noFill/>
+          <a:ln/>
+        </p:spPr>
+        <p:txBody>
+          <a:bodyPr wrap="square" lIns="0" tIns="0" rIns="0" bIns="0" rtlCol="0" anchor="t"/>
+          <a:lstStyle/>
+          <a:p>
+            <a:pPr indent="0" marL="0">
+              <a:buNone/>
+            </a:pPr>
+            <a:r>
+              <a:rPr lang="en-US" sz="2000" b="1" dirty="0">
+                <a:solidFill>
+                  <a:schemeClr val="tx2"/>
+                </a:solidFill>
+              </a:rPr>
+              <a:t>Instalar</a:t>
+            </a:r>
+            <a:endParaRPr lang="en-US" sz="2000" dirty="0"/>
+          </a:p>
+          <a:p>
+            <a:pPr indent="0" marL="0">
+              <a:buNone/>
+            </a:pPr>
+            <a:r>
+              <a:rPr lang="en-US" sz="1300" dirty="0">
+                <a:solidFill>
+                  <a:schemeClr val="accent3"/>
+                </a:solidFill>
+              </a:rPr>
+              <a:t>Nov 2026 – feb 2027</a:t>
+            </a:r>
+            <a:endParaRPr lang="en-US" sz="2000" dirty="0"/>
+          </a:p>
+        </p:txBody>
+      </p:sp>
+      <p:sp>
+        <p:nvSpPr>
+          <p:cNvPr id="7" name="Text 5"/>
+          <p:cNvSpPr txBox="1"/>
+          <p:nvPr/>
+        </p:nvSpPr>
+        <p:spPr>
+          <a:xfrm>
+            <a:off x="777240" y="3291840"/>
+            <a:ext cx="2240280" cy="1645920"/>
+          </a:xfrm>
+          <a:prstGeom prst="rect">
+            <a:avLst/>
+          </a:prstGeom>
+          <a:noFill/>
+          <a:ln/>
+        </p:spPr>
+        <p:txBody>
+          <a:bodyPr wrap="square" lIns="0" tIns="0" rIns="0" bIns="0" rtlCol="0" anchor="t"/>
+          <a:lstStyle/>
+          <a:p>
+            <a:pPr marL="342900" indent="-342900">
+              <a:spcAft>
+                <a:spcPts val="600"/>
+              </a:spcAft>
+              <a:buSzPct val="100000"/>
+              <a:buChar char="•"/>
+            </a:pPr>
+            <a:r>
+              <a:rPr lang="en-US" sz="1400" dirty="0">
+                <a:solidFill>
+                  <a:schemeClr val="tx1"/>
+                </a:solidFill>
+              </a:rPr>
+              <a:t>8 coordinadores de zona</a:t>
+            </a:r>
+            <a:endParaRPr lang="en-US" sz="1400" dirty="0"/>
+          </a:p>
+          <a:p>
+            <a:pPr marL="342900" indent="-342900">
+              <a:spcAft>
+                <a:spcPts val="600"/>
+              </a:spcAft>
+              <a:buSzPct val="100000"/>
+              <a:buChar char="•"/>
+            </a:pPr>
+            <a:r>
+              <a:rPr lang="en-US" sz="1400" dirty="0">
+                <a:solidFill>
+                  <a:schemeClr val="tx1"/>
+                </a:solidFill>
+              </a:rPr>
+              <a:t>18 responsables de recinto</a:t>
+            </a:r>
+            <a:endParaRPr lang="en-US" sz="1400" dirty="0"/>
+          </a:p>
+          <a:p>
+            <a:pPr marL="342900" indent="-342900">
+              <a:spcAft>
+                <a:spcPts val="600"/>
+              </a:spcAft>
+              <a:buSzPct val="100000"/>
+              <a:buChar char="•"/>
+            </a:pPr>
+            <a:r>
+              <a:rPr lang="en-US" sz="1400" dirty="0">
+                <a:solidFill>
+                  <a:schemeClr val="tx1"/>
+                </a:solidFill>
+              </a:rPr>
+              <a:t>100 % de la red 1+10 con cédula nueva</a:t>
+            </a:r>
+            <a:endParaRPr lang="en-US" sz="1400" dirty="0"/>
+          </a:p>
+        </p:txBody>
+      </p:sp>
+      <p:sp>
+        <p:nvSpPr>
+          <p:cNvPr id="8" name="Etapa 2"/>
+          <p:cNvSpPr/>
+          <p:nvPr/>
+        </p:nvSpPr>
+        <p:spPr>
+          <a:xfrm>
+            <a:off x="3364992" y="1600200"/>
+            <a:ext cx="2606040" cy="3429000"/>
+          </a:xfrm>
+          <a:prstGeom prst="roundRect">
+            <a:avLst>
+              <a:gd name="adj" fmla="val 2807"/>
+            </a:avLst>
+          </a:prstGeom>
+          <a:solidFill>
+            <a:schemeClr val="bg2"/>
+          </a:solidFill>
+          <a:ln w="12700">
+            <a:solidFill>
+              <a:schemeClr val="bg2"/>
+            </a:solidFill>
+            <a:prstDash val="solid"/>
+          </a:ln>
+        </p:spPr>
+      </p:sp>
+      <p:sp>
+        <p:nvSpPr>
+          <p:cNvPr id="9" name="Shape 7"/>
+          <p:cNvSpPr/>
+          <p:nvPr/>
+        </p:nvSpPr>
+        <p:spPr>
+          <a:xfrm>
+            <a:off x="3593592" y="1783080"/>
+            <a:ext cx="566928" cy="566928"/>
+          </a:xfrm>
+          <a:prstGeom prst="ellipse">
+            <a:avLst/>
+          </a:prstGeom>
+          <a:solidFill>
+            <a:schemeClr val="accent2"/>
+          </a:solidFill>
+          <a:ln w="12700">
+            <a:solidFill>
+              <a:schemeClr val="accent2"/>
+            </a:solidFill>
+            <a:prstDash val="solid"/>
+          </a:ln>
+        </p:spPr>
+      </p:sp>
+      <p:sp>
+        <p:nvSpPr>
+          <p:cNvPr id="10" name="Text 8"/>
+          <p:cNvSpPr txBox="1"/>
+          <p:nvPr/>
+        </p:nvSpPr>
+        <p:spPr>
+          <a:xfrm>
+            <a:off x="3593592" y="1783080"/>
+            <a:ext cx="566928" cy="566928"/>
+          </a:xfrm>
+          <a:prstGeom prst="rect">
+            <a:avLst/>
+          </a:prstGeom>
+          <a:noFill/>
+          <a:ln/>
+        </p:spPr>
+        <p:txBody>
+          <a:bodyPr wrap="square" lIns="0" tIns="0" rIns="0" bIns="0" rtlCol="0" anchor="ctr"/>
+          <a:lstStyle/>
+          <a:p>
+            <a:pPr algn="ctr" indent="0" marL="0">
+              <a:buNone/>
+            </a:pPr>
+            <a:r>
+              <a:rPr lang="en-US" sz="2000" b="1" dirty="0">
+                <a:solidFill>
+                  <a:schemeClr val="bg1"/>
+                </a:solidFill>
+              </a:rPr>
+              <a:t>2</a:t>
+            </a:r>
+            <a:endParaRPr lang="en-US" sz="2000" dirty="0"/>
+          </a:p>
+        </p:txBody>
+      </p:sp>
+      <p:sp>
+        <p:nvSpPr>
+          <p:cNvPr id="11" name="Text 9"/>
+          <p:cNvSpPr txBox="1"/>
+          <p:nvPr/>
+        </p:nvSpPr>
+        <p:spPr>
+          <a:xfrm>
+            <a:off x="3593592" y="2468880"/>
+            <a:ext cx="2194560" cy="731520"/>
+          </a:xfrm>
+          <a:prstGeom prst="rect">
+            <a:avLst/>
+          </a:prstGeom>
+          <a:noFill/>
+          <a:ln/>
+        </p:spPr>
+        <p:txBody>
+          <a:bodyPr wrap="square" lIns="0" tIns="0" rIns="0" bIns="0" rtlCol="0" anchor="t"/>
+          <a:lstStyle/>
+          <a:p>
+            <a:pPr indent="0" marL="0">
+              <a:buNone/>
+            </a:pPr>
+            <a:r>
+              <a:rPr lang="en-US" sz="2000" b="1" dirty="0">
+                <a:solidFill>
+                  <a:schemeClr val="tx2"/>
+                </a:solidFill>
+              </a:rPr>
+              <a:t>Habilitar</a:t>
+            </a:r>
+            <a:endParaRPr lang="en-US" sz="2000" dirty="0"/>
+          </a:p>
+          <a:p>
+            <a:pPr indent="0" marL="0">
+              <a:buNone/>
+            </a:pPr>
+            <a:r>
+              <a:rPr lang="en-US" sz="1300" dirty="0">
+                <a:solidFill>
+                  <a:schemeClr val="accent3"/>
+                </a:solidFill>
+              </a:rPr>
+              <a:t>Mar – sep 2027</a:t>
+            </a:r>
+            <a:endParaRPr lang="en-US" sz="2000" dirty="0"/>
+          </a:p>
+        </p:txBody>
+      </p:sp>
+      <p:sp>
+        <p:nvSpPr>
+          <p:cNvPr id="12" name="Text 10"/>
+          <p:cNvSpPr txBox="1"/>
+          <p:nvPr/>
+        </p:nvSpPr>
+        <p:spPr>
+          <a:xfrm>
+            <a:off x="3593592" y="3291840"/>
+            <a:ext cx="2240280" cy="1645920"/>
+          </a:xfrm>
+          <a:prstGeom prst="rect">
+            <a:avLst/>
+          </a:prstGeom>
+          <a:noFill/>
+          <a:ln/>
+        </p:spPr>
+        <p:txBody>
+          <a:bodyPr wrap="square" lIns="0" tIns="0" rIns="0" bIns="0" rtlCol="0" anchor="t"/>
+          <a:lstStyle/>
+          <a:p>
+            <a:pPr marL="342900" indent="-342900">
+              <a:spcAft>
+                <a:spcPts val="600"/>
+              </a:spcAft>
+              <a:buSzPct val="100000"/>
+              <a:buChar char="•"/>
+            </a:pPr>
+            <a:r>
+              <a:rPr lang="en-US" sz="1400" dirty="0">
+                <a:solidFill>
+                  <a:schemeClr val="tx1"/>
+                </a:solidFill>
+              </a:rPr>
+              <a:t>362 comités validados</a:t>
+            </a:r>
+            <a:endParaRPr lang="en-US" sz="1400" dirty="0"/>
+          </a:p>
+          <a:p>
+            <a:pPr marL="342900" indent="-342900">
+              <a:spcAft>
+                <a:spcPts val="600"/>
+              </a:spcAft>
+              <a:buSzPct val="100000"/>
+              <a:buChar char="•"/>
+            </a:pPr>
+            <a:r>
+              <a:rPr lang="en-US" sz="1400" dirty="0">
+                <a:solidFill>
+                  <a:schemeClr val="tx1"/>
+                </a:solidFill>
+              </a:rPr>
+              <a:t>60 % o más del padrón renovado</a:t>
+            </a:r>
+            <a:endParaRPr lang="en-US" sz="1400" dirty="0"/>
+          </a:p>
+          <a:p>
+            <a:pPr marL="342900" indent="-342900">
+              <a:spcAft>
+                <a:spcPts val="600"/>
+              </a:spcAft>
+              <a:buSzPct val="100000"/>
+              <a:buChar char="•"/>
+            </a:pPr>
+            <a:r>
+              <a:rPr lang="en-US" sz="1400" dirty="0">
+                <a:solidFill>
+                  <a:schemeClr val="tx1"/>
+                </a:solidFill>
+              </a:rPr>
+              <a:t>Recién llegados trasladados a PA</a:t>
+            </a:r>
+            <a:endParaRPr lang="en-US" sz="1400" dirty="0"/>
+          </a:p>
+        </p:txBody>
+      </p:sp>
+      <p:sp>
+        <p:nvSpPr>
+          <p:cNvPr id="13" name="Etapa 3"/>
+          <p:cNvSpPr/>
+          <p:nvPr/>
+        </p:nvSpPr>
+        <p:spPr>
+          <a:xfrm>
+            <a:off x="6181344" y="1600200"/>
+            <a:ext cx="2606040" cy="3429000"/>
+          </a:xfrm>
+          <a:prstGeom prst="roundRect">
+            <a:avLst>
+              <a:gd name="adj" fmla="val 2807"/>
+            </a:avLst>
+          </a:prstGeom>
+          <a:solidFill>
+            <a:schemeClr val="bg2"/>
+          </a:solidFill>
+          <a:ln w="12700">
+            <a:solidFill>
+              <a:schemeClr val="bg2"/>
+            </a:solidFill>
+            <a:prstDash val="solid"/>
+          </a:ln>
+        </p:spPr>
+      </p:sp>
+      <p:sp>
+        <p:nvSpPr>
+          <p:cNvPr id="14" name="Shape 12"/>
+          <p:cNvSpPr/>
+          <p:nvPr/>
+        </p:nvSpPr>
+        <p:spPr>
+          <a:xfrm>
+            <a:off x="6409944" y="1783080"/>
+            <a:ext cx="566928" cy="566928"/>
+          </a:xfrm>
+          <a:prstGeom prst="ellipse">
+            <a:avLst/>
+          </a:prstGeom>
+          <a:solidFill>
+            <a:schemeClr val="accent2"/>
+          </a:solidFill>
+          <a:ln w="12700">
+            <a:solidFill>
+              <a:schemeClr val="accent2"/>
+            </a:solidFill>
+            <a:prstDash val="solid"/>
+          </a:ln>
+        </p:spPr>
+      </p:sp>
+      <p:sp>
+        <p:nvSpPr>
+          <p:cNvPr id="15" name="Text 13"/>
+          <p:cNvSpPr txBox="1"/>
+          <p:nvPr/>
+        </p:nvSpPr>
+        <p:spPr>
+          <a:xfrm>
+            <a:off x="6409944" y="1783080"/>
+            <a:ext cx="566928" cy="566928"/>
+          </a:xfrm>
+          <a:prstGeom prst="rect">
+            <a:avLst/>
+          </a:prstGeom>
+          <a:noFill/>
+          <a:ln/>
+        </p:spPr>
+        <p:txBody>
+          <a:bodyPr wrap="square" lIns="0" tIns="0" rIns="0" bIns="0" rtlCol="0" anchor="ctr"/>
+          <a:lstStyle/>
+          <a:p>
+            <a:pPr algn="ctr" indent="0" marL="0">
+              <a:buNone/>
+            </a:pPr>
+            <a:r>
+              <a:rPr lang="en-US" sz="2000" b="1" dirty="0">
+                <a:solidFill>
+                  <a:schemeClr val="bg1"/>
+                </a:solidFill>
+              </a:rPr>
+              <a:t>3</a:t>
+            </a:r>
+            <a:endParaRPr lang="en-US" sz="2000" dirty="0"/>
+          </a:p>
+        </p:txBody>
+      </p:sp>
+      <p:sp>
+        <p:nvSpPr>
+          <p:cNvPr id="16" name="Text 14"/>
+          <p:cNvSpPr txBox="1"/>
+          <p:nvPr/>
+        </p:nvSpPr>
+        <p:spPr>
+          <a:xfrm>
+            <a:off x="6409944" y="2468880"/>
+            <a:ext cx="2194560" cy="731520"/>
+          </a:xfrm>
+          <a:prstGeom prst="rect">
+            <a:avLst/>
+          </a:prstGeom>
+          <a:noFill/>
+          <a:ln/>
+        </p:spPr>
+        <p:txBody>
+          <a:bodyPr wrap="square" lIns="0" tIns="0" rIns="0" bIns="0" rtlCol="0" anchor="t"/>
+          <a:lstStyle/>
+          <a:p>
+            <a:pPr indent="0" marL="0">
+              <a:buNone/>
+            </a:pPr>
+            <a:r>
+              <a:rPr lang="en-US" sz="2000" b="1" dirty="0">
+                <a:solidFill>
+                  <a:schemeClr val="tx2"/>
+                </a:solidFill>
+              </a:rPr>
+              <a:t>Consolidar</a:t>
+            </a:r>
+            <a:endParaRPr lang="en-US" sz="2000" dirty="0"/>
+          </a:p>
+          <a:p>
+            <a:pPr indent="0" marL="0">
+              <a:buNone/>
+            </a:pPr>
+            <a:r>
+              <a:rPr lang="en-US" sz="1300" dirty="0">
+                <a:solidFill>
+                  <a:schemeClr val="accent3"/>
+                </a:solidFill>
+              </a:rPr>
+              <a:t>Oct 2027 – ene 2028</a:t>
+            </a:r>
+            <a:endParaRPr lang="en-US" sz="2000" dirty="0"/>
+          </a:p>
+        </p:txBody>
+      </p:sp>
+      <p:sp>
+        <p:nvSpPr>
+          <p:cNvPr id="17" name="Text 15"/>
+          <p:cNvSpPr txBox="1"/>
+          <p:nvPr/>
+        </p:nvSpPr>
+        <p:spPr>
+          <a:xfrm>
+            <a:off x="6409944" y="3291840"/>
+            <a:ext cx="2240280" cy="1645920"/>
+          </a:xfrm>
+          <a:prstGeom prst="rect">
+            <a:avLst/>
+          </a:prstGeom>
+          <a:noFill/>
+          <a:ln/>
+        </p:spPr>
+        <p:txBody>
+          <a:bodyPr wrap="square" lIns="0" tIns="0" rIns="0" bIns="0" rtlCol="0" anchor="t"/>
+          <a:lstStyle/>
+          <a:p>
+            <a:pPr marL="342900" indent="-342900">
+              <a:spcAft>
+                <a:spcPts val="600"/>
+              </a:spcAft>
+              <a:buSzPct val="100000"/>
+              <a:buChar char="•"/>
+            </a:pPr>
+            <a:r>
+              <a:rPr lang="en-US" sz="1400" dirty="0">
+                <a:solidFill>
+                  <a:schemeClr val="tx1"/>
+                </a:solidFill>
+              </a:rPr>
+              <a:t>Proceso interno del partido (fecha legal: 3 oct 2027)</a:t>
+            </a:r>
+            <a:endParaRPr lang="en-US" sz="1400" dirty="0"/>
+          </a:p>
+          <a:p>
+            <a:pPr marL="342900" indent="-342900">
+              <a:spcAft>
+                <a:spcPts val="600"/>
+              </a:spcAft>
+              <a:buSzPct val="100000"/>
+              <a:buChar char="•"/>
+            </a:pPr>
+            <a:r>
+              <a:rPr lang="en-US" sz="1400" dirty="0">
+                <a:solidFill>
+                  <a:schemeClr val="tx1"/>
+                </a:solidFill>
+              </a:rPr>
+              <a:t>90 % o más renovado antes del cierre del padrón</a:t>
+            </a:r>
+            <a:endParaRPr lang="en-US" sz="1400" dirty="0"/>
+          </a:p>
+        </p:txBody>
+      </p:sp>
+      <p:sp>
+        <p:nvSpPr>
+          <p:cNvPr id="18" name="Etapa 4"/>
+          <p:cNvSpPr/>
+          <p:nvPr/>
+        </p:nvSpPr>
+        <p:spPr>
+          <a:xfrm>
+            <a:off x="8997696" y="1600200"/>
+            <a:ext cx="2606040" cy="3429000"/>
+          </a:xfrm>
+          <a:prstGeom prst="roundRect">
+            <a:avLst>
+              <a:gd name="adj" fmla="val 2807"/>
+            </a:avLst>
+          </a:prstGeom>
+          <a:solidFill>
+            <a:schemeClr val="tx2"/>
+          </a:solidFill>
+          <a:ln w="12700">
+            <a:solidFill>
+              <a:schemeClr val="tx2"/>
+            </a:solidFill>
+            <a:prstDash val="solid"/>
+          </a:ln>
+        </p:spPr>
+      </p:sp>
+      <p:sp>
+        <p:nvSpPr>
+          <p:cNvPr id="19" name="Shape 17"/>
+          <p:cNvSpPr/>
+          <p:nvPr/>
+        </p:nvSpPr>
+        <p:spPr>
+          <a:xfrm>
+            <a:off x="9226296" y="1783080"/>
+            <a:ext cx="566928" cy="566928"/>
+          </a:xfrm>
+          <a:prstGeom prst="ellipse">
+            <a:avLst/>
+          </a:prstGeom>
+          <a:solidFill>
+            <a:schemeClr val="accent2"/>
+          </a:solidFill>
+          <a:ln w="12700">
+            <a:solidFill>
+              <a:schemeClr val="accent2"/>
+            </a:solidFill>
+            <a:prstDash val="solid"/>
+          </a:ln>
+        </p:spPr>
+      </p:sp>
+      <p:sp>
+        <p:nvSpPr>
+          <p:cNvPr id="20" name="Text 18"/>
+          <p:cNvSpPr txBox="1"/>
+          <p:nvPr/>
+        </p:nvSpPr>
+        <p:spPr>
+          <a:xfrm>
+            <a:off x="9226296" y="1783080"/>
+            <a:ext cx="566928" cy="566928"/>
+          </a:xfrm>
+          <a:prstGeom prst="rect">
+            <a:avLst/>
+          </a:prstGeom>
+          <a:noFill/>
+          <a:ln/>
+        </p:spPr>
+        <p:txBody>
+          <a:bodyPr wrap="square" lIns="0" tIns="0" rIns="0" bIns="0" rtlCol="0" anchor="ctr"/>
+          <a:lstStyle/>
+          <a:p>
+            <a:pPr algn="ctr" indent="0" marL="0">
+              <a:buNone/>
+            </a:pPr>
+            <a:r>
+              <a:rPr lang="en-US" sz="2000" b="1" dirty="0">
+                <a:solidFill>
+                  <a:schemeClr val="bg1"/>
+                </a:solidFill>
+              </a:rPr>
+              <a:t>4</a:t>
+            </a:r>
+            <a:endParaRPr lang="en-US" sz="2000" dirty="0"/>
+          </a:p>
+        </p:txBody>
+      </p:sp>
+      <p:sp>
+        <p:nvSpPr>
+          <p:cNvPr id="21" name="Text 19"/>
+          <p:cNvSpPr txBox="1"/>
+          <p:nvPr/>
+        </p:nvSpPr>
+        <p:spPr>
+          <a:xfrm>
+            <a:off x="9226296" y="2468880"/>
+            <a:ext cx="2194560" cy="731520"/>
+          </a:xfrm>
+          <a:prstGeom prst="rect">
+            <a:avLst/>
+          </a:prstGeom>
+          <a:noFill/>
+          <a:ln/>
+        </p:spPr>
+        <p:txBody>
+          <a:bodyPr wrap="square" lIns="0" tIns="0" rIns="0" bIns="0" rtlCol="0" anchor="t"/>
+          <a:lstStyle/>
+          <a:p>
+            <a:pPr indent="0" marL="0">
+              <a:buNone/>
+            </a:pPr>
+            <a:r>
+              <a:rPr lang="en-US" sz="2000" b="1" dirty="0">
+                <a:solidFill>
+                  <a:schemeClr val="bg1"/>
+                </a:solidFill>
+              </a:rPr>
+              <a:t>Movilizar</a:t>
+            </a:r>
+            <a:endParaRPr lang="en-US" sz="2000" dirty="0"/>
+          </a:p>
+          <a:p>
+            <a:pPr indent="0" marL="0">
+              <a:buNone/>
+            </a:pPr>
+            <a:r>
+              <a:rPr lang="en-US" sz="1300" dirty="0">
+                <a:solidFill>
+                  <a:schemeClr val="accent4"/>
+                </a:solidFill>
+              </a:rPr>
+              <a:t>Feb – may 2028</a:t>
+            </a:r>
+            <a:endParaRPr lang="en-US" sz="2000" dirty="0"/>
+          </a:p>
+        </p:txBody>
+      </p:sp>
+      <p:sp>
+        <p:nvSpPr>
+          <p:cNvPr id="22" name="Text 20"/>
+          <p:cNvSpPr txBox="1"/>
+          <p:nvPr/>
+        </p:nvSpPr>
+        <p:spPr>
+          <a:xfrm>
+            <a:off x="9226296" y="3291840"/>
+            <a:ext cx="2240280" cy="1645920"/>
+          </a:xfrm>
+          <a:prstGeom prst="rect">
+            <a:avLst/>
+          </a:prstGeom>
+          <a:noFill/>
+          <a:ln/>
+        </p:spPr>
+        <p:txBody>
+          <a:bodyPr wrap="square" lIns="0" tIns="0" rIns="0" bIns="0" rtlCol="0" anchor="t"/>
+          <a:lstStyle/>
+          <a:p>
+            <a:pPr marL="342900" indent="-342900">
+              <a:spcAft>
+                <a:spcPts val="600"/>
+              </a:spcAft>
+              <a:buSzPct val="100000"/>
+              <a:buChar char="•"/>
+            </a:pPr>
+            <a:r>
+              <a:rPr lang="en-US" sz="1400" dirty="0">
+                <a:solidFill>
+                  <a:schemeClr val="bg1"/>
+                </a:solidFill>
+              </a:rPr>
+              <a:t>Delegado y suplente en las 84 mesas (168)</a:t>
+            </a:r>
+            <a:endParaRPr lang="en-US" sz="1400" dirty="0"/>
+          </a:p>
+          <a:p>
+            <a:pPr marL="342900" indent="-342900">
+              <a:spcAft>
+                <a:spcPts val="600"/>
+              </a:spcAft>
+              <a:buSzPct val="100000"/>
+              <a:buChar char="•"/>
+            </a:pPr>
+            <a:r>
+              <a:rPr lang="en-US" sz="1400" dirty="0">
+                <a:solidFill>
+                  <a:schemeClr val="bg1"/>
+                </a:solidFill>
+              </a:rPr>
+              <a:t>Transporte por zona</a:t>
+            </a:r>
+            <a:endParaRPr lang="en-US" sz="1400" dirty="0"/>
+          </a:p>
+          <a:p>
+            <a:pPr marL="342900" indent="-342900">
+              <a:spcAft>
+                <a:spcPts val="600"/>
+              </a:spcAft>
+              <a:buSzPct val="100000"/>
+              <a:buChar char="•"/>
+            </a:pPr>
+            <a:r>
+              <a:rPr lang="en-US" sz="1400" dirty="0">
+                <a:solidFill>
+                  <a:schemeClr val="bg1"/>
+                </a:solidFill>
+              </a:rPr>
+              <a:t>Plan del día de la elección</a:t>
+            </a:r>
+            <a:endParaRPr lang="en-US" sz="1400" dirty="0"/>
+          </a:p>
+        </p:txBody>
+      </p:sp>
+      <p:sp>
+        <p:nvSpPr>
+          <p:cNvPr id="23" name="Indicadores"/>
+          <p:cNvSpPr/>
+          <p:nvPr/>
+        </p:nvSpPr>
+        <p:spPr>
+          <a:xfrm>
+            <a:off x="548640" y="5212080"/>
+            <a:ext cx="11091672" cy="658368"/>
+          </a:xfrm>
+          <a:prstGeom prst="roundRect">
+            <a:avLst>
+              <a:gd name="adj" fmla="val 11111"/>
+            </a:avLst>
+          </a:prstGeom>
+          <a:solidFill>
+            <a:schemeClr val="bg2"/>
+          </a:solidFill>
+          <a:ln w="12700">
+            <a:solidFill>
+              <a:schemeClr val="bg2"/>
+            </a:solidFill>
+            <a:prstDash val="solid"/>
+          </a:ln>
+        </p:spPr>
+      </p:sp>
+      <p:sp>
+        <p:nvSpPr>
+          <p:cNvPr id="24" name="Text 22"/>
+          <p:cNvSpPr txBox="1"/>
+          <p:nvPr/>
+        </p:nvSpPr>
+        <p:spPr>
+          <a:xfrm>
+            <a:off x="777240" y="5212080"/>
+            <a:ext cx="10698480" cy="658368"/>
+          </a:xfrm>
+          <a:prstGeom prst="rect">
+            <a:avLst/>
+          </a:prstGeom>
+          <a:noFill/>
+          <a:ln/>
+        </p:spPr>
+        <p:txBody>
+          <a:bodyPr wrap="square" lIns="0" tIns="0" rIns="0" bIns="0" rtlCol="0" anchor="ctr"/>
+          <a:lstStyle/>
+          <a:p>
+            <a:pPr indent="0" marL="0">
+              <a:buNone/>
+            </a:pPr>
+            <a:r>
+              <a:rPr lang="en-US" sz="1400" b="1" dirty="0">
+                <a:solidFill>
+                  <a:schemeClr val="tx2"/>
+                </a:solidFill>
+              </a:rPr>
+              <a:t>Corte semanal: </a:t>
+            </a:r>
+            <a:pPr indent="0" marL="0">
+              <a:buNone/>
+            </a:pPr>
+            <a:r>
+              <a:rPr lang="en-US" sz="1400" dirty="0">
+                <a:solidFill>
+                  <a:schemeClr val="tx1"/>
+                </a:solidFill>
+              </a:rPr>
+              <a:t>comités validados · cédulas renovadas en la red · mesas con delegado · semáforo por zona.  </a:t>
+            </a:r>
+            <a:pPr indent="0" marL="0">
+              <a:buNone/>
+            </a:pPr>
+            <a:r>
+              <a:rPr lang="en-US" sz="1400" b="1" dirty="0">
+                <a:solidFill>
+                  <a:schemeClr val="accent2"/>
+                </a:solidFill>
+              </a:rPr>
+              <a:t>Alerta: menos de 80 comités en la semana 4 → reasignar recursos y replanificar.</a:t>
+            </a:r>
+            <a:endParaRPr lang="en-US" sz="1400" dirty="0"/>
+          </a:p>
+        </p:txBody>
+      </p:sp>
+      <p:sp>
+        <p:nvSpPr>
+          <p:cNvPr id="25" name="Slide Number Placeholder 0"/>
+          <p:cNvSpPr>
+            <a:spLocks noGrp="1"/>
+          </p:cNvSpPr>
+          <p:nvPr>
+            <p:ph type="sldNum" sz="quarter" idx="4294967295"/>
+          </p:nvPr>
+        </p:nvSpPr>
+        <p:spPr>
+          <a:xfrm>
+            <a:off x="11155680" y="6400800"/>
+            <a:ext cx="548640" cy="274320"/>
+          </a:xfrm>
+          <a:prstGeom prst="rect">
+            <a:avLst/>
+          </a:prstGeom>
+          <a:extLst>
+            <a:ext uri="{C572A759-6A51-4108-AA02-DFA0A04FC94B}">
+              <ma14:wrappingTextBoxFlag xmlns:ma14="http://schemas.microsoft.com/office/mac/drawingml/2011/main" val="0"/>
+            </a:ext>
+          </a:extLst>
+        </p:spPr>
+        <p:txBody>
+          <a:bodyPr/>
+          <a:lstStyle>
+            <a:lvl1pPr>
+              <a:defRPr sz="1000">
+                <a:solidFill>
+                  <a:schemeClr val="accent4"/>
+                </a:solidFill>
+              </a:defRPr>
+            </a:lvl1pPr>
+          </a:lstStyle>
+          <a:p>
+            <a:pPr algn="r"/>
+            <a:fld id="{F7021451-1387-4CA6-816F-3879F97B5CBC}" type="slidenum">
+              <a:rPr b="0" lang="en-US"/>
+              <a:t>10</a:t>
+            </a:fld>
+            <a:endParaRPr lang="en-US"/>
+          </a:p>
+        </p:txBody>
+      </p:sp>
+    </p:spTree>
+  </p:cSld>
+  <p:clrMapOvr>
+    <a:masterClrMapping/>
+  </p:clrMapOvr>
+</p:sld>
+</file>
+
+<file path=ppt/slides/slide11.xml><?xml version="1.0" encoding="utf-8"?>
+<p:sld xmlns:a="http://schemas.openxmlformats.org/drawingml/2006/main" xmlns:r="http://schemas.openxmlformats.org/officeDocument/2006/relationships" xmlns:p="http://schemas.openxmlformats.org/presentationml/2006/main">
+  <p:cSld name="Slide 11">
+    <p:spTree>
+      <p:nvGrpSpPr>
+        <p:cNvPr id="1" name=""/>
+        <p:cNvGrpSpPr/>
+        <p:nvPr/>
+      </p:nvGrpSpPr>
+      <p:grpSpPr>
+        <a:xfrm>
+          <a:off x="0" y="0"/>
+          <a:ext cx="0" cy="0"/>
+          <a:chOff x="0" y="0"/>
+          <a:chExt cx="0" cy="0"/>
+        </a:xfrm>
+      </p:grpSpPr>
+      <p:sp>
+        <p:nvSpPr>
           <p:cNvPr id="2" name="Titulo"/>
           <p:cNvSpPr txBox="1"/>
           <p:nvPr/>
@@ -4583,7 +6047,7 @@
                   <a:schemeClr val="tx2"/>
                 </a:solidFill>
               </a:rPr>
-              <a:t>Aprobar el plan, nombrar a los 8 coordinadores de zona e iniciar la Etapa 1 en noviembre.</a:t>
+              <a:t>Aprobar el plan con la meta de al menos 5,760 votos (+10 % sobre el PRM 2024), nombrar a los 8 coordinadores e iniciar en noviembre.</a:t>
             </a:r>
             <a:endParaRPr lang="en-US" sz="1600" dirty="0"/>
           </a:p>
@@ -4628,7 +6092,7 @@
             <a:pPr algn="r"/>
             <a:fld id="{F7021451-1387-4CA6-816F-3879F97B5CBC}" type="slidenum">
               <a:rPr b="0" lang="en-US"/>
-              <a:t>10</a:t>
+              <a:t>11</a:t>
             </a:fld>
             <a:endParaRPr lang="en-US"/>
           </a:p>
@@ -8895,6 +10359,342 @@
                   <a:schemeClr val="tx2"/>
                 </a:solidFill>
               </a:rPr>
+              <a:t>Para superar en 10 % al PRM de 2024 hacen falta unos 5,760 votos: el escenario realista lo logra</a:t>
+            </a:r>
+            <a:endParaRPr lang="en-US" sz="2800" dirty="0"/>
+          </a:p>
+        </p:txBody>
+      </p:sp>
+      <p:graphicFrame>
+        <p:nvGraphicFramePr>
+          <p:cNvPr id="3" name="Comparacion PRM" descr=""/>
+          <p:cNvGraphicFramePr/>
+          <p:nvPr/>
+        </p:nvGraphicFramePr>
+        <p:xfrm>
+          <a:off x="548640" y="1600200"/>
+          <a:ext cx="6675120" cy="4251960"/>
+        </p:xfrm>
+        <a:graphic xmlns:a="http://schemas.openxmlformats.org/drawingml/2006/main">
+          <a:graphicData uri="http://schemas.openxmlformats.org/drawingml/2006/chart">
+            <c:chart xmlns:c="http://schemas.openxmlformats.org/drawingml/2006/chart" r:id="rId1"/>
+          </a:graphicData>
+        </a:graphic>
+      </p:graphicFrame>
+      <p:sp>
+        <p:nvSpPr>
+          <p:cNvPr id="4" name="Dos caminos"/>
+          <p:cNvSpPr/>
+          <p:nvPr/>
+        </p:nvSpPr>
+        <p:spPr>
+          <a:xfrm>
+            <a:off x="7589520" y="1600200"/>
+            <a:ext cx="4050792" cy="2606040"/>
+          </a:xfrm>
+          <a:prstGeom prst="roundRect">
+            <a:avLst>
+              <a:gd name="adj" fmla="val 2807"/>
+            </a:avLst>
+          </a:prstGeom>
+          <a:solidFill>
+            <a:schemeClr val="bg2"/>
+          </a:solidFill>
+          <a:ln w="12700">
+            <a:solidFill>
+              <a:schemeClr val="bg2"/>
+            </a:solidFill>
+            <a:prstDash val="solid"/>
+          </a:ln>
+        </p:spPr>
+      </p:sp>
+      <p:sp>
+        <p:nvSpPr>
+          <p:cNvPr id="5" name="Text 2"/>
+          <p:cNvSpPr txBox="1"/>
+          <p:nvPr/>
+        </p:nvSpPr>
+        <p:spPr>
+          <a:xfrm>
+            <a:off x="7818120" y="1737360"/>
+            <a:ext cx="3611880" cy="2377440"/>
+          </a:xfrm>
+          <a:prstGeom prst="rect">
+            <a:avLst/>
+          </a:prstGeom>
+          <a:noFill/>
+          <a:ln/>
+        </p:spPr>
+        <p:txBody>
+          <a:bodyPr wrap="square" lIns="0" tIns="0" rIns="0" bIns="0" rtlCol="0" anchor="t"/>
+          <a:lstStyle/>
+          <a:p>
+            <a:pPr indent="0" marL="0">
+              <a:spcAft>
+                <a:spcPts val="600"/>
+              </a:spcAft>
+              <a:buNone/>
+            </a:pPr>
+            <a:r>
+              <a:rPr lang="en-US" sz="1700" b="1" dirty="0">
+                <a:solidFill>
+                  <a:schemeClr val="tx2"/>
+                </a:solidFill>
+              </a:rPr>
+              <a:t>Dos caminos para el +10 %</a:t>
+            </a:r>
+            <a:endParaRPr lang="en-US" sz="1700" dirty="0"/>
+          </a:p>
+          <a:p>
+            <a:pPr marL="342900" indent="-342900">
+              <a:spcAft>
+                <a:spcPts val="600"/>
+              </a:spcAft>
+              <a:buSzPct val="100000"/>
+              <a:buChar char="•"/>
+            </a:pPr>
+            <a:r>
+              <a:rPr lang="en-US" sz="1400" dirty="0">
+                <a:solidFill>
+                  <a:schemeClr val="tx1"/>
+                </a:solidFill>
+              </a:rPr>
+              <a:t>Más votantes: subir la participación al 20.2 % (unos 9,600 votos) con el mismo 60 % de apoyo</a:t>
+            </a:r>
+            <a:endParaRPr lang="en-US" sz="1700" dirty="0"/>
+          </a:p>
+          <a:p>
+            <a:pPr marL="342900" indent="-342900">
+              <a:buSzPct val="100000"/>
+              <a:buChar char="•"/>
+            </a:pPr>
+            <a:r>
+              <a:rPr lang="en-US" sz="1400" dirty="0">
+                <a:solidFill>
+                  <a:schemeClr val="tx1"/>
+                </a:solidFill>
+              </a:rPr>
+              <a:t>Más apoyo: con los mismos 8,731 votantes, subir el apoyo al PRM del 60 % al 66 %</a:t>
+            </a:r>
+            <a:endParaRPr lang="en-US" sz="1700" dirty="0"/>
+          </a:p>
+        </p:txBody>
+      </p:sp>
+      <p:sp>
+        <p:nvSpPr>
+          <p:cNvPr id="6" name="Aporte red"/>
+          <p:cNvSpPr/>
+          <p:nvPr/>
+        </p:nvSpPr>
+        <p:spPr>
+          <a:xfrm>
+            <a:off x="7589520" y="4389120"/>
+            <a:ext cx="4050792" cy="1463040"/>
+          </a:xfrm>
+          <a:prstGeom prst="roundRect">
+            <a:avLst>
+              <a:gd name="adj" fmla="val 5000"/>
+            </a:avLst>
+          </a:prstGeom>
+          <a:solidFill>
+            <a:schemeClr val="tx2"/>
+          </a:solidFill>
+          <a:ln w="12700">
+            <a:solidFill>
+              <a:schemeClr val="tx2"/>
+            </a:solidFill>
+            <a:prstDash val="solid"/>
+          </a:ln>
+        </p:spPr>
+      </p:sp>
+      <p:sp>
+        <p:nvSpPr>
+          <p:cNvPr id="7" name="Text 4"/>
+          <p:cNvSpPr txBox="1"/>
+          <p:nvPr/>
+        </p:nvSpPr>
+        <p:spPr>
+          <a:xfrm>
+            <a:off x="7818120" y="4462272"/>
+            <a:ext cx="3611880" cy="1316736"/>
+          </a:xfrm>
+          <a:prstGeom prst="rect">
+            <a:avLst/>
+          </a:prstGeom>
+          <a:noFill/>
+          <a:ln/>
+        </p:spPr>
+        <p:txBody>
+          <a:bodyPr wrap="square" lIns="0" tIns="0" rIns="0" bIns="0" rtlCol="0" anchor="ctr"/>
+          <a:lstStyle/>
+          <a:p>
+            <a:pPr indent="0" marL="0">
+              <a:buNone/>
+            </a:pPr>
+            <a:r>
+              <a:rPr lang="en-US" sz="2400" b="1" dirty="0">
+                <a:solidFill>
+                  <a:schemeClr val="bg1"/>
+                </a:solidFill>
+              </a:rPr>
+              <a:t>59 % de la meta</a:t>
+            </a:r>
+            <a:endParaRPr lang="en-US" sz="2400" dirty="0"/>
+          </a:p>
+          <a:p>
+            <a:pPr indent="0" marL="0">
+              <a:buNone/>
+            </a:pPr>
+            <a:r>
+              <a:rPr lang="en-US" sz="1400" dirty="0">
+                <a:solidFill>
+                  <a:schemeClr val="accent4"/>
+                </a:solidFill>
+              </a:rPr>
+              <a:t>lo cubre la red 1+10: 3,982 personas, de las que se espera que voten unas 3,385</a:t>
+            </a:r>
+            <a:endParaRPr lang="en-US" sz="2400" dirty="0"/>
+          </a:p>
+        </p:txBody>
+      </p:sp>
+      <p:sp>
+        <p:nvSpPr>
+          <p:cNvPr id="8" name="Fuente"/>
+          <p:cNvSpPr txBox="1"/>
+          <p:nvPr/>
+        </p:nvSpPr>
+        <p:spPr>
+          <a:xfrm>
+            <a:off x="548640" y="5989320"/>
+            <a:ext cx="11091672" cy="274320"/>
+          </a:xfrm>
+          <a:prstGeom prst="rect">
+            <a:avLst/>
+          </a:prstGeom>
+          <a:noFill/>
+          <a:ln/>
+        </p:spPr>
+        <p:txBody>
+          <a:bodyPr wrap="square" lIns="0" tIns="0" rIns="0" bIns="0" rtlCol="0" anchor="ctr"/>
+          <a:lstStyle/>
+          <a:p>
+            <a:pPr indent="0" marL="0">
+              <a:buNone/>
+            </a:pPr>
+            <a:r>
+              <a:rPr lang="en-US" sz="1000" i="1" dirty="0">
+                <a:solidFill>
+                  <a:schemeClr val="accent4"/>
+                </a:solidFill>
+              </a:rPr>
+              <a:t>*Estimado: 60 % (PRM en el conteo de diputados de la C1, Hoy y Diario Libre) × 8,731 votos de la seccional. Nacional: Abinader 57.4 %. Reemplazar con actas por mesa.</a:t>
+            </a:r>
+            <a:endParaRPr lang="en-US" sz="1000" dirty="0"/>
+          </a:p>
+        </p:txBody>
+      </p:sp>
+      <p:sp>
+        <p:nvSpPr>
+          <p:cNvPr id="25" name="Slide Number Placeholder 0"/>
+          <p:cNvSpPr>
+            <a:spLocks noGrp="1"/>
+          </p:cNvSpPr>
+          <p:nvPr>
+            <p:ph type="sldNum" sz="quarter" idx="4294967295"/>
+          </p:nvPr>
+        </p:nvSpPr>
+        <p:spPr>
+          <a:xfrm>
+            <a:off x="11155680" y="6400800"/>
+            <a:ext cx="548640" cy="274320"/>
+          </a:xfrm>
+          <a:prstGeom prst="rect">
+            <a:avLst/>
+          </a:prstGeom>
+          <a:extLst>
+            <a:ext uri="{C572A759-6A51-4108-AA02-DFA0A04FC94B}">
+              <ma14:wrappingTextBoxFlag xmlns:ma14="http://schemas.microsoft.com/office/mac/drawingml/2011/main" val="0"/>
+            </a:ext>
+          </a:extLst>
+        </p:spPr>
+        <p:txBody>
+          <a:bodyPr/>
+          <a:lstStyle>
+            <a:lvl1pPr>
+              <a:defRPr sz="1000">
+                <a:solidFill>
+                  <a:schemeClr val="accent4"/>
+                </a:solidFill>
+              </a:defRPr>
+            </a:lvl1pPr>
+          </a:lstStyle>
+          <a:p>
+            <a:pPr algn="r"/>
+            <a:fld id="{F7021451-1387-4CA6-816F-3879F97B5CBC}" type="slidenum">
+              <a:rPr b="0" lang="en-US"/>
+              <a:t>7</a:t>
+            </a:fld>
+            <a:endParaRPr lang="en-US"/>
+          </a:p>
+        </p:txBody>
+      </p:sp>
+    </p:spTree>
+  </p:cSld>
+  <p:clrMapOvr>
+    <a:masterClrMapping/>
+  </p:clrMapOvr>
+</p:sld>
+</file>
+
+<file path=ppt/slides/slide8.xml><?xml version="1.0" encoding="utf-8"?>
+<p:sld xmlns:a="http://schemas.openxmlformats.org/drawingml/2006/main" xmlns:r="http://schemas.openxmlformats.org/officeDocument/2006/relationships" xmlns:p="http://schemas.openxmlformats.org/presentationml/2006/main">
+  <p:cSld name="Slide 8">
+    <p:spTree>
+      <p:nvGrpSpPr>
+        <p:cNvPr id="1" name=""/>
+        <p:cNvGrpSpPr/>
+        <p:nvPr/>
+      </p:nvGrpSpPr>
+      <p:grpSpPr>
+        <a:xfrm>
+          <a:off x="0" y="0"/>
+          <a:ext cx="0" cy="0"/>
+          <a:chOff x="0" y="0"/>
+          <a:chExt cx="0" cy="0"/>
+        </a:xfrm>
+      </p:grpSpPr>
+      <p:sp>
+        <p:nvSpPr>
+          <p:cNvPr id="2" name="Text 1"/>
+          <p:cNvSpPr/>
+          <p:nvPr>
+            <p:ph idx="101" type="title" hasCustomPrompt="1"/>
+          </p:nvPr>
+        </p:nvSpPr>
+        <p:spPr>
+          <a:xfrm>
+            <a:off x="548640" y="320040"/>
+            <a:ext cx="11091672" cy="1051560"/>
+          </a:xfrm>
+          <a:prstGeom prst="rect">
+            <a:avLst/>
+          </a:prstGeom>
+          <a:noFill/>
+          <a:ln/>
+        </p:spPr>
+        <p:txBody>
+          <a:bodyPr wrap="square" lIns="0" tIns="0" rIns="0" bIns="0" rtlCol="0" anchor="ctr"/>
+          <a:lstStyle/>
+          <a:p>
+            <a:pPr algn="l" indent="0" marL="0">
+              <a:buNone/>
+            </a:pPr>
+            <a:r>
+              <a:rPr lang="en-US" sz="2800" b="1" dirty="0">
+                <a:solidFill>
+                  <a:schemeClr val="tx2"/>
+                </a:solidFill>
+              </a:rPr>
               <a:t>Bajar la abstención de 81.6 % a 78 % suma unos 1,700 votos; llegar a 75 % suma 3,150</a:t>
             </a:r>
             <a:endParaRPr lang="en-US" sz="2800" dirty="0"/>
@@ -8903,7 +10703,7 @@
       </p:sp>
       <p:graphicFrame>
         <p:nvGraphicFramePr>
-          <p:cNvPr id="8" name="Table 0"/>
+          <p:cNvPr id="9" name="Table 0"/>
           <p:cNvGraphicFramePr>
             <a:graphicFrameLocks noGrp="1"/>
           </p:cNvGraphicFramePr>
@@ -12737,7 +14537,7 @@
             <a:pPr algn="r"/>
             <a:fld id="{F7021451-1387-4CA6-816F-3879F97B5CBC}" type="slidenum">
               <a:rPr b="0" lang="en-US"/>
-              <a:t>7</a:t>
+              <a:t>8</a:t>
             </a:fld>
             <a:endParaRPr lang="en-US"/>
           </a:p>
@@ -12751,9 +14551,9 @@
 </p:sld>
 </file>
 
-<file path=ppt/slides/slide8.xml><?xml version="1.0" encoding="utf-8"?>
+<file path=ppt/slides/slide9.xml><?xml version="1.0" encoding="utf-8"?>
 <p:sld xmlns:a="http://schemas.openxmlformats.org/drawingml/2006/main" xmlns:r="http://schemas.openxmlformats.org/officeDocument/2006/relationships" xmlns:p="http://schemas.openxmlformats.org/presentationml/2006/main">
-  <p:cSld name="Slide 8">
+  <p:cSld name="Slide 9">
     <p:spTree>
       <p:nvGrpSpPr>
         <p:cNvPr id="1" name=""/>
@@ -12808,7 +14608,7 @@
       </p:sp>
       <p:graphicFrame>
         <p:nvGraphicFramePr>
-          <p:cNvPr id="9" name="Table 0"/>
+          <p:cNvPr id="10" name="Table 0"/>
           <p:cNvGraphicFramePr>
             <a:graphicFrameLocks noGrp="1"/>
           </p:cNvGraphicFramePr>
@@ -16004,1037 +17804,6 @@
               <a:t>Mesas y electores: Seccional PRM Pennsylvania. Comités repartidos en proporción a los electores; zonas agrupadas por cercanía geográfica (propuesta).</a:t>
             </a:r>
             <a:endParaRPr lang="en-US" sz="1000" dirty="0"/>
-          </a:p>
-        </p:txBody>
-      </p:sp>
-      <p:sp>
-        <p:nvSpPr>
-          <p:cNvPr id="25" name="Slide Number Placeholder 0"/>
-          <p:cNvSpPr>
-            <a:spLocks noGrp="1"/>
-          </p:cNvSpPr>
-          <p:nvPr>
-            <p:ph type="sldNum" sz="quarter" idx="4294967295"/>
-          </p:nvPr>
-        </p:nvSpPr>
-        <p:spPr>
-          <a:xfrm>
-            <a:off x="11155680" y="6400800"/>
-            <a:ext cx="548640" cy="274320"/>
-          </a:xfrm>
-          <a:prstGeom prst="rect">
-            <a:avLst/>
-          </a:prstGeom>
-          <a:extLst>
-            <a:ext uri="{C572A759-6A51-4108-AA02-DFA0A04FC94B}">
-              <ma14:wrappingTextBoxFlag xmlns:ma14="http://schemas.microsoft.com/office/mac/drawingml/2011/main" val="0"/>
-            </a:ext>
-          </a:extLst>
-        </p:spPr>
-        <p:txBody>
-          <a:bodyPr/>
-          <a:lstStyle>
-            <a:lvl1pPr>
-              <a:defRPr sz="1000">
-                <a:solidFill>
-                  <a:schemeClr val="accent4"/>
-                </a:solidFill>
-              </a:defRPr>
-            </a:lvl1pPr>
-          </a:lstStyle>
-          <a:p>
-            <a:pPr algn="r"/>
-            <a:fld id="{F7021451-1387-4CA6-816F-3879F97B5CBC}" type="slidenum">
-              <a:rPr b="0" lang="en-US"/>
-              <a:t>8</a:t>
-            </a:fld>
-            <a:endParaRPr lang="en-US"/>
-          </a:p>
-        </p:txBody>
-      </p:sp>
-    </p:spTree>
-  </p:cSld>
-  <p:clrMapOvr>
-    <a:masterClrMapping/>
-  </p:clrMapOvr>
-</p:sld>
-</file>
-
-<file path=ppt/slides/slide9.xml><?xml version="1.0" encoding="utf-8"?>
-<p:sld xmlns:a="http://schemas.openxmlformats.org/drawingml/2006/main" xmlns:r="http://schemas.openxmlformats.org/officeDocument/2006/relationships" xmlns:p="http://schemas.openxmlformats.org/presentationml/2006/main">
-  <p:cSld name="Slide 9">
-    <p:spTree>
-      <p:nvGrpSpPr>
-        <p:cNvPr id="1" name=""/>
-        <p:cNvGrpSpPr/>
-        <p:nvPr/>
-      </p:nvGrpSpPr>
-      <p:grpSpPr>
-        <a:xfrm>
-          <a:off x="0" y="0"/>
-          <a:ext cx="0" cy="0"/>
-          <a:chOff x="0" y="0"/>
-          <a:chExt cx="0" cy="0"/>
-        </a:xfrm>
-      </p:grpSpPr>
-      <p:sp>
-        <p:nvSpPr>
-          <p:cNvPr id="2" name="Text 1"/>
-          <p:cNvSpPr/>
-          <p:nvPr>
-            <p:ph idx="101" type="title" hasCustomPrompt="1"/>
-          </p:nvPr>
-        </p:nvSpPr>
-        <p:spPr>
-          <a:xfrm>
-            <a:off x="548640" y="320040"/>
-            <a:ext cx="11091672" cy="1051560"/>
-          </a:xfrm>
-          <a:prstGeom prst="rect">
-            <a:avLst/>
-          </a:prstGeom>
-          <a:noFill/>
-          <a:ln/>
-        </p:spPr>
-        <p:txBody>
-          <a:bodyPr wrap="square" lIns="0" tIns="0" rIns="0" bIns="0" rtlCol="0" anchor="ctr"/>
-          <a:lstStyle/>
-          <a:p>
-            <a:pPr algn="l" indent="0" marL="0">
-              <a:buNone/>
-            </a:pPr>
-            <a:r>
-              <a:rPr lang="en-US" sz="2800" b="1" dirty="0">
-                <a:solidFill>
-                  <a:schemeClr val="tx2"/>
-                </a:solidFill>
-              </a:rPr>
-              <a:t>Cuatro etapas hacia mayo de 2028: habilitar primero, movilizar al final</a:t>
-            </a:r>
-            <a:endParaRPr lang="en-US" sz="2800" dirty="0"/>
-          </a:p>
-        </p:txBody>
-      </p:sp>
-      <p:sp>
-        <p:nvSpPr>
-          <p:cNvPr id="3" name="Etapa 1"/>
-          <p:cNvSpPr/>
-          <p:nvPr/>
-        </p:nvSpPr>
-        <p:spPr>
-          <a:xfrm>
-            <a:off x="548640" y="1600200"/>
-            <a:ext cx="2606040" cy="3429000"/>
-          </a:xfrm>
-          <a:prstGeom prst="roundRect">
-            <a:avLst>
-              <a:gd name="adj" fmla="val 2807"/>
-            </a:avLst>
-          </a:prstGeom>
-          <a:solidFill>
-            <a:schemeClr val="bg2"/>
-          </a:solidFill>
-          <a:ln w="12700">
-            <a:solidFill>
-              <a:schemeClr val="bg2"/>
-            </a:solidFill>
-            <a:prstDash val="solid"/>
-          </a:ln>
-        </p:spPr>
-      </p:sp>
-      <p:sp>
-        <p:nvSpPr>
-          <p:cNvPr id="4" name="Shape 2"/>
-          <p:cNvSpPr/>
-          <p:nvPr/>
-        </p:nvSpPr>
-        <p:spPr>
-          <a:xfrm>
-            <a:off x="777240" y="1783080"/>
-            <a:ext cx="566928" cy="566928"/>
-          </a:xfrm>
-          <a:prstGeom prst="ellipse">
-            <a:avLst/>
-          </a:prstGeom>
-          <a:solidFill>
-            <a:schemeClr val="accent2"/>
-          </a:solidFill>
-          <a:ln w="12700">
-            <a:solidFill>
-              <a:schemeClr val="accent2"/>
-            </a:solidFill>
-            <a:prstDash val="solid"/>
-          </a:ln>
-        </p:spPr>
-      </p:sp>
-      <p:sp>
-        <p:nvSpPr>
-          <p:cNvPr id="5" name="Text 3"/>
-          <p:cNvSpPr txBox="1"/>
-          <p:nvPr/>
-        </p:nvSpPr>
-        <p:spPr>
-          <a:xfrm>
-            <a:off x="777240" y="1783080"/>
-            <a:ext cx="566928" cy="566928"/>
-          </a:xfrm>
-          <a:prstGeom prst="rect">
-            <a:avLst/>
-          </a:prstGeom>
-          <a:noFill/>
-          <a:ln/>
-        </p:spPr>
-        <p:txBody>
-          <a:bodyPr wrap="square" lIns="0" tIns="0" rIns="0" bIns="0" rtlCol="0" anchor="ctr"/>
-          <a:lstStyle/>
-          <a:p>
-            <a:pPr algn="ctr" indent="0" marL="0">
-              <a:buNone/>
-            </a:pPr>
-            <a:r>
-              <a:rPr lang="en-US" sz="2000" b="1" dirty="0">
-                <a:solidFill>
-                  <a:schemeClr val="bg1"/>
-                </a:solidFill>
-              </a:rPr>
-              <a:t>1</a:t>
-            </a:r>
-            <a:endParaRPr lang="en-US" sz="2000" dirty="0"/>
-          </a:p>
-        </p:txBody>
-      </p:sp>
-      <p:sp>
-        <p:nvSpPr>
-          <p:cNvPr id="6" name="Text 4"/>
-          <p:cNvSpPr txBox="1"/>
-          <p:nvPr/>
-        </p:nvSpPr>
-        <p:spPr>
-          <a:xfrm>
-            <a:off x="777240" y="2468880"/>
-            <a:ext cx="2194560" cy="731520"/>
-          </a:xfrm>
-          <a:prstGeom prst="rect">
-            <a:avLst/>
-          </a:prstGeom>
-          <a:noFill/>
-          <a:ln/>
-        </p:spPr>
-        <p:txBody>
-          <a:bodyPr wrap="square" lIns="0" tIns="0" rIns="0" bIns="0" rtlCol="0" anchor="t"/>
-          <a:lstStyle/>
-          <a:p>
-            <a:pPr indent="0" marL="0">
-              <a:buNone/>
-            </a:pPr>
-            <a:r>
-              <a:rPr lang="en-US" sz="2000" b="1" dirty="0">
-                <a:solidFill>
-                  <a:schemeClr val="tx2"/>
-                </a:solidFill>
-              </a:rPr>
-              <a:t>Instalar</a:t>
-            </a:r>
-            <a:endParaRPr lang="en-US" sz="2000" dirty="0"/>
-          </a:p>
-          <a:p>
-            <a:pPr indent="0" marL="0">
-              <a:buNone/>
-            </a:pPr>
-            <a:r>
-              <a:rPr lang="en-US" sz="1300" dirty="0">
-                <a:solidFill>
-                  <a:schemeClr val="accent3"/>
-                </a:solidFill>
-              </a:rPr>
-              <a:t>Nov 2026 – feb 2027</a:t>
-            </a:r>
-            <a:endParaRPr lang="en-US" sz="2000" dirty="0"/>
-          </a:p>
-        </p:txBody>
-      </p:sp>
-      <p:sp>
-        <p:nvSpPr>
-          <p:cNvPr id="7" name="Text 5"/>
-          <p:cNvSpPr txBox="1"/>
-          <p:nvPr/>
-        </p:nvSpPr>
-        <p:spPr>
-          <a:xfrm>
-            <a:off x="777240" y="3291840"/>
-            <a:ext cx="2240280" cy="1645920"/>
-          </a:xfrm>
-          <a:prstGeom prst="rect">
-            <a:avLst/>
-          </a:prstGeom>
-          <a:noFill/>
-          <a:ln/>
-        </p:spPr>
-        <p:txBody>
-          <a:bodyPr wrap="square" lIns="0" tIns="0" rIns="0" bIns="0" rtlCol="0" anchor="t"/>
-          <a:lstStyle/>
-          <a:p>
-            <a:pPr marL="342900" indent="-342900">
-              <a:spcAft>
-                <a:spcPts val="600"/>
-              </a:spcAft>
-              <a:buSzPct val="100000"/>
-              <a:buChar char="•"/>
-            </a:pPr>
-            <a:r>
-              <a:rPr lang="en-US" sz="1400" dirty="0">
-                <a:solidFill>
-                  <a:schemeClr val="tx1"/>
-                </a:solidFill>
-              </a:rPr>
-              <a:t>8 coordinadores de zona</a:t>
-            </a:r>
-            <a:endParaRPr lang="en-US" sz="1400" dirty="0"/>
-          </a:p>
-          <a:p>
-            <a:pPr marL="342900" indent="-342900">
-              <a:spcAft>
-                <a:spcPts val="600"/>
-              </a:spcAft>
-              <a:buSzPct val="100000"/>
-              <a:buChar char="•"/>
-            </a:pPr>
-            <a:r>
-              <a:rPr lang="en-US" sz="1400" dirty="0">
-                <a:solidFill>
-                  <a:schemeClr val="tx1"/>
-                </a:solidFill>
-              </a:rPr>
-              <a:t>18 responsables de recinto</a:t>
-            </a:r>
-            <a:endParaRPr lang="en-US" sz="1400" dirty="0"/>
-          </a:p>
-          <a:p>
-            <a:pPr marL="342900" indent="-342900">
-              <a:spcAft>
-                <a:spcPts val="600"/>
-              </a:spcAft>
-              <a:buSzPct val="100000"/>
-              <a:buChar char="•"/>
-            </a:pPr>
-            <a:r>
-              <a:rPr lang="en-US" sz="1400" dirty="0">
-                <a:solidFill>
-                  <a:schemeClr val="tx1"/>
-                </a:solidFill>
-              </a:rPr>
-              <a:t>100 % de la red 1+10 con cédula nueva</a:t>
-            </a:r>
-            <a:endParaRPr lang="en-US" sz="1400" dirty="0"/>
-          </a:p>
-        </p:txBody>
-      </p:sp>
-      <p:sp>
-        <p:nvSpPr>
-          <p:cNvPr id="8" name="Etapa 2"/>
-          <p:cNvSpPr/>
-          <p:nvPr/>
-        </p:nvSpPr>
-        <p:spPr>
-          <a:xfrm>
-            <a:off x="3364992" y="1600200"/>
-            <a:ext cx="2606040" cy="3429000"/>
-          </a:xfrm>
-          <a:prstGeom prst="roundRect">
-            <a:avLst>
-              <a:gd name="adj" fmla="val 2807"/>
-            </a:avLst>
-          </a:prstGeom>
-          <a:solidFill>
-            <a:schemeClr val="bg2"/>
-          </a:solidFill>
-          <a:ln w="12700">
-            <a:solidFill>
-              <a:schemeClr val="bg2"/>
-            </a:solidFill>
-            <a:prstDash val="solid"/>
-          </a:ln>
-        </p:spPr>
-      </p:sp>
-      <p:sp>
-        <p:nvSpPr>
-          <p:cNvPr id="9" name="Shape 7"/>
-          <p:cNvSpPr/>
-          <p:nvPr/>
-        </p:nvSpPr>
-        <p:spPr>
-          <a:xfrm>
-            <a:off x="3593592" y="1783080"/>
-            <a:ext cx="566928" cy="566928"/>
-          </a:xfrm>
-          <a:prstGeom prst="ellipse">
-            <a:avLst/>
-          </a:prstGeom>
-          <a:solidFill>
-            <a:schemeClr val="accent2"/>
-          </a:solidFill>
-          <a:ln w="12700">
-            <a:solidFill>
-              <a:schemeClr val="accent2"/>
-            </a:solidFill>
-            <a:prstDash val="solid"/>
-          </a:ln>
-        </p:spPr>
-      </p:sp>
-      <p:sp>
-        <p:nvSpPr>
-          <p:cNvPr id="10" name="Text 8"/>
-          <p:cNvSpPr txBox="1"/>
-          <p:nvPr/>
-        </p:nvSpPr>
-        <p:spPr>
-          <a:xfrm>
-            <a:off x="3593592" y="1783080"/>
-            <a:ext cx="566928" cy="566928"/>
-          </a:xfrm>
-          <a:prstGeom prst="rect">
-            <a:avLst/>
-          </a:prstGeom>
-          <a:noFill/>
-          <a:ln/>
-        </p:spPr>
-        <p:txBody>
-          <a:bodyPr wrap="square" lIns="0" tIns="0" rIns="0" bIns="0" rtlCol="0" anchor="ctr"/>
-          <a:lstStyle/>
-          <a:p>
-            <a:pPr algn="ctr" indent="0" marL="0">
-              <a:buNone/>
-            </a:pPr>
-            <a:r>
-              <a:rPr lang="en-US" sz="2000" b="1" dirty="0">
-                <a:solidFill>
-                  <a:schemeClr val="bg1"/>
-                </a:solidFill>
-              </a:rPr>
-              <a:t>2</a:t>
-            </a:r>
-            <a:endParaRPr lang="en-US" sz="2000" dirty="0"/>
-          </a:p>
-        </p:txBody>
-      </p:sp>
-      <p:sp>
-        <p:nvSpPr>
-          <p:cNvPr id="11" name="Text 9"/>
-          <p:cNvSpPr txBox="1"/>
-          <p:nvPr/>
-        </p:nvSpPr>
-        <p:spPr>
-          <a:xfrm>
-            <a:off x="3593592" y="2468880"/>
-            <a:ext cx="2194560" cy="731520"/>
-          </a:xfrm>
-          <a:prstGeom prst="rect">
-            <a:avLst/>
-          </a:prstGeom>
-          <a:noFill/>
-          <a:ln/>
-        </p:spPr>
-        <p:txBody>
-          <a:bodyPr wrap="square" lIns="0" tIns="0" rIns="0" bIns="0" rtlCol="0" anchor="t"/>
-          <a:lstStyle/>
-          <a:p>
-            <a:pPr indent="0" marL="0">
-              <a:buNone/>
-            </a:pPr>
-            <a:r>
-              <a:rPr lang="en-US" sz="2000" b="1" dirty="0">
-                <a:solidFill>
-                  <a:schemeClr val="tx2"/>
-                </a:solidFill>
-              </a:rPr>
-              <a:t>Habilitar</a:t>
-            </a:r>
-            <a:endParaRPr lang="en-US" sz="2000" dirty="0"/>
-          </a:p>
-          <a:p>
-            <a:pPr indent="0" marL="0">
-              <a:buNone/>
-            </a:pPr>
-            <a:r>
-              <a:rPr lang="en-US" sz="1300" dirty="0">
-                <a:solidFill>
-                  <a:schemeClr val="accent3"/>
-                </a:solidFill>
-              </a:rPr>
-              <a:t>Mar – sep 2027</a:t>
-            </a:r>
-            <a:endParaRPr lang="en-US" sz="2000" dirty="0"/>
-          </a:p>
-        </p:txBody>
-      </p:sp>
-      <p:sp>
-        <p:nvSpPr>
-          <p:cNvPr id="12" name="Text 10"/>
-          <p:cNvSpPr txBox="1"/>
-          <p:nvPr/>
-        </p:nvSpPr>
-        <p:spPr>
-          <a:xfrm>
-            <a:off x="3593592" y="3291840"/>
-            <a:ext cx="2240280" cy="1645920"/>
-          </a:xfrm>
-          <a:prstGeom prst="rect">
-            <a:avLst/>
-          </a:prstGeom>
-          <a:noFill/>
-          <a:ln/>
-        </p:spPr>
-        <p:txBody>
-          <a:bodyPr wrap="square" lIns="0" tIns="0" rIns="0" bIns="0" rtlCol="0" anchor="t"/>
-          <a:lstStyle/>
-          <a:p>
-            <a:pPr marL="342900" indent="-342900">
-              <a:spcAft>
-                <a:spcPts val="600"/>
-              </a:spcAft>
-              <a:buSzPct val="100000"/>
-              <a:buChar char="•"/>
-            </a:pPr>
-            <a:r>
-              <a:rPr lang="en-US" sz="1400" dirty="0">
-                <a:solidFill>
-                  <a:schemeClr val="tx1"/>
-                </a:solidFill>
-              </a:rPr>
-              <a:t>362 comités validados</a:t>
-            </a:r>
-            <a:endParaRPr lang="en-US" sz="1400" dirty="0"/>
-          </a:p>
-          <a:p>
-            <a:pPr marL="342900" indent="-342900">
-              <a:spcAft>
-                <a:spcPts val="600"/>
-              </a:spcAft>
-              <a:buSzPct val="100000"/>
-              <a:buChar char="•"/>
-            </a:pPr>
-            <a:r>
-              <a:rPr lang="en-US" sz="1400" dirty="0">
-                <a:solidFill>
-                  <a:schemeClr val="tx1"/>
-                </a:solidFill>
-              </a:rPr>
-              <a:t>60 % o más del padrón renovado</a:t>
-            </a:r>
-            <a:endParaRPr lang="en-US" sz="1400" dirty="0"/>
-          </a:p>
-          <a:p>
-            <a:pPr marL="342900" indent="-342900">
-              <a:spcAft>
-                <a:spcPts val="600"/>
-              </a:spcAft>
-              <a:buSzPct val="100000"/>
-              <a:buChar char="•"/>
-            </a:pPr>
-            <a:r>
-              <a:rPr lang="en-US" sz="1400" dirty="0">
-                <a:solidFill>
-                  <a:schemeClr val="tx1"/>
-                </a:solidFill>
-              </a:rPr>
-              <a:t>Recién llegados trasladados a PA</a:t>
-            </a:r>
-            <a:endParaRPr lang="en-US" sz="1400" dirty="0"/>
-          </a:p>
-        </p:txBody>
-      </p:sp>
-      <p:sp>
-        <p:nvSpPr>
-          <p:cNvPr id="13" name="Etapa 3"/>
-          <p:cNvSpPr/>
-          <p:nvPr/>
-        </p:nvSpPr>
-        <p:spPr>
-          <a:xfrm>
-            <a:off x="6181344" y="1600200"/>
-            <a:ext cx="2606040" cy="3429000"/>
-          </a:xfrm>
-          <a:prstGeom prst="roundRect">
-            <a:avLst>
-              <a:gd name="adj" fmla="val 2807"/>
-            </a:avLst>
-          </a:prstGeom>
-          <a:solidFill>
-            <a:schemeClr val="bg2"/>
-          </a:solidFill>
-          <a:ln w="12700">
-            <a:solidFill>
-              <a:schemeClr val="bg2"/>
-            </a:solidFill>
-            <a:prstDash val="solid"/>
-          </a:ln>
-        </p:spPr>
-      </p:sp>
-      <p:sp>
-        <p:nvSpPr>
-          <p:cNvPr id="14" name="Shape 12"/>
-          <p:cNvSpPr/>
-          <p:nvPr/>
-        </p:nvSpPr>
-        <p:spPr>
-          <a:xfrm>
-            <a:off x="6409944" y="1783080"/>
-            <a:ext cx="566928" cy="566928"/>
-          </a:xfrm>
-          <a:prstGeom prst="ellipse">
-            <a:avLst/>
-          </a:prstGeom>
-          <a:solidFill>
-            <a:schemeClr val="accent2"/>
-          </a:solidFill>
-          <a:ln w="12700">
-            <a:solidFill>
-              <a:schemeClr val="accent2"/>
-            </a:solidFill>
-            <a:prstDash val="solid"/>
-          </a:ln>
-        </p:spPr>
-      </p:sp>
-      <p:sp>
-        <p:nvSpPr>
-          <p:cNvPr id="15" name="Text 13"/>
-          <p:cNvSpPr txBox="1"/>
-          <p:nvPr/>
-        </p:nvSpPr>
-        <p:spPr>
-          <a:xfrm>
-            <a:off x="6409944" y="1783080"/>
-            <a:ext cx="566928" cy="566928"/>
-          </a:xfrm>
-          <a:prstGeom prst="rect">
-            <a:avLst/>
-          </a:prstGeom>
-          <a:noFill/>
-          <a:ln/>
-        </p:spPr>
-        <p:txBody>
-          <a:bodyPr wrap="square" lIns="0" tIns="0" rIns="0" bIns="0" rtlCol="0" anchor="ctr"/>
-          <a:lstStyle/>
-          <a:p>
-            <a:pPr algn="ctr" indent="0" marL="0">
-              <a:buNone/>
-            </a:pPr>
-            <a:r>
-              <a:rPr lang="en-US" sz="2000" b="1" dirty="0">
-                <a:solidFill>
-                  <a:schemeClr val="bg1"/>
-                </a:solidFill>
-              </a:rPr>
-              <a:t>3</a:t>
-            </a:r>
-            <a:endParaRPr lang="en-US" sz="2000" dirty="0"/>
-          </a:p>
-        </p:txBody>
-      </p:sp>
-      <p:sp>
-        <p:nvSpPr>
-          <p:cNvPr id="16" name="Text 14"/>
-          <p:cNvSpPr txBox="1"/>
-          <p:nvPr/>
-        </p:nvSpPr>
-        <p:spPr>
-          <a:xfrm>
-            <a:off x="6409944" y="2468880"/>
-            <a:ext cx="2194560" cy="731520"/>
-          </a:xfrm>
-          <a:prstGeom prst="rect">
-            <a:avLst/>
-          </a:prstGeom>
-          <a:noFill/>
-          <a:ln/>
-        </p:spPr>
-        <p:txBody>
-          <a:bodyPr wrap="square" lIns="0" tIns="0" rIns="0" bIns="0" rtlCol="0" anchor="t"/>
-          <a:lstStyle/>
-          <a:p>
-            <a:pPr indent="0" marL="0">
-              <a:buNone/>
-            </a:pPr>
-            <a:r>
-              <a:rPr lang="en-US" sz="2000" b="1" dirty="0">
-                <a:solidFill>
-                  <a:schemeClr val="tx2"/>
-                </a:solidFill>
-              </a:rPr>
-              <a:t>Consolidar</a:t>
-            </a:r>
-            <a:endParaRPr lang="en-US" sz="2000" dirty="0"/>
-          </a:p>
-          <a:p>
-            <a:pPr indent="0" marL="0">
-              <a:buNone/>
-            </a:pPr>
-            <a:r>
-              <a:rPr lang="en-US" sz="1300" dirty="0">
-                <a:solidFill>
-                  <a:schemeClr val="accent3"/>
-                </a:solidFill>
-              </a:rPr>
-              <a:t>Oct 2027 – ene 2028</a:t>
-            </a:r>
-            <a:endParaRPr lang="en-US" sz="2000" dirty="0"/>
-          </a:p>
-        </p:txBody>
-      </p:sp>
-      <p:sp>
-        <p:nvSpPr>
-          <p:cNvPr id="17" name="Text 15"/>
-          <p:cNvSpPr txBox="1"/>
-          <p:nvPr/>
-        </p:nvSpPr>
-        <p:spPr>
-          <a:xfrm>
-            <a:off x="6409944" y="3291840"/>
-            <a:ext cx="2240280" cy="1645920"/>
-          </a:xfrm>
-          <a:prstGeom prst="rect">
-            <a:avLst/>
-          </a:prstGeom>
-          <a:noFill/>
-          <a:ln/>
-        </p:spPr>
-        <p:txBody>
-          <a:bodyPr wrap="square" lIns="0" tIns="0" rIns="0" bIns="0" rtlCol="0" anchor="t"/>
-          <a:lstStyle/>
-          <a:p>
-            <a:pPr marL="342900" indent="-342900">
-              <a:spcAft>
-                <a:spcPts val="600"/>
-              </a:spcAft>
-              <a:buSzPct val="100000"/>
-              <a:buChar char="•"/>
-            </a:pPr>
-            <a:r>
-              <a:rPr lang="en-US" sz="1400" dirty="0">
-                <a:solidFill>
-                  <a:schemeClr val="tx1"/>
-                </a:solidFill>
-              </a:rPr>
-              <a:t>Proceso interno del partido (fecha legal: 3 oct 2027)</a:t>
-            </a:r>
-            <a:endParaRPr lang="en-US" sz="1400" dirty="0"/>
-          </a:p>
-          <a:p>
-            <a:pPr marL="342900" indent="-342900">
-              <a:spcAft>
-                <a:spcPts val="600"/>
-              </a:spcAft>
-              <a:buSzPct val="100000"/>
-              <a:buChar char="•"/>
-            </a:pPr>
-            <a:r>
-              <a:rPr lang="en-US" sz="1400" dirty="0">
-                <a:solidFill>
-                  <a:schemeClr val="tx1"/>
-                </a:solidFill>
-              </a:rPr>
-              <a:t>90 % o más renovado antes del cierre del padrón</a:t>
-            </a:r>
-            <a:endParaRPr lang="en-US" sz="1400" dirty="0"/>
-          </a:p>
-        </p:txBody>
-      </p:sp>
-      <p:sp>
-        <p:nvSpPr>
-          <p:cNvPr id="18" name="Etapa 4"/>
-          <p:cNvSpPr/>
-          <p:nvPr/>
-        </p:nvSpPr>
-        <p:spPr>
-          <a:xfrm>
-            <a:off x="8997696" y="1600200"/>
-            <a:ext cx="2606040" cy="3429000"/>
-          </a:xfrm>
-          <a:prstGeom prst="roundRect">
-            <a:avLst>
-              <a:gd name="adj" fmla="val 2807"/>
-            </a:avLst>
-          </a:prstGeom>
-          <a:solidFill>
-            <a:schemeClr val="tx2"/>
-          </a:solidFill>
-          <a:ln w="12700">
-            <a:solidFill>
-              <a:schemeClr val="tx2"/>
-            </a:solidFill>
-            <a:prstDash val="solid"/>
-          </a:ln>
-        </p:spPr>
-      </p:sp>
-      <p:sp>
-        <p:nvSpPr>
-          <p:cNvPr id="19" name="Shape 17"/>
-          <p:cNvSpPr/>
-          <p:nvPr/>
-        </p:nvSpPr>
-        <p:spPr>
-          <a:xfrm>
-            <a:off x="9226296" y="1783080"/>
-            <a:ext cx="566928" cy="566928"/>
-          </a:xfrm>
-          <a:prstGeom prst="ellipse">
-            <a:avLst/>
-          </a:prstGeom>
-          <a:solidFill>
-            <a:schemeClr val="accent2"/>
-          </a:solidFill>
-          <a:ln w="12700">
-            <a:solidFill>
-              <a:schemeClr val="accent2"/>
-            </a:solidFill>
-            <a:prstDash val="solid"/>
-          </a:ln>
-        </p:spPr>
-      </p:sp>
-      <p:sp>
-        <p:nvSpPr>
-          <p:cNvPr id="20" name="Text 18"/>
-          <p:cNvSpPr txBox="1"/>
-          <p:nvPr/>
-        </p:nvSpPr>
-        <p:spPr>
-          <a:xfrm>
-            <a:off x="9226296" y="1783080"/>
-            <a:ext cx="566928" cy="566928"/>
-          </a:xfrm>
-          <a:prstGeom prst="rect">
-            <a:avLst/>
-          </a:prstGeom>
-          <a:noFill/>
-          <a:ln/>
-        </p:spPr>
-        <p:txBody>
-          <a:bodyPr wrap="square" lIns="0" tIns="0" rIns="0" bIns="0" rtlCol="0" anchor="ctr"/>
-          <a:lstStyle/>
-          <a:p>
-            <a:pPr algn="ctr" indent="0" marL="0">
-              <a:buNone/>
-            </a:pPr>
-            <a:r>
-              <a:rPr lang="en-US" sz="2000" b="1" dirty="0">
-                <a:solidFill>
-                  <a:schemeClr val="bg1"/>
-                </a:solidFill>
-              </a:rPr>
-              <a:t>4</a:t>
-            </a:r>
-            <a:endParaRPr lang="en-US" sz="2000" dirty="0"/>
-          </a:p>
-        </p:txBody>
-      </p:sp>
-      <p:sp>
-        <p:nvSpPr>
-          <p:cNvPr id="21" name="Text 19"/>
-          <p:cNvSpPr txBox="1"/>
-          <p:nvPr/>
-        </p:nvSpPr>
-        <p:spPr>
-          <a:xfrm>
-            <a:off x="9226296" y="2468880"/>
-            <a:ext cx="2194560" cy="731520"/>
-          </a:xfrm>
-          <a:prstGeom prst="rect">
-            <a:avLst/>
-          </a:prstGeom>
-          <a:noFill/>
-          <a:ln/>
-        </p:spPr>
-        <p:txBody>
-          <a:bodyPr wrap="square" lIns="0" tIns="0" rIns="0" bIns="0" rtlCol="0" anchor="t"/>
-          <a:lstStyle/>
-          <a:p>
-            <a:pPr indent="0" marL="0">
-              <a:buNone/>
-            </a:pPr>
-            <a:r>
-              <a:rPr lang="en-US" sz="2000" b="1" dirty="0">
-                <a:solidFill>
-                  <a:schemeClr val="bg1"/>
-                </a:solidFill>
-              </a:rPr>
-              <a:t>Movilizar</a:t>
-            </a:r>
-            <a:endParaRPr lang="en-US" sz="2000" dirty="0"/>
-          </a:p>
-          <a:p>
-            <a:pPr indent="0" marL="0">
-              <a:buNone/>
-            </a:pPr>
-            <a:r>
-              <a:rPr lang="en-US" sz="1300" dirty="0">
-                <a:solidFill>
-                  <a:schemeClr val="accent4"/>
-                </a:solidFill>
-              </a:rPr>
-              <a:t>Feb – may 2028</a:t>
-            </a:r>
-            <a:endParaRPr lang="en-US" sz="2000" dirty="0"/>
-          </a:p>
-        </p:txBody>
-      </p:sp>
-      <p:sp>
-        <p:nvSpPr>
-          <p:cNvPr id="22" name="Text 20"/>
-          <p:cNvSpPr txBox="1"/>
-          <p:nvPr/>
-        </p:nvSpPr>
-        <p:spPr>
-          <a:xfrm>
-            <a:off x="9226296" y="3291840"/>
-            <a:ext cx="2240280" cy="1645920"/>
-          </a:xfrm>
-          <a:prstGeom prst="rect">
-            <a:avLst/>
-          </a:prstGeom>
-          <a:noFill/>
-          <a:ln/>
-        </p:spPr>
-        <p:txBody>
-          <a:bodyPr wrap="square" lIns="0" tIns="0" rIns="0" bIns="0" rtlCol="0" anchor="t"/>
-          <a:lstStyle/>
-          <a:p>
-            <a:pPr marL="342900" indent="-342900">
-              <a:spcAft>
-                <a:spcPts val="600"/>
-              </a:spcAft>
-              <a:buSzPct val="100000"/>
-              <a:buChar char="•"/>
-            </a:pPr>
-            <a:r>
-              <a:rPr lang="en-US" sz="1400" dirty="0">
-                <a:solidFill>
-                  <a:schemeClr val="bg1"/>
-                </a:solidFill>
-              </a:rPr>
-              <a:t>Delegado y suplente en las 84 mesas (168)</a:t>
-            </a:r>
-            <a:endParaRPr lang="en-US" sz="1400" dirty="0"/>
-          </a:p>
-          <a:p>
-            <a:pPr marL="342900" indent="-342900">
-              <a:spcAft>
-                <a:spcPts val="600"/>
-              </a:spcAft>
-              <a:buSzPct val="100000"/>
-              <a:buChar char="•"/>
-            </a:pPr>
-            <a:r>
-              <a:rPr lang="en-US" sz="1400" dirty="0">
-                <a:solidFill>
-                  <a:schemeClr val="bg1"/>
-                </a:solidFill>
-              </a:rPr>
-              <a:t>Transporte por zona</a:t>
-            </a:r>
-            <a:endParaRPr lang="en-US" sz="1400" dirty="0"/>
-          </a:p>
-          <a:p>
-            <a:pPr marL="342900" indent="-342900">
-              <a:spcAft>
-                <a:spcPts val="600"/>
-              </a:spcAft>
-              <a:buSzPct val="100000"/>
-              <a:buChar char="•"/>
-            </a:pPr>
-            <a:r>
-              <a:rPr lang="en-US" sz="1400" dirty="0">
-                <a:solidFill>
-                  <a:schemeClr val="bg1"/>
-                </a:solidFill>
-              </a:rPr>
-              <a:t>Plan del día de la elección</a:t>
-            </a:r>
-            <a:endParaRPr lang="en-US" sz="1400" dirty="0"/>
-          </a:p>
-        </p:txBody>
-      </p:sp>
-      <p:sp>
-        <p:nvSpPr>
-          <p:cNvPr id="23" name="Indicadores"/>
-          <p:cNvSpPr/>
-          <p:nvPr/>
-        </p:nvSpPr>
-        <p:spPr>
-          <a:xfrm>
-            <a:off x="548640" y="5212080"/>
-            <a:ext cx="11091672" cy="658368"/>
-          </a:xfrm>
-          <a:prstGeom prst="roundRect">
-            <a:avLst>
-              <a:gd name="adj" fmla="val 11111"/>
-            </a:avLst>
-          </a:prstGeom>
-          <a:solidFill>
-            <a:schemeClr val="bg2"/>
-          </a:solidFill>
-          <a:ln w="12700">
-            <a:solidFill>
-              <a:schemeClr val="bg2"/>
-            </a:solidFill>
-            <a:prstDash val="solid"/>
-          </a:ln>
-        </p:spPr>
-      </p:sp>
-      <p:sp>
-        <p:nvSpPr>
-          <p:cNvPr id="24" name="Text 22"/>
-          <p:cNvSpPr txBox="1"/>
-          <p:nvPr/>
-        </p:nvSpPr>
-        <p:spPr>
-          <a:xfrm>
-            <a:off x="777240" y="5212080"/>
-            <a:ext cx="10698480" cy="658368"/>
-          </a:xfrm>
-          <a:prstGeom prst="rect">
-            <a:avLst/>
-          </a:prstGeom>
-          <a:noFill/>
-          <a:ln/>
-        </p:spPr>
-        <p:txBody>
-          <a:bodyPr wrap="square" lIns="0" tIns="0" rIns="0" bIns="0" rtlCol="0" anchor="ctr"/>
-          <a:lstStyle/>
-          <a:p>
-            <a:pPr indent="0" marL="0">
-              <a:buNone/>
-            </a:pPr>
-            <a:r>
-              <a:rPr lang="en-US" sz="1400" b="1" dirty="0">
-                <a:solidFill>
-                  <a:schemeClr val="tx2"/>
-                </a:solidFill>
-              </a:rPr>
-              <a:t>Corte semanal: </a:t>
-            </a:r>
-            <a:pPr indent="0" marL="0">
-              <a:buNone/>
-            </a:pPr>
-            <a:r>
-              <a:rPr lang="en-US" sz="1400" dirty="0">
-                <a:solidFill>
-                  <a:schemeClr val="tx1"/>
-                </a:solidFill>
-              </a:rPr>
-              <a:t>comités validados · cédulas renovadas en la red · mesas con delegado · semáforo por zona.  </a:t>
-            </a:r>
-            <a:pPr indent="0" marL="0">
-              <a:buNone/>
-            </a:pPr>
-            <a:r>
-              <a:rPr lang="en-US" sz="1400" b="1" dirty="0">
-                <a:solidFill>
-                  <a:schemeClr val="accent2"/>
-                </a:solidFill>
-              </a:rPr>
-              <a:t>Alerta: menos de 80 comités en la semana 4 → reasignar recursos y replanificar.</a:t>
-            </a:r>
-            <a:endParaRPr lang="en-US" sz="1400" dirty="0"/>
           </a:p>
         </p:txBody>
       </p:sp>

</xml_diff>

<commit_message>
Portada y resumen orientados al equipo de David Collado
Co-Authored-By: Claude Opus 5.5 <noreply@anthropic.com>
Claude-Session: https://claude.ai/code/session_01RrEJtrwRidXxzgveZEVQjf
</commit_message>
<xml_diff>
--- a/presentaciones/Plan_Estrategico_Pennsylvania_2028.pptx
+++ b/presentaciones/Plan_Estrategico_Pennsylvania_2028.pptx
@@ -119,7 +119,7 @@
   <p:extLst>
     <p:ext uri="{521415D9-36F7-43E2-AB2F-B90AF26B5E84}">
       <p14:sectionLst xmlns:p14="http://schemas.microsoft.com/office/powerpoint/2010/main">
-        <p14:section name="Diagnóstico" id="{a94f1860-9a75-a014-904a-aa1a85513fee}">
+        <p14:section name="Diagnóstico" id="{2effa879-61ab-cc27-5589-764ca7cd9fe0}">
           <p14:sldIdLst>
             <p14:sldId id="256"/>
             <p14:sldId id="257"/>
@@ -127,19 +127,19 @@
             <p14:sldId id="259"/>
           </p14:sldIdLst>
         </p14:section>
-        <p14:section name="Desafíos" id="{d6eabba1-7c4e-570c-832c-ce97d3249288}">
+        <p14:section name="Desafíos" id="{8623ffca-c50e-25b4-2380-fad55302ee58}">
           <p14:sldIdLst>
             <p14:sldId id="260"/>
             <p14:sldId id="261"/>
           </p14:sldIdLst>
         </p14:section>
-        <p14:section name="Escenarios y meta" id="{75dd0c32-471d-af73-db80-63280c80ffb6}">
+        <p14:section name="Escenarios y meta" id="{5e0aa89e-7cb1-c211-ad4a-b7f27606d8d9}">
           <p14:sldIdLst>
             <p14:sldId id="262"/>
             <p14:sldId id="263"/>
           </p14:sldIdLst>
         </p14:section>
-        <p14:section name="Plan y recomendación" id="{6938a845-ead4-cd0d-5e7b-ae1222f20a9b}">
+        <p14:section name="Plan y recomendación" id="{df5ed2cd-d51e-fecc-e6a4-9a83febe1138}">
           <p14:sldIdLst>
             <p14:sldId id="264"/>
             <p14:sldId id="265"/>
@@ -147,7 +147,7 @@
             <p14:sldId id="267"/>
           </p14:sldIdLst>
         </p14:section>
-        <p14:section name="Anexo" id="{62246cde-7256-9219-c616-8d9eb2ae995e}">
+        <p14:section name="Anexo" id="{ddaa01d9-60b8-eaf2-7229-6eadc02f26ee}">
           <p14:sldIdLst>
             <p14:sldId id="268"/>
           </p14:sldIdLst>
@@ -3512,7 +3512,7 @@
                   <a:schemeClr val="accent4"/>
                 </a:solidFill>
               </a:rPr>
-              <a:t>SECCIONAL PENNSYLVANIA · CIRCUNSCRIPCIÓN I · RUMBO A MAYO 2028</a:t>
+              <a:t>PROPUESTA PARA EL EQUIPO DE DAVID COLLADO · SECCIONAL PENNSYLVANIA</a:t>
             </a:r>
             <a:endParaRPr lang="en-US" sz="1300" dirty="0"/>
           </a:p>
@@ -13112,7 +13112,7 @@
                   <a:schemeClr val="tx1"/>
                 </a:solidFill>
               </a:rPr>
-              <a:t>Al menos 5,760 votos para el PRM en 2028: un 10 % más que en 2024.</a:t>
+              <a:t>Al menos 5,760 votos para David Collado y el PRM en 2028: un 10 % más que el PRM en 2024.</a:t>
             </a:r>
             <a:endParaRPr lang="en-US" sz="1500" dirty="0"/>
           </a:p>

</xml_diff>

<commit_message>
Meta en tres niveles y escenario de desgaste
Co-Authored-By: Claude Opus 5.5 <noreply@anthropic.com>
Claude-Session: https://claude.ai/code/session_01RrEJtrwRidXxzgveZEVQjf
</commit_message>
<xml_diff>
--- a/presentaciones/Plan_Estrategico_Pennsylvania_2028.pptx
+++ b/presentaciones/Plan_Estrategico_Pennsylvania_2028.pptx
@@ -119,7 +119,7 @@
   <p:extLst>
     <p:ext uri="{521415D9-36F7-43E2-AB2F-B90AF26B5E84}">
       <p14:sectionLst xmlns:p14="http://schemas.microsoft.com/office/powerpoint/2010/main">
-        <p14:section name="Diagnóstico" id="{2effa879-61ab-cc27-5589-764ca7cd9fe0}">
+        <p14:section name="Diagnóstico" id="{55215e52-dfcf-d293-fb98-6690c6c6b4df}">
           <p14:sldIdLst>
             <p14:sldId id="256"/>
             <p14:sldId id="257"/>
@@ -127,19 +127,19 @@
             <p14:sldId id="259"/>
           </p14:sldIdLst>
         </p14:section>
-        <p14:section name="Desafíos" id="{8623ffca-c50e-25b4-2380-fad55302ee58}">
+        <p14:section name="Desafíos" id="{8411a7d9-b139-5489-8bd4-11928ad88145}">
           <p14:sldIdLst>
             <p14:sldId id="260"/>
             <p14:sldId id="261"/>
           </p14:sldIdLst>
         </p14:section>
-        <p14:section name="Escenarios y meta" id="{5e0aa89e-7cb1-c211-ad4a-b7f27606d8d9}">
+        <p14:section name="Escenarios y meta" id="{a0d7f505-fffc-d0fa-0ef2-9bb22c8504c8}">
           <p14:sldIdLst>
             <p14:sldId id="262"/>
             <p14:sldId id="263"/>
           </p14:sldIdLst>
         </p14:section>
-        <p14:section name="Plan y recomendación" id="{df5ed2cd-d51e-fecc-e6a4-9a83febe1138}">
+        <p14:section name="Plan y recomendación" id="{9353d3d5-e4d6-ff6e-7a8d-3c3a5b3f60ad}">
           <p14:sldIdLst>
             <p14:sldId id="264"/>
             <p14:sldId id="265"/>
@@ -147,7 +147,7 @@
             <p14:sldId id="267"/>
           </p14:sldIdLst>
         </p14:section>
-        <p14:section name="Anexo" id="{ddaa01d9-60b8-eaf2-7229-6eadc02f26ee}">
+        <p14:section name="Anexo" id="{20eaf389-659d-c312-1178-60615d97db4a}">
           <p14:sldIdLst>
             <p14:sldId id="268"/>
           </p14:sldIdLst>
@@ -2578,7 +2578,7 @@
           <a:p>
             <a:r>
               <a:rPr lang="en-US" dirty="0"/>
-              <a:t>No hay publicado un resultado presidencial o del PRM específico de la OCLEE Philadelphia. Referencias: en la Circunscripción 1, el PRM tenía entre 59.75 % y 60.22 % de los votos de diputados en los conteos preliminares (Diario Libre; Hoy, con 45 % de colegios); a nivel nacional Abinader obtuvo 57.44 %. Se usa 60 % sobre los 8,731 votos emitidos: unos 5,239 votos PRM en 2024 (estimado; los votos válidos son algo menos que los emitidos). Meta mínima 2028: +10 % = 5,763. Escenarios con 60 % de apoyo: Adverso 5,703 votos totales → 3,422; Inercial 8,745 → 5,247 (no alcanza); Realista (abstención 78 %) 10,456 → 6,274 (+20 %); Favorable 11,550 → 6,930 (+32 %). Dos caminos para el +10 %: 9,605 votos totales (participación 20.2 %) con 60 %, o 66 % de apoyo con 8,731 votantes. Red 1+10: 3,982 personas × 85 % = 3,385 votos, el 59 % de 5,763. Supuestos de los escenarios: Adverso, 60 % renueva la cédula y vota el 20 % de los habilitados; Inercial, 80 % y 23 %; Realista, abstención del 78 % sobre el padrón; Favorable, 90 % y 27 %. Sustituir el estimado por el resultado real de las actas de la seccional.</a:t>
+              <a:t>No hay publicado un resultado presidencial o del PRM específico de la OCLEE Philadelphia. Referencias: en la Circunscripción 1, el PRM tenía entre 59.75 % y 60.22 % de los votos de diputados en los conteos preliminares (Diario Libre; Hoy, con 45 % de colegios); a nivel nacional Abinader obtuvo 57.44 %. Se usa 60 % sobre los 8,731 votos emitidos: unos 5,239 votos PRM en 2024 (estimado; los votos válidos son algo menos que los emitidos). Meta mínima 2028: +10 % = 5,763. Escenarios con 60 % de apoyo: Adverso 5,703 votos totales → 3,422; Inercial 8,745 → 5,247 (no alcanza); Realista (abstención 78 %) 10,456 → 6,274 (+20 %); Favorable 11,550 → 6,930 (+32 %). Dos caminos para el +10 %: 9,605 votos totales (participación 20.2 %) con 60 %, o 66 % de apoyo con 8,731 votantes. Red 1+10: 3,982 personas × 85 % = 3,385 votos, el 59 % de 5,763. Tres niveles: piso igualar 2024 (≈5,240), meta +10 % (≈5,760), techo +20 % (≈6,270). Desgaste: un tercer período consecutivo del PRM sin Abinader en la boleta y el malestar social que muestran las encuestas hacen prudente suponer menos apoyo; con 55 % de apoyo la meta exige 10,478 votos totales (22.0 % de participación; 19.7 % si el padrón crece 12 %); con 50 %, 11,526 votos (24.3 %; 21.7 % con padrón +12 %). Supuestos de los escenarios: Adverso, 60 % renueva la cédula y vota el 20 % de los habilitados; Inercial, 80 % y 23 %; Realista, abstención del 78 % sobre el padrón; Favorable, 90 % y 27 %. Sustituir el estimado por el resultado real de las actas de la seccional.</a:t>
             </a:r>
             <a:endParaRPr lang="en-US" dirty="0"/>
           </a:p>
@@ -13112,7 +13112,7 @@
                   <a:schemeClr val="tx1"/>
                 </a:solidFill>
               </a:rPr>
-              <a:t>Al menos 5,760 votos para David Collado y el PRM en 2028: un 10 % más que el PRM en 2024.</a:t>
+              <a:t>5,760 votos para David Collado y el PRM (+10 % sobre 2024). Aun con desgaste, se logra con un 22 % de participación.</a:t>
             </a:r>
             <a:endParaRPr lang="en-US" sz="1500" dirty="0"/>
           </a:p>
@@ -17002,7 +17002,7 @@
                   <a:schemeClr val="tx2"/>
                 </a:solidFill>
               </a:rPr>
-              <a:t>Para superar en 10 % al PRM de 2024 hacen falta unos 5,760 votos: el escenario realista lo logra</a:t>
+              <a:t>Aun con desgaste, superar en 10 % al PRM de 2024 es alcanzable: hace falta un 22 % de participación</a:t>
             </a:r>
             <a:endParaRPr lang="en-US" sz="2800" dirty="0"/>
           </a:p>
@@ -17026,18 +17026,18 @@
       </p:graphicFrame>
       <p:sp>
         <p:nvSpPr>
-          <p:cNvPr id="4" name="Dos caminos"/>
+          <p:cNvPr id="4" name="Tres niveles"/>
           <p:cNvSpPr/>
           <p:nvPr/>
         </p:nvSpPr>
         <p:spPr>
           <a:xfrm>
             <a:off x="7589520" y="1600200"/>
-            <a:ext cx="4050792" cy="2606040"/>
+            <a:ext cx="4050792" cy="1874520"/>
           </a:xfrm>
           <a:prstGeom prst="roundRect">
             <a:avLst>
-              <a:gd name="adj" fmla="val 2807"/>
+              <a:gd name="adj" fmla="val 3902"/>
             </a:avLst>
           </a:prstGeom>
           <a:solidFill>
@@ -17059,8 +17059,8 @@
         </p:nvSpPr>
         <p:spPr>
           <a:xfrm>
-            <a:off x="7818120" y="1737360"/>
-            <a:ext cx="3611880" cy="2377440"/>
+            <a:off x="7818120" y="1691640"/>
+            <a:ext cx="3611880" cy="365760"/>
           </a:xfrm>
           <a:prstGeom prst="rect">
             <a:avLst/>
@@ -17069,13 +17069,10 @@
           <a:ln/>
         </p:spPr>
         <p:txBody>
-          <a:bodyPr wrap="square" lIns="0" tIns="0" rIns="0" bIns="0" rtlCol="0" anchor="t"/>
+          <a:bodyPr wrap="square" lIns="0" tIns="0" rIns="0" bIns="0" rtlCol="0" anchor="ctr"/>
           <a:lstStyle/>
           <a:p>
             <a:pPr indent="0" marL="0">
-              <a:spcAft>
-                <a:spcPts val="600"/>
-              </a:spcAft>
               <a:buNone/>
             </a:pPr>
             <a:r>
@@ -17084,59 +17081,275 @@
                   <a:schemeClr val="tx2"/>
                 </a:solidFill>
               </a:rPr>
-              <a:t>Dos caminos para el +10 %</a:t>
+              <a:t>Tres niveles de meta</a:t>
             </a:r>
             <a:endParaRPr lang="en-US" sz="1700" dirty="0"/>
           </a:p>
-          <a:p>
-            <a:pPr marL="342900" indent="-342900">
-              <a:spcAft>
-                <a:spcPts val="600"/>
-              </a:spcAft>
-              <a:buSzPct val="100000"/>
-              <a:buChar char="•"/>
+        </p:txBody>
+      </p:sp>
+      <p:sp>
+        <p:nvSpPr>
+          <p:cNvPr id="6" name="Text 3"/>
+          <p:cNvSpPr txBox="1"/>
+          <p:nvPr/>
+        </p:nvSpPr>
+        <p:spPr>
+          <a:xfrm>
+            <a:off x="7818120" y="2121408"/>
+            <a:ext cx="2377440" cy="384048"/>
+          </a:xfrm>
+          <a:prstGeom prst="rect">
+            <a:avLst/>
+          </a:prstGeom>
+          <a:noFill/>
+          <a:ln/>
+        </p:spPr>
+        <p:txBody>
+          <a:bodyPr wrap="square" lIns="0" tIns="0" rIns="0" bIns="0" rtlCol="0" anchor="ctr"/>
+          <a:lstStyle/>
+          <a:p>
+            <a:pPr indent="0" marL="0">
+              <a:buNone/>
             </a:pPr>
             <a:r>
-              <a:rPr lang="en-US" sz="1400" dirty="0">
-                <a:solidFill>
-                  <a:schemeClr val="tx1"/>
+              <a:rPr lang="en-US" sz="1500" b="1" dirty="0">
+                <a:solidFill>
+                  <a:schemeClr val="tx2"/>
                 </a:solidFill>
               </a:rPr>
-              <a:t>Más votantes: subir la participación al 20.2 % (unos 9,600 votos) con el mismo 60 % de apoyo</a:t>
+              <a:t>Piso  </a:t>
             </a:r>
-            <a:endParaRPr lang="en-US" sz="1700" dirty="0"/>
-          </a:p>
-          <a:p>
-            <a:pPr marL="342900" indent="-342900">
-              <a:buSzPct val="100000"/>
-              <a:buChar char="•"/>
+            <a:pPr indent="0" marL="0">
+              <a:buNone/>
             </a:pPr>
             <a:r>
-              <a:rPr lang="en-US" sz="1400" dirty="0">
+              <a:rPr lang="en-US" sz="1500" dirty="0">
                 <a:solidFill>
                   <a:schemeClr val="tx1"/>
                 </a:solidFill>
               </a:rPr>
-              <a:t>Más apoyo: con los mismos 8,731 votantes, subir el apoyo al PRM del 60 % al 66 %</a:t>
+              <a:t>igualar 2024</a:t>
             </a:r>
-            <a:endParaRPr lang="en-US" sz="1700" dirty="0"/>
+            <a:endParaRPr lang="en-US" sz="1500" dirty="0"/>
           </a:p>
         </p:txBody>
       </p:sp>
       <p:sp>
         <p:nvSpPr>
-          <p:cNvPr id="6" name="Aporte red"/>
+          <p:cNvPr id="7" name="Text 4"/>
+          <p:cNvSpPr txBox="1"/>
+          <p:nvPr/>
+        </p:nvSpPr>
+        <p:spPr>
+          <a:xfrm>
+            <a:off x="10058400" y="2121408"/>
+            <a:ext cx="1371600" cy="384048"/>
+          </a:xfrm>
+          <a:prstGeom prst="rect">
+            <a:avLst/>
+          </a:prstGeom>
+          <a:noFill/>
+          <a:ln/>
+        </p:spPr>
+        <p:txBody>
+          <a:bodyPr wrap="square" lIns="0" tIns="0" rIns="0" bIns="0" rtlCol="0" anchor="ctr"/>
+          <a:lstStyle/>
+          <a:p>
+            <a:pPr algn="r" indent="0" marL="0">
+              <a:buNone/>
+            </a:pPr>
+            <a:r>
+              <a:rPr lang="en-US" sz="1500" b="1" dirty="0">
+                <a:solidFill>
+                  <a:schemeClr val="tx2"/>
+                </a:solidFill>
+              </a:rPr>
+              <a:t>5,240 votos</a:t>
+            </a:r>
+            <a:endParaRPr lang="en-US" sz="1500" dirty="0"/>
+          </a:p>
+        </p:txBody>
+      </p:sp>
+      <p:sp>
+        <p:nvSpPr>
+          <p:cNvPr id="8" name="Text 5"/>
+          <p:cNvSpPr txBox="1"/>
+          <p:nvPr/>
+        </p:nvSpPr>
+        <p:spPr>
+          <a:xfrm>
+            <a:off x="7818120" y="2551176"/>
+            <a:ext cx="2377440" cy="384048"/>
+          </a:xfrm>
+          <a:prstGeom prst="rect">
+            <a:avLst/>
+          </a:prstGeom>
+          <a:noFill/>
+          <a:ln/>
+        </p:spPr>
+        <p:txBody>
+          <a:bodyPr wrap="square" lIns="0" tIns="0" rIns="0" bIns="0" rtlCol="0" anchor="ctr"/>
+          <a:lstStyle/>
+          <a:p>
+            <a:pPr indent="0" marL="0">
+              <a:buNone/>
+            </a:pPr>
+            <a:r>
+              <a:rPr lang="en-US" sz="1500" b="1" dirty="0">
+                <a:solidFill>
+                  <a:schemeClr val="accent2"/>
+                </a:solidFill>
+              </a:rPr>
+              <a:t>Meta  </a:t>
+            </a:r>
+            <a:pPr indent="0" marL="0">
+              <a:buNone/>
+            </a:pPr>
+            <a:r>
+              <a:rPr lang="en-US" sz="1500" dirty="0">
+                <a:solidFill>
+                  <a:schemeClr val="tx1"/>
+                </a:solidFill>
+              </a:rPr>
+              <a:t>+10 %</a:t>
+            </a:r>
+            <a:endParaRPr lang="en-US" sz="1500" dirty="0"/>
+          </a:p>
+        </p:txBody>
+      </p:sp>
+      <p:sp>
+        <p:nvSpPr>
+          <p:cNvPr id="9" name="Text 6"/>
+          <p:cNvSpPr txBox="1"/>
+          <p:nvPr/>
+        </p:nvSpPr>
+        <p:spPr>
+          <a:xfrm>
+            <a:off x="10058400" y="2551176"/>
+            <a:ext cx="1371600" cy="384048"/>
+          </a:xfrm>
+          <a:prstGeom prst="rect">
+            <a:avLst/>
+          </a:prstGeom>
+          <a:noFill/>
+          <a:ln/>
+        </p:spPr>
+        <p:txBody>
+          <a:bodyPr wrap="square" lIns="0" tIns="0" rIns="0" bIns="0" rtlCol="0" anchor="ctr"/>
+          <a:lstStyle/>
+          <a:p>
+            <a:pPr algn="r" indent="0" marL="0">
+              <a:buNone/>
+            </a:pPr>
+            <a:r>
+              <a:rPr lang="en-US" sz="1500" b="1" dirty="0">
+                <a:solidFill>
+                  <a:schemeClr val="accent2"/>
+                </a:solidFill>
+              </a:rPr>
+              <a:t>5,760 votos</a:t>
+            </a:r>
+            <a:endParaRPr lang="en-US" sz="1500" dirty="0"/>
+          </a:p>
+        </p:txBody>
+      </p:sp>
+      <p:sp>
+        <p:nvSpPr>
+          <p:cNvPr id="10" name="Text 7"/>
+          <p:cNvSpPr txBox="1"/>
+          <p:nvPr/>
+        </p:nvSpPr>
+        <p:spPr>
+          <a:xfrm>
+            <a:off x="7818120" y="2980944"/>
+            <a:ext cx="2377440" cy="384048"/>
+          </a:xfrm>
+          <a:prstGeom prst="rect">
+            <a:avLst/>
+          </a:prstGeom>
+          <a:noFill/>
+          <a:ln/>
+        </p:spPr>
+        <p:txBody>
+          <a:bodyPr wrap="square" lIns="0" tIns="0" rIns="0" bIns="0" rtlCol="0" anchor="ctr"/>
+          <a:lstStyle/>
+          <a:p>
+            <a:pPr indent="0" marL="0">
+              <a:buNone/>
+            </a:pPr>
+            <a:r>
+              <a:rPr lang="en-US" sz="1500" b="1" dirty="0">
+                <a:solidFill>
+                  <a:schemeClr val="tx2"/>
+                </a:solidFill>
+              </a:rPr>
+              <a:t>Techo  </a:t>
+            </a:r>
+            <a:pPr indent="0" marL="0">
+              <a:buNone/>
+            </a:pPr>
+            <a:r>
+              <a:rPr lang="en-US" sz="1500" dirty="0">
+                <a:solidFill>
+                  <a:schemeClr val="tx1"/>
+                </a:solidFill>
+              </a:rPr>
+              <a:t>+20 %</a:t>
+            </a:r>
+            <a:endParaRPr lang="en-US" sz="1500" dirty="0"/>
+          </a:p>
+        </p:txBody>
+      </p:sp>
+      <p:sp>
+        <p:nvSpPr>
+          <p:cNvPr id="11" name="Text 8"/>
+          <p:cNvSpPr txBox="1"/>
+          <p:nvPr/>
+        </p:nvSpPr>
+        <p:spPr>
+          <a:xfrm>
+            <a:off x="10058400" y="2980944"/>
+            <a:ext cx="1371600" cy="384048"/>
+          </a:xfrm>
+          <a:prstGeom prst="rect">
+            <a:avLst/>
+          </a:prstGeom>
+          <a:noFill/>
+          <a:ln/>
+        </p:spPr>
+        <p:txBody>
+          <a:bodyPr wrap="square" lIns="0" tIns="0" rIns="0" bIns="0" rtlCol="0" anchor="ctr"/>
+          <a:lstStyle/>
+          <a:p>
+            <a:pPr algn="r" indent="0" marL="0">
+              <a:buNone/>
+            </a:pPr>
+            <a:r>
+              <a:rPr lang="en-US" sz="1500" b="1" dirty="0">
+                <a:solidFill>
+                  <a:schemeClr val="tx2"/>
+                </a:solidFill>
+              </a:rPr>
+              <a:t>6,270 votos</a:t>
+            </a:r>
+            <a:endParaRPr lang="en-US" sz="1500" dirty="0"/>
+          </a:p>
+        </p:txBody>
+      </p:sp>
+      <p:sp>
+        <p:nvSpPr>
+          <p:cNvPr id="12" name="Desgaste"/>
           <p:cNvSpPr/>
           <p:nvPr/>
         </p:nvSpPr>
         <p:spPr>
           <a:xfrm>
-            <a:off x="7589520" y="4389120"/>
-            <a:ext cx="4050792" cy="1463040"/>
+            <a:off x="7589520" y="3657600"/>
+            <a:ext cx="4050792" cy="2194560"/>
           </a:xfrm>
           <a:prstGeom prst="roundRect">
             <a:avLst>
-              <a:gd name="adj" fmla="val 5000"/>
+              <a:gd name="adj" fmla="val 3333"/>
             </a:avLst>
           </a:prstGeom>
           <a:solidFill>
@@ -17152,14 +17365,14 @@
       </p:sp>
       <p:sp>
         <p:nvSpPr>
-          <p:cNvPr id="7" name="Text 4"/>
+          <p:cNvPr id="13" name="Text 10"/>
           <p:cNvSpPr txBox="1"/>
           <p:nvPr/>
         </p:nvSpPr>
         <p:spPr>
           <a:xfrm>
-            <a:off x="7818120" y="4462272"/>
-            <a:ext cx="3611880" cy="1316736"/>
+            <a:off x="7818120" y="3749040"/>
+            <a:ext cx="3611880" cy="548640"/>
           </a:xfrm>
           <a:prstGeom prst="rect">
             <a:avLst/>
@@ -17175,34 +17388,236 @@
               <a:buNone/>
             </a:pPr>
             <a:r>
-              <a:rPr lang="en-US" sz="2400" b="1" dirty="0">
+              <a:rPr lang="en-US" sz="1500" b="1" dirty="0">
                 <a:solidFill>
                   <a:schemeClr val="bg1"/>
                 </a:solidFill>
               </a:rPr>
-              <a:t>59 % de la meta</a:t>
+              <a:t>Si hay desgaste: participación necesaria para la meta</a:t>
             </a:r>
-            <a:endParaRPr lang="en-US" sz="2400" dirty="0"/>
-          </a:p>
+            <a:endParaRPr lang="en-US" sz="1500" dirty="0"/>
+          </a:p>
+        </p:txBody>
+      </p:sp>
+      <p:sp>
+        <p:nvSpPr>
+          <p:cNvPr id="14" name="Text 11"/>
+          <p:cNvSpPr txBox="1"/>
+          <p:nvPr/>
+        </p:nvSpPr>
+        <p:spPr>
+          <a:xfrm>
+            <a:off x="7818120" y="4370832"/>
+            <a:ext cx="2743200" cy="411480"/>
+          </a:xfrm>
+          <a:prstGeom prst="rect">
+            <a:avLst/>
+          </a:prstGeom>
+          <a:noFill/>
+          <a:ln/>
+        </p:spPr>
+        <p:txBody>
+          <a:bodyPr wrap="square" lIns="0" tIns="0" rIns="0" bIns="0" rtlCol="0" anchor="ctr"/>
+          <a:lstStyle/>
           <a:p>
             <a:pPr indent="0" marL="0">
               <a:buNone/>
             </a:pPr>
             <a:r>
-              <a:rPr lang="en-US" sz="1400" dirty="0">
+              <a:rPr lang="en-US" sz="1300" dirty="0">
                 <a:solidFill>
                   <a:schemeClr val="accent4"/>
                 </a:solidFill>
               </a:rPr>
-              <a:t>lo cubre la red 1+10: 3,982 personas, de las que se espera que voten unas 3,385</a:t>
+              <a:t>Apoyo 60 % (igual que 2024)</a:t>
             </a:r>
-            <a:endParaRPr lang="en-US" sz="2400" dirty="0"/>
+            <a:endParaRPr lang="en-US" sz="1300" dirty="0"/>
           </a:p>
         </p:txBody>
       </p:sp>
       <p:sp>
         <p:nvSpPr>
-          <p:cNvPr id="8" name="Fuente"/>
+          <p:cNvPr id="15" name="Text 12"/>
+          <p:cNvSpPr txBox="1"/>
+          <p:nvPr/>
+        </p:nvSpPr>
+        <p:spPr>
+          <a:xfrm>
+            <a:off x="10515600" y="4370832"/>
+            <a:ext cx="914400" cy="411480"/>
+          </a:xfrm>
+          <a:prstGeom prst="rect">
+            <a:avLst/>
+          </a:prstGeom>
+          <a:noFill/>
+          <a:ln/>
+        </p:spPr>
+        <p:txBody>
+          <a:bodyPr wrap="square" lIns="0" tIns="0" rIns="0" bIns="0" rtlCol="0" anchor="ctr"/>
+          <a:lstStyle/>
+          <a:p>
+            <a:pPr algn="r" indent="0" marL="0">
+              <a:buNone/>
+            </a:pPr>
+            <a:r>
+              <a:rPr lang="en-US" sz="1600" b="1" dirty="0">
+                <a:solidFill>
+                  <a:schemeClr val="bg1"/>
+                </a:solidFill>
+              </a:rPr>
+              <a:t>20.2 %</a:t>
+            </a:r>
+            <a:endParaRPr lang="en-US" sz="1600" dirty="0"/>
+          </a:p>
+        </p:txBody>
+      </p:sp>
+      <p:sp>
+        <p:nvSpPr>
+          <p:cNvPr id="16" name="Text 13"/>
+          <p:cNvSpPr txBox="1"/>
+          <p:nvPr/>
+        </p:nvSpPr>
+        <p:spPr>
+          <a:xfrm>
+            <a:off x="7818120" y="4828032"/>
+            <a:ext cx="2743200" cy="411480"/>
+          </a:xfrm>
+          <a:prstGeom prst="rect">
+            <a:avLst/>
+          </a:prstGeom>
+          <a:noFill/>
+          <a:ln/>
+        </p:spPr>
+        <p:txBody>
+          <a:bodyPr wrap="square" lIns="0" tIns="0" rIns="0" bIns="0" rtlCol="0" anchor="ctr"/>
+          <a:lstStyle/>
+          <a:p>
+            <a:pPr indent="0" marL="0">
+              <a:buNone/>
+            </a:pPr>
+            <a:r>
+              <a:rPr lang="en-US" sz="1300" b="1" dirty="0">
+                <a:solidFill>
+                  <a:schemeClr val="bg1"/>
+                </a:solidFill>
+              </a:rPr>
+              <a:t>Apoyo 55 % (desgaste moderado)</a:t>
+            </a:r>
+            <a:endParaRPr lang="en-US" sz="1300" dirty="0"/>
+          </a:p>
+        </p:txBody>
+      </p:sp>
+      <p:sp>
+        <p:nvSpPr>
+          <p:cNvPr id="17" name="Text 14"/>
+          <p:cNvSpPr txBox="1"/>
+          <p:nvPr/>
+        </p:nvSpPr>
+        <p:spPr>
+          <a:xfrm>
+            <a:off x="10515600" y="4828032"/>
+            <a:ext cx="914400" cy="411480"/>
+          </a:xfrm>
+          <a:prstGeom prst="rect">
+            <a:avLst/>
+          </a:prstGeom>
+          <a:noFill/>
+          <a:ln/>
+        </p:spPr>
+        <p:txBody>
+          <a:bodyPr wrap="square" lIns="0" tIns="0" rIns="0" bIns="0" rtlCol="0" anchor="ctr"/>
+          <a:lstStyle/>
+          <a:p>
+            <a:pPr algn="r" indent="0" marL="0">
+              <a:buNone/>
+            </a:pPr>
+            <a:r>
+              <a:rPr lang="en-US" sz="1600" b="1" dirty="0">
+                <a:solidFill>
+                  <a:schemeClr val="bg1"/>
+                </a:solidFill>
+              </a:rPr>
+              <a:t>22.0 %</a:t>
+            </a:r>
+            <a:endParaRPr lang="en-US" sz="1600" dirty="0"/>
+          </a:p>
+        </p:txBody>
+      </p:sp>
+      <p:sp>
+        <p:nvSpPr>
+          <p:cNvPr id="18" name="Text 15"/>
+          <p:cNvSpPr txBox="1"/>
+          <p:nvPr/>
+        </p:nvSpPr>
+        <p:spPr>
+          <a:xfrm>
+            <a:off x="7818120" y="5285232"/>
+            <a:ext cx="2743200" cy="411480"/>
+          </a:xfrm>
+          <a:prstGeom prst="rect">
+            <a:avLst/>
+          </a:prstGeom>
+          <a:noFill/>
+          <a:ln/>
+        </p:spPr>
+        <p:txBody>
+          <a:bodyPr wrap="square" lIns="0" tIns="0" rIns="0" bIns="0" rtlCol="0" anchor="ctr"/>
+          <a:lstStyle/>
+          <a:p>
+            <a:pPr indent="0" marL="0">
+              <a:buNone/>
+            </a:pPr>
+            <a:r>
+              <a:rPr lang="en-US" sz="1300" dirty="0">
+                <a:solidFill>
+                  <a:schemeClr val="accent4"/>
+                </a:solidFill>
+              </a:rPr>
+              <a:t>Apoyo 50 % (desgaste fuerte)</a:t>
+            </a:r>
+            <a:endParaRPr lang="en-US" sz="1300" dirty="0"/>
+          </a:p>
+        </p:txBody>
+      </p:sp>
+      <p:sp>
+        <p:nvSpPr>
+          <p:cNvPr id="19" name="Text 16"/>
+          <p:cNvSpPr txBox="1"/>
+          <p:nvPr/>
+        </p:nvSpPr>
+        <p:spPr>
+          <a:xfrm>
+            <a:off x="10515600" y="5285232"/>
+            <a:ext cx="914400" cy="411480"/>
+          </a:xfrm>
+          <a:prstGeom prst="rect">
+            <a:avLst/>
+          </a:prstGeom>
+          <a:noFill/>
+          <a:ln/>
+        </p:spPr>
+        <p:txBody>
+          <a:bodyPr wrap="square" lIns="0" tIns="0" rIns="0" bIns="0" rtlCol="0" anchor="ctr"/>
+          <a:lstStyle/>
+          <a:p>
+            <a:pPr algn="r" indent="0" marL="0">
+              <a:buNone/>
+            </a:pPr>
+            <a:r>
+              <a:rPr lang="en-US" sz="1600" b="1" dirty="0">
+                <a:solidFill>
+                  <a:schemeClr val="bg1"/>
+                </a:solidFill>
+              </a:rPr>
+              <a:t>24.3 %</a:t>
+            </a:r>
+            <a:endParaRPr lang="en-US" sz="1600" dirty="0"/>
+          </a:p>
+        </p:txBody>
+      </p:sp>
+      <p:sp>
+        <p:nvSpPr>
+          <p:cNvPr id="20" name="Fuente"/>
           <p:cNvSpPr txBox="1"/>
           <p:nvPr/>
         </p:nvSpPr>

</xml_diff>

<commit_message>
Quitar referencias a recintos
Co-Authored-By: Claude Opus 5.5 <noreply@anthropic.com>
Claude-Session: https://claude.ai/code/session_01RrEJtrwRidXxzgveZEVQjf
</commit_message>
<xml_diff>
--- a/presentaciones/Plan_Estrategico_Pennsylvania_2028.pptx
+++ b/presentaciones/Plan_Estrategico_Pennsylvania_2028.pptx
@@ -119,7 +119,7 @@
   <p:extLst>
     <p:ext uri="{521415D9-36F7-43E2-AB2F-B90AF26B5E84}">
       <p14:sectionLst xmlns:p14="http://schemas.microsoft.com/office/powerpoint/2010/main">
-        <p14:section name="Diagnóstico" id="{55215e52-dfcf-d293-fb98-6690c6c6b4df}">
+        <p14:section name="Diagnóstico" id="{778caba7-ace0-b31e-59f6-569254a404b8}">
           <p14:sldIdLst>
             <p14:sldId id="256"/>
             <p14:sldId id="257"/>
@@ -127,19 +127,19 @@
             <p14:sldId id="259"/>
           </p14:sldIdLst>
         </p14:section>
-        <p14:section name="Desafíos" id="{8411a7d9-b139-5489-8bd4-11928ad88145}">
+        <p14:section name="Desafíos" id="{878a704d-febb-609c-1322-5cf6c9cdf36e}">
           <p14:sldIdLst>
             <p14:sldId id="260"/>
             <p14:sldId id="261"/>
           </p14:sldIdLst>
         </p14:section>
-        <p14:section name="Escenarios y meta" id="{a0d7f505-fffc-d0fa-0ef2-9bb22c8504c8}">
+        <p14:section name="Escenarios y meta" id="{ead50a3b-991f-5d08-c3f3-a0e2ba855187}">
           <p14:sldIdLst>
             <p14:sldId id="262"/>
             <p14:sldId id="263"/>
           </p14:sldIdLst>
         </p14:section>
-        <p14:section name="Plan y recomendación" id="{9353d3d5-e4d6-ff6e-7a8d-3c3a5b3f60ad}">
+        <p14:section name="Plan y recomendación" id="{73c9cfe9-6ef9-d9f1-a30c-1a23d549ea8c}">
           <p14:sldIdLst>
             <p14:sldId id="264"/>
             <p14:sldId id="265"/>
@@ -147,7 +147,7 @@
             <p14:sldId id="267"/>
           </p14:sldIdLst>
         </p14:section>
-        <p14:section name="Anexo" id="{20eaf389-659d-c312-1178-60615d97db4a}">
+        <p14:section name="Anexo" id="{6afe78bb-5508-20e9-9968-c66be43437b4}">
           <p14:sldIdLst>
             <p14:sldId id="268"/>
           </p14:sldIdLst>
@@ -2138,7 +2138,7 @@
           <a:p>
             <a:r>
               <a:rPr lang="en-US" dirty="0"/>
-              <a:t>Esta es la diapositiva para quien solo lea una. Problema: participación de 18.4 % (8,731 de 47,529) y riesgo de la nueva cédula. Plan: 8 zonas, 18 recintos, 362 equipos 1+10 (3,982 personas). Meta: superar en al menos 10 % los votos estimados del PRM en 2024 (unos 5,239 → 5,763). Decisión: aprobar, nombrar coordinadores e iniciar en noviembre.</a:t>
+              <a:t>Esta es la diapositiva para quien solo lea una. Problema: participación de 18.4 % (8,731 de 47,529) y riesgo de la nueva cédula. Plan: 8 zonas, 362 equipos 1+10 (3,982 personas). Meta: superar en al menos 10 % los votos estimados del PRM en 2024 (unos 5,239 → 5,763). Decisión: aprobar, nombrar coordinadores e iniciar en noviembre.</a:t>
             </a:r>
             <a:endParaRPr lang="en-US" dirty="0"/>
           </a:p>
@@ -3765,7 +3765,7 @@
                   <a:schemeClr val="bg1"/>
                 </a:solidFill>
               </a:rPr>
-              <a:t>18</a:t>
+              <a:t>8</a:t>
             </a:r>
             <a:endParaRPr lang="en-US" sz="3000" dirty="0"/>
           </a:p>
@@ -3779,7 +3779,7 @@
                   <a:schemeClr val="accent4"/>
                 </a:solidFill>
               </a:rPr>
-              <a:t>recintos</a:t>
+              <a:t>zonas de trabajo</a:t>
             </a:r>
             <a:endParaRPr lang="en-US" sz="3000" dirty="0"/>
           </a:p>
@@ -3977,7 +3977,7 @@
                   <a:schemeClr val="accent4"/>
                 </a:solidFill>
               </a:rPr>
-              <a:t>Fuente: padrón por recinto, Seccional PRM Pennsylvania (2024) · Votos emitidos JCE 2024 (OCLEE Philadelphia)</a:t>
+              <a:t>Fuente: padrón electoral, Seccional PRM Pennsylvania (2024) · Votos emitidos JCE 2024 (OCLEE Philadelphia)</a:t>
             </a:r>
             <a:endParaRPr lang="en-US" sz="1000" dirty="0"/>
           </a:p>
@@ -4307,7 +4307,7 @@
                   <a:schemeClr val="tx1"/>
                 </a:solidFill>
               </a:rPr>
-              <a:t>Nombrar a los 18 responsables de recinto y pedir a la JCE y a los consulados el dato de cédulas renovadas en PA</a:t>
+              <a:t>Formar el equipo de cada zona y pedir a la JCE y a los consulados el dato de cédulas renovadas en PA</a:t>
             </a:r>
             <a:endParaRPr lang="en-US" sz="1600" dirty="0"/>
           </a:p>
@@ -8098,7 +8098,7 @@
                   <a:schemeClr val="accent4"/>
                 </a:solidFill>
               </a:rPr>
-              <a:t>Allentown y Hazleton (25 mesas, 2 recintos) y Reading (18 % del padrón)</a:t>
+              <a:t>Allentown y Hazleton (25 mesas en 2 ciudades) y Reading (18 % del padrón)</a:t>
             </a:r>
             <a:endParaRPr lang="en-US" sz="1600" dirty="0"/>
           </a:p>
@@ -8197,7 +8197,7 @@
                   <a:schemeClr val="accent4"/>
                 </a:solidFill>
               </a:rPr>
-              <a:t>8 de 18 recintos son iglesias y centros comunitarios: de ahí salen los responsables</a:t>
+              <a:t>Iglesias, asociaciones y comercios dominicanos: de ahí salen los líderes de cada zona</a:t>
             </a:r>
             <a:endParaRPr lang="en-US" sz="1600" dirty="0"/>
           </a:p>
@@ -12661,7 +12661,7 @@
                   <a:schemeClr val="accent4"/>
                 </a:solidFill>
               </a:rPr>
-              <a:t>electores en 18 recintos</a:t>
+              <a:t>electores en 13 ciudades</a:t>
             </a:r>
             <a:endParaRPr lang="en-US" sz="3400" dirty="0"/>
           </a:p>
@@ -13013,7 +13013,7 @@
                   <a:schemeClr val="tx1"/>
                 </a:solidFill>
               </a:rPr>
-              <a:t>8 zonas, 18 responsables de recinto y 362 equipos 1+10. La cédula y el traslado de los recién llegados son la puerta de entrada.</a:t>
+              <a:t>8 zonas, 8 coordinadores y 362 equipos 1+10. La cédula y el traslado de los recién llegados son la puerta de entrada.</a:t>
             </a:r>
             <a:endParaRPr lang="en-US" sz="1500" dirty="0"/>
           </a:p>
@@ -13247,7 +13247,7 @@
                   <a:schemeClr val="accent4"/>
                 </a:solidFill>
               </a:rPr>
-              <a:t>Fuentes: Seccional PRM Pennsylvania (padrón por recinto); JCE 2024; INDEX (Registro Sociodemográfico). Meta PRM: estimación propia, ver diapositiva de la meta.</a:t>
+              <a:t>Fuentes: Seccional PRM Pennsylvania (padrón electoral); JCE 2024; INDEX (Registro Sociodemográfico). Meta PRM: estimación propia, ver diapositiva de la meta.</a:t>
             </a:r>
             <a:endParaRPr lang="en-US" sz="1000" dirty="0"/>
           </a:p>
@@ -13525,7 +13525,7 @@
                   <a:schemeClr val="tx1"/>
                 </a:solidFill>
               </a:rPr>
-              <a:t>en solo 2 recintos: Allentown (14) y Hazleton (11). Máxima cobertura con mínima estructura</a:t>
+              <a:t>concentradas en solo 2 ciudades: Allentown (14) y Hazleton (11). Máxima cobertura con mínima estructura</a:t>
             </a:r>
             <a:endParaRPr lang="en-US" sz="3600" dirty="0"/>
           </a:p>
@@ -13561,7 +13561,7 @@
                   <a:schemeClr val="accent4"/>
                 </a:solidFill>
               </a:rPr>
-              <a:t>Fuente: Seccional PRM Pennsylvania, Recintos y Colegios Electorales 2024 (18 recintos, 84 mesas, 47,529 electores)</a:t>
+              <a:t>Fuente: Seccional PRM Pennsylvania, padrón electoral 2024 (84 mesas, 47,529 electores, 13 ciudades)</a:t>
             </a:r>
             <a:endParaRPr lang="en-US" sz="1000" dirty="0"/>
           </a:p>
@@ -18110,7 +18110,7 @@
                             <a:schemeClr val="tx1"/>
                           </a:solidFill>
                         </a:rPr>
-                        <a:t>Philadelphia Noreste (3 recintos)</a:t>
+                        <a:t>Philadelphia Noreste</a:t>
                       </a:r>
                       <a:endParaRPr lang="en-US" sz="1300" dirty="0"/>
                     </a:p>
@@ -18402,7 +18402,7 @@
                             <a:schemeClr val="tx1"/>
                           </a:solidFill>
                         </a:rPr>
-                        <a:t>Philadelphia Kensington (2 recintos)</a:t>
+                        <a:t>Philadelphia Kensington</a:t>
                       </a:r>
                       <a:endParaRPr lang="en-US" sz="1300" dirty="0"/>
                     </a:p>
@@ -22429,28 +22429,6 @@
           <a:bodyPr wrap="square" lIns="0" tIns="0" rIns="0" bIns="0" rtlCol="0" anchor="ctr"/>
           <a:lstStyle/>
           <a:p>
-            <a:pPr algn="ctr" indent="0" marL="0">
-              <a:buNone/>
-            </a:pPr>
-            <a:r>
-              <a:rPr lang="en-US" sz="1600" b="1" dirty="0">
-                <a:solidFill>
-                  <a:schemeClr val="bg1"/>
-                </a:solidFill>
-              </a:rPr>
-              <a:t>18 responsables de recinto</a:t>
-            </a:r>
-            <a:pPr algn="ctr" indent="0" marL="0">
-              <a:buNone/>
-            </a:pPr>
-            <a:r>
-              <a:rPr lang="en-US" sz="1600" dirty="0">
-                <a:solidFill>
-                  <a:schemeClr val="accent4"/>
-                </a:solidFill>
-              </a:rPr>
-              <a:t>   →   </a:t>
-            </a:r>
             <a:pPr algn="ctr" indent="0" marL="0">
               <a:buNone/>
             </a:pPr>

</xml_diff>

<commit_message>
Meta de organización simplificada: 400 líderes con 10 personas (4,000)
Co-Authored-By: Claude Opus 5.5 <noreply@anthropic.com>
Claude-Session: https://claude.ai/code/session_01RrEJtrwRidXxzgveZEVQjf
</commit_message>
<xml_diff>
--- a/presentaciones/Plan_Estrategico_Pennsylvania_2028.pptx
+++ b/presentaciones/Plan_Estrategico_Pennsylvania_2028.pptx
@@ -119,7 +119,7 @@
   <p:extLst>
     <p:ext uri="{521415D9-36F7-43E2-AB2F-B90AF26B5E84}">
       <p14:sectionLst xmlns:p14="http://schemas.microsoft.com/office/powerpoint/2010/main">
-        <p14:section name="Diagnóstico" id="{778caba7-ace0-b31e-59f6-569254a404b8}">
+        <p14:section name="Diagnóstico" id="{576c6ff5-d818-9104-4dc8-74f68378f0f4}">
           <p14:sldIdLst>
             <p14:sldId id="256"/>
             <p14:sldId id="257"/>
@@ -127,19 +127,19 @@
             <p14:sldId id="259"/>
           </p14:sldIdLst>
         </p14:section>
-        <p14:section name="Desafíos" id="{878a704d-febb-609c-1322-5cf6c9cdf36e}">
+        <p14:section name="Desafíos" id="{609e4f4a-4d77-77f4-4194-79cf8c934830}">
           <p14:sldIdLst>
             <p14:sldId id="260"/>
             <p14:sldId id="261"/>
           </p14:sldIdLst>
         </p14:section>
-        <p14:section name="Escenarios y meta" id="{ead50a3b-991f-5d08-c3f3-a0e2ba855187}">
+        <p14:section name="Escenarios y meta" id="{15e13e0d-1ea4-574d-7350-a7c77bc4a4b4}">
           <p14:sldIdLst>
             <p14:sldId id="262"/>
             <p14:sldId id="263"/>
           </p14:sldIdLst>
         </p14:section>
-        <p14:section name="Plan y recomendación" id="{73c9cfe9-6ef9-d9f1-a30c-1a23d549ea8c}">
+        <p14:section name="Plan y recomendación" id="{5efc1665-fe24-47b8-22b7-106a58f77fe5}">
           <p14:sldIdLst>
             <p14:sldId id="264"/>
             <p14:sldId id="265"/>
@@ -147,7 +147,7 @@
             <p14:sldId id="267"/>
           </p14:sldIdLst>
         </p14:section>
-        <p14:section name="Anexo" id="{6afe78bb-5508-20e9-9968-c66be43437b4}">
+        <p14:section name="Anexo" id="{7beeb31f-b729-a516-cd6c-2423cbd9764a}">
           <p14:sldIdLst>
             <p14:sldId id="268"/>
           </p14:sldIdLst>
@@ -1786,7 +1786,7 @@
           <a:p>
             <a:r>
               <a:rPr lang="en-US" dirty="0"/>
-              <a:t>Plan de arranque de 30 días con entregables verificables. Ritmo de la meta: 362 equipos en unas 13 semanas, unos 28 por semana; si en la semana 4 hay menos de 80 equipos en marcha, se reasignan recursos y se replanifica. Después siguen las 4 etapas hasta mayo de 2028. La fecha legal de primarias es el 3 de octubre de 2027.</a:t>
+              <a:t>Plan de arranque de 30 días con entregables verificables. Ritmo de la meta: 400 líderes en unas 13 semanas, unos 31 por semana; si en la semana 4 hay menos de 90 líderes, se reasignan recursos y se replanifica. Después siguen las 4 etapas hasta mayo de 2028. La fecha legal de primarias es el 3 de octubre de 2027.</a:t>
             </a:r>
             <a:endParaRPr lang="en-US" dirty="0"/>
           </a:p>
@@ -2138,7 +2138,7 @@
           <a:p>
             <a:r>
               <a:rPr lang="en-US" dirty="0"/>
-              <a:t>Esta es la diapositiva para quien solo lea una. Problema: participación de 18.4 % (8,731 de 47,529) y riesgo de la nueva cédula. Plan: 8 zonas, 362 equipos 1+10 (3,982 personas). Meta: superar en al menos 10 % los votos estimados del PRM en 2024 (unos 5,239 → 5,763). Decisión: aprobar, nombrar coordinadores e iniciar en noviembre.</a:t>
+              <a:t>Esta es la diapositiva para quien solo lea una. Problema: participación de 18.4 % (8,731 de 47,529) y riesgo de la nueva cédula. Plan: 8 zonas, 400 líderes con 10 personas cada uno (4,000 personas). Meta: superar en al menos 10 % los votos estimados del PRM en 2024 (unos 5,239 → 5,763). Decisión: aprobar, nombrar coordinadores e iniciar en noviembre.</a:t>
             </a:r>
             <a:endParaRPr lang="en-US" dirty="0"/>
           </a:p>
@@ -2490,7 +2490,7 @@
           <a:p>
             <a:r>
               <a:rPr lang="en-US" dirty="0"/>
-              <a:t>No hay cifra pública de cédulas renovadas en Pennsylvania; a nivel nacional la JCE reporta 4,009,576 entregadas (45.9 % de 8,730,372) al 13 de octubre de 2026. Pedir el dato a la JCE y a los consulados de Filadelfia y Allentown y medirlo en la red 1+10. Escenarios de habilitación: proyección propia sobre el padrón de la seccional. La JCE ya hizo operativos de empadronamiento en Lancaster y Lebanon en 2023; la entrega en el exterior se ampliará a más locales cuando los consulados obtengan autorización del Departamento de Estado.</a:t>
+              <a:t>No hay cifra pública de cédulas renovadas en Pennsylvania; a nivel nacional la JCE reporta 4,009,576 entregadas (45.9 % de 8,730,372) al 13 de octubre de 2026. Pedir el dato a la JCE y a los consulados de Filadelfia y Allentown y medirlo en la red de líderes. Escenarios de habilitación: proyección propia sobre el padrón de la seccional. La JCE ya hizo operativos de empadronamiento en Lancaster y Lebanon en 2023; la entrega en el exterior se ampliará a más locales cuando los consulados obtengan autorización del Departamento de Estado.</a:t>
             </a:r>
             <a:endParaRPr lang="en-US" dirty="0"/>
           </a:p>
@@ -2578,7 +2578,7 @@
           <a:p>
             <a:r>
               <a:rPr lang="en-US" dirty="0"/>
-              <a:t>No hay publicado un resultado presidencial o del PRM específico de la OCLEE Philadelphia. Referencias: en la Circunscripción 1, el PRM tenía entre 59.75 % y 60.22 % de los votos de diputados en los conteos preliminares (Diario Libre; Hoy, con 45 % de colegios); a nivel nacional Abinader obtuvo 57.44 %. Se usa 60 % sobre los 8,731 votos emitidos: unos 5,239 votos PRM en 2024 (estimado; los votos válidos son algo menos que los emitidos). Meta mínima 2028: +10 % = 5,763. Escenarios con 60 % de apoyo: Adverso 5,703 votos totales → 3,422; Inercial 8,745 → 5,247 (no alcanza); Realista (abstención 78 %) 10,456 → 6,274 (+20 %); Favorable 11,550 → 6,930 (+32 %). Dos caminos para el +10 %: 9,605 votos totales (participación 20.2 %) con 60 %, o 66 % de apoyo con 8,731 votantes. Red 1+10: 3,982 personas × 85 % = 3,385 votos, el 59 % de 5,763. Tres niveles: piso igualar 2024 (≈5,240), meta +10 % (≈5,760), techo +20 % (≈6,270). Desgaste: un tercer período consecutivo del PRM sin Abinader en la boleta y el malestar social que muestran las encuestas hacen prudente suponer menos apoyo; con 55 % de apoyo la meta exige 10,478 votos totales (22.0 % de participación; 19.7 % si el padrón crece 12 %); con 50 %, 11,526 votos (24.3 %; 21.7 % con padrón +12 %). Supuestos de los escenarios: Adverso, 60 % renueva la cédula y vota el 20 % de los habilitados; Inercial, 80 % y 23 %; Realista, abstención del 78 % sobre el padrón; Favorable, 90 % y 27 %. Sustituir el estimado por el resultado real de las actas de la seccional.</a:t>
+              <a:t>No hay publicado un resultado presidencial o del PRM específico de la OCLEE Philadelphia. Referencias: en la Circunscripción 1, el PRM tenía entre 59.75 % y 60.22 % de los votos de diputados en los conteos preliminares (Diario Libre; Hoy, con 45 % de colegios); a nivel nacional Abinader obtuvo 57.44 %. Se usa 60 % sobre los 8,731 votos emitidos: unos 5,239 votos PRM en 2024 (estimado; los votos válidos son algo menos que los emitidos). Meta mínima 2028: +10 % = 5,763. Escenarios con 60 % de apoyo: Adverso 5,703 votos totales → 3,422; Inercial 8,745 → 5,247 (no alcanza); Realista (abstención 78 %) 10,456 → 6,274 (+20 %); Favorable 11,550 → 6,930 (+32 %). Dos caminos para el +10 %: 9,605 votos totales (participación 20.2 %) con 60 %, o 66 % de apoyo con 8,731 votantes. Red: 4,000 personas × 85 % = 3,400 votos, el 59 % de 5,763. Tres niveles: piso igualar 2024 (≈5,240), meta +10 % (≈5,760), techo +20 % (≈6,270). Desgaste: un tercer período consecutivo del PRM sin Abinader en la boleta y el malestar social que muestran las encuestas hacen prudente suponer menos apoyo; con 55 % de apoyo la meta exige 10,478 votos totales (22.0 % de participación; 19.7 % si el padrón crece 12 %); con 50 %, 11,526 votos (24.3 %; 21.7 % con padrón +12 %). Supuestos de los escenarios: Adverso, 60 % renueva la cédula y vota el 20 % de los habilitados; Inercial, 80 % y 23 %; Realista, abstención del 78 % sobre el padrón; Favorable, 90 % y 27 %. Sustituir el estimado por el resultado real de las actas de la seccional.</a:t>
             </a:r>
             <a:endParaRPr lang="en-US" dirty="0"/>
           </a:p>
@@ -2666,7 +2666,7 @@
           <a:p>
             <a:r>
               <a:rPr lang="en-US" dirty="0"/>
-              <a:t>Meta 1+10 de la seccional (CAD): 362 comités = 3,982 personas, calculada como 40 % de los votos emitidos por colegio, redondeado al comité completo. El reparto por zona es proporcional a los electores porque no hay votos por recinto; con los votos JCE por colegio se puede afinar. La agrupación en 8 zonas es una propuesta: ajustar si la seccional usa otra división.</a:t>
+              <a:t>Meta de organización: una red de 4,000 personas comprometidas a votar, con 400 líderes de 10 personas cada uno. Es equivalente a la meta de la carpeta CAD (362 comités de 11 = 3,982 personas, 40 % de los votos de 2024 por colegio con redondeo), pero más fácil de explicar. Si vota el 85 % de la red, son unos 3,400 votos, el 59 % de la meta de 5,760. Los líderes se reparten por zona en proporción a los electores. La agrupación en 8 zonas es una propuesta: ajustar si la seccional usa otra división.</a:t>
             </a:r>
             <a:endParaRPr lang="en-US" dirty="0"/>
           </a:p>
@@ -2754,7 +2754,7 @@
           <a:p>
             <a:r>
               <a:rPr lang="en-US" dirty="0"/>
-              <a:t>Organigrama operativo propuesto. La dirección ejecutiva coordina con la Seccional PRM Pennsylvania y conduce 5 áreas de apoyo: cédula y padrón (renovación y traslado de recién llegados), datos y CRM (registros únicos y tablero), comunicación (agenda de la diáspora), logística del día de la elección (transporte y delegados) y legal y finanzas (cumplimiento de las leyes 20-23 y 33-18). Cada una de las 8 zonas tiene un coordinador; los números son los equipos 1+10 que debe formar cada zona.</a:t>
+              <a:t>Organigrama operativo propuesto. La dirección ejecutiva coordina con la Seccional PRM Pennsylvania y conduce 5 áreas de apoyo: cédula y padrón (renovación y traslado de recién llegados), datos y CRM (registros únicos y tablero), comunicación (agenda de la diáspora), logística del día de la elección (transporte y delegados) y legal y finanzas (cumplimiento de las leyes 20-23 y 33-18). Cada una de las 8 zonas tiene un coordinador; los números son los líderes (de 10 personas cada uno) que necesita cada zona.</a:t>
             </a:r>
             <a:endParaRPr lang="en-US" dirty="0"/>
           </a:p>
@@ -4418,7 +4418,7 @@
                   <a:schemeClr val="tx1"/>
                 </a:solidFill>
               </a:rPr>
-              <a:t>Censo de cédula en la red y primeros equipos 1+10 en formación; reunión de coordinación con la Seccional PRM</a:t>
+              <a:t>Censo de cédula en la red y primeros líderes reclutados; reunión de coordinación con la Seccional PRM</a:t>
             </a:r>
             <a:endParaRPr lang="en-US" sz="1600" dirty="0"/>
           </a:p>
@@ -4529,7 +4529,7 @@
                   <a:schemeClr val="tx1"/>
                 </a:solidFill>
               </a:rPr>
-              <a:t>Primer corte del tablero por zona: al menos 80 equipos en marcha; informe a la dirección de campaña</a:t>
+              <a:t>Primer corte del tablero por zona: al menos 90 líderes reclutados; informe a la dirección de campaña</a:t>
             </a:r>
             <a:endParaRPr lang="en-US" sz="1600" dirty="0"/>
           </a:p>
@@ -4653,7 +4653,7 @@
                   <a:schemeClr val="tx1"/>
                 </a:solidFill>
               </a:rPr>
-              <a:t>Estructura completa; red 1+10 con cédula nueva</a:t>
+              <a:t>Estructura completa; red de líderes con cédula nueva</a:t>
             </a:r>
             <a:endParaRPr lang="en-US" sz="1400" dirty="0"/>
           </a:p>
@@ -4714,7 +4714,7 @@
                   <a:schemeClr val="tx1"/>
                 </a:solidFill>
               </a:rPr>
-              <a:t>362 equipos; 60 % del padrón renovado; recién llegados trasladados</a:t>
+              <a:t>400 líderes y 4,000 personas; 60 % del padrón renovado; recién llegados trasladados</a:t>
             </a:r>
             <a:endParaRPr lang="en-US" sz="1400" dirty="0"/>
           </a:p>
@@ -5337,7 +5337,7 @@
                             <a:schemeClr val="tx1"/>
                           </a:solidFill>
                         </a:rPr>
-                        <a:t>Equipos 1+10 nuevos</a:t>
+                        <a:t>Líderes nuevos</a:t>
                       </a:r>
                       <a:endParaRPr lang="en-US" sz="1300" dirty="0"/>
                     </a:p>
@@ -5395,7 +5395,7 @@
                             <a:schemeClr val="tx1"/>
                           </a:solidFill>
                         </a:rPr>
-                        <a:t>28 / sem.</a:t>
+                        <a:t>31 / sem.</a:t>
                       </a:r>
                       <a:endParaRPr lang="en-US" sz="1300" dirty="0"/>
                     </a:p>
@@ -5453,7 +5453,7 @@
                             <a:schemeClr val="tx1"/>
                           </a:solidFill>
                         </a:rPr>
-                        <a:t>≥ 28</a:t>
+                        <a:t>≥ 31</a:t>
                       </a:r>
                       <a:endParaRPr lang="en-US" sz="1300" dirty="0"/>
                     </a:p>
@@ -5511,7 +5511,7 @@
                             <a:schemeClr val="tx1"/>
                           </a:solidFill>
                         </a:rPr>
-                        <a:t>18 – 27</a:t>
+                        <a:t>20 – 30</a:t>
                       </a:r>
                       <a:endParaRPr lang="en-US" sz="1300" dirty="0"/>
                     </a:p>
@@ -5569,7 +5569,7 @@
                             <a:schemeClr val="tx1"/>
                           </a:solidFill>
                         </a:rPr>
-                        <a:t>&lt; 18</a:t>
+                        <a:t>&lt; 20</a:t>
                       </a:r>
                       <a:endParaRPr lang="en-US" sz="1300" dirty="0"/>
                     </a:p>
@@ -12584,7 +12584,7 @@
                   <a:schemeClr val="tx2"/>
                 </a:solidFill>
               </a:rPr>
-              <a:t>Resumen: con 8 zonas y 362 equipos podemos superar en 10 % al PRM de 2024 en Pennsylvania</a:t>
+              <a:t>Resumen: con 8 zonas y una red de 4,000 votantes podemos superar en 10 % al PRM de 2024</a:t>
             </a:r>
             <a:endParaRPr lang="en-US" sz="2800" dirty="0"/>
           </a:p>
@@ -13013,7 +13013,7 @@
                   <a:schemeClr val="tx1"/>
                 </a:solidFill>
               </a:rPr>
-              <a:t>8 zonas, 8 coordinadores y 362 equipos 1+10. La cédula y el traslado de los recién llegados son la puerta de entrada.</a:t>
+              <a:t>8 zonas, 8 coordinadores y 400 líderes con 10 personas cada uno. La cédula y el traslado de los recién llegados son la puerta de entrada.</a:t>
             </a:r>
             <a:endParaRPr lang="en-US" sz="1500" dirty="0"/>
           </a:p>
@@ -17753,7 +17753,7 @@
                   <a:schemeClr val="tx2"/>
                 </a:solidFill>
               </a:rPr>
-              <a:t>Meta de organización: 362 equipos de 11 personas (3,982 en total) repartidos en 8 zonas</a:t>
+              <a:t>Meta de organización: una red de 4,000 votantes comprometidos, con 400 líderes de 10 personas cada uno</a:t>
             </a:r>
             <a:endParaRPr lang="en-US" sz="2800" dirty="0"/>
           </a:p>
@@ -17986,7 +17986,7 @@
                             <a:schemeClr val="bg1"/>
                           </a:solidFill>
                         </a:rPr>
-                        <a:t>Equipos 1+10</a:t>
+                        <a:t>Líderes</a:t>
                       </a:r>
                       <a:endParaRPr lang="en-US" sz="1300" dirty="0"/>
                     </a:p>
@@ -18284,7 +18284,7 @@
                             <a:schemeClr val="tx1"/>
                           </a:solidFill>
                         </a:rPr>
-                        <a:t>73</a:t>
+                        <a:t>81</a:t>
                       </a:r>
                       <a:endParaRPr lang="en-US" sz="1300" dirty="0"/>
                     </a:p>
@@ -18342,7 +18342,7 @@
                             <a:schemeClr val="tx1"/>
                           </a:solidFill>
                         </a:rPr>
-                        <a:t>803</a:t>
+                        <a:t>810</a:t>
                       </a:r>
                       <a:endParaRPr lang="en-US" sz="1300" dirty="0"/>
                     </a:p>
@@ -18576,7 +18576,7 @@
                             <a:schemeClr val="tx1"/>
                           </a:solidFill>
                         </a:rPr>
-                        <a:t>50</a:t>
+                        <a:t>55</a:t>
                       </a:r>
                       <a:endParaRPr lang="en-US" sz="1300" dirty="0"/>
                     </a:p>
@@ -18868,7 +18868,7 @@
                             <a:schemeClr val="tx1"/>
                           </a:solidFill>
                         </a:rPr>
-                        <a:t>64</a:t>
+                        <a:t>70</a:t>
                       </a:r>
                       <a:endParaRPr lang="en-US" sz="1300" dirty="0"/>
                     </a:p>
@@ -18926,7 +18926,7 @@
                             <a:schemeClr val="tx1"/>
                           </a:solidFill>
                         </a:rPr>
-                        <a:t>704</a:t>
+                        <a:t>700</a:t>
                       </a:r>
                       <a:endParaRPr lang="en-US" sz="1300" dirty="0"/>
                     </a:p>
@@ -19160,7 +19160,7 @@
                             <a:schemeClr val="tx1"/>
                           </a:solidFill>
                         </a:rPr>
-                        <a:t>62</a:t>
+                        <a:t>69</a:t>
                       </a:r>
                       <a:endParaRPr lang="en-US" sz="1300" dirty="0"/>
                     </a:p>
@@ -19218,7 +19218,7 @@
                             <a:schemeClr val="tx1"/>
                           </a:solidFill>
                         </a:rPr>
-                        <a:t>682</a:t>
+                        <a:t>690</a:t>
                       </a:r>
                       <a:endParaRPr lang="en-US" sz="1300" dirty="0"/>
                     </a:p>
@@ -19452,7 +19452,7 @@
                             <a:schemeClr val="tx1"/>
                           </a:solidFill>
                         </a:rPr>
-                        <a:t>50</a:t>
+                        <a:t>55</a:t>
                       </a:r>
                       <a:endParaRPr lang="en-US" sz="1300" dirty="0"/>
                     </a:p>
@@ -19744,7 +19744,7 @@
                             <a:schemeClr val="tx1"/>
                           </a:solidFill>
                         </a:rPr>
-                        <a:t>13</a:t>
+                        <a:t>15</a:t>
                       </a:r>
                       <a:endParaRPr lang="en-US" sz="1300" dirty="0"/>
                     </a:p>
@@ -19802,7 +19802,7 @@
                             <a:schemeClr val="tx1"/>
                           </a:solidFill>
                         </a:rPr>
-                        <a:t>143</a:t>
+                        <a:t>150</a:t>
                       </a:r>
                       <a:endParaRPr lang="en-US" sz="1300" dirty="0"/>
                     </a:p>
@@ -20036,7 +20036,7 @@
                             <a:schemeClr val="tx1"/>
                           </a:solidFill>
                         </a:rPr>
-                        <a:t>42</a:t>
+                        <a:t>46</a:t>
                       </a:r>
                       <a:endParaRPr lang="en-US" sz="1300" dirty="0"/>
                     </a:p>
@@ -20094,7 +20094,7 @@
                             <a:schemeClr val="tx1"/>
                           </a:solidFill>
                         </a:rPr>
-                        <a:t>462</a:t>
+                        <a:t>460</a:t>
                       </a:r>
                       <a:endParaRPr lang="en-US" sz="1300" dirty="0"/>
                     </a:p>
@@ -20328,7 +20328,7 @@
                             <a:schemeClr val="tx1"/>
                           </a:solidFill>
                         </a:rPr>
-                        <a:t>8</a:t>
+                        <a:t>9</a:t>
                       </a:r>
                       <a:endParaRPr lang="en-US" sz="1300" dirty="0"/>
                     </a:p>
@@ -20386,7 +20386,7 @@
                             <a:schemeClr val="tx1"/>
                           </a:solidFill>
                         </a:rPr>
-                        <a:t>88</a:t>
+                        <a:t>90</a:t>
                       </a:r>
                       <a:endParaRPr lang="en-US" sz="1300" dirty="0"/>
                     </a:p>
@@ -20629,7 +20629,7 @@
                             <a:schemeClr val="tx2"/>
                           </a:solidFill>
                         </a:rPr>
-                        <a:t>362</a:t>
+                        <a:t>400</a:t>
                       </a:r>
                       <a:endParaRPr lang="en-US" sz="1300" dirty="0"/>
                     </a:p>
@@ -20690,7 +20690,7 @@
                             <a:schemeClr val="tx2"/>
                           </a:solidFill>
                         </a:rPr>
-                        <a:t>3,982</a:t>
+                        <a:t>4,000</a:t>
                       </a:r>
                       <a:endParaRPr lang="en-US" sz="1300" dirty="0"/>
                     </a:p>
@@ -20813,7 +20813,7 @@
                   <a:schemeClr val="bg1"/>
                 </a:solidFill>
               </a:rPr>
-              <a:t>Cada equipo = 1 dirigente + 10 personas que se comprometen a votar.</a:t>
+              <a:t>Cada líder se compromete a llevar a votar a 10 personas de su entorno.</a:t>
             </a:r>
             <a:endParaRPr lang="en-US" sz="1800" dirty="0"/>
           </a:p>
@@ -20841,7 +20841,7 @@
                   <a:schemeClr val="accent4"/>
                 </a:solidFill>
               </a:rPr>
-              <a:t>Ejemplo: Hazleton debe formar 50 equipos, es decir, 550 personas.</a:t>
+              <a:t>Ejemplo: Hazleton necesita 55 líderes, es decir, 550 personas. Solo cuenta quien ya tenga la cédula nueva.</a:t>
             </a:r>
             <a:endParaRPr lang="en-US" sz="1800" dirty="0"/>
           </a:p>
@@ -20904,7 +20904,7 @@
                   <a:schemeClr val="accent2"/>
                 </a:solidFill>
               </a:rPr>
-              <a:t>Regla</a:t>
+              <a:t>¿Por qué 4,000?</a:t>
             </a:r>
             <a:endParaRPr lang="en-US" sz="1600" dirty="0"/>
           </a:p>
@@ -20918,7 +20918,7 @@
                   <a:schemeClr val="tx1"/>
                 </a:solidFill>
               </a:rPr>
-              <a:t>Una persona cuenta solo si ya tiene la cédula nueva.</a:t>
+              <a:t>Si vota el 85 %, son unos 3,400 votos: el 59 % de la meta de 5,760.</a:t>
             </a:r>
             <a:endParaRPr lang="en-US" sz="1600" dirty="0"/>
           </a:p>
@@ -20954,7 +20954,7 @@
                   <a:schemeClr val="accent4"/>
                 </a:solidFill>
               </a:rPr>
-              <a:t>Mesas y electores: Seccional PRM Pennsylvania. Comités repartidos en proporción a los electores; zonas agrupadas por cercanía geográfica (propuesta).</a:t>
+              <a:t>Mesas y electores: Seccional PRM Pennsylvania. Líderes repartidos en proporción a los electores; zonas agrupadas por cercanía geográfica (propuesta).</a:t>
             </a:r>
             <a:endParaRPr lang="en-US" sz="1000" dirty="0"/>
           </a:p>
@@ -21759,7 +21759,7 @@
                   <a:schemeClr val="tx2"/>
                 </a:solidFill>
               </a:rPr>
-              <a:t>8 coordinadores de zona · equipos 1+10 a formar</a:t>
+              <a:t>8 coordinadores de zona · líderes que necesita cada zona</a:t>
             </a:r>
             <a:endParaRPr lang="en-US" sz="1300" dirty="0"/>
           </a:p>
@@ -21822,7 +21822,7 @@
                   <a:schemeClr val="accent2"/>
                 </a:solidFill>
               </a:rPr>
-              <a:t>73</a:t>
+              <a:t>81</a:t>
             </a:r>
             <a:endParaRPr lang="en-US" sz="2200" dirty="0"/>
           </a:p>
@@ -21899,7 +21899,7 @@
                   <a:schemeClr val="accent2"/>
                 </a:solidFill>
               </a:rPr>
-              <a:t>50</a:t>
+              <a:t>55</a:t>
             </a:r>
             <a:endParaRPr lang="en-US" sz="2200" dirty="0"/>
           </a:p>
@@ -21976,7 +21976,7 @@
                   <a:schemeClr val="accent2"/>
                 </a:solidFill>
               </a:rPr>
-              <a:t>64</a:t>
+              <a:t>70</a:t>
             </a:r>
             <a:endParaRPr lang="en-US" sz="2200" dirty="0"/>
           </a:p>
@@ -22053,7 +22053,7 @@
                   <a:schemeClr val="accent2"/>
                 </a:solidFill>
               </a:rPr>
-              <a:t>62</a:t>
+              <a:t>69</a:t>
             </a:r>
             <a:endParaRPr lang="en-US" sz="2200" dirty="0"/>
           </a:p>
@@ -22130,7 +22130,7 @@
                   <a:schemeClr val="accent2"/>
                 </a:solidFill>
               </a:rPr>
-              <a:t>50</a:t>
+              <a:t>55</a:t>
             </a:r>
             <a:endParaRPr lang="en-US" sz="2200" dirty="0"/>
           </a:p>
@@ -22207,7 +22207,7 @@
                   <a:schemeClr val="accent2"/>
                 </a:solidFill>
               </a:rPr>
-              <a:t>13</a:t>
+              <a:t>15</a:t>
             </a:r>
             <a:endParaRPr lang="en-US" sz="2200" dirty="0"/>
           </a:p>
@@ -22284,7 +22284,7 @@
                   <a:schemeClr val="accent2"/>
                 </a:solidFill>
               </a:rPr>
-              <a:t>42</a:t>
+              <a:t>46</a:t>
             </a:r>
             <a:endParaRPr lang="en-US" sz="2200" dirty="0"/>
           </a:p>
@@ -22361,7 +22361,7 @@
                   <a:schemeClr val="accent2"/>
                 </a:solidFill>
               </a:rPr>
-              <a:t>8</a:t>
+              <a:t>9</a:t>
             </a:r>
             <a:endParaRPr lang="en-US" sz="2200" dirty="0"/>
           </a:p>
@@ -22438,7 +22438,7 @@
                   <a:schemeClr val="bg1"/>
                 </a:solidFill>
               </a:rPr>
-              <a:t>362 equipos 1+10</a:t>
+              <a:t>400 líderes</a:t>
             </a:r>
             <a:pPr algn="ctr" indent="0" marL="0">
               <a:buNone/>
@@ -22460,7 +22460,7 @@
                   <a:schemeClr val="bg1"/>
                 </a:solidFill>
               </a:rPr>
-              <a:t>3,982 personas organizadas</a:t>
+              <a:t>4,000 votantes comprometidos</a:t>
             </a:r>
             <a:pPr algn="ctr" indent="0" marL="0">
               <a:buNone/>

</xml_diff>

<commit_message>
Semana 3: texto más claro sobre la verificación de cédulas
Co-Authored-By: Claude Opus 5.5 <noreply@anthropic.com>
Claude-Session: https://claude.ai/code/session_01RrEJtrwRidXxzgveZEVQjf
</commit_message>
<xml_diff>
--- a/presentaciones/Plan_Estrategico_Pennsylvania_2028.pptx
+++ b/presentaciones/Plan_Estrategico_Pennsylvania_2028.pptx
@@ -119,7 +119,7 @@
   <p:extLst>
     <p:ext uri="{521415D9-36F7-43E2-AB2F-B90AF26B5E84}">
       <p14:sectionLst xmlns:p14="http://schemas.microsoft.com/office/powerpoint/2010/main">
-        <p14:section name="Diagnóstico" id="{576c6ff5-d818-9104-4dc8-74f68378f0f4}">
+        <p14:section name="Diagnóstico" id="{646b16da-2c8d-d10e-df58-d60fbf644bde}">
           <p14:sldIdLst>
             <p14:sldId id="256"/>
             <p14:sldId id="257"/>
@@ -127,19 +127,19 @@
             <p14:sldId id="259"/>
           </p14:sldIdLst>
         </p14:section>
-        <p14:section name="Desafíos" id="{609e4f4a-4d77-77f4-4194-79cf8c934830}">
+        <p14:section name="Desafíos" id="{1b646ec5-9fc8-af10-13e2-c2ae52db30a6}">
           <p14:sldIdLst>
             <p14:sldId id="260"/>
             <p14:sldId id="261"/>
           </p14:sldIdLst>
         </p14:section>
-        <p14:section name="Escenarios y meta" id="{15e13e0d-1ea4-574d-7350-a7c77bc4a4b4}">
+        <p14:section name="Escenarios y meta" id="{5f4e706f-9ccd-58f4-700a-4a0d20259491}">
           <p14:sldIdLst>
             <p14:sldId id="262"/>
             <p14:sldId id="263"/>
           </p14:sldIdLst>
         </p14:section>
-        <p14:section name="Plan y recomendación" id="{5efc1665-fe24-47b8-22b7-106a58f77fe5}">
+        <p14:section name="Plan y recomendación" id="{5167a663-7e10-e90d-f3ec-53d1376dfb75}">
           <p14:sldIdLst>
             <p14:sldId id="264"/>
             <p14:sldId id="265"/>
@@ -147,7 +147,7 @@
             <p14:sldId id="267"/>
           </p14:sldIdLst>
         </p14:section>
-        <p14:section name="Anexo" id="{7beeb31f-b729-a516-cd6c-2423cbd9764a}">
+        <p14:section name="Anexo" id="{e57740a1-747f-7058-1b68-9c863c9f1c83}">
           <p14:sldIdLst>
             <p14:sldId id="268"/>
           </p14:sldIdLst>
@@ -4418,7 +4418,7 @@
                   <a:schemeClr val="tx1"/>
                 </a:solidFill>
               </a:rPr>
-              <a:t>Censo de cédula en la red y primeros líderes reclutados; reunión de coordinación con la Seccional PRM</a:t>
+              <a:t>Verificar quién en la red ya tiene la cédula nueva y quién necesita cita; primeros líderes reclutados; reunión de coordinación con la Seccional PRM</a:t>
             </a:r>
             <a:endParaRPr lang="en-US" sz="1600" dirty="0"/>
           </a:p>

</xml_diff>

<commit_message>
Nombres convencionales para las áreas de apoyo
Co-Authored-By: Claude Opus 5.5 <noreply@anthropic.com>
Claude-Session: https://claude.ai/code/session_01RrEJtrwRidXxzgveZEVQjf
</commit_message>
<xml_diff>
--- a/presentaciones/Plan_Estrategico_Pennsylvania_2028.pptx
+++ b/presentaciones/Plan_Estrategico_Pennsylvania_2028.pptx
@@ -119,7 +119,7 @@
   <p:extLst>
     <p:ext uri="{521415D9-36F7-43E2-AB2F-B90AF26B5E84}">
       <p14:sectionLst xmlns:p14="http://schemas.microsoft.com/office/powerpoint/2010/main">
-        <p14:section name="Diagnóstico" id="{646b16da-2c8d-d10e-df58-d60fbf644bde}">
+        <p14:section name="Diagnóstico" id="{5fea8dc6-c9c6-702e-e7cc-bb2b6b6d4fae}">
           <p14:sldIdLst>
             <p14:sldId id="256"/>
             <p14:sldId id="257"/>
@@ -127,19 +127,19 @@
             <p14:sldId id="259"/>
           </p14:sldIdLst>
         </p14:section>
-        <p14:section name="Desafíos" id="{1b646ec5-9fc8-af10-13e2-c2ae52db30a6}">
+        <p14:section name="Desafíos" id="{e51e7ac3-8364-5f3b-3bd4-4ce1c2b8a4a9}">
           <p14:sldIdLst>
             <p14:sldId id="260"/>
             <p14:sldId id="261"/>
           </p14:sldIdLst>
         </p14:section>
-        <p14:section name="Escenarios y meta" id="{5f4e706f-9ccd-58f4-700a-4a0d20259491}">
+        <p14:section name="Escenarios y meta" id="{a785065f-388b-bc2b-6a1c-50333651fcba}">
           <p14:sldIdLst>
             <p14:sldId id="262"/>
             <p14:sldId id="263"/>
           </p14:sldIdLst>
         </p14:section>
-        <p14:section name="Plan y recomendación" id="{5167a663-7e10-e90d-f3ec-53d1376dfb75}">
+        <p14:section name="Plan y recomendación" id="{d865dcf6-a4e3-d5d1-2ce8-6f3ad643d7d1}">
           <p14:sldIdLst>
             <p14:sldId id="264"/>
             <p14:sldId id="265"/>
@@ -147,7 +147,7 @@
             <p14:sldId id="267"/>
           </p14:sldIdLst>
         </p14:section>
-        <p14:section name="Anexo" id="{e57740a1-747f-7058-1b68-9c863c9f1c83}">
+        <p14:section name="Anexo" id="{da63e559-cd6f-b945-0d06-b60692299507}">
           <p14:sldIdLst>
             <p14:sldId id="268"/>
           </p14:sldIdLst>
@@ -2754,7 +2754,7 @@
           <a:p>
             <a:r>
               <a:rPr lang="en-US" dirty="0"/>
-              <a:t>Organigrama operativo propuesto. La dirección ejecutiva coordina con la Seccional PRM Pennsylvania y conduce 5 áreas de apoyo: cédula y padrón (renovación y traslado de recién llegados), datos y CRM (registros únicos y tablero), comunicación (agenda de la diáspora), logística del día de la elección (transporte y delegados) y legal y finanzas (cumplimiento de las leyes 20-23 y 33-18). Cada una de las 8 zonas tiene un coordinador; los números son los líderes (de 10 personas cada uno) que necesita cada zona.</a:t>
+              <a:t>Organigrama operativo propuesto. La dirección ejecutiva coordina con la Seccional PRM Pennsylvania y conduce 5 áreas de apoyo: Asuntos Electorales (cédula, padrón, renovación y traslado de recién llegados), Tecnología y Datos (base de datos, registros únicos y tablero), Comunicaciones (agenda de la diáspora), Logística y Movilización (transporte, delegados y día de la elección) y Finanzas y Legal (recursos y cumplimiento de las leyes 20-23 y 33-18). Cada una de las 8 zonas tiene un coordinador; los números son los líderes (de 10 personas cada uno) que necesita cada zona.</a:t>
             </a:r>
             <a:endParaRPr lang="en-US" dirty="0"/>
           </a:p>
@@ -6909,7 +6909,7 @@
                             <a:schemeClr val="tx1"/>
                           </a:solidFill>
                         </a:rPr>
-                        <a:t>Cédula y padrón</a:t>
+                        <a:t>Asuntos Electorales</a:t>
                       </a:r>
                       <a:endParaRPr lang="en-US" sz="1200" dirty="0"/>
                     </a:p>
@@ -7085,7 +7085,7 @@
                             <a:schemeClr val="tx1"/>
                           </a:solidFill>
                         </a:rPr>
-                        <a:t>Comunicación</a:t>
+                        <a:t>Comunicaciones</a:t>
                       </a:r>
                       <a:endParaRPr lang="en-US" sz="1200" dirty="0"/>
                     </a:p>
@@ -7261,7 +7261,7 @@
                             <a:schemeClr val="tx1"/>
                           </a:solidFill>
                         </a:rPr>
-                        <a:t>Datos y CRM</a:t>
+                        <a:t>Tecnología y Datos</a:t>
                       </a:r>
                       <a:endParaRPr lang="en-US" sz="1200" dirty="0"/>
                     </a:p>
@@ -7613,7 +7613,7 @@
                             <a:schemeClr val="tx1"/>
                           </a:solidFill>
                         </a:rPr>
-                        <a:t>Legal y finanzas</a:t>
+                        <a:t>Finanzas y Legal</a:t>
                       </a:r>
                       <a:endParaRPr lang="en-US" sz="1200" dirty="0"/>
                     </a:p>
@@ -21288,7 +21288,7 @@
       </p:sp>
       <p:sp>
         <p:nvSpPr>
-          <p:cNvPr id="11" name="Area Cédula y padrón"/>
+          <p:cNvPr id="11" name="Area Asuntos Electorales"/>
           <p:cNvSpPr/>
           <p:nvPr/>
         </p:nvSpPr>
@@ -21343,7 +21343,7 @@
                   <a:schemeClr val="tx2"/>
                 </a:solidFill>
               </a:rPr>
-              <a:t>Cédula y padrón</a:t>
+              <a:t>Asuntos Electorales</a:t>
             </a:r>
             <a:endParaRPr lang="en-US" sz="1400" dirty="0"/>
           </a:p>
@@ -21374,7 +21374,7 @@
       </p:sp>
       <p:sp>
         <p:nvSpPr>
-          <p:cNvPr id="14" name="Area Datos y CRM"/>
+          <p:cNvPr id="14" name="Area Tecnología y Datos"/>
           <p:cNvSpPr/>
           <p:nvPr/>
         </p:nvSpPr>
@@ -21429,7 +21429,7 @@
                   <a:schemeClr val="tx2"/>
                 </a:solidFill>
               </a:rPr>
-              <a:t>Datos y CRM</a:t>
+              <a:t>Tecnología y Datos</a:t>
             </a:r>
             <a:endParaRPr lang="en-US" sz="1400" dirty="0"/>
           </a:p>
@@ -21460,7 +21460,7 @@
       </p:sp>
       <p:sp>
         <p:nvSpPr>
-          <p:cNvPr id="17" name="Area Comunicación"/>
+          <p:cNvPr id="17" name="Area Comunicaciones"/>
           <p:cNvSpPr/>
           <p:nvPr/>
         </p:nvSpPr>
@@ -21515,7 +21515,7 @@
                   <a:schemeClr val="tx2"/>
                 </a:solidFill>
               </a:rPr>
-              <a:t>Comunicación</a:t>
+              <a:t>Comunicaciones</a:t>
             </a:r>
             <a:endParaRPr lang="en-US" sz="1400" dirty="0"/>
           </a:p>
@@ -21546,7 +21546,7 @@
       </p:sp>
       <p:sp>
         <p:nvSpPr>
-          <p:cNvPr id="20" name="Area Logística día E"/>
+          <p:cNvPr id="20" name="Area Logística y Movilización"/>
           <p:cNvSpPr/>
           <p:nvPr/>
         </p:nvSpPr>
@@ -21601,7 +21601,7 @@
                   <a:schemeClr val="tx2"/>
                 </a:solidFill>
               </a:rPr>
-              <a:t>Logística día E</a:t>
+              <a:t>Logística y Movilización</a:t>
             </a:r>
             <a:endParaRPr lang="en-US" sz="1400" dirty="0"/>
           </a:p>
@@ -21632,7 +21632,7 @@
       </p:sp>
       <p:sp>
         <p:nvSpPr>
-          <p:cNvPr id="23" name="Area Legal y finanzas"/>
+          <p:cNvPr id="23" name="Area Finanzas y Legal"/>
           <p:cNvSpPr/>
           <p:nvPr/>
         </p:nvSpPr>
@@ -21687,7 +21687,7 @@
                   <a:schemeClr val="tx2"/>
                 </a:solidFill>
               </a:rPr>
-              <a:t>Legal y finanzas</a:t>
+              <a:t>Finanzas y Legal</a:t>
             </a:r>
             <a:endParaRPr lang="en-US" sz="1400" dirty="0"/>
           </a:p>

</xml_diff>

<commit_message>
Usar la cifra del INDEX (227,647) como soporte del potencial del estado
Co-Authored-By: Claude Opus 5.5 <noreply@anthropic.com>
Claude-Session: https://claude.ai/code/session_01RrEJtrwRidXxzgveZEVQjf
</commit_message>
<xml_diff>
--- a/presentaciones/Plan_Estrategico_Pennsylvania_2028.pptx
+++ b/presentaciones/Plan_Estrategico_Pennsylvania_2028.pptx
@@ -120,7 +120,7 @@
   <p:extLst>
     <p:ext uri="{521415D9-36F7-43E2-AB2F-B90AF26B5E84}">
       <p14:sectionLst xmlns:p14="http://schemas.microsoft.com/office/powerpoint/2010/main">
-        <p14:section name="Diagnóstico" id="{6edf257a-bd32-dd89-3d8f-af60a8b5492a}">
+        <p14:section name="Diagnóstico" id="{4494e012-fe95-aa49-a71e-7abb30476596}">
           <p14:sldIdLst>
             <p14:sldId id="256"/>
             <p14:sldId id="257"/>
@@ -129,19 +129,19 @@
             <p14:sldId id="260"/>
           </p14:sldIdLst>
         </p14:section>
-        <p14:section name="Desafíos" id="{20e1343b-aecb-e0aa-8f3f-5f3be9498b56}">
+        <p14:section name="Desafíos" id="{4f445a1f-64f4-64d7-26ea-2e397fbc8787}">
           <p14:sldIdLst>
             <p14:sldId id="261"/>
             <p14:sldId id="262"/>
           </p14:sldIdLst>
         </p14:section>
-        <p14:section name="Escenarios y meta" id="{c4d5d29b-131a-138c-096c-d659dacd5d47}">
+        <p14:section name="Escenarios y meta" id="{45d7f877-e6b4-95f3-bbd9-3393ef7166cd}">
           <p14:sldIdLst>
             <p14:sldId id="263"/>
             <p14:sldId id="264"/>
           </p14:sldIdLst>
         </p14:section>
-        <p14:section name="Plan y recomendación" id="{e6a9a11f-c331-49d7-a96c-3890480e2eb3}">
+        <p14:section name="Plan y recomendación" id="{1d41c62d-710a-84ed-599a-3095b31a3d53}">
           <p14:sldIdLst>
             <p14:sldId id="265"/>
             <p14:sldId id="266"/>
@@ -149,7 +149,7 @@
             <p14:sldId id="268"/>
           </p14:sldIdLst>
         </p14:section>
-        <p14:section name="Anexo" id="{60ed1003-e482-6a2b-63f0-6e2ccb3777ac}">
+        <p14:section name="Anexo" id="{41f2cca8-bbb9-305a-cf0a-f94a11cfe9bc}">
           <p14:sldIdLst>
             <p14:sldId id="269"/>
           </p14:sldIdLst>
@@ -802,10 +802,10 @@
                 <c:ptCount val="2"/>
                 <c:lvl>
                   <c:pt idx="0">
-                    <c:v>Dic. 2022</c:v>
+                    <c:v>INDEX, dic. 2022</c:v>
                   </c:pt>
                   <c:pt idx="1">
-                    <c:v>Registro más reciente</c:v>
+                    <c:v>INDEX, último informe</c:v>
                   </c:pt>
                 </c:lvl>
               </c:multiLvlStrCache>
@@ -2492,7 +2492,7 @@
           <a:p>
             <a:r>
               <a:rPr lang="en-US" dirty="0"/>
-              <a:t>Crecimiento: el Registro Sociodemográfico del INDEX contaba 181,156 dominicanos en Pennsylvania al 31 de diciembre de 2022; el registro más reciente, citado en prensa, reporta 227,647 (+36,553 en el último año, +19.1 %, el mayor aumento absoluto de todos los estados). El Consulado en Filadelfia atiende a más de 191 mil y afirma que llega un dominicano más cada día, muchos desde Nueva York. Hazleton ya tiene cerca de 43 % de población dominicana (Censo). Implicación: quien se mudó desde NY/NJ sigue empadronado en su OCLEE anterior; hay que trasladar su registro a Pennsylvania antes del cierre del padrón (enero de 2028), idealmente en la misma cita de la nueva cédula; confirmar el procedimiento con la JCE. Escenarios de padrón: proyección propia (+5 %, +12 %, +26 %; el alto replica el crecimiento de la población).</a:t>
+              <a:t>Crecimiento: el Registro Sociodemográfico del INDEX contaba 181,156 dominicanos en Pennsylvania al 31 de diciembre de 2022; el último informe del INDEX reporta 227,647 (+36,553 en el último año, +19.1 %, el mayor aumento absoluto de todos los estados). El Consulado en Filadelfia atiende a más de 191 mil y afirma que llega un dominicano más cada día, muchos desde Nueva York. Hazleton ya tiene cerca de 43 % de población dominicana (Censo). Implicación: quien se mudó desde NY/NJ sigue empadronado en su OCLEE anterior; hay que trasladar su registro a Pennsylvania antes del cierre del padrón (enero de 2028), idealmente en la misma cita de la nueva cédula; confirmar el procedimiento con la JCE. Potencial: 47,529 inscritos son el 21 % de los 227,647 dominicanos que registra el INDEX en el estado (la cifra del INDEX incluye a menores de edad y a personas sin cédula, por lo que no todos pueden votar, pero muestra el tamaño del potencial). Escenarios de padrón: proyección propia (+5 %, +12 %, +26 %; el alto replica el crecimiento de la población).</a:t>
             </a:r>
             <a:endParaRPr lang="en-US" dirty="0"/>
           </a:p>
@@ -14419,7 +14419,7 @@
                   <a:schemeClr val="bg1"/>
                 </a:solidFill>
               </a:rPr>
-              <a:t>+26 %</a:t>
+              <a:t>227,647</a:t>
             </a:r>
             <a:endParaRPr lang="en-US" sz="3400" dirty="0"/>
           </a:p>
@@ -14433,7 +14433,7 @@
                   <a:schemeClr val="accent4"/>
                 </a:solidFill>
               </a:rPr>
-              <a:t>dominicanos en PA desde 2022</a:t>
+              <a:t>dominicanos en PA (INDEX)</a:t>
             </a:r>
             <a:endParaRPr lang="en-US" sz="3400" dirty="0"/>
           </a:p>
@@ -17884,7 +17884,7 @@
                   <a:schemeClr val="tx2"/>
                 </a:solidFill>
               </a:rPr>
-              <a:t>La comunidad dominicana en Pennsylvania creció un 26 % desde 2022: el padrón crecerá si los recién llegados se inscriben aquí</a:t>
+              <a:t>Pennsylvania tiene 227,647 dominicanos y solo 47,529 están inscritos para votar aquí: el potencial es enorme</a:t>
             </a:r>
             <a:endParaRPr lang="en-US" sz="2800" dirty="0"/>
           </a:p>
@@ -17963,7 +17963,7 @@
                   <a:schemeClr val="accent2"/>
                 </a:solidFill>
               </a:rPr>
-              <a:t>+46,500</a:t>
+              <a:t>Solo 1 de cada 5</a:t>
             </a:r>
             <a:endParaRPr lang="en-US" sz="2200" dirty="0"/>
           </a:p>
@@ -17977,7 +17977,7 @@
                   <a:schemeClr val="tx1"/>
                 </a:solidFill>
               </a:rPr>
-              <a:t>dominicanos más en el estado. El consulado reporta que «cada día llega un dominicano más», muchos desde Nueva York</a:t>
+              <a:t>dominicanos del estado está inscrito para votar en la seccional (21 %). Y la comunidad creció un 26 % desde 2022</a:t>
             </a:r>
             <a:endParaRPr lang="en-US" sz="2200" dirty="0"/>
           </a:p>
@@ -18898,7 +18898,7 @@
                   <a:schemeClr val="accent4"/>
                 </a:solidFill>
               </a:rPr>
-              <a:t>Fuentes: INDEX, Registro Sociodemográfico (181,156 a dic. 2022); registro más reciente citado en prensa (227,647); Consulado RD en Filadelfia. Padrón 2028: proyección propia.</a:t>
+              <a:t>Fuentes: INDEX, Registro Sociodemográfico (181,156 a dic. 2022; 227,647 en el último informe); Consulado RD en Filadelfia. Padrón 2028: proyección propia.</a:t>
             </a:r>
             <a:endParaRPr lang="en-US" sz="1000" dirty="0"/>
           </a:p>

</xml_diff>

<commit_message>
Mapa territorial más limpio: un círculo por zona
Co-Authored-By: Claude Opus 5.5 <noreply@anthropic.com>
Claude-Session: https://claude.ai/code/session_01RrEJtrwRidXxzgveZEVQjf
</commit_message>
<xml_diff>
--- a/presentaciones/Plan_Estrategico_Pennsylvania_2028.pptx
+++ b/presentaciones/Plan_Estrategico_Pennsylvania_2028.pptx
@@ -120,7 +120,7 @@
   <p:extLst>
     <p:ext uri="{521415D9-36F7-43E2-AB2F-B90AF26B5E84}">
       <p14:sectionLst xmlns:p14="http://schemas.microsoft.com/office/powerpoint/2010/main">
-        <p14:section name="Diagnóstico" id="{4494e012-fe95-aa49-a71e-7abb30476596}">
+        <p14:section name="Diagnóstico" id="{7b008938-e9a8-c9ca-f8b8-daa4da07423a}">
           <p14:sldIdLst>
             <p14:sldId id="256"/>
             <p14:sldId id="257"/>
@@ -129,19 +129,19 @@
             <p14:sldId id="260"/>
           </p14:sldIdLst>
         </p14:section>
-        <p14:section name="Desafíos" id="{4f445a1f-64f4-64d7-26ea-2e397fbc8787}">
+        <p14:section name="Desafíos" id="{0be04665-0b61-6853-047a-5457c0584a40}">
           <p14:sldIdLst>
             <p14:sldId id="261"/>
             <p14:sldId id="262"/>
           </p14:sldIdLst>
         </p14:section>
-        <p14:section name="Escenarios y meta" id="{45d7f877-e6b4-95f3-bbd9-3393ef7166cd}">
+        <p14:section name="Escenarios y meta" id="{502eea75-1eca-02a8-e408-e413e3172989}">
           <p14:sldIdLst>
             <p14:sldId id="263"/>
             <p14:sldId id="264"/>
           </p14:sldIdLst>
         </p14:section>
-        <p14:section name="Plan y recomendación" id="{1d41c62d-710a-84ed-599a-3095b31a3d53}">
+        <p14:section name="Plan y recomendación" id="{cf62aa64-124b-47a6-dd46-1ecf145c78b9}">
           <p14:sldIdLst>
             <p14:sldId id="265"/>
             <p14:sldId id="266"/>
@@ -149,7 +149,7 @@
             <p14:sldId id="268"/>
           </p14:sldIdLst>
         </p14:section>
-        <p14:section name="Anexo" id="{41f2cca8-bbb9-305a-cf0a-f94a11cfe9bc}">
+        <p14:section name="Anexo" id="{02553240-ca45-9323-a743-fb1c3b2ae734}">
           <p14:sldIdLst>
             <p14:sldId id="269"/>
           </p14:sldIdLst>
@@ -15319,707 +15319,14 @@
       </p:pic>
       <p:sp>
         <p:nvSpPr>
-          <p:cNvPr id="4" name="Ciudad Philadelphia"/>
+          <p:cNvPr id="4" name="Zona 1"/>
           <p:cNvSpPr/>
           <p:nvPr/>
         </p:nvSpPr>
         <p:spPr>
           <a:xfrm>
-            <a:off x="5101338" y="4862814"/>
-            <a:ext cx="566928" cy="566928"/>
-          </a:xfrm>
-          <a:prstGeom prst="ellipse">
-            <a:avLst/>
-          </a:prstGeom>
-          <a:solidFill>
-            <a:schemeClr val="tx2">
-              <a:alpha val="85000"/>
-            </a:schemeClr>
-          </a:solidFill>
-          <a:ln w="12700">
-            <a:solidFill>
-              <a:schemeClr val="bg1"/>
-            </a:solidFill>
-            <a:prstDash val="solid"/>
-          </a:ln>
-        </p:spPr>
-      </p:sp>
-      <p:sp>
-        <p:nvSpPr>
-          <p:cNvPr id="5" name="Text 2"/>
-          <p:cNvSpPr txBox="1"/>
-          <p:nvPr/>
-        </p:nvSpPr>
-        <p:spPr>
-          <a:xfrm>
-            <a:off x="5723130" y="5031978"/>
-            <a:ext cx="1005840" cy="228600"/>
-          </a:xfrm>
-          <a:prstGeom prst="rect">
-            <a:avLst/>
-          </a:prstGeom>
-          <a:noFill/>
-          <a:ln/>
-        </p:spPr>
-        <p:txBody>
-          <a:bodyPr wrap="square" lIns="0" tIns="0" rIns="0" bIns="0" rtlCol="0" anchor="ctr"/>
-          <a:lstStyle/>
-          <a:p>
-            <a:pPr algn="l" indent="0" marL="0">
-              <a:buNone/>
-            </a:pPr>
-            <a:r>
-              <a:rPr lang="en-US" sz="1100" b="1" dirty="0">
-                <a:solidFill>
-                  <a:schemeClr val="tx1"/>
-                </a:solidFill>
-              </a:rPr>
-              <a:t>Philadelphia</a:t>
-            </a:r>
-            <a:endParaRPr lang="en-US" sz="1100" dirty="0"/>
-          </a:p>
-        </p:txBody>
-      </p:sp>
-      <p:sp>
-        <p:nvSpPr>
-          <p:cNvPr id="6" name="Ciudad Reading"/>
-          <p:cNvSpPr/>
-          <p:nvPr/>
-        </p:nvSpPr>
-        <p:spPr>
-          <a:xfrm>
-            <a:off x="3923602" y="4110191"/>
-            <a:ext cx="437947" cy="437947"/>
-          </a:xfrm>
-          <a:prstGeom prst="ellipse">
-            <a:avLst/>
-          </a:prstGeom>
-          <a:solidFill>
-            <a:schemeClr val="tx2">
-              <a:alpha val="85000"/>
-            </a:schemeClr>
-          </a:solidFill>
-          <a:ln w="12700">
-            <a:solidFill>
-              <a:schemeClr val="bg1"/>
-            </a:solidFill>
-            <a:prstDash val="solid"/>
-          </a:ln>
-        </p:spPr>
-      </p:sp>
-      <p:sp>
-        <p:nvSpPr>
-          <p:cNvPr id="7" name="Text 4"/>
-          <p:cNvSpPr txBox="1"/>
-          <p:nvPr/>
-        </p:nvSpPr>
-        <p:spPr>
-          <a:xfrm>
-            <a:off x="4416414" y="4214865"/>
-            <a:ext cx="1005840" cy="228600"/>
-          </a:xfrm>
-          <a:prstGeom prst="rect">
-            <a:avLst/>
-          </a:prstGeom>
-          <a:noFill/>
-          <a:ln/>
-        </p:spPr>
-        <p:txBody>
-          <a:bodyPr wrap="square" lIns="0" tIns="0" rIns="0" bIns="0" rtlCol="0" anchor="ctr"/>
-          <a:lstStyle/>
-          <a:p>
-            <a:pPr algn="l" indent="0" marL="0">
-              <a:buNone/>
-            </a:pPr>
-            <a:r>
-              <a:rPr lang="en-US" sz="1100" b="1" dirty="0">
-                <a:solidFill>
-                  <a:schemeClr val="tx1"/>
-                </a:solidFill>
-              </a:rPr>
-              <a:t>Reading</a:t>
-            </a:r>
-            <a:endParaRPr lang="en-US" sz="1100" dirty="0"/>
-          </a:p>
-        </p:txBody>
-      </p:sp>
-      <p:sp>
-        <p:nvSpPr>
-          <p:cNvPr id="8" name="Ciudad Allentown"/>
-          <p:cNvSpPr/>
-          <p:nvPr/>
-        </p:nvSpPr>
-        <p:spPr>
-          <a:xfrm>
-            <a:off x="4668283" y="3540281"/>
-            <a:ext cx="434299" cy="434299"/>
-          </a:xfrm>
-          <a:prstGeom prst="ellipse">
-            <a:avLst/>
-          </a:prstGeom>
-          <a:solidFill>
-            <a:schemeClr val="tx2">
-              <a:alpha val="85000"/>
-            </a:schemeClr>
-          </a:solidFill>
-          <a:ln w="12700">
-            <a:solidFill>
-              <a:schemeClr val="bg1"/>
-            </a:solidFill>
-            <a:prstDash val="solid"/>
-          </a:ln>
-        </p:spPr>
-      </p:sp>
-      <p:sp>
-        <p:nvSpPr>
-          <p:cNvPr id="9" name="Text 6"/>
-          <p:cNvSpPr txBox="1"/>
-          <p:nvPr/>
-        </p:nvSpPr>
-        <p:spPr>
-          <a:xfrm>
-            <a:off x="5157446" y="3643130"/>
-            <a:ext cx="1005840" cy="228600"/>
-          </a:xfrm>
-          <a:prstGeom prst="rect">
-            <a:avLst/>
-          </a:prstGeom>
-          <a:noFill/>
-          <a:ln/>
-        </p:spPr>
-        <p:txBody>
-          <a:bodyPr wrap="square" lIns="0" tIns="0" rIns="0" bIns="0" rtlCol="0" anchor="ctr"/>
-          <a:lstStyle/>
-          <a:p>
-            <a:pPr algn="l" indent="0" marL="0">
-              <a:buNone/>
-            </a:pPr>
-            <a:r>
-              <a:rPr lang="en-US" sz="1100" b="1" dirty="0">
-                <a:solidFill>
-                  <a:schemeClr val="tx1"/>
-                </a:solidFill>
-              </a:rPr>
-              <a:t>Allentown</a:t>
-            </a:r>
-            <a:endParaRPr lang="en-US" sz="1100" dirty="0"/>
-          </a:p>
-        </p:txBody>
-      </p:sp>
-      <p:sp>
-        <p:nvSpPr>
-          <p:cNvPr id="10" name="Ciudad Hazleton"/>
-          <p:cNvSpPr/>
-          <p:nvPr/>
-        </p:nvSpPr>
-        <p:spPr>
-          <a:xfrm>
-            <a:off x="3865060" y="2790754"/>
-            <a:ext cx="399447" cy="399447"/>
-          </a:xfrm>
-          <a:prstGeom prst="ellipse">
-            <a:avLst/>
-          </a:prstGeom>
-          <a:solidFill>
-            <a:schemeClr val="tx2">
-              <a:alpha val="85000"/>
-            </a:schemeClr>
-          </a:solidFill>
-          <a:ln w="12700">
-            <a:solidFill>
-              <a:schemeClr val="bg1"/>
-            </a:solidFill>
-            <a:prstDash val="solid"/>
-          </a:ln>
-        </p:spPr>
-      </p:sp>
-      <p:sp>
-        <p:nvSpPr>
-          <p:cNvPr id="11" name="Text 8"/>
-          <p:cNvSpPr txBox="1"/>
-          <p:nvPr/>
-        </p:nvSpPr>
-        <p:spPr>
-          <a:xfrm>
-            <a:off x="4319371" y="2876177"/>
-            <a:ext cx="1005840" cy="228600"/>
-          </a:xfrm>
-          <a:prstGeom prst="rect">
-            <a:avLst/>
-          </a:prstGeom>
-          <a:noFill/>
-          <a:ln/>
-        </p:spPr>
-        <p:txBody>
-          <a:bodyPr wrap="square" lIns="0" tIns="0" rIns="0" bIns="0" rtlCol="0" anchor="ctr"/>
-          <a:lstStyle/>
-          <a:p>
-            <a:pPr algn="l" indent="0" marL="0">
-              <a:buNone/>
-            </a:pPr>
-            <a:r>
-              <a:rPr lang="en-US" sz="1100" b="1" dirty="0">
-                <a:solidFill>
-                  <a:schemeClr val="tx1"/>
-                </a:solidFill>
-              </a:rPr>
-              <a:t>Hazleton</a:t>
-            </a:r>
-            <a:endParaRPr lang="en-US" sz="1100" dirty="0"/>
-          </a:p>
-        </p:txBody>
-      </p:sp>
-      <p:sp>
-        <p:nvSpPr>
-          <p:cNvPr id="12" name="Ciudad Wilkes-Barre"/>
-          <p:cNvSpPr/>
-          <p:nvPr/>
-        </p:nvSpPr>
-        <p:spPr>
-          <a:xfrm>
-            <a:off x="4096924" y="2248230"/>
-            <a:ext cx="240037" cy="240037"/>
-          </a:xfrm>
-          <a:prstGeom prst="ellipse">
-            <a:avLst/>
-          </a:prstGeom>
-          <a:solidFill>
-            <a:schemeClr val="tx2">
-              <a:alpha val="85000"/>
-            </a:schemeClr>
-          </a:solidFill>
-          <a:ln w="12700">
-            <a:solidFill>
-              <a:schemeClr val="bg1"/>
-            </a:solidFill>
-            <a:prstDash val="solid"/>
-          </a:ln>
-        </p:spPr>
-      </p:sp>
-      <p:sp>
-        <p:nvSpPr>
-          <p:cNvPr id="13" name="Text 10"/>
-          <p:cNvSpPr txBox="1"/>
-          <p:nvPr/>
-        </p:nvSpPr>
-        <p:spPr>
-          <a:xfrm>
-            <a:off x="3036220" y="2253949"/>
-            <a:ext cx="1005840" cy="228600"/>
-          </a:xfrm>
-          <a:prstGeom prst="rect">
-            <a:avLst/>
-          </a:prstGeom>
-          <a:noFill/>
-          <a:ln/>
-        </p:spPr>
-        <p:txBody>
-          <a:bodyPr wrap="square" lIns="0" tIns="0" rIns="0" bIns="0" rtlCol="0" anchor="ctr"/>
-          <a:lstStyle/>
-          <a:p>
-            <a:pPr algn="r" indent="0" marL="0">
-              <a:buNone/>
-            </a:pPr>
-            <a:r>
-              <a:rPr lang="en-US" sz="1100" b="1" dirty="0">
-                <a:solidFill>
-                  <a:schemeClr val="tx1"/>
-                </a:solidFill>
-              </a:rPr>
-              <a:t>Wilkes-Barre</a:t>
-            </a:r>
-            <a:endParaRPr lang="en-US" sz="1100" dirty="0"/>
-          </a:p>
-        </p:txBody>
-      </p:sp>
-      <p:sp>
-        <p:nvSpPr>
-          <p:cNvPr id="14" name="Ciudad Scranton"/>
-          <p:cNvSpPr/>
-          <p:nvPr/>
-        </p:nvSpPr>
-        <p:spPr>
-          <a:xfrm>
-            <a:off x="4481102" y="1921203"/>
-            <a:ext cx="185672" cy="185672"/>
-          </a:xfrm>
-          <a:prstGeom prst="ellipse">
-            <a:avLst/>
-          </a:prstGeom>
-          <a:solidFill>
-            <a:schemeClr val="tx2">
-              <a:alpha val="85000"/>
-            </a:schemeClr>
-          </a:solidFill>
-          <a:ln w="12700">
-            <a:solidFill>
-              <a:schemeClr val="bg1"/>
-            </a:solidFill>
-            <a:prstDash val="solid"/>
-          </a:ln>
-        </p:spPr>
-      </p:sp>
-      <p:sp>
-        <p:nvSpPr>
-          <p:cNvPr id="15" name="Text 12"/>
-          <p:cNvSpPr txBox="1"/>
-          <p:nvPr/>
-        </p:nvSpPr>
-        <p:spPr>
-          <a:xfrm>
-            <a:off x="4721638" y="1899738"/>
-            <a:ext cx="1005840" cy="228600"/>
-          </a:xfrm>
-          <a:prstGeom prst="rect">
-            <a:avLst/>
-          </a:prstGeom>
-          <a:noFill/>
-          <a:ln/>
-        </p:spPr>
-        <p:txBody>
-          <a:bodyPr wrap="square" lIns="0" tIns="0" rIns="0" bIns="0" rtlCol="0" anchor="ctr"/>
-          <a:lstStyle/>
-          <a:p>
-            <a:pPr algn="l" indent="0" marL="0">
-              <a:buNone/>
-            </a:pPr>
-            <a:r>
-              <a:rPr lang="en-US" sz="1100" b="1" dirty="0">
-                <a:solidFill>
-                  <a:schemeClr val="tx1"/>
-                </a:solidFill>
-              </a:rPr>
-              <a:t>Scranton</a:t>
-            </a:r>
-            <a:endParaRPr lang="en-US" sz="1100" dirty="0"/>
-          </a:p>
-        </p:txBody>
-      </p:sp>
-      <p:sp>
-        <p:nvSpPr>
-          <p:cNvPr id="16" name="Ciudad Harrisburg"/>
-          <p:cNvSpPr/>
-          <p:nvPr/>
-        </p:nvSpPr>
-        <p:spPr>
-          <a:xfrm>
-            <a:off x="2449100" y="4334430"/>
-            <a:ext cx="256354" cy="256354"/>
-          </a:xfrm>
-          <a:prstGeom prst="ellipse">
-            <a:avLst/>
-          </a:prstGeom>
-          <a:solidFill>
-            <a:schemeClr val="tx2">
-              <a:alpha val="85000"/>
-            </a:schemeClr>
-          </a:solidFill>
-          <a:ln w="12700">
-            <a:solidFill>
-              <a:schemeClr val="bg1"/>
-            </a:solidFill>
-            <a:prstDash val="solid"/>
-          </a:ln>
-        </p:spPr>
-      </p:sp>
-      <p:sp>
-        <p:nvSpPr>
-          <p:cNvPr id="17" name="Text 14"/>
-          <p:cNvSpPr txBox="1"/>
-          <p:nvPr/>
-        </p:nvSpPr>
-        <p:spPr>
-          <a:xfrm>
-            <a:off x="1388396" y="4348307"/>
-            <a:ext cx="1005840" cy="228600"/>
-          </a:xfrm>
-          <a:prstGeom prst="rect">
-            <a:avLst/>
-          </a:prstGeom>
-          <a:noFill/>
-          <a:ln/>
-        </p:spPr>
-        <p:txBody>
-          <a:bodyPr wrap="square" lIns="0" tIns="0" rIns="0" bIns="0" rtlCol="0" anchor="ctr"/>
-          <a:lstStyle/>
-          <a:p>
-            <a:pPr algn="r" indent="0" marL="0">
-              <a:buNone/>
-            </a:pPr>
-            <a:r>
-              <a:rPr lang="en-US" sz="1100" b="1" dirty="0">
-                <a:solidFill>
-                  <a:schemeClr val="tx1"/>
-                </a:solidFill>
-              </a:rPr>
-              <a:t>Harrisburg</a:t>
-            </a:r>
-            <a:endParaRPr lang="en-US" sz="1100" dirty="0"/>
-          </a:p>
-        </p:txBody>
-      </p:sp>
-      <p:sp>
-        <p:nvSpPr>
-          <p:cNvPr id="18" name="Ciudad Lancaster"/>
-          <p:cNvSpPr/>
-          <p:nvPr/>
-        </p:nvSpPr>
-        <p:spPr>
-          <a:xfrm>
-            <a:off x="3394856" y="4834416"/>
-            <a:ext cx="260552" cy="260552"/>
-          </a:xfrm>
-          <a:prstGeom prst="ellipse">
-            <a:avLst/>
-          </a:prstGeom>
-          <a:solidFill>
-            <a:schemeClr val="tx2">
-              <a:alpha val="85000"/>
-            </a:schemeClr>
-          </a:solidFill>
-          <a:ln w="12700">
-            <a:solidFill>
-              <a:schemeClr val="bg1"/>
-            </a:solidFill>
-            <a:prstDash val="solid"/>
-          </a:ln>
-        </p:spPr>
-      </p:sp>
-      <p:sp>
-        <p:nvSpPr>
-          <p:cNvPr id="19" name="Text 16"/>
-          <p:cNvSpPr txBox="1"/>
-          <p:nvPr/>
-        </p:nvSpPr>
-        <p:spPr>
-          <a:xfrm>
-            <a:off x="3710273" y="4850392"/>
-            <a:ext cx="1005840" cy="228600"/>
-          </a:xfrm>
-          <a:prstGeom prst="rect">
-            <a:avLst/>
-          </a:prstGeom>
-          <a:noFill/>
-          <a:ln/>
-        </p:spPr>
-        <p:txBody>
-          <a:bodyPr wrap="square" lIns="0" tIns="0" rIns="0" bIns="0" rtlCol="0" anchor="ctr"/>
-          <a:lstStyle/>
-          <a:p>
-            <a:pPr algn="l" indent="0" marL="0">
-              <a:buNone/>
-            </a:pPr>
-            <a:r>
-              <a:rPr lang="en-US" sz="1100" b="1" dirty="0">
-                <a:solidFill>
-                  <a:schemeClr val="tx1"/>
-                </a:solidFill>
-              </a:rPr>
-              <a:t>Lancaster</a:t>
-            </a:r>
-            <a:endParaRPr lang="en-US" sz="1100" dirty="0"/>
-          </a:p>
-        </p:txBody>
-      </p:sp>
-      <p:sp>
-        <p:nvSpPr>
-          <p:cNvPr id="20" name="Ciudad York"/>
-          <p:cNvSpPr/>
-          <p:nvPr/>
-        </p:nvSpPr>
-        <p:spPr>
-          <a:xfrm>
-            <a:off x="2718955" y="5007373"/>
-            <a:ext cx="235257" cy="235257"/>
-          </a:xfrm>
-          <a:prstGeom prst="ellipse">
-            <a:avLst/>
-          </a:prstGeom>
-          <a:solidFill>
-            <a:schemeClr val="tx2">
-              <a:alpha val="85000"/>
-            </a:schemeClr>
-          </a:solidFill>
-          <a:ln w="12700">
-            <a:solidFill>
-              <a:schemeClr val="bg1"/>
-            </a:solidFill>
-            <a:prstDash val="solid"/>
-          </a:ln>
-        </p:spPr>
-      </p:sp>
-      <p:sp>
-        <p:nvSpPr>
-          <p:cNvPr id="21" name="Text 18"/>
-          <p:cNvSpPr txBox="1"/>
-          <p:nvPr/>
-        </p:nvSpPr>
-        <p:spPr>
-          <a:xfrm>
-            <a:off x="2333663" y="5270062"/>
-            <a:ext cx="1005840" cy="228600"/>
-          </a:xfrm>
-          <a:prstGeom prst="rect">
-            <a:avLst/>
-          </a:prstGeom>
-          <a:noFill/>
-          <a:ln/>
-        </p:spPr>
-        <p:txBody>
-          <a:bodyPr wrap="square" lIns="0" tIns="0" rIns="0" bIns="0" rtlCol="0" anchor="ctr"/>
-          <a:lstStyle/>
-          <a:p>
-            <a:pPr algn="ctr" indent="0" marL="0">
-              <a:buNone/>
-            </a:pPr>
-            <a:r>
-              <a:rPr lang="en-US" sz="1100" b="1" dirty="0">
-                <a:solidFill>
-                  <a:schemeClr val="tx1"/>
-                </a:solidFill>
-              </a:rPr>
-              <a:t>York</a:t>
-            </a:r>
-            <a:endParaRPr lang="en-US" sz="1100" dirty="0"/>
-          </a:p>
-        </p:txBody>
-      </p:sp>
-      <p:sp>
-        <p:nvSpPr>
-          <p:cNvPr id="22" name="Ciudad Lebanon"/>
-          <p:cNvSpPr/>
-          <p:nvPr/>
-        </p:nvSpPr>
-        <p:spPr>
-          <a:xfrm>
-            <a:off x="3247331" y="4212569"/>
-            <a:ext cx="210512" cy="210512"/>
-          </a:xfrm>
-          <a:prstGeom prst="ellipse">
-            <a:avLst/>
-          </a:prstGeom>
-          <a:solidFill>
-            <a:schemeClr val="tx2">
-              <a:alpha val="85000"/>
-            </a:schemeClr>
-          </a:solidFill>
-          <a:ln w="12700">
-            <a:solidFill>
-              <a:schemeClr val="bg1"/>
-            </a:solidFill>
-            <a:prstDash val="solid"/>
-          </a:ln>
-        </p:spPr>
-      </p:sp>
-      <p:sp>
-        <p:nvSpPr>
-          <p:cNvPr id="23" name="Text 20"/>
-          <p:cNvSpPr txBox="1"/>
-          <p:nvPr/>
-        </p:nvSpPr>
-        <p:spPr>
-          <a:xfrm>
-            <a:off x="2849667" y="3956537"/>
-            <a:ext cx="1005840" cy="228600"/>
-          </a:xfrm>
-          <a:prstGeom prst="rect">
-            <a:avLst/>
-          </a:prstGeom>
-          <a:noFill/>
-          <a:ln/>
-        </p:spPr>
-        <p:txBody>
-          <a:bodyPr wrap="square" lIns="0" tIns="0" rIns="0" bIns="0" rtlCol="0" anchor="ctr"/>
-          <a:lstStyle/>
-          <a:p>
-            <a:pPr algn="ctr" indent="0" marL="0">
-              <a:buNone/>
-            </a:pPr>
-            <a:r>
-              <a:rPr lang="en-US" sz="1100" b="1" dirty="0">
-                <a:solidFill>
-                  <a:schemeClr val="tx1"/>
-                </a:solidFill>
-              </a:rPr>
-              <a:t>Lebanon</a:t>
-            </a:r>
-            <a:endParaRPr lang="en-US" sz="1100" dirty="0"/>
-          </a:p>
-        </p:txBody>
-      </p:sp>
-      <p:sp>
-        <p:nvSpPr>
-          <p:cNvPr id="24" name="Ciudad Wilmington"/>
-          <p:cNvSpPr/>
-          <p:nvPr/>
-        </p:nvSpPr>
-        <p:spPr>
-          <a:xfrm>
-            <a:off x="4662173" y="5488075"/>
-            <a:ext cx="223417" cy="223417"/>
-          </a:xfrm>
-          <a:prstGeom prst="ellipse">
-            <a:avLst/>
-          </a:prstGeom>
-          <a:solidFill>
-            <a:schemeClr val="tx2">
-              <a:alpha val="85000"/>
-            </a:schemeClr>
-          </a:solidFill>
-          <a:ln w="12700">
-            <a:solidFill>
-              <a:schemeClr val="bg1"/>
-            </a:solidFill>
-            <a:prstDash val="solid"/>
-          </a:ln>
-        </p:spPr>
-      </p:sp>
-      <p:sp>
-        <p:nvSpPr>
-          <p:cNvPr id="25" name="Text 22"/>
-          <p:cNvSpPr txBox="1"/>
-          <p:nvPr/>
-        </p:nvSpPr>
-        <p:spPr>
-          <a:xfrm>
-            <a:off x="4940454" y="5485484"/>
-            <a:ext cx="1005840" cy="228600"/>
-          </a:xfrm>
-          <a:prstGeom prst="rect">
-            <a:avLst/>
-          </a:prstGeom>
-          <a:noFill/>
-          <a:ln/>
-        </p:spPr>
-        <p:txBody>
-          <a:bodyPr wrap="square" lIns="0" tIns="0" rIns="0" bIns="0" rtlCol="0" anchor="ctr"/>
-          <a:lstStyle/>
-          <a:p>
-            <a:pPr algn="l" indent="0" marL="0">
-              <a:buNone/>
-            </a:pPr>
-            <a:r>
-              <a:rPr lang="en-US" sz="1100" b="1" dirty="0">
-                <a:solidFill>
-                  <a:schemeClr val="tx1"/>
-                </a:solidFill>
-              </a:rPr>
-              <a:t>Wilmington</a:t>
-            </a:r>
-            <a:endParaRPr lang="en-US" sz="1100" dirty="0"/>
-          </a:p>
-        </p:txBody>
-      </p:sp>
-      <p:sp>
-        <p:nvSpPr>
-          <p:cNvPr id="26" name="Shape 23"/>
-          <p:cNvSpPr/>
-          <p:nvPr/>
-        </p:nvSpPr>
-        <p:spPr>
-          <a:xfrm>
-            <a:off x="5366514" y="4533630"/>
-            <a:ext cx="310896" cy="310896"/>
+            <a:off x="5340096" y="4517136"/>
+            <a:ext cx="658368" cy="658368"/>
           </a:xfrm>
           <a:prstGeom prst="ellipse">
             <a:avLst/>
@@ -16037,14 +15344,14 @@
       </p:sp>
       <p:sp>
         <p:nvSpPr>
-          <p:cNvPr id="27" name="Text 24"/>
+          <p:cNvPr id="5" name="Text 2"/>
           <p:cNvSpPr txBox="1"/>
           <p:nvPr/>
         </p:nvSpPr>
         <p:spPr>
           <a:xfrm>
-            <a:off x="5366514" y="4533630"/>
-            <a:ext cx="310896" cy="310896"/>
+            <a:off x="5340096" y="4517136"/>
+            <a:ext cx="658368" cy="658368"/>
           </a:xfrm>
           <a:prstGeom prst="rect">
             <a:avLst/>
@@ -16060,27 +15367,63 @@
               <a:buNone/>
             </a:pPr>
             <a:r>
-              <a:rPr lang="en-US" sz="1200" b="1" dirty="0">
+              <a:rPr lang="en-US" sz="1300" b="1" dirty="0">
                 <a:solidFill>
                   <a:schemeClr val="bg1"/>
                 </a:solidFill>
               </a:rPr>
               <a:t>1</a:t>
             </a:r>
-            <a:endParaRPr lang="en-US" sz="1200" dirty="0"/>
+            <a:endParaRPr lang="en-US" sz="1300" dirty="0"/>
           </a:p>
         </p:txBody>
       </p:sp>
       <p:sp>
         <p:nvSpPr>
-          <p:cNvPr id="28" name="Shape 25"/>
+          <p:cNvPr id="6" name="Text 3"/>
+          <p:cNvSpPr txBox="1"/>
+          <p:nvPr/>
+        </p:nvSpPr>
+        <p:spPr>
+          <a:xfrm>
+            <a:off x="6053328" y="4727448"/>
+            <a:ext cx="1463040" cy="237744"/>
+          </a:xfrm>
+          <a:prstGeom prst="rect">
+            <a:avLst/>
+          </a:prstGeom>
+          <a:noFill/>
+          <a:ln/>
+        </p:spPr>
+        <p:txBody>
+          <a:bodyPr wrap="square" lIns="0" tIns="0" rIns="0" bIns="0" rtlCol="0" anchor="ctr"/>
+          <a:lstStyle/>
+          <a:p>
+            <a:pPr algn="l" indent="0" marL="0">
+              <a:buNone/>
+            </a:pPr>
+            <a:r>
+              <a:rPr lang="en-US" sz="1100" b="1" dirty="0">
+                <a:solidFill>
+                  <a:schemeClr val="tx2"/>
+                </a:solidFill>
+              </a:rPr>
+              <a:t>Phila. Noreste</a:t>
+            </a:r>
+            <a:endParaRPr lang="en-US" sz="1100" dirty="0"/>
+          </a:p>
+        </p:txBody>
+      </p:sp>
+      <p:sp>
+        <p:nvSpPr>
+          <p:cNvPr id="7" name="Zona 2"/>
           <p:cNvSpPr/>
           <p:nvPr/>
         </p:nvSpPr>
         <p:spPr>
           <a:xfrm>
-            <a:off x="5732274" y="4789662"/>
-            <a:ext cx="310896" cy="310896"/>
+            <a:off x="4870531" y="5025979"/>
+            <a:ext cx="591657" cy="591657"/>
           </a:xfrm>
           <a:prstGeom prst="ellipse">
             <a:avLst/>
@@ -16098,14 +15441,14 @@
       </p:sp>
       <p:sp>
         <p:nvSpPr>
-          <p:cNvPr id="29" name="Text 26"/>
+          <p:cNvPr id="8" name="Text 5"/>
           <p:cNvSpPr txBox="1"/>
           <p:nvPr/>
         </p:nvSpPr>
         <p:spPr>
           <a:xfrm>
-            <a:off x="5732274" y="4789662"/>
-            <a:ext cx="310896" cy="310896"/>
+            <a:off x="4870531" y="5025979"/>
+            <a:ext cx="591657" cy="591657"/>
           </a:xfrm>
           <a:prstGeom prst="rect">
             <a:avLst/>
@@ -16121,27 +15464,63 @@
               <a:buNone/>
             </a:pPr>
             <a:r>
-              <a:rPr lang="en-US" sz="1200" b="1" dirty="0">
+              <a:rPr lang="en-US" sz="1300" b="1" dirty="0">
                 <a:solidFill>
                   <a:schemeClr val="bg1"/>
                 </a:solidFill>
               </a:rPr>
               <a:t>2</a:t>
             </a:r>
-            <a:endParaRPr lang="en-US" sz="1200" dirty="0"/>
+            <a:endParaRPr lang="en-US" sz="1300" dirty="0"/>
           </a:p>
         </p:txBody>
       </p:sp>
       <p:sp>
         <p:nvSpPr>
-          <p:cNvPr id="30" name="Shape 27"/>
+          <p:cNvPr id="9" name="Text 6"/>
+          <p:cNvSpPr txBox="1"/>
+          <p:nvPr/>
+        </p:nvSpPr>
+        <p:spPr>
+          <a:xfrm>
+            <a:off x="5517053" y="5202936"/>
+            <a:ext cx="1463040" cy="237744"/>
+          </a:xfrm>
+          <a:prstGeom prst="rect">
+            <a:avLst/>
+          </a:prstGeom>
+          <a:noFill/>
+          <a:ln/>
+        </p:spPr>
+        <p:txBody>
+          <a:bodyPr wrap="square" lIns="0" tIns="0" rIns="0" bIns="0" rtlCol="0" anchor="ctr"/>
+          <a:lstStyle/>
+          <a:p>
+            <a:pPr algn="l" indent="0" marL="0">
+              <a:buNone/>
+            </a:pPr>
+            <a:r>
+              <a:rPr lang="en-US" sz="1100" b="1" dirty="0">
+                <a:solidFill>
+                  <a:schemeClr val="tx2"/>
+                </a:solidFill>
+              </a:rPr>
+              <a:t>Phila. Kensington</a:t>
+            </a:r>
+            <a:endParaRPr lang="en-US" sz="1100" dirty="0"/>
+          </a:p>
+        </p:txBody>
+      </p:sp>
+      <p:sp>
+        <p:nvSpPr>
+          <p:cNvPr id="10" name="Zona 3"/>
           <p:cNvSpPr/>
           <p:nvPr/>
         </p:nvSpPr>
         <p:spPr>
           <a:xfrm>
-            <a:off x="3575648" y="4036557"/>
-            <a:ext cx="310896" cy="310896"/>
+            <a:off x="3826248" y="4009128"/>
+            <a:ext cx="631967" cy="631967"/>
           </a:xfrm>
           <a:prstGeom prst="ellipse">
             <a:avLst/>
@@ -16159,14 +15538,14 @@
       </p:sp>
       <p:sp>
         <p:nvSpPr>
-          <p:cNvPr id="31" name="Text 28"/>
+          <p:cNvPr id="11" name="Text 8"/>
           <p:cNvSpPr txBox="1"/>
           <p:nvPr/>
         </p:nvSpPr>
         <p:spPr>
           <a:xfrm>
-            <a:off x="3575648" y="4036557"/>
-            <a:ext cx="310896" cy="310896"/>
+            <a:off x="3826248" y="4009128"/>
+            <a:ext cx="631967" cy="631967"/>
           </a:xfrm>
           <a:prstGeom prst="rect">
             <a:avLst/>
@@ -16182,27 +15561,63 @@
               <a:buNone/>
             </a:pPr>
             <a:r>
-              <a:rPr lang="en-US" sz="1200" b="1" dirty="0">
+              <a:rPr lang="en-US" sz="1300" b="1" dirty="0">
                 <a:solidFill>
                   <a:schemeClr val="bg1"/>
                 </a:solidFill>
               </a:rPr>
               <a:t>3</a:t>
             </a:r>
-            <a:endParaRPr lang="en-US" sz="1200" dirty="0"/>
+            <a:endParaRPr lang="en-US" sz="1300" dirty="0"/>
           </a:p>
         </p:txBody>
       </p:sp>
       <p:sp>
         <p:nvSpPr>
-          <p:cNvPr id="32" name="Shape 29"/>
+          <p:cNvPr id="12" name="Text 9"/>
+          <p:cNvSpPr txBox="1"/>
+          <p:nvPr/>
+        </p:nvSpPr>
+        <p:spPr>
+          <a:xfrm>
+            <a:off x="4513080" y="4206240"/>
+            <a:ext cx="1463040" cy="237744"/>
+          </a:xfrm>
+          <a:prstGeom prst="rect">
+            <a:avLst/>
+          </a:prstGeom>
+          <a:noFill/>
+          <a:ln/>
+        </p:spPr>
+        <p:txBody>
+          <a:bodyPr wrap="square" lIns="0" tIns="0" rIns="0" bIns="0" rtlCol="0" anchor="ctr"/>
+          <a:lstStyle/>
+          <a:p>
+            <a:pPr algn="l" indent="0" marL="0">
+              <a:buNone/>
+            </a:pPr>
+            <a:r>
+              <a:rPr lang="en-US" sz="1100" b="1" dirty="0">
+                <a:solidFill>
+                  <a:schemeClr val="tx2"/>
+                </a:solidFill>
+              </a:rPr>
+              <a:t>Reading</a:t>
+            </a:r>
+            <a:endParaRPr lang="en-US" sz="1100" dirty="0"/>
+          </a:p>
+        </p:txBody>
+      </p:sp>
+      <p:sp>
+        <p:nvSpPr>
+          <p:cNvPr id="13" name="Zona 4"/>
           <p:cNvSpPr/>
           <p:nvPr/>
         </p:nvSpPr>
         <p:spPr>
           <a:xfrm>
-            <a:off x="4318504" y="3464822"/>
-            <a:ext cx="310896" cy="310896"/>
+            <a:off x="4568900" y="3444188"/>
+            <a:ext cx="627992" cy="627992"/>
           </a:xfrm>
           <a:prstGeom prst="ellipse">
             <a:avLst/>
@@ -16220,14 +15635,14 @@
       </p:sp>
       <p:sp>
         <p:nvSpPr>
-          <p:cNvPr id="33" name="Text 30"/>
+          <p:cNvPr id="14" name="Text 11"/>
           <p:cNvSpPr txBox="1"/>
           <p:nvPr/>
         </p:nvSpPr>
         <p:spPr>
           <a:xfrm>
-            <a:off x="4318504" y="3464822"/>
-            <a:ext cx="310896" cy="310896"/>
+            <a:off x="4568900" y="3444188"/>
+            <a:ext cx="627992" cy="627992"/>
           </a:xfrm>
           <a:prstGeom prst="rect">
             <a:avLst/>
@@ -16243,27 +15658,63 @@
               <a:buNone/>
             </a:pPr>
             <a:r>
-              <a:rPr lang="en-US" sz="1200" b="1" dirty="0">
+              <a:rPr lang="en-US" sz="1300" b="1" dirty="0">
                 <a:solidFill>
                   <a:schemeClr val="bg1"/>
                 </a:solidFill>
               </a:rPr>
               <a:t>4</a:t>
             </a:r>
-            <a:endParaRPr lang="en-US" sz="1200" dirty="0"/>
+            <a:endParaRPr lang="en-US" sz="1300" dirty="0"/>
           </a:p>
         </p:txBody>
       </p:sp>
       <p:sp>
         <p:nvSpPr>
-          <p:cNvPr id="34" name="Shape 31"/>
+          <p:cNvPr id="15" name="Text 12"/>
+          <p:cNvSpPr txBox="1"/>
+          <p:nvPr/>
+        </p:nvSpPr>
+        <p:spPr>
+          <a:xfrm>
+            <a:off x="5251756" y="3639312"/>
+            <a:ext cx="1463040" cy="237744"/>
+          </a:xfrm>
+          <a:prstGeom prst="rect">
+            <a:avLst/>
+          </a:prstGeom>
+          <a:noFill/>
+          <a:ln/>
+        </p:spPr>
+        <p:txBody>
+          <a:bodyPr wrap="square" lIns="0" tIns="0" rIns="0" bIns="0" rtlCol="0" anchor="ctr"/>
+          <a:lstStyle/>
+          <a:p>
+            <a:pPr algn="l" indent="0" marL="0">
+              <a:buNone/>
+            </a:pPr>
+            <a:r>
+              <a:rPr lang="en-US" sz="1100" b="1" dirty="0">
+                <a:solidFill>
+                  <a:schemeClr val="tx2"/>
+                </a:solidFill>
+              </a:rPr>
+              <a:t>Allentown</a:t>
+            </a:r>
+            <a:endParaRPr lang="en-US" sz="1100" dirty="0"/>
+          </a:p>
+        </p:txBody>
+      </p:sp>
+      <p:sp>
+        <p:nvSpPr>
+          <p:cNvPr id="16" name="Zona 5"/>
           <p:cNvSpPr/>
           <p:nvPr/>
         </p:nvSpPr>
         <p:spPr>
           <a:xfrm>
-            <a:off x="3497856" y="2743589"/>
-            <a:ext cx="310896" cy="310896"/>
+            <a:off x="3774072" y="2695080"/>
+            <a:ext cx="590015" cy="590015"/>
           </a:xfrm>
           <a:prstGeom prst="ellipse">
             <a:avLst/>
@@ -16281,14 +15732,14 @@
       </p:sp>
       <p:sp>
         <p:nvSpPr>
-          <p:cNvPr id="35" name="Text 32"/>
+          <p:cNvPr id="17" name="Text 14"/>
           <p:cNvSpPr txBox="1"/>
           <p:nvPr/>
         </p:nvSpPr>
         <p:spPr>
           <a:xfrm>
-            <a:off x="3497856" y="2743589"/>
-            <a:ext cx="310896" cy="310896"/>
+            <a:off x="3774072" y="2695080"/>
+            <a:ext cx="590015" cy="590015"/>
           </a:xfrm>
           <a:prstGeom prst="rect">
             <a:avLst/>
@@ -16304,27 +15755,63 @@
               <a:buNone/>
             </a:pPr>
             <a:r>
-              <a:rPr lang="en-US" sz="1200" b="1" dirty="0">
+              <a:rPr lang="en-US" sz="1300" b="1" dirty="0">
                 <a:solidFill>
                   <a:schemeClr val="bg1"/>
                 </a:solidFill>
               </a:rPr>
               <a:t>5</a:t>
             </a:r>
-            <a:endParaRPr lang="en-US" sz="1200" dirty="0"/>
+            <a:endParaRPr lang="en-US" sz="1300" dirty="0"/>
           </a:p>
         </p:txBody>
       </p:sp>
       <p:sp>
         <p:nvSpPr>
-          <p:cNvPr id="36" name="Shape 33"/>
+          <p:cNvPr id="18" name="Text 15"/>
+          <p:cNvSpPr txBox="1"/>
+          <p:nvPr/>
+        </p:nvSpPr>
+        <p:spPr>
+          <a:xfrm>
+            <a:off x="4418952" y="2871216"/>
+            <a:ext cx="1463040" cy="237744"/>
+          </a:xfrm>
+          <a:prstGeom prst="rect">
+            <a:avLst/>
+          </a:prstGeom>
+          <a:noFill/>
+          <a:ln/>
+        </p:spPr>
+        <p:txBody>
+          <a:bodyPr wrap="square" lIns="0" tIns="0" rIns="0" bIns="0" rtlCol="0" anchor="ctr"/>
+          <a:lstStyle/>
+          <a:p>
+            <a:pPr algn="l" indent="0" marL="0">
+              <a:buNone/>
+            </a:pPr>
+            <a:r>
+              <a:rPr lang="en-US" sz="1100" b="1" dirty="0">
+                <a:solidFill>
+                  <a:schemeClr val="tx2"/>
+                </a:solidFill>
+              </a:rPr>
+              <a:t>Hazleton</a:t>
+            </a:r>
+            <a:endParaRPr lang="en-US" sz="1100" dirty="0"/>
+          </a:p>
+        </p:txBody>
+      </p:sp>
+      <p:sp>
+        <p:nvSpPr>
+          <p:cNvPr id="19" name="Zona 6"/>
           <p:cNvSpPr/>
           <p:nvPr/>
         </p:nvSpPr>
         <p:spPr>
           <a:xfrm>
-            <a:off x="4464210" y="2304241"/>
-            <a:ext cx="310896" cy="310896"/>
+            <a:off x="4178930" y="1975226"/>
+            <a:ext cx="438667" cy="438667"/>
           </a:xfrm>
           <a:prstGeom prst="ellipse">
             <a:avLst/>
@@ -16342,14 +15829,14 @@
       </p:sp>
       <p:sp>
         <p:nvSpPr>
-          <p:cNvPr id="37" name="Text 34"/>
+          <p:cNvPr id="20" name="Text 17"/>
           <p:cNvSpPr txBox="1"/>
           <p:nvPr/>
         </p:nvSpPr>
         <p:spPr>
           <a:xfrm>
-            <a:off x="4464210" y="2304241"/>
-            <a:ext cx="310896" cy="310896"/>
+            <a:off x="4178930" y="1975226"/>
+            <a:ext cx="438667" cy="438667"/>
           </a:xfrm>
           <a:prstGeom prst="rect">
             <a:avLst/>
@@ -16365,27 +15852,63 @@
               <a:buNone/>
             </a:pPr>
             <a:r>
-              <a:rPr lang="en-US" sz="1200" b="1" dirty="0">
+              <a:rPr lang="en-US" sz="1300" b="1" dirty="0">
                 <a:solidFill>
                   <a:schemeClr val="bg1"/>
                 </a:solidFill>
               </a:rPr>
               <a:t>6</a:t>
             </a:r>
-            <a:endParaRPr lang="en-US" sz="1200" dirty="0"/>
+            <a:endParaRPr lang="en-US" sz="1300" dirty="0"/>
           </a:p>
         </p:txBody>
       </p:sp>
       <p:sp>
         <p:nvSpPr>
-          <p:cNvPr id="38" name="Shape 35"/>
+          <p:cNvPr id="21" name="Text 18"/>
+          <p:cNvSpPr txBox="1"/>
+          <p:nvPr/>
+        </p:nvSpPr>
+        <p:spPr>
+          <a:xfrm>
+            <a:off x="4672462" y="2075688"/>
+            <a:ext cx="1463040" cy="237744"/>
+          </a:xfrm>
+          <a:prstGeom prst="rect">
+            <a:avLst/>
+          </a:prstGeom>
+          <a:noFill/>
+          <a:ln/>
+        </p:spPr>
+        <p:txBody>
+          <a:bodyPr wrap="square" lIns="0" tIns="0" rIns="0" bIns="0" rtlCol="0" anchor="ctr"/>
+          <a:lstStyle/>
+          <a:p>
+            <a:pPr algn="l" indent="0" marL="0">
+              <a:buNone/>
+            </a:pPr>
+            <a:r>
+              <a:rPr lang="en-US" sz="1100" b="1" dirty="0">
+                <a:solidFill>
+                  <a:schemeClr val="tx2"/>
+                </a:solidFill>
+              </a:rPr>
+              <a:t>Wilkes-Barre / Scranton</a:t>
+            </a:r>
+            <a:endParaRPr lang="en-US" sz="1100" dirty="0"/>
+          </a:p>
+        </p:txBody>
+      </p:sp>
+      <p:sp>
+        <p:nvSpPr>
+          <p:cNvPr id="22" name="Zona 7"/>
           <p:cNvSpPr/>
           <p:nvPr/>
         </p:nvSpPr>
         <p:spPr>
           <a:xfrm>
-            <a:off x="2916936" y="4562856"/>
-            <a:ext cx="310896" cy="310896"/>
+            <a:off x="2790909" y="4436829"/>
+            <a:ext cx="562951" cy="562951"/>
           </a:xfrm>
           <a:prstGeom prst="ellipse">
             <a:avLst/>
@@ -16403,14 +15926,14 @@
       </p:sp>
       <p:sp>
         <p:nvSpPr>
-          <p:cNvPr id="39" name="Text 36"/>
+          <p:cNvPr id="23" name="Text 20"/>
           <p:cNvSpPr txBox="1"/>
           <p:nvPr/>
         </p:nvSpPr>
         <p:spPr>
           <a:xfrm>
-            <a:off x="2916936" y="4562856"/>
-            <a:ext cx="310896" cy="310896"/>
+            <a:off x="2790909" y="4436829"/>
+            <a:ext cx="562951" cy="562951"/>
           </a:xfrm>
           <a:prstGeom prst="rect">
             <a:avLst/>
@@ -16426,27 +15949,63 @@
               <a:buNone/>
             </a:pPr>
             <a:r>
-              <a:rPr lang="en-US" sz="1200" b="1" dirty="0">
+              <a:rPr lang="en-US" sz="1300" b="1" dirty="0">
                 <a:solidFill>
                   <a:schemeClr val="bg1"/>
                 </a:solidFill>
               </a:rPr>
               <a:t>7</a:t>
             </a:r>
-            <a:endParaRPr lang="en-US" sz="1200" dirty="0"/>
+            <a:endParaRPr lang="en-US" sz="1300" dirty="0"/>
           </a:p>
         </p:txBody>
       </p:sp>
       <p:sp>
         <p:nvSpPr>
-          <p:cNvPr id="40" name="Shape 37"/>
+          <p:cNvPr id="24" name="Text 21"/>
+          <p:cNvSpPr txBox="1"/>
+          <p:nvPr/>
+        </p:nvSpPr>
+        <p:spPr>
+          <a:xfrm>
+            <a:off x="1273005" y="4599432"/>
+            <a:ext cx="1463040" cy="237744"/>
+          </a:xfrm>
+          <a:prstGeom prst="rect">
+            <a:avLst/>
+          </a:prstGeom>
+          <a:noFill/>
+          <a:ln/>
+        </p:spPr>
+        <p:txBody>
+          <a:bodyPr wrap="square" lIns="0" tIns="0" rIns="0" bIns="0" rtlCol="0" anchor="ctr"/>
+          <a:lstStyle/>
+          <a:p>
+            <a:pPr algn="r" indent="0" marL="0">
+              <a:buNone/>
+            </a:pPr>
+            <a:r>
+              <a:rPr lang="en-US" sz="1100" b="1" dirty="0">
+                <a:solidFill>
+                  <a:schemeClr val="tx2"/>
+                </a:solidFill>
+              </a:rPr>
+              <a:t>Centro-Sur</a:t>
+            </a:r>
+            <a:endParaRPr lang="en-US" sz="1100" dirty="0"/>
+          </a:p>
+        </p:txBody>
+      </p:sp>
+      <p:sp>
+        <p:nvSpPr>
+          <p:cNvPr id="25" name="Zona 8"/>
           <p:cNvSpPr/>
           <p:nvPr/>
         </p:nvSpPr>
         <p:spPr>
           <a:xfrm>
-            <a:off x="4234386" y="5398616"/>
-            <a:ext cx="310896" cy="310896"/>
+            <a:off x="4574067" y="5397027"/>
+            <a:ext cx="398203" cy="398203"/>
           </a:xfrm>
           <a:prstGeom prst="ellipse">
             <a:avLst/>
@@ -16464,14 +16023,14 @@
       </p:sp>
       <p:sp>
         <p:nvSpPr>
-          <p:cNvPr id="41" name="Text 38"/>
+          <p:cNvPr id="26" name="Text 23"/>
           <p:cNvSpPr txBox="1"/>
           <p:nvPr/>
         </p:nvSpPr>
         <p:spPr>
           <a:xfrm>
-            <a:off x="4234386" y="5398616"/>
-            <a:ext cx="310896" cy="310896"/>
+            <a:off x="4574067" y="5397027"/>
+            <a:ext cx="398203" cy="398203"/>
           </a:xfrm>
           <a:prstGeom prst="rect">
             <a:avLst/>
@@ -16487,27 +16046,27 @@
               <a:buNone/>
             </a:pPr>
             <a:r>
-              <a:rPr lang="en-US" sz="1200" b="1" dirty="0">
+              <a:rPr lang="en-US" sz="1300" b="1" dirty="0">
                 <a:solidFill>
                   <a:schemeClr val="bg1"/>
                 </a:solidFill>
               </a:rPr>
               <a:t>8</a:t>
             </a:r>
-            <a:endParaRPr lang="en-US" sz="1200" dirty="0"/>
+            <a:endParaRPr lang="en-US" sz="1300" dirty="0"/>
           </a:p>
         </p:txBody>
       </p:sp>
       <p:sp>
         <p:nvSpPr>
-          <p:cNvPr id="42" name="Text 39"/>
+          <p:cNvPr id="27" name="Text 24"/>
           <p:cNvSpPr txBox="1"/>
           <p:nvPr/>
         </p:nvSpPr>
         <p:spPr>
           <a:xfrm>
-            <a:off x="8275320" y="1554480"/>
-            <a:ext cx="2286000" cy="256032"/>
+            <a:off x="3056163" y="5477256"/>
+            <a:ext cx="1463040" cy="237744"/>
           </a:xfrm>
           <a:prstGeom prst="rect">
             <a:avLst/>
@@ -16519,16 +16078,16 @@
           <a:bodyPr wrap="square" lIns="0" tIns="0" rIns="0" bIns="0" rtlCol="0" anchor="ctr"/>
           <a:lstStyle/>
           <a:p>
-            <a:pPr indent="0" marL="0">
+            <a:pPr algn="r" indent="0" marL="0">
               <a:buNone/>
             </a:pPr>
             <a:r>
               <a:rPr lang="en-US" sz="1100" b="1" dirty="0">
                 <a:solidFill>
-                  <a:schemeClr val="accent3"/>
-                </a:solidFill>
-              </a:rPr>
-              <a:t>Zona</a:t>
+                  <a:schemeClr val="tx2"/>
+                </a:solidFill>
+              </a:rPr>
+              <a:t>Wilmington</a:t>
             </a:r>
             <a:endParaRPr lang="en-US" sz="1100" dirty="0"/>
           </a:p>
@@ -16536,14 +16095,14 @@
       </p:sp>
       <p:sp>
         <p:nvSpPr>
-          <p:cNvPr id="43" name="Text 40"/>
+          <p:cNvPr id="28" name="Text 25"/>
           <p:cNvSpPr txBox="1"/>
           <p:nvPr/>
         </p:nvSpPr>
         <p:spPr>
           <a:xfrm>
-            <a:off x="10744200" y="1554480"/>
-            <a:ext cx="896112" cy="256032"/>
+            <a:off x="8275320" y="1554480"/>
+            <a:ext cx="2286000" cy="256032"/>
           </a:xfrm>
           <a:prstGeom prst="rect">
             <a:avLst/>
@@ -16555,6 +16114,42 @@
           <a:bodyPr wrap="square" lIns="0" tIns="0" rIns="0" bIns="0" rtlCol="0" anchor="ctr"/>
           <a:lstStyle/>
           <a:p>
+            <a:pPr indent="0" marL="0">
+              <a:buNone/>
+            </a:pPr>
+            <a:r>
+              <a:rPr lang="en-US" sz="1100" b="1" dirty="0">
+                <a:solidFill>
+                  <a:schemeClr val="accent3"/>
+                </a:solidFill>
+              </a:rPr>
+              <a:t>Zona</a:t>
+            </a:r>
+            <a:endParaRPr lang="en-US" sz="1100" dirty="0"/>
+          </a:p>
+        </p:txBody>
+      </p:sp>
+      <p:sp>
+        <p:nvSpPr>
+          <p:cNvPr id="29" name="Text 26"/>
+          <p:cNvSpPr txBox="1"/>
+          <p:nvPr/>
+        </p:nvSpPr>
+        <p:spPr>
+          <a:xfrm>
+            <a:off x="10744200" y="1554480"/>
+            <a:ext cx="896112" cy="256032"/>
+          </a:xfrm>
+          <a:prstGeom prst="rect">
+            <a:avLst/>
+          </a:prstGeom>
+          <a:noFill/>
+          <a:ln/>
+        </p:spPr>
+        <p:txBody>
+          <a:bodyPr wrap="square" lIns="0" tIns="0" rIns="0" bIns="0" rtlCol="0" anchor="ctr"/>
+          <a:lstStyle/>
+          <a:p>
             <a:pPr algn="r" indent="0" marL="0">
               <a:buNone/>
             </a:pPr>
@@ -16572,7 +16167,7 @@
       </p:sp>
       <p:sp>
         <p:nvSpPr>
-          <p:cNvPr id="44" name="Shape 41"/>
+          <p:cNvPr id="30" name="Shape 27"/>
           <p:cNvSpPr/>
           <p:nvPr/>
         </p:nvSpPr>
@@ -16597,7 +16192,7 @@
       </p:sp>
       <p:sp>
         <p:nvSpPr>
-          <p:cNvPr id="45" name="Text 42"/>
+          <p:cNvPr id="31" name="Text 28"/>
           <p:cNvSpPr txBox="1"/>
           <p:nvPr/>
         </p:nvSpPr>
@@ -16633,7 +16228,7 @@
       </p:sp>
       <p:sp>
         <p:nvSpPr>
-          <p:cNvPr id="46" name="Text 43"/>
+          <p:cNvPr id="32" name="Text 29"/>
           <p:cNvSpPr txBox="1"/>
           <p:nvPr/>
         </p:nvSpPr>
@@ -16683,7 +16278,7 @@
       </p:sp>
       <p:sp>
         <p:nvSpPr>
-          <p:cNvPr id="47" name="Text 44"/>
+          <p:cNvPr id="33" name="Text 30"/>
           <p:cNvSpPr txBox="1"/>
           <p:nvPr/>
         </p:nvSpPr>
@@ -16719,7 +16314,7 @@
       </p:sp>
       <p:sp>
         <p:nvSpPr>
-          <p:cNvPr id="48" name="Shape 45"/>
+          <p:cNvPr id="34" name="Shape 31"/>
           <p:cNvSpPr/>
           <p:nvPr/>
         </p:nvSpPr>
@@ -16744,7 +16339,7 @@
       </p:sp>
       <p:sp>
         <p:nvSpPr>
-          <p:cNvPr id="49" name="Text 46"/>
+          <p:cNvPr id="35" name="Text 32"/>
           <p:cNvSpPr txBox="1"/>
           <p:nvPr/>
         </p:nvSpPr>
@@ -16780,7 +16375,7 @@
       </p:sp>
       <p:sp>
         <p:nvSpPr>
-          <p:cNvPr id="50" name="Text 47"/>
+          <p:cNvPr id="36" name="Text 33"/>
           <p:cNvSpPr txBox="1"/>
           <p:nvPr/>
         </p:nvSpPr>
@@ -16830,7 +16425,7 @@
       </p:sp>
       <p:sp>
         <p:nvSpPr>
-          <p:cNvPr id="51" name="Text 48"/>
+          <p:cNvPr id="37" name="Text 34"/>
           <p:cNvSpPr txBox="1"/>
           <p:nvPr/>
         </p:nvSpPr>
@@ -16866,7 +16461,7 @@
       </p:sp>
       <p:sp>
         <p:nvSpPr>
-          <p:cNvPr id="52" name="Shape 49"/>
+          <p:cNvPr id="38" name="Shape 35"/>
           <p:cNvSpPr/>
           <p:nvPr/>
         </p:nvSpPr>
@@ -16891,7 +16486,7 @@
       </p:sp>
       <p:sp>
         <p:nvSpPr>
-          <p:cNvPr id="53" name="Text 50"/>
+          <p:cNvPr id="39" name="Text 36"/>
           <p:cNvSpPr txBox="1"/>
           <p:nvPr/>
         </p:nvSpPr>
@@ -16927,7 +16522,7 @@
       </p:sp>
       <p:sp>
         <p:nvSpPr>
-          <p:cNvPr id="54" name="Text 51"/>
+          <p:cNvPr id="40" name="Text 37"/>
           <p:cNvSpPr txBox="1"/>
           <p:nvPr/>
         </p:nvSpPr>
@@ -16977,7 +16572,7 @@
       </p:sp>
       <p:sp>
         <p:nvSpPr>
-          <p:cNvPr id="55" name="Text 52"/>
+          <p:cNvPr id="41" name="Text 38"/>
           <p:cNvSpPr txBox="1"/>
           <p:nvPr/>
         </p:nvSpPr>
@@ -17013,7 +16608,7 @@
       </p:sp>
       <p:sp>
         <p:nvSpPr>
-          <p:cNvPr id="56" name="Shape 53"/>
+          <p:cNvPr id="42" name="Shape 39"/>
           <p:cNvSpPr/>
           <p:nvPr/>
         </p:nvSpPr>
@@ -17038,7 +16633,7 @@
       </p:sp>
       <p:sp>
         <p:nvSpPr>
-          <p:cNvPr id="57" name="Text 54"/>
+          <p:cNvPr id="43" name="Text 40"/>
           <p:cNvSpPr txBox="1"/>
           <p:nvPr/>
         </p:nvSpPr>
@@ -17074,7 +16669,7 @@
       </p:sp>
       <p:sp>
         <p:nvSpPr>
-          <p:cNvPr id="58" name="Text 55"/>
+          <p:cNvPr id="44" name="Text 41"/>
           <p:cNvSpPr txBox="1"/>
           <p:nvPr/>
         </p:nvSpPr>
@@ -17124,7 +16719,7 @@
       </p:sp>
       <p:sp>
         <p:nvSpPr>
-          <p:cNvPr id="59" name="Text 56"/>
+          <p:cNvPr id="45" name="Text 42"/>
           <p:cNvSpPr txBox="1"/>
           <p:nvPr/>
         </p:nvSpPr>
@@ -17160,7 +16755,7 @@
       </p:sp>
       <p:sp>
         <p:nvSpPr>
-          <p:cNvPr id="60" name="Shape 57"/>
+          <p:cNvPr id="46" name="Shape 43"/>
           <p:cNvSpPr/>
           <p:nvPr/>
         </p:nvSpPr>
@@ -17185,7 +16780,7 @@
       </p:sp>
       <p:sp>
         <p:nvSpPr>
-          <p:cNvPr id="61" name="Text 58"/>
+          <p:cNvPr id="47" name="Text 44"/>
           <p:cNvSpPr txBox="1"/>
           <p:nvPr/>
         </p:nvSpPr>
@@ -17221,7 +16816,7 @@
       </p:sp>
       <p:sp>
         <p:nvSpPr>
-          <p:cNvPr id="62" name="Text 59"/>
+          <p:cNvPr id="48" name="Text 45"/>
           <p:cNvSpPr txBox="1"/>
           <p:nvPr/>
         </p:nvSpPr>
@@ -17271,7 +16866,7 @@
       </p:sp>
       <p:sp>
         <p:nvSpPr>
-          <p:cNvPr id="63" name="Text 60"/>
+          <p:cNvPr id="49" name="Text 46"/>
           <p:cNvSpPr txBox="1"/>
           <p:nvPr/>
         </p:nvSpPr>
@@ -17307,7 +16902,7 @@
       </p:sp>
       <p:sp>
         <p:nvSpPr>
-          <p:cNvPr id="64" name="Shape 61"/>
+          <p:cNvPr id="50" name="Shape 47"/>
           <p:cNvSpPr/>
           <p:nvPr/>
         </p:nvSpPr>
@@ -17332,7 +16927,7 @@
       </p:sp>
       <p:sp>
         <p:nvSpPr>
-          <p:cNvPr id="65" name="Text 62"/>
+          <p:cNvPr id="51" name="Text 48"/>
           <p:cNvSpPr txBox="1"/>
           <p:nvPr/>
         </p:nvSpPr>
@@ -17368,7 +16963,7 @@
       </p:sp>
       <p:sp>
         <p:nvSpPr>
-          <p:cNvPr id="66" name="Text 63"/>
+          <p:cNvPr id="52" name="Text 49"/>
           <p:cNvSpPr txBox="1"/>
           <p:nvPr/>
         </p:nvSpPr>
@@ -17418,7 +17013,7 @@
       </p:sp>
       <p:sp>
         <p:nvSpPr>
-          <p:cNvPr id="67" name="Text 64"/>
+          <p:cNvPr id="53" name="Text 50"/>
           <p:cNvSpPr txBox="1"/>
           <p:nvPr/>
         </p:nvSpPr>
@@ -17454,7 +17049,7 @@
       </p:sp>
       <p:sp>
         <p:nvSpPr>
-          <p:cNvPr id="68" name="Shape 65"/>
+          <p:cNvPr id="54" name="Shape 51"/>
           <p:cNvSpPr/>
           <p:nvPr/>
         </p:nvSpPr>
@@ -17479,7 +17074,7 @@
       </p:sp>
       <p:sp>
         <p:nvSpPr>
-          <p:cNvPr id="69" name="Text 66"/>
+          <p:cNvPr id="55" name="Text 52"/>
           <p:cNvSpPr txBox="1"/>
           <p:nvPr/>
         </p:nvSpPr>
@@ -17515,7 +17110,7 @@
       </p:sp>
       <p:sp>
         <p:nvSpPr>
-          <p:cNvPr id="70" name="Text 67"/>
+          <p:cNvPr id="56" name="Text 53"/>
           <p:cNvSpPr txBox="1"/>
           <p:nvPr/>
         </p:nvSpPr>
@@ -17565,7 +17160,7 @@
       </p:sp>
       <p:sp>
         <p:nvSpPr>
-          <p:cNvPr id="71" name="Text 68"/>
+          <p:cNvPr id="57" name="Text 54"/>
           <p:cNvSpPr txBox="1"/>
           <p:nvPr/>
         </p:nvSpPr>
@@ -17601,7 +17196,7 @@
       </p:sp>
       <p:sp>
         <p:nvSpPr>
-          <p:cNvPr id="72" name="Shape 69"/>
+          <p:cNvPr id="58" name="Shape 55"/>
           <p:cNvSpPr/>
           <p:nvPr/>
         </p:nvSpPr>
@@ -17626,7 +17221,7 @@
       </p:sp>
       <p:sp>
         <p:nvSpPr>
-          <p:cNvPr id="73" name="Text 70"/>
+          <p:cNvPr id="59" name="Text 56"/>
           <p:cNvSpPr txBox="1"/>
           <p:nvPr/>
         </p:nvSpPr>
@@ -17662,7 +17257,7 @@
       </p:sp>
       <p:sp>
         <p:nvSpPr>
-          <p:cNvPr id="74" name="Text 71"/>
+          <p:cNvPr id="60" name="Text 57"/>
           <p:cNvSpPr txBox="1"/>
           <p:nvPr/>
         </p:nvSpPr>
@@ -17712,7 +17307,7 @@
       </p:sp>
       <p:sp>
         <p:nvSpPr>
-          <p:cNvPr id="75" name="Text 72"/>
+          <p:cNvPr id="61" name="Text 58"/>
           <p:cNvSpPr txBox="1"/>
           <p:nvPr/>
         </p:nvSpPr>
@@ -17748,7 +17343,7 @@
       </p:sp>
       <p:sp>
         <p:nvSpPr>
-          <p:cNvPr id="76" name="Fuente"/>
+          <p:cNvPr id="62" name="Fuente"/>
           <p:cNvSpPr txBox="1"/>
           <p:nvPr/>
         </p:nvSpPr>
@@ -17776,7 +17371,7 @@
                   <a:schemeClr val="accent4"/>
                 </a:solidFill>
               </a:rPr>
-              <a:t>Electores: Seccional PRM Pennsylvania (2024). Tamaño del círculo según electores de cada ciudad. Zonas: agrupación propuesta. Cartografía: US Census (us-atlas).</a:t>
+              <a:t>Electores: Seccional PRM Pennsylvania (2024). Tamaño del círculo según los electores de cada zona. Versión interactiva en el enlace web. Cartografía: US Census.</a:t>
             </a:r>
             <a:endParaRPr lang="en-US" sz="1000" dirty="0"/>
           </a:p>

</xml_diff>

<commit_message>
Destacar 4.ª seccional y mayor crecimiento; nombrar la zona 7 por sus ciudades
Co-Authored-By: Claude Opus 5.5 <noreply@anthropic.com>
Claude-Session: https://claude.ai/code/session_01RrEJtrwRidXxzgveZEVQjf
</commit_message>
<xml_diff>
--- a/presentaciones/Plan_Estrategico_Pennsylvania_2028.pptx
+++ b/presentaciones/Plan_Estrategico_Pennsylvania_2028.pptx
@@ -120,7 +120,7 @@
   <p:extLst>
     <p:ext uri="{521415D9-36F7-43E2-AB2F-B90AF26B5E84}">
       <p14:sectionLst xmlns:p14="http://schemas.microsoft.com/office/powerpoint/2010/main">
-        <p14:section name="Diagnóstico" id="{7b008938-e9a8-c9ca-f8b8-daa4da07423a}">
+        <p14:section name="Diagnóstico" id="{20c2cb34-6b7a-e69e-1a79-906b779d0ac3}">
           <p14:sldIdLst>
             <p14:sldId id="256"/>
             <p14:sldId id="257"/>
@@ -129,19 +129,19 @@
             <p14:sldId id="260"/>
           </p14:sldIdLst>
         </p14:section>
-        <p14:section name="Desafíos" id="{0be04665-0b61-6853-047a-5457c0584a40}">
+        <p14:section name="Desafíos" id="{767d5d3c-18b3-524d-b4a9-4227ba16a0a3}">
           <p14:sldIdLst>
             <p14:sldId id="261"/>
             <p14:sldId id="262"/>
           </p14:sldIdLst>
         </p14:section>
-        <p14:section name="Escenarios y meta" id="{502eea75-1eca-02a8-e408-e413e3172989}">
+        <p14:section name="Escenarios y meta" id="{ce49d770-b378-517a-e302-4b1af7597e28}">
           <p14:sldIdLst>
             <p14:sldId id="263"/>
             <p14:sldId id="264"/>
           </p14:sldIdLst>
         </p14:section>
-        <p14:section name="Plan y recomendación" id="{cf62aa64-124b-47a6-dd46-1ecf145c78b9}">
+        <p14:section name="Plan y recomendación" id="{6d32070f-6284-0b6f-949a-018606f26ad3}">
           <p14:sldIdLst>
             <p14:sldId id="265"/>
             <p14:sldId id="266"/>
@@ -149,7 +149,7 @@
             <p14:sldId id="268"/>
           </p14:sldIdLst>
         </p14:section>
-        <p14:section name="Anexo" id="{02553240-ca45-9323-a743-fb1c3b2ae734}">
+        <p14:section name="Anexo" id="{4e0de1db-156d-b02f-ee07-9808f64ccaaa}">
           <p14:sldIdLst>
             <p14:sldId id="269"/>
           </p14:sldIdLst>
@@ -713,7 +713,7 @@
                 </a:solidFill>
                 <a:latin typeface="+mn-lt"/>
               </a:rPr>
-              <a:t>Dominicanos registrados en Pennsylvania</a:t>
+              <a:t>Dominicanos en Pennsylvania (INDEX): el mayor crecimiento de EE. UU.</a:t>
             </a:r>
           </a:p>
         </c:rich>
@@ -2404,7 +2404,7 @@
           <a:p>
             <a:r>
               <a:rPr lang="en-US" dirty="0"/>
-              <a:t>Mapa del este de Pennsylvania con las 13 ciudades de la seccional (12 en Pennsylvania y Wilmington, Delaware). El recuadro muestra la ubicación dentro del estado. Zonas: 1 Philadelphia Noreste, 2 Philadelphia Kensington, 3 Berks (Reading), 4 Lehigh Valley (Allentown), 5 Hazleton, 6 Wilkes-Barre y Scranton, 7 Centro-Sur (Harrisburg, Lancaster, York y Lebanon), 8 Delaware (Wilmington). Philadelphia, Reading y Allentown (zonas 1 a 4) suman 32,788 electores, el 69 % del padrón. Líderes: red de 400 líderes de 10 personas, repartida según los electores.</a:t>
+              <a:t>Mapa del este de Pennsylvania con las 13 ciudades de la seccional (12 en Pennsylvania y Wilmington, Delaware). El recuadro muestra la ubicación dentro del estado. Zonas: 1 Philadelphia Noreste, 2 Philadelphia Kensington, 3 Berks (Reading), 4 Lehigh Valley (Allentown), 5 Hazleton, 6 Wilkes-Barre y Scranton, 7 Harrisburg, Lancaster, York y Lebanon, 8 Delaware (Wilmington). Philadelphia, Reading y Allentown (zonas 1 a 4) suman 32,788 electores, el 69 % del padrón. Líderes: red de 400 líderes de 10 personas, repartida según los electores.</a:t>
             </a:r>
             <a:endParaRPr lang="en-US" dirty="0"/>
           </a:p>
@@ -2580,7 +2580,7 @@
           <a:p>
             <a:r>
               <a:rPr lang="en-US" dirty="0"/>
-              <a:t>Desafección: la abstención en el exterior pasó de 51 % (2016) a 81 % (2024); el estudio IIDH/CAPEL para la JCE analiza desafección, desinformación y logística. Nueva cédula: según la JCE, quien no renueve no podrá votar; en el exterior es por cita y culmina en enero de 2028. Centros: Philadelphia (1500 JFK Blvd, 2.º piso) y Consulado de Allentown (1710 Union Blvd). Dispersión: Reading, Noreste y Centro-Sur suman unos 22,100 electores a 40 millas o más de un centro (aproximado).</a:t>
+              <a:t>Desafección: la abstención en el exterior pasó de 51 % (2016) a 81 % (2024); el estudio IIDH/CAPEL para la JCE analiza desafección, desinformación y logística. Nueva cédula: según la JCE, quien no renueve no podrá votar; en el exterior es por cita y culmina en enero de 2028. Centros: Philadelphia (1500 JFK Blvd, 2.º piso) y Consulado de Allentown (1710 Union Blvd). Dispersión: Reading, el noreste (Hazleton, Wilkes-Barre y Scranton) y Harrisburg, Lancaster, York y Lebanon suman unos 22,100 electores a 40 millas o más de un centro (aproximado).</a:t>
             </a:r>
             <a:endParaRPr lang="en-US" dirty="0"/>
           </a:p>
@@ -3855,7 +3855,7 @@
                   <a:schemeClr val="bg1"/>
                 </a:solidFill>
               </a:rPr>
-              <a:t>8</a:t>
+              <a:t>4.ª</a:t>
             </a:r>
             <a:endParaRPr lang="en-US" sz="3000" dirty="0"/>
           </a:p>
@@ -3869,7 +3869,7 @@
                   <a:schemeClr val="accent4"/>
                 </a:solidFill>
               </a:rPr>
-              <a:t>zonas de trabajo</a:t>
+              <a:t>seccional más grande de la Circunscripción I</a:t>
             </a:r>
             <a:endParaRPr lang="en-US" sz="3000" dirty="0"/>
           </a:p>
@@ -3936,7 +3936,7 @@
                   <a:schemeClr val="bg1"/>
                 </a:solidFill>
               </a:rPr>
-              <a:t>13</a:t>
+              <a:t>N.º 1</a:t>
             </a:r>
             <a:endParaRPr lang="en-US" sz="3000" dirty="0"/>
           </a:p>
@@ -3950,7 +3950,7 @@
                   <a:schemeClr val="accent4"/>
                 </a:solidFill>
               </a:rPr>
-              <a:t>ciudades (PA y DE)</a:t>
+              <a:t>en crecimiento dominicano en EE. UU.</a:t>
             </a:r>
             <a:endParaRPr lang="en-US" sz="3000" dirty="0"/>
           </a:p>
@@ -5342,7 +5342,7 @@
       </p:sp>
       <p:sp>
         <p:nvSpPr>
-          <p:cNvPr id="39" name="Zona Centro-Sur"/>
+          <p:cNvPr id="39" name="Zona Harrisburg, Lancaster, York y Lebanon"/>
           <p:cNvSpPr/>
           <p:nvPr/>
         </p:nvSpPr>
@@ -5411,7 +5411,7 @@
                   <a:schemeClr val="tx1"/>
                 </a:solidFill>
               </a:rPr>
-              <a:t>Centro-Sur</a:t>
+              <a:t>Harrisburg, Lancaster, York y Lebanon</a:t>
             </a:r>
             <a:endParaRPr lang="en-US" sz="2200" dirty="0"/>
           </a:p>
@@ -12816,7 +12816,7 @@
                             <a:schemeClr val="tx1"/>
                           </a:solidFill>
                         </a:rPr>
-                        <a:t>Centro-Sur</a:t>
+                        <a:t>Harrisburg, Lancaster, York y Lebanon</a:t>
                       </a:r>
                       <a:endParaRPr lang="en-US" sz="1300" dirty="0"/>
                     </a:p>
@@ -14433,7 +14433,7 @@
                   <a:schemeClr val="accent4"/>
                 </a:solidFill>
               </a:rPr>
-              <a:t>dominicanos en PA (INDEX)</a:t>
+              <a:t>dominicanos en PA: el mayor crecimiento de EE. UU.</a:t>
             </a:r>
             <a:endParaRPr lang="en-US" sz="3400" dirty="0"/>
           </a:p>
@@ -15872,7 +15872,7 @@
         <p:spPr>
           <a:xfrm>
             <a:off x="4672462" y="2075688"/>
-            <a:ext cx="1463040" cy="237744"/>
+            <a:ext cx="2377440" cy="237744"/>
           </a:xfrm>
           <a:prstGeom prst="rect">
             <a:avLst/>
@@ -15968,8 +15968,8 @@
         </p:nvSpPr>
         <p:spPr>
           <a:xfrm>
-            <a:off x="1273005" y="4599432"/>
-            <a:ext cx="1463040" cy="237744"/>
+            <a:off x="358605" y="4599432"/>
+            <a:ext cx="2377440" cy="237744"/>
           </a:xfrm>
           <a:prstGeom prst="rect">
             <a:avLst/>
@@ -15990,7 +15990,7 @@
                   <a:schemeClr val="tx2"/>
                 </a:solidFill>
               </a:rPr>
-              <a:t>Centro-Sur</a:t>
+              <a:t>Harrisburg, Lancaster, York y Lebanon</a:t>
             </a:r>
             <a:endParaRPr lang="en-US" sz="1100" dirty="0"/>
           </a:p>
@@ -16235,7 +16235,7 @@
         <p:spPr>
           <a:xfrm>
             <a:off x="8275320" y="1847088"/>
-            <a:ext cx="2468880" cy="493776"/>
+            <a:ext cx="2743200" cy="493776"/>
           </a:xfrm>
           <a:prstGeom prst="rect">
             <a:avLst/>
@@ -16251,14 +16251,14 @@
               <a:buNone/>
             </a:pPr>
             <a:r>
-              <a:rPr lang="en-US" sz="1300" b="1" dirty="0">
+              <a:rPr lang="en-US" sz="1200" b="1" dirty="0">
                 <a:solidFill>
                   <a:schemeClr val="tx2"/>
                 </a:solidFill>
               </a:rPr>
               <a:t>Philadelphia Noreste</a:t>
             </a:r>
-            <a:endParaRPr lang="en-US" sz="1300" dirty="0"/>
+            <a:endParaRPr lang="en-US" sz="1200" dirty="0"/>
           </a:p>
           <a:p>
             <a:pPr indent="0" marL="0">
@@ -16272,7 +16272,7 @@
               </a:rPr>
               <a:t>9,649 electores · 20.3 %</a:t>
             </a:r>
-            <a:endParaRPr lang="en-US" sz="1300" dirty="0"/>
+            <a:endParaRPr lang="en-US" sz="1200" dirty="0"/>
           </a:p>
         </p:txBody>
       </p:sp>
@@ -16382,7 +16382,7 @@
         <p:spPr>
           <a:xfrm>
             <a:off x="8275320" y="2354580"/>
-            <a:ext cx="2468880" cy="493776"/>
+            <a:ext cx="2743200" cy="493776"/>
           </a:xfrm>
           <a:prstGeom prst="rect">
             <a:avLst/>
@@ -16398,14 +16398,14 @@
               <a:buNone/>
             </a:pPr>
             <a:r>
-              <a:rPr lang="en-US" sz="1300" b="1" dirty="0">
+              <a:rPr lang="en-US" sz="1200" b="1" dirty="0">
                 <a:solidFill>
                   <a:schemeClr val="tx2"/>
                 </a:solidFill>
               </a:rPr>
               <a:t>Philadelphia Kensington</a:t>
             </a:r>
-            <a:endParaRPr lang="en-US" sz="1300" dirty="0"/>
+            <a:endParaRPr lang="en-US" sz="1200" dirty="0"/>
           </a:p>
           <a:p>
             <a:pPr indent="0" marL="0">
@@ -16419,7 +16419,7 @@
               </a:rPr>
               <a:t>6,588 electores · 13.9 %</a:t>
             </a:r>
-            <a:endParaRPr lang="en-US" sz="1300" dirty="0"/>
+            <a:endParaRPr lang="en-US" sz="1200" dirty="0"/>
           </a:p>
         </p:txBody>
       </p:sp>
@@ -16529,7 +16529,7 @@
         <p:spPr>
           <a:xfrm>
             <a:off x="8275320" y="2862072"/>
-            <a:ext cx="2468880" cy="493776"/>
+            <a:ext cx="2743200" cy="493776"/>
           </a:xfrm>
           <a:prstGeom prst="rect">
             <a:avLst/>
@@ -16545,14 +16545,14 @@
               <a:buNone/>
             </a:pPr>
             <a:r>
-              <a:rPr lang="en-US" sz="1300" b="1" dirty="0">
+              <a:rPr lang="en-US" sz="1200" b="1" dirty="0">
                 <a:solidFill>
                   <a:schemeClr val="tx2"/>
                 </a:solidFill>
               </a:rPr>
               <a:t>Berks (Reading)</a:t>
             </a:r>
-            <a:endParaRPr lang="en-US" sz="1300" dirty="0"/>
+            <a:endParaRPr lang="en-US" sz="1200" dirty="0"/>
           </a:p>
           <a:p>
             <a:pPr indent="0" marL="0">
@@ -16566,7 +16566,7 @@
               </a:rPr>
               <a:t>8,368 electores · 17.6 %</a:t>
             </a:r>
-            <a:endParaRPr lang="en-US" sz="1300" dirty="0"/>
+            <a:endParaRPr lang="en-US" sz="1200" dirty="0"/>
           </a:p>
         </p:txBody>
       </p:sp>
@@ -16676,7 +16676,7 @@
         <p:spPr>
           <a:xfrm>
             <a:off x="8275320" y="3369564"/>
-            <a:ext cx="2468880" cy="493776"/>
+            <a:ext cx="2743200" cy="493776"/>
           </a:xfrm>
           <a:prstGeom prst="rect">
             <a:avLst/>
@@ -16692,14 +16692,14 @@
               <a:buNone/>
             </a:pPr>
             <a:r>
-              <a:rPr lang="en-US" sz="1300" b="1" dirty="0">
+              <a:rPr lang="en-US" sz="1200" b="1" dirty="0">
                 <a:solidFill>
                   <a:schemeClr val="tx2"/>
                 </a:solidFill>
               </a:rPr>
               <a:t>Lehigh Valley (Allentown)</a:t>
             </a:r>
-            <a:endParaRPr lang="en-US" sz="1300" dirty="0"/>
+            <a:endParaRPr lang="en-US" sz="1200" dirty="0"/>
           </a:p>
           <a:p>
             <a:pPr indent="0" marL="0">
@@ -16713,7 +16713,7 @@
               </a:rPr>
               <a:t>8,183 electores · 17.2 %</a:t>
             </a:r>
-            <a:endParaRPr lang="en-US" sz="1300" dirty="0"/>
+            <a:endParaRPr lang="en-US" sz="1200" dirty="0"/>
           </a:p>
         </p:txBody>
       </p:sp>
@@ -16823,7 +16823,7 @@
         <p:spPr>
           <a:xfrm>
             <a:off x="8275320" y="3877056"/>
-            <a:ext cx="2468880" cy="493776"/>
+            <a:ext cx="2743200" cy="493776"/>
           </a:xfrm>
           <a:prstGeom prst="rect">
             <a:avLst/>
@@ -16839,14 +16839,14 @@
               <a:buNone/>
             </a:pPr>
             <a:r>
-              <a:rPr lang="en-US" sz="1300" b="1" dirty="0">
+              <a:rPr lang="en-US" sz="1200" b="1" dirty="0">
                 <a:solidFill>
                   <a:schemeClr val="tx2"/>
                 </a:solidFill>
               </a:rPr>
               <a:t>Hazleton</a:t>
             </a:r>
-            <a:endParaRPr lang="en-US" sz="1300" dirty="0"/>
+            <a:endParaRPr lang="en-US" sz="1200" dirty="0"/>
           </a:p>
           <a:p>
             <a:pPr indent="0" marL="0">
@@ -16860,7 +16860,7 @@
               </a:rPr>
               <a:t>6,520 electores · 13.7 %</a:t>
             </a:r>
-            <a:endParaRPr lang="en-US" sz="1300" dirty="0"/>
+            <a:endParaRPr lang="en-US" sz="1200" dirty="0"/>
           </a:p>
         </p:txBody>
       </p:sp>
@@ -16970,7 +16970,7 @@
         <p:spPr>
           <a:xfrm>
             <a:off x="8275320" y="4384548"/>
-            <a:ext cx="2468880" cy="493776"/>
+            <a:ext cx="2743200" cy="493776"/>
           </a:xfrm>
           <a:prstGeom prst="rect">
             <a:avLst/>
@@ -16986,14 +16986,14 @@
               <a:buNone/>
             </a:pPr>
             <a:r>
-              <a:rPr lang="en-US" sz="1300" b="1" dirty="0">
+              <a:rPr lang="en-US" sz="1200" b="1" dirty="0">
                 <a:solidFill>
                   <a:schemeClr val="tx2"/>
                 </a:solidFill>
               </a:rPr>
               <a:t>Wilkes-Barre y Scranton</a:t>
             </a:r>
-            <a:endParaRPr lang="en-US" sz="1300" dirty="0"/>
+            <a:endParaRPr lang="en-US" sz="1200" dirty="0"/>
           </a:p>
           <a:p>
             <a:pPr indent="0" marL="0">
@@ -17007,7 +17007,7 @@
               </a:rPr>
               <a:t>1,767 electores · 3.7 %</a:t>
             </a:r>
-            <a:endParaRPr lang="en-US" sz="1300" dirty="0"/>
+            <a:endParaRPr lang="en-US" sz="1200" dirty="0"/>
           </a:p>
         </p:txBody>
       </p:sp>
@@ -17117,7 +17117,7 @@
         <p:spPr>
           <a:xfrm>
             <a:off x="8275320" y="4892040"/>
-            <a:ext cx="2468880" cy="493776"/>
+            <a:ext cx="2743200" cy="493776"/>
           </a:xfrm>
           <a:prstGeom prst="rect">
             <a:avLst/>
@@ -17133,14 +17133,14 @@
               <a:buNone/>
             </a:pPr>
             <a:r>
-              <a:rPr lang="en-US" sz="1300" b="1" dirty="0">
+              <a:rPr lang="en-US" sz="1200" b="1" dirty="0">
                 <a:solidFill>
                   <a:schemeClr val="tx2"/>
                 </a:solidFill>
               </a:rPr>
-              <a:t>Centro-Sur</a:t>
-            </a:r>
-            <a:endParaRPr lang="en-US" sz="1300" dirty="0"/>
+              <a:t>Harrisburg, Lancaster, York y Lebanon</a:t>
+            </a:r>
+            <a:endParaRPr lang="en-US" sz="1200" dirty="0"/>
           </a:p>
           <a:p>
             <a:pPr indent="0" marL="0">
@@ -17154,7 +17154,7 @@
               </a:rPr>
               <a:t>5,450 electores · 11.5 %</a:t>
             </a:r>
-            <a:endParaRPr lang="en-US" sz="1300" dirty="0"/>
+            <a:endParaRPr lang="en-US" sz="1200" dirty="0"/>
           </a:p>
         </p:txBody>
       </p:sp>
@@ -17264,7 +17264,7 @@
         <p:spPr>
           <a:xfrm>
             <a:off x="8275320" y="5399532"/>
-            <a:ext cx="2468880" cy="493776"/>
+            <a:ext cx="2743200" cy="493776"/>
           </a:xfrm>
           <a:prstGeom prst="rect">
             <a:avLst/>
@@ -17280,14 +17280,14 @@
               <a:buNone/>
             </a:pPr>
             <a:r>
-              <a:rPr lang="en-US" sz="1300" b="1" dirty="0">
+              <a:rPr lang="en-US" sz="1200" b="1" dirty="0">
                 <a:solidFill>
                   <a:schemeClr val="tx2"/>
                 </a:solidFill>
               </a:rPr>
               <a:t>Delaware (Wilmington)</a:t>
             </a:r>
-            <a:endParaRPr lang="en-US" sz="1300" dirty="0"/>
+            <a:endParaRPr lang="en-US" sz="1200" dirty="0"/>
           </a:p>
           <a:p>
             <a:pPr indent="0" marL="0">
@@ -17301,7 +17301,7 @@
               </a:rPr>
               <a:t>1,004 electores · 2.1 %</a:t>
             </a:r>
-            <a:endParaRPr lang="en-US" sz="1300" dirty="0"/>
+            <a:endParaRPr lang="en-US" sz="1200" dirty="0"/>
           </a:p>
         </p:txBody>
       </p:sp>
@@ -23672,7 +23672,7 @@
                             <a:schemeClr val="tx1"/>
                           </a:solidFill>
                         </a:rPr>
-                        <a:t>Centro-Sur (Harrisburg, Lancaster, York, Lebanon)</a:t>
+                        <a:t>Harrisburg, Lancaster, York y Lebanon</a:t>
                       </a:r>
                       <a:endParaRPr lang="en-US" sz="1300" dirty="0"/>
                     </a:p>

</xml_diff>

<commit_message>
Mapa: cada ciudad en su ubicación real y etiquetas legibles
Co-Authored-By: Claude Opus 5.5 <noreply@anthropic.com>
Claude-Session: https://claude.ai/code/session_01RrEJtrwRidXxzgveZEVQjf
</commit_message>
<xml_diff>
--- a/presentaciones/Plan_Estrategico_Pennsylvania_2028.pptx
+++ b/presentaciones/Plan_Estrategico_Pennsylvania_2028.pptx
@@ -120,7 +120,7 @@
   <p:extLst>
     <p:ext uri="{521415D9-36F7-43E2-AB2F-B90AF26B5E84}">
       <p14:sectionLst xmlns:p14="http://schemas.microsoft.com/office/powerpoint/2010/main">
-        <p14:section name="Diagnóstico" id="{20c2cb34-6b7a-e69e-1a79-906b779d0ac3}">
+        <p14:section name="Diagnóstico" id="{0b4b796e-ae87-46f0-a46d-9e76c0b08eef}">
           <p14:sldIdLst>
             <p14:sldId id="256"/>
             <p14:sldId id="257"/>
@@ -129,19 +129,19 @@
             <p14:sldId id="260"/>
           </p14:sldIdLst>
         </p14:section>
-        <p14:section name="Desafíos" id="{767d5d3c-18b3-524d-b4a9-4227ba16a0a3}">
+        <p14:section name="Desafíos" id="{d38a52c3-d018-052e-9570-1be76e49cd7d}">
           <p14:sldIdLst>
             <p14:sldId id="261"/>
             <p14:sldId id="262"/>
           </p14:sldIdLst>
         </p14:section>
-        <p14:section name="Escenarios y meta" id="{ce49d770-b378-517a-e302-4b1af7597e28}">
+        <p14:section name="Escenarios y meta" id="{7b02b31e-abf8-4370-1bdf-d4ca2eea7944}">
           <p14:sldIdLst>
             <p14:sldId id="263"/>
             <p14:sldId id="264"/>
           </p14:sldIdLst>
         </p14:section>
-        <p14:section name="Plan y recomendación" id="{6d32070f-6284-0b6f-949a-018606f26ad3}">
+        <p14:section name="Plan y recomendación" id="{6719efa2-1ef9-9b5a-9c21-fadcf89cf738}">
           <p14:sldIdLst>
             <p14:sldId id="265"/>
             <p14:sldId id="266"/>
@@ -149,7 +149,7 @@
             <p14:sldId id="268"/>
           </p14:sldIdLst>
         </p14:section>
-        <p14:section name="Anexo" id="{4e0de1db-156d-b02f-ee07-9808f64ccaaa}">
+        <p14:section name="Anexo" id="{aacc1b60-44ab-e55c-be56-ae7bdf5ffb72}">
           <p14:sldIdLst>
             <p14:sldId id="269"/>
           </p14:sldIdLst>
@@ -15319,7 +15319,7 @@
       </p:pic>
       <p:sp>
         <p:nvSpPr>
-          <p:cNvPr id="4" name="Zona 1"/>
+          <p:cNvPr id="4" name="Zona 1 Phila. Noreste"/>
           <p:cNvSpPr/>
           <p:nvPr/>
         </p:nvSpPr>
@@ -15367,27 +15367,54 @@
               <a:buNone/>
             </a:pPr>
             <a:r>
-              <a:rPr lang="en-US" sz="1300" b="1" dirty="0">
+              <a:rPr lang="en-US" sz="1200" b="1" dirty="0">
                 <a:solidFill>
                   <a:schemeClr val="bg1"/>
                 </a:solidFill>
               </a:rPr>
               <a:t>1</a:t>
             </a:r>
-            <a:endParaRPr lang="en-US" sz="1300" dirty="0"/>
+            <a:endParaRPr lang="en-US" sz="1200" dirty="0"/>
           </a:p>
         </p:txBody>
       </p:sp>
       <p:sp>
         <p:nvSpPr>
-          <p:cNvPr id="6" name="Text 3"/>
+          <p:cNvPr id="6" name="Etiqueta Phila. Noreste"/>
+          <p:cNvSpPr/>
+          <p:nvPr/>
+        </p:nvSpPr>
+        <p:spPr>
+          <a:xfrm>
+            <a:off x="6044184" y="4722876"/>
+            <a:ext cx="1271016" cy="246888"/>
+          </a:xfrm>
+          <a:prstGeom prst="roundRect">
+            <a:avLst>
+              <a:gd name="adj" fmla="val 22222"/>
+            </a:avLst>
+          </a:prstGeom>
+          <a:solidFill>
+            <a:schemeClr val="bg1"/>
+          </a:solidFill>
+          <a:ln w="9525">
+            <a:solidFill>
+              <a:schemeClr val="tx2"/>
+            </a:solidFill>
+            <a:prstDash val="solid"/>
+          </a:ln>
+        </p:spPr>
+      </p:sp>
+      <p:sp>
+        <p:nvSpPr>
+          <p:cNvPr id="7" name="Text 4"/>
           <p:cNvSpPr txBox="1"/>
           <p:nvPr/>
         </p:nvSpPr>
         <p:spPr>
           <a:xfrm>
-            <a:off x="6053328" y="4727448"/>
-            <a:ext cx="1463040" cy="237744"/>
+            <a:off x="6044184" y="4722876"/>
+            <a:ext cx="1271016" cy="246888"/>
           </a:xfrm>
           <a:prstGeom prst="rect">
             <a:avLst/>
@@ -15399,7 +15426,7 @@
           <a:bodyPr wrap="square" lIns="0" tIns="0" rIns="0" bIns="0" rtlCol="0" anchor="ctr"/>
           <a:lstStyle/>
           <a:p>
-            <a:pPr algn="l" indent="0" marL="0">
+            <a:pPr algn="ctr" indent="0" marL="0">
               <a:buNone/>
             </a:pPr>
             <a:r>
@@ -15416,14 +15443,14 @@
       </p:sp>
       <p:sp>
         <p:nvSpPr>
-          <p:cNvPr id="7" name="Zona 2"/>
+          <p:cNvPr id="8" name="Zona 2 Phila. Kensington"/>
           <p:cNvSpPr/>
           <p:nvPr/>
         </p:nvSpPr>
         <p:spPr>
           <a:xfrm>
-            <a:off x="4870531" y="5025979"/>
-            <a:ext cx="591657" cy="591657"/>
+            <a:off x="4868943" y="5024391"/>
+            <a:ext cx="594834" cy="594834"/>
           </a:xfrm>
           <a:prstGeom prst="ellipse">
             <a:avLst/>
@@ -15441,14 +15468,14 @@
       </p:sp>
       <p:sp>
         <p:nvSpPr>
-          <p:cNvPr id="8" name="Text 5"/>
+          <p:cNvPr id="9" name="Text 6"/>
           <p:cNvSpPr txBox="1"/>
           <p:nvPr/>
         </p:nvSpPr>
         <p:spPr>
           <a:xfrm>
-            <a:off x="4870531" y="5025979"/>
-            <a:ext cx="591657" cy="591657"/>
+            <a:off x="4868943" y="5024391"/>
+            <a:ext cx="594834" cy="594834"/>
           </a:xfrm>
           <a:prstGeom prst="rect">
             <a:avLst/>
@@ -15464,27 +15491,54 @@
               <a:buNone/>
             </a:pPr>
             <a:r>
-              <a:rPr lang="en-US" sz="1300" b="1" dirty="0">
+              <a:rPr lang="en-US" sz="1200" b="1" dirty="0">
                 <a:solidFill>
                   <a:schemeClr val="bg1"/>
                 </a:solidFill>
               </a:rPr>
               <a:t>2</a:t>
             </a:r>
-            <a:endParaRPr lang="en-US" sz="1300" dirty="0"/>
+            <a:endParaRPr lang="en-US" sz="1200" dirty="0"/>
           </a:p>
         </p:txBody>
       </p:sp>
       <p:sp>
         <p:nvSpPr>
-          <p:cNvPr id="9" name="Text 6"/>
+          <p:cNvPr id="10" name="Etiqueta Phila. Kensington"/>
+          <p:cNvSpPr/>
+          <p:nvPr/>
+        </p:nvSpPr>
+        <p:spPr>
+          <a:xfrm>
+            <a:off x="5509497" y="5198364"/>
+            <a:ext cx="1504188" cy="246888"/>
+          </a:xfrm>
+          <a:prstGeom prst="roundRect">
+            <a:avLst>
+              <a:gd name="adj" fmla="val 22222"/>
+            </a:avLst>
+          </a:prstGeom>
+          <a:solidFill>
+            <a:schemeClr val="bg1"/>
+          </a:solidFill>
+          <a:ln w="9525">
+            <a:solidFill>
+              <a:schemeClr val="tx2"/>
+            </a:solidFill>
+            <a:prstDash val="solid"/>
+          </a:ln>
+        </p:spPr>
+      </p:sp>
+      <p:sp>
+        <p:nvSpPr>
+          <p:cNvPr id="11" name="Text 8"/>
           <p:cNvSpPr txBox="1"/>
           <p:nvPr/>
         </p:nvSpPr>
         <p:spPr>
           <a:xfrm>
-            <a:off x="5517053" y="5202936"/>
-            <a:ext cx="1463040" cy="237744"/>
+            <a:off x="5509497" y="5198364"/>
+            <a:ext cx="1504188" cy="246888"/>
           </a:xfrm>
           <a:prstGeom prst="rect">
             <a:avLst/>
@@ -15496,7 +15550,7 @@
           <a:bodyPr wrap="square" lIns="0" tIns="0" rIns="0" bIns="0" rtlCol="0" anchor="ctr"/>
           <a:lstStyle/>
           <a:p>
-            <a:pPr algn="l" indent="0" marL="0">
+            <a:pPr algn="ctr" indent="0" marL="0">
               <a:buNone/>
             </a:pPr>
             <a:r>
@@ -15513,14 +15567,14 @@
       </p:sp>
       <p:sp>
         <p:nvSpPr>
-          <p:cNvPr id="10" name="Zona 3"/>
+          <p:cNvPr id="12" name="Zona 3 Reading"/>
           <p:cNvSpPr/>
           <p:nvPr/>
         </p:nvSpPr>
         <p:spPr>
           <a:xfrm>
-            <a:off x="3826248" y="4009128"/>
-            <a:ext cx="631967" cy="631967"/>
+            <a:off x="3825620" y="4008500"/>
+            <a:ext cx="633225" cy="633225"/>
           </a:xfrm>
           <a:prstGeom prst="ellipse">
             <a:avLst/>
@@ -15538,14 +15592,14 @@
       </p:sp>
       <p:sp>
         <p:nvSpPr>
-          <p:cNvPr id="11" name="Text 8"/>
+          <p:cNvPr id="13" name="Text 10"/>
           <p:cNvSpPr txBox="1"/>
           <p:nvPr/>
         </p:nvSpPr>
         <p:spPr>
           <a:xfrm>
-            <a:off x="3826248" y="4009128"/>
-            <a:ext cx="631967" cy="631967"/>
+            <a:off x="3825620" y="4008500"/>
+            <a:ext cx="633225" cy="633225"/>
           </a:xfrm>
           <a:prstGeom prst="rect">
             <a:avLst/>
@@ -15561,27 +15615,54 @@
               <a:buNone/>
             </a:pPr>
             <a:r>
-              <a:rPr lang="en-US" sz="1300" b="1" dirty="0">
+              <a:rPr lang="en-US" sz="1200" b="1" dirty="0">
                 <a:solidFill>
                   <a:schemeClr val="bg1"/>
                 </a:solidFill>
               </a:rPr>
               <a:t>3</a:t>
             </a:r>
-            <a:endParaRPr lang="en-US" sz="1300" dirty="0"/>
+            <a:endParaRPr lang="en-US" sz="1200" dirty="0"/>
           </a:p>
         </p:txBody>
       </p:sp>
       <p:sp>
         <p:nvSpPr>
-          <p:cNvPr id="12" name="Text 9"/>
+          <p:cNvPr id="14" name="Etiqueta Reading"/>
+          <p:cNvSpPr/>
+          <p:nvPr/>
+        </p:nvSpPr>
+        <p:spPr>
+          <a:xfrm>
+            <a:off x="4504564" y="4201668"/>
+            <a:ext cx="726948" cy="246888"/>
+          </a:xfrm>
+          <a:prstGeom prst="roundRect">
+            <a:avLst>
+              <a:gd name="adj" fmla="val 22222"/>
+            </a:avLst>
+          </a:prstGeom>
+          <a:solidFill>
+            <a:schemeClr val="bg1"/>
+          </a:solidFill>
+          <a:ln w="9525">
+            <a:solidFill>
+              <a:schemeClr val="tx2"/>
+            </a:solidFill>
+            <a:prstDash val="solid"/>
+          </a:ln>
+        </p:spPr>
+      </p:sp>
+      <p:sp>
+        <p:nvSpPr>
+          <p:cNvPr id="15" name="Text 12"/>
           <p:cNvSpPr txBox="1"/>
           <p:nvPr/>
         </p:nvSpPr>
         <p:spPr>
           <a:xfrm>
-            <a:off x="4513080" y="4206240"/>
-            <a:ext cx="1463040" cy="237744"/>
+            <a:off x="4504564" y="4201668"/>
+            <a:ext cx="726948" cy="246888"/>
           </a:xfrm>
           <a:prstGeom prst="rect">
             <a:avLst/>
@@ -15593,7 +15674,7 @@
           <a:bodyPr wrap="square" lIns="0" tIns="0" rIns="0" bIns="0" rtlCol="0" anchor="ctr"/>
           <a:lstStyle/>
           <a:p>
-            <a:pPr algn="l" indent="0" marL="0">
+            <a:pPr algn="ctr" indent="0" marL="0">
               <a:buNone/>
             </a:pPr>
             <a:r>
@@ -15610,14 +15691,14 @@
       </p:sp>
       <p:sp>
         <p:nvSpPr>
-          <p:cNvPr id="13" name="Zona 4"/>
+          <p:cNvPr id="16" name="Zona 4 Allentown"/>
           <p:cNvSpPr/>
           <p:nvPr/>
         </p:nvSpPr>
         <p:spPr>
           <a:xfrm>
-            <a:off x="4568900" y="3444188"/>
-            <a:ext cx="627992" cy="627992"/>
+            <a:off x="4568177" y="3443465"/>
+            <a:ext cx="629438" cy="629438"/>
           </a:xfrm>
           <a:prstGeom prst="ellipse">
             <a:avLst/>
@@ -15635,14 +15716,14 @@
       </p:sp>
       <p:sp>
         <p:nvSpPr>
-          <p:cNvPr id="14" name="Text 11"/>
+          <p:cNvPr id="17" name="Text 14"/>
           <p:cNvSpPr txBox="1"/>
           <p:nvPr/>
         </p:nvSpPr>
         <p:spPr>
           <a:xfrm>
-            <a:off x="4568900" y="3444188"/>
-            <a:ext cx="627992" cy="627992"/>
+            <a:off x="4568177" y="3443465"/>
+            <a:ext cx="629438" cy="629438"/>
           </a:xfrm>
           <a:prstGeom prst="rect">
             <a:avLst/>
@@ -15658,27 +15739,54 @@
               <a:buNone/>
             </a:pPr>
             <a:r>
-              <a:rPr lang="en-US" sz="1300" b="1" dirty="0">
+              <a:rPr lang="en-US" sz="1200" b="1" dirty="0">
                 <a:solidFill>
                   <a:schemeClr val="bg1"/>
                 </a:solidFill>
               </a:rPr>
               <a:t>4</a:t>
             </a:r>
-            <a:endParaRPr lang="en-US" sz="1300" dirty="0"/>
+            <a:endParaRPr lang="en-US" sz="1200" dirty="0"/>
           </a:p>
         </p:txBody>
       </p:sp>
       <p:sp>
         <p:nvSpPr>
-          <p:cNvPr id="15" name="Text 12"/>
+          <p:cNvPr id="18" name="Etiqueta Allentown"/>
+          <p:cNvSpPr/>
+          <p:nvPr/>
+        </p:nvSpPr>
+        <p:spPr>
+          <a:xfrm>
+            <a:off x="4441698" y="3150857"/>
+            <a:ext cx="882396" cy="246888"/>
+          </a:xfrm>
+          <a:prstGeom prst="roundRect">
+            <a:avLst>
+              <a:gd name="adj" fmla="val 22222"/>
+            </a:avLst>
+          </a:prstGeom>
+          <a:solidFill>
+            <a:schemeClr val="bg1"/>
+          </a:solidFill>
+          <a:ln w="9525">
+            <a:solidFill>
+              <a:schemeClr val="tx2"/>
+            </a:solidFill>
+            <a:prstDash val="solid"/>
+          </a:ln>
+        </p:spPr>
+      </p:sp>
+      <p:sp>
+        <p:nvSpPr>
+          <p:cNvPr id="19" name="Text 16"/>
           <p:cNvSpPr txBox="1"/>
           <p:nvPr/>
         </p:nvSpPr>
         <p:spPr>
           <a:xfrm>
-            <a:off x="5251756" y="3639312"/>
-            <a:ext cx="1463040" cy="237744"/>
+            <a:off x="4441698" y="3150857"/>
+            <a:ext cx="882396" cy="246888"/>
           </a:xfrm>
           <a:prstGeom prst="rect">
             <a:avLst/>
@@ -15690,7 +15798,7 @@
           <a:bodyPr wrap="square" lIns="0" tIns="0" rIns="0" bIns="0" rtlCol="0" anchor="ctr"/>
           <a:lstStyle/>
           <a:p>
-            <a:pPr algn="l" indent="0" marL="0">
+            <a:pPr algn="ctr" indent="0" marL="0">
               <a:buNone/>
             </a:pPr>
             <a:r>
@@ -15707,14 +15815,14 @@
       </p:sp>
       <p:sp>
         <p:nvSpPr>
-          <p:cNvPr id="16" name="Zona 5"/>
+          <p:cNvPr id="20" name="Zona 5 Hazleton"/>
           <p:cNvSpPr/>
           <p:nvPr/>
         </p:nvSpPr>
         <p:spPr>
           <a:xfrm>
-            <a:off x="3774072" y="2695080"/>
-            <a:ext cx="590015" cy="590015"/>
+            <a:off x="3772445" y="2693453"/>
+            <a:ext cx="593270" cy="593270"/>
           </a:xfrm>
           <a:prstGeom prst="ellipse">
             <a:avLst/>
@@ -15732,14 +15840,14 @@
       </p:sp>
       <p:sp>
         <p:nvSpPr>
-          <p:cNvPr id="17" name="Text 14"/>
+          <p:cNvPr id="21" name="Text 18"/>
           <p:cNvSpPr txBox="1"/>
           <p:nvPr/>
         </p:nvSpPr>
         <p:spPr>
           <a:xfrm>
-            <a:off x="3774072" y="2695080"/>
-            <a:ext cx="590015" cy="590015"/>
+            <a:off x="3772445" y="2693453"/>
+            <a:ext cx="593270" cy="593270"/>
           </a:xfrm>
           <a:prstGeom prst="rect">
             <a:avLst/>
@@ -15755,27 +15863,54 @@
               <a:buNone/>
             </a:pPr>
             <a:r>
-              <a:rPr lang="en-US" sz="1300" b="1" dirty="0">
+              <a:rPr lang="en-US" sz="1200" b="1" dirty="0">
                 <a:solidFill>
                   <a:schemeClr val="bg1"/>
                 </a:solidFill>
               </a:rPr>
               <a:t>5</a:t>
             </a:r>
-            <a:endParaRPr lang="en-US" sz="1300" dirty="0"/>
+            <a:endParaRPr lang="en-US" sz="1200" dirty="0"/>
           </a:p>
         </p:txBody>
       </p:sp>
       <p:sp>
         <p:nvSpPr>
-          <p:cNvPr id="18" name="Text 15"/>
+          <p:cNvPr id="22" name="Etiqueta Hazleton"/>
+          <p:cNvSpPr/>
+          <p:nvPr/>
+        </p:nvSpPr>
+        <p:spPr>
+          <a:xfrm>
+            <a:off x="2922053" y="2866644"/>
+            <a:ext cx="804672" cy="246888"/>
+          </a:xfrm>
+          <a:prstGeom prst="roundRect">
+            <a:avLst>
+              <a:gd name="adj" fmla="val 22222"/>
+            </a:avLst>
+          </a:prstGeom>
+          <a:solidFill>
+            <a:schemeClr val="bg1"/>
+          </a:solidFill>
+          <a:ln w="9525">
+            <a:solidFill>
+              <a:schemeClr val="tx2"/>
+            </a:solidFill>
+            <a:prstDash val="solid"/>
+          </a:ln>
+        </p:spPr>
+      </p:sp>
+      <p:sp>
+        <p:nvSpPr>
+          <p:cNvPr id="23" name="Text 20"/>
           <p:cNvSpPr txBox="1"/>
           <p:nvPr/>
         </p:nvSpPr>
         <p:spPr>
           <a:xfrm>
-            <a:off x="4418952" y="2871216"/>
-            <a:ext cx="1463040" cy="237744"/>
+            <a:off x="2922053" y="2866644"/>
+            <a:ext cx="804672" cy="246888"/>
           </a:xfrm>
           <a:prstGeom prst="rect">
             <a:avLst/>
@@ -15787,7 +15922,7 @@
           <a:bodyPr wrap="square" lIns="0" tIns="0" rIns="0" bIns="0" rtlCol="0" anchor="ctr"/>
           <a:lstStyle/>
           <a:p>
-            <a:pPr algn="l" indent="0" marL="0">
+            <a:pPr algn="ctr" indent="0" marL="0">
               <a:buNone/>
             </a:pPr>
             <a:r>
@@ -15804,14 +15939,14 @@
       </p:sp>
       <p:sp>
         <p:nvSpPr>
-          <p:cNvPr id="19" name="Zona 6"/>
+          <p:cNvPr id="24" name="Zona 6 Wilkes-Barre"/>
           <p:cNvSpPr/>
           <p:nvPr/>
         </p:nvSpPr>
         <p:spPr>
           <a:xfrm>
-            <a:off x="4178930" y="1975226"/>
-            <a:ext cx="438667" cy="438667"/>
+            <a:off x="4001464" y="2154376"/>
+            <a:ext cx="427839" cy="427839"/>
           </a:xfrm>
           <a:prstGeom prst="ellipse">
             <a:avLst/>
@@ -15829,14 +15964,14 @@
       </p:sp>
       <p:sp>
         <p:nvSpPr>
-          <p:cNvPr id="20" name="Text 17"/>
+          <p:cNvPr id="25" name="Text 22"/>
           <p:cNvSpPr txBox="1"/>
           <p:nvPr/>
         </p:nvSpPr>
         <p:spPr>
           <a:xfrm>
-            <a:off x="4178930" y="1975226"/>
-            <a:ext cx="438667" cy="438667"/>
+            <a:off x="4001464" y="2154376"/>
+            <a:ext cx="427839" cy="427839"/>
           </a:xfrm>
           <a:prstGeom prst="rect">
             <a:avLst/>
@@ -15852,27 +15987,54 @@
               <a:buNone/>
             </a:pPr>
             <a:r>
-              <a:rPr lang="en-US" sz="1300" b="1" dirty="0">
+              <a:rPr lang="en-US" sz="1200" b="1" dirty="0">
                 <a:solidFill>
                   <a:schemeClr val="bg1"/>
                 </a:solidFill>
               </a:rPr>
               <a:t>6</a:t>
             </a:r>
-            <a:endParaRPr lang="en-US" sz="1300" dirty="0"/>
+            <a:endParaRPr lang="en-US" sz="1200" dirty="0"/>
           </a:p>
         </p:txBody>
       </p:sp>
       <p:sp>
         <p:nvSpPr>
-          <p:cNvPr id="21" name="Text 18"/>
+          <p:cNvPr id="26" name="Etiqueta Wilkes-Barre"/>
+          <p:cNvSpPr/>
+          <p:nvPr/>
+        </p:nvSpPr>
+        <p:spPr>
+          <a:xfrm>
+            <a:off x="2840176" y="2244852"/>
+            <a:ext cx="1115568" cy="246888"/>
+          </a:xfrm>
+          <a:prstGeom prst="roundRect">
+            <a:avLst>
+              <a:gd name="adj" fmla="val 22222"/>
+            </a:avLst>
+          </a:prstGeom>
+          <a:solidFill>
+            <a:schemeClr val="bg1"/>
+          </a:solidFill>
+          <a:ln w="9525">
+            <a:solidFill>
+              <a:schemeClr val="tx2"/>
+            </a:solidFill>
+            <a:prstDash val="solid"/>
+          </a:ln>
+        </p:spPr>
+      </p:sp>
+      <p:sp>
+        <p:nvSpPr>
+          <p:cNvPr id="27" name="Text 24"/>
           <p:cNvSpPr txBox="1"/>
           <p:nvPr/>
         </p:nvSpPr>
         <p:spPr>
           <a:xfrm>
-            <a:off x="4672462" y="2075688"/>
-            <a:ext cx="2377440" cy="237744"/>
+            <a:off x="2840176" y="2244852"/>
+            <a:ext cx="1115568" cy="246888"/>
           </a:xfrm>
           <a:prstGeom prst="rect">
             <a:avLst/>
@@ -15884,7 +16046,7 @@
           <a:bodyPr wrap="square" lIns="0" tIns="0" rIns="0" bIns="0" rtlCol="0" anchor="ctr"/>
           <a:lstStyle/>
           <a:p>
-            <a:pPr algn="l" indent="0" marL="0">
+            <a:pPr algn="ctr" indent="0" marL="0">
               <a:buNone/>
             </a:pPr>
             <a:r>
@@ -15893,7 +16055,7 @@
                   <a:schemeClr val="tx2"/>
                 </a:solidFill>
               </a:rPr>
-              <a:t>Wilkes-Barre / Scranton</a:t>
+              <a:t>Wilkes-Barre</a:t>
             </a:r>
             <a:endParaRPr lang="en-US" sz="1100" dirty="0"/>
           </a:p>
@@ -15901,14 +16063,14 @@
       </p:sp>
       <p:sp>
         <p:nvSpPr>
-          <p:cNvPr id="22" name="Zona 7"/>
+          <p:cNvPr id="28" name="Zona 6 Scranton"/>
           <p:cNvSpPr/>
           <p:nvPr/>
         </p:nvSpPr>
         <p:spPr>
           <a:xfrm>
-            <a:off x="2790909" y="4436829"/>
-            <a:ext cx="562951" cy="562951"/>
+            <a:off x="4386290" y="1825970"/>
+            <a:ext cx="371420" cy="371420"/>
           </a:xfrm>
           <a:prstGeom prst="ellipse">
             <a:avLst/>
@@ -15926,14 +16088,14 @@
       </p:sp>
       <p:sp>
         <p:nvSpPr>
-          <p:cNvPr id="23" name="Text 20"/>
+          <p:cNvPr id="29" name="Text 26"/>
           <p:cNvSpPr txBox="1"/>
           <p:nvPr/>
         </p:nvSpPr>
         <p:spPr>
           <a:xfrm>
-            <a:off x="2790909" y="4436829"/>
-            <a:ext cx="562951" cy="562951"/>
+            <a:off x="4386290" y="1825970"/>
+            <a:ext cx="371420" cy="371420"/>
           </a:xfrm>
           <a:prstGeom prst="rect">
             <a:avLst/>
@@ -15949,27 +16111,54 @@
               <a:buNone/>
             </a:pPr>
             <a:r>
-              <a:rPr lang="en-US" sz="1300" b="1" dirty="0">
+              <a:rPr lang="en-US" sz="1200" b="1" dirty="0">
                 <a:solidFill>
                   <a:schemeClr val="bg1"/>
                 </a:solidFill>
               </a:rPr>
-              <a:t>7</a:t>
-            </a:r>
-            <a:endParaRPr lang="en-US" sz="1300" dirty="0"/>
+              <a:t>6</a:t>
+            </a:r>
+            <a:endParaRPr lang="en-US" sz="1200" dirty="0"/>
           </a:p>
         </p:txBody>
       </p:sp>
       <p:sp>
         <p:nvSpPr>
-          <p:cNvPr id="24" name="Text 21"/>
+          <p:cNvPr id="30" name="Etiqueta Scranton"/>
+          <p:cNvSpPr/>
+          <p:nvPr/>
+        </p:nvSpPr>
+        <p:spPr>
+          <a:xfrm>
+            <a:off x="3535898" y="1888236"/>
+            <a:ext cx="804672" cy="246888"/>
+          </a:xfrm>
+          <a:prstGeom prst="roundRect">
+            <a:avLst>
+              <a:gd name="adj" fmla="val 22222"/>
+            </a:avLst>
+          </a:prstGeom>
+          <a:solidFill>
+            <a:schemeClr val="bg1"/>
+          </a:solidFill>
+          <a:ln w="9525">
+            <a:solidFill>
+              <a:schemeClr val="tx2"/>
+            </a:solidFill>
+            <a:prstDash val="solid"/>
+          </a:ln>
+        </p:spPr>
+      </p:sp>
+      <p:sp>
+        <p:nvSpPr>
+          <p:cNvPr id="31" name="Text 28"/>
           <p:cNvSpPr txBox="1"/>
           <p:nvPr/>
         </p:nvSpPr>
         <p:spPr>
           <a:xfrm>
-            <a:off x="358605" y="4599432"/>
-            <a:ext cx="2377440" cy="237744"/>
+            <a:off x="3535898" y="1888236"/>
+            <a:ext cx="804672" cy="246888"/>
           </a:xfrm>
           <a:prstGeom prst="rect">
             <a:avLst/>
@@ -15981,7 +16170,7 @@
           <a:bodyPr wrap="square" lIns="0" tIns="0" rIns="0" bIns="0" rtlCol="0" anchor="ctr"/>
           <a:lstStyle/>
           <a:p>
-            <a:pPr algn="r" indent="0" marL="0">
+            <a:pPr algn="ctr" indent="0" marL="0">
               <a:buNone/>
             </a:pPr>
             <a:r>
@@ -15990,7 +16179,7 @@
                   <a:schemeClr val="tx2"/>
                 </a:solidFill>
               </a:rPr>
-              <a:t>Harrisburg, Lancaster, York y Lebanon</a:t>
+              <a:t>Scranton</a:t>
             </a:r>
             <a:endParaRPr lang="en-US" sz="1100" dirty="0"/>
           </a:p>
@@ -15998,14 +16187,14 @@
       </p:sp>
       <p:sp>
         <p:nvSpPr>
-          <p:cNvPr id="25" name="Zona 8"/>
+          <p:cNvPr id="32" name="Zona 7 Harrisburg"/>
           <p:cNvSpPr/>
           <p:nvPr/>
         </p:nvSpPr>
         <p:spPr>
           <a:xfrm>
-            <a:off x="4574067" y="5397027"/>
-            <a:ext cx="398203" cy="398203"/>
+            <a:off x="2356222" y="4239886"/>
+            <a:ext cx="444772" cy="444772"/>
           </a:xfrm>
           <a:prstGeom prst="ellipse">
             <a:avLst/>
@@ -16023,14 +16212,14 @@
       </p:sp>
       <p:sp>
         <p:nvSpPr>
-          <p:cNvPr id="26" name="Text 23"/>
+          <p:cNvPr id="33" name="Text 30"/>
           <p:cNvSpPr txBox="1"/>
           <p:nvPr/>
         </p:nvSpPr>
         <p:spPr>
           <a:xfrm>
-            <a:off x="4574067" y="5397027"/>
-            <a:ext cx="398203" cy="398203"/>
+            <a:off x="2356222" y="4239886"/>
+            <a:ext cx="444772" cy="444772"/>
           </a:xfrm>
           <a:prstGeom prst="rect">
             <a:avLst/>
@@ -16046,27 +16235,54 @@
               <a:buNone/>
             </a:pPr>
             <a:r>
-              <a:rPr lang="en-US" sz="1300" b="1" dirty="0">
+              <a:rPr lang="en-US" sz="1200" b="1" dirty="0">
                 <a:solidFill>
                   <a:schemeClr val="bg1"/>
                 </a:solidFill>
               </a:rPr>
-              <a:t>8</a:t>
-            </a:r>
-            <a:endParaRPr lang="en-US" sz="1300" dirty="0"/>
+              <a:t>7</a:t>
+            </a:r>
+            <a:endParaRPr lang="en-US" sz="1200" dirty="0"/>
           </a:p>
         </p:txBody>
       </p:sp>
       <p:sp>
         <p:nvSpPr>
-          <p:cNvPr id="27" name="Text 24"/>
+          <p:cNvPr id="34" name="Etiqueta Harrisburg"/>
+          <p:cNvSpPr/>
+          <p:nvPr/>
+        </p:nvSpPr>
+        <p:spPr>
+          <a:xfrm>
+            <a:off x="1350382" y="4338828"/>
+            <a:ext cx="960120" cy="246888"/>
+          </a:xfrm>
+          <a:prstGeom prst="roundRect">
+            <a:avLst>
+              <a:gd name="adj" fmla="val 22222"/>
+            </a:avLst>
+          </a:prstGeom>
+          <a:solidFill>
+            <a:schemeClr val="bg1"/>
+          </a:solidFill>
+          <a:ln w="9525">
+            <a:solidFill>
+              <a:schemeClr val="tx2"/>
+            </a:solidFill>
+            <a:prstDash val="solid"/>
+          </a:ln>
+        </p:spPr>
+      </p:sp>
+      <p:sp>
+        <p:nvSpPr>
+          <p:cNvPr id="35" name="Text 32"/>
           <p:cNvSpPr txBox="1"/>
           <p:nvPr/>
         </p:nvSpPr>
         <p:spPr>
           <a:xfrm>
-            <a:off x="3056163" y="5477256"/>
-            <a:ext cx="1463040" cy="237744"/>
+            <a:off x="1350382" y="4338828"/>
+            <a:ext cx="960120" cy="246888"/>
           </a:xfrm>
           <a:prstGeom prst="rect">
             <a:avLst/>
@@ -16078,7 +16294,7 @@
           <a:bodyPr wrap="square" lIns="0" tIns="0" rIns="0" bIns="0" rtlCol="0" anchor="ctr"/>
           <a:lstStyle/>
           <a:p>
-            <a:pPr algn="r" indent="0" marL="0">
+            <a:pPr algn="ctr" indent="0" marL="0">
               <a:buNone/>
             </a:pPr>
             <a:r>
@@ -16087,7 +16303,7 @@
                   <a:schemeClr val="tx2"/>
                 </a:solidFill>
               </a:rPr>
-              <a:t>Wilmington</a:t>
+              <a:t>Harrisburg</a:t>
             </a:r>
             <a:endParaRPr lang="en-US" sz="1100" dirty="0"/>
           </a:p>
@@ -16095,14 +16311,39 @@
       </p:sp>
       <p:sp>
         <p:nvSpPr>
-          <p:cNvPr id="28" name="Text 25"/>
+          <p:cNvPr id="36" name="Zona 7 Lebanon"/>
+          <p:cNvSpPr/>
+          <p:nvPr/>
+        </p:nvSpPr>
+        <p:spPr>
+          <a:xfrm>
+            <a:off x="3157249" y="4117369"/>
+            <a:ext cx="397199" cy="397199"/>
+          </a:xfrm>
+          <a:prstGeom prst="ellipse">
+            <a:avLst/>
+          </a:prstGeom>
+          <a:solidFill>
+            <a:schemeClr val="accent2"/>
+          </a:solidFill>
+          <a:ln w="19050">
+            <a:solidFill>
+              <a:schemeClr val="bg1"/>
+            </a:solidFill>
+            <a:prstDash val="solid"/>
+          </a:ln>
+        </p:spPr>
+      </p:sp>
+      <p:sp>
+        <p:nvSpPr>
+          <p:cNvPr id="37" name="Text 34"/>
           <p:cNvSpPr txBox="1"/>
           <p:nvPr/>
         </p:nvSpPr>
         <p:spPr>
           <a:xfrm>
-            <a:off x="8275320" y="1554480"/>
-            <a:ext cx="2286000" cy="256032"/>
+            <a:off x="3157249" y="4117369"/>
+            <a:ext cx="397199" cy="397199"/>
           </a:xfrm>
           <a:prstGeom prst="rect">
             <a:avLst/>
@@ -16114,31 +16355,58 @@
           <a:bodyPr wrap="square" lIns="0" tIns="0" rIns="0" bIns="0" rtlCol="0" anchor="ctr"/>
           <a:lstStyle/>
           <a:p>
-            <a:pPr indent="0" marL="0">
+            <a:pPr algn="ctr" indent="0" marL="0">
               <a:buNone/>
             </a:pPr>
             <a:r>
-              <a:rPr lang="en-US" sz="1100" b="1" dirty="0">
-                <a:solidFill>
-                  <a:schemeClr val="accent3"/>
-                </a:solidFill>
-              </a:rPr>
-              <a:t>Zona</a:t>
-            </a:r>
-            <a:endParaRPr lang="en-US" sz="1100" dirty="0"/>
+              <a:rPr lang="en-US" sz="1200" b="1" dirty="0">
+                <a:solidFill>
+                  <a:schemeClr val="bg1"/>
+                </a:solidFill>
+              </a:rPr>
+              <a:t>7</a:t>
+            </a:r>
+            <a:endParaRPr lang="en-US" sz="1200" dirty="0"/>
           </a:p>
         </p:txBody>
       </p:sp>
       <p:sp>
         <p:nvSpPr>
-          <p:cNvPr id="29" name="Text 26"/>
+          <p:cNvPr id="38" name="Etiqueta Lebanon"/>
+          <p:cNvSpPr/>
+          <p:nvPr/>
+        </p:nvSpPr>
+        <p:spPr>
+          <a:xfrm>
+            <a:off x="2992374" y="3824761"/>
+            <a:ext cx="726948" cy="246888"/>
+          </a:xfrm>
+          <a:prstGeom prst="roundRect">
+            <a:avLst>
+              <a:gd name="adj" fmla="val 22222"/>
+            </a:avLst>
+          </a:prstGeom>
+          <a:solidFill>
+            <a:schemeClr val="bg1"/>
+          </a:solidFill>
+          <a:ln w="9525">
+            <a:solidFill>
+              <a:schemeClr val="tx2"/>
+            </a:solidFill>
+            <a:prstDash val="solid"/>
+          </a:ln>
+        </p:spPr>
+      </p:sp>
+      <p:sp>
+        <p:nvSpPr>
+          <p:cNvPr id="39" name="Text 36"/>
           <p:cNvSpPr txBox="1"/>
           <p:nvPr/>
         </p:nvSpPr>
         <p:spPr>
           <a:xfrm>
-            <a:off x="10744200" y="1554480"/>
-            <a:ext cx="896112" cy="256032"/>
+            <a:off x="2992374" y="3824761"/>
+            <a:ext cx="726948" cy="246888"/>
           </a:xfrm>
           <a:prstGeom prst="rect">
             <a:avLst/>
@@ -16150,6 +16418,450 @@
           <a:bodyPr wrap="square" lIns="0" tIns="0" rIns="0" bIns="0" rtlCol="0" anchor="ctr"/>
           <a:lstStyle/>
           <a:p>
+            <a:pPr algn="ctr" indent="0" marL="0">
+              <a:buNone/>
+            </a:pPr>
+            <a:r>
+              <a:rPr lang="en-US" sz="1100" b="1" dirty="0">
+                <a:solidFill>
+                  <a:schemeClr val="tx2"/>
+                </a:solidFill>
+              </a:rPr>
+              <a:t>Lebanon</a:t>
+            </a:r>
+            <a:endParaRPr lang="en-US" sz="1100" dirty="0"/>
+          </a:p>
+        </p:txBody>
+      </p:sp>
+      <p:sp>
+        <p:nvSpPr>
+          <p:cNvPr id="40" name="Zona 7 Lancaster"/>
+          <p:cNvSpPr/>
+          <p:nvPr/>
+        </p:nvSpPr>
+        <p:spPr>
+          <a:xfrm>
+            <a:off x="3305019" y="4740627"/>
+            <a:ext cx="449129" cy="449129"/>
+          </a:xfrm>
+          <a:prstGeom prst="ellipse">
+            <a:avLst/>
+          </a:prstGeom>
+          <a:solidFill>
+            <a:schemeClr val="accent2"/>
+          </a:solidFill>
+          <a:ln w="19050">
+            <a:solidFill>
+              <a:schemeClr val="bg1"/>
+            </a:solidFill>
+            <a:prstDash val="solid"/>
+          </a:ln>
+        </p:spPr>
+      </p:sp>
+      <p:sp>
+        <p:nvSpPr>
+          <p:cNvPr id="41" name="Text 38"/>
+          <p:cNvSpPr txBox="1"/>
+          <p:nvPr/>
+        </p:nvSpPr>
+        <p:spPr>
+          <a:xfrm>
+            <a:off x="3305019" y="4740627"/>
+            <a:ext cx="449129" cy="449129"/>
+          </a:xfrm>
+          <a:prstGeom prst="rect">
+            <a:avLst/>
+          </a:prstGeom>
+          <a:noFill/>
+          <a:ln/>
+        </p:spPr>
+        <p:txBody>
+          <a:bodyPr wrap="square" lIns="0" tIns="0" rIns="0" bIns="0" rtlCol="0" anchor="ctr"/>
+          <a:lstStyle/>
+          <a:p>
+            <a:pPr algn="ctr" indent="0" marL="0">
+              <a:buNone/>
+            </a:pPr>
+            <a:r>
+              <a:rPr lang="en-US" sz="1200" b="1" dirty="0">
+                <a:solidFill>
+                  <a:schemeClr val="bg1"/>
+                </a:solidFill>
+              </a:rPr>
+              <a:t>7</a:t>
+            </a:r>
+            <a:endParaRPr lang="en-US" sz="1200" dirty="0"/>
+          </a:p>
+        </p:txBody>
+      </p:sp>
+      <p:sp>
+        <p:nvSpPr>
+          <p:cNvPr id="42" name="Etiqueta Lancaster"/>
+          <p:cNvSpPr/>
+          <p:nvPr/>
+        </p:nvSpPr>
+        <p:spPr>
+          <a:xfrm>
+            <a:off x="3088386" y="5235477"/>
+            <a:ext cx="882396" cy="246888"/>
+          </a:xfrm>
+          <a:prstGeom prst="roundRect">
+            <a:avLst>
+              <a:gd name="adj" fmla="val 22222"/>
+            </a:avLst>
+          </a:prstGeom>
+          <a:solidFill>
+            <a:schemeClr val="bg1"/>
+          </a:solidFill>
+          <a:ln w="9525">
+            <a:solidFill>
+              <a:schemeClr val="tx2"/>
+            </a:solidFill>
+            <a:prstDash val="solid"/>
+          </a:ln>
+        </p:spPr>
+      </p:sp>
+      <p:sp>
+        <p:nvSpPr>
+          <p:cNvPr id="43" name="Text 40"/>
+          <p:cNvSpPr txBox="1"/>
+          <p:nvPr/>
+        </p:nvSpPr>
+        <p:spPr>
+          <a:xfrm>
+            <a:off x="3088386" y="5235477"/>
+            <a:ext cx="882396" cy="246888"/>
+          </a:xfrm>
+          <a:prstGeom prst="rect">
+            <a:avLst/>
+          </a:prstGeom>
+          <a:noFill/>
+          <a:ln/>
+        </p:spPr>
+        <p:txBody>
+          <a:bodyPr wrap="square" lIns="0" tIns="0" rIns="0" bIns="0" rtlCol="0" anchor="ctr"/>
+          <a:lstStyle/>
+          <a:p>
+            <a:pPr algn="ctr" indent="0" marL="0">
+              <a:buNone/>
+            </a:pPr>
+            <a:r>
+              <a:rPr lang="en-US" sz="1100" b="1" dirty="0">
+                <a:solidFill>
+                  <a:schemeClr val="tx2"/>
+                </a:solidFill>
+              </a:rPr>
+              <a:t>Lancaster</a:t>
+            </a:r>
+            <a:endParaRPr lang="en-US" sz="1100" dirty="0"/>
+          </a:p>
+        </p:txBody>
+      </p:sp>
+      <p:sp>
+        <p:nvSpPr>
+          <p:cNvPr id="44" name="Zona 7 York"/>
+          <p:cNvSpPr/>
+          <p:nvPr/>
+        </p:nvSpPr>
+        <p:spPr>
+          <a:xfrm>
+            <a:off x="2623201" y="4909201"/>
+            <a:ext cx="422878" cy="422878"/>
+          </a:xfrm>
+          <a:prstGeom prst="ellipse">
+            <a:avLst/>
+          </a:prstGeom>
+          <a:solidFill>
+            <a:schemeClr val="accent2"/>
+          </a:solidFill>
+          <a:ln w="19050">
+            <a:solidFill>
+              <a:schemeClr val="bg1"/>
+            </a:solidFill>
+            <a:prstDash val="solid"/>
+          </a:ln>
+        </p:spPr>
+      </p:sp>
+      <p:sp>
+        <p:nvSpPr>
+          <p:cNvPr id="45" name="Text 42"/>
+          <p:cNvSpPr txBox="1"/>
+          <p:nvPr/>
+        </p:nvSpPr>
+        <p:spPr>
+          <a:xfrm>
+            <a:off x="2623201" y="4909201"/>
+            <a:ext cx="422878" cy="422878"/>
+          </a:xfrm>
+          <a:prstGeom prst="rect">
+            <a:avLst/>
+          </a:prstGeom>
+          <a:noFill/>
+          <a:ln/>
+        </p:spPr>
+        <p:txBody>
+          <a:bodyPr wrap="square" lIns="0" tIns="0" rIns="0" bIns="0" rtlCol="0" anchor="ctr"/>
+          <a:lstStyle/>
+          <a:p>
+            <a:pPr algn="ctr" indent="0" marL="0">
+              <a:buNone/>
+            </a:pPr>
+            <a:r>
+              <a:rPr lang="en-US" sz="1200" b="1" dirty="0">
+                <a:solidFill>
+                  <a:schemeClr val="bg1"/>
+                </a:solidFill>
+              </a:rPr>
+              <a:t>7</a:t>
+            </a:r>
+            <a:endParaRPr lang="en-US" sz="1200" dirty="0"/>
+          </a:p>
+        </p:txBody>
+      </p:sp>
+      <p:sp>
+        <p:nvSpPr>
+          <p:cNvPr id="46" name="Etiqueta York"/>
+          <p:cNvSpPr/>
+          <p:nvPr/>
+        </p:nvSpPr>
+        <p:spPr>
+          <a:xfrm>
+            <a:off x="2083705" y="4997196"/>
+            <a:ext cx="493776" cy="246888"/>
+          </a:xfrm>
+          <a:prstGeom prst="roundRect">
+            <a:avLst>
+              <a:gd name="adj" fmla="val 22222"/>
+            </a:avLst>
+          </a:prstGeom>
+          <a:solidFill>
+            <a:schemeClr val="bg1"/>
+          </a:solidFill>
+          <a:ln w="9525">
+            <a:solidFill>
+              <a:schemeClr val="tx2"/>
+            </a:solidFill>
+            <a:prstDash val="solid"/>
+          </a:ln>
+        </p:spPr>
+      </p:sp>
+      <p:sp>
+        <p:nvSpPr>
+          <p:cNvPr id="47" name="Text 44"/>
+          <p:cNvSpPr txBox="1"/>
+          <p:nvPr/>
+        </p:nvSpPr>
+        <p:spPr>
+          <a:xfrm>
+            <a:off x="2083705" y="4997196"/>
+            <a:ext cx="493776" cy="246888"/>
+          </a:xfrm>
+          <a:prstGeom prst="rect">
+            <a:avLst/>
+          </a:prstGeom>
+          <a:noFill/>
+          <a:ln/>
+        </p:spPr>
+        <p:txBody>
+          <a:bodyPr wrap="square" lIns="0" tIns="0" rIns="0" bIns="0" rtlCol="0" anchor="ctr"/>
+          <a:lstStyle/>
+          <a:p>
+            <a:pPr algn="ctr" indent="0" marL="0">
+              <a:buNone/>
+            </a:pPr>
+            <a:r>
+              <a:rPr lang="en-US" sz="1100" b="1" dirty="0">
+                <a:solidFill>
+                  <a:schemeClr val="tx2"/>
+                </a:solidFill>
+              </a:rPr>
+              <a:t>York</a:t>
+            </a:r>
+            <a:endParaRPr lang="en-US" sz="1100" dirty="0"/>
+          </a:p>
+        </p:txBody>
+      </p:sp>
+      <p:sp>
+        <p:nvSpPr>
+          <p:cNvPr id="48" name="Zona 8 Wilmington"/>
+          <p:cNvSpPr/>
+          <p:nvPr/>
+        </p:nvSpPr>
+        <p:spPr>
+          <a:xfrm>
+            <a:off x="4567872" y="5390832"/>
+            <a:ext cx="410592" cy="410592"/>
+          </a:xfrm>
+          <a:prstGeom prst="ellipse">
+            <a:avLst/>
+          </a:prstGeom>
+          <a:solidFill>
+            <a:schemeClr val="accent2"/>
+          </a:solidFill>
+          <a:ln w="19050">
+            <a:solidFill>
+              <a:schemeClr val="bg1"/>
+            </a:solidFill>
+            <a:prstDash val="solid"/>
+          </a:ln>
+        </p:spPr>
+      </p:sp>
+      <p:sp>
+        <p:nvSpPr>
+          <p:cNvPr id="49" name="Text 46"/>
+          <p:cNvSpPr txBox="1"/>
+          <p:nvPr/>
+        </p:nvSpPr>
+        <p:spPr>
+          <a:xfrm>
+            <a:off x="4567872" y="5390832"/>
+            <a:ext cx="410592" cy="410592"/>
+          </a:xfrm>
+          <a:prstGeom prst="rect">
+            <a:avLst/>
+          </a:prstGeom>
+          <a:noFill/>
+          <a:ln/>
+        </p:spPr>
+        <p:txBody>
+          <a:bodyPr wrap="square" lIns="0" tIns="0" rIns="0" bIns="0" rtlCol="0" anchor="ctr"/>
+          <a:lstStyle/>
+          <a:p>
+            <a:pPr algn="ctr" indent="0" marL="0">
+              <a:buNone/>
+            </a:pPr>
+            <a:r>
+              <a:rPr lang="en-US" sz="1200" b="1" dirty="0">
+                <a:solidFill>
+                  <a:schemeClr val="bg1"/>
+                </a:solidFill>
+              </a:rPr>
+              <a:t>8</a:t>
+            </a:r>
+            <a:endParaRPr lang="en-US" sz="1200" dirty="0"/>
+          </a:p>
+        </p:txBody>
+      </p:sp>
+      <p:sp>
+        <p:nvSpPr>
+          <p:cNvPr id="50" name="Etiqueta Wilmington"/>
+          <p:cNvSpPr/>
+          <p:nvPr/>
+        </p:nvSpPr>
+        <p:spPr>
+          <a:xfrm>
+            <a:off x="3562032" y="5472684"/>
+            <a:ext cx="960120" cy="246888"/>
+          </a:xfrm>
+          <a:prstGeom prst="roundRect">
+            <a:avLst>
+              <a:gd name="adj" fmla="val 22222"/>
+            </a:avLst>
+          </a:prstGeom>
+          <a:solidFill>
+            <a:schemeClr val="bg1"/>
+          </a:solidFill>
+          <a:ln w="9525">
+            <a:solidFill>
+              <a:schemeClr val="tx2"/>
+            </a:solidFill>
+            <a:prstDash val="solid"/>
+          </a:ln>
+        </p:spPr>
+      </p:sp>
+      <p:sp>
+        <p:nvSpPr>
+          <p:cNvPr id="51" name="Text 48"/>
+          <p:cNvSpPr txBox="1"/>
+          <p:nvPr/>
+        </p:nvSpPr>
+        <p:spPr>
+          <a:xfrm>
+            <a:off x="3562032" y="5472684"/>
+            <a:ext cx="960120" cy="246888"/>
+          </a:xfrm>
+          <a:prstGeom prst="rect">
+            <a:avLst/>
+          </a:prstGeom>
+          <a:noFill/>
+          <a:ln/>
+        </p:spPr>
+        <p:txBody>
+          <a:bodyPr wrap="square" lIns="0" tIns="0" rIns="0" bIns="0" rtlCol="0" anchor="ctr"/>
+          <a:lstStyle/>
+          <a:p>
+            <a:pPr algn="ctr" indent="0" marL="0">
+              <a:buNone/>
+            </a:pPr>
+            <a:r>
+              <a:rPr lang="en-US" sz="1100" b="1" dirty="0">
+                <a:solidFill>
+                  <a:schemeClr val="tx2"/>
+                </a:solidFill>
+              </a:rPr>
+              <a:t>Wilmington</a:t>
+            </a:r>
+            <a:endParaRPr lang="en-US" sz="1100" dirty="0"/>
+          </a:p>
+        </p:txBody>
+      </p:sp>
+      <p:sp>
+        <p:nvSpPr>
+          <p:cNvPr id="52" name="Text 49"/>
+          <p:cNvSpPr txBox="1"/>
+          <p:nvPr/>
+        </p:nvSpPr>
+        <p:spPr>
+          <a:xfrm>
+            <a:off x="8275320" y="1554480"/>
+            <a:ext cx="2286000" cy="256032"/>
+          </a:xfrm>
+          <a:prstGeom prst="rect">
+            <a:avLst/>
+          </a:prstGeom>
+          <a:noFill/>
+          <a:ln/>
+        </p:spPr>
+        <p:txBody>
+          <a:bodyPr wrap="square" lIns="0" tIns="0" rIns="0" bIns="0" rtlCol="0" anchor="ctr"/>
+          <a:lstStyle/>
+          <a:p>
+            <a:pPr indent="0" marL="0">
+              <a:buNone/>
+            </a:pPr>
+            <a:r>
+              <a:rPr lang="en-US" sz="1100" b="1" dirty="0">
+                <a:solidFill>
+                  <a:schemeClr val="accent3"/>
+                </a:solidFill>
+              </a:rPr>
+              <a:t>Zona</a:t>
+            </a:r>
+            <a:endParaRPr lang="en-US" sz="1100" dirty="0"/>
+          </a:p>
+        </p:txBody>
+      </p:sp>
+      <p:sp>
+        <p:nvSpPr>
+          <p:cNvPr id="53" name="Text 50"/>
+          <p:cNvSpPr txBox="1"/>
+          <p:nvPr/>
+        </p:nvSpPr>
+        <p:spPr>
+          <a:xfrm>
+            <a:off x="10744200" y="1554480"/>
+            <a:ext cx="896112" cy="256032"/>
+          </a:xfrm>
+          <a:prstGeom prst="rect">
+            <a:avLst/>
+          </a:prstGeom>
+          <a:noFill/>
+          <a:ln/>
+        </p:spPr>
+        <p:txBody>
+          <a:bodyPr wrap="square" lIns="0" tIns="0" rIns="0" bIns="0" rtlCol="0" anchor="ctr"/>
+          <a:lstStyle/>
+          <a:p>
             <a:pPr algn="r" indent="0" marL="0">
               <a:buNone/>
             </a:pPr>
@@ -16167,7 +16879,7 @@
       </p:sp>
       <p:sp>
         <p:nvSpPr>
-          <p:cNvPr id="30" name="Shape 27"/>
+          <p:cNvPr id="54" name="Shape 51"/>
           <p:cNvSpPr/>
           <p:nvPr/>
         </p:nvSpPr>
@@ -16192,7 +16904,7 @@
       </p:sp>
       <p:sp>
         <p:nvSpPr>
-          <p:cNvPr id="31" name="Text 28"/>
+          <p:cNvPr id="55" name="Text 52"/>
           <p:cNvSpPr txBox="1"/>
           <p:nvPr/>
         </p:nvSpPr>
@@ -16228,7 +16940,7 @@
       </p:sp>
       <p:sp>
         <p:nvSpPr>
-          <p:cNvPr id="32" name="Text 29"/>
+          <p:cNvPr id="56" name="Text 53"/>
           <p:cNvSpPr txBox="1"/>
           <p:nvPr/>
         </p:nvSpPr>
@@ -16278,7 +16990,7 @@
       </p:sp>
       <p:sp>
         <p:nvSpPr>
-          <p:cNvPr id="33" name="Text 30"/>
+          <p:cNvPr id="57" name="Text 54"/>
           <p:cNvSpPr txBox="1"/>
           <p:nvPr/>
         </p:nvSpPr>
@@ -16314,7 +17026,7 @@
       </p:sp>
       <p:sp>
         <p:nvSpPr>
-          <p:cNvPr id="34" name="Shape 31"/>
+          <p:cNvPr id="58" name="Shape 55"/>
           <p:cNvSpPr/>
           <p:nvPr/>
         </p:nvSpPr>
@@ -16339,7 +17051,7 @@
       </p:sp>
       <p:sp>
         <p:nvSpPr>
-          <p:cNvPr id="35" name="Text 32"/>
+          <p:cNvPr id="59" name="Text 56"/>
           <p:cNvSpPr txBox="1"/>
           <p:nvPr/>
         </p:nvSpPr>
@@ -16375,7 +17087,7 @@
       </p:sp>
       <p:sp>
         <p:nvSpPr>
-          <p:cNvPr id="36" name="Text 33"/>
+          <p:cNvPr id="60" name="Text 57"/>
           <p:cNvSpPr txBox="1"/>
           <p:nvPr/>
         </p:nvSpPr>
@@ -16425,7 +17137,7 @@
       </p:sp>
       <p:sp>
         <p:nvSpPr>
-          <p:cNvPr id="37" name="Text 34"/>
+          <p:cNvPr id="61" name="Text 58"/>
           <p:cNvSpPr txBox="1"/>
           <p:nvPr/>
         </p:nvSpPr>
@@ -16461,7 +17173,7 @@
       </p:sp>
       <p:sp>
         <p:nvSpPr>
-          <p:cNvPr id="38" name="Shape 35"/>
+          <p:cNvPr id="62" name="Shape 59"/>
           <p:cNvSpPr/>
           <p:nvPr/>
         </p:nvSpPr>
@@ -16486,7 +17198,7 @@
       </p:sp>
       <p:sp>
         <p:nvSpPr>
-          <p:cNvPr id="39" name="Text 36"/>
+          <p:cNvPr id="63" name="Text 60"/>
           <p:cNvSpPr txBox="1"/>
           <p:nvPr/>
         </p:nvSpPr>
@@ -16522,7 +17234,7 @@
       </p:sp>
       <p:sp>
         <p:nvSpPr>
-          <p:cNvPr id="40" name="Text 37"/>
+          <p:cNvPr id="64" name="Text 61"/>
           <p:cNvSpPr txBox="1"/>
           <p:nvPr/>
         </p:nvSpPr>
@@ -16572,7 +17284,7 @@
       </p:sp>
       <p:sp>
         <p:nvSpPr>
-          <p:cNvPr id="41" name="Text 38"/>
+          <p:cNvPr id="65" name="Text 62"/>
           <p:cNvSpPr txBox="1"/>
           <p:nvPr/>
         </p:nvSpPr>
@@ -16608,7 +17320,7 @@
       </p:sp>
       <p:sp>
         <p:nvSpPr>
-          <p:cNvPr id="42" name="Shape 39"/>
+          <p:cNvPr id="66" name="Shape 63"/>
           <p:cNvSpPr/>
           <p:nvPr/>
         </p:nvSpPr>
@@ -16633,7 +17345,7 @@
       </p:sp>
       <p:sp>
         <p:nvSpPr>
-          <p:cNvPr id="43" name="Text 40"/>
+          <p:cNvPr id="67" name="Text 64"/>
           <p:cNvSpPr txBox="1"/>
           <p:nvPr/>
         </p:nvSpPr>
@@ -16669,7 +17381,7 @@
       </p:sp>
       <p:sp>
         <p:nvSpPr>
-          <p:cNvPr id="44" name="Text 41"/>
+          <p:cNvPr id="68" name="Text 65"/>
           <p:cNvSpPr txBox="1"/>
           <p:nvPr/>
         </p:nvSpPr>
@@ -16719,7 +17431,7 @@
       </p:sp>
       <p:sp>
         <p:nvSpPr>
-          <p:cNvPr id="45" name="Text 42"/>
+          <p:cNvPr id="69" name="Text 66"/>
           <p:cNvSpPr txBox="1"/>
           <p:nvPr/>
         </p:nvSpPr>
@@ -16755,7 +17467,7 @@
       </p:sp>
       <p:sp>
         <p:nvSpPr>
-          <p:cNvPr id="46" name="Shape 43"/>
+          <p:cNvPr id="70" name="Shape 67"/>
           <p:cNvSpPr/>
           <p:nvPr/>
         </p:nvSpPr>
@@ -16780,7 +17492,7 @@
       </p:sp>
       <p:sp>
         <p:nvSpPr>
-          <p:cNvPr id="47" name="Text 44"/>
+          <p:cNvPr id="71" name="Text 68"/>
           <p:cNvSpPr txBox="1"/>
           <p:nvPr/>
         </p:nvSpPr>
@@ -16816,7 +17528,7 @@
       </p:sp>
       <p:sp>
         <p:nvSpPr>
-          <p:cNvPr id="48" name="Text 45"/>
+          <p:cNvPr id="72" name="Text 69"/>
           <p:cNvSpPr txBox="1"/>
           <p:nvPr/>
         </p:nvSpPr>
@@ -16866,7 +17578,7 @@
       </p:sp>
       <p:sp>
         <p:nvSpPr>
-          <p:cNvPr id="49" name="Text 46"/>
+          <p:cNvPr id="73" name="Text 70"/>
           <p:cNvSpPr txBox="1"/>
           <p:nvPr/>
         </p:nvSpPr>
@@ -16902,7 +17614,7 @@
       </p:sp>
       <p:sp>
         <p:nvSpPr>
-          <p:cNvPr id="50" name="Shape 47"/>
+          <p:cNvPr id="74" name="Shape 71"/>
           <p:cNvSpPr/>
           <p:nvPr/>
         </p:nvSpPr>
@@ -16927,7 +17639,7 @@
       </p:sp>
       <p:sp>
         <p:nvSpPr>
-          <p:cNvPr id="51" name="Text 48"/>
+          <p:cNvPr id="75" name="Text 72"/>
           <p:cNvSpPr txBox="1"/>
           <p:nvPr/>
         </p:nvSpPr>
@@ -16963,7 +17675,7 @@
       </p:sp>
       <p:sp>
         <p:nvSpPr>
-          <p:cNvPr id="52" name="Text 49"/>
+          <p:cNvPr id="76" name="Text 73"/>
           <p:cNvSpPr txBox="1"/>
           <p:nvPr/>
         </p:nvSpPr>
@@ -17013,7 +17725,7 @@
       </p:sp>
       <p:sp>
         <p:nvSpPr>
-          <p:cNvPr id="53" name="Text 50"/>
+          <p:cNvPr id="77" name="Text 74"/>
           <p:cNvSpPr txBox="1"/>
           <p:nvPr/>
         </p:nvSpPr>
@@ -17049,7 +17761,7 @@
       </p:sp>
       <p:sp>
         <p:nvSpPr>
-          <p:cNvPr id="54" name="Shape 51"/>
+          <p:cNvPr id="78" name="Shape 75"/>
           <p:cNvSpPr/>
           <p:nvPr/>
         </p:nvSpPr>
@@ -17074,7 +17786,7 @@
       </p:sp>
       <p:sp>
         <p:nvSpPr>
-          <p:cNvPr id="55" name="Text 52"/>
+          <p:cNvPr id="79" name="Text 76"/>
           <p:cNvSpPr txBox="1"/>
           <p:nvPr/>
         </p:nvSpPr>
@@ -17110,7 +17822,7 @@
       </p:sp>
       <p:sp>
         <p:nvSpPr>
-          <p:cNvPr id="56" name="Text 53"/>
+          <p:cNvPr id="80" name="Text 77"/>
           <p:cNvSpPr txBox="1"/>
           <p:nvPr/>
         </p:nvSpPr>
@@ -17160,7 +17872,7 @@
       </p:sp>
       <p:sp>
         <p:nvSpPr>
-          <p:cNvPr id="57" name="Text 54"/>
+          <p:cNvPr id="81" name="Text 78"/>
           <p:cNvSpPr txBox="1"/>
           <p:nvPr/>
         </p:nvSpPr>
@@ -17196,7 +17908,7 @@
       </p:sp>
       <p:sp>
         <p:nvSpPr>
-          <p:cNvPr id="58" name="Shape 55"/>
+          <p:cNvPr id="82" name="Shape 79"/>
           <p:cNvSpPr/>
           <p:nvPr/>
         </p:nvSpPr>
@@ -17221,7 +17933,7 @@
       </p:sp>
       <p:sp>
         <p:nvSpPr>
-          <p:cNvPr id="59" name="Text 56"/>
+          <p:cNvPr id="83" name="Text 80"/>
           <p:cNvSpPr txBox="1"/>
           <p:nvPr/>
         </p:nvSpPr>
@@ -17257,7 +17969,7 @@
       </p:sp>
       <p:sp>
         <p:nvSpPr>
-          <p:cNvPr id="60" name="Text 57"/>
+          <p:cNvPr id="84" name="Text 81"/>
           <p:cNvSpPr txBox="1"/>
           <p:nvPr/>
         </p:nvSpPr>
@@ -17307,7 +18019,7 @@
       </p:sp>
       <p:sp>
         <p:nvSpPr>
-          <p:cNvPr id="61" name="Text 58"/>
+          <p:cNvPr id="85" name="Text 82"/>
           <p:cNvSpPr txBox="1"/>
           <p:nvPr/>
         </p:nvSpPr>
@@ -17343,7 +18055,7 @@
       </p:sp>
       <p:sp>
         <p:nvSpPr>
-          <p:cNvPr id="62" name="Fuente"/>
+          <p:cNvPr id="86" name="Fuente"/>
           <p:cNvSpPr txBox="1"/>
           <p:nvPr/>
         </p:nvSpPr>
@@ -17371,7 +18083,7 @@
                   <a:schemeClr val="accent4"/>
                 </a:solidFill>
               </a:rPr>
-              <a:t>Electores: Seccional PRM Pennsylvania (2024). Tamaño del círculo según los electores de cada zona. Versión interactiva en el enlace web. Cartografía: US Census.</a:t>
+              <a:t>Electores: Seccional PRM Pennsylvania (2024). Cada círculo es una ciudad; el número indica su zona y el tamaño, sus electores. Versión interactiva en el enlace web.</a:t>
             </a:r>
             <a:endParaRPr lang="en-US" sz="1000" dirty="0"/>
           </a:p>

</xml_diff>

<commit_message>
Precisar el dato de crecimiento: mayor aumento absoluto de dominicanos en 2025 (INDEX)
Co-Authored-By: Claude Opus 5.5 <noreply@anthropic.com>
Claude-Session: https://claude.ai/code/session_01RrEJtrwRidXxzgveZEVQjf
</commit_message>
<xml_diff>
--- a/presentaciones/Plan_Estrategico_Pennsylvania_2028.pptx
+++ b/presentaciones/Plan_Estrategico_Pennsylvania_2028.pptx
@@ -120,7 +120,7 @@
   <p:extLst>
     <p:ext uri="{521415D9-36F7-43E2-AB2F-B90AF26B5E84}">
       <p14:sectionLst xmlns:p14="http://schemas.microsoft.com/office/powerpoint/2010/main">
-        <p14:section name="Diagnóstico" id="{0b4b796e-ae87-46f0-a46d-9e76c0b08eef}">
+        <p14:section name="Diagnóstico" id="{9fccc47c-4194-ed9a-5af7-a8e8f06d9677}">
           <p14:sldIdLst>
             <p14:sldId id="256"/>
             <p14:sldId id="257"/>
@@ -129,19 +129,19 @@
             <p14:sldId id="260"/>
           </p14:sldIdLst>
         </p14:section>
-        <p14:section name="Desafíos" id="{d38a52c3-d018-052e-9570-1be76e49cd7d}">
+        <p14:section name="Desafíos" id="{03fbc879-4fdc-7d91-de03-650cc90e4f91}">
           <p14:sldIdLst>
             <p14:sldId id="261"/>
             <p14:sldId id="262"/>
           </p14:sldIdLst>
         </p14:section>
-        <p14:section name="Escenarios y meta" id="{7b02b31e-abf8-4370-1bdf-d4ca2eea7944}">
+        <p14:section name="Escenarios y meta" id="{bfe9bb2b-1b1a-c16b-929f-e9402d81d164}">
           <p14:sldIdLst>
             <p14:sldId id="263"/>
             <p14:sldId id="264"/>
           </p14:sldIdLst>
         </p14:section>
-        <p14:section name="Plan y recomendación" id="{6719efa2-1ef9-9b5a-9c21-fadcf89cf738}">
+        <p14:section name="Plan y recomendación" id="{f5d111d4-5064-09e7-4d7c-f7e91cb692db}">
           <p14:sldIdLst>
             <p14:sldId id="265"/>
             <p14:sldId id="266"/>
@@ -149,7 +149,7 @@
             <p14:sldId id="268"/>
           </p14:sldIdLst>
         </p14:section>
-        <p14:section name="Anexo" id="{aacc1b60-44ab-e55c-be56-ae7bdf5ffb72}">
+        <p14:section name="Anexo" id="{987f5466-7707-34d9-e3e9-b3deff6dcce5}">
           <p14:sldIdLst>
             <p14:sldId id="269"/>
           </p14:sldIdLst>
@@ -713,7 +713,7 @@
                 </a:solidFill>
                 <a:latin typeface="+mn-lt"/>
               </a:rPr>
-              <a:t>Dominicanos en Pennsylvania (INDEX): el mayor crecimiento de EE. UU.</a:t>
+              <a:t>Dominicanos en Pennsylvania (INDEX): +36,553 en 2025, el mayor aumento de EE. UU.</a:t>
             </a:r>
           </a:p>
         </c:rich>
@@ -2492,7 +2492,7 @@
           <a:p>
             <a:r>
               <a:rPr lang="en-US" dirty="0"/>
-              <a:t>Crecimiento: el Registro Sociodemográfico del INDEX contaba 181,156 dominicanos en Pennsylvania al 31 de diciembre de 2022; el último informe del INDEX reporta 227,647 (+36,553 en el último año, +19.1 %, el mayor aumento absoluto de todos los estados). El Consulado en Filadelfia atiende a más de 191 mil y afirma que llega un dominicano más cada día, muchos desde Nueva York. Hazleton ya tiene cerca de 43 % de población dominicana (Censo). Implicación: quien se mudó desde NY/NJ sigue empadronado en su OCLEE anterior; hay que trasladar su registro a Pennsylvania antes del cierre del padrón (enero de 2028), idealmente en la misma cita de la nueva cédula; confirmar el procedimiento con la JCE. Potencial: 47,529 inscritos son el 21 % de los 227,647 dominicanos que registra el INDEX en el estado (la cifra del INDEX incluye a menores de edad y a personas sin cédula, por lo que no todos pueden votar, pero muestra el tamaño del potencial). Escenarios de padrón: proyección propia (+5 %, +12 %, +26 %; el alto replica el crecimiento de la población).</a:t>
+              <a:t>Crecimiento: el Registro Sociodemográfico del INDEX contaba 181,156 dominicanos en Pennsylvania al 31 de diciembre de 2022; el último informe del INDEX (5.ª edición, julio de 2026) reporta 227,647: +36,553 frente a 191,094 en 2024 (+19.1 %), el mayor aumento absoluto de todos los estados; Massachusetts fue segundo (+30,846) y Texas tuvo el mayor aumento porcentual (+28.3 %). Pennsylvania es el 4.º estado con más dominicanos, después de Nueva York, Nueva Jersey y Florida. El Consulado en Filadelfia atiende a más de 191 mil y afirma que llega un dominicano más cada día, muchos desde Nueva York. Hazleton ya tiene cerca de 43 % de población dominicana (Censo). Implicación: quien se mudó desde NY/NJ sigue empadronado en su OCLEE anterior; hay que trasladar su registro a Pennsylvania antes del cierre del padrón (enero de 2028), idealmente en la misma cita de la nueva cédula; confirmar el procedimiento con la JCE. Potencial: 47,529 inscritos son el 21 % de los 227,647 dominicanos que registra el INDEX en el estado (la cifra del INDEX incluye a menores de edad y a personas sin cédula, por lo que no todos pueden votar, pero muestra el tamaño del potencial). Escenarios de padrón: proyección propia (+5 %, +12 %, +26 %; el alto replica el crecimiento de la población).</a:t>
             </a:r>
             <a:endParaRPr lang="en-US" dirty="0"/>
           </a:p>
@@ -3950,7 +3950,7 @@
                   <a:schemeClr val="accent4"/>
                 </a:solidFill>
               </a:rPr>
-              <a:t>en crecimiento dominicano en EE. UU.</a:t>
+              <a:t>en aumento de dominicanos en EE. UU. (2025)</a:t>
             </a:r>
             <a:endParaRPr lang="en-US" sz="3000" dirty="0"/>
           </a:p>
@@ -14433,7 +14433,7 @@
                   <a:schemeClr val="accent4"/>
                 </a:solidFill>
               </a:rPr>
-              <a:t>dominicanos en PA: el mayor crecimiento de EE. UU.</a:t>
+              <a:t>dominicanos en PA: el mayor aumento de EE. UU.</a:t>
             </a:r>
             <a:endParaRPr lang="en-US" sz="3400" dirty="0"/>
           </a:p>

</xml_diff>

<commit_message>
Quitar el recuadro de decisión de la diapositiva final
Co-Authored-By: Claude Opus 5.5 <noreply@anthropic.com>
Claude-Session: https://claude.ai/code/session_01RrEJtrwRidXxzgveZEVQjf
</commit_message>
<xml_diff>
--- a/presentaciones/Plan_Estrategico_Pennsylvania_2028.pptx
+++ b/presentaciones/Plan_Estrategico_Pennsylvania_2028.pptx
@@ -120,7 +120,7 @@
   <p:extLst>
     <p:ext uri="{521415D9-36F7-43E2-AB2F-B90AF26B5E84}">
       <p14:sectionLst xmlns:p14="http://schemas.microsoft.com/office/powerpoint/2010/main">
-        <p14:section name="Diagnóstico" id="{9fccc47c-4194-ed9a-5af7-a8e8f06d9677}">
+        <p14:section name="Diagnóstico" id="{90171608-9719-231c-b66d-58b2245911b2}">
           <p14:sldIdLst>
             <p14:sldId id="256"/>
             <p14:sldId id="257"/>
@@ -129,19 +129,19 @@
             <p14:sldId id="260"/>
           </p14:sldIdLst>
         </p14:section>
-        <p14:section name="Desafíos" id="{03fbc879-4fdc-7d91-de03-650cc90e4f91}">
+        <p14:section name="Desafíos" id="{54dc8ab0-e4b7-9982-9d8e-ad870390eda4}">
           <p14:sldIdLst>
             <p14:sldId id="261"/>
             <p14:sldId id="262"/>
           </p14:sldIdLst>
         </p14:section>
-        <p14:section name="Escenarios y meta" id="{bfe9bb2b-1b1a-c16b-929f-e9402d81d164}">
+        <p14:section name="Escenarios y meta" id="{7feaf327-003b-b422-687a-c7f7716023a0}">
           <p14:sldIdLst>
             <p14:sldId id="263"/>
             <p14:sldId id="264"/>
           </p14:sldIdLst>
         </p14:section>
-        <p14:section name="Plan y recomendación" id="{f5d111d4-5064-09e7-4d7c-f7e91cb692db}">
+        <p14:section name="Plan y recomendación" id="{d623ce6c-869c-98c4-63b4-dc62f8ca2f27}">
           <p14:sldIdLst>
             <p14:sldId id="265"/>
             <p14:sldId id="266"/>
@@ -149,7 +149,7 @@
             <p14:sldId id="268"/>
           </p14:sldIdLst>
         </p14:section>
-        <p14:section name="Anexo" id="{987f5466-7707-34d9-e3e9-b3deff6dcce5}">
+        <p14:section name="Anexo" id="{efded245-8b92-7819-2c18-1f828092abeb}">
           <p14:sldIdLst>
             <p14:sldId id="269"/>
           </p14:sldIdLst>
@@ -10113,83 +10113,6 @@
                 </a:solidFill>
               </a:rPr>
               <a:t>Leyes 20-23 y 33-18, sin recursos públicos, datos con consentimiento expreso</a:t>
-            </a:r>
-            <a:endParaRPr lang="en-US" sz="1600" dirty="0"/>
-          </a:p>
-        </p:txBody>
-      </p:sp>
-      <p:sp>
-        <p:nvSpPr>
-          <p:cNvPr id="25" name="Decision"/>
-          <p:cNvSpPr/>
-          <p:nvPr/>
-        </p:nvSpPr>
-        <p:spPr>
-          <a:xfrm>
-            <a:off x="6217920" y="4800600"/>
-            <a:ext cx="5422392" cy="1371600"/>
-          </a:xfrm>
-          <a:prstGeom prst="roundRect">
-            <a:avLst>
-              <a:gd name="adj" fmla="val 5333"/>
-            </a:avLst>
-          </a:prstGeom>
-          <a:solidFill>
-            <a:schemeClr val="bg1"/>
-          </a:solidFill>
-          <a:ln w="12700">
-            <a:solidFill>
-              <a:schemeClr val="bg1"/>
-            </a:solidFill>
-            <a:prstDash val="solid"/>
-          </a:ln>
-        </p:spPr>
-      </p:sp>
-      <p:sp>
-        <p:nvSpPr>
-          <p:cNvPr id="26" name="Text 17"/>
-          <p:cNvSpPr txBox="1"/>
-          <p:nvPr/>
-        </p:nvSpPr>
-        <p:spPr>
-          <a:xfrm>
-            <a:off x="6446520" y="4846320"/>
-            <a:ext cx="4983480" cy="1280160"/>
-          </a:xfrm>
-          <a:prstGeom prst="rect">
-            <a:avLst/>
-          </a:prstGeom>
-          <a:noFill/>
-          <a:ln/>
-        </p:spPr>
-        <p:txBody>
-          <a:bodyPr wrap="square" lIns="0" tIns="0" rIns="0" bIns="0" rtlCol="0" anchor="ctr"/>
-          <a:lstStyle/>
-          <a:p>
-            <a:pPr indent="0" marL="0">
-              <a:buNone/>
-            </a:pPr>
-            <a:r>
-              <a:rPr lang="en-US" sz="1600" b="1" dirty="0">
-                <a:solidFill>
-                  <a:schemeClr val="accent2"/>
-                </a:solidFill>
-              </a:rPr>
-              <a:t>Decisión que se pide hoy</a:t>
-            </a:r>
-            <a:endParaRPr lang="en-US" sz="1600" dirty="0"/>
-          </a:p>
-          <a:p>
-            <a:pPr indent="0" marL="0">
-              <a:buNone/>
-            </a:pPr>
-            <a:r>
-              <a:rPr lang="en-US" sz="1500" b="1" dirty="0">
-                <a:solidFill>
-                  <a:schemeClr val="tx2"/>
-                </a:solidFill>
-              </a:rPr>
-              <a:t>Aprobar el plan con la meta de al menos 5,760 votos (+10 % sobre el PRM 2024), nombrar a los 8 coordinadores e iniciar en noviembre.</a:t>
             </a:r>
             <a:endParaRPr lang="en-US" sz="1600" dirty="0"/>
           </a:p>

</xml_diff>

<commit_message>
Portada: propuesta para el CAD
Co-Authored-By: Claude Opus 5.5 <noreply@anthropic.com>
Claude-Session: https://claude.ai/code/session_01RrEJtrwRidXxzgveZEVQjf
</commit_message>
<xml_diff>
--- a/presentaciones/Plan_Estrategico_Pennsylvania_2028.pptx
+++ b/presentaciones/Plan_Estrategico_Pennsylvania_2028.pptx
@@ -120,7 +120,7 @@
   <p:extLst>
     <p:ext uri="{521415D9-36F7-43E2-AB2F-B90AF26B5E84}">
       <p14:sectionLst xmlns:p14="http://schemas.microsoft.com/office/powerpoint/2010/main">
-        <p14:section name="Diagnóstico" id="{90171608-9719-231c-b66d-58b2245911b2}">
+        <p14:section name="Diagnóstico" id="{b0564c4c-9f99-a273-10e3-9035e724b5eb}">
           <p14:sldIdLst>
             <p14:sldId id="256"/>
             <p14:sldId id="257"/>
@@ -129,19 +129,19 @@
             <p14:sldId id="260"/>
           </p14:sldIdLst>
         </p14:section>
-        <p14:section name="Desafíos" id="{54dc8ab0-e4b7-9982-9d8e-ad870390eda4}">
+        <p14:section name="Desafíos" id="{9f1b25be-2b35-109b-9758-565e34a21e78}">
           <p14:sldIdLst>
             <p14:sldId id="261"/>
             <p14:sldId id="262"/>
           </p14:sldIdLst>
         </p14:section>
-        <p14:section name="Escenarios y meta" id="{7feaf327-003b-b422-687a-c7f7716023a0}">
+        <p14:section name="Escenarios y meta" id="{642fa6bc-124d-980d-091c-1d9ed2fa208c}">
           <p14:sldIdLst>
             <p14:sldId id="263"/>
             <p14:sldId id="264"/>
           </p14:sldIdLst>
         </p14:section>
-        <p14:section name="Plan y recomendación" id="{d623ce6c-869c-98c4-63b4-dc62f8ca2f27}">
+        <p14:section name="Plan y recomendación" id="{02f322f7-a1fe-6cac-67e4-1e95b4bd90aa}">
           <p14:sldIdLst>
             <p14:sldId id="265"/>
             <p14:sldId id="266"/>
@@ -149,7 +149,7 @@
             <p14:sldId id="268"/>
           </p14:sldIdLst>
         </p14:section>
-        <p14:section name="Anexo" id="{efded245-8b92-7819-2c18-1f828092abeb}">
+        <p14:section name="Anexo" id="{869e3132-5cc7-4e0d-ae9c-90056cf58491}">
           <p14:sldIdLst>
             <p14:sldId id="269"/>
           </p14:sldIdLst>
@@ -3602,7 +3602,7 @@
                   <a:schemeClr val="accent4"/>
                 </a:solidFill>
               </a:rPr>
-              <a:t>PROPUESTA PARA EL EQUIPO DE DAVID COLLADO · SECCIONAL PENNSYLVANIA</a:t>
+              <a:t>PROPUESTA PARA EL CAD · SECCIONAL PENNSYLVANIA</a:t>
             </a:r>
             <a:endParaRPr lang="en-US" sz="1300" dirty="0"/>
           </a:p>

</xml_diff>

<commit_message>
Citar al INDEX en las fuentes de portada, resumen y potencial
Co-Authored-By: Claude Opus 5.5 <noreply@anthropic.com>
Claude-Session: https://claude.ai/code/session_01RrEJtrwRidXxzgveZEVQjf
</commit_message>
<xml_diff>
--- a/presentaciones/Plan_Estrategico_Pennsylvania_2028.pptx
+++ b/presentaciones/Plan_Estrategico_Pennsylvania_2028.pptx
@@ -120,7 +120,7 @@
   <p:extLst>
     <p:ext uri="{521415D9-36F7-43E2-AB2F-B90AF26B5E84}">
       <p14:sectionLst xmlns:p14="http://schemas.microsoft.com/office/powerpoint/2010/main">
-        <p14:section name="Diagnóstico" id="{b0564c4c-9f99-a273-10e3-9035e724b5eb}">
+        <p14:section name="Diagnóstico" id="{df5b350e-df9e-98e9-1dcf-42259421b7d6}">
           <p14:sldIdLst>
             <p14:sldId id="256"/>
             <p14:sldId id="257"/>
@@ -129,19 +129,19 @@
             <p14:sldId id="260"/>
           </p14:sldIdLst>
         </p14:section>
-        <p14:section name="Desafíos" id="{9f1b25be-2b35-109b-9758-565e34a21e78}">
+        <p14:section name="Desafíos" id="{928c7521-1aca-ae30-3f59-565499093205}">
           <p14:sldIdLst>
             <p14:sldId id="261"/>
             <p14:sldId id="262"/>
           </p14:sldIdLst>
         </p14:section>
-        <p14:section name="Escenarios y meta" id="{642fa6bc-124d-980d-091c-1d9ed2fa208c}">
+        <p14:section name="Escenarios y meta" id="{eec36563-55c2-915b-76dd-73a8e10e810c}">
           <p14:sldIdLst>
             <p14:sldId id="263"/>
             <p14:sldId id="264"/>
           </p14:sldIdLst>
         </p14:section>
-        <p14:section name="Plan y recomendación" id="{02f322f7-a1fe-6cac-67e4-1e95b4bd90aa}">
+        <p14:section name="Plan y recomendación" id="{362908da-aafa-472c-d464-d689c3c21730}">
           <p14:sldIdLst>
             <p14:sldId id="265"/>
             <p14:sldId id="266"/>
@@ -149,7 +149,7 @@
             <p14:sldId id="268"/>
           </p14:sldIdLst>
         </p14:section>
-        <p14:section name="Anexo" id="{869e3132-5cc7-4e0d-ae9c-90056cf58491}">
+        <p14:section name="Anexo" id="{5a8ecd1a-53a4-380f-e266-0b61d3133da5}">
           <p14:sldIdLst>
             <p14:sldId id="269"/>
           </p14:sldIdLst>
@@ -4067,7 +4067,7 @@
                   <a:schemeClr val="accent4"/>
                 </a:solidFill>
               </a:rPr>
-              <a:t>Fuente: padrón electoral, Seccional PRM Pennsylvania (2024) · Votos emitidos JCE 2024 (OCLEE Philadelphia)</a:t>
+              <a:t>Fuentes: padrón electoral, Seccional PRM Pennsylvania (2024) · JCE 2024 (OCLEE Philadelphia) · INDEX, Registro Sociodemográfico de los Dominicanos en el Exterior (5.ª edición, 2026)</a:t>
             </a:r>
             <a:endParaRPr lang="en-US" sz="1000" dirty="0"/>
           </a:p>
@@ -14788,7 +14788,7 @@
                   <a:schemeClr val="accent4"/>
                 </a:solidFill>
               </a:rPr>
-              <a:t>Fuentes: Seccional PRM Pennsylvania (padrón electoral); JCE 2024; INDEX (Registro Sociodemográfico). Meta PRM: estimación propia, ver diapositiva de la meta.</a:t>
+              <a:t>Fuentes: Seccional PRM Pennsylvania (padrón electoral); JCE 2024; INDEX, Registro Sociodemográfico de los Dominicanos en el Exterior (5.ª edición, 2026). Meta PRM: estimación propia.</a:t>
             </a:r>
             <a:endParaRPr lang="en-US" sz="1000" dirty="0"/>
           </a:p>
@@ -19128,7 +19128,7 @@
                   <a:schemeClr val="accent4"/>
                 </a:solidFill>
               </a:rPr>
-              <a:t>Fuentes: INDEX, Registro Sociodemográfico (181,156 a dic. 2022; 227,647 en el último informe); Consulado RD en Filadelfia. Padrón 2028: proyección propia.</a:t>
+              <a:t>Fuentes: INDEX, Registro Sociodemográfico de los Dominicanos en el Exterior (181,156 a dic. 2022; 227,647 en la 5.ª edición, 2026); Consulado RD en Filadelfia. Padrón 2028: proyección propia.</a:t>
             </a:r>
             <a:endParaRPr lang="en-US" sz="1000" dirty="0"/>
           </a:p>

</xml_diff>

<commit_message>
Enfocar la meta en David Collado y aclarar que son votos duros
Co-Authored-By: Claude Opus 5.5 <noreply@anthropic.com>
Claude-Session: https://claude.ai/code/session_01RrEJtrwRidXxzgveZEVQjf
</commit_message>
<xml_diff>
--- a/presentaciones/Plan_Estrategico_Pennsylvania_2028.pptx
+++ b/presentaciones/Plan_Estrategico_Pennsylvania_2028.pptx
@@ -120,7 +120,7 @@
   <p:extLst>
     <p:ext uri="{521415D9-36F7-43E2-AB2F-B90AF26B5E84}">
       <p14:sectionLst xmlns:p14="http://schemas.microsoft.com/office/powerpoint/2010/main">
-        <p14:section name="Diagnóstico" id="{df5b350e-df9e-98e9-1dcf-42259421b7d6}">
+        <p14:section name="Diagnóstico" id="{24cf3d5a-59df-fa7e-5544-4817be613350}">
           <p14:sldIdLst>
             <p14:sldId id="256"/>
             <p14:sldId id="257"/>
@@ -129,19 +129,19 @@
             <p14:sldId id="260"/>
           </p14:sldIdLst>
         </p14:section>
-        <p14:section name="Desafíos" id="{928c7521-1aca-ae30-3f59-565499093205}">
+        <p14:section name="Desafíos" id="{4d118862-b4b2-11f5-5666-6e7d21e22eb8}">
           <p14:sldIdLst>
             <p14:sldId id="261"/>
             <p14:sldId id="262"/>
           </p14:sldIdLst>
         </p14:section>
-        <p14:section name="Escenarios y meta" id="{eec36563-55c2-915b-76dd-73a8e10e810c}">
+        <p14:section name="Escenarios y meta" id="{d48dafbc-6617-8cd6-48db-5a96fb5ac7ec}">
           <p14:sldIdLst>
             <p14:sldId id="263"/>
             <p14:sldId id="264"/>
           </p14:sldIdLst>
         </p14:section>
-        <p14:section name="Plan y recomendación" id="{362908da-aafa-472c-d464-d689c3c21730}">
+        <p14:section name="Plan y recomendación" id="{7ad80dd8-a57a-278b-9c99-ec2f365a4154}">
           <p14:sldIdLst>
             <p14:sldId id="265"/>
             <p14:sldId id="266"/>
@@ -149,7 +149,7 @@
             <p14:sldId id="268"/>
           </p14:sldIdLst>
         </p14:section>
-        <p14:section name="Anexo" id="{5a8ecd1a-53a4-380f-e266-0b61d3133da5}">
+        <p14:section name="Anexo" id="{bf639c6f-7ef2-dafc-fa8f-c10d1c6a0430}">
           <p14:sldIdLst>
             <p14:sldId id="269"/>
           </p14:sldIdLst>
@@ -988,7 +988,7 @@
                 </a:solidFill>
                 <a:latin typeface="+mn-lt"/>
               </a:rPr>
-              <a:t>Votos PRM en la seccional (con 60 % de apoyo)</a:t>
+              <a:t>Votos duros para David Collado por escenario (60 % de apoyo)</a:t>
             </a:r>
           </a:p>
         </c:rich>
@@ -1012,7 +1012,7 @@
               <c:strCache>
                 <c:ptCount val="1"/>
                 <c:pt idx="0">
-                  <c:v>Votos PRM</c:v>
+                  <c:v>Votos duros</c:v>
                 </c:pt>
               </c:strCache>
             </c:strRef>
@@ -14125,7 +14125,7 @@
                   <a:schemeClr val="tx2"/>
                 </a:solidFill>
               </a:rPr>
-              <a:t>Resumen: con 8 zonas y una red de 4,000 votantes podemos superar en 10 % al PRM de 2024</a:t>
+              <a:t>Resumen: con 8 zonas y una red de 4,000 votantes, David Collado puede asegurar 5,760 votos duros en Pennsylvania</a:t>
             </a:r>
             <a:endParaRPr lang="en-US" sz="2800" dirty="0"/>
           </a:p>
@@ -14653,7 +14653,7 @@
                   <a:schemeClr val="tx1"/>
                 </a:solidFill>
               </a:rPr>
-              <a:t>5,760 votos para David Collado y el PRM (+10 % sobre 2024). Aun con desgaste, se logra con un 22 % de participación.</a:t>
+              <a:t>5,760 votos duros (seguros) para David Collado: un 10 % más que el PRM en 2024. El resultado final será mayor.</a:t>
             </a:r>
             <a:endParaRPr lang="en-US" sz="1500" dirty="0"/>
           </a:p>
@@ -14788,7 +14788,7 @@
                   <a:schemeClr val="accent4"/>
                 </a:solidFill>
               </a:rPr>
-              <a:t>Fuentes: Seccional PRM Pennsylvania (padrón electoral); JCE 2024; INDEX, Registro Sociodemográfico de los Dominicanos en el Exterior (5.ª edición, 2026). Meta PRM: estimación propia.</a:t>
+              <a:t>Fuentes: Seccional PRM Pennsylvania (padrón electoral); JCE 2024; INDEX, Registro Sociodemográfico de los Dominicanos en el Exterior (5.ª edición, 2026). Meta de voto duro: estimación propia.</a:t>
             </a:r>
             <a:endParaRPr lang="en-US" sz="1000" dirty="0"/>
           </a:p>
@@ -21447,7 +21447,7 @@
                   <a:schemeClr val="tx2"/>
                 </a:solidFill>
               </a:rPr>
-              <a:t>Aun con desgaste, superar en 10 % al PRM de 2024 es alcanzable: hace falta un 22 % de participación</a:t>
+              <a:t>Meta: 5,760 votos duros para David Collado, un 10 % más que el PRM en 2024; se logra aun con desgaste</a:t>
             </a:r>
             <a:endParaRPr lang="en-US" sz="2800" dirty="0"/>
           </a:p>
@@ -21461,7 +21461,7 @@
         </p:nvGraphicFramePr>
         <p:xfrm>
           <a:off x="548640" y="1600200"/>
-          <a:ext cx="6675120" cy="4251960"/>
+          <a:ext cx="6675120" cy="3794760"/>
         </p:xfrm>
         <a:graphic xmlns:a="http://schemas.openxmlformats.org/drawingml/2006/main">
           <a:graphicData uri="http://schemas.openxmlformats.org/drawingml/2006/chart">
@@ -21471,7 +21471,54 @@
       </p:graphicFrame>
       <p:sp>
         <p:nvSpPr>
-          <p:cNvPr id="4" name="Tres niveles"/>
+          <p:cNvPr id="4" name="Text 1"/>
+          <p:cNvSpPr txBox="1"/>
+          <p:nvPr/>
+        </p:nvSpPr>
+        <p:spPr>
+          <a:xfrm>
+            <a:off x="548640" y="5440680"/>
+            <a:ext cx="6675120" cy="411480"/>
+          </a:xfrm>
+          <a:prstGeom prst="rect">
+            <a:avLst/>
+          </a:prstGeom>
+          <a:noFill/>
+          <a:ln/>
+        </p:spPr>
+        <p:txBody>
+          <a:bodyPr wrap="square" lIns="0" tIns="0" rIns="0" bIns="0" rtlCol="0" anchor="ctr"/>
+          <a:lstStyle/>
+          <a:p>
+            <a:pPr indent="0" marL="0">
+              <a:buNone/>
+            </a:pPr>
+            <a:r>
+              <a:rPr lang="en-US" sz="1400" b="1" dirty="0">
+                <a:solidFill>
+                  <a:schemeClr val="accent2"/>
+                </a:solidFill>
+              </a:rPr>
+              <a:t>Voto duro: </a:t>
+            </a:r>
+            <a:pPr indent="0" marL="0">
+              <a:buNone/>
+            </a:pPr>
+            <a:r>
+              <a:rPr lang="en-US" sz="1400" dirty="0">
+                <a:solidFill>
+                  <a:schemeClr val="tx2"/>
+                </a:solidFill>
+              </a:rPr>
+              <a:t>los votos seguros con los que cuenta David Collado. El resultado final será mayor.</a:t>
+            </a:r>
+            <a:endParaRPr lang="en-US" sz="1400" dirty="0"/>
+          </a:p>
+        </p:txBody>
+      </p:sp>
+      <p:sp>
+        <p:nvSpPr>
+          <p:cNvPr id="5" name="Tres niveles"/>
           <p:cNvSpPr/>
           <p:nvPr/>
         </p:nvSpPr>
@@ -21498,7 +21545,7 @@
       </p:sp>
       <p:sp>
         <p:nvSpPr>
-          <p:cNvPr id="5" name="Text 2"/>
+          <p:cNvPr id="6" name="Text 3"/>
           <p:cNvSpPr txBox="1"/>
           <p:nvPr/>
         </p:nvSpPr>
@@ -21526,7 +21573,7 @@
                   <a:schemeClr val="tx2"/>
                 </a:solidFill>
               </a:rPr>
-              <a:t>Tres niveles de meta</a:t>
+              <a:t>Tres niveles de voto duro</a:t>
             </a:r>
             <a:endParaRPr lang="en-US" sz="1700" dirty="0"/>
           </a:p>
@@ -21534,7 +21581,7 @@
       </p:sp>
       <p:sp>
         <p:nvSpPr>
-          <p:cNvPr id="6" name="Text 3"/>
+          <p:cNvPr id="7" name="Text 4"/>
           <p:cNvSpPr txBox="1"/>
           <p:nvPr/>
         </p:nvSpPr>
@@ -21581,7 +21628,7 @@
       </p:sp>
       <p:sp>
         <p:nvSpPr>
-          <p:cNvPr id="7" name="Text 4"/>
+          <p:cNvPr id="8" name="Text 5"/>
           <p:cNvSpPr txBox="1"/>
           <p:nvPr/>
         </p:nvSpPr>
@@ -21617,7 +21664,7 @@
       </p:sp>
       <p:sp>
         <p:nvSpPr>
-          <p:cNvPr id="8" name="Text 5"/>
+          <p:cNvPr id="9" name="Text 6"/>
           <p:cNvSpPr txBox="1"/>
           <p:nvPr/>
         </p:nvSpPr>
@@ -21664,7 +21711,7 @@
       </p:sp>
       <p:sp>
         <p:nvSpPr>
-          <p:cNvPr id="9" name="Text 6"/>
+          <p:cNvPr id="10" name="Text 7"/>
           <p:cNvSpPr txBox="1"/>
           <p:nvPr/>
         </p:nvSpPr>
@@ -21700,7 +21747,7 @@
       </p:sp>
       <p:sp>
         <p:nvSpPr>
-          <p:cNvPr id="10" name="Text 7"/>
+          <p:cNvPr id="11" name="Text 8"/>
           <p:cNvSpPr txBox="1"/>
           <p:nvPr/>
         </p:nvSpPr>
@@ -21747,7 +21794,7 @@
       </p:sp>
       <p:sp>
         <p:nvSpPr>
-          <p:cNvPr id="11" name="Text 8"/>
+          <p:cNvPr id="12" name="Text 9"/>
           <p:cNvSpPr txBox="1"/>
           <p:nvPr/>
         </p:nvSpPr>
@@ -21783,7 +21830,7 @@
       </p:sp>
       <p:sp>
         <p:nvSpPr>
-          <p:cNvPr id="12" name="Desgaste"/>
+          <p:cNvPr id="13" name="Desgaste"/>
           <p:cNvSpPr/>
           <p:nvPr/>
         </p:nvSpPr>
@@ -21810,7 +21857,7 @@
       </p:sp>
       <p:sp>
         <p:nvSpPr>
-          <p:cNvPr id="13" name="Text 10"/>
+          <p:cNvPr id="14" name="Text 11"/>
           <p:cNvSpPr txBox="1"/>
           <p:nvPr/>
         </p:nvSpPr>
@@ -21838,7 +21885,7 @@
                   <a:schemeClr val="bg1"/>
                 </a:solidFill>
               </a:rPr>
-              <a:t>Si hay desgaste: participación necesaria para la meta</a:t>
+              <a:t>Si hay desgaste: participación necesaria para la meta de voto duro</a:t>
             </a:r>
             <a:endParaRPr lang="en-US" sz="1500" dirty="0"/>
           </a:p>
@@ -21846,7 +21893,7 @@
       </p:sp>
       <p:sp>
         <p:nvSpPr>
-          <p:cNvPr id="14" name="Text 11"/>
+          <p:cNvPr id="15" name="Text 12"/>
           <p:cNvSpPr txBox="1"/>
           <p:nvPr/>
         </p:nvSpPr>
@@ -21874,7 +21921,7 @@
                   <a:schemeClr val="accent4"/>
                 </a:solidFill>
               </a:rPr>
-              <a:t>Apoyo 60 % (igual que 2024)</a:t>
+              <a:t>Collado al 60 % (como 2024)</a:t>
             </a:r>
             <a:endParaRPr lang="en-US" sz="1300" dirty="0"/>
           </a:p>
@@ -21882,7 +21929,7 @@
       </p:sp>
       <p:sp>
         <p:nvSpPr>
-          <p:cNvPr id="15" name="Text 12"/>
+          <p:cNvPr id="16" name="Text 13"/>
           <p:cNvSpPr txBox="1"/>
           <p:nvPr/>
         </p:nvSpPr>
@@ -21918,7 +21965,7 @@
       </p:sp>
       <p:sp>
         <p:nvSpPr>
-          <p:cNvPr id="16" name="Text 13"/>
+          <p:cNvPr id="17" name="Text 14"/>
           <p:cNvSpPr txBox="1"/>
           <p:nvPr/>
         </p:nvSpPr>
@@ -21946,7 +21993,7 @@
                   <a:schemeClr val="bg1"/>
                 </a:solidFill>
               </a:rPr>
-              <a:t>Apoyo 55 % (desgaste moderado)</a:t>
+              <a:t>Collado al 55 % (desgaste)</a:t>
             </a:r>
             <a:endParaRPr lang="en-US" sz="1300" dirty="0"/>
           </a:p>
@@ -21954,7 +22001,7 @@
       </p:sp>
       <p:sp>
         <p:nvSpPr>
-          <p:cNvPr id="17" name="Text 14"/>
+          <p:cNvPr id="18" name="Text 15"/>
           <p:cNvSpPr txBox="1"/>
           <p:nvPr/>
         </p:nvSpPr>
@@ -21990,7 +22037,7 @@
       </p:sp>
       <p:sp>
         <p:nvSpPr>
-          <p:cNvPr id="18" name="Text 15"/>
+          <p:cNvPr id="19" name="Text 16"/>
           <p:cNvSpPr txBox="1"/>
           <p:nvPr/>
         </p:nvSpPr>
@@ -22018,7 +22065,7 @@
                   <a:schemeClr val="accent4"/>
                 </a:solidFill>
               </a:rPr>
-              <a:t>Apoyo 50 % (desgaste fuerte)</a:t>
+              <a:t>Collado al 50 % (desgaste fuerte)</a:t>
             </a:r>
             <a:endParaRPr lang="en-US" sz="1300" dirty="0"/>
           </a:p>
@@ -22026,7 +22073,7 @@
       </p:sp>
       <p:sp>
         <p:nvSpPr>
-          <p:cNvPr id="19" name="Text 16"/>
+          <p:cNvPr id="20" name="Text 17"/>
           <p:cNvSpPr txBox="1"/>
           <p:nvPr/>
         </p:nvSpPr>
@@ -22062,7 +22109,7 @@
       </p:sp>
       <p:sp>
         <p:nvSpPr>
-          <p:cNvPr id="20" name="Fuente"/>
+          <p:cNvPr id="21" name="Fuente"/>
           <p:cNvSpPr txBox="1"/>
           <p:nvPr/>
         </p:nvSpPr>
@@ -25363,7 +25410,7 @@
                   <a:schemeClr val="tx1"/>
                 </a:solidFill>
               </a:rPr>
-              <a:t>Si vota el 85 %, son unos 3,400 votos: el 59 % de la meta de 5,760.</a:t>
+              <a:t>Si vota el 85 %, son unos 3,400 votos: el 59 % de los 5,760 votos duros.</a:t>
             </a:r>
             <a:endParaRPr lang="en-US" sz="1600" dirty="0"/>
           </a:p>

</xml_diff>

<commit_message>
Retirar el concepto de voto duro; mantener el enfoque en David Collado
Co-Authored-By: Claude Opus 5.5 <noreply@anthropic.com>
Claude-Session: https://claude.ai/code/session_01RrEJtrwRidXxzgveZEVQjf
</commit_message>
<xml_diff>
--- a/presentaciones/Plan_Estrategico_Pennsylvania_2028.pptx
+++ b/presentaciones/Plan_Estrategico_Pennsylvania_2028.pptx
@@ -120,7 +120,7 @@
   <p:extLst>
     <p:ext uri="{521415D9-36F7-43E2-AB2F-B90AF26B5E84}">
       <p14:sectionLst xmlns:p14="http://schemas.microsoft.com/office/powerpoint/2010/main">
-        <p14:section name="Diagnóstico" id="{24cf3d5a-59df-fa7e-5544-4817be613350}">
+        <p14:section name="Diagnóstico" id="{5f7c6179-0ccd-ee92-eb5e-aa8125e40933}">
           <p14:sldIdLst>
             <p14:sldId id="256"/>
             <p14:sldId id="257"/>
@@ -129,19 +129,19 @@
             <p14:sldId id="260"/>
           </p14:sldIdLst>
         </p14:section>
-        <p14:section name="Desafíos" id="{4d118862-b4b2-11f5-5666-6e7d21e22eb8}">
+        <p14:section name="Desafíos" id="{fb1dcc8b-8448-3f86-5962-200b23868253}">
           <p14:sldIdLst>
             <p14:sldId id="261"/>
             <p14:sldId id="262"/>
           </p14:sldIdLst>
         </p14:section>
-        <p14:section name="Escenarios y meta" id="{d48dafbc-6617-8cd6-48db-5a96fb5ac7ec}">
+        <p14:section name="Escenarios y meta" id="{22cbdd03-1da5-736c-1b35-1928b8215e7e}">
           <p14:sldIdLst>
             <p14:sldId id="263"/>
             <p14:sldId id="264"/>
           </p14:sldIdLst>
         </p14:section>
-        <p14:section name="Plan y recomendación" id="{7ad80dd8-a57a-278b-9c99-ec2f365a4154}">
+        <p14:section name="Plan y recomendación" id="{a924a8c4-60c4-d519-2515-92934dd5028d}">
           <p14:sldIdLst>
             <p14:sldId id="265"/>
             <p14:sldId id="266"/>
@@ -149,7 +149,7 @@
             <p14:sldId id="268"/>
           </p14:sldIdLst>
         </p14:section>
-        <p14:section name="Anexo" id="{bf639c6f-7ef2-dafc-fa8f-c10d1c6a0430}">
+        <p14:section name="Anexo" id="{23ff2fb9-411f-0e9b-3321-070ec4eaa5c2}">
           <p14:sldIdLst>
             <p14:sldId id="269"/>
           </p14:sldIdLst>
@@ -988,7 +988,7 @@
                 </a:solidFill>
                 <a:latin typeface="+mn-lt"/>
               </a:rPr>
-              <a:t>Votos duros para David Collado por escenario (60 % de apoyo)</a:t>
+              <a:t>Votos para David Collado por escenario (60 % de apoyo)</a:t>
             </a:r>
           </a:p>
         </c:rich>
@@ -1012,7 +1012,7 @@
               <c:strCache>
                 <c:ptCount val="1"/>
                 <c:pt idx="0">
-                  <c:v>Votos duros</c:v>
+                  <c:v>Votos</c:v>
                 </c:pt>
               </c:strCache>
             </c:strRef>
@@ -14125,7 +14125,7 @@
                   <a:schemeClr val="tx2"/>
                 </a:solidFill>
               </a:rPr>
-              <a:t>Resumen: con 8 zonas y una red de 4,000 votantes, David Collado puede asegurar 5,760 votos duros en Pennsylvania</a:t>
+              <a:t>Resumen: con 8 zonas y una red de 4,000 votantes, David Collado puede superar en 10 % al PRM de 2024</a:t>
             </a:r>
             <a:endParaRPr lang="en-US" sz="2800" dirty="0"/>
           </a:p>
@@ -14653,7 +14653,7 @@
                   <a:schemeClr val="tx1"/>
                 </a:solidFill>
               </a:rPr>
-              <a:t>5,760 votos duros (seguros) para David Collado: un 10 % más que el PRM en 2024. El resultado final será mayor.</a:t>
+              <a:t>5,760 votos para David Collado: un 10 % más que el PRM en 2024. Aun con desgaste, se logra con un 22 % de participación.</a:t>
             </a:r>
             <a:endParaRPr lang="en-US" sz="1500" dirty="0"/>
           </a:p>
@@ -14788,7 +14788,7 @@
                   <a:schemeClr val="accent4"/>
                 </a:solidFill>
               </a:rPr>
-              <a:t>Fuentes: Seccional PRM Pennsylvania (padrón electoral); JCE 2024; INDEX, Registro Sociodemográfico de los Dominicanos en el Exterior (5.ª edición, 2026). Meta de voto duro: estimación propia.</a:t>
+              <a:t>Fuentes: Seccional PRM Pennsylvania (padrón electoral); JCE 2024; INDEX, Registro Sociodemográfico de los Dominicanos en el Exterior (5.ª edición, 2026). Meta: estimación propia.</a:t>
             </a:r>
             <a:endParaRPr lang="en-US" sz="1000" dirty="0"/>
           </a:p>
@@ -21447,7 +21447,7 @@
                   <a:schemeClr val="tx2"/>
                 </a:solidFill>
               </a:rPr>
-              <a:t>Meta: 5,760 votos duros para David Collado, un 10 % más que el PRM en 2024; se logra aun con desgaste</a:t>
+              <a:t>Meta: 5,760 votos para David Collado, un 10 % más que el PRM en 2024; se logra aun con desgaste</a:t>
             </a:r>
             <a:endParaRPr lang="en-US" sz="2800" dirty="0"/>
           </a:p>
@@ -21461,7 +21461,7 @@
         </p:nvGraphicFramePr>
         <p:xfrm>
           <a:off x="548640" y="1600200"/>
-          <a:ext cx="6675120" cy="3794760"/>
+          <a:ext cx="6675120" cy="4251960"/>
         </p:xfrm>
         <a:graphic xmlns:a="http://schemas.openxmlformats.org/drawingml/2006/main">
           <a:graphicData uri="http://schemas.openxmlformats.org/drawingml/2006/chart">
@@ -21471,54 +21471,7 @@
       </p:graphicFrame>
       <p:sp>
         <p:nvSpPr>
-          <p:cNvPr id="4" name="Text 1"/>
-          <p:cNvSpPr txBox="1"/>
-          <p:nvPr/>
-        </p:nvSpPr>
-        <p:spPr>
-          <a:xfrm>
-            <a:off x="548640" y="5440680"/>
-            <a:ext cx="6675120" cy="411480"/>
-          </a:xfrm>
-          <a:prstGeom prst="rect">
-            <a:avLst/>
-          </a:prstGeom>
-          <a:noFill/>
-          <a:ln/>
-        </p:spPr>
-        <p:txBody>
-          <a:bodyPr wrap="square" lIns="0" tIns="0" rIns="0" bIns="0" rtlCol="0" anchor="ctr"/>
-          <a:lstStyle/>
-          <a:p>
-            <a:pPr indent="0" marL="0">
-              <a:buNone/>
-            </a:pPr>
-            <a:r>
-              <a:rPr lang="en-US" sz="1400" b="1" dirty="0">
-                <a:solidFill>
-                  <a:schemeClr val="accent2"/>
-                </a:solidFill>
-              </a:rPr>
-              <a:t>Voto duro: </a:t>
-            </a:r>
-            <a:pPr indent="0" marL="0">
-              <a:buNone/>
-            </a:pPr>
-            <a:r>
-              <a:rPr lang="en-US" sz="1400" dirty="0">
-                <a:solidFill>
-                  <a:schemeClr val="tx2"/>
-                </a:solidFill>
-              </a:rPr>
-              <a:t>los votos seguros con los que cuenta David Collado. El resultado final será mayor.</a:t>
-            </a:r>
-            <a:endParaRPr lang="en-US" sz="1400" dirty="0"/>
-          </a:p>
-        </p:txBody>
-      </p:sp>
-      <p:sp>
-        <p:nvSpPr>
-          <p:cNvPr id="5" name="Tres niveles"/>
+          <p:cNvPr id="4" name="Tres niveles"/>
           <p:cNvSpPr/>
           <p:nvPr/>
         </p:nvSpPr>
@@ -21545,7 +21498,7 @@
       </p:sp>
       <p:sp>
         <p:nvSpPr>
-          <p:cNvPr id="6" name="Text 3"/>
+          <p:cNvPr id="5" name="Text 2"/>
           <p:cNvSpPr txBox="1"/>
           <p:nvPr/>
         </p:nvSpPr>
@@ -21573,7 +21526,7 @@
                   <a:schemeClr val="tx2"/>
                 </a:solidFill>
               </a:rPr>
-              <a:t>Tres niveles de voto duro</a:t>
+              <a:t>Tres niveles de meta</a:t>
             </a:r>
             <a:endParaRPr lang="en-US" sz="1700" dirty="0"/>
           </a:p>
@@ -21581,7 +21534,7 @@
       </p:sp>
       <p:sp>
         <p:nvSpPr>
-          <p:cNvPr id="7" name="Text 4"/>
+          <p:cNvPr id="6" name="Text 3"/>
           <p:cNvSpPr txBox="1"/>
           <p:nvPr/>
         </p:nvSpPr>
@@ -21628,7 +21581,7 @@
       </p:sp>
       <p:sp>
         <p:nvSpPr>
-          <p:cNvPr id="8" name="Text 5"/>
+          <p:cNvPr id="7" name="Text 4"/>
           <p:cNvSpPr txBox="1"/>
           <p:nvPr/>
         </p:nvSpPr>
@@ -21664,7 +21617,7 @@
       </p:sp>
       <p:sp>
         <p:nvSpPr>
-          <p:cNvPr id="9" name="Text 6"/>
+          <p:cNvPr id="8" name="Text 5"/>
           <p:cNvSpPr txBox="1"/>
           <p:nvPr/>
         </p:nvSpPr>
@@ -21711,7 +21664,7 @@
       </p:sp>
       <p:sp>
         <p:nvSpPr>
-          <p:cNvPr id="10" name="Text 7"/>
+          <p:cNvPr id="9" name="Text 6"/>
           <p:cNvSpPr txBox="1"/>
           <p:nvPr/>
         </p:nvSpPr>
@@ -21747,7 +21700,7 @@
       </p:sp>
       <p:sp>
         <p:nvSpPr>
-          <p:cNvPr id="11" name="Text 8"/>
+          <p:cNvPr id="10" name="Text 7"/>
           <p:cNvSpPr txBox="1"/>
           <p:nvPr/>
         </p:nvSpPr>
@@ -21794,7 +21747,7 @@
       </p:sp>
       <p:sp>
         <p:nvSpPr>
-          <p:cNvPr id="12" name="Text 9"/>
+          <p:cNvPr id="11" name="Text 8"/>
           <p:cNvSpPr txBox="1"/>
           <p:nvPr/>
         </p:nvSpPr>
@@ -21830,7 +21783,7 @@
       </p:sp>
       <p:sp>
         <p:nvSpPr>
-          <p:cNvPr id="13" name="Desgaste"/>
+          <p:cNvPr id="12" name="Desgaste"/>
           <p:cNvSpPr/>
           <p:nvPr/>
         </p:nvSpPr>
@@ -21857,7 +21810,7 @@
       </p:sp>
       <p:sp>
         <p:nvSpPr>
-          <p:cNvPr id="14" name="Text 11"/>
+          <p:cNvPr id="13" name="Text 10"/>
           <p:cNvSpPr txBox="1"/>
           <p:nvPr/>
         </p:nvSpPr>
@@ -21885,7 +21838,7 @@
                   <a:schemeClr val="bg1"/>
                 </a:solidFill>
               </a:rPr>
-              <a:t>Si hay desgaste: participación necesaria para la meta de voto duro</a:t>
+              <a:t>Si hay desgaste: participación necesaria para la meta</a:t>
             </a:r>
             <a:endParaRPr lang="en-US" sz="1500" dirty="0"/>
           </a:p>
@@ -21893,7 +21846,7 @@
       </p:sp>
       <p:sp>
         <p:nvSpPr>
-          <p:cNvPr id="15" name="Text 12"/>
+          <p:cNvPr id="14" name="Text 11"/>
           <p:cNvSpPr txBox="1"/>
           <p:nvPr/>
         </p:nvSpPr>
@@ -21929,7 +21882,7 @@
       </p:sp>
       <p:sp>
         <p:nvSpPr>
-          <p:cNvPr id="16" name="Text 13"/>
+          <p:cNvPr id="15" name="Text 12"/>
           <p:cNvSpPr txBox="1"/>
           <p:nvPr/>
         </p:nvSpPr>
@@ -21965,7 +21918,7 @@
       </p:sp>
       <p:sp>
         <p:nvSpPr>
-          <p:cNvPr id="17" name="Text 14"/>
+          <p:cNvPr id="16" name="Text 13"/>
           <p:cNvSpPr txBox="1"/>
           <p:nvPr/>
         </p:nvSpPr>
@@ -22001,7 +21954,7 @@
       </p:sp>
       <p:sp>
         <p:nvSpPr>
-          <p:cNvPr id="18" name="Text 15"/>
+          <p:cNvPr id="17" name="Text 14"/>
           <p:cNvSpPr txBox="1"/>
           <p:nvPr/>
         </p:nvSpPr>
@@ -22037,7 +21990,7 @@
       </p:sp>
       <p:sp>
         <p:nvSpPr>
-          <p:cNvPr id="19" name="Text 16"/>
+          <p:cNvPr id="18" name="Text 15"/>
           <p:cNvSpPr txBox="1"/>
           <p:nvPr/>
         </p:nvSpPr>
@@ -22073,7 +22026,7 @@
       </p:sp>
       <p:sp>
         <p:nvSpPr>
-          <p:cNvPr id="20" name="Text 17"/>
+          <p:cNvPr id="19" name="Text 16"/>
           <p:cNvSpPr txBox="1"/>
           <p:nvPr/>
         </p:nvSpPr>
@@ -22109,7 +22062,7 @@
       </p:sp>
       <p:sp>
         <p:nvSpPr>
-          <p:cNvPr id="21" name="Fuente"/>
+          <p:cNvPr id="20" name="Fuente"/>
           <p:cNvSpPr txBox="1"/>
           <p:nvPr/>
         </p:nvSpPr>
@@ -25410,7 +25363,7 @@
                   <a:schemeClr val="tx1"/>
                 </a:solidFill>
               </a:rPr>
-              <a:t>Si vota el 85 %, son unos 3,400 votos: el 59 % de los 5,760 votos duros.</a:t>
+              <a:t>Si vota el 85 %, son unos 3,400 votos: el 59 % de la meta de 5,760.</a:t>
             </a:r>
             <a:endParaRPr lang="en-US" sz="1600" dirty="0"/>
           </a:p>

</xml_diff>

<commit_message>
Diapositiva 6: resultados 2024 completos por ciudad, ordenados por % PRM y aliados
Co-Authored-By: Claude Opus 5.5 <noreply@anthropic.com>
Claude-Session: https://claude.ai/code/session_01RrEJtrwRidXxzgveZEVQjf
</commit_message>
<xml_diff>
--- a/presentaciones/Plan_Estrategico_Pennsylvania_2028.pptx
+++ b/presentaciones/Plan_Estrategico_Pennsylvania_2028.pptx
@@ -117,7 +117,7 @@
   <p:extLst>
     <p:ext uri="{521415D9-36F7-43E2-AB2F-B90AF26B5E84}">
       <p14:sectionLst xmlns:p14="http://schemas.microsoft.com/office/powerpoint/2010/main">
-        <p14:section name="Diagnóstico" id="{df868450-7c26-051f-c578-407b9cf1feda}">
+        <p14:section name="Diagnóstico" id="{29ab36e9-6177-1e27-ae16-2ad65d4040ed}">
           <p14:sldIdLst>
             <p14:sldId id="256"/>
             <p14:sldId id="257"/>
@@ -125,22 +125,22 @@
             <p14:sldId id="259"/>
           </p14:sldIdLst>
         </p14:section>
-        <p14:section name="Riesgos" id="{c2e40342-826d-3503-1a3c-cb99cd36d6b6}">
+        <p14:section name="Riesgos" id="{916991ab-a37d-e001-8087-196b577aa99f}">
           <p14:sldIdLst>
             <p14:sldId id="260"/>
           </p14:sldIdLst>
         </p14:section>
-        <p14:section name="Resultados 2024" id="{a829add8-3249-6426-d561-9d59701628fc}">
+        <p14:section name="Resultados 2024" id="{0b2f8f5e-db70-a417-50f7-0444627bc5d0}">
           <p14:sldIdLst>
             <p14:sldId id="261"/>
           </p14:sldIdLst>
         </p14:section>
-        <p14:section name="Meta" id="{c2b8580d-ea55-3fff-ff8e-511f27398f6b}">
+        <p14:section name="Meta" id="{9e33115e-a9ac-6f32-7e0a-f6a385d96de4}">
           <p14:sldIdLst>
             <p14:sldId id="262"/>
           </p14:sldIdLst>
         </p14:section>
-        <p14:section name="Plan y recomendación" id="{dce2b17e-dfaf-f6f4-d4ad-607d10ebf479}">
+        <p14:section name="Plan y recomendación" id="{b4153145-0b6e-b1d7-936b-2fa6b04c78ca}">
           <p14:sldIdLst>
             <p14:sldId id="263"/>
             <p14:sldId id="264"/>
@@ -12000,7 +12000,7 @@
                   <a:schemeClr val="tx2"/>
                 </a:solidFill>
               </a:rPr>
-              <a:t>En 2024 el PRM y aliados ganaron en las 8 zonas; Reading es donde menos apoyo tuvo y Kensington donde menos se votó</a:t>
+              <a:t>En 2024 el PRM y aliados ganaron en las 11 ciudades; Reading, con el 18 % del padrón, quedó entre las de menor apoyo</a:t>
             </a:r>
             <a:endParaRPr lang="en-US" sz="2800" dirty="0"/>
           </a:p>
@@ -12021,7 +12021,7 @@
           </p:nvPr>
         </p:nvGraphicFramePr>
         <p:xfrm>
-          <a:off x="548640" y="1600200"/>
+          <a:off x="548640" y="1554480"/>
           <a:ext cx="7680960" cy="914400"/>
         </p:xfrm>
         <a:graphic>
@@ -12029,14 +12029,14 @@
             <a:tbl>
               <a:tblPr/>
               <a:tblGrid>
-                <a:gridCol w="2743200"/>
+                <a:gridCol w="2103120"/>
+                <a:gridCol w="1051560"/>
                 <a:gridCol w="960120"/>
-                <a:gridCol w="868680"/>
-                <a:gridCol w="1143000"/>
-                <a:gridCol w="1005840"/>
-                <a:gridCol w="960120"/>
+                <a:gridCol w="1234440"/>
+                <a:gridCol w="1234440"/>
+                <a:gridCol w="1097280"/>
               </a:tblGrid>
-              <a:tr h="420624">
+              <a:tr h="324612">
                 <a:tc>
                   <a:txBody>
                     <a:bodyPr/>
@@ -12046,14 +12046,14 @@
                         <a:buNone/>
                       </a:pPr>
                       <a:r>
-                        <a:rPr lang="en-US" sz="1300" b="1" dirty="0">
+                        <a:rPr lang="en-US" sz="1200" b="1" dirty="0">
                           <a:solidFill>
                             <a:schemeClr val="bg1"/>
                           </a:solidFill>
                         </a:rPr>
-                        <a:t>Zona</a:t>
+                        <a:t>Ciudad</a:t>
                       </a:r>
-                      <a:endParaRPr lang="en-US" sz="1300" dirty="0"/>
+                      <a:endParaRPr lang="en-US" sz="1200" dirty="0"/>
                     </a:p>
                   </a:txBody>
                   <a:tcPr marL="73152" marR="73152" marT="0" marB="0" anchor="ctr">
@@ -12107,14 +12107,14 @@
                         <a:buNone/>
                       </a:pPr>
                       <a:r>
-                        <a:rPr lang="en-US" sz="1300" b="1" dirty="0">
+                        <a:rPr lang="en-US" sz="1200" b="1" dirty="0">
                           <a:solidFill>
                             <a:schemeClr val="bg1"/>
                           </a:solidFill>
                         </a:rPr>
                         <a:t>Electores</a:t>
                       </a:r>
-                      <a:endParaRPr lang="en-US" sz="1300" dirty="0"/>
+                      <a:endParaRPr lang="en-US" sz="1200" dirty="0"/>
                     </a:p>
                   </a:txBody>
                   <a:tcPr marL="73152" marR="73152" marT="0" marB="0" anchor="ctr">
@@ -12168,14 +12168,14 @@
                         <a:buNone/>
                       </a:pPr>
                       <a:r>
-                        <a:rPr lang="en-US" sz="1300" b="1" dirty="0">
+                        <a:rPr lang="en-US" sz="1200" b="1" dirty="0">
                           <a:solidFill>
                             <a:schemeClr val="bg1"/>
                           </a:solidFill>
                         </a:rPr>
                         <a:t>Votaron</a:t>
                       </a:r>
-                      <a:endParaRPr lang="en-US" sz="1300" dirty="0"/>
+                      <a:endParaRPr lang="en-US" sz="1200" dirty="0"/>
                     </a:p>
                   </a:txBody>
                   <a:tcPr marL="73152" marR="73152" marT="0" marB="0" anchor="ctr">
@@ -12229,14 +12229,14 @@
                         <a:buNone/>
                       </a:pPr>
                       <a:r>
-                        <a:rPr lang="en-US" sz="1300" b="1" dirty="0">
+                        <a:rPr lang="en-US" sz="1200" b="1" dirty="0">
                           <a:solidFill>
                             <a:schemeClr val="bg1"/>
                           </a:solidFill>
                         </a:rPr>
                         <a:t>Participación</a:t>
                       </a:r>
-                      <a:endParaRPr lang="en-US" sz="1300" dirty="0"/>
+                      <a:endParaRPr lang="en-US" sz="1200" dirty="0"/>
                     </a:p>
                   </a:txBody>
                   <a:tcPr marL="73152" marR="73152" marT="0" marB="0" anchor="ctr">
@@ -12290,14 +12290,14 @@
                         <a:buNone/>
                       </a:pPr>
                       <a:r>
-                        <a:rPr lang="en-US" sz="1300" b="1" dirty="0">
+                        <a:rPr lang="en-US" sz="1200" b="1" dirty="0">
                           <a:solidFill>
                             <a:schemeClr val="bg1"/>
                           </a:solidFill>
                         </a:rPr>
                         <a:t>PRM y aliados</a:t>
                       </a:r>
-                      <a:endParaRPr lang="en-US" sz="1300" dirty="0"/>
+                      <a:endParaRPr lang="en-US" sz="1200" dirty="0"/>
                     </a:p>
                   </a:txBody>
                   <a:tcPr marL="73152" marR="73152" marT="0" marB="0" anchor="ctr">
@@ -12351,14 +12351,14 @@
                         <a:buNone/>
                       </a:pPr>
                       <a:r>
-                        <a:rPr lang="en-US" sz="1300" b="1" dirty="0">
+                        <a:rPr lang="en-US" sz="1200" b="1" dirty="0">
                           <a:solidFill>
                             <a:schemeClr val="bg1"/>
                           </a:solidFill>
                         </a:rPr>
                         <a:t>% PRM y al.</a:t>
                       </a:r>
-                      <a:endParaRPr lang="en-US" sz="1300" dirty="0"/>
+                      <a:endParaRPr lang="en-US" sz="1200" dirty="0"/>
                     </a:p>
                   </a:txBody>
                   <a:tcPr marL="73152" marR="73152" marT="0" marB="0" anchor="ctr">
@@ -12404,7 +12404,7 @@
                   </a:tcPr>
                 </a:tc>
               </a:tr>
-              <a:tr h="420624">
+              <a:tr h="324612">
                 <a:tc>
                   <a:txBody>
                     <a:bodyPr/>
@@ -12414,14 +12414,14 @@
                         <a:buNone/>
                       </a:pPr>
                       <a:r>
-                        <a:rPr lang="en-US" sz="1300" dirty="0">
+                        <a:rPr lang="en-US" sz="1200" dirty="0">
                           <a:solidFill>
                             <a:schemeClr val="tx1"/>
                           </a:solidFill>
                         </a:rPr>
-                        <a:t>Philadelphia Noreste</a:t>
+                        <a:t>Wilkes-Barre</a:t>
                       </a:r>
-                      <a:endParaRPr lang="en-US" sz="1300" dirty="0"/>
+                      <a:endParaRPr lang="en-US" sz="1200" dirty="0"/>
                     </a:p>
                   </a:txBody>
                   <a:tcPr marL="73152" marR="73152" marT="0" marB="0" anchor="ctr">
@@ -12472,14 +12472,14 @@
                         <a:buNone/>
                       </a:pPr>
                       <a:r>
-                        <a:rPr lang="en-US" sz="1300" dirty="0">
+                        <a:rPr lang="en-US" sz="1200" dirty="0">
                           <a:solidFill>
                             <a:schemeClr val="tx1"/>
                           </a:solidFill>
                         </a:rPr>
-                        <a:t>9,649</a:t>
+                        <a:t>1,319</a:t>
                       </a:r>
-                      <a:endParaRPr lang="en-US" sz="1300" dirty="0"/>
+                      <a:endParaRPr lang="en-US" sz="1200" dirty="0"/>
                     </a:p>
                   </a:txBody>
                   <a:tcPr marL="73152" marR="73152" marT="0" marB="0" anchor="ctr">
@@ -12530,14 +12530,14 @@
                         <a:buNone/>
                       </a:pPr>
                       <a:r>
-                        <a:rPr lang="en-US" sz="1300" dirty="0">
+                        <a:rPr lang="en-US" sz="1200" dirty="0">
                           <a:solidFill>
                             <a:schemeClr val="tx1"/>
                           </a:solidFill>
                         </a:rPr>
-                        <a:t>1,810</a:t>
+                        <a:t>178</a:t>
                       </a:r>
-                      <a:endParaRPr lang="en-US" sz="1300" dirty="0"/>
+                      <a:endParaRPr lang="en-US" sz="1200" dirty="0"/>
                     </a:p>
                   </a:txBody>
                   <a:tcPr marL="73152" marR="73152" marT="0" marB="0" anchor="ctr">
@@ -12588,14 +12588,14 @@
                         <a:buNone/>
                       </a:pPr>
                       <a:r>
-                        <a:rPr lang="en-US" sz="1300" dirty="0">
+                        <a:rPr lang="en-US" sz="1200" b="1" dirty="0">
                           <a:solidFill>
-                            <a:schemeClr val="tx1"/>
+                            <a:schemeClr val="accent2"/>
                           </a:solidFill>
                         </a:rPr>
-                        <a:t>18.8 %</a:t>
+                        <a:t>13.5 %</a:t>
                       </a:r>
-                      <a:endParaRPr lang="en-US" sz="1300" dirty="0"/>
+                      <a:endParaRPr lang="en-US" sz="1200" dirty="0"/>
                     </a:p>
                   </a:txBody>
                   <a:tcPr marL="73152" marR="73152" marT="0" marB="0" anchor="ctr">
@@ -12646,14 +12646,14 @@
                         <a:buNone/>
                       </a:pPr>
                       <a:r>
-                        <a:rPr lang="en-US" sz="1300" dirty="0">
+                        <a:rPr lang="en-US" sz="1200" dirty="0">
                           <a:solidFill>
                             <a:schemeClr val="tx1"/>
                           </a:solidFill>
                         </a:rPr>
-                        <a:t>1,164</a:t>
+                        <a:t>121</a:t>
                       </a:r>
-                      <a:endParaRPr lang="en-US" sz="1300" dirty="0"/>
+                      <a:endParaRPr lang="en-US" sz="1200" dirty="0"/>
                     </a:p>
                   </a:txBody>
                   <a:tcPr marL="73152" marR="73152" marT="0" marB="0" anchor="ctr">
@@ -12704,14 +12704,14 @@
                         <a:buNone/>
                       </a:pPr>
                       <a:r>
-                        <a:rPr lang="en-US" sz="1300" dirty="0">
+                        <a:rPr lang="en-US" sz="1200" dirty="0">
                           <a:solidFill>
                             <a:schemeClr val="tx1"/>
                           </a:solidFill>
                         </a:rPr>
-                        <a:t>64.9 %</a:t>
+                        <a:t>68.0 %</a:t>
                       </a:r>
-                      <a:endParaRPr lang="en-US" sz="1300" dirty="0"/>
+                      <a:endParaRPr lang="en-US" sz="1200" dirty="0"/>
                     </a:p>
                   </a:txBody>
                   <a:tcPr marL="73152" marR="73152" marT="0" marB="0" anchor="ctr">
@@ -12754,7 +12754,7 @@
                   </a:tcPr>
                 </a:tc>
               </a:tr>
-              <a:tr h="420624">
+              <a:tr h="324612">
                 <a:tc>
                   <a:txBody>
                     <a:bodyPr/>
@@ -12764,14 +12764,14 @@
                         <a:buNone/>
                       </a:pPr>
                       <a:r>
-                        <a:rPr lang="en-US" sz="1300" dirty="0">
+                        <a:rPr lang="en-US" sz="1200" dirty="0">
                           <a:solidFill>
                             <a:schemeClr val="tx1"/>
                           </a:solidFill>
                         </a:rPr>
-                        <a:t>Philadelphia Kensington</a:t>
+                        <a:t>Wilmington</a:t>
                       </a:r>
-                      <a:endParaRPr lang="en-US" sz="1300" dirty="0"/>
+                      <a:endParaRPr lang="en-US" sz="1200" dirty="0"/>
                     </a:p>
                   </a:txBody>
                   <a:tcPr marL="73152" marR="73152" marT="0" marB="0" anchor="ctr">
@@ -12822,14 +12822,14 @@
                         <a:buNone/>
                       </a:pPr>
                       <a:r>
-                        <a:rPr lang="en-US" sz="1300" dirty="0">
+                        <a:rPr lang="en-US" sz="1200" dirty="0">
                           <a:solidFill>
                             <a:schemeClr val="tx1"/>
                           </a:solidFill>
                         </a:rPr>
-                        <a:t>6,588</a:t>
+                        <a:t>1,004</a:t>
                       </a:r>
-                      <a:endParaRPr lang="en-US" sz="1300" dirty="0"/>
+                      <a:endParaRPr lang="en-US" sz="1200" dirty="0"/>
                     </a:p>
                   </a:txBody>
                   <a:tcPr marL="73152" marR="73152" marT="0" marB="0" anchor="ctr">
@@ -12880,14 +12880,14 @@
                         <a:buNone/>
                       </a:pPr>
                       <a:r>
-                        <a:rPr lang="en-US" sz="1300" dirty="0">
+                        <a:rPr lang="en-US" sz="1200" dirty="0">
                           <a:solidFill>
                             <a:schemeClr val="tx1"/>
                           </a:solidFill>
                         </a:rPr>
-                        <a:t>1,113</a:t>
+                        <a:t>171</a:t>
                       </a:r>
-                      <a:endParaRPr lang="en-US" sz="1300" dirty="0"/>
+                      <a:endParaRPr lang="en-US" sz="1200" dirty="0"/>
                     </a:p>
                   </a:txBody>
                   <a:tcPr marL="73152" marR="73152" marT="0" marB="0" anchor="ctr">
@@ -12938,14 +12938,14 @@
                         <a:buNone/>
                       </a:pPr>
                       <a:r>
-                        <a:rPr lang="en-US" sz="1300" b="1" dirty="0">
+                        <a:rPr lang="en-US" sz="1200" dirty="0">
                           <a:solidFill>
-                            <a:schemeClr val="accent2"/>
+                            <a:schemeClr val="tx1"/>
                           </a:solidFill>
                         </a:rPr>
-                        <a:t>16.9 %</a:t>
+                        <a:t>17.0 %</a:t>
                       </a:r>
-                      <a:endParaRPr lang="en-US" sz="1300" dirty="0"/>
+                      <a:endParaRPr lang="en-US" sz="1200" dirty="0"/>
                     </a:p>
                   </a:txBody>
                   <a:tcPr marL="73152" marR="73152" marT="0" marB="0" anchor="ctr">
@@ -12996,14 +12996,14 @@
                         <a:buNone/>
                       </a:pPr>
                       <a:r>
-                        <a:rPr lang="en-US" sz="1300" dirty="0">
+                        <a:rPr lang="en-US" sz="1200" dirty="0">
                           <a:solidFill>
                             <a:schemeClr val="tx1"/>
                           </a:solidFill>
                         </a:rPr>
-                        <a:t>722</a:t>
+                        <a:t>110</a:t>
                       </a:r>
-                      <a:endParaRPr lang="en-US" sz="1300" dirty="0"/>
+                      <a:endParaRPr lang="en-US" sz="1200" dirty="0"/>
                     </a:p>
                   </a:txBody>
                   <a:tcPr marL="73152" marR="73152" marT="0" marB="0" anchor="ctr">
@@ -13054,14 +13054,14 @@
                         <a:buNone/>
                       </a:pPr>
                       <a:r>
-                        <a:rPr lang="en-US" sz="1300" dirty="0">
+                        <a:rPr lang="en-US" sz="1200" dirty="0">
                           <a:solidFill>
                             <a:schemeClr val="tx1"/>
                           </a:solidFill>
                         </a:rPr>
-                        <a:t>65.8 %</a:t>
+                        <a:t>65.9 %</a:t>
                       </a:r>
-                      <a:endParaRPr lang="en-US" sz="1300" dirty="0"/>
+                      <a:endParaRPr lang="en-US" sz="1200" dirty="0"/>
                     </a:p>
                   </a:txBody>
                   <a:tcPr marL="73152" marR="73152" marT="0" marB="0" anchor="ctr">
@@ -13104,7 +13104,7 @@
                   </a:tcPr>
                 </a:tc>
               </a:tr>
-              <a:tr h="420624">
+              <a:tr h="324612">
                 <a:tc>
                   <a:txBody>
                     <a:bodyPr/>
@@ -13114,14 +13114,14 @@
                         <a:buNone/>
                       </a:pPr>
                       <a:r>
-                        <a:rPr lang="en-US" sz="1300" dirty="0">
+                        <a:rPr lang="en-US" sz="1200" dirty="0">
                           <a:solidFill>
                             <a:schemeClr val="tx1"/>
                           </a:solidFill>
                         </a:rPr>
-                        <a:t>Reading</a:t>
+                        <a:t>Hazleton</a:t>
                       </a:r>
-                      <a:endParaRPr lang="en-US" sz="1300" dirty="0"/>
+                      <a:endParaRPr lang="en-US" sz="1200" dirty="0"/>
                     </a:p>
                   </a:txBody>
                   <a:tcPr marL="73152" marR="73152" marT="0" marB="0" anchor="ctr">
@@ -13172,14 +13172,14 @@
                         <a:buNone/>
                       </a:pPr>
                       <a:r>
-                        <a:rPr lang="en-US" sz="1300" dirty="0">
+                        <a:rPr lang="en-US" sz="1200" dirty="0">
                           <a:solidFill>
                             <a:schemeClr val="tx1"/>
                           </a:solidFill>
                         </a:rPr>
-                        <a:t>8,368</a:t>
+                        <a:t>6,520</a:t>
                       </a:r>
-                      <a:endParaRPr lang="en-US" sz="1300" dirty="0"/>
+                      <a:endParaRPr lang="en-US" sz="1200" dirty="0"/>
                     </a:p>
                   </a:txBody>
                   <a:tcPr marL="73152" marR="73152" marT="0" marB="0" anchor="ctr">
@@ -13230,14 +13230,14 @@
                         <a:buNone/>
                       </a:pPr>
                       <a:r>
-                        <a:rPr lang="en-US" sz="1300" dirty="0">
+                        <a:rPr lang="en-US" sz="1200" dirty="0">
                           <a:solidFill>
                             <a:schemeClr val="tx1"/>
                           </a:solidFill>
                         </a:rPr>
-                        <a:t>1,577</a:t>
+                        <a:t>1,159</a:t>
                       </a:r>
-                      <a:endParaRPr lang="en-US" sz="1300" dirty="0"/>
+                      <a:endParaRPr lang="en-US" sz="1200" dirty="0"/>
                     </a:p>
                   </a:txBody>
                   <a:tcPr marL="73152" marR="73152" marT="0" marB="0" anchor="ctr">
@@ -13288,14 +13288,14 @@
                         <a:buNone/>
                       </a:pPr>
                       <a:r>
-                        <a:rPr lang="en-US" sz="1300" dirty="0">
+                        <a:rPr lang="en-US" sz="1200" dirty="0">
                           <a:solidFill>
                             <a:schemeClr val="tx1"/>
                           </a:solidFill>
                         </a:rPr>
-                        <a:t>18.8 %</a:t>
+                        <a:t>17.8 %</a:t>
                       </a:r>
-                      <a:endParaRPr lang="en-US" sz="1300" dirty="0"/>
+                      <a:endParaRPr lang="en-US" sz="1200" dirty="0"/>
                     </a:p>
                   </a:txBody>
                   <a:tcPr marL="73152" marR="73152" marT="0" marB="0" anchor="ctr">
@@ -13346,14 +13346,14 @@
                         <a:buNone/>
                       </a:pPr>
                       <a:r>
-                        <a:rPr lang="en-US" sz="1300" dirty="0">
+                        <a:rPr lang="en-US" sz="1200" dirty="0">
                           <a:solidFill>
                             <a:schemeClr val="tx1"/>
                           </a:solidFill>
                         </a:rPr>
-                        <a:t>918</a:t>
+                        <a:t>749</a:t>
                       </a:r>
-                      <a:endParaRPr lang="en-US" sz="1300" dirty="0"/>
+                      <a:endParaRPr lang="en-US" sz="1200" dirty="0"/>
                     </a:p>
                   </a:txBody>
                   <a:tcPr marL="73152" marR="73152" marT="0" marB="0" anchor="ctr">
@@ -13404,14 +13404,14 @@
                         <a:buNone/>
                       </a:pPr>
                       <a:r>
-                        <a:rPr lang="en-US" sz="1300" b="1" dirty="0">
+                        <a:rPr lang="en-US" sz="1200" dirty="0">
                           <a:solidFill>
-                            <a:schemeClr val="accent2"/>
+                            <a:schemeClr val="tx1"/>
                           </a:solidFill>
                         </a:rPr>
-                        <a:t>59.5 %</a:t>
+                        <a:t>65.6 %</a:t>
                       </a:r>
-                      <a:endParaRPr lang="en-US" sz="1300" dirty="0"/>
+                      <a:endParaRPr lang="en-US" sz="1200" dirty="0"/>
                     </a:p>
                   </a:txBody>
                   <a:tcPr marL="73152" marR="73152" marT="0" marB="0" anchor="ctr">
@@ -13454,7 +13454,7 @@
                   </a:tcPr>
                 </a:tc>
               </a:tr>
-              <a:tr h="420624">
+              <a:tr h="324612">
                 <a:tc>
                   <a:txBody>
                     <a:bodyPr/>
@@ -13464,14 +13464,14 @@
                         <a:buNone/>
                       </a:pPr>
                       <a:r>
-                        <a:rPr lang="en-US" sz="1300" dirty="0">
+                        <a:rPr lang="en-US" sz="1200" dirty="0">
                           <a:solidFill>
                             <a:schemeClr val="tx1"/>
                           </a:solidFill>
                         </a:rPr>
-                        <a:t>Allentown</a:t>
+                        <a:t>Philadelphia</a:t>
                       </a:r>
-                      <a:endParaRPr lang="en-US" sz="1300" dirty="0"/>
+                      <a:endParaRPr lang="en-US" sz="1200" dirty="0"/>
                     </a:p>
                   </a:txBody>
                   <a:tcPr marL="73152" marR="73152" marT="0" marB="0" anchor="ctr">
@@ -13522,14 +13522,14 @@
                         <a:buNone/>
                       </a:pPr>
                       <a:r>
-                        <a:rPr lang="en-US" sz="1300" dirty="0">
+                        <a:rPr lang="en-US" sz="1200" dirty="0">
                           <a:solidFill>
                             <a:schemeClr val="tx1"/>
                           </a:solidFill>
                         </a:rPr>
-                        <a:t>8,183</a:t>
+                        <a:t>16,237</a:t>
                       </a:r>
-                      <a:endParaRPr lang="en-US" sz="1300" dirty="0"/>
+                      <a:endParaRPr lang="en-US" sz="1200" dirty="0"/>
                     </a:p>
                   </a:txBody>
                   <a:tcPr marL="73152" marR="73152" marT="0" marB="0" anchor="ctr">
@@ -13580,14 +13580,14 @@
                         <a:buNone/>
                       </a:pPr>
                       <a:r>
-                        <a:rPr lang="en-US" sz="1300" dirty="0">
+                        <a:rPr lang="en-US" sz="1200" dirty="0">
                           <a:solidFill>
                             <a:schemeClr val="tx1"/>
                           </a:solidFill>
                         </a:rPr>
-                        <a:t>1,697</a:t>
+                        <a:t>2,923</a:t>
                       </a:r>
-                      <a:endParaRPr lang="en-US" sz="1300" dirty="0"/>
+                      <a:endParaRPr lang="en-US" sz="1200" dirty="0"/>
                     </a:p>
                   </a:txBody>
                   <a:tcPr marL="73152" marR="73152" marT="0" marB="0" anchor="ctr">
@@ -13638,14 +13638,14 @@
                         <a:buNone/>
                       </a:pPr>
                       <a:r>
-                        <a:rPr lang="en-US" sz="1300" dirty="0">
+                        <a:rPr lang="en-US" sz="1200" dirty="0">
                           <a:solidFill>
                             <a:schemeClr val="tx1"/>
                           </a:solidFill>
                         </a:rPr>
-                        <a:t>20.7 %</a:t>
+                        <a:t>18.0 %</a:t>
                       </a:r>
-                      <a:endParaRPr lang="en-US" sz="1300" dirty="0"/>
+                      <a:endParaRPr lang="en-US" sz="1200" dirty="0"/>
                     </a:p>
                   </a:txBody>
                   <a:tcPr marL="73152" marR="73152" marT="0" marB="0" anchor="ctr">
@@ -13696,14 +13696,14 @@
                         <a:buNone/>
                       </a:pPr>
                       <a:r>
-                        <a:rPr lang="en-US" sz="1300" dirty="0">
+                        <a:rPr lang="en-US" sz="1200" dirty="0">
                           <a:solidFill>
                             <a:schemeClr val="tx1"/>
                           </a:solidFill>
                         </a:rPr>
-                        <a:t>1,059</a:t>
+                        <a:t>1,886</a:t>
                       </a:r>
-                      <a:endParaRPr lang="en-US" sz="1300" dirty="0"/>
+                      <a:endParaRPr lang="en-US" sz="1200" dirty="0"/>
                     </a:p>
                   </a:txBody>
                   <a:tcPr marL="73152" marR="73152" marT="0" marB="0" anchor="ctr">
@@ -13754,14 +13754,14 @@
                         <a:buNone/>
                       </a:pPr>
                       <a:r>
-                        <a:rPr lang="en-US" sz="1300" dirty="0">
+                        <a:rPr lang="en-US" sz="1200" dirty="0">
                           <a:solidFill>
                             <a:schemeClr val="tx1"/>
                           </a:solidFill>
                         </a:rPr>
-                        <a:t>63.0 %</a:t>
+                        <a:t>65.2 %</a:t>
                       </a:r>
-                      <a:endParaRPr lang="en-US" sz="1300" dirty="0"/>
+                      <a:endParaRPr lang="en-US" sz="1200" dirty="0"/>
                     </a:p>
                   </a:txBody>
                   <a:tcPr marL="73152" marR="73152" marT="0" marB="0" anchor="ctr">
@@ -13804,7 +13804,7 @@
                   </a:tcPr>
                 </a:tc>
               </a:tr>
-              <a:tr h="420624">
+              <a:tr h="324612">
                 <a:tc>
                   <a:txBody>
                     <a:bodyPr/>
@@ -13814,14 +13814,14 @@
                         <a:buNone/>
                       </a:pPr>
                       <a:r>
-                        <a:rPr lang="en-US" sz="1300" dirty="0">
+                        <a:rPr lang="en-US" sz="1200" dirty="0">
                           <a:solidFill>
                             <a:schemeClr val="tx1"/>
                           </a:solidFill>
                         </a:rPr>
-                        <a:t>Hazleton</a:t>
+                        <a:t>Harrisburg</a:t>
                       </a:r>
-                      <a:endParaRPr lang="en-US" sz="1300" dirty="0"/>
+                      <a:endParaRPr lang="en-US" sz="1200" dirty="0"/>
                     </a:p>
                   </a:txBody>
                   <a:tcPr marL="73152" marR="73152" marT="0" marB="0" anchor="ctr">
@@ -13872,14 +13872,14 @@
                         <a:buNone/>
                       </a:pPr>
                       <a:r>
-                        <a:rPr lang="en-US" sz="1300" dirty="0">
+                        <a:rPr lang="en-US" sz="1200" dirty="0">
                           <a:solidFill>
                             <a:schemeClr val="tx1"/>
                           </a:solidFill>
                         </a:rPr>
-                        <a:t>6,520</a:t>
+                        <a:t>1,670</a:t>
                       </a:r>
-                      <a:endParaRPr lang="en-US" sz="1300" dirty="0"/>
+                      <a:endParaRPr lang="en-US" sz="1200" dirty="0"/>
                     </a:p>
                   </a:txBody>
                   <a:tcPr marL="73152" marR="73152" marT="0" marB="0" anchor="ctr">
@@ -13930,14 +13930,14 @@
                         <a:buNone/>
                       </a:pPr>
                       <a:r>
-                        <a:rPr lang="en-US" sz="1300" dirty="0">
+                        <a:rPr lang="en-US" sz="1200" dirty="0">
                           <a:solidFill>
                             <a:schemeClr val="tx1"/>
                           </a:solidFill>
                         </a:rPr>
-                        <a:t>1,159</a:t>
+                        <a:t>227</a:t>
                       </a:r>
-                      <a:endParaRPr lang="en-US" sz="1300" dirty="0"/>
+                      <a:endParaRPr lang="en-US" sz="1200" dirty="0"/>
                     </a:p>
                   </a:txBody>
                   <a:tcPr marL="73152" marR="73152" marT="0" marB="0" anchor="ctr">
@@ -13988,14 +13988,14 @@
                         <a:buNone/>
                       </a:pPr>
                       <a:r>
-                        <a:rPr lang="en-US" sz="1300" dirty="0">
+                        <a:rPr lang="en-US" sz="1200" b="1" dirty="0">
                           <a:solidFill>
-                            <a:schemeClr val="tx1"/>
+                            <a:schemeClr val="accent2"/>
                           </a:solidFill>
                         </a:rPr>
-                        <a:t>17.8 %</a:t>
+                        <a:t>13.6 %</a:t>
                       </a:r>
-                      <a:endParaRPr lang="en-US" sz="1300" dirty="0"/>
+                      <a:endParaRPr lang="en-US" sz="1200" dirty="0"/>
                     </a:p>
                   </a:txBody>
                   <a:tcPr marL="73152" marR="73152" marT="0" marB="0" anchor="ctr">
@@ -14046,14 +14046,14 @@
                         <a:buNone/>
                       </a:pPr>
                       <a:r>
-                        <a:rPr lang="en-US" sz="1300" dirty="0">
+                        <a:rPr lang="en-US" sz="1200" dirty="0">
                           <a:solidFill>
                             <a:schemeClr val="tx1"/>
                           </a:solidFill>
                         </a:rPr>
-                        <a:t>749</a:t>
+                        <a:t>144</a:t>
                       </a:r>
-                      <a:endParaRPr lang="en-US" sz="1300" dirty="0"/>
+                      <a:endParaRPr lang="en-US" sz="1200" dirty="0"/>
                     </a:p>
                   </a:txBody>
                   <a:tcPr marL="73152" marR="73152" marT="0" marB="0" anchor="ctr">
@@ -14104,14 +14104,14 @@
                         <a:buNone/>
                       </a:pPr>
                       <a:r>
-                        <a:rPr lang="en-US" sz="1300" dirty="0">
+                        <a:rPr lang="en-US" sz="1200" dirty="0">
                           <a:solidFill>
                             <a:schemeClr val="tx1"/>
                           </a:solidFill>
                         </a:rPr>
-                        <a:t>65.6 %</a:t>
+                        <a:t>63.7 %</a:t>
                       </a:r>
-                      <a:endParaRPr lang="en-US" sz="1300" dirty="0"/>
+                      <a:endParaRPr lang="en-US" sz="1200" dirty="0"/>
                     </a:p>
                   </a:txBody>
                   <a:tcPr marL="73152" marR="73152" marT="0" marB="0" anchor="ctr">
@@ -14154,7 +14154,7 @@
                   </a:tcPr>
                 </a:tc>
               </a:tr>
-              <a:tr h="420624">
+              <a:tr h="324612">
                 <a:tc>
                   <a:txBody>
                     <a:bodyPr/>
@@ -14164,14 +14164,14 @@
                         <a:buNone/>
                       </a:pPr>
                       <a:r>
-                        <a:rPr lang="en-US" sz="1300" dirty="0">
+                        <a:rPr lang="en-US" sz="1200" dirty="0">
                           <a:solidFill>
                             <a:schemeClr val="tx1"/>
                           </a:solidFill>
                         </a:rPr>
-                        <a:t>Wilkes-Barre y Scranton</a:t>
+                        <a:t>Allentown</a:t>
                       </a:r>
-                      <a:endParaRPr lang="en-US" sz="1300" dirty="0"/>
+                      <a:endParaRPr lang="en-US" sz="1200" dirty="0"/>
                     </a:p>
                   </a:txBody>
                   <a:tcPr marL="73152" marR="73152" marT="0" marB="0" anchor="ctr">
@@ -14222,14 +14222,14 @@
                         <a:buNone/>
                       </a:pPr>
                       <a:r>
-                        <a:rPr lang="en-US" sz="1300" dirty="0">
+                        <a:rPr lang="en-US" sz="1200" dirty="0">
                           <a:solidFill>
                             <a:schemeClr val="tx1"/>
                           </a:solidFill>
                         </a:rPr>
-                        <a:t>1,767</a:t>
+                        <a:t>8,183</a:t>
                       </a:r>
-                      <a:endParaRPr lang="en-US" sz="1300" dirty="0"/>
+                      <a:endParaRPr lang="en-US" sz="1200" dirty="0"/>
                     </a:p>
                   </a:txBody>
                   <a:tcPr marL="73152" marR="73152" marT="0" marB="0" anchor="ctr">
@@ -14280,14 +14280,14 @@
                         <a:buNone/>
                       </a:pPr>
                       <a:r>
-                        <a:rPr lang="en-US" sz="1300" dirty="0">
+                        <a:rPr lang="en-US" sz="1200" dirty="0">
                           <a:solidFill>
                             <a:schemeClr val="tx1"/>
                           </a:solidFill>
                         </a:rPr>
-                        <a:t>271</a:t>
+                        <a:t>1,697</a:t>
                       </a:r>
-                      <a:endParaRPr lang="en-US" sz="1300" dirty="0"/>
+                      <a:endParaRPr lang="en-US" sz="1200" dirty="0"/>
                     </a:p>
                   </a:txBody>
                   <a:tcPr marL="73152" marR="73152" marT="0" marB="0" anchor="ctr">
@@ -14338,14 +14338,14 @@
                         <a:buNone/>
                       </a:pPr>
                       <a:r>
-                        <a:rPr lang="en-US" sz="1300" b="1" dirty="0">
+                        <a:rPr lang="en-US" sz="1200" dirty="0">
                           <a:solidFill>
-                            <a:schemeClr val="accent2"/>
+                            <a:schemeClr val="tx1"/>
                           </a:solidFill>
                         </a:rPr>
-                        <a:t>15.3 %</a:t>
+                        <a:t>20.7 %</a:t>
                       </a:r>
-                      <a:endParaRPr lang="en-US" sz="1300" dirty="0"/>
+                      <a:endParaRPr lang="en-US" sz="1200" dirty="0"/>
                     </a:p>
                   </a:txBody>
                   <a:tcPr marL="73152" marR="73152" marT="0" marB="0" anchor="ctr">
@@ -14396,14 +14396,14 @@
                         <a:buNone/>
                       </a:pPr>
                       <a:r>
-                        <a:rPr lang="en-US" sz="1300" dirty="0">
+                        <a:rPr lang="en-US" sz="1200" dirty="0">
                           <a:solidFill>
                             <a:schemeClr val="tx1"/>
                           </a:solidFill>
                         </a:rPr>
-                        <a:t>165</a:t>
+                        <a:t>1,059</a:t>
                       </a:r>
-                      <a:endParaRPr lang="en-US" sz="1300" dirty="0"/>
+                      <a:endParaRPr lang="en-US" sz="1200" dirty="0"/>
                     </a:p>
                   </a:txBody>
                   <a:tcPr marL="73152" marR="73152" marT="0" marB="0" anchor="ctr">
@@ -14454,14 +14454,14 @@
                         <a:buNone/>
                       </a:pPr>
                       <a:r>
-                        <a:rPr lang="en-US" sz="1300" dirty="0">
+                        <a:rPr lang="en-US" sz="1200" dirty="0">
                           <a:solidFill>
                             <a:schemeClr val="tx1"/>
                           </a:solidFill>
                         </a:rPr>
-                        <a:t>63.5 %</a:t>
+                        <a:t>63.0 %</a:t>
                       </a:r>
-                      <a:endParaRPr lang="en-US" sz="1300" dirty="0"/>
+                      <a:endParaRPr lang="en-US" sz="1200" dirty="0"/>
                     </a:p>
                   </a:txBody>
                   <a:tcPr marL="73152" marR="73152" marT="0" marB="0" anchor="ctr">
@@ -14504,7 +14504,7 @@
                   </a:tcPr>
                 </a:tc>
               </a:tr>
-              <a:tr h="420624">
+              <a:tr h="324612">
                 <a:tc>
                   <a:txBody>
                     <a:bodyPr/>
@@ -14514,14 +14514,14 @@
                         <a:buNone/>
                       </a:pPr>
                       <a:r>
-                        <a:rPr lang="en-US" sz="1300" dirty="0">
+                        <a:rPr lang="en-US" sz="1200" dirty="0">
                           <a:solidFill>
                             <a:schemeClr val="tx1"/>
                           </a:solidFill>
                         </a:rPr>
-                        <a:t>Harrisburg, Lancaster, York y Lebanon</a:t>
+                        <a:t>Lancaster</a:t>
                       </a:r>
-                      <a:endParaRPr lang="en-US" sz="1300" dirty="0"/>
+                      <a:endParaRPr lang="en-US" sz="1200" dirty="0"/>
                     </a:p>
                   </a:txBody>
                   <a:tcPr marL="73152" marR="73152" marT="0" marB="0" anchor="ctr">
@@ -14572,14 +14572,14 @@
                         <a:buNone/>
                       </a:pPr>
                       <a:r>
-                        <a:rPr lang="en-US" sz="1300" dirty="0">
+                        <a:rPr lang="en-US" sz="1200" dirty="0">
                           <a:solidFill>
                             <a:schemeClr val="tx1"/>
                           </a:solidFill>
                         </a:rPr>
-                        <a:t>5,450</a:t>
+                        <a:t>1,767</a:t>
                       </a:r>
-                      <a:endParaRPr lang="en-US" sz="1300" dirty="0"/>
+                      <a:endParaRPr lang="en-US" sz="1200" dirty="0"/>
                     </a:p>
                   </a:txBody>
                   <a:tcPr marL="73152" marR="73152" marT="0" marB="0" anchor="ctr">
@@ -14630,14 +14630,14 @@
                         <a:buNone/>
                       </a:pPr>
                       <a:r>
-                        <a:rPr lang="en-US" sz="1300" dirty="0">
+                        <a:rPr lang="en-US" sz="1200" dirty="0">
                           <a:solidFill>
                             <a:schemeClr val="tx1"/>
                           </a:solidFill>
                         </a:rPr>
-                        <a:t>1,141</a:t>
+                        <a:t>520</a:t>
                       </a:r>
-                      <a:endParaRPr lang="en-US" sz="1300" dirty="0"/>
+                      <a:endParaRPr lang="en-US" sz="1200" dirty="0"/>
                     </a:p>
                   </a:txBody>
                   <a:tcPr marL="73152" marR="73152" marT="0" marB="0" anchor="ctr">
@@ -14688,14 +14688,14 @@
                         <a:buNone/>
                       </a:pPr>
                       <a:r>
-                        <a:rPr lang="en-US" sz="1300" dirty="0">
+                        <a:rPr lang="en-US" sz="1200" dirty="0">
                           <a:solidFill>
                             <a:schemeClr val="tx1"/>
                           </a:solidFill>
                         </a:rPr>
-                        <a:t>20.9 %</a:t>
+                        <a:t>29.4 %</a:t>
                       </a:r>
-                      <a:endParaRPr lang="en-US" sz="1300" dirty="0"/>
+                      <a:endParaRPr lang="en-US" sz="1200" dirty="0"/>
                     </a:p>
                   </a:txBody>
                   <a:tcPr marL="73152" marR="73152" marT="0" marB="0" anchor="ctr">
@@ -14746,14 +14746,14 @@
                         <a:buNone/>
                       </a:pPr>
                       <a:r>
-                        <a:rPr lang="en-US" sz="1300" dirty="0">
+                        <a:rPr lang="en-US" sz="1200" dirty="0">
                           <a:solidFill>
                             <a:schemeClr val="tx1"/>
                           </a:solidFill>
                         </a:rPr>
-                        <a:t>694</a:t>
+                        <a:t>318</a:t>
                       </a:r>
-                      <a:endParaRPr lang="en-US" sz="1300" dirty="0"/>
+                      <a:endParaRPr lang="en-US" sz="1200" dirty="0"/>
                     </a:p>
                   </a:txBody>
                   <a:tcPr marL="73152" marR="73152" marT="0" marB="0" anchor="ctr">
@@ -14804,14 +14804,14 @@
                         <a:buNone/>
                       </a:pPr>
                       <a:r>
-                        <a:rPr lang="en-US" sz="1300" dirty="0">
+                        <a:rPr lang="en-US" sz="1200" dirty="0">
                           <a:solidFill>
                             <a:schemeClr val="tx1"/>
                           </a:solidFill>
                         </a:rPr>
-                        <a:t>61.6 %</a:t>
+                        <a:t>62.0 %</a:t>
                       </a:r>
-                      <a:endParaRPr lang="en-US" sz="1300" dirty="0"/>
+                      <a:endParaRPr lang="en-US" sz="1200" dirty="0"/>
                     </a:p>
                   </a:txBody>
                   <a:tcPr marL="73152" marR="73152" marT="0" marB="0" anchor="ctr">
@@ -14854,7 +14854,7 @@
                   </a:tcPr>
                 </a:tc>
               </a:tr>
-              <a:tr h="420624">
+              <a:tr h="324612">
                 <a:tc>
                   <a:txBody>
                     <a:bodyPr/>
@@ -14864,14 +14864,14 @@
                         <a:buNone/>
                       </a:pPr>
                       <a:r>
-                        <a:rPr lang="en-US" sz="1300" dirty="0">
+                        <a:rPr lang="en-US" sz="1200" dirty="0">
                           <a:solidFill>
                             <a:schemeClr val="tx1"/>
                           </a:solidFill>
                         </a:rPr>
-                        <a:t>Wilmington</a:t>
+                        <a:t>Lebanon</a:t>
                       </a:r>
-                      <a:endParaRPr lang="en-US" sz="1300" dirty="0"/>
+                      <a:endParaRPr lang="en-US" sz="1200" dirty="0"/>
                     </a:p>
                   </a:txBody>
                   <a:tcPr marL="73152" marR="73152" marT="0" marB="0" anchor="ctr">
@@ -14922,14 +14922,14 @@
                         <a:buNone/>
                       </a:pPr>
                       <a:r>
-                        <a:rPr lang="en-US" sz="1300" dirty="0">
+                        <a:rPr lang="en-US" sz="1200" dirty="0">
                           <a:solidFill>
                             <a:schemeClr val="tx1"/>
                           </a:solidFill>
                         </a:rPr>
-                        <a:t>1,004</a:t>
+                        <a:t>789</a:t>
                       </a:r>
-                      <a:endParaRPr lang="en-US" sz="1300" dirty="0"/>
+                      <a:endParaRPr lang="en-US" sz="1200" dirty="0"/>
                     </a:p>
                   </a:txBody>
                   <a:tcPr marL="73152" marR="73152" marT="0" marB="0" anchor="ctr">
@@ -14980,14 +14980,14 @@
                         <a:buNone/>
                       </a:pPr>
                       <a:r>
-                        <a:rPr lang="en-US" sz="1300" dirty="0">
+                        <a:rPr lang="en-US" sz="1200" dirty="0">
                           <a:solidFill>
                             <a:schemeClr val="tx1"/>
                           </a:solidFill>
                         </a:rPr>
-                        <a:t>171</a:t>
+                        <a:t>174</a:t>
                       </a:r>
-                      <a:endParaRPr lang="en-US" sz="1300" dirty="0"/>
+                      <a:endParaRPr lang="en-US" sz="1200" dirty="0"/>
                     </a:p>
                   </a:txBody>
                   <a:tcPr marL="73152" marR="73152" marT="0" marB="0" anchor="ctr">
@@ -15038,14 +15038,14 @@
                         <a:buNone/>
                       </a:pPr>
                       <a:r>
-                        <a:rPr lang="en-US" sz="1300" dirty="0">
+                        <a:rPr lang="en-US" sz="1200" dirty="0">
                           <a:solidFill>
                             <a:schemeClr val="tx1"/>
                           </a:solidFill>
                         </a:rPr>
-                        <a:t>17.0 %</a:t>
+                        <a:t>22.1 %</a:t>
                       </a:r>
-                      <a:endParaRPr lang="en-US" sz="1300" dirty="0"/>
+                      <a:endParaRPr lang="en-US" sz="1200" dirty="0"/>
                     </a:p>
                   </a:txBody>
                   <a:tcPr marL="73152" marR="73152" marT="0" marB="0" anchor="ctr">
@@ -15096,14 +15096,14 @@
                         <a:buNone/>
                       </a:pPr>
                       <a:r>
-                        <a:rPr lang="en-US" sz="1300" dirty="0">
+                        <a:rPr lang="en-US" sz="1200" dirty="0">
                           <a:solidFill>
                             <a:schemeClr val="tx1"/>
                           </a:solidFill>
                         </a:rPr>
-                        <a:t>110</a:t>
+                        <a:t>103</a:t>
                       </a:r>
-                      <a:endParaRPr lang="en-US" sz="1300" dirty="0"/>
+                      <a:endParaRPr lang="en-US" sz="1200" dirty="0"/>
                     </a:p>
                   </a:txBody>
                   <a:tcPr marL="73152" marR="73152" marT="0" marB="0" anchor="ctr">
@@ -15154,14 +15154,14 @@
                         <a:buNone/>
                       </a:pPr>
                       <a:r>
-                        <a:rPr lang="en-US" sz="1300" dirty="0">
+                        <a:rPr lang="en-US" sz="1200" dirty="0">
                           <a:solidFill>
                             <a:schemeClr val="tx1"/>
                           </a:solidFill>
                         </a:rPr>
-                        <a:t>65.9 %</a:t>
+                        <a:t>60.2 %</a:t>
                       </a:r>
-                      <a:endParaRPr lang="en-US" sz="1300" dirty="0"/>
+                      <a:endParaRPr lang="en-US" sz="1200" dirty="0"/>
                     </a:p>
                   </a:txBody>
                   <a:tcPr marL="73152" marR="73152" marT="0" marB="0" anchor="ctr">
@@ -15204,7 +15204,7 @@
                   </a:tcPr>
                 </a:tc>
               </a:tr>
-              <a:tr h="420624">
+              <a:tr h="324612">
                 <a:tc>
                   <a:txBody>
                     <a:bodyPr/>
@@ -15214,14 +15214,1064 @@
                         <a:buNone/>
                       </a:pPr>
                       <a:r>
-                        <a:rPr lang="en-US" sz="1300" b="1" dirty="0">
+                        <a:rPr lang="en-US" sz="1200" dirty="0">
+                          <a:solidFill>
+                            <a:schemeClr val="tx1"/>
+                          </a:solidFill>
+                        </a:rPr>
+                        <a:t>York</a:t>
+                      </a:r>
+                      <a:endParaRPr lang="en-US" sz="1200" dirty="0"/>
+                    </a:p>
+                  </a:txBody>
+                  <a:tcPr marL="73152" marR="73152" marT="0" marB="0" anchor="ctr">
+                    <a:lnL w="9525" cap="flat" cmpd="sng" algn="ctr">
+                      <a:solidFill>
+                        <a:srgbClr val="EEF2F8"/>
+                      </a:solidFill>
+                      <a:prstDash val="solid"/>
+                      <a:round/>
+                      <a:headEnd type="none" w="med" len="med"/>
+                      <a:tailEnd type="none" w="med" len="med"/>
+                    </a:lnL>
+                    <a:lnR w="9525" cap="flat" cmpd="sng" algn="ctr">
+                      <a:solidFill>
+                        <a:srgbClr val="EEF2F8"/>
+                      </a:solidFill>
+                      <a:prstDash val="solid"/>
+                      <a:round/>
+                      <a:headEnd type="none" w="med" len="med"/>
+                      <a:tailEnd type="none" w="med" len="med"/>
+                    </a:lnR>
+                    <a:lnT w="9525" cap="flat" cmpd="sng" algn="ctr">
+                      <a:solidFill>
+                        <a:srgbClr val="EEF2F8"/>
+                      </a:solidFill>
+                      <a:prstDash val="solid"/>
+                      <a:round/>
+                      <a:headEnd type="none" w="med" len="med"/>
+                      <a:tailEnd type="none" w="med" len="med"/>
+                    </a:lnT>
+                    <a:lnB w="9525" cap="flat" cmpd="sng" algn="ctr">
+                      <a:solidFill>
+                        <a:srgbClr val="EEF2F8"/>
+                      </a:solidFill>
+                      <a:prstDash val="solid"/>
+                      <a:round/>
+                      <a:headEnd type="none" w="med" len="med"/>
+                      <a:tailEnd type="none" w="med" len="med"/>
+                    </a:lnB>
+                  </a:tcPr>
+                </a:tc>
+                <a:tc>
+                  <a:txBody>
+                    <a:bodyPr/>
+                    <a:lstStyle/>
+                    <a:p>
+                      <a:pPr algn="r" indent="0" marL="0">
+                        <a:buNone/>
+                      </a:pPr>
+                      <a:r>
+                        <a:rPr lang="en-US" sz="1200" dirty="0">
+                          <a:solidFill>
+                            <a:schemeClr val="tx1"/>
+                          </a:solidFill>
+                        </a:rPr>
+                        <a:t>1,224</a:t>
+                      </a:r>
+                      <a:endParaRPr lang="en-US" sz="1200" dirty="0"/>
+                    </a:p>
+                  </a:txBody>
+                  <a:tcPr marL="73152" marR="73152" marT="0" marB="0" anchor="ctr">
+                    <a:lnL w="9525" cap="flat" cmpd="sng" algn="ctr">
+                      <a:solidFill>
+                        <a:srgbClr val="EEF2F8"/>
+                      </a:solidFill>
+                      <a:prstDash val="solid"/>
+                      <a:round/>
+                      <a:headEnd type="none" w="med" len="med"/>
+                      <a:tailEnd type="none" w="med" len="med"/>
+                    </a:lnL>
+                    <a:lnR w="9525" cap="flat" cmpd="sng" algn="ctr">
+                      <a:solidFill>
+                        <a:srgbClr val="EEF2F8"/>
+                      </a:solidFill>
+                      <a:prstDash val="solid"/>
+                      <a:round/>
+                      <a:headEnd type="none" w="med" len="med"/>
+                      <a:tailEnd type="none" w="med" len="med"/>
+                    </a:lnR>
+                    <a:lnT w="9525" cap="flat" cmpd="sng" algn="ctr">
+                      <a:solidFill>
+                        <a:srgbClr val="EEF2F8"/>
+                      </a:solidFill>
+                      <a:prstDash val="solid"/>
+                      <a:round/>
+                      <a:headEnd type="none" w="med" len="med"/>
+                      <a:tailEnd type="none" w="med" len="med"/>
+                    </a:lnT>
+                    <a:lnB w="9525" cap="flat" cmpd="sng" algn="ctr">
+                      <a:solidFill>
+                        <a:srgbClr val="EEF2F8"/>
+                      </a:solidFill>
+                      <a:prstDash val="solid"/>
+                      <a:round/>
+                      <a:headEnd type="none" w="med" len="med"/>
+                      <a:tailEnd type="none" w="med" len="med"/>
+                    </a:lnB>
+                  </a:tcPr>
+                </a:tc>
+                <a:tc>
+                  <a:txBody>
+                    <a:bodyPr/>
+                    <a:lstStyle/>
+                    <a:p>
+                      <a:pPr algn="r" indent="0" marL="0">
+                        <a:buNone/>
+                      </a:pPr>
+                      <a:r>
+                        <a:rPr lang="en-US" sz="1200" dirty="0">
+                          <a:solidFill>
+                            <a:schemeClr val="tx1"/>
+                          </a:solidFill>
+                        </a:rPr>
+                        <a:t>220</a:t>
+                      </a:r>
+                      <a:endParaRPr lang="en-US" sz="1200" dirty="0"/>
+                    </a:p>
+                  </a:txBody>
+                  <a:tcPr marL="73152" marR="73152" marT="0" marB="0" anchor="ctr">
+                    <a:lnL w="9525" cap="flat" cmpd="sng" algn="ctr">
+                      <a:solidFill>
+                        <a:srgbClr val="EEF2F8"/>
+                      </a:solidFill>
+                      <a:prstDash val="solid"/>
+                      <a:round/>
+                      <a:headEnd type="none" w="med" len="med"/>
+                      <a:tailEnd type="none" w="med" len="med"/>
+                    </a:lnL>
+                    <a:lnR w="9525" cap="flat" cmpd="sng" algn="ctr">
+                      <a:solidFill>
+                        <a:srgbClr val="EEF2F8"/>
+                      </a:solidFill>
+                      <a:prstDash val="solid"/>
+                      <a:round/>
+                      <a:headEnd type="none" w="med" len="med"/>
+                      <a:tailEnd type="none" w="med" len="med"/>
+                    </a:lnR>
+                    <a:lnT w="9525" cap="flat" cmpd="sng" algn="ctr">
+                      <a:solidFill>
+                        <a:srgbClr val="EEF2F8"/>
+                      </a:solidFill>
+                      <a:prstDash val="solid"/>
+                      <a:round/>
+                      <a:headEnd type="none" w="med" len="med"/>
+                      <a:tailEnd type="none" w="med" len="med"/>
+                    </a:lnT>
+                    <a:lnB w="9525" cap="flat" cmpd="sng" algn="ctr">
+                      <a:solidFill>
+                        <a:srgbClr val="EEF2F8"/>
+                      </a:solidFill>
+                      <a:prstDash val="solid"/>
+                      <a:round/>
+                      <a:headEnd type="none" w="med" len="med"/>
+                      <a:tailEnd type="none" w="med" len="med"/>
+                    </a:lnB>
+                  </a:tcPr>
+                </a:tc>
+                <a:tc>
+                  <a:txBody>
+                    <a:bodyPr/>
+                    <a:lstStyle/>
+                    <a:p>
+                      <a:pPr algn="r" indent="0" marL="0">
+                        <a:buNone/>
+                      </a:pPr>
+                      <a:r>
+                        <a:rPr lang="en-US" sz="1200" dirty="0">
+                          <a:solidFill>
+                            <a:schemeClr val="tx1"/>
+                          </a:solidFill>
+                        </a:rPr>
+                        <a:t>18.0 %</a:t>
+                      </a:r>
+                      <a:endParaRPr lang="en-US" sz="1200" dirty="0"/>
+                    </a:p>
+                  </a:txBody>
+                  <a:tcPr marL="73152" marR="73152" marT="0" marB="0" anchor="ctr">
+                    <a:lnL w="9525" cap="flat" cmpd="sng" algn="ctr">
+                      <a:solidFill>
+                        <a:srgbClr val="EEF2F8"/>
+                      </a:solidFill>
+                      <a:prstDash val="solid"/>
+                      <a:round/>
+                      <a:headEnd type="none" w="med" len="med"/>
+                      <a:tailEnd type="none" w="med" len="med"/>
+                    </a:lnL>
+                    <a:lnR w="9525" cap="flat" cmpd="sng" algn="ctr">
+                      <a:solidFill>
+                        <a:srgbClr val="EEF2F8"/>
+                      </a:solidFill>
+                      <a:prstDash val="solid"/>
+                      <a:round/>
+                      <a:headEnd type="none" w="med" len="med"/>
+                      <a:tailEnd type="none" w="med" len="med"/>
+                    </a:lnR>
+                    <a:lnT w="9525" cap="flat" cmpd="sng" algn="ctr">
+                      <a:solidFill>
+                        <a:srgbClr val="EEF2F8"/>
+                      </a:solidFill>
+                      <a:prstDash val="solid"/>
+                      <a:round/>
+                      <a:headEnd type="none" w="med" len="med"/>
+                      <a:tailEnd type="none" w="med" len="med"/>
+                    </a:lnT>
+                    <a:lnB w="9525" cap="flat" cmpd="sng" algn="ctr">
+                      <a:solidFill>
+                        <a:srgbClr val="EEF2F8"/>
+                      </a:solidFill>
+                      <a:prstDash val="solid"/>
+                      <a:round/>
+                      <a:headEnd type="none" w="med" len="med"/>
+                      <a:tailEnd type="none" w="med" len="med"/>
+                    </a:lnB>
+                  </a:tcPr>
+                </a:tc>
+                <a:tc>
+                  <a:txBody>
+                    <a:bodyPr/>
+                    <a:lstStyle/>
+                    <a:p>
+                      <a:pPr algn="r" indent="0" marL="0">
+                        <a:buNone/>
+                      </a:pPr>
+                      <a:r>
+                        <a:rPr lang="en-US" sz="1200" dirty="0">
+                          <a:solidFill>
+                            <a:schemeClr val="tx1"/>
+                          </a:solidFill>
+                        </a:rPr>
+                        <a:t>129</a:t>
+                      </a:r>
+                      <a:endParaRPr lang="en-US" sz="1200" dirty="0"/>
+                    </a:p>
+                  </a:txBody>
+                  <a:tcPr marL="73152" marR="73152" marT="0" marB="0" anchor="ctr">
+                    <a:lnL w="9525" cap="flat" cmpd="sng" algn="ctr">
+                      <a:solidFill>
+                        <a:srgbClr val="EEF2F8"/>
+                      </a:solidFill>
+                      <a:prstDash val="solid"/>
+                      <a:round/>
+                      <a:headEnd type="none" w="med" len="med"/>
+                      <a:tailEnd type="none" w="med" len="med"/>
+                    </a:lnL>
+                    <a:lnR w="9525" cap="flat" cmpd="sng" algn="ctr">
+                      <a:solidFill>
+                        <a:srgbClr val="EEF2F8"/>
+                      </a:solidFill>
+                      <a:prstDash val="solid"/>
+                      <a:round/>
+                      <a:headEnd type="none" w="med" len="med"/>
+                      <a:tailEnd type="none" w="med" len="med"/>
+                    </a:lnR>
+                    <a:lnT w="9525" cap="flat" cmpd="sng" algn="ctr">
+                      <a:solidFill>
+                        <a:srgbClr val="EEF2F8"/>
+                      </a:solidFill>
+                      <a:prstDash val="solid"/>
+                      <a:round/>
+                      <a:headEnd type="none" w="med" len="med"/>
+                      <a:tailEnd type="none" w="med" len="med"/>
+                    </a:lnT>
+                    <a:lnB w="9525" cap="flat" cmpd="sng" algn="ctr">
+                      <a:solidFill>
+                        <a:srgbClr val="EEF2F8"/>
+                      </a:solidFill>
+                      <a:prstDash val="solid"/>
+                      <a:round/>
+                      <a:headEnd type="none" w="med" len="med"/>
+                      <a:tailEnd type="none" w="med" len="med"/>
+                    </a:lnB>
+                  </a:tcPr>
+                </a:tc>
+                <a:tc>
+                  <a:txBody>
+                    <a:bodyPr/>
+                    <a:lstStyle/>
+                    <a:p>
+                      <a:pPr algn="r" indent="0" marL="0">
+                        <a:buNone/>
+                      </a:pPr>
+                      <a:r>
+                        <a:rPr lang="en-US" sz="1200" b="1" dirty="0">
+                          <a:solidFill>
+                            <a:schemeClr val="accent2"/>
+                          </a:solidFill>
+                        </a:rPr>
+                        <a:t>59.7 %</a:t>
+                      </a:r>
+                      <a:endParaRPr lang="en-US" sz="1200" dirty="0"/>
+                    </a:p>
+                  </a:txBody>
+                  <a:tcPr marL="73152" marR="73152" marT="0" marB="0" anchor="ctr">
+                    <a:lnL w="9525" cap="flat" cmpd="sng" algn="ctr">
+                      <a:solidFill>
+                        <a:srgbClr val="EEF2F8"/>
+                      </a:solidFill>
+                      <a:prstDash val="solid"/>
+                      <a:round/>
+                      <a:headEnd type="none" w="med" len="med"/>
+                      <a:tailEnd type="none" w="med" len="med"/>
+                    </a:lnL>
+                    <a:lnR w="9525" cap="flat" cmpd="sng" algn="ctr">
+                      <a:solidFill>
+                        <a:srgbClr val="EEF2F8"/>
+                      </a:solidFill>
+                      <a:prstDash val="solid"/>
+                      <a:round/>
+                      <a:headEnd type="none" w="med" len="med"/>
+                      <a:tailEnd type="none" w="med" len="med"/>
+                    </a:lnR>
+                    <a:lnT w="9525" cap="flat" cmpd="sng" algn="ctr">
+                      <a:solidFill>
+                        <a:srgbClr val="EEF2F8"/>
+                      </a:solidFill>
+                      <a:prstDash val="solid"/>
+                      <a:round/>
+                      <a:headEnd type="none" w="med" len="med"/>
+                      <a:tailEnd type="none" w="med" len="med"/>
+                    </a:lnT>
+                    <a:lnB w="9525" cap="flat" cmpd="sng" algn="ctr">
+                      <a:solidFill>
+                        <a:srgbClr val="EEF2F8"/>
+                      </a:solidFill>
+                      <a:prstDash val="solid"/>
+                      <a:round/>
+                      <a:headEnd type="none" w="med" len="med"/>
+                      <a:tailEnd type="none" w="med" len="med"/>
+                    </a:lnB>
+                  </a:tcPr>
+                </a:tc>
+              </a:tr>
+              <a:tr h="324612">
+                <a:tc>
+                  <a:txBody>
+                    <a:bodyPr/>
+                    <a:lstStyle/>
+                    <a:p>
+                      <a:pPr algn="l" indent="0" marL="0">
+                        <a:buNone/>
+                      </a:pPr>
+                      <a:r>
+                        <a:rPr lang="en-US" sz="1200" b="1" dirty="0">
+                          <a:solidFill>
+                            <a:schemeClr val="tx1"/>
+                          </a:solidFill>
+                        </a:rPr>
+                        <a:t>Reading</a:t>
+                      </a:r>
+                      <a:endParaRPr lang="en-US" sz="1200" dirty="0"/>
+                    </a:p>
+                  </a:txBody>
+                  <a:tcPr marL="73152" marR="73152" marT="0" marB="0" anchor="ctr">
+                    <a:lnL w="9525" cap="flat" cmpd="sng" algn="ctr">
+                      <a:solidFill>
+                        <a:srgbClr val="EEF2F8"/>
+                      </a:solidFill>
+                      <a:prstDash val="solid"/>
+                      <a:round/>
+                      <a:headEnd type="none" w="med" len="med"/>
+                      <a:tailEnd type="none" w="med" len="med"/>
+                    </a:lnL>
+                    <a:lnR w="9525" cap="flat" cmpd="sng" algn="ctr">
+                      <a:solidFill>
+                        <a:srgbClr val="EEF2F8"/>
+                      </a:solidFill>
+                      <a:prstDash val="solid"/>
+                      <a:round/>
+                      <a:headEnd type="none" w="med" len="med"/>
+                      <a:tailEnd type="none" w="med" len="med"/>
+                    </a:lnR>
+                    <a:lnT w="9525" cap="flat" cmpd="sng" algn="ctr">
+                      <a:solidFill>
+                        <a:srgbClr val="EEF2F8"/>
+                      </a:solidFill>
+                      <a:prstDash val="solid"/>
+                      <a:round/>
+                      <a:headEnd type="none" w="med" len="med"/>
+                      <a:tailEnd type="none" w="med" len="med"/>
+                    </a:lnT>
+                    <a:lnB w="9525" cap="flat" cmpd="sng" algn="ctr">
+                      <a:solidFill>
+                        <a:srgbClr val="EEF2F8"/>
+                      </a:solidFill>
+                      <a:prstDash val="solid"/>
+                      <a:round/>
+                      <a:headEnd type="none" w="med" len="med"/>
+                      <a:tailEnd type="none" w="med" len="med"/>
+                    </a:lnB>
+                  </a:tcPr>
+                </a:tc>
+                <a:tc>
+                  <a:txBody>
+                    <a:bodyPr/>
+                    <a:lstStyle/>
+                    <a:p>
+                      <a:pPr algn="r" indent="0" marL="0">
+                        <a:buNone/>
+                      </a:pPr>
+                      <a:r>
+                        <a:rPr lang="en-US" sz="1200" dirty="0">
+                          <a:solidFill>
+                            <a:schemeClr val="tx1"/>
+                          </a:solidFill>
+                        </a:rPr>
+                        <a:t>8,368</a:t>
+                      </a:r>
+                      <a:endParaRPr lang="en-US" sz="1200" dirty="0"/>
+                    </a:p>
+                  </a:txBody>
+                  <a:tcPr marL="73152" marR="73152" marT="0" marB="0" anchor="ctr">
+                    <a:lnL w="9525" cap="flat" cmpd="sng" algn="ctr">
+                      <a:solidFill>
+                        <a:srgbClr val="EEF2F8"/>
+                      </a:solidFill>
+                      <a:prstDash val="solid"/>
+                      <a:round/>
+                      <a:headEnd type="none" w="med" len="med"/>
+                      <a:tailEnd type="none" w="med" len="med"/>
+                    </a:lnL>
+                    <a:lnR w="9525" cap="flat" cmpd="sng" algn="ctr">
+                      <a:solidFill>
+                        <a:srgbClr val="EEF2F8"/>
+                      </a:solidFill>
+                      <a:prstDash val="solid"/>
+                      <a:round/>
+                      <a:headEnd type="none" w="med" len="med"/>
+                      <a:tailEnd type="none" w="med" len="med"/>
+                    </a:lnR>
+                    <a:lnT w="9525" cap="flat" cmpd="sng" algn="ctr">
+                      <a:solidFill>
+                        <a:srgbClr val="EEF2F8"/>
+                      </a:solidFill>
+                      <a:prstDash val="solid"/>
+                      <a:round/>
+                      <a:headEnd type="none" w="med" len="med"/>
+                      <a:tailEnd type="none" w="med" len="med"/>
+                    </a:lnT>
+                    <a:lnB w="9525" cap="flat" cmpd="sng" algn="ctr">
+                      <a:solidFill>
+                        <a:srgbClr val="EEF2F8"/>
+                      </a:solidFill>
+                      <a:prstDash val="solid"/>
+                      <a:round/>
+                      <a:headEnd type="none" w="med" len="med"/>
+                      <a:tailEnd type="none" w="med" len="med"/>
+                    </a:lnB>
+                  </a:tcPr>
+                </a:tc>
+                <a:tc>
+                  <a:txBody>
+                    <a:bodyPr/>
+                    <a:lstStyle/>
+                    <a:p>
+                      <a:pPr algn="r" indent="0" marL="0">
+                        <a:buNone/>
+                      </a:pPr>
+                      <a:r>
+                        <a:rPr lang="en-US" sz="1200" dirty="0">
+                          <a:solidFill>
+                            <a:schemeClr val="tx1"/>
+                          </a:solidFill>
+                        </a:rPr>
+                        <a:t>1,577</a:t>
+                      </a:r>
+                      <a:endParaRPr lang="en-US" sz="1200" dirty="0"/>
+                    </a:p>
+                  </a:txBody>
+                  <a:tcPr marL="73152" marR="73152" marT="0" marB="0" anchor="ctr">
+                    <a:lnL w="9525" cap="flat" cmpd="sng" algn="ctr">
+                      <a:solidFill>
+                        <a:srgbClr val="EEF2F8"/>
+                      </a:solidFill>
+                      <a:prstDash val="solid"/>
+                      <a:round/>
+                      <a:headEnd type="none" w="med" len="med"/>
+                      <a:tailEnd type="none" w="med" len="med"/>
+                    </a:lnL>
+                    <a:lnR w="9525" cap="flat" cmpd="sng" algn="ctr">
+                      <a:solidFill>
+                        <a:srgbClr val="EEF2F8"/>
+                      </a:solidFill>
+                      <a:prstDash val="solid"/>
+                      <a:round/>
+                      <a:headEnd type="none" w="med" len="med"/>
+                      <a:tailEnd type="none" w="med" len="med"/>
+                    </a:lnR>
+                    <a:lnT w="9525" cap="flat" cmpd="sng" algn="ctr">
+                      <a:solidFill>
+                        <a:srgbClr val="EEF2F8"/>
+                      </a:solidFill>
+                      <a:prstDash val="solid"/>
+                      <a:round/>
+                      <a:headEnd type="none" w="med" len="med"/>
+                      <a:tailEnd type="none" w="med" len="med"/>
+                    </a:lnT>
+                    <a:lnB w="9525" cap="flat" cmpd="sng" algn="ctr">
+                      <a:solidFill>
+                        <a:srgbClr val="EEF2F8"/>
+                      </a:solidFill>
+                      <a:prstDash val="solid"/>
+                      <a:round/>
+                      <a:headEnd type="none" w="med" len="med"/>
+                      <a:tailEnd type="none" w="med" len="med"/>
+                    </a:lnB>
+                  </a:tcPr>
+                </a:tc>
+                <a:tc>
+                  <a:txBody>
+                    <a:bodyPr/>
+                    <a:lstStyle/>
+                    <a:p>
+                      <a:pPr algn="r" indent="0" marL="0">
+                        <a:buNone/>
+                      </a:pPr>
+                      <a:r>
+                        <a:rPr lang="en-US" sz="1200" dirty="0">
+                          <a:solidFill>
+                            <a:schemeClr val="tx1"/>
+                          </a:solidFill>
+                        </a:rPr>
+                        <a:t>18.8 %</a:t>
+                      </a:r>
+                      <a:endParaRPr lang="en-US" sz="1200" dirty="0"/>
+                    </a:p>
+                  </a:txBody>
+                  <a:tcPr marL="73152" marR="73152" marT="0" marB="0" anchor="ctr">
+                    <a:lnL w="9525" cap="flat" cmpd="sng" algn="ctr">
+                      <a:solidFill>
+                        <a:srgbClr val="EEF2F8"/>
+                      </a:solidFill>
+                      <a:prstDash val="solid"/>
+                      <a:round/>
+                      <a:headEnd type="none" w="med" len="med"/>
+                      <a:tailEnd type="none" w="med" len="med"/>
+                    </a:lnL>
+                    <a:lnR w="9525" cap="flat" cmpd="sng" algn="ctr">
+                      <a:solidFill>
+                        <a:srgbClr val="EEF2F8"/>
+                      </a:solidFill>
+                      <a:prstDash val="solid"/>
+                      <a:round/>
+                      <a:headEnd type="none" w="med" len="med"/>
+                      <a:tailEnd type="none" w="med" len="med"/>
+                    </a:lnR>
+                    <a:lnT w="9525" cap="flat" cmpd="sng" algn="ctr">
+                      <a:solidFill>
+                        <a:srgbClr val="EEF2F8"/>
+                      </a:solidFill>
+                      <a:prstDash val="solid"/>
+                      <a:round/>
+                      <a:headEnd type="none" w="med" len="med"/>
+                      <a:tailEnd type="none" w="med" len="med"/>
+                    </a:lnT>
+                    <a:lnB w="9525" cap="flat" cmpd="sng" algn="ctr">
+                      <a:solidFill>
+                        <a:srgbClr val="EEF2F8"/>
+                      </a:solidFill>
+                      <a:prstDash val="solid"/>
+                      <a:round/>
+                      <a:headEnd type="none" w="med" len="med"/>
+                      <a:tailEnd type="none" w="med" len="med"/>
+                    </a:lnB>
+                  </a:tcPr>
+                </a:tc>
+                <a:tc>
+                  <a:txBody>
+                    <a:bodyPr/>
+                    <a:lstStyle/>
+                    <a:p>
+                      <a:pPr algn="r" indent="0" marL="0">
+                        <a:buNone/>
+                      </a:pPr>
+                      <a:r>
+                        <a:rPr lang="en-US" sz="1200" dirty="0">
+                          <a:solidFill>
+                            <a:schemeClr val="tx1"/>
+                          </a:solidFill>
+                        </a:rPr>
+                        <a:t>918</a:t>
+                      </a:r>
+                      <a:endParaRPr lang="en-US" sz="1200" dirty="0"/>
+                    </a:p>
+                  </a:txBody>
+                  <a:tcPr marL="73152" marR="73152" marT="0" marB="0" anchor="ctr">
+                    <a:lnL w="9525" cap="flat" cmpd="sng" algn="ctr">
+                      <a:solidFill>
+                        <a:srgbClr val="EEF2F8"/>
+                      </a:solidFill>
+                      <a:prstDash val="solid"/>
+                      <a:round/>
+                      <a:headEnd type="none" w="med" len="med"/>
+                      <a:tailEnd type="none" w="med" len="med"/>
+                    </a:lnL>
+                    <a:lnR w="9525" cap="flat" cmpd="sng" algn="ctr">
+                      <a:solidFill>
+                        <a:srgbClr val="EEF2F8"/>
+                      </a:solidFill>
+                      <a:prstDash val="solid"/>
+                      <a:round/>
+                      <a:headEnd type="none" w="med" len="med"/>
+                      <a:tailEnd type="none" w="med" len="med"/>
+                    </a:lnR>
+                    <a:lnT w="9525" cap="flat" cmpd="sng" algn="ctr">
+                      <a:solidFill>
+                        <a:srgbClr val="EEF2F8"/>
+                      </a:solidFill>
+                      <a:prstDash val="solid"/>
+                      <a:round/>
+                      <a:headEnd type="none" w="med" len="med"/>
+                      <a:tailEnd type="none" w="med" len="med"/>
+                    </a:lnT>
+                    <a:lnB w="9525" cap="flat" cmpd="sng" algn="ctr">
+                      <a:solidFill>
+                        <a:srgbClr val="EEF2F8"/>
+                      </a:solidFill>
+                      <a:prstDash val="solid"/>
+                      <a:round/>
+                      <a:headEnd type="none" w="med" len="med"/>
+                      <a:tailEnd type="none" w="med" len="med"/>
+                    </a:lnB>
+                  </a:tcPr>
+                </a:tc>
+                <a:tc>
+                  <a:txBody>
+                    <a:bodyPr/>
+                    <a:lstStyle/>
+                    <a:p>
+                      <a:pPr algn="r" indent="0" marL="0">
+                        <a:buNone/>
+                      </a:pPr>
+                      <a:r>
+                        <a:rPr lang="en-US" sz="1200" b="1" dirty="0">
+                          <a:solidFill>
+                            <a:schemeClr val="accent2"/>
+                          </a:solidFill>
+                        </a:rPr>
+                        <a:t>59.5 %</a:t>
+                      </a:r>
+                      <a:endParaRPr lang="en-US" sz="1200" dirty="0"/>
+                    </a:p>
+                  </a:txBody>
+                  <a:tcPr marL="73152" marR="73152" marT="0" marB="0" anchor="ctr">
+                    <a:lnL w="9525" cap="flat" cmpd="sng" algn="ctr">
+                      <a:solidFill>
+                        <a:srgbClr val="EEF2F8"/>
+                      </a:solidFill>
+                      <a:prstDash val="solid"/>
+                      <a:round/>
+                      <a:headEnd type="none" w="med" len="med"/>
+                      <a:tailEnd type="none" w="med" len="med"/>
+                    </a:lnL>
+                    <a:lnR w="9525" cap="flat" cmpd="sng" algn="ctr">
+                      <a:solidFill>
+                        <a:srgbClr val="EEF2F8"/>
+                      </a:solidFill>
+                      <a:prstDash val="solid"/>
+                      <a:round/>
+                      <a:headEnd type="none" w="med" len="med"/>
+                      <a:tailEnd type="none" w="med" len="med"/>
+                    </a:lnR>
+                    <a:lnT w="9525" cap="flat" cmpd="sng" algn="ctr">
+                      <a:solidFill>
+                        <a:srgbClr val="EEF2F8"/>
+                      </a:solidFill>
+                      <a:prstDash val="solid"/>
+                      <a:round/>
+                      <a:headEnd type="none" w="med" len="med"/>
+                      <a:tailEnd type="none" w="med" len="med"/>
+                    </a:lnT>
+                    <a:lnB w="9525" cap="flat" cmpd="sng" algn="ctr">
+                      <a:solidFill>
+                        <a:srgbClr val="EEF2F8"/>
+                      </a:solidFill>
+                      <a:prstDash val="solid"/>
+                      <a:round/>
+                      <a:headEnd type="none" w="med" len="med"/>
+                      <a:tailEnd type="none" w="med" len="med"/>
+                    </a:lnB>
+                  </a:tcPr>
+                </a:tc>
+              </a:tr>
+              <a:tr h="324612">
+                <a:tc>
+                  <a:txBody>
+                    <a:bodyPr/>
+                    <a:lstStyle/>
+                    <a:p>
+                      <a:pPr algn="l" indent="0" marL="0">
+                        <a:buNone/>
+                      </a:pPr>
+                      <a:r>
+                        <a:rPr lang="en-US" sz="1200" dirty="0">
+                          <a:solidFill>
+                            <a:schemeClr val="tx1"/>
+                          </a:solidFill>
+                        </a:rPr>
+                        <a:t>Scranton</a:t>
+                      </a:r>
+                      <a:endParaRPr lang="en-US" sz="1200" dirty="0"/>
+                    </a:p>
+                  </a:txBody>
+                  <a:tcPr marL="73152" marR="73152" marT="0" marB="0" anchor="ctr">
+                    <a:lnL w="9525" cap="flat" cmpd="sng" algn="ctr">
+                      <a:solidFill>
+                        <a:srgbClr val="EEF2F8"/>
+                      </a:solidFill>
+                      <a:prstDash val="solid"/>
+                      <a:round/>
+                      <a:headEnd type="none" w="med" len="med"/>
+                      <a:tailEnd type="none" w="med" len="med"/>
+                    </a:lnL>
+                    <a:lnR w="9525" cap="flat" cmpd="sng" algn="ctr">
+                      <a:solidFill>
+                        <a:srgbClr val="EEF2F8"/>
+                      </a:solidFill>
+                      <a:prstDash val="solid"/>
+                      <a:round/>
+                      <a:headEnd type="none" w="med" len="med"/>
+                      <a:tailEnd type="none" w="med" len="med"/>
+                    </a:lnR>
+                    <a:lnT w="9525" cap="flat" cmpd="sng" algn="ctr">
+                      <a:solidFill>
+                        <a:srgbClr val="EEF2F8"/>
+                      </a:solidFill>
+                      <a:prstDash val="solid"/>
+                      <a:round/>
+                      <a:headEnd type="none" w="med" len="med"/>
+                      <a:tailEnd type="none" w="med" len="med"/>
+                    </a:lnT>
+                    <a:lnB w="9525" cap="flat" cmpd="sng" algn="ctr">
+                      <a:solidFill>
+                        <a:srgbClr val="EEF2F8"/>
+                      </a:solidFill>
+                      <a:prstDash val="solid"/>
+                      <a:round/>
+                      <a:headEnd type="none" w="med" len="med"/>
+                      <a:tailEnd type="none" w="med" len="med"/>
+                    </a:lnB>
+                  </a:tcPr>
+                </a:tc>
+                <a:tc>
+                  <a:txBody>
+                    <a:bodyPr/>
+                    <a:lstStyle/>
+                    <a:p>
+                      <a:pPr algn="r" indent="0" marL="0">
+                        <a:buNone/>
+                      </a:pPr>
+                      <a:r>
+                        <a:rPr lang="en-US" sz="1200" dirty="0">
+                          <a:solidFill>
+                            <a:schemeClr val="tx1"/>
+                          </a:solidFill>
+                        </a:rPr>
+                        <a:t>448</a:t>
+                      </a:r>
+                      <a:endParaRPr lang="en-US" sz="1200" dirty="0"/>
+                    </a:p>
+                  </a:txBody>
+                  <a:tcPr marL="73152" marR="73152" marT="0" marB="0" anchor="ctr">
+                    <a:lnL w="9525" cap="flat" cmpd="sng" algn="ctr">
+                      <a:solidFill>
+                        <a:srgbClr val="EEF2F8"/>
+                      </a:solidFill>
+                      <a:prstDash val="solid"/>
+                      <a:round/>
+                      <a:headEnd type="none" w="med" len="med"/>
+                      <a:tailEnd type="none" w="med" len="med"/>
+                    </a:lnL>
+                    <a:lnR w="9525" cap="flat" cmpd="sng" algn="ctr">
+                      <a:solidFill>
+                        <a:srgbClr val="EEF2F8"/>
+                      </a:solidFill>
+                      <a:prstDash val="solid"/>
+                      <a:round/>
+                      <a:headEnd type="none" w="med" len="med"/>
+                      <a:tailEnd type="none" w="med" len="med"/>
+                    </a:lnR>
+                    <a:lnT w="9525" cap="flat" cmpd="sng" algn="ctr">
+                      <a:solidFill>
+                        <a:srgbClr val="EEF2F8"/>
+                      </a:solidFill>
+                      <a:prstDash val="solid"/>
+                      <a:round/>
+                      <a:headEnd type="none" w="med" len="med"/>
+                      <a:tailEnd type="none" w="med" len="med"/>
+                    </a:lnT>
+                    <a:lnB w="9525" cap="flat" cmpd="sng" algn="ctr">
+                      <a:solidFill>
+                        <a:srgbClr val="EEF2F8"/>
+                      </a:solidFill>
+                      <a:prstDash val="solid"/>
+                      <a:round/>
+                      <a:headEnd type="none" w="med" len="med"/>
+                      <a:tailEnd type="none" w="med" len="med"/>
+                    </a:lnB>
+                  </a:tcPr>
+                </a:tc>
+                <a:tc>
+                  <a:txBody>
+                    <a:bodyPr/>
+                    <a:lstStyle/>
+                    <a:p>
+                      <a:pPr algn="r" indent="0" marL="0">
+                        <a:buNone/>
+                      </a:pPr>
+                      <a:r>
+                        <a:rPr lang="en-US" sz="1200" dirty="0">
+                          <a:solidFill>
+                            <a:schemeClr val="tx1"/>
+                          </a:solidFill>
+                        </a:rPr>
+                        <a:t>93</a:t>
+                      </a:r>
+                      <a:endParaRPr lang="en-US" sz="1200" dirty="0"/>
+                    </a:p>
+                  </a:txBody>
+                  <a:tcPr marL="73152" marR="73152" marT="0" marB="0" anchor="ctr">
+                    <a:lnL w="9525" cap="flat" cmpd="sng" algn="ctr">
+                      <a:solidFill>
+                        <a:srgbClr val="EEF2F8"/>
+                      </a:solidFill>
+                      <a:prstDash val="solid"/>
+                      <a:round/>
+                      <a:headEnd type="none" w="med" len="med"/>
+                      <a:tailEnd type="none" w="med" len="med"/>
+                    </a:lnL>
+                    <a:lnR w="9525" cap="flat" cmpd="sng" algn="ctr">
+                      <a:solidFill>
+                        <a:srgbClr val="EEF2F8"/>
+                      </a:solidFill>
+                      <a:prstDash val="solid"/>
+                      <a:round/>
+                      <a:headEnd type="none" w="med" len="med"/>
+                      <a:tailEnd type="none" w="med" len="med"/>
+                    </a:lnR>
+                    <a:lnT w="9525" cap="flat" cmpd="sng" algn="ctr">
+                      <a:solidFill>
+                        <a:srgbClr val="EEF2F8"/>
+                      </a:solidFill>
+                      <a:prstDash val="solid"/>
+                      <a:round/>
+                      <a:headEnd type="none" w="med" len="med"/>
+                      <a:tailEnd type="none" w="med" len="med"/>
+                    </a:lnT>
+                    <a:lnB w="9525" cap="flat" cmpd="sng" algn="ctr">
+                      <a:solidFill>
+                        <a:srgbClr val="EEF2F8"/>
+                      </a:solidFill>
+                      <a:prstDash val="solid"/>
+                      <a:round/>
+                      <a:headEnd type="none" w="med" len="med"/>
+                      <a:tailEnd type="none" w="med" len="med"/>
+                    </a:lnB>
+                  </a:tcPr>
+                </a:tc>
+                <a:tc>
+                  <a:txBody>
+                    <a:bodyPr/>
+                    <a:lstStyle/>
+                    <a:p>
+                      <a:pPr algn="r" indent="0" marL="0">
+                        <a:buNone/>
+                      </a:pPr>
+                      <a:r>
+                        <a:rPr lang="en-US" sz="1200" dirty="0">
+                          <a:solidFill>
+                            <a:schemeClr val="tx1"/>
+                          </a:solidFill>
+                        </a:rPr>
+                        <a:t>20.8 %</a:t>
+                      </a:r>
+                      <a:endParaRPr lang="en-US" sz="1200" dirty="0"/>
+                    </a:p>
+                  </a:txBody>
+                  <a:tcPr marL="73152" marR="73152" marT="0" marB="0" anchor="ctr">
+                    <a:lnL w="9525" cap="flat" cmpd="sng" algn="ctr">
+                      <a:solidFill>
+                        <a:srgbClr val="EEF2F8"/>
+                      </a:solidFill>
+                      <a:prstDash val="solid"/>
+                      <a:round/>
+                      <a:headEnd type="none" w="med" len="med"/>
+                      <a:tailEnd type="none" w="med" len="med"/>
+                    </a:lnL>
+                    <a:lnR w="9525" cap="flat" cmpd="sng" algn="ctr">
+                      <a:solidFill>
+                        <a:srgbClr val="EEF2F8"/>
+                      </a:solidFill>
+                      <a:prstDash val="solid"/>
+                      <a:round/>
+                      <a:headEnd type="none" w="med" len="med"/>
+                      <a:tailEnd type="none" w="med" len="med"/>
+                    </a:lnR>
+                    <a:lnT w="9525" cap="flat" cmpd="sng" algn="ctr">
+                      <a:solidFill>
+                        <a:srgbClr val="EEF2F8"/>
+                      </a:solidFill>
+                      <a:prstDash val="solid"/>
+                      <a:round/>
+                      <a:headEnd type="none" w="med" len="med"/>
+                      <a:tailEnd type="none" w="med" len="med"/>
+                    </a:lnT>
+                    <a:lnB w="9525" cap="flat" cmpd="sng" algn="ctr">
+                      <a:solidFill>
+                        <a:srgbClr val="EEF2F8"/>
+                      </a:solidFill>
+                      <a:prstDash val="solid"/>
+                      <a:round/>
+                      <a:headEnd type="none" w="med" len="med"/>
+                      <a:tailEnd type="none" w="med" len="med"/>
+                    </a:lnB>
+                  </a:tcPr>
+                </a:tc>
+                <a:tc>
+                  <a:txBody>
+                    <a:bodyPr/>
+                    <a:lstStyle/>
+                    <a:p>
+                      <a:pPr algn="r" indent="0" marL="0">
+                        <a:buNone/>
+                      </a:pPr>
+                      <a:r>
+                        <a:rPr lang="en-US" sz="1200" dirty="0">
+                          <a:solidFill>
+                            <a:schemeClr val="tx1"/>
+                          </a:solidFill>
+                        </a:rPr>
+                        <a:t>44</a:t>
+                      </a:r>
+                      <a:endParaRPr lang="en-US" sz="1200" dirty="0"/>
+                    </a:p>
+                  </a:txBody>
+                  <a:tcPr marL="73152" marR="73152" marT="0" marB="0" anchor="ctr">
+                    <a:lnL w="9525" cap="flat" cmpd="sng" algn="ctr">
+                      <a:solidFill>
+                        <a:srgbClr val="EEF2F8"/>
+                      </a:solidFill>
+                      <a:prstDash val="solid"/>
+                      <a:round/>
+                      <a:headEnd type="none" w="med" len="med"/>
+                      <a:tailEnd type="none" w="med" len="med"/>
+                    </a:lnL>
+                    <a:lnR w="9525" cap="flat" cmpd="sng" algn="ctr">
+                      <a:solidFill>
+                        <a:srgbClr val="EEF2F8"/>
+                      </a:solidFill>
+                      <a:prstDash val="solid"/>
+                      <a:round/>
+                      <a:headEnd type="none" w="med" len="med"/>
+                      <a:tailEnd type="none" w="med" len="med"/>
+                    </a:lnR>
+                    <a:lnT w="9525" cap="flat" cmpd="sng" algn="ctr">
+                      <a:solidFill>
+                        <a:srgbClr val="EEF2F8"/>
+                      </a:solidFill>
+                      <a:prstDash val="solid"/>
+                      <a:round/>
+                      <a:headEnd type="none" w="med" len="med"/>
+                      <a:tailEnd type="none" w="med" len="med"/>
+                    </a:lnT>
+                    <a:lnB w="9525" cap="flat" cmpd="sng" algn="ctr">
+                      <a:solidFill>
+                        <a:srgbClr val="EEF2F8"/>
+                      </a:solidFill>
+                      <a:prstDash val="solid"/>
+                      <a:round/>
+                      <a:headEnd type="none" w="med" len="med"/>
+                      <a:tailEnd type="none" w="med" len="med"/>
+                    </a:lnB>
+                  </a:tcPr>
+                </a:tc>
+                <a:tc>
+                  <a:txBody>
+                    <a:bodyPr/>
+                    <a:lstStyle/>
+                    <a:p>
+                      <a:pPr algn="r" indent="0" marL="0">
+                        <a:buNone/>
+                      </a:pPr>
+                      <a:r>
+                        <a:rPr lang="en-US" sz="1200" b="1" dirty="0">
+                          <a:solidFill>
+                            <a:schemeClr val="accent2"/>
+                          </a:solidFill>
+                        </a:rPr>
+                        <a:t>53.7 %</a:t>
+                      </a:r>
+                      <a:endParaRPr lang="en-US" sz="1200" dirty="0"/>
+                    </a:p>
+                  </a:txBody>
+                  <a:tcPr marL="73152" marR="73152" marT="0" marB="0" anchor="ctr">
+                    <a:lnL w="9525" cap="flat" cmpd="sng" algn="ctr">
+                      <a:solidFill>
+                        <a:srgbClr val="EEF2F8"/>
+                      </a:solidFill>
+                      <a:prstDash val="solid"/>
+                      <a:round/>
+                      <a:headEnd type="none" w="med" len="med"/>
+                      <a:tailEnd type="none" w="med" len="med"/>
+                    </a:lnL>
+                    <a:lnR w="9525" cap="flat" cmpd="sng" algn="ctr">
+                      <a:solidFill>
+                        <a:srgbClr val="EEF2F8"/>
+                      </a:solidFill>
+                      <a:prstDash val="solid"/>
+                      <a:round/>
+                      <a:headEnd type="none" w="med" len="med"/>
+                      <a:tailEnd type="none" w="med" len="med"/>
+                    </a:lnR>
+                    <a:lnT w="9525" cap="flat" cmpd="sng" algn="ctr">
+                      <a:solidFill>
+                        <a:srgbClr val="EEF2F8"/>
+                      </a:solidFill>
+                      <a:prstDash val="solid"/>
+                      <a:round/>
+                      <a:headEnd type="none" w="med" len="med"/>
+                      <a:tailEnd type="none" w="med" len="med"/>
+                    </a:lnT>
+                    <a:lnB w="9525" cap="flat" cmpd="sng" algn="ctr">
+                      <a:solidFill>
+                        <a:srgbClr val="EEF2F8"/>
+                      </a:solidFill>
+                      <a:prstDash val="solid"/>
+                      <a:round/>
+                      <a:headEnd type="none" w="med" len="med"/>
+                      <a:tailEnd type="none" w="med" len="med"/>
+                    </a:lnB>
+                  </a:tcPr>
+                </a:tc>
+              </a:tr>
+              <a:tr h="324612">
+                <a:tc>
+                  <a:txBody>
+                    <a:bodyPr/>
+                    <a:lstStyle/>
+                    <a:p>
+                      <a:pPr algn="l" indent="0" marL="0">
+                        <a:buNone/>
+                      </a:pPr>
+                      <a:r>
+                        <a:rPr lang="en-US" sz="1200" b="1" dirty="0">
                           <a:solidFill>
                             <a:schemeClr val="tx2"/>
                           </a:solidFill>
                         </a:rPr>
                         <a:t>Seccional</a:t>
                       </a:r>
-                      <a:endParaRPr lang="en-US" sz="1300" dirty="0"/>
+                      <a:endParaRPr lang="en-US" sz="1200" dirty="0"/>
                     </a:p>
                   </a:txBody>
                   <a:tcPr marL="73152" marR="73152" marT="0" marB="0" anchor="ctr">
@@ -15275,14 +16325,14 @@
                         <a:buNone/>
                       </a:pPr>
                       <a:r>
-                        <a:rPr lang="en-US" sz="1300" b="1" dirty="0">
+                        <a:rPr lang="en-US" sz="1200" b="1" dirty="0">
                           <a:solidFill>
                             <a:schemeClr val="tx2"/>
                           </a:solidFill>
                         </a:rPr>
                         <a:t>47,529</a:t>
                       </a:r>
-                      <a:endParaRPr lang="en-US" sz="1300" dirty="0"/>
+                      <a:endParaRPr lang="en-US" sz="1200" dirty="0"/>
                     </a:p>
                   </a:txBody>
                   <a:tcPr marL="73152" marR="73152" marT="0" marB="0" anchor="ctr">
@@ -15336,14 +16386,14 @@
                         <a:buNone/>
                       </a:pPr>
                       <a:r>
-                        <a:rPr lang="en-US" sz="1300" b="1" dirty="0">
+                        <a:rPr lang="en-US" sz="1200" b="1" dirty="0">
                           <a:solidFill>
                             <a:schemeClr val="tx2"/>
                           </a:solidFill>
                         </a:rPr>
                         <a:t>8,939</a:t>
                       </a:r>
-                      <a:endParaRPr lang="en-US" sz="1300" dirty="0"/>
+                      <a:endParaRPr lang="en-US" sz="1200" dirty="0"/>
                     </a:p>
                   </a:txBody>
                   <a:tcPr marL="73152" marR="73152" marT="0" marB="0" anchor="ctr">
@@ -15397,14 +16447,14 @@
                         <a:buNone/>
                       </a:pPr>
                       <a:r>
-                        <a:rPr lang="en-US" sz="1300" b="1" dirty="0">
+                        <a:rPr lang="en-US" sz="1200" b="1" dirty="0">
                           <a:solidFill>
                             <a:schemeClr val="tx2"/>
                           </a:solidFill>
                         </a:rPr>
                         <a:t>18.8 %</a:t>
                       </a:r>
-                      <a:endParaRPr lang="en-US" sz="1300" dirty="0"/>
+                      <a:endParaRPr lang="en-US" sz="1200" dirty="0"/>
                     </a:p>
                   </a:txBody>
                   <a:tcPr marL="73152" marR="73152" marT="0" marB="0" anchor="ctr">
@@ -15458,14 +16508,14 @@
                         <a:buNone/>
                       </a:pPr>
                       <a:r>
-                        <a:rPr lang="en-US" sz="1300" b="1" dirty="0">
+                        <a:rPr lang="en-US" sz="1200" b="1" dirty="0">
                           <a:solidFill>
                             <a:schemeClr val="tx2"/>
                           </a:solidFill>
                         </a:rPr>
                         <a:t>5,581</a:t>
                       </a:r>
-                      <a:endParaRPr lang="en-US" sz="1300" dirty="0"/>
+                      <a:endParaRPr lang="en-US" sz="1200" dirty="0"/>
                     </a:p>
                   </a:txBody>
                   <a:tcPr marL="73152" marR="73152" marT="0" marB="0" anchor="ctr">
@@ -15519,14 +16569,14 @@
                         <a:buNone/>
                       </a:pPr>
                       <a:r>
-                        <a:rPr lang="en-US" sz="1300" b="1" dirty="0">
+                        <a:rPr lang="en-US" sz="1200" b="1" dirty="0">
                           <a:solidFill>
                             <a:schemeClr val="tx2"/>
                           </a:solidFill>
                         </a:rPr>
                         <a:t>63.4 %</a:t>
                       </a:r>
-                      <a:endParaRPr lang="en-US" sz="1300" dirty="0"/>
+                      <a:endParaRPr lang="en-US" sz="1200" dirty="0"/>
                     </a:p>
                   </a:txBody>
                   <a:tcPr marL="73152" marR="73152" marT="0" marB="0" anchor="ctr">
@@ -15741,7 +16791,7 @@
                   <a:schemeClr val="tx1"/>
                 </a:solidFill>
               </a:rPr>
-              <a:t>el apoyo más bajo (59.5 %) con el 18 % del padrón.</a:t>
+              <a:t>el menor apoyo entre las ciudades grandes (59.5 %), con el 18 % del padrón.</a:t>
             </a:r>
             <a:endParaRPr lang="en-US" sz="1600" dirty="0"/>
           </a:p>
@@ -15755,7 +16805,7 @@
                   <a:schemeClr val="accent2"/>
                 </a:solidFill>
               </a:rPr>
-              <a:t>Movilizar en Kensington, Wilkes-Barre y Harrisburg: </a:t>
+              <a:t>Movilizar en Wilkes-Barre, Harrisburg y Kensington (Philadelphia): </a:t>
             </a:r>
             <a:pPr indent="0" marL="0">
               <a:spcAft>
@@ -15769,7 +16819,7 @@
                   <a:schemeClr val="tx1"/>
                 </a:solidFill>
               </a:rPr>
-              <a:t>la participación más baja (13.5 % a 16.9 %).</a:t>
+              <a:t>la participación más baja (13.5 %, 13.6 % y 16.9 %).</a:t>
             </a:r>
             <a:endParaRPr lang="en-US" sz="1600" dirty="0"/>
           </a:p>
@@ -15830,7 +16880,7 @@
                   <a:schemeClr val="accent4"/>
                 </a:solidFill>
               </a:rPr>
-              <a:t>Fuente: JCE, «Resultado Presidencial por colegios» (2024), agrupado por recinto según la lista de la Seccional PRM Pennsylvania. En rojo: participación menor de 17 % o apoyo menor de 60 %.</a:t>
+              <a:t>Fuente: JCE, «Resultado Presidencial por colegios» (2024), agrupado por ciudad según la lista de la Seccional PRM Pennsylvania. Ordenado por % del PRM y aliados. En rojo: participación &lt; 17 % o apoyo &lt; 60 %.</a:t>
             </a:r>
             <a:endParaRPr lang="en-US" sz="1000" dirty="0"/>
           </a:p>

</xml_diff>

<commit_message>
Quitar la diapositiva de tablero y riesgos (10 diapositivas)
Co-Authored-By: Claude Opus 5.5 <noreply@anthropic.com>
Claude-Session: https://claude.ai/code/session_01RrEJtrwRidXxzgveZEVQjf
</commit_message>
<xml_diff>
--- a/presentaciones/Plan_Estrategico_Pennsylvania_2028.pptx
+++ b/presentaciones/Plan_Estrategico_Pennsylvania_2028.pptx
@@ -15,10 +15,9 @@
     <p:sldId id="263" r:id="rId9"/>
     <p:sldId id="264" r:id="rId10"/>
     <p:sldId id="265" r:id="rId11"/>
-    <p:sldId id="266" r:id="rId12"/>
   </p:sldIdLst>
   <p:notesMasterIdLst>
-    <p:notesMasterId r:id="rId13"/>
+    <p:notesMasterId r:id="rId12"/>
   </p:notesMasterIdLst>
   <p:sldSz cx="12192000" cy="6858000"/>
   <p:notesSz cx="6858000" cy="12192000"/>
@@ -117,7 +116,7 @@
   <p:extLst>
     <p:ext uri="{521415D9-36F7-43E2-AB2F-B90AF26B5E84}">
       <p14:sectionLst xmlns:p14="http://schemas.microsoft.com/office/powerpoint/2010/main">
-        <p14:section name="Diagnóstico" id="{29ab36e9-6177-1e27-ae16-2ad65d4040ed}">
+        <p14:section name="Diagnóstico" id="{d950ac19-7cee-2584-3de0-c6b84d5799cd}">
           <p14:sldIdLst>
             <p14:sldId id="256"/>
             <p14:sldId id="257"/>
@@ -125,27 +124,26 @@
             <p14:sldId id="259"/>
           </p14:sldIdLst>
         </p14:section>
-        <p14:section name="Riesgos" id="{916991ab-a37d-e001-8087-196b577aa99f}">
+        <p14:section name="Riesgos" id="{3086cc7e-a762-a172-3769-74f0339b3588}">
           <p14:sldIdLst>
             <p14:sldId id="260"/>
           </p14:sldIdLst>
         </p14:section>
-        <p14:section name="Resultados 2024" id="{0b2f8f5e-db70-a417-50f7-0444627bc5d0}">
+        <p14:section name="Resultados 2024" id="{5515d0bb-f72a-05cd-0d36-688c0cd54000}">
           <p14:sldIdLst>
             <p14:sldId id="261"/>
           </p14:sldIdLst>
         </p14:section>
-        <p14:section name="Meta" id="{9e33115e-a9ac-6f32-7e0a-f6a385d96de4}">
+        <p14:section name="Meta" id="{c7c40058-fe31-6ded-6b70-506df0f6a985}">
           <p14:sldIdLst>
             <p14:sldId id="262"/>
           </p14:sldIdLst>
         </p14:section>
-        <p14:section name="Plan y recomendación" id="{b4153145-0b6e-b1d7-936b-2fa6b04c78ca}">
+        <p14:section name="Plan y recomendación" id="{8970b575-728c-0754-a828-379ea98246fe}">
           <p14:sldIdLst>
             <p14:sldId id="263"/>
             <p14:sldId id="264"/>
             <p14:sldId id="265"/>
-            <p14:sldId id="266"/>
           </p14:sldIdLst>
         </p14:section>
       </p14:sectionLst>
@@ -1459,7 +1457,7 @@
           <a:p>
             <a:r>
               <a:rPr lang="en-US" dirty="0"/>
-              <a:t>Tablero: 4 indicadores con umbrales de semáforo, reportados por zona cada semana. Riesgos: cada uno con su mitigación y un área responsable del organigrama.</a:t>
+              <a:t>Encuestas internas PRM: Markestrategia (2–4 oct. 2026) 48.8 %; RD Elige (sept. 2026) 66.5 % entre simpatizantes. Collado ha dicho que aún no inicia recorridos como aspirante. Respetar los plazos de precampaña y campaña (Ley 20-23 de Régimen Electoral y Ley 33-18 de Partidos), no usar recursos públicos y obtener consentimiento expreso para los datos personales.</a:t>
             </a:r>
             <a:endParaRPr lang="en-US" dirty="0"/>
           </a:p>
@@ -1483,94 +1481,6 @@
             <a:fld id="{F7021451-1387-4CA6-816F-3879F97B5CBC}" type="slidenum">
               <a:rPr lang="en-US"/>
               <a:t>10</a:t>
-            </a:fld>
-            <a:endParaRPr lang="en-US"/>
-          </a:p>
-        </p:txBody>
-      </p:sp>
-    </p:spTree>
-    <p:extLst>
-      <p:ext uri="{BB962C8B-B14F-4D97-AF65-F5344CB8AC3E}">
-        <p14:creationId xmlns:p14="http://schemas.microsoft.com/office/powerpoint/2010/main" val="1024086991"/>
-      </p:ext>
-    </p:extLst>
-  </p:cSld>
-  <p:clrMapOvr>
-    <a:masterClrMapping/>
-  </p:clrMapOvr>
-</p:notes>
-</file>
-
-<file path=ppt/notesSlides/notesSlide11.xml><?xml version="1.0" encoding="utf-8"?>
-<p:notes xmlns:a="http://schemas.openxmlformats.org/drawingml/2006/main" xmlns:r="http://schemas.openxmlformats.org/officeDocument/2006/relationships" xmlns:p="http://schemas.openxmlformats.org/presentationml/2006/main">
-  <p:cSld>
-    <p:spTree>
-      <p:nvGrpSpPr>
-        <p:cNvPr id="1" name=""/>
-        <p:cNvGrpSpPr/>
-        <p:nvPr/>
-      </p:nvGrpSpPr>
-      <p:grpSpPr>
-        <a:xfrm>
-          <a:off x="0" y="0"/>
-          <a:ext cx="0" cy="0"/>
-          <a:chOff x="0" y="0"/>
-          <a:chExt cx="0" cy="0"/>
-        </a:xfrm>
-      </p:grpSpPr>
-      <p:sp>
-        <p:nvSpPr>
-          <p:cNvPr id="2" name="Slide Image Placeholder 1"/>
-          <p:cNvSpPr>
-            <a:spLocks noGrp="1" noRot="1" noChangeAspect="1"/>
-          </p:cNvSpPr>
-          <p:nvPr>
-            <p:ph type="sldImg"/>
-          </p:nvPr>
-        </p:nvSpPr>
-        <p:spPr/>
-      </p:sp>
-      <p:sp>
-        <p:nvSpPr>
-          <p:cNvPr id="3" name="Notes Placeholder 2"/>
-          <p:cNvSpPr>
-            <a:spLocks noGrp="1"/>
-          </p:cNvSpPr>
-          <p:nvPr>
-            <p:ph type="body" idx="1"/>
-          </p:nvPr>
-        </p:nvSpPr>
-        <p:spPr/>
-        <p:txBody>
-          <a:bodyPr/>
-          <a:lstStyle/>
-          <a:p>
-            <a:r>
-              <a:rPr lang="en-US" dirty="0"/>
-              <a:t>Encuestas internas PRM: Markestrategia (2–4 oct. 2026) 48.8 %; RD Elige (sept. 2026) 66.5 % entre simpatizantes. Collado ha dicho que aún no inicia recorridos como aspirante. Respetar los plazos de precampaña y campaña (Ley 20-23 de Régimen Electoral y Ley 33-18 de Partidos), no usar recursos públicos y obtener consentimiento expreso para los datos personales.</a:t>
-            </a:r>
-            <a:endParaRPr lang="en-US" dirty="0"/>
-          </a:p>
-        </p:txBody>
-      </p:sp>
-      <p:sp>
-        <p:nvSpPr>
-          <p:cNvPr id="4" name="Slide Number Placeholder 3"/>
-          <p:cNvSpPr>
-            <a:spLocks noGrp="1"/>
-          </p:cNvSpPr>
-          <p:nvPr>
-            <p:ph type="sldNum" sz="quarter" idx="10"/>
-          </p:nvPr>
-        </p:nvSpPr>
-        <p:spPr/>
-        <p:txBody>
-          <a:bodyPr/>
-          <a:lstStyle/>
-          <a:p>
-            <a:fld id="{F7021451-1387-4CA6-816F-3879F97B5CBC}" type="slidenum">
-              <a:rPr lang="en-US"/>
-              <a:t>11</a:t>
             </a:fld>
             <a:endParaRPr lang="en-US"/>
           </a:p>
@@ -3552,2826 +3462,6 @@
       </p:grpSpPr>
       <p:sp>
         <p:nvSpPr>
-          <p:cNvPr id="2" name="Text 1"/>
-          <p:cNvSpPr/>
-          <p:nvPr>
-            <p:ph idx="101" type="title" hasCustomPrompt="1"/>
-          </p:nvPr>
-        </p:nvSpPr>
-        <p:spPr>
-          <a:xfrm>
-            <a:off x="548640" y="320040"/>
-            <a:ext cx="11091672" cy="1051560"/>
-          </a:xfrm>
-          <a:prstGeom prst="rect">
-            <a:avLst/>
-          </a:prstGeom>
-          <a:noFill/>
-          <a:ln/>
-        </p:spPr>
-        <p:txBody>
-          <a:bodyPr wrap="square" lIns="0" tIns="0" rIns="0" bIns="0" rtlCol="0" anchor="ctr"/>
-          <a:lstStyle/>
-          <a:p>
-            <a:pPr algn="l" indent="0" marL="0">
-              <a:buNone/>
-            </a:pPr>
-            <a:r>
-              <a:rPr lang="en-US" sz="2800" b="1" dirty="0">
-                <a:solidFill>
-                  <a:schemeClr val="tx2"/>
-                </a:solidFill>
-              </a:rPr>
-              <a:t>Cada semana, un tablero por zona; cada riesgo, un responsable</a:t>
-            </a:r>
-            <a:endParaRPr lang="en-US" sz="2800" dirty="0"/>
-          </a:p>
-        </p:txBody>
-      </p:sp>
-      <p:sp>
-        <p:nvSpPr>
-          <p:cNvPr id="3" name="Text 1"/>
-          <p:cNvSpPr txBox="1"/>
-          <p:nvPr/>
-        </p:nvSpPr>
-        <p:spPr>
-          <a:xfrm>
-            <a:off x="548640" y="1554480"/>
-            <a:ext cx="5120640" cy="365760"/>
-          </a:xfrm>
-          <a:prstGeom prst="rect">
-            <a:avLst/>
-          </a:prstGeom>
-          <a:noFill/>
-          <a:ln/>
-        </p:spPr>
-        <p:txBody>
-          <a:bodyPr wrap="square" lIns="0" tIns="0" rIns="0" bIns="0" rtlCol="0" anchor="ctr"/>
-          <a:lstStyle/>
-          <a:p>
-            <a:pPr indent="0" marL="0">
-              <a:buNone/>
-            </a:pPr>
-            <a:r>
-              <a:rPr lang="en-US" sz="1600" b="1" dirty="0">
-                <a:solidFill>
-                  <a:schemeClr val="tx2"/>
-                </a:solidFill>
-              </a:rPr>
-              <a:t>Tablero semanal por zona</a:t>
-            </a:r>
-            <a:endParaRPr lang="en-US" sz="1600" dirty="0"/>
-          </a:p>
-        </p:txBody>
-      </p:sp>
-      <p:graphicFrame>
-        <p:nvGraphicFramePr>
-          <p:cNvPr id="11" name="Table 0"/>
-          <p:cNvGraphicFramePr>
-            <a:graphicFrameLocks noGrp="1"/>
-          </p:cNvGraphicFramePr>
-          <p:nvPr>
-            <p:extLst>
-              <p:ext uri="{D42A27DB-BD31-4B8C-83A1-F6EECF244321}">
-                <p14:modId xmlns:p14="http://schemas.microsoft.com/office/powerpoint/2010/main" val="1579011935"/>
-              </p:ext>
-            </p:extLst>
-          </p:nvPr>
-        </p:nvGraphicFramePr>
-        <p:xfrm>
-          <a:off x="548640" y="1965960"/>
-          <a:ext cx="5394960" cy="914400"/>
-        </p:xfrm>
-        <a:graphic>
-          <a:graphicData uri="http://schemas.openxmlformats.org/drawingml/2006/table">
-            <a:tbl>
-              <a:tblPr/>
-              <a:tblGrid>
-                <a:gridCol w="1920240"/>
-                <a:gridCol w="868680"/>
-                <a:gridCol w="868680"/>
-                <a:gridCol w="868680"/>
-                <a:gridCol w="868680"/>
-              </a:tblGrid>
-              <a:tr h="502920">
-                <a:tc>
-                  <a:txBody>
-                    <a:bodyPr/>
-                    <a:lstStyle/>
-                    <a:p>
-                      <a:pPr algn="ctr" indent="0" marL="0">
-                        <a:buNone/>
-                      </a:pPr>
-                      <a:r>
-                        <a:rPr lang="en-US" sz="1300" b="1" dirty="0">
-                          <a:solidFill>
-                            <a:schemeClr val="bg1"/>
-                          </a:solidFill>
-                        </a:rPr>
-                        <a:t>Indicador</a:t>
-                      </a:r>
-                      <a:endParaRPr lang="en-US" sz="1300" dirty="0"/>
-                    </a:p>
-                  </a:txBody>
-                  <a:tcPr marL="54864" marR="54864" marT="0" marB="0" anchor="ctr">
-                    <a:lnL w="9525" cap="flat" cmpd="sng" algn="ctr">
-                      <a:solidFill>
-                        <a:srgbClr val="EEF2F8"/>
-                      </a:solidFill>
-                      <a:prstDash val="solid"/>
-                      <a:round/>
-                      <a:headEnd type="none" w="med" len="med"/>
-                      <a:tailEnd type="none" w="med" len="med"/>
-                    </a:lnL>
-                    <a:lnR w="9525" cap="flat" cmpd="sng" algn="ctr">
-                      <a:solidFill>
-                        <a:srgbClr val="EEF2F8"/>
-                      </a:solidFill>
-                      <a:prstDash val="solid"/>
-                      <a:round/>
-                      <a:headEnd type="none" w="med" len="med"/>
-                      <a:tailEnd type="none" w="med" len="med"/>
-                    </a:lnR>
-                    <a:lnT w="9525" cap="flat" cmpd="sng" algn="ctr">
-                      <a:solidFill>
-                        <a:srgbClr val="EEF2F8"/>
-                      </a:solidFill>
-                      <a:prstDash val="solid"/>
-                      <a:round/>
-                      <a:headEnd type="none" w="med" len="med"/>
-                      <a:tailEnd type="none" w="med" len="med"/>
-                    </a:lnT>
-                    <a:lnB w="9525" cap="flat" cmpd="sng" algn="ctr">
-                      <a:solidFill>
-                        <a:srgbClr val="EEF2F8"/>
-                      </a:solidFill>
-                      <a:prstDash val="solid"/>
-                      <a:round/>
-                      <a:headEnd type="none" w="med" len="med"/>
-                      <a:tailEnd type="none" w="med" len="med"/>
-                    </a:lnB>
-                    <a:solidFill>
-                      <a:schemeClr val="tx2"/>
-                    </a:solidFill>
-                  </a:tcPr>
-                </a:tc>
-                <a:tc>
-                  <a:txBody>
-                    <a:bodyPr/>
-                    <a:lstStyle/>
-                    <a:p>
-                      <a:pPr algn="ctr" indent="0" marL="0">
-                        <a:buNone/>
-                      </a:pPr>
-                      <a:r>
-                        <a:rPr lang="en-US" sz="1300" b="1" dirty="0">
-                          <a:solidFill>
-                            <a:schemeClr val="bg1"/>
-                          </a:solidFill>
-                        </a:rPr>
-                        <a:t>Meta</a:t>
-                      </a:r>
-                      <a:endParaRPr lang="en-US" sz="1300" dirty="0"/>
-                    </a:p>
-                  </a:txBody>
-                  <a:tcPr marL="54864" marR="54864" marT="0" marB="0" anchor="ctr">
-                    <a:lnL w="9525" cap="flat" cmpd="sng" algn="ctr">
-                      <a:solidFill>
-                        <a:srgbClr val="EEF2F8"/>
-                      </a:solidFill>
-                      <a:prstDash val="solid"/>
-                      <a:round/>
-                      <a:headEnd type="none" w="med" len="med"/>
-                      <a:tailEnd type="none" w="med" len="med"/>
-                    </a:lnL>
-                    <a:lnR w="9525" cap="flat" cmpd="sng" algn="ctr">
-                      <a:solidFill>
-                        <a:srgbClr val="EEF2F8"/>
-                      </a:solidFill>
-                      <a:prstDash val="solid"/>
-                      <a:round/>
-                      <a:headEnd type="none" w="med" len="med"/>
-                      <a:tailEnd type="none" w="med" len="med"/>
-                    </a:lnR>
-                    <a:lnT w="9525" cap="flat" cmpd="sng" algn="ctr">
-                      <a:solidFill>
-                        <a:srgbClr val="EEF2F8"/>
-                      </a:solidFill>
-                      <a:prstDash val="solid"/>
-                      <a:round/>
-                      <a:headEnd type="none" w="med" len="med"/>
-                      <a:tailEnd type="none" w="med" len="med"/>
-                    </a:lnT>
-                    <a:lnB w="9525" cap="flat" cmpd="sng" algn="ctr">
-                      <a:solidFill>
-                        <a:srgbClr val="EEF2F8"/>
-                      </a:solidFill>
-                      <a:prstDash val="solid"/>
-                      <a:round/>
-                      <a:headEnd type="none" w="med" len="med"/>
-                      <a:tailEnd type="none" w="med" len="med"/>
-                    </a:lnB>
-                    <a:solidFill>
-                      <a:schemeClr val="tx2"/>
-                    </a:solidFill>
-                  </a:tcPr>
-                </a:tc>
-                <a:tc>
-                  <a:txBody>
-                    <a:bodyPr/>
-                    <a:lstStyle/>
-                    <a:p>
-                      <a:pPr algn="ctr" indent="0" marL="0">
-                        <a:buNone/>
-                      </a:pPr>
-                      <a:r>
-                        <a:rPr lang="en-US" sz="1300" b="1" dirty="0">
-                          <a:solidFill>
-                            <a:schemeClr val="bg1"/>
-                          </a:solidFill>
-                        </a:rPr>
-                        <a:t>Verde</a:t>
-                      </a:r>
-                      <a:endParaRPr lang="en-US" sz="1300" dirty="0"/>
-                    </a:p>
-                  </a:txBody>
-                  <a:tcPr marL="54864" marR="54864" marT="0" marB="0" anchor="ctr">
-                    <a:lnL w="9525" cap="flat" cmpd="sng" algn="ctr">
-                      <a:solidFill>
-                        <a:srgbClr val="EEF2F8"/>
-                      </a:solidFill>
-                      <a:prstDash val="solid"/>
-                      <a:round/>
-                      <a:headEnd type="none" w="med" len="med"/>
-                      <a:tailEnd type="none" w="med" len="med"/>
-                    </a:lnL>
-                    <a:lnR w="9525" cap="flat" cmpd="sng" algn="ctr">
-                      <a:solidFill>
-                        <a:srgbClr val="EEF2F8"/>
-                      </a:solidFill>
-                      <a:prstDash val="solid"/>
-                      <a:round/>
-                      <a:headEnd type="none" w="med" len="med"/>
-                      <a:tailEnd type="none" w="med" len="med"/>
-                    </a:lnR>
-                    <a:lnT w="9525" cap="flat" cmpd="sng" algn="ctr">
-                      <a:solidFill>
-                        <a:srgbClr val="EEF2F8"/>
-                      </a:solidFill>
-                      <a:prstDash val="solid"/>
-                      <a:round/>
-                      <a:headEnd type="none" w="med" len="med"/>
-                      <a:tailEnd type="none" w="med" len="med"/>
-                    </a:lnT>
-                    <a:lnB w="9525" cap="flat" cmpd="sng" algn="ctr">
-                      <a:solidFill>
-                        <a:srgbClr val="EEF2F8"/>
-                      </a:solidFill>
-                      <a:prstDash val="solid"/>
-                      <a:round/>
-                      <a:headEnd type="none" w="med" len="med"/>
-                      <a:tailEnd type="none" w="med" len="med"/>
-                    </a:lnB>
-                    <a:solidFill>
-                      <a:schemeClr val="accent6"/>
-                    </a:solidFill>
-                  </a:tcPr>
-                </a:tc>
-                <a:tc>
-                  <a:txBody>
-                    <a:bodyPr/>
-                    <a:lstStyle/>
-                    <a:p>
-                      <a:pPr algn="ctr" indent="0" marL="0">
-                        <a:buNone/>
-                      </a:pPr>
-                      <a:r>
-                        <a:rPr lang="en-US" sz="1300" b="1" dirty="0">
-                          <a:solidFill>
-                            <a:schemeClr val="tx1"/>
-                          </a:solidFill>
-                        </a:rPr>
-                        <a:t>Amarillo</a:t>
-                      </a:r>
-                      <a:endParaRPr lang="en-US" sz="1300" dirty="0"/>
-                    </a:p>
-                  </a:txBody>
-                  <a:tcPr marL="54864" marR="54864" marT="0" marB="0" anchor="ctr">
-                    <a:lnL w="9525" cap="flat" cmpd="sng" algn="ctr">
-                      <a:solidFill>
-                        <a:srgbClr val="EEF2F8"/>
-                      </a:solidFill>
-                      <a:prstDash val="solid"/>
-                      <a:round/>
-                      <a:headEnd type="none" w="med" len="med"/>
-                      <a:tailEnd type="none" w="med" len="med"/>
-                    </a:lnL>
-                    <a:lnR w="9525" cap="flat" cmpd="sng" algn="ctr">
-                      <a:solidFill>
-                        <a:srgbClr val="EEF2F8"/>
-                      </a:solidFill>
-                      <a:prstDash val="solid"/>
-                      <a:round/>
-                      <a:headEnd type="none" w="med" len="med"/>
-                      <a:tailEnd type="none" w="med" len="med"/>
-                    </a:lnR>
-                    <a:lnT w="9525" cap="flat" cmpd="sng" algn="ctr">
-                      <a:solidFill>
-                        <a:srgbClr val="EEF2F8"/>
-                      </a:solidFill>
-                      <a:prstDash val="solid"/>
-                      <a:round/>
-                      <a:headEnd type="none" w="med" len="med"/>
-                      <a:tailEnd type="none" w="med" len="med"/>
-                    </a:lnT>
-                    <a:lnB w="9525" cap="flat" cmpd="sng" algn="ctr">
-                      <a:solidFill>
-                        <a:srgbClr val="EEF2F8"/>
-                      </a:solidFill>
-                      <a:prstDash val="solid"/>
-                      <a:round/>
-                      <a:headEnd type="none" w="med" len="med"/>
-                      <a:tailEnd type="none" w="med" len="med"/>
-                    </a:lnB>
-                    <a:solidFill>
-                      <a:schemeClr val="accent5"/>
-                    </a:solidFill>
-                  </a:tcPr>
-                </a:tc>
-                <a:tc>
-                  <a:txBody>
-                    <a:bodyPr/>
-                    <a:lstStyle/>
-                    <a:p>
-                      <a:pPr algn="ctr" indent="0" marL="0">
-                        <a:buNone/>
-                      </a:pPr>
-                      <a:r>
-                        <a:rPr lang="en-US" sz="1300" b="1" dirty="0">
-                          <a:solidFill>
-                            <a:schemeClr val="bg1"/>
-                          </a:solidFill>
-                        </a:rPr>
-                        <a:t>Rojo</a:t>
-                      </a:r>
-                      <a:endParaRPr lang="en-US" sz="1300" dirty="0"/>
-                    </a:p>
-                  </a:txBody>
-                  <a:tcPr marL="54864" marR="54864" marT="0" marB="0" anchor="ctr">
-                    <a:lnL w="9525" cap="flat" cmpd="sng" algn="ctr">
-                      <a:solidFill>
-                        <a:srgbClr val="EEF2F8"/>
-                      </a:solidFill>
-                      <a:prstDash val="solid"/>
-                      <a:round/>
-                      <a:headEnd type="none" w="med" len="med"/>
-                      <a:tailEnd type="none" w="med" len="med"/>
-                    </a:lnL>
-                    <a:lnR w="9525" cap="flat" cmpd="sng" algn="ctr">
-                      <a:solidFill>
-                        <a:srgbClr val="EEF2F8"/>
-                      </a:solidFill>
-                      <a:prstDash val="solid"/>
-                      <a:round/>
-                      <a:headEnd type="none" w="med" len="med"/>
-                      <a:tailEnd type="none" w="med" len="med"/>
-                    </a:lnR>
-                    <a:lnT w="9525" cap="flat" cmpd="sng" algn="ctr">
-                      <a:solidFill>
-                        <a:srgbClr val="EEF2F8"/>
-                      </a:solidFill>
-                      <a:prstDash val="solid"/>
-                      <a:round/>
-                      <a:headEnd type="none" w="med" len="med"/>
-                      <a:tailEnd type="none" w="med" len="med"/>
-                    </a:lnT>
-                    <a:lnB w="9525" cap="flat" cmpd="sng" algn="ctr">
-                      <a:solidFill>
-                        <a:srgbClr val="EEF2F8"/>
-                      </a:solidFill>
-                      <a:prstDash val="solid"/>
-                      <a:round/>
-                      <a:headEnd type="none" w="med" len="med"/>
-                      <a:tailEnd type="none" w="med" len="med"/>
-                    </a:lnB>
-                    <a:solidFill>
-                      <a:schemeClr val="accent2"/>
-                    </a:solidFill>
-                  </a:tcPr>
-                </a:tc>
-              </a:tr>
-              <a:tr h="502920">
-                <a:tc>
-                  <a:txBody>
-                    <a:bodyPr/>
-                    <a:lstStyle/>
-                    <a:p>
-                      <a:pPr algn="ctr" indent="0" marL="0">
-                        <a:buNone/>
-                      </a:pPr>
-                      <a:r>
-                        <a:rPr lang="en-US" sz="1300" dirty="0">
-                          <a:solidFill>
-                            <a:schemeClr val="tx1"/>
-                          </a:solidFill>
-                        </a:rPr>
-                        <a:t>Líderes nuevos</a:t>
-                      </a:r>
-                      <a:endParaRPr lang="en-US" sz="1300" dirty="0"/>
-                    </a:p>
-                  </a:txBody>
-                  <a:tcPr marL="54864" marR="54864" marT="0" marB="0" anchor="ctr">
-                    <a:lnL w="9525" cap="flat" cmpd="sng" algn="ctr">
-                      <a:solidFill>
-                        <a:srgbClr val="EEF2F8"/>
-                      </a:solidFill>
-                      <a:prstDash val="solid"/>
-                      <a:round/>
-                      <a:headEnd type="none" w="med" len="med"/>
-                      <a:tailEnd type="none" w="med" len="med"/>
-                    </a:lnL>
-                    <a:lnR w="9525" cap="flat" cmpd="sng" algn="ctr">
-                      <a:solidFill>
-                        <a:srgbClr val="EEF2F8"/>
-                      </a:solidFill>
-                      <a:prstDash val="solid"/>
-                      <a:round/>
-                      <a:headEnd type="none" w="med" len="med"/>
-                      <a:tailEnd type="none" w="med" len="med"/>
-                    </a:lnR>
-                    <a:lnT w="9525" cap="flat" cmpd="sng" algn="ctr">
-                      <a:solidFill>
-                        <a:srgbClr val="EEF2F8"/>
-                      </a:solidFill>
-                      <a:prstDash val="solid"/>
-                      <a:round/>
-                      <a:headEnd type="none" w="med" len="med"/>
-                      <a:tailEnd type="none" w="med" len="med"/>
-                    </a:lnT>
-                    <a:lnB w="9525" cap="flat" cmpd="sng" algn="ctr">
-                      <a:solidFill>
-                        <a:srgbClr val="EEF2F8"/>
-                      </a:solidFill>
-                      <a:prstDash val="solid"/>
-                      <a:round/>
-                      <a:headEnd type="none" w="med" len="med"/>
-                      <a:tailEnd type="none" w="med" len="med"/>
-                    </a:lnB>
-                  </a:tcPr>
-                </a:tc>
-                <a:tc>
-                  <a:txBody>
-                    <a:bodyPr/>
-                    <a:lstStyle/>
-                    <a:p>
-                      <a:pPr algn="ctr" indent="0" marL="0">
-                        <a:buNone/>
-                      </a:pPr>
-                      <a:r>
-                        <a:rPr lang="en-US" sz="1300" dirty="0">
-                          <a:solidFill>
-                            <a:schemeClr val="tx1"/>
-                          </a:solidFill>
-                        </a:rPr>
-                        <a:t>31 / sem.</a:t>
-                      </a:r>
-                      <a:endParaRPr lang="en-US" sz="1300" dirty="0"/>
-                    </a:p>
-                  </a:txBody>
-                  <a:tcPr marL="54864" marR="54864" marT="0" marB="0" anchor="ctr">
-                    <a:lnL w="9525" cap="flat" cmpd="sng" algn="ctr">
-                      <a:solidFill>
-                        <a:srgbClr val="EEF2F8"/>
-                      </a:solidFill>
-                      <a:prstDash val="solid"/>
-                      <a:round/>
-                      <a:headEnd type="none" w="med" len="med"/>
-                      <a:tailEnd type="none" w="med" len="med"/>
-                    </a:lnL>
-                    <a:lnR w="9525" cap="flat" cmpd="sng" algn="ctr">
-                      <a:solidFill>
-                        <a:srgbClr val="EEF2F8"/>
-                      </a:solidFill>
-                      <a:prstDash val="solid"/>
-                      <a:round/>
-                      <a:headEnd type="none" w="med" len="med"/>
-                      <a:tailEnd type="none" w="med" len="med"/>
-                    </a:lnR>
-                    <a:lnT w="9525" cap="flat" cmpd="sng" algn="ctr">
-                      <a:solidFill>
-                        <a:srgbClr val="EEF2F8"/>
-                      </a:solidFill>
-                      <a:prstDash val="solid"/>
-                      <a:round/>
-                      <a:headEnd type="none" w="med" len="med"/>
-                      <a:tailEnd type="none" w="med" len="med"/>
-                    </a:lnT>
-                    <a:lnB w="9525" cap="flat" cmpd="sng" algn="ctr">
-                      <a:solidFill>
-                        <a:srgbClr val="EEF2F8"/>
-                      </a:solidFill>
-                      <a:prstDash val="solid"/>
-                      <a:round/>
-                      <a:headEnd type="none" w="med" len="med"/>
-                      <a:tailEnd type="none" w="med" len="med"/>
-                    </a:lnB>
-                  </a:tcPr>
-                </a:tc>
-                <a:tc>
-                  <a:txBody>
-                    <a:bodyPr/>
-                    <a:lstStyle/>
-                    <a:p>
-                      <a:pPr algn="ctr" indent="0" marL="0">
-                        <a:buNone/>
-                      </a:pPr>
-                      <a:r>
-                        <a:rPr lang="en-US" sz="1300" dirty="0">
-                          <a:solidFill>
-                            <a:schemeClr val="tx1"/>
-                          </a:solidFill>
-                        </a:rPr>
-                        <a:t>≥ 31</a:t>
-                      </a:r>
-                      <a:endParaRPr lang="en-US" sz="1300" dirty="0"/>
-                    </a:p>
-                  </a:txBody>
-                  <a:tcPr marL="54864" marR="54864" marT="0" marB="0" anchor="ctr">
-                    <a:lnL w="9525" cap="flat" cmpd="sng" algn="ctr">
-                      <a:solidFill>
-                        <a:srgbClr val="EEF2F8"/>
-                      </a:solidFill>
-                      <a:prstDash val="solid"/>
-                      <a:round/>
-                      <a:headEnd type="none" w="med" len="med"/>
-                      <a:tailEnd type="none" w="med" len="med"/>
-                    </a:lnL>
-                    <a:lnR w="9525" cap="flat" cmpd="sng" algn="ctr">
-                      <a:solidFill>
-                        <a:srgbClr val="EEF2F8"/>
-                      </a:solidFill>
-                      <a:prstDash val="solid"/>
-                      <a:round/>
-                      <a:headEnd type="none" w="med" len="med"/>
-                      <a:tailEnd type="none" w="med" len="med"/>
-                    </a:lnR>
-                    <a:lnT w="9525" cap="flat" cmpd="sng" algn="ctr">
-                      <a:solidFill>
-                        <a:srgbClr val="EEF2F8"/>
-                      </a:solidFill>
-                      <a:prstDash val="solid"/>
-                      <a:round/>
-                      <a:headEnd type="none" w="med" len="med"/>
-                      <a:tailEnd type="none" w="med" len="med"/>
-                    </a:lnT>
-                    <a:lnB w="9525" cap="flat" cmpd="sng" algn="ctr">
-                      <a:solidFill>
-                        <a:srgbClr val="EEF2F8"/>
-                      </a:solidFill>
-                      <a:prstDash val="solid"/>
-                      <a:round/>
-                      <a:headEnd type="none" w="med" len="med"/>
-                      <a:tailEnd type="none" w="med" len="med"/>
-                    </a:lnB>
-                  </a:tcPr>
-                </a:tc>
-                <a:tc>
-                  <a:txBody>
-                    <a:bodyPr/>
-                    <a:lstStyle/>
-                    <a:p>
-                      <a:pPr algn="ctr" indent="0" marL="0">
-                        <a:buNone/>
-                      </a:pPr>
-                      <a:r>
-                        <a:rPr lang="en-US" sz="1300" dirty="0">
-                          <a:solidFill>
-                            <a:schemeClr val="tx1"/>
-                          </a:solidFill>
-                        </a:rPr>
-                        <a:t>20 – 30</a:t>
-                      </a:r>
-                      <a:endParaRPr lang="en-US" sz="1300" dirty="0"/>
-                    </a:p>
-                  </a:txBody>
-                  <a:tcPr marL="54864" marR="54864" marT="0" marB="0" anchor="ctr">
-                    <a:lnL w="9525" cap="flat" cmpd="sng" algn="ctr">
-                      <a:solidFill>
-                        <a:srgbClr val="EEF2F8"/>
-                      </a:solidFill>
-                      <a:prstDash val="solid"/>
-                      <a:round/>
-                      <a:headEnd type="none" w="med" len="med"/>
-                      <a:tailEnd type="none" w="med" len="med"/>
-                    </a:lnL>
-                    <a:lnR w="9525" cap="flat" cmpd="sng" algn="ctr">
-                      <a:solidFill>
-                        <a:srgbClr val="EEF2F8"/>
-                      </a:solidFill>
-                      <a:prstDash val="solid"/>
-                      <a:round/>
-                      <a:headEnd type="none" w="med" len="med"/>
-                      <a:tailEnd type="none" w="med" len="med"/>
-                    </a:lnR>
-                    <a:lnT w="9525" cap="flat" cmpd="sng" algn="ctr">
-                      <a:solidFill>
-                        <a:srgbClr val="EEF2F8"/>
-                      </a:solidFill>
-                      <a:prstDash val="solid"/>
-                      <a:round/>
-                      <a:headEnd type="none" w="med" len="med"/>
-                      <a:tailEnd type="none" w="med" len="med"/>
-                    </a:lnT>
-                    <a:lnB w="9525" cap="flat" cmpd="sng" algn="ctr">
-                      <a:solidFill>
-                        <a:srgbClr val="EEF2F8"/>
-                      </a:solidFill>
-                      <a:prstDash val="solid"/>
-                      <a:round/>
-                      <a:headEnd type="none" w="med" len="med"/>
-                      <a:tailEnd type="none" w="med" len="med"/>
-                    </a:lnB>
-                  </a:tcPr>
-                </a:tc>
-                <a:tc>
-                  <a:txBody>
-                    <a:bodyPr/>
-                    <a:lstStyle/>
-                    <a:p>
-                      <a:pPr algn="ctr" indent="0" marL="0">
-                        <a:buNone/>
-                      </a:pPr>
-                      <a:r>
-                        <a:rPr lang="en-US" sz="1300" dirty="0">
-                          <a:solidFill>
-                            <a:schemeClr val="tx1"/>
-                          </a:solidFill>
-                        </a:rPr>
-                        <a:t>&lt; 20</a:t>
-                      </a:r>
-                      <a:endParaRPr lang="en-US" sz="1300" dirty="0"/>
-                    </a:p>
-                  </a:txBody>
-                  <a:tcPr marL="54864" marR="54864" marT="0" marB="0" anchor="ctr">
-                    <a:lnL w="9525" cap="flat" cmpd="sng" algn="ctr">
-                      <a:solidFill>
-                        <a:srgbClr val="EEF2F8"/>
-                      </a:solidFill>
-                      <a:prstDash val="solid"/>
-                      <a:round/>
-                      <a:headEnd type="none" w="med" len="med"/>
-                      <a:tailEnd type="none" w="med" len="med"/>
-                    </a:lnL>
-                    <a:lnR w="9525" cap="flat" cmpd="sng" algn="ctr">
-                      <a:solidFill>
-                        <a:srgbClr val="EEF2F8"/>
-                      </a:solidFill>
-                      <a:prstDash val="solid"/>
-                      <a:round/>
-                      <a:headEnd type="none" w="med" len="med"/>
-                      <a:tailEnd type="none" w="med" len="med"/>
-                    </a:lnR>
-                    <a:lnT w="9525" cap="flat" cmpd="sng" algn="ctr">
-                      <a:solidFill>
-                        <a:srgbClr val="EEF2F8"/>
-                      </a:solidFill>
-                      <a:prstDash val="solid"/>
-                      <a:round/>
-                      <a:headEnd type="none" w="med" len="med"/>
-                      <a:tailEnd type="none" w="med" len="med"/>
-                    </a:lnT>
-                    <a:lnB w="9525" cap="flat" cmpd="sng" algn="ctr">
-                      <a:solidFill>
-                        <a:srgbClr val="EEF2F8"/>
-                      </a:solidFill>
-                      <a:prstDash val="solid"/>
-                      <a:round/>
-                      <a:headEnd type="none" w="med" len="med"/>
-                      <a:tailEnd type="none" w="med" len="med"/>
-                    </a:lnB>
-                  </a:tcPr>
-                </a:tc>
-              </a:tr>
-              <a:tr h="502920">
-                <a:tc>
-                  <a:txBody>
-                    <a:bodyPr/>
-                    <a:lstStyle/>
-                    <a:p>
-                      <a:pPr algn="ctr" indent="0" marL="0">
-                        <a:buNone/>
-                      </a:pPr>
-                      <a:r>
-                        <a:rPr lang="en-US" sz="1300" dirty="0">
-                          <a:solidFill>
-                            <a:schemeClr val="tx1"/>
-                          </a:solidFill>
-                        </a:rPr>
-                        <a:t>Red con cédula nueva</a:t>
-                      </a:r>
-                      <a:endParaRPr lang="en-US" sz="1300" dirty="0"/>
-                    </a:p>
-                  </a:txBody>
-                  <a:tcPr marL="54864" marR="54864" marT="0" marB="0" anchor="ctr">
-                    <a:lnL w="9525" cap="flat" cmpd="sng" algn="ctr">
-                      <a:solidFill>
-                        <a:srgbClr val="EEF2F8"/>
-                      </a:solidFill>
-                      <a:prstDash val="solid"/>
-                      <a:round/>
-                      <a:headEnd type="none" w="med" len="med"/>
-                      <a:tailEnd type="none" w="med" len="med"/>
-                    </a:lnL>
-                    <a:lnR w="9525" cap="flat" cmpd="sng" algn="ctr">
-                      <a:solidFill>
-                        <a:srgbClr val="EEF2F8"/>
-                      </a:solidFill>
-                      <a:prstDash val="solid"/>
-                      <a:round/>
-                      <a:headEnd type="none" w="med" len="med"/>
-                      <a:tailEnd type="none" w="med" len="med"/>
-                    </a:lnR>
-                    <a:lnT w="9525" cap="flat" cmpd="sng" algn="ctr">
-                      <a:solidFill>
-                        <a:srgbClr val="EEF2F8"/>
-                      </a:solidFill>
-                      <a:prstDash val="solid"/>
-                      <a:round/>
-                      <a:headEnd type="none" w="med" len="med"/>
-                      <a:tailEnd type="none" w="med" len="med"/>
-                    </a:lnT>
-                    <a:lnB w="9525" cap="flat" cmpd="sng" algn="ctr">
-                      <a:solidFill>
-                        <a:srgbClr val="EEF2F8"/>
-                      </a:solidFill>
-                      <a:prstDash val="solid"/>
-                      <a:round/>
-                      <a:headEnd type="none" w="med" len="med"/>
-                      <a:tailEnd type="none" w="med" len="med"/>
-                    </a:lnB>
-                  </a:tcPr>
-                </a:tc>
-                <a:tc>
-                  <a:txBody>
-                    <a:bodyPr/>
-                    <a:lstStyle/>
-                    <a:p>
-                      <a:pPr algn="ctr" indent="0" marL="0">
-                        <a:buNone/>
-                      </a:pPr>
-                      <a:r>
-                        <a:rPr lang="en-US" sz="1300" dirty="0">
-                          <a:solidFill>
-                            <a:schemeClr val="tx1"/>
-                          </a:solidFill>
-                        </a:rPr>
-                        <a:t>100 %</a:t>
-                      </a:r>
-                      <a:endParaRPr lang="en-US" sz="1300" dirty="0"/>
-                    </a:p>
-                  </a:txBody>
-                  <a:tcPr marL="54864" marR="54864" marT="0" marB="0" anchor="ctr">
-                    <a:lnL w="9525" cap="flat" cmpd="sng" algn="ctr">
-                      <a:solidFill>
-                        <a:srgbClr val="EEF2F8"/>
-                      </a:solidFill>
-                      <a:prstDash val="solid"/>
-                      <a:round/>
-                      <a:headEnd type="none" w="med" len="med"/>
-                      <a:tailEnd type="none" w="med" len="med"/>
-                    </a:lnL>
-                    <a:lnR w="9525" cap="flat" cmpd="sng" algn="ctr">
-                      <a:solidFill>
-                        <a:srgbClr val="EEF2F8"/>
-                      </a:solidFill>
-                      <a:prstDash val="solid"/>
-                      <a:round/>
-                      <a:headEnd type="none" w="med" len="med"/>
-                      <a:tailEnd type="none" w="med" len="med"/>
-                    </a:lnR>
-                    <a:lnT w="9525" cap="flat" cmpd="sng" algn="ctr">
-                      <a:solidFill>
-                        <a:srgbClr val="EEF2F8"/>
-                      </a:solidFill>
-                      <a:prstDash val="solid"/>
-                      <a:round/>
-                      <a:headEnd type="none" w="med" len="med"/>
-                      <a:tailEnd type="none" w="med" len="med"/>
-                    </a:lnT>
-                    <a:lnB w="9525" cap="flat" cmpd="sng" algn="ctr">
-                      <a:solidFill>
-                        <a:srgbClr val="EEF2F8"/>
-                      </a:solidFill>
-                      <a:prstDash val="solid"/>
-                      <a:round/>
-                      <a:headEnd type="none" w="med" len="med"/>
-                      <a:tailEnd type="none" w="med" len="med"/>
-                    </a:lnB>
-                  </a:tcPr>
-                </a:tc>
-                <a:tc>
-                  <a:txBody>
-                    <a:bodyPr/>
-                    <a:lstStyle/>
-                    <a:p>
-                      <a:pPr algn="ctr" indent="0" marL="0">
-                        <a:buNone/>
-                      </a:pPr>
-                      <a:r>
-                        <a:rPr lang="en-US" sz="1300" dirty="0">
-                          <a:solidFill>
-                            <a:schemeClr val="tx1"/>
-                          </a:solidFill>
-                        </a:rPr>
-                        <a:t>≥ 90 %</a:t>
-                      </a:r>
-                      <a:endParaRPr lang="en-US" sz="1300" dirty="0"/>
-                    </a:p>
-                  </a:txBody>
-                  <a:tcPr marL="54864" marR="54864" marT="0" marB="0" anchor="ctr">
-                    <a:lnL w="9525" cap="flat" cmpd="sng" algn="ctr">
-                      <a:solidFill>
-                        <a:srgbClr val="EEF2F8"/>
-                      </a:solidFill>
-                      <a:prstDash val="solid"/>
-                      <a:round/>
-                      <a:headEnd type="none" w="med" len="med"/>
-                      <a:tailEnd type="none" w="med" len="med"/>
-                    </a:lnL>
-                    <a:lnR w="9525" cap="flat" cmpd="sng" algn="ctr">
-                      <a:solidFill>
-                        <a:srgbClr val="EEF2F8"/>
-                      </a:solidFill>
-                      <a:prstDash val="solid"/>
-                      <a:round/>
-                      <a:headEnd type="none" w="med" len="med"/>
-                      <a:tailEnd type="none" w="med" len="med"/>
-                    </a:lnR>
-                    <a:lnT w="9525" cap="flat" cmpd="sng" algn="ctr">
-                      <a:solidFill>
-                        <a:srgbClr val="EEF2F8"/>
-                      </a:solidFill>
-                      <a:prstDash val="solid"/>
-                      <a:round/>
-                      <a:headEnd type="none" w="med" len="med"/>
-                      <a:tailEnd type="none" w="med" len="med"/>
-                    </a:lnT>
-                    <a:lnB w="9525" cap="flat" cmpd="sng" algn="ctr">
-                      <a:solidFill>
-                        <a:srgbClr val="EEF2F8"/>
-                      </a:solidFill>
-                      <a:prstDash val="solid"/>
-                      <a:round/>
-                      <a:headEnd type="none" w="med" len="med"/>
-                      <a:tailEnd type="none" w="med" len="med"/>
-                    </a:lnB>
-                  </a:tcPr>
-                </a:tc>
-                <a:tc>
-                  <a:txBody>
-                    <a:bodyPr/>
-                    <a:lstStyle/>
-                    <a:p>
-                      <a:pPr algn="ctr" indent="0" marL="0">
-                        <a:buNone/>
-                      </a:pPr>
-                      <a:r>
-                        <a:rPr lang="en-US" sz="1300" dirty="0">
-                          <a:solidFill>
-                            <a:schemeClr val="tx1"/>
-                          </a:solidFill>
-                        </a:rPr>
-                        <a:t>60 – 89 %</a:t>
-                      </a:r>
-                      <a:endParaRPr lang="en-US" sz="1300" dirty="0"/>
-                    </a:p>
-                  </a:txBody>
-                  <a:tcPr marL="54864" marR="54864" marT="0" marB="0" anchor="ctr">
-                    <a:lnL w="9525" cap="flat" cmpd="sng" algn="ctr">
-                      <a:solidFill>
-                        <a:srgbClr val="EEF2F8"/>
-                      </a:solidFill>
-                      <a:prstDash val="solid"/>
-                      <a:round/>
-                      <a:headEnd type="none" w="med" len="med"/>
-                      <a:tailEnd type="none" w="med" len="med"/>
-                    </a:lnL>
-                    <a:lnR w="9525" cap="flat" cmpd="sng" algn="ctr">
-                      <a:solidFill>
-                        <a:srgbClr val="EEF2F8"/>
-                      </a:solidFill>
-                      <a:prstDash val="solid"/>
-                      <a:round/>
-                      <a:headEnd type="none" w="med" len="med"/>
-                      <a:tailEnd type="none" w="med" len="med"/>
-                    </a:lnR>
-                    <a:lnT w="9525" cap="flat" cmpd="sng" algn="ctr">
-                      <a:solidFill>
-                        <a:srgbClr val="EEF2F8"/>
-                      </a:solidFill>
-                      <a:prstDash val="solid"/>
-                      <a:round/>
-                      <a:headEnd type="none" w="med" len="med"/>
-                      <a:tailEnd type="none" w="med" len="med"/>
-                    </a:lnT>
-                    <a:lnB w="9525" cap="flat" cmpd="sng" algn="ctr">
-                      <a:solidFill>
-                        <a:srgbClr val="EEF2F8"/>
-                      </a:solidFill>
-                      <a:prstDash val="solid"/>
-                      <a:round/>
-                      <a:headEnd type="none" w="med" len="med"/>
-                      <a:tailEnd type="none" w="med" len="med"/>
-                    </a:lnB>
-                  </a:tcPr>
-                </a:tc>
-                <a:tc>
-                  <a:txBody>
-                    <a:bodyPr/>
-                    <a:lstStyle/>
-                    <a:p>
-                      <a:pPr algn="ctr" indent="0" marL="0">
-                        <a:buNone/>
-                      </a:pPr>
-                      <a:r>
-                        <a:rPr lang="en-US" sz="1300" dirty="0">
-                          <a:solidFill>
-                            <a:schemeClr val="tx1"/>
-                          </a:solidFill>
-                        </a:rPr>
-                        <a:t>&lt; 60 %</a:t>
-                      </a:r>
-                      <a:endParaRPr lang="en-US" sz="1300" dirty="0"/>
-                    </a:p>
-                  </a:txBody>
-                  <a:tcPr marL="54864" marR="54864" marT="0" marB="0" anchor="ctr">
-                    <a:lnL w="9525" cap="flat" cmpd="sng" algn="ctr">
-                      <a:solidFill>
-                        <a:srgbClr val="EEF2F8"/>
-                      </a:solidFill>
-                      <a:prstDash val="solid"/>
-                      <a:round/>
-                      <a:headEnd type="none" w="med" len="med"/>
-                      <a:tailEnd type="none" w="med" len="med"/>
-                    </a:lnL>
-                    <a:lnR w="9525" cap="flat" cmpd="sng" algn="ctr">
-                      <a:solidFill>
-                        <a:srgbClr val="EEF2F8"/>
-                      </a:solidFill>
-                      <a:prstDash val="solid"/>
-                      <a:round/>
-                      <a:headEnd type="none" w="med" len="med"/>
-                      <a:tailEnd type="none" w="med" len="med"/>
-                    </a:lnR>
-                    <a:lnT w="9525" cap="flat" cmpd="sng" algn="ctr">
-                      <a:solidFill>
-                        <a:srgbClr val="EEF2F8"/>
-                      </a:solidFill>
-                      <a:prstDash val="solid"/>
-                      <a:round/>
-                      <a:headEnd type="none" w="med" len="med"/>
-                      <a:tailEnd type="none" w="med" len="med"/>
-                    </a:lnT>
-                    <a:lnB w="9525" cap="flat" cmpd="sng" algn="ctr">
-                      <a:solidFill>
-                        <a:srgbClr val="EEF2F8"/>
-                      </a:solidFill>
-                      <a:prstDash val="solid"/>
-                      <a:round/>
-                      <a:headEnd type="none" w="med" len="med"/>
-                      <a:tailEnd type="none" w="med" len="med"/>
-                    </a:lnB>
-                  </a:tcPr>
-                </a:tc>
-              </a:tr>
-              <a:tr h="502920">
-                <a:tc>
-                  <a:txBody>
-                    <a:bodyPr/>
-                    <a:lstStyle/>
-                    <a:p>
-                      <a:pPr algn="ctr" indent="0" marL="0">
-                        <a:buNone/>
-                      </a:pPr>
-                      <a:r>
-                        <a:rPr lang="en-US" sz="1300" dirty="0">
-                          <a:solidFill>
-                            <a:schemeClr val="tx1"/>
-                          </a:solidFill>
-                        </a:rPr>
-                        <a:t>Recién llegados trasladados</a:t>
-                      </a:r>
-                      <a:endParaRPr lang="en-US" sz="1300" dirty="0"/>
-                    </a:p>
-                  </a:txBody>
-                  <a:tcPr marL="54864" marR="54864" marT="0" marB="0" anchor="ctr">
-                    <a:lnL w="9525" cap="flat" cmpd="sng" algn="ctr">
-                      <a:solidFill>
-                        <a:srgbClr val="EEF2F8"/>
-                      </a:solidFill>
-                      <a:prstDash val="solid"/>
-                      <a:round/>
-                      <a:headEnd type="none" w="med" len="med"/>
-                      <a:tailEnd type="none" w="med" len="med"/>
-                    </a:lnL>
-                    <a:lnR w="9525" cap="flat" cmpd="sng" algn="ctr">
-                      <a:solidFill>
-                        <a:srgbClr val="EEF2F8"/>
-                      </a:solidFill>
-                      <a:prstDash val="solid"/>
-                      <a:round/>
-                      <a:headEnd type="none" w="med" len="med"/>
-                      <a:tailEnd type="none" w="med" len="med"/>
-                    </a:lnR>
-                    <a:lnT w="9525" cap="flat" cmpd="sng" algn="ctr">
-                      <a:solidFill>
-                        <a:srgbClr val="EEF2F8"/>
-                      </a:solidFill>
-                      <a:prstDash val="solid"/>
-                      <a:round/>
-                      <a:headEnd type="none" w="med" len="med"/>
-                      <a:tailEnd type="none" w="med" len="med"/>
-                    </a:lnT>
-                    <a:lnB w="9525" cap="flat" cmpd="sng" algn="ctr">
-                      <a:solidFill>
-                        <a:srgbClr val="EEF2F8"/>
-                      </a:solidFill>
-                      <a:prstDash val="solid"/>
-                      <a:round/>
-                      <a:headEnd type="none" w="med" len="med"/>
-                      <a:tailEnd type="none" w="med" len="med"/>
-                    </a:lnB>
-                  </a:tcPr>
-                </a:tc>
-                <a:tc>
-                  <a:txBody>
-                    <a:bodyPr/>
-                    <a:lstStyle/>
-                    <a:p>
-                      <a:pPr algn="ctr" indent="0" marL="0">
-                        <a:buNone/>
-                      </a:pPr>
-                      <a:r>
-                        <a:rPr lang="en-US" sz="1300" dirty="0">
-                          <a:solidFill>
-                            <a:schemeClr val="tx1"/>
-                          </a:solidFill>
-                        </a:rPr>
-                        <a:t>Por zona</a:t>
-                      </a:r>
-                      <a:endParaRPr lang="en-US" sz="1300" dirty="0"/>
-                    </a:p>
-                  </a:txBody>
-                  <a:tcPr marL="54864" marR="54864" marT="0" marB="0" anchor="ctr">
-                    <a:lnL w="9525" cap="flat" cmpd="sng" algn="ctr">
-                      <a:solidFill>
-                        <a:srgbClr val="EEF2F8"/>
-                      </a:solidFill>
-                      <a:prstDash val="solid"/>
-                      <a:round/>
-                      <a:headEnd type="none" w="med" len="med"/>
-                      <a:tailEnd type="none" w="med" len="med"/>
-                    </a:lnL>
-                    <a:lnR w="9525" cap="flat" cmpd="sng" algn="ctr">
-                      <a:solidFill>
-                        <a:srgbClr val="EEF2F8"/>
-                      </a:solidFill>
-                      <a:prstDash val="solid"/>
-                      <a:round/>
-                      <a:headEnd type="none" w="med" len="med"/>
-                      <a:tailEnd type="none" w="med" len="med"/>
-                    </a:lnR>
-                    <a:lnT w="9525" cap="flat" cmpd="sng" algn="ctr">
-                      <a:solidFill>
-                        <a:srgbClr val="EEF2F8"/>
-                      </a:solidFill>
-                      <a:prstDash val="solid"/>
-                      <a:round/>
-                      <a:headEnd type="none" w="med" len="med"/>
-                      <a:tailEnd type="none" w="med" len="med"/>
-                    </a:lnT>
-                    <a:lnB w="9525" cap="flat" cmpd="sng" algn="ctr">
-                      <a:solidFill>
-                        <a:srgbClr val="EEF2F8"/>
-                      </a:solidFill>
-                      <a:prstDash val="solid"/>
-                      <a:round/>
-                      <a:headEnd type="none" w="med" len="med"/>
-                      <a:tailEnd type="none" w="med" len="med"/>
-                    </a:lnB>
-                  </a:tcPr>
-                </a:tc>
-                <a:tc>
-                  <a:txBody>
-                    <a:bodyPr/>
-                    <a:lstStyle/>
-                    <a:p>
-                      <a:pPr algn="ctr" indent="0" marL="0">
-                        <a:buNone/>
-                      </a:pPr>
-                      <a:r>
-                        <a:rPr lang="en-US" sz="1300" dirty="0">
-                          <a:solidFill>
-                            <a:schemeClr val="tx1"/>
-                          </a:solidFill>
-                        </a:rPr>
-                        <a:t>≥ 90 %</a:t>
-                      </a:r>
-                      <a:endParaRPr lang="en-US" sz="1300" dirty="0"/>
-                    </a:p>
-                  </a:txBody>
-                  <a:tcPr marL="54864" marR="54864" marT="0" marB="0" anchor="ctr">
-                    <a:lnL w="9525" cap="flat" cmpd="sng" algn="ctr">
-                      <a:solidFill>
-                        <a:srgbClr val="EEF2F8"/>
-                      </a:solidFill>
-                      <a:prstDash val="solid"/>
-                      <a:round/>
-                      <a:headEnd type="none" w="med" len="med"/>
-                      <a:tailEnd type="none" w="med" len="med"/>
-                    </a:lnL>
-                    <a:lnR w="9525" cap="flat" cmpd="sng" algn="ctr">
-                      <a:solidFill>
-                        <a:srgbClr val="EEF2F8"/>
-                      </a:solidFill>
-                      <a:prstDash val="solid"/>
-                      <a:round/>
-                      <a:headEnd type="none" w="med" len="med"/>
-                      <a:tailEnd type="none" w="med" len="med"/>
-                    </a:lnR>
-                    <a:lnT w="9525" cap="flat" cmpd="sng" algn="ctr">
-                      <a:solidFill>
-                        <a:srgbClr val="EEF2F8"/>
-                      </a:solidFill>
-                      <a:prstDash val="solid"/>
-                      <a:round/>
-                      <a:headEnd type="none" w="med" len="med"/>
-                      <a:tailEnd type="none" w="med" len="med"/>
-                    </a:lnT>
-                    <a:lnB w="9525" cap="flat" cmpd="sng" algn="ctr">
-                      <a:solidFill>
-                        <a:srgbClr val="EEF2F8"/>
-                      </a:solidFill>
-                      <a:prstDash val="solid"/>
-                      <a:round/>
-                      <a:headEnd type="none" w="med" len="med"/>
-                      <a:tailEnd type="none" w="med" len="med"/>
-                    </a:lnB>
-                  </a:tcPr>
-                </a:tc>
-                <a:tc>
-                  <a:txBody>
-                    <a:bodyPr/>
-                    <a:lstStyle/>
-                    <a:p>
-                      <a:pPr algn="ctr" indent="0" marL="0">
-                        <a:buNone/>
-                      </a:pPr>
-                      <a:r>
-                        <a:rPr lang="en-US" sz="1300" dirty="0">
-                          <a:solidFill>
-                            <a:schemeClr val="tx1"/>
-                          </a:solidFill>
-                        </a:rPr>
-                        <a:t>60 – 89 %</a:t>
-                      </a:r>
-                      <a:endParaRPr lang="en-US" sz="1300" dirty="0"/>
-                    </a:p>
-                  </a:txBody>
-                  <a:tcPr marL="54864" marR="54864" marT="0" marB="0" anchor="ctr">
-                    <a:lnL w="9525" cap="flat" cmpd="sng" algn="ctr">
-                      <a:solidFill>
-                        <a:srgbClr val="EEF2F8"/>
-                      </a:solidFill>
-                      <a:prstDash val="solid"/>
-                      <a:round/>
-                      <a:headEnd type="none" w="med" len="med"/>
-                      <a:tailEnd type="none" w="med" len="med"/>
-                    </a:lnL>
-                    <a:lnR w="9525" cap="flat" cmpd="sng" algn="ctr">
-                      <a:solidFill>
-                        <a:srgbClr val="EEF2F8"/>
-                      </a:solidFill>
-                      <a:prstDash val="solid"/>
-                      <a:round/>
-                      <a:headEnd type="none" w="med" len="med"/>
-                      <a:tailEnd type="none" w="med" len="med"/>
-                    </a:lnR>
-                    <a:lnT w="9525" cap="flat" cmpd="sng" algn="ctr">
-                      <a:solidFill>
-                        <a:srgbClr val="EEF2F8"/>
-                      </a:solidFill>
-                      <a:prstDash val="solid"/>
-                      <a:round/>
-                      <a:headEnd type="none" w="med" len="med"/>
-                      <a:tailEnd type="none" w="med" len="med"/>
-                    </a:lnT>
-                    <a:lnB w="9525" cap="flat" cmpd="sng" algn="ctr">
-                      <a:solidFill>
-                        <a:srgbClr val="EEF2F8"/>
-                      </a:solidFill>
-                      <a:prstDash val="solid"/>
-                      <a:round/>
-                      <a:headEnd type="none" w="med" len="med"/>
-                      <a:tailEnd type="none" w="med" len="med"/>
-                    </a:lnB>
-                  </a:tcPr>
-                </a:tc>
-                <a:tc>
-                  <a:txBody>
-                    <a:bodyPr/>
-                    <a:lstStyle/>
-                    <a:p>
-                      <a:pPr algn="ctr" indent="0" marL="0">
-                        <a:buNone/>
-                      </a:pPr>
-                      <a:r>
-                        <a:rPr lang="en-US" sz="1300" dirty="0">
-                          <a:solidFill>
-                            <a:schemeClr val="tx1"/>
-                          </a:solidFill>
-                        </a:rPr>
-                        <a:t>&lt; 60 %</a:t>
-                      </a:r>
-                      <a:endParaRPr lang="en-US" sz="1300" dirty="0"/>
-                    </a:p>
-                  </a:txBody>
-                  <a:tcPr marL="54864" marR="54864" marT="0" marB="0" anchor="ctr">
-                    <a:lnL w="9525" cap="flat" cmpd="sng" algn="ctr">
-                      <a:solidFill>
-                        <a:srgbClr val="EEF2F8"/>
-                      </a:solidFill>
-                      <a:prstDash val="solid"/>
-                      <a:round/>
-                      <a:headEnd type="none" w="med" len="med"/>
-                      <a:tailEnd type="none" w="med" len="med"/>
-                    </a:lnL>
-                    <a:lnR w="9525" cap="flat" cmpd="sng" algn="ctr">
-                      <a:solidFill>
-                        <a:srgbClr val="EEF2F8"/>
-                      </a:solidFill>
-                      <a:prstDash val="solid"/>
-                      <a:round/>
-                      <a:headEnd type="none" w="med" len="med"/>
-                      <a:tailEnd type="none" w="med" len="med"/>
-                    </a:lnR>
-                    <a:lnT w="9525" cap="flat" cmpd="sng" algn="ctr">
-                      <a:solidFill>
-                        <a:srgbClr val="EEF2F8"/>
-                      </a:solidFill>
-                      <a:prstDash val="solid"/>
-                      <a:round/>
-                      <a:headEnd type="none" w="med" len="med"/>
-                      <a:tailEnd type="none" w="med" len="med"/>
-                    </a:lnT>
-                    <a:lnB w="9525" cap="flat" cmpd="sng" algn="ctr">
-                      <a:solidFill>
-                        <a:srgbClr val="EEF2F8"/>
-                      </a:solidFill>
-                      <a:prstDash val="solid"/>
-                      <a:round/>
-                      <a:headEnd type="none" w="med" len="med"/>
-                      <a:tailEnd type="none" w="med" len="med"/>
-                    </a:lnB>
-                  </a:tcPr>
-                </a:tc>
-              </a:tr>
-              <a:tr h="502920">
-                <a:tc>
-                  <a:txBody>
-                    <a:bodyPr/>
-                    <a:lstStyle/>
-                    <a:p>
-                      <a:pPr algn="ctr" indent="0" marL="0">
-                        <a:buNone/>
-                      </a:pPr>
-                      <a:r>
-                        <a:rPr lang="en-US" sz="1300" dirty="0">
-                          <a:solidFill>
-                            <a:schemeClr val="tx1"/>
-                          </a:solidFill>
-                        </a:rPr>
-                        <a:t>Mesas con delegado</a:t>
-                      </a:r>
-                      <a:endParaRPr lang="en-US" sz="1300" dirty="0"/>
-                    </a:p>
-                  </a:txBody>
-                  <a:tcPr marL="54864" marR="54864" marT="0" marB="0" anchor="ctr">
-                    <a:lnL w="9525" cap="flat" cmpd="sng" algn="ctr">
-                      <a:solidFill>
-                        <a:srgbClr val="EEF2F8"/>
-                      </a:solidFill>
-                      <a:prstDash val="solid"/>
-                      <a:round/>
-                      <a:headEnd type="none" w="med" len="med"/>
-                      <a:tailEnd type="none" w="med" len="med"/>
-                    </a:lnL>
-                    <a:lnR w="9525" cap="flat" cmpd="sng" algn="ctr">
-                      <a:solidFill>
-                        <a:srgbClr val="EEF2F8"/>
-                      </a:solidFill>
-                      <a:prstDash val="solid"/>
-                      <a:round/>
-                      <a:headEnd type="none" w="med" len="med"/>
-                      <a:tailEnd type="none" w="med" len="med"/>
-                    </a:lnR>
-                    <a:lnT w="9525" cap="flat" cmpd="sng" algn="ctr">
-                      <a:solidFill>
-                        <a:srgbClr val="EEF2F8"/>
-                      </a:solidFill>
-                      <a:prstDash val="solid"/>
-                      <a:round/>
-                      <a:headEnd type="none" w="med" len="med"/>
-                      <a:tailEnd type="none" w="med" len="med"/>
-                    </a:lnT>
-                    <a:lnB w="9525" cap="flat" cmpd="sng" algn="ctr">
-                      <a:solidFill>
-                        <a:srgbClr val="EEF2F8"/>
-                      </a:solidFill>
-                      <a:prstDash val="solid"/>
-                      <a:round/>
-                      <a:headEnd type="none" w="med" len="med"/>
-                      <a:tailEnd type="none" w="med" len="med"/>
-                    </a:lnB>
-                  </a:tcPr>
-                </a:tc>
-                <a:tc>
-                  <a:txBody>
-                    <a:bodyPr/>
-                    <a:lstStyle/>
-                    <a:p>
-                      <a:pPr algn="ctr" indent="0" marL="0">
-                        <a:buNone/>
-                      </a:pPr>
-                      <a:r>
-                        <a:rPr lang="en-US" sz="1300" dirty="0">
-                          <a:solidFill>
-                            <a:schemeClr val="tx1"/>
-                          </a:solidFill>
-                        </a:rPr>
-                        <a:t>84</a:t>
-                      </a:r>
-                      <a:endParaRPr lang="en-US" sz="1300" dirty="0"/>
-                    </a:p>
-                  </a:txBody>
-                  <a:tcPr marL="54864" marR="54864" marT="0" marB="0" anchor="ctr">
-                    <a:lnL w="9525" cap="flat" cmpd="sng" algn="ctr">
-                      <a:solidFill>
-                        <a:srgbClr val="EEF2F8"/>
-                      </a:solidFill>
-                      <a:prstDash val="solid"/>
-                      <a:round/>
-                      <a:headEnd type="none" w="med" len="med"/>
-                      <a:tailEnd type="none" w="med" len="med"/>
-                    </a:lnL>
-                    <a:lnR w="9525" cap="flat" cmpd="sng" algn="ctr">
-                      <a:solidFill>
-                        <a:srgbClr val="EEF2F8"/>
-                      </a:solidFill>
-                      <a:prstDash val="solid"/>
-                      <a:round/>
-                      <a:headEnd type="none" w="med" len="med"/>
-                      <a:tailEnd type="none" w="med" len="med"/>
-                    </a:lnR>
-                    <a:lnT w="9525" cap="flat" cmpd="sng" algn="ctr">
-                      <a:solidFill>
-                        <a:srgbClr val="EEF2F8"/>
-                      </a:solidFill>
-                      <a:prstDash val="solid"/>
-                      <a:round/>
-                      <a:headEnd type="none" w="med" len="med"/>
-                      <a:tailEnd type="none" w="med" len="med"/>
-                    </a:lnT>
-                    <a:lnB w="9525" cap="flat" cmpd="sng" algn="ctr">
-                      <a:solidFill>
-                        <a:srgbClr val="EEF2F8"/>
-                      </a:solidFill>
-                      <a:prstDash val="solid"/>
-                      <a:round/>
-                      <a:headEnd type="none" w="med" len="med"/>
-                      <a:tailEnd type="none" w="med" len="med"/>
-                    </a:lnB>
-                  </a:tcPr>
-                </a:tc>
-                <a:tc>
-                  <a:txBody>
-                    <a:bodyPr/>
-                    <a:lstStyle/>
-                    <a:p>
-                      <a:pPr algn="ctr" indent="0" marL="0">
-                        <a:buNone/>
-                      </a:pPr>
-                      <a:r>
-                        <a:rPr lang="en-US" sz="1300" dirty="0">
-                          <a:solidFill>
-                            <a:schemeClr val="tx1"/>
-                          </a:solidFill>
-                        </a:rPr>
-                        <a:t>84</a:t>
-                      </a:r>
-                      <a:endParaRPr lang="en-US" sz="1300" dirty="0"/>
-                    </a:p>
-                  </a:txBody>
-                  <a:tcPr marL="54864" marR="54864" marT="0" marB="0" anchor="ctr">
-                    <a:lnL w="9525" cap="flat" cmpd="sng" algn="ctr">
-                      <a:solidFill>
-                        <a:srgbClr val="EEF2F8"/>
-                      </a:solidFill>
-                      <a:prstDash val="solid"/>
-                      <a:round/>
-                      <a:headEnd type="none" w="med" len="med"/>
-                      <a:tailEnd type="none" w="med" len="med"/>
-                    </a:lnL>
-                    <a:lnR w="9525" cap="flat" cmpd="sng" algn="ctr">
-                      <a:solidFill>
-                        <a:srgbClr val="EEF2F8"/>
-                      </a:solidFill>
-                      <a:prstDash val="solid"/>
-                      <a:round/>
-                      <a:headEnd type="none" w="med" len="med"/>
-                      <a:tailEnd type="none" w="med" len="med"/>
-                    </a:lnR>
-                    <a:lnT w="9525" cap="flat" cmpd="sng" algn="ctr">
-                      <a:solidFill>
-                        <a:srgbClr val="EEF2F8"/>
-                      </a:solidFill>
-                      <a:prstDash val="solid"/>
-                      <a:round/>
-                      <a:headEnd type="none" w="med" len="med"/>
-                      <a:tailEnd type="none" w="med" len="med"/>
-                    </a:lnT>
-                    <a:lnB w="9525" cap="flat" cmpd="sng" algn="ctr">
-                      <a:solidFill>
-                        <a:srgbClr val="EEF2F8"/>
-                      </a:solidFill>
-                      <a:prstDash val="solid"/>
-                      <a:round/>
-                      <a:headEnd type="none" w="med" len="med"/>
-                      <a:tailEnd type="none" w="med" len="med"/>
-                    </a:lnB>
-                  </a:tcPr>
-                </a:tc>
-                <a:tc>
-                  <a:txBody>
-                    <a:bodyPr/>
-                    <a:lstStyle/>
-                    <a:p>
-                      <a:pPr algn="ctr" indent="0" marL="0">
-                        <a:buNone/>
-                      </a:pPr>
-                      <a:r>
-                        <a:rPr lang="en-US" sz="1300" dirty="0">
-                          <a:solidFill>
-                            <a:schemeClr val="tx1"/>
-                          </a:solidFill>
-                        </a:rPr>
-                        <a:t>70 – 83</a:t>
-                      </a:r>
-                      <a:endParaRPr lang="en-US" sz="1300" dirty="0"/>
-                    </a:p>
-                  </a:txBody>
-                  <a:tcPr marL="54864" marR="54864" marT="0" marB="0" anchor="ctr">
-                    <a:lnL w="9525" cap="flat" cmpd="sng" algn="ctr">
-                      <a:solidFill>
-                        <a:srgbClr val="EEF2F8"/>
-                      </a:solidFill>
-                      <a:prstDash val="solid"/>
-                      <a:round/>
-                      <a:headEnd type="none" w="med" len="med"/>
-                      <a:tailEnd type="none" w="med" len="med"/>
-                    </a:lnL>
-                    <a:lnR w="9525" cap="flat" cmpd="sng" algn="ctr">
-                      <a:solidFill>
-                        <a:srgbClr val="EEF2F8"/>
-                      </a:solidFill>
-                      <a:prstDash val="solid"/>
-                      <a:round/>
-                      <a:headEnd type="none" w="med" len="med"/>
-                      <a:tailEnd type="none" w="med" len="med"/>
-                    </a:lnR>
-                    <a:lnT w="9525" cap="flat" cmpd="sng" algn="ctr">
-                      <a:solidFill>
-                        <a:srgbClr val="EEF2F8"/>
-                      </a:solidFill>
-                      <a:prstDash val="solid"/>
-                      <a:round/>
-                      <a:headEnd type="none" w="med" len="med"/>
-                      <a:tailEnd type="none" w="med" len="med"/>
-                    </a:lnT>
-                    <a:lnB w="9525" cap="flat" cmpd="sng" algn="ctr">
-                      <a:solidFill>
-                        <a:srgbClr val="EEF2F8"/>
-                      </a:solidFill>
-                      <a:prstDash val="solid"/>
-                      <a:round/>
-                      <a:headEnd type="none" w="med" len="med"/>
-                      <a:tailEnd type="none" w="med" len="med"/>
-                    </a:lnB>
-                  </a:tcPr>
-                </a:tc>
-                <a:tc>
-                  <a:txBody>
-                    <a:bodyPr/>
-                    <a:lstStyle/>
-                    <a:p>
-                      <a:pPr algn="ctr" indent="0" marL="0">
-                        <a:buNone/>
-                      </a:pPr>
-                      <a:r>
-                        <a:rPr lang="en-US" sz="1300" dirty="0">
-                          <a:solidFill>
-                            <a:schemeClr val="tx1"/>
-                          </a:solidFill>
-                        </a:rPr>
-                        <a:t>&lt; 70</a:t>
-                      </a:r>
-                      <a:endParaRPr lang="en-US" sz="1300" dirty="0"/>
-                    </a:p>
-                  </a:txBody>
-                  <a:tcPr marL="54864" marR="54864" marT="0" marB="0" anchor="ctr">
-                    <a:lnL w="9525" cap="flat" cmpd="sng" algn="ctr">
-                      <a:solidFill>
-                        <a:srgbClr val="EEF2F8"/>
-                      </a:solidFill>
-                      <a:prstDash val="solid"/>
-                      <a:round/>
-                      <a:headEnd type="none" w="med" len="med"/>
-                      <a:tailEnd type="none" w="med" len="med"/>
-                    </a:lnL>
-                    <a:lnR w="9525" cap="flat" cmpd="sng" algn="ctr">
-                      <a:solidFill>
-                        <a:srgbClr val="EEF2F8"/>
-                      </a:solidFill>
-                      <a:prstDash val="solid"/>
-                      <a:round/>
-                      <a:headEnd type="none" w="med" len="med"/>
-                      <a:tailEnd type="none" w="med" len="med"/>
-                    </a:lnR>
-                    <a:lnT w="9525" cap="flat" cmpd="sng" algn="ctr">
-                      <a:solidFill>
-                        <a:srgbClr val="EEF2F8"/>
-                      </a:solidFill>
-                      <a:prstDash val="solid"/>
-                      <a:round/>
-                      <a:headEnd type="none" w="med" len="med"/>
-                      <a:tailEnd type="none" w="med" len="med"/>
-                    </a:lnT>
-                    <a:lnB w="9525" cap="flat" cmpd="sng" algn="ctr">
-                      <a:solidFill>
-                        <a:srgbClr val="EEF2F8"/>
-                      </a:solidFill>
-                      <a:prstDash val="solid"/>
-                      <a:round/>
-                      <a:headEnd type="none" w="med" len="med"/>
-                      <a:tailEnd type="none" w="med" len="med"/>
-                    </a:lnB>
-                  </a:tcPr>
-                </a:tc>
-              </a:tr>
-            </a:tbl>
-          </a:graphicData>
-        </a:graphic>
-      </p:graphicFrame>
-      <p:sp>
-        <p:nvSpPr>
-          <p:cNvPr id="5" name="Text 2"/>
-          <p:cNvSpPr txBox="1"/>
-          <p:nvPr/>
-        </p:nvSpPr>
-        <p:spPr>
-          <a:xfrm>
-            <a:off x="548640" y="4617720"/>
-            <a:ext cx="5394960" cy="548640"/>
-          </a:xfrm>
-          <a:prstGeom prst="rect">
-            <a:avLst/>
-          </a:prstGeom>
-          <a:noFill/>
-          <a:ln/>
-        </p:spPr>
-        <p:txBody>
-          <a:bodyPr wrap="square" lIns="0" tIns="0" rIns="0" bIns="0" rtlCol="0" anchor="ctr"/>
-          <a:lstStyle/>
-          <a:p>
-            <a:pPr indent="0" marL="0">
-              <a:buNone/>
-            </a:pPr>
-            <a:r>
-              <a:rPr lang="en-US" sz="1300" i="1" dirty="0">
-                <a:solidFill>
-                  <a:schemeClr val="accent3"/>
-                </a:solidFill>
-              </a:rPr>
-              <a:t>Se reporta cada semana por zona; el corte mensual va a la dirección de campaña.</a:t>
-            </a:r>
-            <a:endParaRPr lang="en-US" sz="1300" dirty="0"/>
-          </a:p>
-        </p:txBody>
-      </p:sp>
-      <p:sp>
-        <p:nvSpPr>
-          <p:cNvPr id="6" name="Text 3"/>
-          <p:cNvSpPr txBox="1"/>
-          <p:nvPr/>
-        </p:nvSpPr>
-        <p:spPr>
-          <a:xfrm>
-            <a:off x="6263640" y="1554480"/>
-            <a:ext cx="5376672" cy="365760"/>
-          </a:xfrm>
-          <a:prstGeom prst="rect">
-            <a:avLst/>
-          </a:prstGeom>
-          <a:noFill/>
-          <a:ln/>
-        </p:spPr>
-        <p:txBody>
-          <a:bodyPr wrap="square" lIns="0" tIns="0" rIns="0" bIns="0" rtlCol="0" anchor="ctr"/>
-          <a:lstStyle/>
-          <a:p>
-            <a:pPr indent="0" marL="0">
-              <a:buNone/>
-            </a:pPr>
-            <a:r>
-              <a:rPr lang="en-US" sz="1600" b="1" dirty="0">
-                <a:solidFill>
-                  <a:schemeClr val="tx2"/>
-                </a:solidFill>
-              </a:rPr>
-              <a:t>Riesgos y cómo los mitigamos</a:t>
-            </a:r>
-            <a:endParaRPr lang="en-US" sz="1600" dirty="0"/>
-          </a:p>
-        </p:txBody>
-      </p:sp>
-      <p:graphicFrame>
-        <p:nvGraphicFramePr>
-          <p:cNvPr id="21" name="Table 1"/>
-          <p:cNvGraphicFramePr>
-            <a:graphicFrameLocks noGrp="1"/>
-          </p:cNvGraphicFramePr>
-          <p:nvPr>
-            <p:extLst>
-              <p:ext uri="{D42A27DB-BD31-4B8C-83A1-F6EECF244321}">
-                <p14:modId xmlns:p14="http://schemas.microsoft.com/office/powerpoint/2010/main" val="1579011935"/>
-              </p:ext>
-            </p:extLst>
-          </p:nvPr>
-        </p:nvGraphicFramePr>
-        <p:xfrm>
-          <a:off x="6263640" y="1965960"/>
-          <a:ext cx="5376672" cy="914400"/>
-        </p:xfrm>
-        <a:graphic>
-          <a:graphicData uri="http://schemas.openxmlformats.org/drawingml/2006/table">
-            <a:tbl>
-              <a:tblPr/>
-              <a:tblGrid>
-                <a:gridCol w="1417320"/>
-                <a:gridCol w="2496312"/>
-                <a:gridCol w="1463040"/>
-              </a:tblGrid>
-              <a:tr h="502920">
-                <a:tc>
-                  <a:txBody>
-                    <a:bodyPr/>
-                    <a:lstStyle/>
-                    <a:p>
-                      <a:pPr indent="0" marL="0">
-                        <a:buNone/>
-                      </a:pPr>
-                      <a:r>
-                        <a:rPr lang="en-US" sz="1200" b="1" dirty="0">
-                          <a:solidFill>
-                            <a:schemeClr val="bg1"/>
-                          </a:solidFill>
-                        </a:rPr>
-                        <a:t>Riesgo</a:t>
-                      </a:r>
-                      <a:endParaRPr lang="en-US" sz="1200" dirty="0"/>
-                    </a:p>
-                  </a:txBody>
-                  <a:tcPr marL="54864" marR="54864" marT="0" marB="0" anchor="ctr">
-                    <a:lnL w="9525" cap="flat" cmpd="sng" algn="ctr">
-                      <a:solidFill>
-                        <a:srgbClr val="EEF2F8"/>
-                      </a:solidFill>
-                      <a:prstDash val="solid"/>
-                      <a:round/>
-                      <a:headEnd type="none" w="med" len="med"/>
-                      <a:tailEnd type="none" w="med" len="med"/>
-                    </a:lnL>
-                    <a:lnR w="9525" cap="flat" cmpd="sng" algn="ctr">
-                      <a:solidFill>
-                        <a:srgbClr val="EEF2F8"/>
-                      </a:solidFill>
-                      <a:prstDash val="solid"/>
-                      <a:round/>
-                      <a:headEnd type="none" w="med" len="med"/>
-                      <a:tailEnd type="none" w="med" len="med"/>
-                    </a:lnR>
-                    <a:lnT w="9525" cap="flat" cmpd="sng" algn="ctr">
-                      <a:solidFill>
-                        <a:srgbClr val="EEF2F8"/>
-                      </a:solidFill>
-                      <a:prstDash val="solid"/>
-                      <a:round/>
-                      <a:headEnd type="none" w="med" len="med"/>
-                      <a:tailEnd type="none" w="med" len="med"/>
-                    </a:lnT>
-                    <a:lnB w="9525" cap="flat" cmpd="sng" algn="ctr">
-                      <a:solidFill>
-                        <a:srgbClr val="EEF2F8"/>
-                      </a:solidFill>
-                      <a:prstDash val="solid"/>
-                      <a:round/>
-                      <a:headEnd type="none" w="med" len="med"/>
-                      <a:tailEnd type="none" w="med" len="med"/>
-                    </a:lnB>
-                    <a:solidFill>
-                      <a:schemeClr val="tx2"/>
-                    </a:solidFill>
-                  </a:tcPr>
-                </a:tc>
-                <a:tc>
-                  <a:txBody>
-                    <a:bodyPr/>
-                    <a:lstStyle/>
-                    <a:p>
-                      <a:pPr indent="0" marL="0">
-                        <a:buNone/>
-                      </a:pPr>
-                      <a:r>
-                        <a:rPr lang="en-US" sz="1200" b="1" dirty="0">
-                          <a:solidFill>
-                            <a:schemeClr val="bg1"/>
-                          </a:solidFill>
-                        </a:rPr>
-                        <a:t>Mitigación</a:t>
-                      </a:r>
-                      <a:endParaRPr lang="en-US" sz="1200" dirty="0"/>
-                    </a:p>
-                  </a:txBody>
-                  <a:tcPr marL="54864" marR="54864" marT="0" marB="0" anchor="ctr">
-                    <a:lnL w="9525" cap="flat" cmpd="sng" algn="ctr">
-                      <a:solidFill>
-                        <a:srgbClr val="EEF2F8"/>
-                      </a:solidFill>
-                      <a:prstDash val="solid"/>
-                      <a:round/>
-                      <a:headEnd type="none" w="med" len="med"/>
-                      <a:tailEnd type="none" w="med" len="med"/>
-                    </a:lnL>
-                    <a:lnR w="9525" cap="flat" cmpd="sng" algn="ctr">
-                      <a:solidFill>
-                        <a:srgbClr val="EEF2F8"/>
-                      </a:solidFill>
-                      <a:prstDash val="solid"/>
-                      <a:round/>
-                      <a:headEnd type="none" w="med" len="med"/>
-                      <a:tailEnd type="none" w="med" len="med"/>
-                    </a:lnR>
-                    <a:lnT w="9525" cap="flat" cmpd="sng" algn="ctr">
-                      <a:solidFill>
-                        <a:srgbClr val="EEF2F8"/>
-                      </a:solidFill>
-                      <a:prstDash val="solid"/>
-                      <a:round/>
-                      <a:headEnd type="none" w="med" len="med"/>
-                      <a:tailEnd type="none" w="med" len="med"/>
-                    </a:lnT>
-                    <a:lnB w="9525" cap="flat" cmpd="sng" algn="ctr">
-                      <a:solidFill>
-                        <a:srgbClr val="EEF2F8"/>
-                      </a:solidFill>
-                      <a:prstDash val="solid"/>
-                      <a:round/>
-                      <a:headEnd type="none" w="med" len="med"/>
-                      <a:tailEnd type="none" w="med" len="med"/>
-                    </a:lnB>
-                    <a:solidFill>
-                      <a:schemeClr val="tx2"/>
-                    </a:solidFill>
-                  </a:tcPr>
-                </a:tc>
-                <a:tc>
-                  <a:txBody>
-                    <a:bodyPr/>
-                    <a:lstStyle/>
-                    <a:p>
-                      <a:pPr indent="0" marL="0">
-                        <a:buNone/>
-                      </a:pPr>
-                      <a:r>
-                        <a:rPr lang="en-US" sz="1200" b="1" dirty="0">
-                          <a:solidFill>
-                            <a:schemeClr val="bg1"/>
-                          </a:solidFill>
-                        </a:rPr>
-                        <a:t>Responsable</a:t>
-                      </a:r>
-                      <a:endParaRPr lang="en-US" sz="1200" dirty="0"/>
-                    </a:p>
-                  </a:txBody>
-                  <a:tcPr marL="54864" marR="54864" marT="0" marB="0" anchor="ctr">
-                    <a:lnL w="9525" cap="flat" cmpd="sng" algn="ctr">
-                      <a:solidFill>
-                        <a:srgbClr val="EEF2F8"/>
-                      </a:solidFill>
-                      <a:prstDash val="solid"/>
-                      <a:round/>
-                      <a:headEnd type="none" w="med" len="med"/>
-                      <a:tailEnd type="none" w="med" len="med"/>
-                    </a:lnL>
-                    <a:lnR w="9525" cap="flat" cmpd="sng" algn="ctr">
-                      <a:solidFill>
-                        <a:srgbClr val="EEF2F8"/>
-                      </a:solidFill>
-                      <a:prstDash val="solid"/>
-                      <a:round/>
-                      <a:headEnd type="none" w="med" len="med"/>
-                      <a:tailEnd type="none" w="med" len="med"/>
-                    </a:lnR>
-                    <a:lnT w="9525" cap="flat" cmpd="sng" algn="ctr">
-                      <a:solidFill>
-                        <a:srgbClr val="EEF2F8"/>
-                      </a:solidFill>
-                      <a:prstDash val="solid"/>
-                      <a:round/>
-                      <a:headEnd type="none" w="med" len="med"/>
-                      <a:tailEnd type="none" w="med" len="med"/>
-                    </a:lnT>
-                    <a:lnB w="9525" cap="flat" cmpd="sng" algn="ctr">
-                      <a:solidFill>
-                        <a:srgbClr val="EEF2F8"/>
-                      </a:solidFill>
-                      <a:prstDash val="solid"/>
-                      <a:round/>
-                      <a:headEnd type="none" w="med" len="med"/>
-                      <a:tailEnd type="none" w="med" len="med"/>
-                    </a:lnB>
-                    <a:solidFill>
-                      <a:schemeClr val="tx2"/>
-                    </a:solidFill>
-                  </a:tcPr>
-                </a:tc>
-              </a:tr>
-              <a:tr h="502920">
-                <a:tc>
-                  <a:txBody>
-                    <a:bodyPr/>
-                    <a:lstStyle/>
-                    <a:p>
-                      <a:pPr indent="0" marL="0">
-                        <a:buNone/>
-                      </a:pPr>
-                      <a:r>
-                        <a:rPr lang="en-US" sz="1200" dirty="0">
-                          <a:solidFill>
-                            <a:schemeClr val="tx1"/>
-                          </a:solidFill>
-                        </a:rPr>
-                        <a:t>Nueva cédula</a:t>
-                      </a:r>
-                      <a:endParaRPr lang="en-US" sz="1200" dirty="0"/>
-                    </a:p>
-                  </a:txBody>
-                  <a:tcPr marL="54864" marR="54864" marT="0" marB="0" anchor="ctr">
-                    <a:lnL w="9525" cap="flat" cmpd="sng" algn="ctr">
-                      <a:solidFill>
-                        <a:srgbClr val="EEF2F8"/>
-                      </a:solidFill>
-                      <a:prstDash val="solid"/>
-                      <a:round/>
-                      <a:headEnd type="none" w="med" len="med"/>
-                      <a:tailEnd type="none" w="med" len="med"/>
-                    </a:lnL>
-                    <a:lnR w="9525" cap="flat" cmpd="sng" algn="ctr">
-                      <a:solidFill>
-                        <a:srgbClr val="EEF2F8"/>
-                      </a:solidFill>
-                      <a:prstDash val="solid"/>
-                      <a:round/>
-                      <a:headEnd type="none" w="med" len="med"/>
-                      <a:tailEnd type="none" w="med" len="med"/>
-                    </a:lnR>
-                    <a:lnT w="9525" cap="flat" cmpd="sng" algn="ctr">
-                      <a:solidFill>
-                        <a:srgbClr val="EEF2F8"/>
-                      </a:solidFill>
-                      <a:prstDash val="solid"/>
-                      <a:round/>
-                      <a:headEnd type="none" w="med" len="med"/>
-                      <a:tailEnd type="none" w="med" len="med"/>
-                    </a:lnT>
-                    <a:lnB w="9525" cap="flat" cmpd="sng" algn="ctr">
-                      <a:solidFill>
-                        <a:srgbClr val="EEF2F8"/>
-                      </a:solidFill>
-                      <a:prstDash val="solid"/>
-                      <a:round/>
-                      <a:headEnd type="none" w="med" len="med"/>
-                      <a:tailEnd type="none" w="med" len="med"/>
-                    </a:lnB>
-                  </a:tcPr>
-                </a:tc>
-                <a:tc>
-                  <a:txBody>
-                    <a:bodyPr/>
-                    <a:lstStyle/>
-                    <a:p>
-                      <a:pPr indent="0" marL="0">
-                        <a:buNone/>
-                      </a:pPr>
-                      <a:r>
-                        <a:rPr lang="en-US" sz="1200" dirty="0">
-                          <a:solidFill>
-                            <a:schemeClr val="tx1"/>
-                          </a:solidFill>
-                        </a:rPr>
-                        <a:t>Operativos móviles y viajes en grupo con cita</a:t>
-                      </a:r>
-                      <a:endParaRPr lang="en-US" sz="1200" dirty="0"/>
-                    </a:p>
-                  </a:txBody>
-                  <a:tcPr marL="54864" marR="54864" marT="0" marB="0" anchor="ctr">
-                    <a:lnL w="9525" cap="flat" cmpd="sng" algn="ctr">
-                      <a:solidFill>
-                        <a:srgbClr val="EEF2F8"/>
-                      </a:solidFill>
-                      <a:prstDash val="solid"/>
-                      <a:round/>
-                      <a:headEnd type="none" w="med" len="med"/>
-                      <a:tailEnd type="none" w="med" len="med"/>
-                    </a:lnL>
-                    <a:lnR w="9525" cap="flat" cmpd="sng" algn="ctr">
-                      <a:solidFill>
-                        <a:srgbClr val="EEF2F8"/>
-                      </a:solidFill>
-                      <a:prstDash val="solid"/>
-                      <a:round/>
-                      <a:headEnd type="none" w="med" len="med"/>
-                      <a:tailEnd type="none" w="med" len="med"/>
-                    </a:lnR>
-                    <a:lnT w="9525" cap="flat" cmpd="sng" algn="ctr">
-                      <a:solidFill>
-                        <a:srgbClr val="EEF2F8"/>
-                      </a:solidFill>
-                      <a:prstDash val="solid"/>
-                      <a:round/>
-                      <a:headEnd type="none" w="med" len="med"/>
-                      <a:tailEnd type="none" w="med" len="med"/>
-                    </a:lnT>
-                    <a:lnB w="9525" cap="flat" cmpd="sng" algn="ctr">
-                      <a:solidFill>
-                        <a:srgbClr val="EEF2F8"/>
-                      </a:solidFill>
-                      <a:prstDash val="solid"/>
-                      <a:round/>
-                      <a:headEnd type="none" w="med" len="med"/>
-                      <a:tailEnd type="none" w="med" len="med"/>
-                    </a:lnB>
-                  </a:tcPr>
-                </a:tc>
-                <a:tc>
-                  <a:txBody>
-                    <a:bodyPr/>
-                    <a:lstStyle/>
-                    <a:p>
-                      <a:pPr indent="0" marL="0">
-                        <a:buNone/>
-                      </a:pPr>
-                      <a:r>
-                        <a:rPr lang="en-US" sz="1200" dirty="0">
-                          <a:solidFill>
-                            <a:schemeClr val="tx1"/>
-                          </a:solidFill>
-                        </a:rPr>
-                        <a:t>Asuntos Electorales</a:t>
-                      </a:r>
-                      <a:endParaRPr lang="en-US" sz="1200" dirty="0"/>
-                    </a:p>
-                  </a:txBody>
-                  <a:tcPr marL="54864" marR="54864" marT="0" marB="0" anchor="ctr">
-                    <a:lnL w="9525" cap="flat" cmpd="sng" algn="ctr">
-                      <a:solidFill>
-                        <a:srgbClr val="EEF2F8"/>
-                      </a:solidFill>
-                      <a:prstDash val="solid"/>
-                      <a:round/>
-                      <a:headEnd type="none" w="med" len="med"/>
-                      <a:tailEnd type="none" w="med" len="med"/>
-                    </a:lnL>
-                    <a:lnR w="9525" cap="flat" cmpd="sng" algn="ctr">
-                      <a:solidFill>
-                        <a:srgbClr val="EEF2F8"/>
-                      </a:solidFill>
-                      <a:prstDash val="solid"/>
-                      <a:round/>
-                      <a:headEnd type="none" w="med" len="med"/>
-                      <a:tailEnd type="none" w="med" len="med"/>
-                    </a:lnR>
-                    <a:lnT w="9525" cap="flat" cmpd="sng" algn="ctr">
-                      <a:solidFill>
-                        <a:srgbClr val="EEF2F8"/>
-                      </a:solidFill>
-                      <a:prstDash val="solid"/>
-                      <a:round/>
-                      <a:headEnd type="none" w="med" len="med"/>
-                      <a:tailEnd type="none" w="med" len="med"/>
-                    </a:lnT>
-                    <a:lnB w="9525" cap="flat" cmpd="sng" algn="ctr">
-                      <a:solidFill>
-                        <a:srgbClr val="EEF2F8"/>
-                      </a:solidFill>
-                      <a:prstDash val="solid"/>
-                      <a:round/>
-                      <a:headEnd type="none" w="med" len="med"/>
-                      <a:tailEnd type="none" w="med" len="med"/>
-                    </a:lnB>
-                  </a:tcPr>
-                </a:tc>
-              </a:tr>
-              <a:tr h="502920">
-                <a:tc>
-                  <a:txBody>
-                    <a:bodyPr/>
-                    <a:lstStyle/>
-                    <a:p>
-                      <a:pPr indent="0" marL="0">
-                        <a:buNone/>
-                      </a:pPr>
-                      <a:r>
-                        <a:rPr lang="en-US" sz="1200" dirty="0">
-                          <a:solidFill>
-                            <a:schemeClr val="tx1"/>
-                          </a:solidFill>
-                        </a:rPr>
-                        <a:t>Desafección</a:t>
-                      </a:r>
-                      <a:endParaRPr lang="en-US" sz="1200" dirty="0"/>
-                    </a:p>
-                  </a:txBody>
-                  <a:tcPr marL="54864" marR="54864" marT="0" marB="0" anchor="ctr">
-                    <a:lnL w="9525" cap="flat" cmpd="sng" algn="ctr">
-                      <a:solidFill>
-                        <a:srgbClr val="EEF2F8"/>
-                      </a:solidFill>
-                      <a:prstDash val="solid"/>
-                      <a:round/>
-                      <a:headEnd type="none" w="med" len="med"/>
-                      <a:tailEnd type="none" w="med" len="med"/>
-                    </a:lnL>
-                    <a:lnR w="9525" cap="flat" cmpd="sng" algn="ctr">
-                      <a:solidFill>
-                        <a:srgbClr val="EEF2F8"/>
-                      </a:solidFill>
-                      <a:prstDash val="solid"/>
-                      <a:round/>
-                      <a:headEnd type="none" w="med" len="med"/>
-                      <a:tailEnd type="none" w="med" len="med"/>
-                    </a:lnR>
-                    <a:lnT w="9525" cap="flat" cmpd="sng" algn="ctr">
-                      <a:solidFill>
-                        <a:srgbClr val="EEF2F8"/>
-                      </a:solidFill>
-                      <a:prstDash val="solid"/>
-                      <a:round/>
-                      <a:headEnd type="none" w="med" len="med"/>
-                      <a:tailEnd type="none" w="med" len="med"/>
-                    </a:lnT>
-                    <a:lnB w="9525" cap="flat" cmpd="sng" algn="ctr">
-                      <a:solidFill>
-                        <a:srgbClr val="EEF2F8"/>
-                      </a:solidFill>
-                      <a:prstDash val="solid"/>
-                      <a:round/>
-                      <a:headEnd type="none" w="med" len="med"/>
-                      <a:tailEnd type="none" w="med" len="med"/>
-                    </a:lnB>
-                  </a:tcPr>
-                </a:tc>
-                <a:tc>
-                  <a:txBody>
-                    <a:bodyPr/>
-                    <a:lstStyle/>
-                    <a:p>
-                      <a:pPr indent="0" marL="0">
-                        <a:buNone/>
-                      </a:pPr>
-                      <a:r>
-                        <a:rPr lang="en-US" sz="1200" dirty="0">
-                          <a:solidFill>
-                            <a:schemeClr val="tx1"/>
-                          </a:solidFill>
-                        </a:rPr>
-                        <a:t>Agenda de la diáspora; 8 encuentros de escucha</a:t>
-                      </a:r>
-                      <a:endParaRPr lang="en-US" sz="1200" dirty="0"/>
-                    </a:p>
-                  </a:txBody>
-                  <a:tcPr marL="54864" marR="54864" marT="0" marB="0" anchor="ctr">
-                    <a:lnL w="9525" cap="flat" cmpd="sng" algn="ctr">
-                      <a:solidFill>
-                        <a:srgbClr val="EEF2F8"/>
-                      </a:solidFill>
-                      <a:prstDash val="solid"/>
-                      <a:round/>
-                      <a:headEnd type="none" w="med" len="med"/>
-                      <a:tailEnd type="none" w="med" len="med"/>
-                    </a:lnL>
-                    <a:lnR w="9525" cap="flat" cmpd="sng" algn="ctr">
-                      <a:solidFill>
-                        <a:srgbClr val="EEF2F8"/>
-                      </a:solidFill>
-                      <a:prstDash val="solid"/>
-                      <a:round/>
-                      <a:headEnd type="none" w="med" len="med"/>
-                      <a:tailEnd type="none" w="med" len="med"/>
-                    </a:lnR>
-                    <a:lnT w="9525" cap="flat" cmpd="sng" algn="ctr">
-                      <a:solidFill>
-                        <a:srgbClr val="EEF2F8"/>
-                      </a:solidFill>
-                      <a:prstDash val="solid"/>
-                      <a:round/>
-                      <a:headEnd type="none" w="med" len="med"/>
-                      <a:tailEnd type="none" w="med" len="med"/>
-                    </a:lnT>
-                    <a:lnB w="9525" cap="flat" cmpd="sng" algn="ctr">
-                      <a:solidFill>
-                        <a:srgbClr val="EEF2F8"/>
-                      </a:solidFill>
-                      <a:prstDash val="solid"/>
-                      <a:round/>
-                      <a:headEnd type="none" w="med" len="med"/>
-                      <a:tailEnd type="none" w="med" len="med"/>
-                    </a:lnB>
-                  </a:tcPr>
-                </a:tc>
-                <a:tc>
-                  <a:txBody>
-                    <a:bodyPr/>
-                    <a:lstStyle/>
-                    <a:p>
-                      <a:pPr indent="0" marL="0">
-                        <a:buNone/>
-                      </a:pPr>
-                      <a:r>
-                        <a:rPr lang="en-US" sz="1200" dirty="0">
-                          <a:solidFill>
-                            <a:schemeClr val="tx1"/>
-                          </a:solidFill>
-                        </a:rPr>
-                        <a:t>Comunicaciones</a:t>
-                      </a:r>
-                      <a:endParaRPr lang="en-US" sz="1200" dirty="0"/>
-                    </a:p>
-                  </a:txBody>
-                  <a:tcPr marL="54864" marR="54864" marT="0" marB="0" anchor="ctr">
-                    <a:lnL w="9525" cap="flat" cmpd="sng" algn="ctr">
-                      <a:solidFill>
-                        <a:srgbClr val="EEF2F8"/>
-                      </a:solidFill>
-                      <a:prstDash val="solid"/>
-                      <a:round/>
-                      <a:headEnd type="none" w="med" len="med"/>
-                      <a:tailEnd type="none" w="med" len="med"/>
-                    </a:lnL>
-                    <a:lnR w="9525" cap="flat" cmpd="sng" algn="ctr">
-                      <a:solidFill>
-                        <a:srgbClr val="EEF2F8"/>
-                      </a:solidFill>
-                      <a:prstDash val="solid"/>
-                      <a:round/>
-                      <a:headEnd type="none" w="med" len="med"/>
-                      <a:tailEnd type="none" w="med" len="med"/>
-                    </a:lnR>
-                    <a:lnT w="9525" cap="flat" cmpd="sng" algn="ctr">
-                      <a:solidFill>
-                        <a:srgbClr val="EEF2F8"/>
-                      </a:solidFill>
-                      <a:prstDash val="solid"/>
-                      <a:round/>
-                      <a:headEnd type="none" w="med" len="med"/>
-                      <a:tailEnd type="none" w="med" len="med"/>
-                    </a:lnT>
-                    <a:lnB w="9525" cap="flat" cmpd="sng" algn="ctr">
-                      <a:solidFill>
-                        <a:srgbClr val="EEF2F8"/>
-                      </a:solidFill>
-                      <a:prstDash val="solid"/>
-                      <a:round/>
-                      <a:headEnd type="none" w="med" len="med"/>
-                      <a:tailEnd type="none" w="med" len="med"/>
-                    </a:lnB>
-                  </a:tcPr>
-                </a:tc>
-              </a:tr>
-              <a:tr h="502920">
-                <a:tc>
-                  <a:txBody>
-                    <a:bodyPr/>
-                    <a:lstStyle/>
-                    <a:p>
-                      <a:pPr indent="0" marL="0">
-                        <a:buNone/>
-                      </a:pPr>
-                      <a:r>
-                        <a:rPr lang="en-US" sz="1200" dirty="0">
-                          <a:solidFill>
-                            <a:schemeClr val="tx1"/>
-                          </a:solidFill>
-                        </a:rPr>
-                        <a:t>Datos incompletos</a:t>
-                      </a:r>
-                      <a:endParaRPr lang="en-US" sz="1200" dirty="0"/>
-                    </a:p>
-                  </a:txBody>
-                  <a:tcPr marL="54864" marR="54864" marT="0" marB="0" anchor="ctr">
-                    <a:lnL w="9525" cap="flat" cmpd="sng" algn="ctr">
-                      <a:solidFill>
-                        <a:srgbClr val="EEF2F8"/>
-                      </a:solidFill>
-                      <a:prstDash val="solid"/>
-                      <a:round/>
-                      <a:headEnd type="none" w="med" len="med"/>
-                      <a:tailEnd type="none" w="med" len="med"/>
-                    </a:lnL>
-                    <a:lnR w="9525" cap="flat" cmpd="sng" algn="ctr">
-                      <a:solidFill>
-                        <a:srgbClr val="EEF2F8"/>
-                      </a:solidFill>
-                      <a:prstDash val="solid"/>
-                      <a:round/>
-                      <a:headEnd type="none" w="med" len="med"/>
-                      <a:tailEnd type="none" w="med" len="med"/>
-                    </a:lnR>
-                    <a:lnT w="9525" cap="flat" cmpd="sng" algn="ctr">
-                      <a:solidFill>
-                        <a:srgbClr val="EEF2F8"/>
-                      </a:solidFill>
-                      <a:prstDash val="solid"/>
-                      <a:round/>
-                      <a:headEnd type="none" w="med" len="med"/>
-                      <a:tailEnd type="none" w="med" len="med"/>
-                    </a:lnT>
-                    <a:lnB w="9525" cap="flat" cmpd="sng" algn="ctr">
-                      <a:solidFill>
-                        <a:srgbClr val="EEF2F8"/>
-                      </a:solidFill>
-                      <a:prstDash val="solid"/>
-                      <a:round/>
-                      <a:headEnd type="none" w="med" len="med"/>
-                      <a:tailEnd type="none" w="med" len="med"/>
-                    </a:lnB>
-                  </a:tcPr>
-                </a:tc>
-                <a:tc>
-                  <a:txBody>
-                    <a:bodyPr/>
-                    <a:lstStyle/>
-                    <a:p>
-                      <a:pPr indent="0" marL="0">
-                        <a:buNone/>
-                      </a:pPr>
-                      <a:r>
-                        <a:rPr lang="en-US" sz="1200" dirty="0">
-                          <a:solidFill>
-                            <a:schemeClr val="tx1"/>
-                          </a:solidFill>
-                        </a:rPr>
-                        <a:t>CRM con registros únicos; actas por mesa</a:t>
-                      </a:r>
-                      <a:endParaRPr lang="en-US" sz="1200" dirty="0"/>
-                    </a:p>
-                  </a:txBody>
-                  <a:tcPr marL="54864" marR="54864" marT="0" marB="0" anchor="ctr">
-                    <a:lnL w="9525" cap="flat" cmpd="sng" algn="ctr">
-                      <a:solidFill>
-                        <a:srgbClr val="EEF2F8"/>
-                      </a:solidFill>
-                      <a:prstDash val="solid"/>
-                      <a:round/>
-                      <a:headEnd type="none" w="med" len="med"/>
-                      <a:tailEnd type="none" w="med" len="med"/>
-                    </a:lnL>
-                    <a:lnR w="9525" cap="flat" cmpd="sng" algn="ctr">
-                      <a:solidFill>
-                        <a:srgbClr val="EEF2F8"/>
-                      </a:solidFill>
-                      <a:prstDash val="solid"/>
-                      <a:round/>
-                      <a:headEnd type="none" w="med" len="med"/>
-                      <a:tailEnd type="none" w="med" len="med"/>
-                    </a:lnR>
-                    <a:lnT w="9525" cap="flat" cmpd="sng" algn="ctr">
-                      <a:solidFill>
-                        <a:srgbClr val="EEF2F8"/>
-                      </a:solidFill>
-                      <a:prstDash val="solid"/>
-                      <a:round/>
-                      <a:headEnd type="none" w="med" len="med"/>
-                      <a:tailEnd type="none" w="med" len="med"/>
-                    </a:lnT>
-                    <a:lnB w="9525" cap="flat" cmpd="sng" algn="ctr">
-                      <a:solidFill>
-                        <a:srgbClr val="EEF2F8"/>
-                      </a:solidFill>
-                      <a:prstDash val="solid"/>
-                      <a:round/>
-                      <a:headEnd type="none" w="med" len="med"/>
-                      <a:tailEnd type="none" w="med" len="med"/>
-                    </a:lnB>
-                  </a:tcPr>
-                </a:tc>
-                <a:tc>
-                  <a:txBody>
-                    <a:bodyPr/>
-                    <a:lstStyle/>
-                    <a:p>
-                      <a:pPr indent="0" marL="0">
-                        <a:buNone/>
-                      </a:pPr>
-                      <a:r>
-                        <a:rPr lang="en-US" sz="1200" dirty="0">
-                          <a:solidFill>
-                            <a:schemeClr val="tx1"/>
-                          </a:solidFill>
-                        </a:rPr>
-                        <a:t>Tecnología y Datos</a:t>
-                      </a:r>
-                      <a:endParaRPr lang="en-US" sz="1200" dirty="0"/>
-                    </a:p>
-                  </a:txBody>
-                  <a:tcPr marL="54864" marR="54864" marT="0" marB="0" anchor="ctr">
-                    <a:lnL w="9525" cap="flat" cmpd="sng" algn="ctr">
-                      <a:solidFill>
-                        <a:srgbClr val="EEF2F8"/>
-                      </a:solidFill>
-                      <a:prstDash val="solid"/>
-                      <a:round/>
-                      <a:headEnd type="none" w="med" len="med"/>
-                      <a:tailEnd type="none" w="med" len="med"/>
-                    </a:lnL>
-                    <a:lnR w="9525" cap="flat" cmpd="sng" algn="ctr">
-                      <a:solidFill>
-                        <a:srgbClr val="EEF2F8"/>
-                      </a:solidFill>
-                      <a:prstDash val="solid"/>
-                      <a:round/>
-                      <a:headEnd type="none" w="med" len="med"/>
-                      <a:tailEnd type="none" w="med" len="med"/>
-                    </a:lnR>
-                    <a:lnT w="9525" cap="flat" cmpd="sng" algn="ctr">
-                      <a:solidFill>
-                        <a:srgbClr val="EEF2F8"/>
-                      </a:solidFill>
-                      <a:prstDash val="solid"/>
-                      <a:round/>
-                      <a:headEnd type="none" w="med" len="med"/>
-                      <a:tailEnd type="none" w="med" len="med"/>
-                    </a:lnT>
-                    <a:lnB w="9525" cap="flat" cmpd="sng" algn="ctr">
-                      <a:solidFill>
-                        <a:srgbClr val="EEF2F8"/>
-                      </a:solidFill>
-                      <a:prstDash val="solid"/>
-                      <a:round/>
-                      <a:headEnd type="none" w="med" len="med"/>
-                      <a:tailEnd type="none" w="med" len="med"/>
-                    </a:lnB>
-                  </a:tcPr>
-                </a:tc>
-              </a:tr>
-              <a:tr h="502920">
-                <a:tc>
-                  <a:txBody>
-                    <a:bodyPr/>
-                    <a:lstStyle/>
-                    <a:p>
-                      <a:pPr indent="0" marL="0">
-                        <a:buNone/>
-                      </a:pPr>
-                      <a:r>
-                        <a:rPr lang="en-US" sz="1200" dirty="0">
-                          <a:solidFill>
-                            <a:schemeClr val="tx1"/>
-                          </a:solidFill>
-                        </a:rPr>
-                        <a:t>División interna</a:t>
-                      </a:r>
-                      <a:endParaRPr lang="en-US" sz="1200" dirty="0"/>
-                    </a:p>
-                  </a:txBody>
-                  <a:tcPr marL="54864" marR="54864" marT="0" marB="0" anchor="ctr">
-                    <a:lnL w="9525" cap="flat" cmpd="sng" algn="ctr">
-                      <a:solidFill>
-                        <a:srgbClr val="EEF2F8"/>
-                      </a:solidFill>
-                      <a:prstDash val="solid"/>
-                      <a:round/>
-                      <a:headEnd type="none" w="med" len="med"/>
-                      <a:tailEnd type="none" w="med" len="med"/>
-                    </a:lnL>
-                    <a:lnR w="9525" cap="flat" cmpd="sng" algn="ctr">
-                      <a:solidFill>
-                        <a:srgbClr val="EEF2F8"/>
-                      </a:solidFill>
-                      <a:prstDash val="solid"/>
-                      <a:round/>
-                      <a:headEnd type="none" w="med" len="med"/>
-                      <a:tailEnd type="none" w="med" len="med"/>
-                    </a:lnR>
-                    <a:lnT w="9525" cap="flat" cmpd="sng" algn="ctr">
-                      <a:solidFill>
-                        <a:srgbClr val="EEF2F8"/>
-                      </a:solidFill>
-                      <a:prstDash val="solid"/>
-                      <a:round/>
-                      <a:headEnd type="none" w="med" len="med"/>
-                      <a:tailEnd type="none" w="med" len="med"/>
-                    </a:lnT>
-                    <a:lnB w="9525" cap="flat" cmpd="sng" algn="ctr">
-                      <a:solidFill>
-                        <a:srgbClr val="EEF2F8"/>
-                      </a:solidFill>
-                      <a:prstDash val="solid"/>
-                      <a:round/>
-                      <a:headEnd type="none" w="med" len="med"/>
-                      <a:tailEnd type="none" w="med" len="med"/>
-                    </a:lnB>
-                  </a:tcPr>
-                </a:tc>
-                <a:tc>
-                  <a:txBody>
-                    <a:bodyPr/>
-                    <a:lstStyle/>
-                    <a:p>
-                      <a:pPr indent="0" marL="0">
-                        <a:buNone/>
-                      </a:pPr>
-                      <a:r>
-                        <a:rPr lang="en-US" sz="1200" dirty="0">
-                          <a:solidFill>
-                            <a:schemeClr val="tx1"/>
-                          </a:solidFill>
-                        </a:rPr>
-                        <a:t>Una sola estructura con la Seccional PRM</a:t>
-                      </a:r>
-                      <a:endParaRPr lang="en-US" sz="1200" dirty="0"/>
-                    </a:p>
-                  </a:txBody>
-                  <a:tcPr marL="54864" marR="54864" marT="0" marB="0" anchor="ctr">
-                    <a:lnL w="9525" cap="flat" cmpd="sng" algn="ctr">
-                      <a:solidFill>
-                        <a:srgbClr val="EEF2F8"/>
-                      </a:solidFill>
-                      <a:prstDash val="solid"/>
-                      <a:round/>
-                      <a:headEnd type="none" w="med" len="med"/>
-                      <a:tailEnd type="none" w="med" len="med"/>
-                    </a:lnL>
-                    <a:lnR w="9525" cap="flat" cmpd="sng" algn="ctr">
-                      <a:solidFill>
-                        <a:srgbClr val="EEF2F8"/>
-                      </a:solidFill>
-                      <a:prstDash val="solid"/>
-                      <a:round/>
-                      <a:headEnd type="none" w="med" len="med"/>
-                      <a:tailEnd type="none" w="med" len="med"/>
-                    </a:lnR>
-                    <a:lnT w="9525" cap="flat" cmpd="sng" algn="ctr">
-                      <a:solidFill>
-                        <a:srgbClr val="EEF2F8"/>
-                      </a:solidFill>
-                      <a:prstDash val="solid"/>
-                      <a:round/>
-                      <a:headEnd type="none" w="med" len="med"/>
-                      <a:tailEnd type="none" w="med" len="med"/>
-                    </a:lnT>
-                    <a:lnB w="9525" cap="flat" cmpd="sng" algn="ctr">
-                      <a:solidFill>
-                        <a:srgbClr val="EEF2F8"/>
-                      </a:solidFill>
-                      <a:prstDash val="solid"/>
-                      <a:round/>
-                      <a:headEnd type="none" w="med" len="med"/>
-                      <a:tailEnd type="none" w="med" len="med"/>
-                    </a:lnB>
-                  </a:tcPr>
-                </a:tc>
-                <a:tc>
-                  <a:txBody>
-                    <a:bodyPr/>
-                    <a:lstStyle/>
-                    <a:p>
-                      <a:pPr indent="0" marL="0">
-                        <a:buNone/>
-                      </a:pPr>
-                      <a:r>
-                        <a:rPr lang="en-US" sz="1200" dirty="0">
-                          <a:solidFill>
-                            <a:schemeClr val="tx1"/>
-                          </a:solidFill>
-                        </a:rPr>
-                        <a:t>Dirección ejecutiva</a:t>
-                      </a:r>
-                      <a:endParaRPr lang="en-US" sz="1200" dirty="0"/>
-                    </a:p>
-                  </a:txBody>
-                  <a:tcPr marL="54864" marR="54864" marT="0" marB="0" anchor="ctr">
-                    <a:lnL w="9525" cap="flat" cmpd="sng" algn="ctr">
-                      <a:solidFill>
-                        <a:srgbClr val="EEF2F8"/>
-                      </a:solidFill>
-                      <a:prstDash val="solid"/>
-                      <a:round/>
-                      <a:headEnd type="none" w="med" len="med"/>
-                      <a:tailEnd type="none" w="med" len="med"/>
-                    </a:lnL>
-                    <a:lnR w="9525" cap="flat" cmpd="sng" algn="ctr">
-                      <a:solidFill>
-                        <a:srgbClr val="EEF2F8"/>
-                      </a:solidFill>
-                      <a:prstDash val="solid"/>
-                      <a:round/>
-                      <a:headEnd type="none" w="med" len="med"/>
-                      <a:tailEnd type="none" w="med" len="med"/>
-                    </a:lnR>
-                    <a:lnT w="9525" cap="flat" cmpd="sng" algn="ctr">
-                      <a:solidFill>
-                        <a:srgbClr val="EEF2F8"/>
-                      </a:solidFill>
-                      <a:prstDash val="solid"/>
-                      <a:round/>
-                      <a:headEnd type="none" w="med" len="med"/>
-                      <a:tailEnd type="none" w="med" len="med"/>
-                    </a:lnT>
-                    <a:lnB w="9525" cap="flat" cmpd="sng" algn="ctr">
-                      <a:solidFill>
-                        <a:srgbClr val="EEF2F8"/>
-                      </a:solidFill>
-                      <a:prstDash val="solid"/>
-                      <a:round/>
-                      <a:headEnd type="none" w="med" len="med"/>
-                      <a:tailEnd type="none" w="med" len="med"/>
-                    </a:lnB>
-                  </a:tcPr>
-                </a:tc>
-              </a:tr>
-              <a:tr h="502920">
-                <a:tc>
-                  <a:txBody>
-                    <a:bodyPr/>
-                    <a:lstStyle/>
-                    <a:p>
-                      <a:pPr indent="0" marL="0">
-                        <a:buNone/>
-                      </a:pPr>
-                      <a:r>
-                        <a:rPr lang="en-US" sz="1200" dirty="0">
-                          <a:solidFill>
-                            <a:schemeClr val="tx1"/>
-                          </a:solidFill>
-                        </a:rPr>
-                        <a:t>Cumplimiento legal</a:t>
-                      </a:r>
-                      <a:endParaRPr lang="en-US" sz="1200" dirty="0"/>
-                    </a:p>
-                  </a:txBody>
-                  <a:tcPr marL="54864" marR="54864" marT="0" marB="0" anchor="ctr">
-                    <a:lnL w="9525" cap="flat" cmpd="sng" algn="ctr">
-                      <a:solidFill>
-                        <a:srgbClr val="EEF2F8"/>
-                      </a:solidFill>
-                      <a:prstDash val="solid"/>
-                      <a:round/>
-                      <a:headEnd type="none" w="med" len="med"/>
-                      <a:tailEnd type="none" w="med" len="med"/>
-                    </a:lnL>
-                    <a:lnR w="9525" cap="flat" cmpd="sng" algn="ctr">
-                      <a:solidFill>
-                        <a:srgbClr val="EEF2F8"/>
-                      </a:solidFill>
-                      <a:prstDash val="solid"/>
-                      <a:round/>
-                      <a:headEnd type="none" w="med" len="med"/>
-                      <a:tailEnd type="none" w="med" len="med"/>
-                    </a:lnR>
-                    <a:lnT w="9525" cap="flat" cmpd="sng" algn="ctr">
-                      <a:solidFill>
-                        <a:srgbClr val="EEF2F8"/>
-                      </a:solidFill>
-                      <a:prstDash val="solid"/>
-                      <a:round/>
-                      <a:headEnd type="none" w="med" len="med"/>
-                      <a:tailEnd type="none" w="med" len="med"/>
-                    </a:lnT>
-                    <a:lnB w="9525" cap="flat" cmpd="sng" algn="ctr">
-                      <a:solidFill>
-                        <a:srgbClr val="EEF2F8"/>
-                      </a:solidFill>
-                      <a:prstDash val="solid"/>
-                      <a:round/>
-                      <a:headEnd type="none" w="med" len="med"/>
-                      <a:tailEnd type="none" w="med" len="med"/>
-                    </a:lnB>
-                  </a:tcPr>
-                </a:tc>
-                <a:tc>
-                  <a:txBody>
-                    <a:bodyPr/>
-                    <a:lstStyle/>
-                    <a:p>
-                      <a:pPr indent="0" marL="0">
-                        <a:buNone/>
-                      </a:pPr>
-                      <a:r>
-                        <a:rPr lang="en-US" sz="1200" dirty="0">
-                          <a:solidFill>
-                            <a:schemeClr val="tx1"/>
-                          </a:solidFill>
-                        </a:rPr>
-                        <a:t>Revisión de actividades; datos con consentimiento</a:t>
-                      </a:r>
-                      <a:endParaRPr lang="en-US" sz="1200" dirty="0"/>
-                    </a:p>
-                  </a:txBody>
-                  <a:tcPr marL="54864" marR="54864" marT="0" marB="0" anchor="ctr">
-                    <a:lnL w="9525" cap="flat" cmpd="sng" algn="ctr">
-                      <a:solidFill>
-                        <a:srgbClr val="EEF2F8"/>
-                      </a:solidFill>
-                      <a:prstDash val="solid"/>
-                      <a:round/>
-                      <a:headEnd type="none" w="med" len="med"/>
-                      <a:tailEnd type="none" w="med" len="med"/>
-                    </a:lnL>
-                    <a:lnR w="9525" cap="flat" cmpd="sng" algn="ctr">
-                      <a:solidFill>
-                        <a:srgbClr val="EEF2F8"/>
-                      </a:solidFill>
-                      <a:prstDash val="solid"/>
-                      <a:round/>
-                      <a:headEnd type="none" w="med" len="med"/>
-                      <a:tailEnd type="none" w="med" len="med"/>
-                    </a:lnR>
-                    <a:lnT w="9525" cap="flat" cmpd="sng" algn="ctr">
-                      <a:solidFill>
-                        <a:srgbClr val="EEF2F8"/>
-                      </a:solidFill>
-                      <a:prstDash val="solid"/>
-                      <a:round/>
-                      <a:headEnd type="none" w="med" len="med"/>
-                      <a:tailEnd type="none" w="med" len="med"/>
-                    </a:lnT>
-                    <a:lnB w="9525" cap="flat" cmpd="sng" algn="ctr">
-                      <a:solidFill>
-                        <a:srgbClr val="EEF2F8"/>
-                      </a:solidFill>
-                      <a:prstDash val="solid"/>
-                      <a:round/>
-                      <a:headEnd type="none" w="med" len="med"/>
-                      <a:tailEnd type="none" w="med" len="med"/>
-                    </a:lnB>
-                  </a:tcPr>
-                </a:tc>
-                <a:tc>
-                  <a:txBody>
-                    <a:bodyPr/>
-                    <a:lstStyle/>
-                    <a:p>
-                      <a:pPr indent="0" marL="0">
-                        <a:buNone/>
-                      </a:pPr>
-                      <a:r>
-                        <a:rPr lang="en-US" sz="1200" dirty="0">
-                          <a:solidFill>
-                            <a:schemeClr val="tx1"/>
-                          </a:solidFill>
-                        </a:rPr>
-                        <a:t>Finanzas y Legal</a:t>
-                      </a:r>
-                      <a:endParaRPr lang="en-US" sz="1200" dirty="0"/>
-                    </a:p>
-                  </a:txBody>
-                  <a:tcPr marL="54864" marR="54864" marT="0" marB="0" anchor="ctr">
-                    <a:lnL w="9525" cap="flat" cmpd="sng" algn="ctr">
-                      <a:solidFill>
-                        <a:srgbClr val="EEF2F8"/>
-                      </a:solidFill>
-                      <a:prstDash val="solid"/>
-                      <a:round/>
-                      <a:headEnd type="none" w="med" len="med"/>
-                      <a:tailEnd type="none" w="med" len="med"/>
-                    </a:lnL>
-                    <a:lnR w="9525" cap="flat" cmpd="sng" algn="ctr">
-                      <a:solidFill>
-                        <a:srgbClr val="EEF2F8"/>
-                      </a:solidFill>
-                      <a:prstDash val="solid"/>
-                      <a:round/>
-                      <a:headEnd type="none" w="med" len="med"/>
-                      <a:tailEnd type="none" w="med" len="med"/>
-                    </a:lnR>
-                    <a:lnT w="9525" cap="flat" cmpd="sng" algn="ctr">
-                      <a:solidFill>
-                        <a:srgbClr val="EEF2F8"/>
-                      </a:solidFill>
-                      <a:prstDash val="solid"/>
-                      <a:round/>
-                      <a:headEnd type="none" w="med" len="med"/>
-                      <a:tailEnd type="none" w="med" len="med"/>
-                    </a:lnT>
-                    <a:lnB w="9525" cap="flat" cmpd="sng" algn="ctr">
-                      <a:solidFill>
-                        <a:srgbClr val="EEF2F8"/>
-                      </a:solidFill>
-                      <a:prstDash val="solid"/>
-                      <a:round/>
-                      <a:headEnd type="none" w="med" len="med"/>
-                      <a:tailEnd type="none" w="med" len="med"/>
-                    </a:lnB>
-                  </a:tcPr>
-                </a:tc>
-              </a:tr>
-            </a:tbl>
-          </a:graphicData>
-        </a:graphic>
-      </p:graphicFrame>
-      <p:sp>
-        <p:nvSpPr>
-          <p:cNvPr id="25" name="Slide Number Placeholder 0"/>
-          <p:cNvSpPr>
-            <a:spLocks noGrp="1"/>
-          </p:cNvSpPr>
-          <p:nvPr>
-            <p:ph type="sldNum" sz="quarter" idx="4294967295"/>
-          </p:nvPr>
-        </p:nvSpPr>
-        <p:spPr>
-          <a:xfrm>
-            <a:off x="11155680" y="6400800"/>
-            <a:ext cx="548640" cy="274320"/>
-          </a:xfrm>
-          <a:prstGeom prst="rect">
-            <a:avLst/>
-          </a:prstGeom>
-          <a:extLst>
-            <a:ext uri="{C572A759-6A51-4108-AA02-DFA0A04FC94B}">
-              <ma14:wrappingTextBoxFlag xmlns:ma14="http://schemas.microsoft.com/office/mac/drawingml/2011/main" val="0"/>
-            </a:ext>
-          </a:extLst>
-        </p:spPr>
-        <p:txBody>
-          <a:bodyPr/>
-          <a:lstStyle>
-            <a:lvl1pPr>
-              <a:defRPr sz="1000">
-                <a:solidFill>
-                  <a:schemeClr val="accent4"/>
-                </a:solidFill>
-              </a:defRPr>
-            </a:lvl1pPr>
-          </a:lstStyle>
-          <a:p>
-            <a:pPr algn="r"/>
-            <a:fld id="{F7021451-1387-4CA6-816F-3879F97B5CBC}" type="slidenum">
-              <a:rPr b="0" lang="en-US"/>
-              <a:t>10</a:t>
-            </a:fld>
-            <a:endParaRPr lang="en-US"/>
-          </a:p>
-        </p:txBody>
-      </p:sp>
-    </p:spTree>
-  </p:cSld>
-  <p:clrMapOvr>
-    <a:masterClrMapping/>
-  </p:clrMapOvr>
-</p:sld>
-</file>
-
-<file path=ppt/slides/slide11.xml><?xml version="1.0" encoding="utf-8"?>
-<p:sld xmlns:a="http://schemas.openxmlformats.org/drawingml/2006/main" xmlns:r="http://schemas.openxmlformats.org/officeDocument/2006/relationships" xmlns:p="http://schemas.openxmlformats.org/presentationml/2006/main">
-  <p:cSld name="Slide 11">
-    <p:spTree>
-      <p:nvGrpSpPr>
-        <p:cNvPr id="1" name=""/>
-        <p:cNvGrpSpPr/>
-        <p:nvPr/>
-      </p:nvGrpSpPr>
-      <p:grpSpPr>
-        <a:xfrm>
-          <a:off x="0" y="0"/>
-          <a:ext cx="0" cy="0"/>
-          <a:chOff x="0" y="0"/>
-          <a:chExt cx="0" cy="0"/>
-        </a:xfrm>
-      </p:grpSpPr>
-      <p:sp>
-        <p:nvSpPr>
           <p:cNvPr id="2" name="Titulo"/>
           <p:cNvSpPr txBox="1"/>
           <p:nvPr/>
@@ -7177,7 +4267,7 @@
             <a:pPr algn="r"/>
             <a:fld id="{F7021451-1387-4CA6-816F-3879F97B5CBC}" type="slidenum">
               <a:rPr b="0" lang="en-US"/>
-              <a:t>11</a:t>
+              <a:t>10</a:t>
             </a:fld>
             <a:endParaRPr lang="en-US"/>
           </a:p>

</xml_diff>

<commit_message>
Barra de navegación por secciones en todas las diapositivas (enlaces internos en PPTX y PDF) y en la versión web
Co-Authored-By: Claude Opus 5.5 <noreply@anthropic.com>
Claude-Session: https://claude.ai/code/session_01RrEJtrwRidXxzgveZEVQjf
</commit_message>
<xml_diff>
--- a/presentaciones/Plan_Estrategico_Pennsylvania_2028.pptx
+++ b/presentaciones/Plan_Estrategico_Pennsylvania_2028.pptx
@@ -116,7 +116,7 @@
   <p:extLst>
     <p:ext uri="{521415D9-36F7-43E2-AB2F-B90AF26B5E84}">
       <p14:sectionLst xmlns:p14="http://schemas.microsoft.com/office/powerpoint/2010/main">
-        <p14:section name="Diagnóstico" id="{d950ac19-7cee-2584-3de0-c6b84d5799cd}">
+        <p14:section name="Diagnóstico" id="{610ae22a-1fdd-8c98-6053-5f3a6570370f}">
           <p14:sldIdLst>
             <p14:sldId id="256"/>
             <p14:sldId id="257"/>
@@ -124,22 +124,22 @@
             <p14:sldId id="259"/>
           </p14:sldIdLst>
         </p14:section>
-        <p14:section name="Riesgos" id="{3086cc7e-a762-a172-3769-74f0339b3588}">
+        <p14:section name="Riesgos" id="{5c9431a8-3dfe-2666-00fe-c280f5ddff39}">
           <p14:sldIdLst>
             <p14:sldId id="260"/>
           </p14:sldIdLst>
         </p14:section>
-        <p14:section name="Resultados 2024" id="{5515d0bb-f72a-05cd-0d36-688c0cd54000}">
+        <p14:section name="Resultados 2024" id="{3e7f8c2d-276a-ff6e-e64a-33e557910cdf}">
           <p14:sldIdLst>
             <p14:sldId id="261"/>
           </p14:sldIdLst>
         </p14:section>
-        <p14:section name="Meta" id="{c7c40058-fe31-6ded-6b70-506df0f6a985}">
+        <p14:section name="Meta" id="{cec5a85e-49b9-2c43-4e20-295089137b48}">
           <p14:sldIdLst>
             <p14:sldId id="262"/>
           </p14:sldIdLst>
         </p14:section>
-        <p14:section name="Plan y recomendación" id="{8970b575-728c-0754-a828-379ea98246fe}">
+        <p14:section name="Plan y recomendación" id="{a4afb536-4cee-b15b-b979-4a966fb327bf}">
           <p14:sldIdLst>
             <p14:sldId id="263"/>
             <p14:sldId id="264"/>
@@ -2416,8 +2416,8 @@
         </p:nvSpPr>
         <p:spPr>
           <a:xfrm>
-            <a:off x="548640" y="320040"/>
-            <a:ext cx="11091672" cy="1051560"/>
+            <a:off x="548640" y="502920"/>
+            <a:ext cx="11091672" cy="1005840"/>
           </a:xfrm>
           <a:prstGeom prst="rect">
             <a:avLst/>
@@ -3392,6 +3392,287 @@
       </p:sp>
       <p:sp>
         <p:nvSpPr>
+          <p:cNvPr id="17" name="Barra de navegación"/>
+          <p:cNvSpPr/>
+          <p:nvPr/>
+        </p:nvSpPr>
+        <p:spPr>
+          <a:xfrm>
+            <a:off x="0" y="0"/>
+            <a:ext cx="12191695" cy="384048"/>
+          </a:xfrm>
+          <a:prstGeom prst="rect">
+            <a:avLst/>
+          </a:prstGeom>
+          <a:solidFill>
+            <a:srgbClr val="001F4A"/>
+          </a:solidFill>
+          <a:ln w="12700">
+            <a:solidFill>
+              <a:srgbClr val="001F4A"/>
+            </a:solidFill>
+            <a:prstDash val="solid"/>
+          </a:ln>
+        </p:spPr>
+      </p:sp>
+      <p:sp>
+        <p:nvSpPr>
+          <p:cNvPr id="18" name="Shape 14"/>
+          <p:cNvSpPr/>
+          <p:nvPr/>
+        </p:nvSpPr>
+        <p:spPr>
+          <a:xfrm>
+            <a:off x="0" y="384048"/>
+            <a:ext cx="12191695" cy="0"/>
+          </a:xfrm>
+          <a:prstGeom prst="line">
+            <a:avLst/>
+          </a:prstGeom>
+          <a:noFill/>
+          <a:ln w="9525">
+            <a:solidFill>
+              <a:srgbClr val="2E4C7A"/>
+            </a:solidFill>
+            <a:prstDash val="solid"/>
+          </a:ln>
+        </p:spPr>
+      </p:sp>
+      <p:sp>
+        <p:nvSpPr>
+          <p:cNvPr id="19" name="Pestaña Diagnóstico"/>
+          <p:cNvSpPr txBox="1"/>
+          <p:nvPr/>
+        </p:nvSpPr>
+        <p:spPr>
+          <a:xfrm>
+            <a:off x="548640" y="0"/>
+            <a:ext cx="2218334" cy="384048"/>
+          </a:xfrm>
+          <a:prstGeom prst="rect">
+            <a:avLst/>
+          </a:prstGeom>
+          <a:noFill/>
+          <a:ln/>
+        </p:spPr>
+        <p:txBody>
+          <a:bodyPr wrap="square" lIns="0" tIns="0" rIns="0" bIns="0" rtlCol="0" anchor="ctr"/>
+          <a:lstStyle/>
+          <a:p>
+            <a:pPr algn="ctr" indent="0" marL="0">
+              <a:buNone/>
+            </a:pPr>
+            <a:r>
+              <a:rPr lang="en-US" sz="1000" b="1" spc="150" kern="0" dirty="0">
+                <a:solidFill>
+                  <a:srgbClr val="FFFFFF"/>
+                </a:solidFill>
+              </a:rPr>
+              <a:t>DIAGNÓSTICO</a:t>
+            </a:r>
+            <a:endParaRPr lang="en-US" sz="1000" dirty="0"/>
+          </a:p>
+        </p:txBody>
+      </p:sp>
+      <p:sp>
+        <p:nvSpPr>
+          <p:cNvPr id="20" name="Sección actual"/>
+          <p:cNvSpPr/>
+          <p:nvPr/>
+        </p:nvSpPr>
+        <p:spPr>
+          <a:xfrm>
+            <a:off x="1214140" y="338328"/>
+            <a:ext cx="887334" cy="45720"/>
+          </a:xfrm>
+          <a:prstGeom prst="rect">
+            <a:avLst/>
+          </a:prstGeom>
+          <a:solidFill>
+            <a:srgbClr val="DA1822"/>
+          </a:solidFill>
+          <a:ln w="12700">
+            <a:solidFill>
+              <a:srgbClr val="DA1822"/>
+            </a:solidFill>
+            <a:prstDash val="solid"/>
+          </a:ln>
+        </p:spPr>
+      </p:sp>
+      <p:sp>
+        <p:nvSpPr>
+          <p:cNvPr id="21" name="Pestaña Riesgos"/>
+          <p:cNvSpPr txBox="1"/>
+          <p:nvPr/>
+        </p:nvSpPr>
+        <p:spPr>
+          <a:xfrm>
+            <a:off x="2766974" y="0"/>
+            <a:ext cx="2218334" cy="384048"/>
+          </a:xfrm>
+          <a:prstGeom prst="rect">
+            <a:avLst/>
+          </a:prstGeom>
+          <a:noFill/>
+          <a:ln/>
+        </p:spPr>
+        <p:txBody>
+          <a:bodyPr wrap="square" lIns="0" tIns="0" rIns="0" bIns="0" rtlCol="0" anchor="ctr"/>
+          <a:lstStyle/>
+          <a:p>
+            <a:pPr algn="ctr" indent="0" marL="0">
+              <a:buNone/>
+            </a:pPr>
+            <a:r>
+              <a:rPr lang="en-US" sz="1000" u="none" spc="150" kern="0" dirty="0">
+                <a:solidFill>
+                  <a:srgbClr val="AFC0DA"/>
+                </a:solidFill>
+                <a:hlinkClick r:id="rId2" action="ppaction://hlinksldjump" tooltip="Ir a Riesgos">
+                  <a:extLst>
+                    <a:ext uri="{A12FA001-AC4F-418D-AE19-62706E023703}">
+                      <ahyp:hlinkClr xmlns:ahyp="http://schemas.microsoft.com/office/drawing/2018/hyperlinkcolor" val="tx"/>
+                    </a:ext>
+                  </a:extLst>
+                </a:hlinkClick>
+              </a:rPr>
+              <a:t>RIESGOS</a:t>
+            </a:r>
+            <a:endParaRPr lang="en-US" sz="1000" dirty="0"/>
+          </a:p>
+        </p:txBody>
+      </p:sp>
+      <p:sp>
+        <p:nvSpPr>
+          <p:cNvPr id="22" name="Pestaña Resultados 2024"/>
+          <p:cNvSpPr txBox="1"/>
+          <p:nvPr/>
+        </p:nvSpPr>
+        <p:spPr>
+          <a:xfrm>
+            <a:off x="4985309" y="0"/>
+            <a:ext cx="2218334" cy="384048"/>
+          </a:xfrm>
+          <a:prstGeom prst="rect">
+            <a:avLst/>
+          </a:prstGeom>
+          <a:noFill/>
+          <a:ln/>
+        </p:spPr>
+        <p:txBody>
+          <a:bodyPr wrap="square" lIns="0" tIns="0" rIns="0" bIns="0" rtlCol="0" anchor="ctr"/>
+          <a:lstStyle/>
+          <a:p>
+            <a:pPr algn="ctr" indent="0" marL="0">
+              <a:buNone/>
+            </a:pPr>
+            <a:r>
+              <a:rPr lang="en-US" sz="1000" u="none" spc="150" kern="0" dirty="0">
+                <a:solidFill>
+                  <a:srgbClr val="AFC0DA"/>
+                </a:solidFill>
+                <a:hlinkClick r:id="rId3" action="ppaction://hlinksldjump" tooltip="Ir a Resultados 2024">
+                  <a:extLst>
+                    <a:ext uri="{A12FA001-AC4F-418D-AE19-62706E023703}">
+                      <ahyp:hlinkClr xmlns:ahyp="http://schemas.microsoft.com/office/drawing/2018/hyperlinkcolor" val="tx"/>
+                    </a:ext>
+                  </a:extLst>
+                </a:hlinkClick>
+              </a:rPr>
+              <a:t>RESULTADOS 2024</a:t>
+            </a:r>
+            <a:endParaRPr lang="en-US" sz="1000" dirty="0"/>
+          </a:p>
+        </p:txBody>
+      </p:sp>
+      <p:sp>
+        <p:nvSpPr>
+          <p:cNvPr id="23" name="Pestaña Meta"/>
+          <p:cNvSpPr txBox="1"/>
+          <p:nvPr/>
+        </p:nvSpPr>
+        <p:spPr>
+          <a:xfrm>
+            <a:off x="7203643" y="0"/>
+            <a:ext cx="2218334" cy="384048"/>
+          </a:xfrm>
+          <a:prstGeom prst="rect">
+            <a:avLst/>
+          </a:prstGeom>
+          <a:noFill/>
+          <a:ln/>
+        </p:spPr>
+        <p:txBody>
+          <a:bodyPr wrap="square" lIns="0" tIns="0" rIns="0" bIns="0" rtlCol="0" anchor="ctr"/>
+          <a:lstStyle/>
+          <a:p>
+            <a:pPr algn="ctr" indent="0" marL="0">
+              <a:buNone/>
+            </a:pPr>
+            <a:r>
+              <a:rPr lang="en-US" sz="1000" u="none" spc="150" kern="0" dirty="0">
+                <a:solidFill>
+                  <a:srgbClr val="AFC0DA"/>
+                </a:solidFill>
+                <a:hlinkClick r:id="rId4" action="ppaction://hlinksldjump" tooltip="Ir a Meta">
+                  <a:extLst>
+                    <a:ext uri="{A12FA001-AC4F-418D-AE19-62706E023703}">
+                      <ahyp:hlinkClr xmlns:ahyp="http://schemas.microsoft.com/office/drawing/2018/hyperlinkcolor" val="tx"/>
+                    </a:ext>
+                  </a:extLst>
+                </a:hlinkClick>
+              </a:rPr>
+              <a:t>META</a:t>
+            </a:r>
+            <a:endParaRPr lang="en-US" sz="1000" dirty="0"/>
+          </a:p>
+        </p:txBody>
+      </p:sp>
+      <p:sp>
+        <p:nvSpPr>
+          <p:cNvPr id="24" name="Pestaña Plan y recomendación"/>
+          <p:cNvSpPr txBox="1"/>
+          <p:nvPr/>
+        </p:nvSpPr>
+        <p:spPr>
+          <a:xfrm>
+            <a:off x="9421978" y="0"/>
+            <a:ext cx="2218334" cy="384048"/>
+          </a:xfrm>
+          <a:prstGeom prst="rect">
+            <a:avLst/>
+          </a:prstGeom>
+          <a:noFill/>
+          <a:ln/>
+        </p:spPr>
+        <p:txBody>
+          <a:bodyPr wrap="square" lIns="0" tIns="0" rIns="0" bIns="0" rtlCol="0" anchor="ctr"/>
+          <a:lstStyle/>
+          <a:p>
+            <a:pPr algn="ctr" indent="0" marL="0">
+              <a:buNone/>
+            </a:pPr>
+            <a:r>
+              <a:rPr lang="en-US" sz="1000" u="none" spc="150" kern="0" dirty="0">
+                <a:solidFill>
+                  <a:srgbClr val="AFC0DA"/>
+                </a:solidFill>
+                <a:hlinkClick r:id="rId5" action="ppaction://hlinksldjump" tooltip="Ir a Plan y recomendación">
+                  <a:extLst>
+                    <a:ext uri="{A12FA001-AC4F-418D-AE19-62706E023703}">
+                      <ahyp:hlinkClr xmlns:ahyp="http://schemas.microsoft.com/office/drawing/2018/hyperlinkcolor" val="tx"/>
+                    </a:ext>
+                  </a:extLst>
+                </a:hlinkClick>
+              </a:rPr>
+              <a:t>PLAN Y RECOMENDACIÓN</a:t>
+            </a:r>
+            <a:endParaRPr lang="en-US" sz="1000" dirty="0"/>
+          </a:p>
+        </p:txBody>
+      </p:sp>
+      <p:sp>
+        <p:nvSpPr>
           <p:cNvPr id="25" name="Slide Number Placeholder 0"/>
           <p:cNvSpPr>
             <a:spLocks noGrp="1"/>
@@ -3468,8 +3749,8 @@
         </p:nvSpPr>
         <p:spPr>
           <a:xfrm>
-            <a:off x="548640" y="365760"/>
-            <a:ext cx="11091672" cy="1051560"/>
+            <a:off x="548640" y="502920"/>
+            <a:ext cx="11091672" cy="960120"/>
           </a:xfrm>
           <a:prstGeom prst="rect">
             <a:avLst/>
@@ -3507,8 +3788,8 @@
         </p:nvSpPr>
         <p:spPr>
           <a:xfrm>
-            <a:off x="548640" y="1417320"/>
-            <a:ext cx="11091672" cy="411480"/>
+            <a:off x="548640" y="1481328"/>
+            <a:ext cx="11091672" cy="457200"/>
           </a:xfrm>
           <a:prstGeom prst="rect">
             <a:avLst/>
@@ -4227,6 +4508,287 @@
             <a:endParaRPr lang="en-US" sz="1600" dirty="0"/>
           </a:p>
         </p:txBody>
+      </p:sp>
+      <p:sp>
+        <p:nvSpPr>
+          <p:cNvPr id="26" name="Barra de navegación"/>
+          <p:cNvSpPr/>
+          <p:nvPr/>
+        </p:nvSpPr>
+        <p:spPr>
+          <a:xfrm>
+            <a:off x="0" y="0"/>
+            <a:ext cx="12191695" cy="384048"/>
+          </a:xfrm>
+          <a:prstGeom prst="rect">
+            <a:avLst/>
+          </a:prstGeom>
+          <a:solidFill>
+            <a:srgbClr val="001F4A"/>
+          </a:solidFill>
+          <a:ln w="12700">
+            <a:solidFill>
+              <a:srgbClr val="001F4A"/>
+            </a:solidFill>
+            <a:prstDash val="solid"/>
+          </a:ln>
+        </p:spPr>
+      </p:sp>
+      <p:sp>
+        <p:nvSpPr>
+          <p:cNvPr id="27" name="Shape 17"/>
+          <p:cNvSpPr/>
+          <p:nvPr/>
+        </p:nvSpPr>
+        <p:spPr>
+          <a:xfrm>
+            <a:off x="0" y="384048"/>
+            <a:ext cx="12191695" cy="0"/>
+          </a:xfrm>
+          <a:prstGeom prst="line">
+            <a:avLst/>
+          </a:prstGeom>
+          <a:noFill/>
+          <a:ln w="9525">
+            <a:solidFill>
+              <a:srgbClr val="2E4C7A"/>
+            </a:solidFill>
+            <a:prstDash val="solid"/>
+          </a:ln>
+        </p:spPr>
+      </p:sp>
+      <p:sp>
+        <p:nvSpPr>
+          <p:cNvPr id="28" name="Pestaña Diagnóstico"/>
+          <p:cNvSpPr txBox="1"/>
+          <p:nvPr/>
+        </p:nvSpPr>
+        <p:spPr>
+          <a:xfrm>
+            <a:off x="548640" y="0"/>
+            <a:ext cx="2218334" cy="384048"/>
+          </a:xfrm>
+          <a:prstGeom prst="rect">
+            <a:avLst/>
+          </a:prstGeom>
+          <a:noFill/>
+          <a:ln/>
+        </p:spPr>
+        <p:txBody>
+          <a:bodyPr wrap="square" lIns="0" tIns="0" rIns="0" bIns="0" rtlCol="0" anchor="ctr"/>
+          <a:lstStyle/>
+          <a:p>
+            <a:pPr algn="ctr" indent="0" marL="0">
+              <a:buNone/>
+            </a:pPr>
+            <a:r>
+              <a:rPr lang="en-US" sz="1000" u="none" spc="150" kern="0" dirty="0">
+                <a:solidFill>
+                  <a:srgbClr val="AFC0DA"/>
+                </a:solidFill>
+                <a:hlinkClick r:id="rId8" action="ppaction://hlinksldjump" tooltip="Ir a Diagnóstico">
+                  <a:extLst>
+                    <a:ext uri="{A12FA001-AC4F-418D-AE19-62706E023703}">
+                      <ahyp:hlinkClr xmlns:ahyp="http://schemas.microsoft.com/office/drawing/2018/hyperlinkcolor" val="tx"/>
+                    </a:ext>
+                  </a:extLst>
+                </a:hlinkClick>
+              </a:rPr>
+              <a:t>DIAGNÓSTICO</a:t>
+            </a:r>
+            <a:endParaRPr lang="en-US" sz="1000" dirty="0"/>
+          </a:p>
+        </p:txBody>
+      </p:sp>
+      <p:sp>
+        <p:nvSpPr>
+          <p:cNvPr id="29" name="Pestaña Riesgos"/>
+          <p:cNvSpPr txBox="1"/>
+          <p:nvPr/>
+        </p:nvSpPr>
+        <p:spPr>
+          <a:xfrm>
+            <a:off x="2766974" y="0"/>
+            <a:ext cx="2218334" cy="384048"/>
+          </a:xfrm>
+          <a:prstGeom prst="rect">
+            <a:avLst/>
+          </a:prstGeom>
+          <a:noFill/>
+          <a:ln/>
+        </p:spPr>
+        <p:txBody>
+          <a:bodyPr wrap="square" lIns="0" tIns="0" rIns="0" bIns="0" rtlCol="0" anchor="ctr"/>
+          <a:lstStyle/>
+          <a:p>
+            <a:pPr algn="ctr" indent="0" marL="0">
+              <a:buNone/>
+            </a:pPr>
+            <a:r>
+              <a:rPr lang="en-US" sz="1000" u="none" spc="150" kern="0" dirty="0">
+                <a:solidFill>
+                  <a:srgbClr val="AFC0DA"/>
+                </a:solidFill>
+                <a:hlinkClick r:id="rId9" action="ppaction://hlinksldjump" tooltip="Ir a Riesgos">
+                  <a:extLst>
+                    <a:ext uri="{A12FA001-AC4F-418D-AE19-62706E023703}">
+                      <ahyp:hlinkClr xmlns:ahyp="http://schemas.microsoft.com/office/drawing/2018/hyperlinkcolor" val="tx"/>
+                    </a:ext>
+                  </a:extLst>
+                </a:hlinkClick>
+              </a:rPr>
+              <a:t>RIESGOS</a:t>
+            </a:r>
+            <a:endParaRPr lang="en-US" sz="1000" dirty="0"/>
+          </a:p>
+        </p:txBody>
+      </p:sp>
+      <p:sp>
+        <p:nvSpPr>
+          <p:cNvPr id="30" name="Pestaña Resultados 2024"/>
+          <p:cNvSpPr txBox="1"/>
+          <p:nvPr/>
+        </p:nvSpPr>
+        <p:spPr>
+          <a:xfrm>
+            <a:off x="4985309" y="0"/>
+            <a:ext cx="2218334" cy="384048"/>
+          </a:xfrm>
+          <a:prstGeom prst="rect">
+            <a:avLst/>
+          </a:prstGeom>
+          <a:noFill/>
+          <a:ln/>
+        </p:spPr>
+        <p:txBody>
+          <a:bodyPr wrap="square" lIns="0" tIns="0" rIns="0" bIns="0" rtlCol="0" anchor="ctr"/>
+          <a:lstStyle/>
+          <a:p>
+            <a:pPr algn="ctr" indent="0" marL="0">
+              <a:buNone/>
+            </a:pPr>
+            <a:r>
+              <a:rPr lang="en-US" sz="1000" u="none" spc="150" kern="0" dirty="0">
+                <a:solidFill>
+                  <a:srgbClr val="AFC0DA"/>
+                </a:solidFill>
+                <a:hlinkClick r:id="rId10" action="ppaction://hlinksldjump" tooltip="Ir a Resultados 2024">
+                  <a:extLst>
+                    <a:ext uri="{A12FA001-AC4F-418D-AE19-62706E023703}">
+                      <ahyp:hlinkClr xmlns:ahyp="http://schemas.microsoft.com/office/drawing/2018/hyperlinkcolor" val="tx"/>
+                    </a:ext>
+                  </a:extLst>
+                </a:hlinkClick>
+              </a:rPr>
+              <a:t>RESULTADOS 2024</a:t>
+            </a:r>
+            <a:endParaRPr lang="en-US" sz="1000" dirty="0"/>
+          </a:p>
+        </p:txBody>
+      </p:sp>
+      <p:sp>
+        <p:nvSpPr>
+          <p:cNvPr id="31" name="Pestaña Meta"/>
+          <p:cNvSpPr txBox="1"/>
+          <p:nvPr/>
+        </p:nvSpPr>
+        <p:spPr>
+          <a:xfrm>
+            <a:off x="7203643" y="0"/>
+            <a:ext cx="2218334" cy="384048"/>
+          </a:xfrm>
+          <a:prstGeom prst="rect">
+            <a:avLst/>
+          </a:prstGeom>
+          <a:noFill/>
+          <a:ln/>
+        </p:spPr>
+        <p:txBody>
+          <a:bodyPr wrap="square" lIns="0" tIns="0" rIns="0" bIns="0" rtlCol="0" anchor="ctr"/>
+          <a:lstStyle/>
+          <a:p>
+            <a:pPr algn="ctr" indent="0" marL="0">
+              <a:buNone/>
+            </a:pPr>
+            <a:r>
+              <a:rPr lang="en-US" sz="1000" u="none" spc="150" kern="0" dirty="0">
+                <a:solidFill>
+                  <a:srgbClr val="AFC0DA"/>
+                </a:solidFill>
+                <a:hlinkClick r:id="rId11" action="ppaction://hlinksldjump" tooltip="Ir a Meta">
+                  <a:extLst>
+                    <a:ext uri="{A12FA001-AC4F-418D-AE19-62706E023703}">
+                      <ahyp:hlinkClr xmlns:ahyp="http://schemas.microsoft.com/office/drawing/2018/hyperlinkcolor" val="tx"/>
+                    </a:ext>
+                  </a:extLst>
+                </a:hlinkClick>
+              </a:rPr>
+              <a:t>META</a:t>
+            </a:r>
+            <a:endParaRPr lang="en-US" sz="1000" dirty="0"/>
+          </a:p>
+        </p:txBody>
+      </p:sp>
+      <p:sp>
+        <p:nvSpPr>
+          <p:cNvPr id="32" name="Pestaña Plan y recomendación"/>
+          <p:cNvSpPr txBox="1"/>
+          <p:nvPr/>
+        </p:nvSpPr>
+        <p:spPr>
+          <a:xfrm>
+            <a:off x="9421978" y="0"/>
+            <a:ext cx="2218334" cy="384048"/>
+          </a:xfrm>
+          <a:prstGeom prst="rect">
+            <a:avLst/>
+          </a:prstGeom>
+          <a:noFill/>
+          <a:ln/>
+        </p:spPr>
+        <p:txBody>
+          <a:bodyPr wrap="square" lIns="0" tIns="0" rIns="0" bIns="0" rtlCol="0" anchor="ctr"/>
+          <a:lstStyle/>
+          <a:p>
+            <a:pPr algn="ctr" indent="0" marL="0">
+              <a:buNone/>
+            </a:pPr>
+            <a:r>
+              <a:rPr lang="en-US" sz="1000" b="1" spc="150" kern="0" dirty="0">
+                <a:solidFill>
+                  <a:srgbClr val="FFFFFF"/>
+                </a:solidFill>
+              </a:rPr>
+              <a:t>PLAN Y RECOMENDACIÓN</a:t>
+            </a:r>
+            <a:endParaRPr lang="en-US" sz="1000" dirty="0"/>
+          </a:p>
+        </p:txBody>
+      </p:sp>
+      <p:sp>
+        <p:nvSpPr>
+          <p:cNvPr id="33" name="Sección actual"/>
+          <p:cNvSpPr/>
+          <p:nvPr/>
+        </p:nvSpPr>
+        <p:spPr>
+          <a:xfrm>
+            <a:off x="10087478" y="338328"/>
+            <a:ext cx="887334" cy="45720"/>
+          </a:xfrm>
+          <a:prstGeom prst="rect">
+            <a:avLst/>
+          </a:prstGeom>
+          <a:solidFill>
+            <a:srgbClr val="DA1822"/>
+          </a:solidFill>
+          <a:ln w="12700">
+            <a:solidFill>
+              <a:srgbClr val="DA1822"/>
+            </a:solidFill>
+            <a:prstDash val="solid"/>
+          </a:ln>
+        </p:spPr>
       </p:sp>
       <p:sp>
         <p:nvSpPr>
@@ -4308,8 +4870,8 @@
         </p:nvSpPr>
         <p:spPr>
           <a:xfrm>
-            <a:off x="548640" y="320040"/>
-            <a:ext cx="11091672" cy="1051560"/>
+            <a:off x="548640" y="502920"/>
+            <a:ext cx="11091672" cy="1005840"/>
           </a:xfrm>
           <a:prstGeom prst="rect">
             <a:avLst/>
@@ -4994,6 +5556,287 @@
                 </a:solidFill>
               </a:rPr>
               <a:t>Fuentes: Seccional PRM Pennsylvania (padrón electoral); JCE 2024; INDEX, Registro Sociodemográfico de los Dominicanos en el Exterior (5.ª edición, 2026). Meta: proyección propia.</a:t>
+            </a:r>
+            <a:endParaRPr lang="en-US" sz="1000" dirty="0"/>
+          </a:p>
+        </p:txBody>
+      </p:sp>
+      <p:sp>
+        <p:nvSpPr>
+          <p:cNvPr id="23" name="Barra de navegación"/>
+          <p:cNvSpPr/>
+          <p:nvPr/>
+        </p:nvSpPr>
+        <p:spPr>
+          <a:xfrm>
+            <a:off x="0" y="0"/>
+            <a:ext cx="12191695" cy="384048"/>
+          </a:xfrm>
+          <a:prstGeom prst="rect">
+            <a:avLst/>
+          </a:prstGeom>
+          <a:solidFill>
+            <a:srgbClr val="F4F7FB"/>
+          </a:solidFill>
+          <a:ln w="12700">
+            <a:solidFill>
+              <a:srgbClr val="F4F7FB"/>
+            </a:solidFill>
+            <a:prstDash val="solid"/>
+          </a:ln>
+        </p:spPr>
+      </p:sp>
+      <p:sp>
+        <p:nvSpPr>
+          <p:cNvPr id="24" name="Shape 21"/>
+          <p:cNvSpPr/>
+          <p:nvPr/>
+        </p:nvSpPr>
+        <p:spPr>
+          <a:xfrm>
+            <a:off x="0" y="384048"/>
+            <a:ext cx="12191695" cy="0"/>
+          </a:xfrm>
+          <a:prstGeom prst="line">
+            <a:avLst/>
+          </a:prstGeom>
+          <a:noFill/>
+          <a:ln w="9525">
+            <a:solidFill>
+              <a:srgbClr val="D6DEEA"/>
+            </a:solidFill>
+            <a:prstDash val="solid"/>
+          </a:ln>
+        </p:spPr>
+      </p:sp>
+      <p:sp>
+        <p:nvSpPr>
+          <p:cNvPr id="25" name="Pestaña Diagnóstico"/>
+          <p:cNvSpPr txBox="1"/>
+          <p:nvPr/>
+        </p:nvSpPr>
+        <p:spPr>
+          <a:xfrm>
+            <a:off x="548640" y="0"/>
+            <a:ext cx="2218334" cy="384048"/>
+          </a:xfrm>
+          <a:prstGeom prst="rect">
+            <a:avLst/>
+          </a:prstGeom>
+          <a:noFill/>
+          <a:ln/>
+        </p:spPr>
+        <p:txBody>
+          <a:bodyPr wrap="square" lIns="0" tIns="0" rIns="0" bIns="0" rtlCol="0" anchor="ctr"/>
+          <a:lstStyle/>
+          <a:p>
+            <a:pPr algn="ctr" indent="0" marL="0">
+              <a:buNone/>
+            </a:pPr>
+            <a:r>
+              <a:rPr lang="en-US" sz="1000" b="1" spc="150" kern="0" dirty="0">
+                <a:solidFill>
+                  <a:srgbClr val="002B63"/>
+                </a:solidFill>
+              </a:rPr>
+              <a:t>DIAGNÓSTICO</a:t>
+            </a:r>
+            <a:endParaRPr lang="en-US" sz="1000" dirty="0"/>
+          </a:p>
+        </p:txBody>
+      </p:sp>
+      <p:sp>
+        <p:nvSpPr>
+          <p:cNvPr id="26" name="Sección actual"/>
+          <p:cNvSpPr/>
+          <p:nvPr/>
+        </p:nvSpPr>
+        <p:spPr>
+          <a:xfrm>
+            <a:off x="1214140" y="338328"/>
+            <a:ext cx="887334" cy="45720"/>
+          </a:xfrm>
+          <a:prstGeom prst="rect">
+            <a:avLst/>
+          </a:prstGeom>
+          <a:solidFill>
+            <a:srgbClr val="DA1822"/>
+          </a:solidFill>
+          <a:ln w="12700">
+            <a:solidFill>
+              <a:srgbClr val="DA1822"/>
+            </a:solidFill>
+            <a:prstDash val="solid"/>
+          </a:ln>
+        </p:spPr>
+      </p:sp>
+      <p:sp>
+        <p:nvSpPr>
+          <p:cNvPr id="27" name="Pestaña Riesgos"/>
+          <p:cNvSpPr txBox="1"/>
+          <p:nvPr/>
+        </p:nvSpPr>
+        <p:spPr>
+          <a:xfrm>
+            <a:off x="2766974" y="0"/>
+            <a:ext cx="2218334" cy="384048"/>
+          </a:xfrm>
+          <a:prstGeom prst="rect">
+            <a:avLst/>
+          </a:prstGeom>
+          <a:noFill/>
+          <a:ln/>
+        </p:spPr>
+        <p:txBody>
+          <a:bodyPr wrap="square" lIns="0" tIns="0" rIns="0" bIns="0" rtlCol="0" anchor="ctr"/>
+          <a:lstStyle/>
+          <a:p>
+            <a:pPr algn="ctr" indent="0" marL="0">
+              <a:buNone/>
+            </a:pPr>
+            <a:r>
+              <a:rPr lang="en-US" sz="1000" u="none" spc="150" kern="0" dirty="0">
+                <a:solidFill>
+                  <a:srgbClr val="5A6B86"/>
+                </a:solidFill>
+                <a:hlinkClick r:id="rId1" action="ppaction://hlinksldjump" tooltip="Ir a Riesgos">
+                  <a:extLst>
+                    <a:ext uri="{A12FA001-AC4F-418D-AE19-62706E023703}">
+                      <ahyp:hlinkClr xmlns:ahyp="http://schemas.microsoft.com/office/drawing/2018/hyperlinkcolor" val="tx"/>
+                    </a:ext>
+                  </a:extLst>
+                </a:hlinkClick>
+              </a:rPr>
+              <a:t>RIESGOS</a:t>
+            </a:r>
+            <a:endParaRPr lang="en-US" sz="1000" dirty="0"/>
+          </a:p>
+        </p:txBody>
+      </p:sp>
+      <p:sp>
+        <p:nvSpPr>
+          <p:cNvPr id="28" name="Pestaña Resultados 2024"/>
+          <p:cNvSpPr txBox="1"/>
+          <p:nvPr/>
+        </p:nvSpPr>
+        <p:spPr>
+          <a:xfrm>
+            <a:off x="4985309" y="0"/>
+            <a:ext cx="2218334" cy="384048"/>
+          </a:xfrm>
+          <a:prstGeom prst="rect">
+            <a:avLst/>
+          </a:prstGeom>
+          <a:noFill/>
+          <a:ln/>
+        </p:spPr>
+        <p:txBody>
+          <a:bodyPr wrap="square" lIns="0" tIns="0" rIns="0" bIns="0" rtlCol="0" anchor="ctr"/>
+          <a:lstStyle/>
+          <a:p>
+            <a:pPr algn="ctr" indent="0" marL="0">
+              <a:buNone/>
+            </a:pPr>
+            <a:r>
+              <a:rPr lang="en-US" sz="1000" u="none" spc="150" kern="0" dirty="0">
+                <a:solidFill>
+                  <a:srgbClr val="5A6B86"/>
+                </a:solidFill>
+                <a:hlinkClick r:id="rId2" action="ppaction://hlinksldjump" tooltip="Ir a Resultados 2024">
+                  <a:extLst>
+                    <a:ext uri="{A12FA001-AC4F-418D-AE19-62706E023703}">
+                      <ahyp:hlinkClr xmlns:ahyp="http://schemas.microsoft.com/office/drawing/2018/hyperlinkcolor" val="tx"/>
+                    </a:ext>
+                  </a:extLst>
+                </a:hlinkClick>
+              </a:rPr>
+              <a:t>RESULTADOS 2024</a:t>
+            </a:r>
+            <a:endParaRPr lang="en-US" sz="1000" dirty="0"/>
+          </a:p>
+        </p:txBody>
+      </p:sp>
+      <p:sp>
+        <p:nvSpPr>
+          <p:cNvPr id="29" name="Pestaña Meta"/>
+          <p:cNvSpPr txBox="1"/>
+          <p:nvPr/>
+        </p:nvSpPr>
+        <p:spPr>
+          <a:xfrm>
+            <a:off x="7203643" y="0"/>
+            <a:ext cx="2218334" cy="384048"/>
+          </a:xfrm>
+          <a:prstGeom prst="rect">
+            <a:avLst/>
+          </a:prstGeom>
+          <a:noFill/>
+          <a:ln/>
+        </p:spPr>
+        <p:txBody>
+          <a:bodyPr wrap="square" lIns="0" tIns="0" rIns="0" bIns="0" rtlCol="0" anchor="ctr"/>
+          <a:lstStyle/>
+          <a:p>
+            <a:pPr algn="ctr" indent="0" marL="0">
+              <a:buNone/>
+            </a:pPr>
+            <a:r>
+              <a:rPr lang="en-US" sz="1000" u="none" spc="150" kern="0" dirty="0">
+                <a:solidFill>
+                  <a:srgbClr val="5A6B86"/>
+                </a:solidFill>
+                <a:hlinkClick r:id="rId3" action="ppaction://hlinksldjump" tooltip="Ir a Meta">
+                  <a:extLst>
+                    <a:ext uri="{A12FA001-AC4F-418D-AE19-62706E023703}">
+                      <ahyp:hlinkClr xmlns:ahyp="http://schemas.microsoft.com/office/drawing/2018/hyperlinkcolor" val="tx"/>
+                    </a:ext>
+                  </a:extLst>
+                </a:hlinkClick>
+              </a:rPr>
+              <a:t>META</a:t>
+            </a:r>
+            <a:endParaRPr lang="en-US" sz="1000" dirty="0"/>
+          </a:p>
+        </p:txBody>
+      </p:sp>
+      <p:sp>
+        <p:nvSpPr>
+          <p:cNvPr id="30" name="Pestaña Plan y recomendación"/>
+          <p:cNvSpPr txBox="1"/>
+          <p:nvPr/>
+        </p:nvSpPr>
+        <p:spPr>
+          <a:xfrm>
+            <a:off x="9421978" y="0"/>
+            <a:ext cx="2218334" cy="384048"/>
+          </a:xfrm>
+          <a:prstGeom prst="rect">
+            <a:avLst/>
+          </a:prstGeom>
+          <a:noFill/>
+          <a:ln/>
+        </p:spPr>
+        <p:txBody>
+          <a:bodyPr wrap="square" lIns="0" tIns="0" rIns="0" bIns="0" rtlCol="0" anchor="ctr"/>
+          <a:lstStyle/>
+          <a:p>
+            <a:pPr algn="ctr" indent="0" marL="0">
+              <a:buNone/>
+            </a:pPr>
+            <a:r>
+              <a:rPr lang="en-US" sz="1000" u="none" spc="150" kern="0" dirty="0">
+                <a:solidFill>
+                  <a:srgbClr val="5A6B86"/>
+                </a:solidFill>
+                <a:hlinkClick r:id="rId4" action="ppaction://hlinksldjump" tooltip="Ir a Plan y recomendación">
+                  <a:extLst>
+                    <a:ext uri="{A12FA001-AC4F-418D-AE19-62706E023703}">
+                      <ahyp:hlinkClr xmlns:ahyp="http://schemas.microsoft.com/office/drawing/2018/hyperlinkcolor" val="tx"/>
+                    </a:ext>
+                  </a:extLst>
+                </a:hlinkClick>
+              </a:rPr>
+              <a:t>PLAN Y RECOMENDACIÓN</a:t>
             </a:r>
             <a:endParaRPr lang="en-US" sz="1000" dirty="0"/>
           </a:p>
@@ -5079,8 +5922,8 @@
         </p:nvSpPr>
         <p:spPr>
           <a:xfrm>
-            <a:off x="548640" y="320040"/>
-            <a:ext cx="11091672" cy="1051560"/>
+            <a:off x="548640" y="502920"/>
+            <a:ext cx="11091672" cy="1005840"/>
           </a:xfrm>
           <a:prstGeom prst="rect">
             <a:avLst/>
@@ -7898,6 +8741,287 @@
                 </a:solidFill>
               </a:rPr>
               <a:t>Electores: Seccional PRM Pennsylvania (2024). Cada círculo es una ciudad; el número indica su zona y el tamaño, sus electores. Versión interactiva en el enlace web.</a:t>
+            </a:r>
+            <a:endParaRPr lang="en-US" sz="1000" dirty="0"/>
+          </a:p>
+        </p:txBody>
+      </p:sp>
+      <p:sp>
+        <p:nvSpPr>
+          <p:cNvPr id="88" name="Barra de navegación"/>
+          <p:cNvSpPr/>
+          <p:nvPr/>
+        </p:nvSpPr>
+        <p:spPr>
+          <a:xfrm>
+            <a:off x="0" y="0"/>
+            <a:ext cx="12191695" cy="384048"/>
+          </a:xfrm>
+          <a:prstGeom prst="rect">
+            <a:avLst/>
+          </a:prstGeom>
+          <a:solidFill>
+            <a:srgbClr val="F4F7FB"/>
+          </a:solidFill>
+          <a:ln w="12700">
+            <a:solidFill>
+              <a:srgbClr val="F4F7FB"/>
+            </a:solidFill>
+            <a:prstDash val="solid"/>
+          </a:ln>
+        </p:spPr>
+      </p:sp>
+      <p:sp>
+        <p:nvSpPr>
+          <p:cNvPr id="89" name="Shape 85"/>
+          <p:cNvSpPr/>
+          <p:nvPr/>
+        </p:nvSpPr>
+        <p:spPr>
+          <a:xfrm>
+            <a:off x="0" y="384048"/>
+            <a:ext cx="12191695" cy="0"/>
+          </a:xfrm>
+          <a:prstGeom prst="line">
+            <a:avLst/>
+          </a:prstGeom>
+          <a:noFill/>
+          <a:ln w="9525">
+            <a:solidFill>
+              <a:srgbClr val="D6DEEA"/>
+            </a:solidFill>
+            <a:prstDash val="solid"/>
+          </a:ln>
+        </p:spPr>
+      </p:sp>
+      <p:sp>
+        <p:nvSpPr>
+          <p:cNvPr id="90" name="Pestaña Diagnóstico"/>
+          <p:cNvSpPr txBox="1"/>
+          <p:nvPr/>
+        </p:nvSpPr>
+        <p:spPr>
+          <a:xfrm>
+            <a:off x="548640" y="0"/>
+            <a:ext cx="2218334" cy="384048"/>
+          </a:xfrm>
+          <a:prstGeom prst="rect">
+            <a:avLst/>
+          </a:prstGeom>
+          <a:noFill/>
+          <a:ln/>
+        </p:spPr>
+        <p:txBody>
+          <a:bodyPr wrap="square" lIns="0" tIns="0" rIns="0" bIns="0" rtlCol="0" anchor="ctr"/>
+          <a:lstStyle/>
+          <a:p>
+            <a:pPr algn="ctr" indent="0" marL="0">
+              <a:buNone/>
+            </a:pPr>
+            <a:r>
+              <a:rPr lang="en-US" sz="1000" b="1" spc="150" kern="0" dirty="0">
+                <a:solidFill>
+                  <a:srgbClr val="002B63"/>
+                </a:solidFill>
+              </a:rPr>
+              <a:t>DIAGNÓSTICO</a:t>
+            </a:r>
+            <a:endParaRPr lang="en-US" sz="1000" dirty="0"/>
+          </a:p>
+        </p:txBody>
+      </p:sp>
+      <p:sp>
+        <p:nvSpPr>
+          <p:cNvPr id="91" name="Sección actual"/>
+          <p:cNvSpPr/>
+          <p:nvPr/>
+        </p:nvSpPr>
+        <p:spPr>
+          <a:xfrm>
+            <a:off x="1214140" y="338328"/>
+            <a:ext cx="887334" cy="45720"/>
+          </a:xfrm>
+          <a:prstGeom prst="rect">
+            <a:avLst/>
+          </a:prstGeom>
+          <a:solidFill>
+            <a:srgbClr val="DA1822"/>
+          </a:solidFill>
+          <a:ln w="12700">
+            <a:solidFill>
+              <a:srgbClr val="DA1822"/>
+            </a:solidFill>
+            <a:prstDash val="solid"/>
+          </a:ln>
+        </p:spPr>
+      </p:sp>
+      <p:sp>
+        <p:nvSpPr>
+          <p:cNvPr id="92" name="Pestaña Riesgos"/>
+          <p:cNvSpPr txBox="1"/>
+          <p:nvPr/>
+        </p:nvSpPr>
+        <p:spPr>
+          <a:xfrm>
+            <a:off x="2766974" y="0"/>
+            <a:ext cx="2218334" cy="384048"/>
+          </a:xfrm>
+          <a:prstGeom prst="rect">
+            <a:avLst/>
+          </a:prstGeom>
+          <a:noFill/>
+          <a:ln/>
+        </p:spPr>
+        <p:txBody>
+          <a:bodyPr wrap="square" lIns="0" tIns="0" rIns="0" bIns="0" rtlCol="0" anchor="ctr"/>
+          <a:lstStyle/>
+          <a:p>
+            <a:pPr algn="ctr" indent="0" marL="0">
+              <a:buNone/>
+            </a:pPr>
+            <a:r>
+              <a:rPr lang="en-US" sz="1000" u="none" spc="150" kern="0" dirty="0">
+                <a:solidFill>
+                  <a:srgbClr val="5A6B86"/>
+                </a:solidFill>
+                <a:hlinkClick r:id="rId2" action="ppaction://hlinksldjump" tooltip="Ir a Riesgos">
+                  <a:extLst>
+                    <a:ext uri="{A12FA001-AC4F-418D-AE19-62706E023703}">
+                      <ahyp:hlinkClr xmlns:ahyp="http://schemas.microsoft.com/office/drawing/2018/hyperlinkcolor" val="tx"/>
+                    </a:ext>
+                  </a:extLst>
+                </a:hlinkClick>
+              </a:rPr>
+              <a:t>RIESGOS</a:t>
+            </a:r>
+            <a:endParaRPr lang="en-US" sz="1000" dirty="0"/>
+          </a:p>
+        </p:txBody>
+      </p:sp>
+      <p:sp>
+        <p:nvSpPr>
+          <p:cNvPr id="93" name="Pestaña Resultados 2024"/>
+          <p:cNvSpPr txBox="1"/>
+          <p:nvPr/>
+        </p:nvSpPr>
+        <p:spPr>
+          <a:xfrm>
+            <a:off x="4985309" y="0"/>
+            <a:ext cx="2218334" cy="384048"/>
+          </a:xfrm>
+          <a:prstGeom prst="rect">
+            <a:avLst/>
+          </a:prstGeom>
+          <a:noFill/>
+          <a:ln/>
+        </p:spPr>
+        <p:txBody>
+          <a:bodyPr wrap="square" lIns="0" tIns="0" rIns="0" bIns="0" rtlCol="0" anchor="ctr"/>
+          <a:lstStyle/>
+          <a:p>
+            <a:pPr algn="ctr" indent="0" marL="0">
+              <a:buNone/>
+            </a:pPr>
+            <a:r>
+              <a:rPr lang="en-US" sz="1000" u="none" spc="150" kern="0" dirty="0">
+                <a:solidFill>
+                  <a:srgbClr val="5A6B86"/>
+                </a:solidFill>
+                <a:hlinkClick r:id="rId3" action="ppaction://hlinksldjump" tooltip="Ir a Resultados 2024">
+                  <a:extLst>
+                    <a:ext uri="{A12FA001-AC4F-418D-AE19-62706E023703}">
+                      <ahyp:hlinkClr xmlns:ahyp="http://schemas.microsoft.com/office/drawing/2018/hyperlinkcolor" val="tx"/>
+                    </a:ext>
+                  </a:extLst>
+                </a:hlinkClick>
+              </a:rPr>
+              <a:t>RESULTADOS 2024</a:t>
+            </a:r>
+            <a:endParaRPr lang="en-US" sz="1000" dirty="0"/>
+          </a:p>
+        </p:txBody>
+      </p:sp>
+      <p:sp>
+        <p:nvSpPr>
+          <p:cNvPr id="94" name="Pestaña Meta"/>
+          <p:cNvSpPr txBox="1"/>
+          <p:nvPr/>
+        </p:nvSpPr>
+        <p:spPr>
+          <a:xfrm>
+            <a:off x="7203643" y="0"/>
+            <a:ext cx="2218334" cy="384048"/>
+          </a:xfrm>
+          <a:prstGeom prst="rect">
+            <a:avLst/>
+          </a:prstGeom>
+          <a:noFill/>
+          <a:ln/>
+        </p:spPr>
+        <p:txBody>
+          <a:bodyPr wrap="square" lIns="0" tIns="0" rIns="0" bIns="0" rtlCol="0" anchor="ctr"/>
+          <a:lstStyle/>
+          <a:p>
+            <a:pPr algn="ctr" indent="0" marL="0">
+              <a:buNone/>
+            </a:pPr>
+            <a:r>
+              <a:rPr lang="en-US" sz="1000" u="none" spc="150" kern="0" dirty="0">
+                <a:solidFill>
+                  <a:srgbClr val="5A6B86"/>
+                </a:solidFill>
+                <a:hlinkClick r:id="rId4" action="ppaction://hlinksldjump" tooltip="Ir a Meta">
+                  <a:extLst>
+                    <a:ext uri="{A12FA001-AC4F-418D-AE19-62706E023703}">
+                      <ahyp:hlinkClr xmlns:ahyp="http://schemas.microsoft.com/office/drawing/2018/hyperlinkcolor" val="tx"/>
+                    </a:ext>
+                  </a:extLst>
+                </a:hlinkClick>
+              </a:rPr>
+              <a:t>META</a:t>
+            </a:r>
+            <a:endParaRPr lang="en-US" sz="1000" dirty="0"/>
+          </a:p>
+        </p:txBody>
+      </p:sp>
+      <p:sp>
+        <p:nvSpPr>
+          <p:cNvPr id="95" name="Pestaña Plan y recomendación"/>
+          <p:cNvSpPr txBox="1"/>
+          <p:nvPr/>
+        </p:nvSpPr>
+        <p:spPr>
+          <a:xfrm>
+            <a:off x="9421978" y="0"/>
+            <a:ext cx="2218334" cy="384048"/>
+          </a:xfrm>
+          <a:prstGeom prst="rect">
+            <a:avLst/>
+          </a:prstGeom>
+          <a:noFill/>
+          <a:ln/>
+        </p:spPr>
+        <p:txBody>
+          <a:bodyPr wrap="square" lIns="0" tIns="0" rIns="0" bIns="0" rtlCol="0" anchor="ctr"/>
+          <a:lstStyle/>
+          <a:p>
+            <a:pPr algn="ctr" indent="0" marL="0">
+              <a:buNone/>
+            </a:pPr>
+            <a:r>
+              <a:rPr lang="en-US" sz="1000" u="none" spc="150" kern="0" dirty="0">
+                <a:solidFill>
+                  <a:srgbClr val="5A6B86"/>
+                </a:solidFill>
+                <a:hlinkClick r:id="rId5" action="ppaction://hlinksldjump" tooltip="Ir a Plan y recomendación">
+                  <a:extLst>
+                    <a:ext uri="{A12FA001-AC4F-418D-AE19-62706E023703}">
+                      <ahyp:hlinkClr xmlns:ahyp="http://schemas.microsoft.com/office/drawing/2018/hyperlinkcolor" val="tx"/>
+                    </a:ext>
+                  </a:extLst>
+                </a:hlinkClick>
+              </a:rPr>
+              <a:t>PLAN Y RECOMENDACIÓN</a:t>
             </a:r>
             <a:endParaRPr lang="en-US" sz="1000" dirty="0"/>
           </a:p>
@@ -7983,8 +9107,8 @@
         </p:nvSpPr>
         <p:spPr>
           <a:xfrm>
-            <a:off x="548640" y="320040"/>
-            <a:ext cx="11091672" cy="1051560"/>
+            <a:off x="548640" y="502920"/>
+            <a:ext cx="11091672" cy="1005840"/>
           </a:xfrm>
           <a:prstGeom prst="rect">
             <a:avLst/>
@@ -8289,6 +9413,287 @@
                 </a:solidFill>
               </a:rPr>
               <a:t>Fuentes: INDEX, Registro Sociodemográfico de los Dominicanos en el Exterior (181,156 a dic. 2022; 227,647 en la 5.ª edición, 2026); Consulado RD en Filadelfia.</a:t>
+            </a:r>
+            <a:endParaRPr lang="en-US" sz="1000" dirty="0"/>
+          </a:p>
+        </p:txBody>
+      </p:sp>
+      <p:sp>
+        <p:nvSpPr>
+          <p:cNvPr id="12" name="Barra de navegación"/>
+          <p:cNvSpPr/>
+          <p:nvPr/>
+        </p:nvSpPr>
+        <p:spPr>
+          <a:xfrm>
+            <a:off x="0" y="0"/>
+            <a:ext cx="12191695" cy="384048"/>
+          </a:xfrm>
+          <a:prstGeom prst="rect">
+            <a:avLst/>
+          </a:prstGeom>
+          <a:solidFill>
+            <a:srgbClr val="F4F7FB"/>
+          </a:solidFill>
+          <a:ln w="12700">
+            <a:solidFill>
+              <a:srgbClr val="F4F7FB"/>
+            </a:solidFill>
+            <a:prstDash val="solid"/>
+          </a:ln>
+        </p:spPr>
+      </p:sp>
+      <p:sp>
+        <p:nvSpPr>
+          <p:cNvPr id="13" name="Shape 9"/>
+          <p:cNvSpPr/>
+          <p:nvPr/>
+        </p:nvSpPr>
+        <p:spPr>
+          <a:xfrm>
+            <a:off x="0" y="384048"/>
+            <a:ext cx="12191695" cy="0"/>
+          </a:xfrm>
+          <a:prstGeom prst="line">
+            <a:avLst/>
+          </a:prstGeom>
+          <a:noFill/>
+          <a:ln w="9525">
+            <a:solidFill>
+              <a:srgbClr val="D6DEEA"/>
+            </a:solidFill>
+            <a:prstDash val="solid"/>
+          </a:ln>
+        </p:spPr>
+      </p:sp>
+      <p:sp>
+        <p:nvSpPr>
+          <p:cNvPr id="14" name="Pestaña Diagnóstico"/>
+          <p:cNvSpPr txBox="1"/>
+          <p:nvPr/>
+        </p:nvSpPr>
+        <p:spPr>
+          <a:xfrm>
+            <a:off x="548640" y="0"/>
+            <a:ext cx="2218334" cy="384048"/>
+          </a:xfrm>
+          <a:prstGeom prst="rect">
+            <a:avLst/>
+          </a:prstGeom>
+          <a:noFill/>
+          <a:ln/>
+        </p:spPr>
+        <p:txBody>
+          <a:bodyPr wrap="square" lIns="0" tIns="0" rIns="0" bIns="0" rtlCol="0" anchor="ctr"/>
+          <a:lstStyle/>
+          <a:p>
+            <a:pPr algn="ctr" indent="0" marL="0">
+              <a:buNone/>
+            </a:pPr>
+            <a:r>
+              <a:rPr lang="en-US" sz="1000" b="1" spc="150" kern="0" dirty="0">
+                <a:solidFill>
+                  <a:srgbClr val="002B63"/>
+                </a:solidFill>
+              </a:rPr>
+              <a:t>DIAGNÓSTICO</a:t>
+            </a:r>
+            <a:endParaRPr lang="en-US" sz="1000" dirty="0"/>
+          </a:p>
+        </p:txBody>
+      </p:sp>
+      <p:sp>
+        <p:nvSpPr>
+          <p:cNvPr id="15" name="Sección actual"/>
+          <p:cNvSpPr/>
+          <p:nvPr/>
+        </p:nvSpPr>
+        <p:spPr>
+          <a:xfrm>
+            <a:off x="1214140" y="338328"/>
+            <a:ext cx="887334" cy="45720"/>
+          </a:xfrm>
+          <a:prstGeom prst="rect">
+            <a:avLst/>
+          </a:prstGeom>
+          <a:solidFill>
+            <a:srgbClr val="DA1822"/>
+          </a:solidFill>
+          <a:ln w="12700">
+            <a:solidFill>
+              <a:srgbClr val="DA1822"/>
+            </a:solidFill>
+            <a:prstDash val="solid"/>
+          </a:ln>
+        </p:spPr>
+      </p:sp>
+      <p:sp>
+        <p:nvSpPr>
+          <p:cNvPr id="16" name="Pestaña Riesgos"/>
+          <p:cNvSpPr txBox="1"/>
+          <p:nvPr/>
+        </p:nvSpPr>
+        <p:spPr>
+          <a:xfrm>
+            <a:off x="2766974" y="0"/>
+            <a:ext cx="2218334" cy="384048"/>
+          </a:xfrm>
+          <a:prstGeom prst="rect">
+            <a:avLst/>
+          </a:prstGeom>
+          <a:noFill/>
+          <a:ln/>
+        </p:spPr>
+        <p:txBody>
+          <a:bodyPr wrap="square" lIns="0" tIns="0" rIns="0" bIns="0" rtlCol="0" anchor="ctr"/>
+          <a:lstStyle/>
+          <a:p>
+            <a:pPr algn="ctr" indent="0" marL="0">
+              <a:buNone/>
+            </a:pPr>
+            <a:r>
+              <a:rPr lang="en-US" sz="1000" u="none" spc="150" kern="0" dirty="0">
+                <a:solidFill>
+                  <a:srgbClr val="5A6B86"/>
+                </a:solidFill>
+                <a:hlinkClick r:id="rId2" action="ppaction://hlinksldjump" tooltip="Ir a Riesgos">
+                  <a:extLst>
+                    <a:ext uri="{A12FA001-AC4F-418D-AE19-62706E023703}">
+                      <ahyp:hlinkClr xmlns:ahyp="http://schemas.microsoft.com/office/drawing/2018/hyperlinkcolor" val="tx"/>
+                    </a:ext>
+                  </a:extLst>
+                </a:hlinkClick>
+              </a:rPr>
+              <a:t>RIESGOS</a:t>
+            </a:r>
+            <a:endParaRPr lang="en-US" sz="1000" dirty="0"/>
+          </a:p>
+        </p:txBody>
+      </p:sp>
+      <p:sp>
+        <p:nvSpPr>
+          <p:cNvPr id="17" name="Pestaña Resultados 2024"/>
+          <p:cNvSpPr txBox="1"/>
+          <p:nvPr/>
+        </p:nvSpPr>
+        <p:spPr>
+          <a:xfrm>
+            <a:off x="4985309" y="0"/>
+            <a:ext cx="2218334" cy="384048"/>
+          </a:xfrm>
+          <a:prstGeom prst="rect">
+            <a:avLst/>
+          </a:prstGeom>
+          <a:noFill/>
+          <a:ln/>
+        </p:spPr>
+        <p:txBody>
+          <a:bodyPr wrap="square" lIns="0" tIns="0" rIns="0" bIns="0" rtlCol="0" anchor="ctr"/>
+          <a:lstStyle/>
+          <a:p>
+            <a:pPr algn="ctr" indent="0" marL="0">
+              <a:buNone/>
+            </a:pPr>
+            <a:r>
+              <a:rPr lang="en-US" sz="1000" u="none" spc="150" kern="0" dirty="0">
+                <a:solidFill>
+                  <a:srgbClr val="5A6B86"/>
+                </a:solidFill>
+                <a:hlinkClick r:id="rId3" action="ppaction://hlinksldjump" tooltip="Ir a Resultados 2024">
+                  <a:extLst>
+                    <a:ext uri="{A12FA001-AC4F-418D-AE19-62706E023703}">
+                      <ahyp:hlinkClr xmlns:ahyp="http://schemas.microsoft.com/office/drawing/2018/hyperlinkcolor" val="tx"/>
+                    </a:ext>
+                  </a:extLst>
+                </a:hlinkClick>
+              </a:rPr>
+              <a:t>RESULTADOS 2024</a:t>
+            </a:r>
+            <a:endParaRPr lang="en-US" sz="1000" dirty="0"/>
+          </a:p>
+        </p:txBody>
+      </p:sp>
+      <p:sp>
+        <p:nvSpPr>
+          <p:cNvPr id="18" name="Pestaña Meta"/>
+          <p:cNvSpPr txBox="1"/>
+          <p:nvPr/>
+        </p:nvSpPr>
+        <p:spPr>
+          <a:xfrm>
+            <a:off x="7203643" y="0"/>
+            <a:ext cx="2218334" cy="384048"/>
+          </a:xfrm>
+          <a:prstGeom prst="rect">
+            <a:avLst/>
+          </a:prstGeom>
+          <a:noFill/>
+          <a:ln/>
+        </p:spPr>
+        <p:txBody>
+          <a:bodyPr wrap="square" lIns="0" tIns="0" rIns="0" bIns="0" rtlCol="0" anchor="ctr"/>
+          <a:lstStyle/>
+          <a:p>
+            <a:pPr algn="ctr" indent="0" marL="0">
+              <a:buNone/>
+            </a:pPr>
+            <a:r>
+              <a:rPr lang="en-US" sz="1000" u="none" spc="150" kern="0" dirty="0">
+                <a:solidFill>
+                  <a:srgbClr val="5A6B86"/>
+                </a:solidFill>
+                <a:hlinkClick r:id="rId4" action="ppaction://hlinksldjump" tooltip="Ir a Meta">
+                  <a:extLst>
+                    <a:ext uri="{A12FA001-AC4F-418D-AE19-62706E023703}">
+                      <ahyp:hlinkClr xmlns:ahyp="http://schemas.microsoft.com/office/drawing/2018/hyperlinkcolor" val="tx"/>
+                    </a:ext>
+                  </a:extLst>
+                </a:hlinkClick>
+              </a:rPr>
+              <a:t>META</a:t>
+            </a:r>
+            <a:endParaRPr lang="en-US" sz="1000" dirty="0"/>
+          </a:p>
+        </p:txBody>
+      </p:sp>
+      <p:sp>
+        <p:nvSpPr>
+          <p:cNvPr id="19" name="Pestaña Plan y recomendación"/>
+          <p:cNvSpPr txBox="1"/>
+          <p:nvPr/>
+        </p:nvSpPr>
+        <p:spPr>
+          <a:xfrm>
+            <a:off x="9421978" y="0"/>
+            <a:ext cx="2218334" cy="384048"/>
+          </a:xfrm>
+          <a:prstGeom prst="rect">
+            <a:avLst/>
+          </a:prstGeom>
+          <a:noFill/>
+          <a:ln/>
+        </p:spPr>
+        <p:txBody>
+          <a:bodyPr wrap="square" lIns="0" tIns="0" rIns="0" bIns="0" rtlCol="0" anchor="ctr"/>
+          <a:lstStyle/>
+          <a:p>
+            <a:pPr algn="ctr" indent="0" marL="0">
+              <a:buNone/>
+            </a:pPr>
+            <a:r>
+              <a:rPr lang="en-US" sz="1000" u="none" spc="150" kern="0" dirty="0">
+                <a:solidFill>
+                  <a:srgbClr val="5A6B86"/>
+                </a:solidFill>
+                <a:hlinkClick r:id="rId5" action="ppaction://hlinksldjump" tooltip="Ir a Plan y recomendación">
+                  <a:extLst>
+                    <a:ext uri="{A12FA001-AC4F-418D-AE19-62706E023703}">
+                      <ahyp:hlinkClr xmlns:ahyp="http://schemas.microsoft.com/office/drawing/2018/hyperlinkcolor" val="tx"/>
+                    </a:ext>
+                  </a:extLst>
+                </a:hlinkClick>
+              </a:rPr>
+              <a:t>PLAN Y RECOMENDACIÓN</a:t>
             </a:r>
             <a:endParaRPr lang="en-US" sz="1000" dirty="0"/>
           </a:p>
@@ -8374,8 +9779,8 @@
         </p:nvSpPr>
         <p:spPr>
           <a:xfrm>
-            <a:off x="548640" y="320040"/>
-            <a:ext cx="11091672" cy="1051560"/>
+            <a:off x="548640" y="502920"/>
+            <a:ext cx="11091672" cy="1005840"/>
           </a:xfrm>
           <a:prstGeom prst="rect">
             <a:avLst/>
@@ -8983,6 +10388,287 @@
                 </a:solidFill>
               </a:rPr>
               <a:t>Fuentes: JCE (nueva cédula en el exterior: por cita, cierre en enero de 2028; 4,009,576 entregadas en el país al 13-oct-2026); estudio IIDH/CAPEL para la JCE; JCE 2024.</a:t>
+            </a:r>
+            <a:endParaRPr lang="en-US" sz="1000" dirty="0"/>
+          </a:p>
+        </p:txBody>
+      </p:sp>
+      <p:sp>
+        <p:nvSpPr>
+          <p:cNvPr id="19" name="Barra de navegación"/>
+          <p:cNvSpPr/>
+          <p:nvPr/>
+        </p:nvSpPr>
+        <p:spPr>
+          <a:xfrm>
+            <a:off x="0" y="0"/>
+            <a:ext cx="12191695" cy="384048"/>
+          </a:xfrm>
+          <a:prstGeom prst="rect">
+            <a:avLst/>
+          </a:prstGeom>
+          <a:solidFill>
+            <a:srgbClr val="F4F7FB"/>
+          </a:solidFill>
+          <a:ln w="12700">
+            <a:solidFill>
+              <a:srgbClr val="F4F7FB"/>
+            </a:solidFill>
+            <a:prstDash val="solid"/>
+          </a:ln>
+        </p:spPr>
+      </p:sp>
+      <p:sp>
+        <p:nvSpPr>
+          <p:cNvPr id="20" name="Shape 15"/>
+          <p:cNvSpPr/>
+          <p:nvPr/>
+        </p:nvSpPr>
+        <p:spPr>
+          <a:xfrm>
+            <a:off x="0" y="384048"/>
+            <a:ext cx="12191695" cy="0"/>
+          </a:xfrm>
+          <a:prstGeom prst="line">
+            <a:avLst/>
+          </a:prstGeom>
+          <a:noFill/>
+          <a:ln w="9525">
+            <a:solidFill>
+              <a:srgbClr val="D6DEEA"/>
+            </a:solidFill>
+            <a:prstDash val="solid"/>
+          </a:ln>
+        </p:spPr>
+      </p:sp>
+      <p:sp>
+        <p:nvSpPr>
+          <p:cNvPr id="21" name="Pestaña Diagnóstico"/>
+          <p:cNvSpPr txBox="1"/>
+          <p:nvPr/>
+        </p:nvSpPr>
+        <p:spPr>
+          <a:xfrm>
+            <a:off x="548640" y="0"/>
+            <a:ext cx="2218334" cy="384048"/>
+          </a:xfrm>
+          <a:prstGeom prst="rect">
+            <a:avLst/>
+          </a:prstGeom>
+          <a:noFill/>
+          <a:ln/>
+        </p:spPr>
+        <p:txBody>
+          <a:bodyPr wrap="square" lIns="0" tIns="0" rIns="0" bIns="0" rtlCol="0" anchor="ctr"/>
+          <a:lstStyle/>
+          <a:p>
+            <a:pPr algn="ctr" indent="0" marL="0">
+              <a:buNone/>
+            </a:pPr>
+            <a:r>
+              <a:rPr lang="en-US" sz="1000" u="none" spc="150" kern="0" dirty="0">
+                <a:solidFill>
+                  <a:srgbClr val="5A6B86"/>
+                </a:solidFill>
+                <a:hlinkClick r:id="rId3" action="ppaction://hlinksldjump" tooltip="Ir a Diagnóstico">
+                  <a:extLst>
+                    <a:ext uri="{A12FA001-AC4F-418D-AE19-62706E023703}">
+                      <ahyp:hlinkClr xmlns:ahyp="http://schemas.microsoft.com/office/drawing/2018/hyperlinkcolor" val="tx"/>
+                    </a:ext>
+                  </a:extLst>
+                </a:hlinkClick>
+              </a:rPr>
+              <a:t>DIAGNÓSTICO</a:t>
+            </a:r>
+            <a:endParaRPr lang="en-US" sz="1000" dirty="0"/>
+          </a:p>
+        </p:txBody>
+      </p:sp>
+      <p:sp>
+        <p:nvSpPr>
+          <p:cNvPr id="22" name="Pestaña Riesgos"/>
+          <p:cNvSpPr txBox="1"/>
+          <p:nvPr/>
+        </p:nvSpPr>
+        <p:spPr>
+          <a:xfrm>
+            <a:off x="2766974" y="0"/>
+            <a:ext cx="2218334" cy="384048"/>
+          </a:xfrm>
+          <a:prstGeom prst="rect">
+            <a:avLst/>
+          </a:prstGeom>
+          <a:noFill/>
+          <a:ln/>
+        </p:spPr>
+        <p:txBody>
+          <a:bodyPr wrap="square" lIns="0" tIns="0" rIns="0" bIns="0" rtlCol="0" anchor="ctr"/>
+          <a:lstStyle/>
+          <a:p>
+            <a:pPr algn="ctr" indent="0" marL="0">
+              <a:buNone/>
+            </a:pPr>
+            <a:r>
+              <a:rPr lang="en-US" sz="1000" b="1" spc="150" kern="0" dirty="0">
+                <a:solidFill>
+                  <a:srgbClr val="002B63"/>
+                </a:solidFill>
+              </a:rPr>
+              <a:t>RIESGOS</a:t>
+            </a:r>
+            <a:endParaRPr lang="en-US" sz="1000" dirty="0"/>
+          </a:p>
+        </p:txBody>
+      </p:sp>
+      <p:sp>
+        <p:nvSpPr>
+          <p:cNvPr id="23" name="Sección actual"/>
+          <p:cNvSpPr/>
+          <p:nvPr/>
+        </p:nvSpPr>
+        <p:spPr>
+          <a:xfrm>
+            <a:off x="3432475" y="338328"/>
+            <a:ext cx="887334" cy="45720"/>
+          </a:xfrm>
+          <a:prstGeom prst="rect">
+            <a:avLst/>
+          </a:prstGeom>
+          <a:solidFill>
+            <a:srgbClr val="DA1822"/>
+          </a:solidFill>
+          <a:ln w="12700">
+            <a:solidFill>
+              <a:srgbClr val="DA1822"/>
+            </a:solidFill>
+            <a:prstDash val="solid"/>
+          </a:ln>
+        </p:spPr>
+      </p:sp>
+      <p:sp>
+        <p:nvSpPr>
+          <p:cNvPr id="24" name="Pestaña Resultados 2024"/>
+          <p:cNvSpPr txBox="1"/>
+          <p:nvPr/>
+        </p:nvSpPr>
+        <p:spPr>
+          <a:xfrm>
+            <a:off x="4985309" y="0"/>
+            <a:ext cx="2218334" cy="384048"/>
+          </a:xfrm>
+          <a:prstGeom prst="rect">
+            <a:avLst/>
+          </a:prstGeom>
+          <a:noFill/>
+          <a:ln/>
+        </p:spPr>
+        <p:txBody>
+          <a:bodyPr wrap="square" lIns="0" tIns="0" rIns="0" bIns="0" rtlCol="0" anchor="ctr"/>
+          <a:lstStyle/>
+          <a:p>
+            <a:pPr algn="ctr" indent="0" marL="0">
+              <a:buNone/>
+            </a:pPr>
+            <a:r>
+              <a:rPr lang="en-US" sz="1000" u="none" spc="150" kern="0" dirty="0">
+                <a:solidFill>
+                  <a:srgbClr val="5A6B86"/>
+                </a:solidFill>
+                <a:hlinkClick r:id="rId4" action="ppaction://hlinksldjump" tooltip="Ir a Resultados 2024">
+                  <a:extLst>
+                    <a:ext uri="{A12FA001-AC4F-418D-AE19-62706E023703}">
+                      <ahyp:hlinkClr xmlns:ahyp="http://schemas.microsoft.com/office/drawing/2018/hyperlinkcolor" val="tx"/>
+                    </a:ext>
+                  </a:extLst>
+                </a:hlinkClick>
+              </a:rPr>
+              <a:t>RESULTADOS 2024</a:t>
+            </a:r>
+            <a:endParaRPr lang="en-US" sz="1000" dirty="0"/>
+          </a:p>
+        </p:txBody>
+      </p:sp>
+      <p:sp>
+        <p:nvSpPr>
+          <p:cNvPr id="25" name="Pestaña Meta"/>
+          <p:cNvSpPr txBox="1"/>
+          <p:nvPr/>
+        </p:nvSpPr>
+        <p:spPr>
+          <a:xfrm>
+            <a:off x="7203643" y="0"/>
+            <a:ext cx="2218334" cy="384048"/>
+          </a:xfrm>
+          <a:prstGeom prst="rect">
+            <a:avLst/>
+          </a:prstGeom>
+          <a:noFill/>
+          <a:ln/>
+        </p:spPr>
+        <p:txBody>
+          <a:bodyPr wrap="square" lIns="0" tIns="0" rIns="0" bIns="0" rtlCol="0" anchor="ctr"/>
+          <a:lstStyle/>
+          <a:p>
+            <a:pPr algn="ctr" indent="0" marL="0">
+              <a:buNone/>
+            </a:pPr>
+            <a:r>
+              <a:rPr lang="en-US" sz="1000" u="none" spc="150" kern="0" dirty="0">
+                <a:solidFill>
+                  <a:srgbClr val="5A6B86"/>
+                </a:solidFill>
+                <a:hlinkClick r:id="rId5" action="ppaction://hlinksldjump" tooltip="Ir a Meta">
+                  <a:extLst>
+                    <a:ext uri="{A12FA001-AC4F-418D-AE19-62706E023703}">
+                      <ahyp:hlinkClr xmlns:ahyp="http://schemas.microsoft.com/office/drawing/2018/hyperlinkcolor" val="tx"/>
+                    </a:ext>
+                  </a:extLst>
+                </a:hlinkClick>
+              </a:rPr>
+              <a:t>META</a:t>
+            </a:r>
+            <a:endParaRPr lang="en-US" sz="1000" dirty="0"/>
+          </a:p>
+        </p:txBody>
+      </p:sp>
+      <p:sp>
+        <p:nvSpPr>
+          <p:cNvPr id="26" name="Pestaña Plan y recomendación"/>
+          <p:cNvSpPr txBox="1"/>
+          <p:nvPr/>
+        </p:nvSpPr>
+        <p:spPr>
+          <a:xfrm>
+            <a:off x="9421978" y="0"/>
+            <a:ext cx="2218334" cy="384048"/>
+          </a:xfrm>
+          <a:prstGeom prst="rect">
+            <a:avLst/>
+          </a:prstGeom>
+          <a:noFill/>
+          <a:ln/>
+        </p:spPr>
+        <p:txBody>
+          <a:bodyPr wrap="square" lIns="0" tIns="0" rIns="0" bIns="0" rtlCol="0" anchor="ctr"/>
+          <a:lstStyle/>
+          <a:p>
+            <a:pPr algn="ctr" indent="0" marL="0">
+              <a:buNone/>
+            </a:pPr>
+            <a:r>
+              <a:rPr lang="en-US" sz="1000" u="none" spc="150" kern="0" dirty="0">
+                <a:solidFill>
+                  <a:srgbClr val="5A6B86"/>
+                </a:solidFill>
+                <a:hlinkClick r:id="rId6" action="ppaction://hlinksldjump" tooltip="Ir a Plan y recomendación">
+                  <a:extLst>
+                    <a:ext uri="{A12FA001-AC4F-418D-AE19-62706E023703}">
+                      <ahyp:hlinkClr xmlns:ahyp="http://schemas.microsoft.com/office/drawing/2018/hyperlinkcolor" val="tx"/>
+                    </a:ext>
+                  </a:extLst>
+                </a:hlinkClick>
+              </a:rPr>
+              <a:t>PLAN Y RECOMENDACIÓN</a:t>
             </a:r>
             <a:endParaRPr lang="en-US" sz="1000" dirty="0"/>
           </a:p>
@@ -9068,8 +10754,8 @@
         </p:nvSpPr>
         <p:spPr>
           <a:xfrm>
-            <a:off x="548640" y="320040"/>
-            <a:ext cx="11091672" cy="1051560"/>
+            <a:off x="548640" y="502920"/>
+            <a:ext cx="11091672" cy="1005840"/>
           </a:xfrm>
           <a:prstGeom prst="rect">
             <a:avLst/>
@@ -13978,6 +15664,287 @@
       </p:sp>
       <p:sp>
         <p:nvSpPr>
+          <p:cNvPr id="10" name="Barra de navegación"/>
+          <p:cNvSpPr/>
+          <p:nvPr/>
+        </p:nvSpPr>
+        <p:spPr>
+          <a:xfrm>
+            <a:off x="0" y="0"/>
+            <a:ext cx="12191695" cy="384048"/>
+          </a:xfrm>
+          <a:prstGeom prst="rect">
+            <a:avLst/>
+          </a:prstGeom>
+          <a:solidFill>
+            <a:srgbClr val="F4F7FB"/>
+          </a:solidFill>
+          <a:ln w="12700">
+            <a:solidFill>
+              <a:srgbClr val="F4F7FB"/>
+            </a:solidFill>
+            <a:prstDash val="solid"/>
+          </a:ln>
+        </p:spPr>
+      </p:sp>
+      <p:sp>
+        <p:nvSpPr>
+          <p:cNvPr id="11" name="Shape 7"/>
+          <p:cNvSpPr/>
+          <p:nvPr/>
+        </p:nvSpPr>
+        <p:spPr>
+          <a:xfrm>
+            <a:off x="0" y="384048"/>
+            <a:ext cx="12191695" cy="0"/>
+          </a:xfrm>
+          <a:prstGeom prst="line">
+            <a:avLst/>
+          </a:prstGeom>
+          <a:noFill/>
+          <a:ln w="9525">
+            <a:solidFill>
+              <a:srgbClr val="D6DEEA"/>
+            </a:solidFill>
+            <a:prstDash val="solid"/>
+          </a:ln>
+        </p:spPr>
+      </p:sp>
+      <p:sp>
+        <p:nvSpPr>
+          <p:cNvPr id="12" name="Pestaña Diagnóstico"/>
+          <p:cNvSpPr txBox="1"/>
+          <p:nvPr/>
+        </p:nvSpPr>
+        <p:spPr>
+          <a:xfrm>
+            <a:off x="548640" y="0"/>
+            <a:ext cx="2218334" cy="384048"/>
+          </a:xfrm>
+          <a:prstGeom prst="rect">
+            <a:avLst/>
+          </a:prstGeom>
+          <a:noFill/>
+          <a:ln/>
+        </p:spPr>
+        <p:txBody>
+          <a:bodyPr wrap="square" lIns="0" tIns="0" rIns="0" bIns="0" rtlCol="0" anchor="ctr"/>
+          <a:lstStyle/>
+          <a:p>
+            <a:pPr algn="ctr" indent="0" marL="0">
+              <a:buNone/>
+            </a:pPr>
+            <a:r>
+              <a:rPr lang="en-US" sz="1000" u="none" spc="150" kern="0" dirty="0">
+                <a:solidFill>
+                  <a:srgbClr val="5A6B86"/>
+                </a:solidFill>
+                <a:hlinkClick r:id="rId1" action="ppaction://hlinksldjump" tooltip="Ir a Diagnóstico">
+                  <a:extLst>
+                    <a:ext uri="{A12FA001-AC4F-418D-AE19-62706E023703}">
+                      <ahyp:hlinkClr xmlns:ahyp="http://schemas.microsoft.com/office/drawing/2018/hyperlinkcolor" val="tx"/>
+                    </a:ext>
+                  </a:extLst>
+                </a:hlinkClick>
+              </a:rPr>
+              <a:t>DIAGNÓSTICO</a:t>
+            </a:r>
+            <a:endParaRPr lang="en-US" sz="1000" dirty="0"/>
+          </a:p>
+        </p:txBody>
+      </p:sp>
+      <p:sp>
+        <p:nvSpPr>
+          <p:cNvPr id="13" name="Pestaña Riesgos"/>
+          <p:cNvSpPr txBox="1"/>
+          <p:nvPr/>
+        </p:nvSpPr>
+        <p:spPr>
+          <a:xfrm>
+            <a:off x="2766974" y="0"/>
+            <a:ext cx="2218334" cy="384048"/>
+          </a:xfrm>
+          <a:prstGeom prst="rect">
+            <a:avLst/>
+          </a:prstGeom>
+          <a:noFill/>
+          <a:ln/>
+        </p:spPr>
+        <p:txBody>
+          <a:bodyPr wrap="square" lIns="0" tIns="0" rIns="0" bIns="0" rtlCol="0" anchor="ctr"/>
+          <a:lstStyle/>
+          <a:p>
+            <a:pPr algn="ctr" indent="0" marL="0">
+              <a:buNone/>
+            </a:pPr>
+            <a:r>
+              <a:rPr lang="en-US" sz="1000" u="none" spc="150" kern="0" dirty="0">
+                <a:solidFill>
+                  <a:srgbClr val="5A6B86"/>
+                </a:solidFill>
+                <a:hlinkClick r:id="rId2" action="ppaction://hlinksldjump" tooltip="Ir a Riesgos">
+                  <a:extLst>
+                    <a:ext uri="{A12FA001-AC4F-418D-AE19-62706E023703}">
+                      <ahyp:hlinkClr xmlns:ahyp="http://schemas.microsoft.com/office/drawing/2018/hyperlinkcolor" val="tx"/>
+                    </a:ext>
+                  </a:extLst>
+                </a:hlinkClick>
+              </a:rPr>
+              <a:t>RIESGOS</a:t>
+            </a:r>
+            <a:endParaRPr lang="en-US" sz="1000" dirty="0"/>
+          </a:p>
+        </p:txBody>
+      </p:sp>
+      <p:sp>
+        <p:nvSpPr>
+          <p:cNvPr id="14" name="Pestaña Resultados 2024"/>
+          <p:cNvSpPr txBox="1"/>
+          <p:nvPr/>
+        </p:nvSpPr>
+        <p:spPr>
+          <a:xfrm>
+            <a:off x="4985309" y="0"/>
+            <a:ext cx="2218334" cy="384048"/>
+          </a:xfrm>
+          <a:prstGeom prst="rect">
+            <a:avLst/>
+          </a:prstGeom>
+          <a:noFill/>
+          <a:ln/>
+        </p:spPr>
+        <p:txBody>
+          <a:bodyPr wrap="square" lIns="0" tIns="0" rIns="0" bIns="0" rtlCol="0" anchor="ctr"/>
+          <a:lstStyle/>
+          <a:p>
+            <a:pPr algn="ctr" indent="0" marL="0">
+              <a:buNone/>
+            </a:pPr>
+            <a:r>
+              <a:rPr lang="en-US" sz="1000" b="1" spc="150" kern="0" dirty="0">
+                <a:solidFill>
+                  <a:srgbClr val="002B63"/>
+                </a:solidFill>
+              </a:rPr>
+              <a:t>RESULTADOS 2024</a:t>
+            </a:r>
+            <a:endParaRPr lang="en-US" sz="1000" dirty="0"/>
+          </a:p>
+        </p:txBody>
+      </p:sp>
+      <p:sp>
+        <p:nvSpPr>
+          <p:cNvPr id="15" name="Sección actual"/>
+          <p:cNvSpPr/>
+          <p:nvPr/>
+        </p:nvSpPr>
+        <p:spPr>
+          <a:xfrm>
+            <a:off x="5650809" y="338328"/>
+            <a:ext cx="887334" cy="45720"/>
+          </a:xfrm>
+          <a:prstGeom prst="rect">
+            <a:avLst/>
+          </a:prstGeom>
+          <a:solidFill>
+            <a:srgbClr val="DA1822"/>
+          </a:solidFill>
+          <a:ln w="12700">
+            <a:solidFill>
+              <a:srgbClr val="DA1822"/>
+            </a:solidFill>
+            <a:prstDash val="solid"/>
+          </a:ln>
+        </p:spPr>
+      </p:sp>
+      <p:sp>
+        <p:nvSpPr>
+          <p:cNvPr id="16" name="Pestaña Meta"/>
+          <p:cNvSpPr txBox="1"/>
+          <p:nvPr/>
+        </p:nvSpPr>
+        <p:spPr>
+          <a:xfrm>
+            <a:off x="7203643" y="0"/>
+            <a:ext cx="2218334" cy="384048"/>
+          </a:xfrm>
+          <a:prstGeom prst="rect">
+            <a:avLst/>
+          </a:prstGeom>
+          <a:noFill/>
+          <a:ln/>
+        </p:spPr>
+        <p:txBody>
+          <a:bodyPr wrap="square" lIns="0" tIns="0" rIns="0" bIns="0" rtlCol="0" anchor="ctr"/>
+          <a:lstStyle/>
+          <a:p>
+            <a:pPr algn="ctr" indent="0" marL="0">
+              <a:buNone/>
+            </a:pPr>
+            <a:r>
+              <a:rPr lang="en-US" sz="1000" u="none" spc="150" kern="0" dirty="0">
+                <a:solidFill>
+                  <a:srgbClr val="5A6B86"/>
+                </a:solidFill>
+                <a:hlinkClick r:id="rId3" action="ppaction://hlinksldjump" tooltip="Ir a Meta">
+                  <a:extLst>
+                    <a:ext uri="{A12FA001-AC4F-418D-AE19-62706E023703}">
+                      <ahyp:hlinkClr xmlns:ahyp="http://schemas.microsoft.com/office/drawing/2018/hyperlinkcolor" val="tx"/>
+                    </a:ext>
+                  </a:extLst>
+                </a:hlinkClick>
+              </a:rPr>
+              <a:t>META</a:t>
+            </a:r>
+            <a:endParaRPr lang="en-US" sz="1000" dirty="0"/>
+          </a:p>
+        </p:txBody>
+      </p:sp>
+      <p:sp>
+        <p:nvSpPr>
+          <p:cNvPr id="17" name="Pestaña Plan y recomendación"/>
+          <p:cNvSpPr txBox="1"/>
+          <p:nvPr/>
+        </p:nvSpPr>
+        <p:spPr>
+          <a:xfrm>
+            <a:off x="9421978" y="0"/>
+            <a:ext cx="2218334" cy="384048"/>
+          </a:xfrm>
+          <a:prstGeom prst="rect">
+            <a:avLst/>
+          </a:prstGeom>
+          <a:noFill/>
+          <a:ln/>
+        </p:spPr>
+        <p:txBody>
+          <a:bodyPr wrap="square" lIns="0" tIns="0" rIns="0" bIns="0" rtlCol="0" anchor="ctr"/>
+          <a:lstStyle/>
+          <a:p>
+            <a:pPr algn="ctr" indent="0" marL="0">
+              <a:buNone/>
+            </a:pPr>
+            <a:r>
+              <a:rPr lang="en-US" sz="1000" u="none" spc="150" kern="0" dirty="0">
+                <a:solidFill>
+                  <a:srgbClr val="5A6B86"/>
+                </a:solidFill>
+                <a:hlinkClick r:id="rId4" action="ppaction://hlinksldjump" tooltip="Ir a Plan y recomendación">
+                  <a:extLst>
+                    <a:ext uri="{A12FA001-AC4F-418D-AE19-62706E023703}">
+                      <ahyp:hlinkClr xmlns:ahyp="http://schemas.microsoft.com/office/drawing/2018/hyperlinkcolor" val="tx"/>
+                    </a:ext>
+                  </a:extLst>
+                </a:hlinkClick>
+              </a:rPr>
+              <a:t>PLAN Y RECOMENDACIÓN</a:t>
+            </a:r>
+            <a:endParaRPr lang="en-US" sz="1000" dirty="0"/>
+          </a:p>
+        </p:txBody>
+      </p:sp>
+      <p:sp>
+        <p:nvSpPr>
           <p:cNvPr id="25" name="Slide Number Placeholder 0"/>
           <p:cNvSpPr>
             <a:spLocks noGrp="1"/>
@@ -14056,8 +16023,8 @@
         </p:nvSpPr>
         <p:spPr>
           <a:xfrm>
-            <a:off x="548640" y="320040"/>
-            <a:ext cx="11091672" cy="1051560"/>
+            <a:off x="548640" y="502920"/>
+            <a:ext cx="11091672" cy="1005840"/>
           </a:xfrm>
           <a:prstGeom prst="rect">
             <a:avLst/>
@@ -14769,6 +16736,287 @@
                 </a:solidFill>
               </a:rPr>
               <a:t>Fuente 2024: JCE, resultado presidencial por colegios, OCLEE Philadelphia (PRM y aliados 5,581 votos, 63.4 % de los válidos). Escenarios 2028: proyección propia.</a:t>
+            </a:r>
+            <a:endParaRPr lang="en-US" sz="1000" dirty="0"/>
+          </a:p>
+        </p:txBody>
+      </p:sp>
+      <p:sp>
+        <p:nvSpPr>
+          <p:cNvPr id="23" name="Barra de navegación"/>
+          <p:cNvSpPr/>
+          <p:nvPr/>
+        </p:nvSpPr>
+        <p:spPr>
+          <a:xfrm>
+            <a:off x="0" y="0"/>
+            <a:ext cx="12191695" cy="384048"/>
+          </a:xfrm>
+          <a:prstGeom prst="rect">
+            <a:avLst/>
+          </a:prstGeom>
+          <a:solidFill>
+            <a:srgbClr val="F4F7FB"/>
+          </a:solidFill>
+          <a:ln w="12700">
+            <a:solidFill>
+              <a:srgbClr val="F4F7FB"/>
+            </a:solidFill>
+            <a:prstDash val="solid"/>
+          </a:ln>
+        </p:spPr>
+      </p:sp>
+      <p:sp>
+        <p:nvSpPr>
+          <p:cNvPr id="24" name="Shape 20"/>
+          <p:cNvSpPr/>
+          <p:nvPr/>
+        </p:nvSpPr>
+        <p:spPr>
+          <a:xfrm>
+            <a:off x="0" y="384048"/>
+            <a:ext cx="12191695" cy="0"/>
+          </a:xfrm>
+          <a:prstGeom prst="line">
+            <a:avLst/>
+          </a:prstGeom>
+          <a:noFill/>
+          <a:ln w="9525">
+            <a:solidFill>
+              <a:srgbClr val="D6DEEA"/>
+            </a:solidFill>
+            <a:prstDash val="solid"/>
+          </a:ln>
+        </p:spPr>
+      </p:sp>
+      <p:sp>
+        <p:nvSpPr>
+          <p:cNvPr id="25" name="Pestaña Diagnóstico"/>
+          <p:cNvSpPr txBox="1"/>
+          <p:nvPr/>
+        </p:nvSpPr>
+        <p:spPr>
+          <a:xfrm>
+            <a:off x="548640" y="0"/>
+            <a:ext cx="2218334" cy="384048"/>
+          </a:xfrm>
+          <a:prstGeom prst="rect">
+            <a:avLst/>
+          </a:prstGeom>
+          <a:noFill/>
+          <a:ln/>
+        </p:spPr>
+        <p:txBody>
+          <a:bodyPr wrap="square" lIns="0" tIns="0" rIns="0" bIns="0" rtlCol="0" anchor="ctr"/>
+          <a:lstStyle/>
+          <a:p>
+            <a:pPr algn="ctr" indent="0" marL="0">
+              <a:buNone/>
+            </a:pPr>
+            <a:r>
+              <a:rPr lang="en-US" sz="1000" u="none" spc="150" kern="0" dirty="0">
+                <a:solidFill>
+                  <a:srgbClr val="5A6B86"/>
+                </a:solidFill>
+                <a:hlinkClick r:id="rId2" action="ppaction://hlinksldjump" tooltip="Ir a Diagnóstico">
+                  <a:extLst>
+                    <a:ext uri="{A12FA001-AC4F-418D-AE19-62706E023703}">
+                      <ahyp:hlinkClr xmlns:ahyp="http://schemas.microsoft.com/office/drawing/2018/hyperlinkcolor" val="tx"/>
+                    </a:ext>
+                  </a:extLst>
+                </a:hlinkClick>
+              </a:rPr>
+              <a:t>DIAGNÓSTICO</a:t>
+            </a:r>
+            <a:endParaRPr lang="en-US" sz="1000" dirty="0"/>
+          </a:p>
+        </p:txBody>
+      </p:sp>
+      <p:sp>
+        <p:nvSpPr>
+          <p:cNvPr id="26" name="Pestaña Riesgos"/>
+          <p:cNvSpPr txBox="1"/>
+          <p:nvPr/>
+        </p:nvSpPr>
+        <p:spPr>
+          <a:xfrm>
+            <a:off x="2766974" y="0"/>
+            <a:ext cx="2218334" cy="384048"/>
+          </a:xfrm>
+          <a:prstGeom prst="rect">
+            <a:avLst/>
+          </a:prstGeom>
+          <a:noFill/>
+          <a:ln/>
+        </p:spPr>
+        <p:txBody>
+          <a:bodyPr wrap="square" lIns="0" tIns="0" rIns="0" bIns="0" rtlCol="0" anchor="ctr"/>
+          <a:lstStyle/>
+          <a:p>
+            <a:pPr algn="ctr" indent="0" marL="0">
+              <a:buNone/>
+            </a:pPr>
+            <a:r>
+              <a:rPr lang="en-US" sz="1000" u="none" spc="150" kern="0" dirty="0">
+                <a:solidFill>
+                  <a:srgbClr val="5A6B86"/>
+                </a:solidFill>
+                <a:hlinkClick r:id="rId3" action="ppaction://hlinksldjump" tooltip="Ir a Riesgos">
+                  <a:extLst>
+                    <a:ext uri="{A12FA001-AC4F-418D-AE19-62706E023703}">
+                      <ahyp:hlinkClr xmlns:ahyp="http://schemas.microsoft.com/office/drawing/2018/hyperlinkcolor" val="tx"/>
+                    </a:ext>
+                  </a:extLst>
+                </a:hlinkClick>
+              </a:rPr>
+              <a:t>RIESGOS</a:t>
+            </a:r>
+            <a:endParaRPr lang="en-US" sz="1000" dirty="0"/>
+          </a:p>
+        </p:txBody>
+      </p:sp>
+      <p:sp>
+        <p:nvSpPr>
+          <p:cNvPr id="27" name="Pestaña Resultados 2024"/>
+          <p:cNvSpPr txBox="1"/>
+          <p:nvPr/>
+        </p:nvSpPr>
+        <p:spPr>
+          <a:xfrm>
+            <a:off x="4985309" y="0"/>
+            <a:ext cx="2218334" cy="384048"/>
+          </a:xfrm>
+          <a:prstGeom prst="rect">
+            <a:avLst/>
+          </a:prstGeom>
+          <a:noFill/>
+          <a:ln/>
+        </p:spPr>
+        <p:txBody>
+          <a:bodyPr wrap="square" lIns="0" tIns="0" rIns="0" bIns="0" rtlCol="0" anchor="ctr"/>
+          <a:lstStyle/>
+          <a:p>
+            <a:pPr algn="ctr" indent="0" marL="0">
+              <a:buNone/>
+            </a:pPr>
+            <a:r>
+              <a:rPr lang="en-US" sz="1000" u="none" spc="150" kern="0" dirty="0">
+                <a:solidFill>
+                  <a:srgbClr val="5A6B86"/>
+                </a:solidFill>
+                <a:hlinkClick r:id="rId4" action="ppaction://hlinksldjump" tooltip="Ir a Resultados 2024">
+                  <a:extLst>
+                    <a:ext uri="{A12FA001-AC4F-418D-AE19-62706E023703}">
+                      <ahyp:hlinkClr xmlns:ahyp="http://schemas.microsoft.com/office/drawing/2018/hyperlinkcolor" val="tx"/>
+                    </a:ext>
+                  </a:extLst>
+                </a:hlinkClick>
+              </a:rPr>
+              <a:t>RESULTADOS 2024</a:t>
+            </a:r>
+            <a:endParaRPr lang="en-US" sz="1000" dirty="0"/>
+          </a:p>
+        </p:txBody>
+      </p:sp>
+      <p:sp>
+        <p:nvSpPr>
+          <p:cNvPr id="28" name="Pestaña Meta"/>
+          <p:cNvSpPr txBox="1"/>
+          <p:nvPr/>
+        </p:nvSpPr>
+        <p:spPr>
+          <a:xfrm>
+            <a:off x="7203643" y="0"/>
+            <a:ext cx="2218334" cy="384048"/>
+          </a:xfrm>
+          <a:prstGeom prst="rect">
+            <a:avLst/>
+          </a:prstGeom>
+          <a:noFill/>
+          <a:ln/>
+        </p:spPr>
+        <p:txBody>
+          <a:bodyPr wrap="square" lIns="0" tIns="0" rIns="0" bIns="0" rtlCol="0" anchor="ctr"/>
+          <a:lstStyle/>
+          <a:p>
+            <a:pPr algn="ctr" indent="0" marL="0">
+              <a:buNone/>
+            </a:pPr>
+            <a:r>
+              <a:rPr lang="en-US" sz="1000" b="1" spc="150" kern="0" dirty="0">
+                <a:solidFill>
+                  <a:srgbClr val="002B63"/>
+                </a:solidFill>
+              </a:rPr>
+              <a:t>META</a:t>
+            </a:r>
+            <a:endParaRPr lang="en-US" sz="1000" dirty="0"/>
+          </a:p>
+        </p:txBody>
+      </p:sp>
+      <p:sp>
+        <p:nvSpPr>
+          <p:cNvPr id="29" name="Sección actual"/>
+          <p:cNvSpPr/>
+          <p:nvPr/>
+        </p:nvSpPr>
+        <p:spPr>
+          <a:xfrm>
+            <a:off x="7869144" y="338328"/>
+            <a:ext cx="887334" cy="45720"/>
+          </a:xfrm>
+          <a:prstGeom prst="rect">
+            <a:avLst/>
+          </a:prstGeom>
+          <a:solidFill>
+            <a:srgbClr val="DA1822"/>
+          </a:solidFill>
+          <a:ln w="12700">
+            <a:solidFill>
+              <a:srgbClr val="DA1822"/>
+            </a:solidFill>
+            <a:prstDash val="solid"/>
+          </a:ln>
+        </p:spPr>
+      </p:sp>
+      <p:sp>
+        <p:nvSpPr>
+          <p:cNvPr id="30" name="Pestaña Plan y recomendación"/>
+          <p:cNvSpPr txBox="1"/>
+          <p:nvPr/>
+        </p:nvSpPr>
+        <p:spPr>
+          <a:xfrm>
+            <a:off x="9421978" y="0"/>
+            <a:ext cx="2218334" cy="384048"/>
+          </a:xfrm>
+          <a:prstGeom prst="rect">
+            <a:avLst/>
+          </a:prstGeom>
+          <a:noFill/>
+          <a:ln/>
+        </p:spPr>
+        <p:txBody>
+          <a:bodyPr wrap="square" lIns="0" tIns="0" rIns="0" bIns="0" rtlCol="0" anchor="ctr"/>
+          <a:lstStyle/>
+          <a:p>
+            <a:pPr algn="ctr" indent="0" marL="0">
+              <a:buNone/>
+            </a:pPr>
+            <a:r>
+              <a:rPr lang="en-US" sz="1000" u="none" spc="150" kern="0" dirty="0">
+                <a:solidFill>
+                  <a:srgbClr val="5A6B86"/>
+                </a:solidFill>
+                <a:hlinkClick r:id="rId5" action="ppaction://hlinksldjump" tooltip="Ir a Plan y recomendación">
+                  <a:extLst>
+                    <a:ext uri="{A12FA001-AC4F-418D-AE19-62706E023703}">
+                      <ahyp:hlinkClr xmlns:ahyp="http://schemas.microsoft.com/office/drawing/2018/hyperlinkcolor" val="tx"/>
+                    </a:ext>
+                  </a:extLst>
+                </a:hlinkClick>
+              </a:rPr>
+              <a:t>PLAN Y RECOMENDACIÓN</a:t>
             </a:r>
             <a:endParaRPr lang="en-US" sz="1000" dirty="0"/>
           </a:p>
@@ -14854,8 +17102,8 @@
         </p:nvSpPr>
         <p:spPr>
           <a:xfrm>
-            <a:off x="548640" y="320040"/>
-            <a:ext cx="11091672" cy="1051560"/>
+            <a:off x="548640" y="502920"/>
+            <a:ext cx="11091672" cy="1005840"/>
           </a:xfrm>
           <a:prstGeom prst="rect">
             <a:avLst/>
@@ -16301,6 +18549,287 @@
             <a:endParaRPr lang="en-US" sz="1600" dirty="0"/>
           </a:p>
         </p:txBody>
+      </p:sp>
+      <p:sp>
+        <p:nvSpPr>
+          <p:cNvPr id="46" name="Barra de navegación"/>
+          <p:cNvSpPr/>
+          <p:nvPr/>
+        </p:nvSpPr>
+        <p:spPr>
+          <a:xfrm>
+            <a:off x="0" y="0"/>
+            <a:ext cx="12191695" cy="384048"/>
+          </a:xfrm>
+          <a:prstGeom prst="rect">
+            <a:avLst/>
+          </a:prstGeom>
+          <a:solidFill>
+            <a:srgbClr val="F4F7FB"/>
+          </a:solidFill>
+          <a:ln w="12700">
+            <a:solidFill>
+              <a:srgbClr val="F4F7FB"/>
+            </a:solidFill>
+            <a:prstDash val="solid"/>
+          </a:ln>
+        </p:spPr>
+      </p:sp>
+      <p:sp>
+        <p:nvSpPr>
+          <p:cNvPr id="47" name="Shape 44"/>
+          <p:cNvSpPr/>
+          <p:nvPr/>
+        </p:nvSpPr>
+        <p:spPr>
+          <a:xfrm>
+            <a:off x="0" y="384048"/>
+            <a:ext cx="12191695" cy="0"/>
+          </a:xfrm>
+          <a:prstGeom prst="line">
+            <a:avLst/>
+          </a:prstGeom>
+          <a:noFill/>
+          <a:ln w="9525">
+            <a:solidFill>
+              <a:srgbClr val="D6DEEA"/>
+            </a:solidFill>
+            <a:prstDash val="solid"/>
+          </a:ln>
+        </p:spPr>
+      </p:sp>
+      <p:sp>
+        <p:nvSpPr>
+          <p:cNvPr id="48" name="Pestaña Diagnóstico"/>
+          <p:cNvSpPr txBox="1"/>
+          <p:nvPr/>
+        </p:nvSpPr>
+        <p:spPr>
+          <a:xfrm>
+            <a:off x="548640" y="0"/>
+            <a:ext cx="2218334" cy="384048"/>
+          </a:xfrm>
+          <a:prstGeom prst="rect">
+            <a:avLst/>
+          </a:prstGeom>
+          <a:noFill/>
+          <a:ln/>
+        </p:spPr>
+        <p:txBody>
+          <a:bodyPr wrap="square" lIns="0" tIns="0" rIns="0" bIns="0" rtlCol="0" anchor="ctr"/>
+          <a:lstStyle/>
+          <a:p>
+            <a:pPr algn="ctr" indent="0" marL="0">
+              <a:buNone/>
+            </a:pPr>
+            <a:r>
+              <a:rPr lang="en-US" sz="1000" u="none" spc="150" kern="0" dirty="0">
+                <a:solidFill>
+                  <a:srgbClr val="5A6B86"/>
+                </a:solidFill>
+                <a:hlinkClick r:id="rId1" action="ppaction://hlinksldjump" tooltip="Ir a Diagnóstico">
+                  <a:extLst>
+                    <a:ext uri="{A12FA001-AC4F-418D-AE19-62706E023703}">
+                      <ahyp:hlinkClr xmlns:ahyp="http://schemas.microsoft.com/office/drawing/2018/hyperlinkcolor" val="tx"/>
+                    </a:ext>
+                  </a:extLst>
+                </a:hlinkClick>
+              </a:rPr>
+              <a:t>DIAGNÓSTICO</a:t>
+            </a:r>
+            <a:endParaRPr lang="en-US" sz="1000" dirty="0"/>
+          </a:p>
+        </p:txBody>
+      </p:sp>
+      <p:sp>
+        <p:nvSpPr>
+          <p:cNvPr id="49" name="Pestaña Riesgos"/>
+          <p:cNvSpPr txBox="1"/>
+          <p:nvPr/>
+        </p:nvSpPr>
+        <p:spPr>
+          <a:xfrm>
+            <a:off x="2766974" y="0"/>
+            <a:ext cx="2218334" cy="384048"/>
+          </a:xfrm>
+          <a:prstGeom prst="rect">
+            <a:avLst/>
+          </a:prstGeom>
+          <a:noFill/>
+          <a:ln/>
+        </p:spPr>
+        <p:txBody>
+          <a:bodyPr wrap="square" lIns="0" tIns="0" rIns="0" bIns="0" rtlCol="0" anchor="ctr"/>
+          <a:lstStyle/>
+          <a:p>
+            <a:pPr algn="ctr" indent="0" marL="0">
+              <a:buNone/>
+            </a:pPr>
+            <a:r>
+              <a:rPr lang="en-US" sz="1000" u="none" spc="150" kern="0" dirty="0">
+                <a:solidFill>
+                  <a:srgbClr val="5A6B86"/>
+                </a:solidFill>
+                <a:hlinkClick r:id="rId2" action="ppaction://hlinksldjump" tooltip="Ir a Riesgos">
+                  <a:extLst>
+                    <a:ext uri="{A12FA001-AC4F-418D-AE19-62706E023703}">
+                      <ahyp:hlinkClr xmlns:ahyp="http://schemas.microsoft.com/office/drawing/2018/hyperlinkcolor" val="tx"/>
+                    </a:ext>
+                  </a:extLst>
+                </a:hlinkClick>
+              </a:rPr>
+              <a:t>RIESGOS</a:t>
+            </a:r>
+            <a:endParaRPr lang="en-US" sz="1000" dirty="0"/>
+          </a:p>
+        </p:txBody>
+      </p:sp>
+      <p:sp>
+        <p:nvSpPr>
+          <p:cNvPr id="50" name="Pestaña Resultados 2024"/>
+          <p:cNvSpPr txBox="1"/>
+          <p:nvPr/>
+        </p:nvSpPr>
+        <p:spPr>
+          <a:xfrm>
+            <a:off x="4985309" y="0"/>
+            <a:ext cx="2218334" cy="384048"/>
+          </a:xfrm>
+          <a:prstGeom prst="rect">
+            <a:avLst/>
+          </a:prstGeom>
+          <a:noFill/>
+          <a:ln/>
+        </p:spPr>
+        <p:txBody>
+          <a:bodyPr wrap="square" lIns="0" tIns="0" rIns="0" bIns="0" rtlCol="0" anchor="ctr"/>
+          <a:lstStyle/>
+          <a:p>
+            <a:pPr algn="ctr" indent="0" marL="0">
+              <a:buNone/>
+            </a:pPr>
+            <a:r>
+              <a:rPr lang="en-US" sz="1000" u="none" spc="150" kern="0" dirty="0">
+                <a:solidFill>
+                  <a:srgbClr val="5A6B86"/>
+                </a:solidFill>
+                <a:hlinkClick r:id="rId3" action="ppaction://hlinksldjump" tooltip="Ir a Resultados 2024">
+                  <a:extLst>
+                    <a:ext uri="{A12FA001-AC4F-418D-AE19-62706E023703}">
+                      <ahyp:hlinkClr xmlns:ahyp="http://schemas.microsoft.com/office/drawing/2018/hyperlinkcolor" val="tx"/>
+                    </a:ext>
+                  </a:extLst>
+                </a:hlinkClick>
+              </a:rPr>
+              <a:t>RESULTADOS 2024</a:t>
+            </a:r>
+            <a:endParaRPr lang="en-US" sz="1000" dirty="0"/>
+          </a:p>
+        </p:txBody>
+      </p:sp>
+      <p:sp>
+        <p:nvSpPr>
+          <p:cNvPr id="51" name="Pestaña Meta"/>
+          <p:cNvSpPr txBox="1"/>
+          <p:nvPr/>
+        </p:nvSpPr>
+        <p:spPr>
+          <a:xfrm>
+            <a:off x="7203643" y="0"/>
+            <a:ext cx="2218334" cy="384048"/>
+          </a:xfrm>
+          <a:prstGeom prst="rect">
+            <a:avLst/>
+          </a:prstGeom>
+          <a:noFill/>
+          <a:ln/>
+        </p:spPr>
+        <p:txBody>
+          <a:bodyPr wrap="square" lIns="0" tIns="0" rIns="0" bIns="0" rtlCol="0" anchor="ctr"/>
+          <a:lstStyle/>
+          <a:p>
+            <a:pPr algn="ctr" indent="0" marL="0">
+              <a:buNone/>
+            </a:pPr>
+            <a:r>
+              <a:rPr lang="en-US" sz="1000" u="none" spc="150" kern="0" dirty="0">
+                <a:solidFill>
+                  <a:srgbClr val="5A6B86"/>
+                </a:solidFill>
+                <a:hlinkClick r:id="rId4" action="ppaction://hlinksldjump" tooltip="Ir a Meta">
+                  <a:extLst>
+                    <a:ext uri="{A12FA001-AC4F-418D-AE19-62706E023703}">
+                      <ahyp:hlinkClr xmlns:ahyp="http://schemas.microsoft.com/office/drawing/2018/hyperlinkcolor" val="tx"/>
+                    </a:ext>
+                  </a:extLst>
+                </a:hlinkClick>
+              </a:rPr>
+              <a:t>META</a:t>
+            </a:r>
+            <a:endParaRPr lang="en-US" sz="1000" dirty="0"/>
+          </a:p>
+        </p:txBody>
+      </p:sp>
+      <p:sp>
+        <p:nvSpPr>
+          <p:cNvPr id="52" name="Pestaña Plan y recomendación"/>
+          <p:cNvSpPr txBox="1"/>
+          <p:nvPr/>
+        </p:nvSpPr>
+        <p:spPr>
+          <a:xfrm>
+            <a:off x="9421978" y="0"/>
+            <a:ext cx="2218334" cy="384048"/>
+          </a:xfrm>
+          <a:prstGeom prst="rect">
+            <a:avLst/>
+          </a:prstGeom>
+          <a:noFill/>
+          <a:ln/>
+        </p:spPr>
+        <p:txBody>
+          <a:bodyPr wrap="square" lIns="0" tIns="0" rIns="0" bIns="0" rtlCol="0" anchor="ctr"/>
+          <a:lstStyle/>
+          <a:p>
+            <a:pPr algn="ctr" indent="0" marL="0">
+              <a:buNone/>
+            </a:pPr>
+            <a:r>
+              <a:rPr lang="en-US" sz="1000" b="1" spc="150" kern="0" dirty="0">
+                <a:solidFill>
+                  <a:srgbClr val="002B63"/>
+                </a:solidFill>
+              </a:rPr>
+              <a:t>PLAN Y RECOMENDACIÓN</a:t>
+            </a:r>
+            <a:endParaRPr lang="en-US" sz="1000" dirty="0"/>
+          </a:p>
+        </p:txBody>
+      </p:sp>
+      <p:sp>
+        <p:nvSpPr>
+          <p:cNvPr id="53" name="Sección actual"/>
+          <p:cNvSpPr/>
+          <p:nvPr/>
+        </p:nvSpPr>
+        <p:spPr>
+          <a:xfrm>
+            <a:off x="10087478" y="338328"/>
+            <a:ext cx="887334" cy="45720"/>
+          </a:xfrm>
+          <a:prstGeom prst="rect">
+            <a:avLst/>
+          </a:prstGeom>
+          <a:solidFill>
+            <a:srgbClr val="DA1822"/>
+          </a:solidFill>
+          <a:ln w="12700">
+            <a:solidFill>
+              <a:srgbClr val="DA1822"/>
+            </a:solidFill>
+            <a:prstDash val="solid"/>
+          </a:ln>
+        </p:spPr>
       </p:sp>
       <p:sp>
         <p:nvSpPr>
@@ -16382,8 +18911,8 @@
         </p:nvSpPr>
         <p:spPr>
           <a:xfrm>
-            <a:off x="548640" y="320040"/>
-            <a:ext cx="11091672" cy="1051560"/>
+            <a:off x="548640" y="502920"/>
+            <a:ext cx="11091672" cy="1005840"/>
           </a:xfrm>
           <a:prstGeom prst="rect">
             <a:avLst/>
@@ -17160,6 +19689,287 @@
             <a:endParaRPr lang="en-US" sz="1400" dirty="0"/>
           </a:p>
         </p:txBody>
+      </p:sp>
+      <p:sp>
+        <p:nvSpPr>
+          <p:cNvPr id="22" name="Barra de navegación"/>
+          <p:cNvSpPr/>
+          <p:nvPr/>
+        </p:nvSpPr>
+        <p:spPr>
+          <a:xfrm>
+            <a:off x="0" y="0"/>
+            <a:ext cx="12191695" cy="384048"/>
+          </a:xfrm>
+          <a:prstGeom prst="rect">
+            <a:avLst/>
+          </a:prstGeom>
+          <a:solidFill>
+            <a:srgbClr val="F4F7FB"/>
+          </a:solidFill>
+          <a:ln w="12700">
+            <a:solidFill>
+              <a:srgbClr val="F4F7FB"/>
+            </a:solidFill>
+            <a:prstDash val="solid"/>
+          </a:ln>
+        </p:spPr>
+      </p:sp>
+      <p:sp>
+        <p:nvSpPr>
+          <p:cNvPr id="23" name="Shape 20"/>
+          <p:cNvSpPr/>
+          <p:nvPr/>
+        </p:nvSpPr>
+        <p:spPr>
+          <a:xfrm>
+            <a:off x="0" y="384048"/>
+            <a:ext cx="12191695" cy="0"/>
+          </a:xfrm>
+          <a:prstGeom prst="line">
+            <a:avLst/>
+          </a:prstGeom>
+          <a:noFill/>
+          <a:ln w="9525">
+            <a:solidFill>
+              <a:srgbClr val="D6DEEA"/>
+            </a:solidFill>
+            <a:prstDash val="solid"/>
+          </a:ln>
+        </p:spPr>
+      </p:sp>
+      <p:sp>
+        <p:nvSpPr>
+          <p:cNvPr id="24" name="Pestaña Diagnóstico"/>
+          <p:cNvSpPr txBox="1"/>
+          <p:nvPr/>
+        </p:nvSpPr>
+        <p:spPr>
+          <a:xfrm>
+            <a:off x="548640" y="0"/>
+            <a:ext cx="2218334" cy="384048"/>
+          </a:xfrm>
+          <a:prstGeom prst="rect">
+            <a:avLst/>
+          </a:prstGeom>
+          <a:noFill/>
+          <a:ln/>
+        </p:spPr>
+        <p:txBody>
+          <a:bodyPr wrap="square" lIns="0" tIns="0" rIns="0" bIns="0" rtlCol="0" anchor="ctr"/>
+          <a:lstStyle/>
+          <a:p>
+            <a:pPr algn="ctr" indent="0" marL="0">
+              <a:buNone/>
+            </a:pPr>
+            <a:r>
+              <a:rPr lang="en-US" sz="1000" u="none" spc="150" kern="0" dirty="0">
+                <a:solidFill>
+                  <a:srgbClr val="5A6B86"/>
+                </a:solidFill>
+                <a:hlinkClick r:id="rId1" action="ppaction://hlinksldjump" tooltip="Ir a Diagnóstico">
+                  <a:extLst>
+                    <a:ext uri="{A12FA001-AC4F-418D-AE19-62706E023703}">
+                      <ahyp:hlinkClr xmlns:ahyp="http://schemas.microsoft.com/office/drawing/2018/hyperlinkcolor" val="tx"/>
+                    </a:ext>
+                  </a:extLst>
+                </a:hlinkClick>
+              </a:rPr>
+              <a:t>DIAGNÓSTICO</a:t>
+            </a:r>
+            <a:endParaRPr lang="en-US" sz="1000" dirty="0"/>
+          </a:p>
+        </p:txBody>
+      </p:sp>
+      <p:sp>
+        <p:nvSpPr>
+          <p:cNvPr id="25" name="Pestaña Riesgos"/>
+          <p:cNvSpPr txBox="1"/>
+          <p:nvPr/>
+        </p:nvSpPr>
+        <p:spPr>
+          <a:xfrm>
+            <a:off x="2766974" y="0"/>
+            <a:ext cx="2218334" cy="384048"/>
+          </a:xfrm>
+          <a:prstGeom prst="rect">
+            <a:avLst/>
+          </a:prstGeom>
+          <a:noFill/>
+          <a:ln/>
+        </p:spPr>
+        <p:txBody>
+          <a:bodyPr wrap="square" lIns="0" tIns="0" rIns="0" bIns="0" rtlCol="0" anchor="ctr"/>
+          <a:lstStyle/>
+          <a:p>
+            <a:pPr algn="ctr" indent="0" marL="0">
+              <a:buNone/>
+            </a:pPr>
+            <a:r>
+              <a:rPr lang="en-US" sz="1000" u="none" spc="150" kern="0" dirty="0">
+                <a:solidFill>
+                  <a:srgbClr val="5A6B86"/>
+                </a:solidFill>
+                <a:hlinkClick r:id="rId2" action="ppaction://hlinksldjump" tooltip="Ir a Riesgos">
+                  <a:extLst>
+                    <a:ext uri="{A12FA001-AC4F-418D-AE19-62706E023703}">
+                      <ahyp:hlinkClr xmlns:ahyp="http://schemas.microsoft.com/office/drawing/2018/hyperlinkcolor" val="tx"/>
+                    </a:ext>
+                  </a:extLst>
+                </a:hlinkClick>
+              </a:rPr>
+              <a:t>RIESGOS</a:t>
+            </a:r>
+            <a:endParaRPr lang="en-US" sz="1000" dirty="0"/>
+          </a:p>
+        </p:txBody>
+      </p:sp>
+      <p:sp>
+        <p:nvSpPr>
+          <p:cNvPr id="26" name="Pestaña Resultados 2024"/>
+          <p:cNvSpPr txBox="1"/>
+          <p:nvPr/>
+        </p:nvSpPr>
+        <p:spPr>
+          <a:xfrm>
+            <a:off x="4985309" y="0"/>
+            <a:ext cx="2218334" cy="384048"/>
+          </a:xfrm>
+          <a:prstGeom prst="rect">
+            <a:avLst/>
+          </a:prstGeom>
+          <a:noFill/>
+          <a:ln/>
+        </p:spPr>
+        <p:txBody>
+          <a:bodyPr wrap="square" lIns="0" tIns="0" rIns="0" bIns="0" rtlCol="0" anchor="ctr"/>
+          <a:lstStyle/>
+          <a:p>
+            <a:pPr algn="ctr" indent="0" marL="0">
+              <a:buNone/>
+            </a:pPr>
+            <a:r>
+              <a:rPr lang="en-US" sz="1000" u="none" spc="150" kern="0" dirty="0">
+                <a:solidFill>
+                  <a:srgbClr val="5A6B86"/>
+                </a:solidFill>
+                <a:hlinkClick r:id="rId3" action="ppaction://hlinksldjump" tooltip="Ir a Resultados 2024">
+                  <a:extLst>
+                    <a:ext uri="{A12FA001-AC4F-418D-AE19-62706E023703}">
+                      <ahyp:hlinkClr xmlns:ahyp="http://schemas.microsoft.com/office/drawing/2018/hyperlinkcolor" val="tx"/>
+                    </a:ext>
+                  </a:extLst>
+                </a:hlinkClick>
+              </a:rPr>
+              <a:t>RESULTADOS 2024</a:t>
+            </a:r>
+            <a:endParaRPr lang="en-US" sz="1000" dirty="0"/>
+          </a:p>
+        </p:txBody>
+      </p:sp>
+      <p:sp>
+        <p:nvSpPr>
+          <p:cNvPr id="27" name="Pestaña Meta"/>
+          <p:cNvSpPr txBox="1"/>
+          <p:nvPr/>
+        </p:nvSpPr>
+        <p:spPr>
+          <a:xfrm>
+            <a:off x="7203643" y="0"/>
+            <a:ext cx="2218334" cy="384048"/>
+          </a:xfrm>
+          <a:prstGeom prst="rect">
+            <a:avLst/>
+          </a:prstGeom>
+          <a:noFill/>
+          <a:ln/>
+        </p:spPr>
+        <p:txBody>
+          <a:bodyPr wrap="square" lIns="0" tIns="0" rIns="0" bIns="0" rtlCol="0" anchor="ctr"/>
+          <a:lstStyle/>
+          <a:p>
+            <a:pPr algn="ctr" indent="0" marL="0">
+              <a:buNone/>
+            </a:pPr>
+            <a:r>
+              <a:rPr lang="en-US" sz="1000" u="none" spc="150" kern="0" dirty="0">
+                <a:solidFill>
+                  <a:srgbClr val="5A6B86"/>
+                </a:solidFill>
+                <a:hlinkClick r:id="rId4" action="ppaction://hlinksldjump" tooltip="Ir a Meta">
+                  <a:extLst>
+                    <a:ext uri="{A12FA001-AC4F-418D-AE19-62706E023703}">
+                      <ahyp:hlinkClr xmlns:ahyp="http://schemas.microsoft.com/office/drawing/2018/hyperlinkcolor" val="tx"/>
+                    </a:ext>
+                  </a:extLst>
+                </a:hlinkClick>
+              </a:rPr>
+              <a:t>META</a:t>
+            </a:r>
+            <a:endParaRPr lang="en-US" sz="1000" dirty="0"/>
+          </a:p>
+        </p:txBody>
+      </p:sp>
+      <p:sp>
+        <p:nvSpPr>
+          <p:cNvPr id="28" name="Pestaña Plan y recomendación"/>
+          <p:cNvSpPr txBox="1"/>
+          <p:nvPr/>
+        </p:nvSpPr>
+        <p:spPr>
+          <a:xfrm>
+            <a:off x="9421978" y="0"/>
+            <a:ext cx="2218334" cy="384048"/>
+          </a:xfrm>
+          <a:prstGeom prst="rect">
+            <a:avLst/>
+          </a:prstGeom>
+          <a:noFill/>
+          <a:ln/>
+        </p:spPr>
+        <p:txBody>
+          <a:bodyPr wrap="square" lIns="0" tIns="0" rIns="0" bIns="0" rtlCol="0" anchor="ctr"/>
+          <a:lstStyle/>
+          <a:p>
+            <a:pPr algn="ctr" indent="0" marL="0">
+              <a:buNone/>
+            </a:pPr>
+            <a:r>
+              <a:rPr lang="en-US" sz="1000" b="1" spc="150" kern="0" dirty="0">
+                <a:solidFill>
+                  <a:srgbClr val="002B63"/>
+                </a:solidFill>
+              </a:rPr>
+              <a:t>PLAN Y RECOMENDACIÓN</a:t>
+            </a:r>
+            <a:endParaRPr lang="en-US" sz="1000" dirty="0"/>
+          </a:p>
+        </p:txBody>
+      </p:sp>
+      <p:sp>
+        <p:nvSpPr>
+          <p:cNvPr id="29" name="Sección actual"/>
+          <p:cNvSpPr/>
+          <p:nvPr/>
+        </p:nvSpPr>
+        <p:spPr>
+          <a:xfrm>
+            <a:off x="10087478" y="338328"/>
+            <a:ext cx="887334" cy="45720"/>
+          </a:xfrm>
+          <a:prstGeom prst="rect">
+            <a:avLst/>
+          </a:prstGeom>
+          <a:solidFill>
+            <a:srgbClr val="DA1822"/>
+          </a:solidFill>
+          <a:ln w="12700">
+            <a:solidFill>
+              <a:srgbClr val="DA1822"/>
+            </a:solidFill>
+            <a:prstDash val="solid"/>
+          </a:ln>
+        </p:spPr>
       </p:sp>
       <p:sp>
         <p:nvSpPr>
@@ -17249,10 +20059,10 @@
         <a:srgbClr val="2E8B57"/>
       </a:accent6>
       <a:hlink>
-        <a:srgbClr val="4F75AE"/>
+        <a:srgbClr val="5A6B86"/>
       </a:hlink>
       <a:folHlink>
-        <a:srgbClr val="9AA7BD"/>
+        <a:srgbClr val="5A6B86"/>
       </a:folHlink>
     </a:clrScheme>
     <a:fontScheme name="CAD El Proximo">

</xml_diff>

<commit_message>
Añadir ficha técnica (fuentes, método y supuestos)
Co-Authored-By: Claude Opus 5.5 <noreply@anthropic.com>
Claude-Session: https://claude.ai/code/session_01RrEJtrwRidXxzgveZEVQjf
</commit_message>
<xml_diff>
--- a/presentaciones/Plan_Estrategico_Pennsylvania_2028.pptx
+++ b/presentaciones/Plan_Estrategico_Pennsylvania_2028.pptx
@@ -14,9 +14,10 @@
     <p:sldId id="262" r:id="rId8"/>
     <p:sldId id="263" r:id="rId9"/>
     <p:sldId id="264" r:id="rId10"/>
+    <p:sldId id="265" r:id="rId11"/>
   </p:sldIdLst>
   <p:notesMasterIdLst>
-    <p:notesMasterId r:id="rId11"/>
+    <p:notesMasterId r:id="rId12"/>
   </p:notesMasterIdLst>
   <p:sldSz cx="12192000" cy="6858000"/>
   <p:notesSz cx="6858000" cy="12192000"/>
@@ -115,7 +116,7 @@
   <p:extLst>
     <p:ext uri="{521415D9-36F7-43E2-AB2F-B90AF26B5E84}">
       <p14:sectionLst xmlns:p14="http://schemas.microsoft.com/office/powerpoint/2010/main">
-        <p14:section name="Diagnóstico" id="{bb3b267e-2e6f-40db-eaa8-d6392b7f6bd3}">
+        <p14:section name="Diagnóstico" id="{b6326cce-9be6-66df-06e9-8db0c3e993e9}">
           <p14:sldIdLst>
             <p14:sldId id="256"/>
             <p14:sldId id="257"/>
@@ -123,21 +124,26 @@
             <p14:sldId id="259"/>
           </p14:sldIdLst>
         </p14:section>
-        <p14:section name="Resultados 2024" id="{ae121a12-4a9a-10b6-8111-e27cd0c207a5}">
+        <p14:section name="Resultados 2024" id="{bb257b73-7b69-22b0-6da3-6acbec614371}">
           <p14:sldIdLst>
             <p14:sldId id="260"/>
           </p14:sldIdLst>
         </p14:section>
-        <p14:section name="Meta" id="{ff90cd68-69d2-3927-b1ed-be2cb49716d1}">
+        <p14:section name="Meta" id="{f5d9d351-d8e9-1685-470c-c17839cee27c}">
           <p14:sldIdLst>
             <p14:sldId id="261"/>
           </p14:sldIdLst>
         </p14:section>
-        <p14:section name="Plan y recomendación" id="{5c157c18-83f3-6044-5a01-fb022bd0ffdc}">
+        <p14:section name="Plan y recomendación" id="{fdb269bf-a2aa-e003-22c3-cfee09074382}">
           <p14:sldIdLst>
             <p14:sldId id="262"/>
             <p14:sldId id="263"/>
             <p14:sldId id="264"/>
+          </p14:sldIdLst>
+        </p14:section>
+        <p14:section name="Ficha técnica" id="{ca45b114-b65f-fe28-8feb-f4bd18f41d9a}">
+          <p14:sldIdLst>
+            <p14:sldId id="265"/>
           </p14:sldIdLst>
         </p14:section>
       </p14:sectionLst>
@@ -1387,6 +1393,94 @@
             <a:fld id="{F7021451-1387-4CA6-816F-3879F97B5CBC}" type="slidenum">
               <a:rPr lang="en-US"/>
               <a:t>1</a:t>
+            </a:fld>
+            <a:endParaRPr lang="en-US"/>
+          </a:p>
+        </p:txBody>
+      </p:sp>
+    </p:spTree>
+    <p:extLst>
+      <p:ext uri="{BB962C8B-B14F-4D97-AF65-F5344CB8AC3E}">
+        <p14:creationId xmlns:p14="http://schemas.microsoft.com/office/powerpoint/2010/main" val="1024086991"/>
+      </p:ext>
+    </p:extLst>
+  </p:cSld>
+  <p:clrMapOvr>
+    <a:masterClrMapping/>
+  </p:clrMapOvr>
+</p:notes>
+</file>
+
+<file path=ppt/notesSlides/notesSlide10.xml><?xml version="1.0" encoding="utf-8"?>
+<p:notes xmlns:a="http://schemas.openxmlformats.org/drawingml/2006/main" xmlns:r="http://schemas.openxmlformats.org/officeDocument/2006/relationships" xmlns:p="http://schemas.openxmlformats.org/presentationml/2006/main">
+  <p:cSld>
+    <p:spTree>
+      <p:nvGrpSpPr>
+        <p:cNvPr id="1" name=""/>
+        <p:cNvGrpSpPr/>
+        <p:nvPr/>
+      </p:nvGrpSpPr>
+      <p:grpSpPr>
+        <a:xfrm>
+          <a:off x="0" y="0"/>
+          <a:ext cx="0" cy="0"/>
+          <a:chOff x="0" y="0"/>
+          <a:chExt cx="0" cy="0"/>
+        </a:xfrm>
+      </p:grpSpPr>
+      <p:sp>
+        <p:nvSpPr>
+          <p:cNvPr id="2" name="Slide Image Placeholder 1"/>
+          <p:cNvSpPr>
+            <a:spLocks noGrp="1" noRot="1" noChangeAspect="1"/>
+          </p:cNvSpPr>
+          <p:nvPr>
+            <p:ph type="sldImg"/>
+          </p:nvPr>
+        </p:nvSpPr>
+        <p:spPr/>
+      </p:sp>
+      <p:sp>
+        <p:nvSpPr>
+          <p:cNvPr id="3" name="Notes Placeholder 2"/>
+          <p:cNvSpPr>
+            <a:spLocks noGrp="1"/>
+          </p:cNvSpPr>
+          <p:nvPr>
+            <p:ph type="body" idx="1"/>
+          </p:nvPr>
+        </p:nvSpPr>
+        <p:spPr/>
+        <p:txBody>
+          <a:bodyPr/>
+          <a:lstStyle/>
+          <a:p>
+            <a:r>
+              <a:rPr lang="en-US" dirty="0"/>
+              <a:t>Ficha técnica del documento: fuentes de cada dato, método de cálculo y supuestos. Todos los resultados de 2024 son oficiales de la JCE; los escenarios y la meta son proyecciones propias.</a:t>
+            </a:r>
+            <a:endParaRPr lang="en-US" dirty="0"/>
+          </a:p>
+        </p:txBody>
+      </p:sp>
+      <p:sp>
+        <p:nvSpPr>
+          <p:cNvPr id="4" name="Slide Number Placeholder 3"/>
+          <p:cNvSpPr>
+            <a:spLocks noGrp="1"/>
+          </p:cNvSpPr>
+          <p:nvPr>
+            <p:ph type="sldNum" sz="quarter" idx="10"/>
+          </p:nvPr>
+        </p:nvSpPr>
+        <p:spPr/>
+        <p:txBody>
+          <a:bodyPr/>
+          <a:lstStyle/>
+          <a:p>
+            <a:fld id="{F7021451-1387-4CA6-816F-3879F97B5CBC}" type="slidenum">
+              <a:rPr lang="en-US"/>
+              <a:t>10</a:t>
             </a:fld>
             <a:endParaRPr lang="en-US"/>
           </a:p>
@@ -3353,7 +3447,7 @@
         <p:spPr>
           <a:xfrm>
             <a:off x="548640" y="0"/>
-            <a:ext cx="2772918" cy="384048"/>
+            <a:ext cx="2218334" cy="384048"/>
           </a:xfrm>
           <a:prstGeom prst="rect">
             <a:avLst/>
@@ -3388,8 +3482,8 @@
         </p:nvSpPr>
         <p:spPr>
           <a:xfrm>
-            <a:off x="1380515" y="338328"/>
-            <a:ext cx="1109167" cy="45720"/>
+            <a:off x="1214140" y="338328"/>
+            <a:ext cx="887334" cy="45720"/>
           </a:xfrm>
           <a:prstGeom prst="rect">
             <a:avLst/>
@@ -3413,8 +3507,8 @@
         </p:nvSpPr>
         <p:spPr>
           <a:xfrm>
-            <a:off x="3321558" y="0"/>
-            <a:ext cx="2772918" cy="384048"/>
+            <a:off x="2766974" y="0"/>
+            <a:ext cx="2218334" cy="384048"/>
           </a:xfrm>
           <a:prstGeom prst="rect">
             <a:avLst/>
@@ -3456,8 +3550,8 @@
         </p:nvSpPr>
         <p:spPr>
           <a:xfrm>
-            <a:off x="6094476" y="0"/>
-            <a:ext cx="2772918" cy="384048"/>
+            <a:off x="4985309" y="0"/>
+            <a:ext cx="2218334" cy="384048"/>
           </a:xfrm>
           <a:prstGeom prst="rect">
             <a:avLst/>
@@ -3499,8 +3593,8 @@
         </p:nvSpPr>
         <p:spPr>
           <a:xfrm>
-            <a:off x="8867394" y="0"/>
-            <a:ext cx="2772918" cy="384048"/>
+            <a:off x="7203643" y="0"/>
+            <a:ext cx="2218334" cy="384048"/>
           </a:xfrm>
           <a:prstGeom prst="rect">
             <a:avLst/>
@@ -3536,6 +3630,49 @@
       </p:sp>
       <p:sp>
         <p:nvSpPr>
+          <p:cNvPr id="24" name="Pestaña Ficha técnica"/>
+          <p:cNvSpPr txBox="1"/>
+          <p:nvPr/>
+        </p:nvSpPr>
+        <p:spPr>
+          <a:xfrm>
+            <a:off x="9421978" y="0"/>
+            <a:ext cx="2218334" cy="384048"/>
+          </a:xfrm>
+          <a:prstGeom prst="rect">
+            <a:avLst/>
+          </a:prstGeom>
+          <a:noFill/>
+          <a:ln/>
+        </p:spPr>
+        <p:txBody>
+          <a:bodyPr wrap="square" lIns="0" tIns="0" rIns="0" bIns="0" rtlCol="0" anchor="ctr"/>
+          <a:lstStyle/>
+          <a:p>
+            <a:pPr algn="ctr" indent="0" marL="0">
+              <a:buNone/>
+            </a:pPr>
+            <a:r>
+              <a:rPr lang="en-US" sz="1000" u="none" spc="150" kern="0" dirty="0">
+                <a:solidFill>
+                  <a:srgbClr val="AFC0DA"/>
+                </a:solidFill>
+                <a:hlinkClick r:id="rId5" action="ppaction://hlinksldjump" tooltip="Ir a Ficha técnica">
+                  <a:extLst>
+                    <a:ext uri="{A12FA001-AC4F-418D-AE19-62706E023703}">
+                      <ahyp:hlinkClr xmlns:ahyp="http://schemas.microsoft.com/office/drawing/2018/hyperlinkcolor" val="tx"/>
+                    </a:ext>
+                  </a:extLst>
+                </a:hlinkClick>
+              </a:rPr>
+              <a:t>FICHA TÉCNICA</a:t>
+            </a:r>
+            <a:endParaRPr lang="en-US" sz="1000" dirty="0"/>
+          </a:p>
+        </p:txBody>
+      </p:sp>
+      <p:sp>
+        <p:nvSpPr>
           <p:cNvPr id="25" name="Slide Number Placeholder 0"/>
           <p:cNvSpPr>
             <a:spLocks noGrp="1"/>
@@ -3574,6 +3711,913 @@
             <a:fld id="{F7021451-1387-4CA6-816F-3879F97B5CBC}" type="slidenum">
               <a:rPr b="0" lang="en-US"/>
               <a:t>1</a:t>
+            </a:fld>
+            <a:endParaRPr lang="en-US"/>
+          </a:p>
+        </p:txBody>
+      </p:sp>
+    </p:spTree>
+  </p:cSld>
+  <p:clrMapOvr>
+    <a:masterClrMapping/>
+  </p:clrMapOvr>
+</p:sld>
+</file>
+
+<file path=ppt/slides/slide10.xml><?xml version="1.0" encoding="utf-8"?>
+<p:sld xmlns:a="http://schemas.openxmlformats.org/drawingml/2006/main" xmlns:r="http://schemas.openxmlformats.org/officeDocument/2006/relationships" xmlns:p="http://schemas.openxmlformats.org/presentationml/2006/main">
+  <p:cSld name="Slide 10">
+    <p:spTree>
+      <p:nvGrpSpPr>
+        <p:cNvPr id="1" name=""/>
+        <p:cNvGrpSpPr/>
+        <p:nvPr/>
+      </p:nvGrpSpPr>
+      <p:grpSpPr>
+        <a:xfrm>
+          <a:off x="0" y="0"/>
+          <a:ext cx="0" cy="0"/>
+          <a:chOff x="0" y="0"/>
+          <a:chExt cx="0" cy="0"/>
+        </a:xfrm>
+      </p:grpSpPr>
+      <p:sp>
+        <p:nvSpPr>
+          <p:cNvPr id="2" name="Text 1"/>
+          <p:cNvSpPr/>
+          <p:nvPr>
+            <p:ph idx="101" type="title" hasCustomPrompt="1"/>
+          </p:nvPr>
+        </p:nvSpPr>
+        <p:spPr>
+          <a:xfrm>
+            <a:off x="548640" y="502920"/>
+            <a:ext cx="11091672" cy="1005840"/>
+          </a:xfrm>
+          <a:prstGeom prst="rect">
+            <a:avLst/>
+          </a:prstGeom>
+          <a:noFill/>
+          <a:ln/>
+        </p:spPr>
+        <p:txBody>
+          <a:bodyPr wrap="square" lIns="0" tIns="0" rIns="0" bIns="0" rtlCol="0" anchor="ctr"/>
+          <a:lstStyle/>
+          <a:p>
+            <a:pPr algn="l" indent="0" marL="0">
+              <a:buNone/>
+            </a:pPr>
+            <a:r>
+              <a:rPr lang="en-US" sz="2800" b="1" dirty="0">
+                <a:solidFill>
+                  <a:schemeClr val="tx2"/>
+                </a:solidFill>
+              </a:rPr>
+              <a:t>Ficha técnica: fuentes, método y supuestos del plan</a:t>
+            </a:r>
+            <a:endParaRPr lang="en-US" sz="2800" dirty="0"/>
+          </a:p>
+        </p:txBody>
+      </p:sp>
+      <p:sp>
+        <p:nvSpPr>
+          <p:cNvPr id="3" name="Ficha Fuentes de datos"/>
+          <p:cNvSpPr/>
+          <p:nvPr/>
+        </p:nvSpPr>
+        <p:spPr>
+          <a:xfrm>
+            <a:off x="548640" y="1600200"/>
+            <a:ext cx="3520440" cy="3703320"/>
+          </a:xfrm>
+          <a:prstGeom prst="roundRect">
+            <a:avLst>
+              <a:gd name="adj" fmla="val 2078"/>
+            </a:avLst>
+          </a:prstGeom>
+          <a:solidFill>
+            <a:schemeClr val="bg2"/>
+          </a:solidFill>
+          <a:ln w="12700">
+            <a:solidFill>
+              <a:schemeClr val="bg2"/>
+            </a:solidFill>
+            <a:prstDash val="solid"/>
+          </a:ln>
+        </p:spPr>
+      </p:sp>
+      <p:sp>
+        <p:nvSpPr>
+          <p:cNvPr id="4" name="Text 2"/>
+          <p:cNvSpPr txBox="1"/>
+          <p:nvPr/>
+        </p:nvSpPr>
+        <p:spPr>
+          <a:xfrm>
+            <a:off x="777240" y="1737360"/>
+            <a:ext cx="3063240" cy="411480"/>
+          </a:xfrm>
+          <a:prstGeom prst="rect">
+            <a:avLst/>
+          </a:prstGeom>
+          <a:noFill/>
+          <a:ln/>
+        </p:spPr>
+        <p:txBody>
+          <a:bodyPr wrap="square" lIns="0" tIns="0" rIns="0" bIns="0" rtlCol="0" anchor="ctr"/>
+          <a:lstStyle/>
+          <a:p>
+            <a:pPr indent="0" marL="0">
+              <a:buNone/>
+            </a:pPr>
+            <a:r>
+              <a:rPr lang="en-US" sz="1700" b="1" dirty="0">
+                <a:solidFill>
+                  <a:schemeClr val="tx2"/>
+                </a:solidFill>
+              </a:rPr>
+              <a:t>Fuentes de datos</a:t>
+            </a:r>
+            <a:endParaRPr lang="en-US" sz="1700" dirty="0"/>
+          </a:p>
+        </p:txBody>
+      </p:sp>
+      <p:sp>
+        <p:nvSpPr>
+          <p:cNvPr id="5" name="Text 3"/>
+          <p:cNvSpPr txBox="1"/>
+          <p:nvPr/>
+        </p:nvSpPr>
+        <p:spPr>
+          <a:xfrm>
+            <a:off x="777240" y="2240280"/>
+            <a:ext cx="3063240" cy="2971800"/>
+          </a:xfrm>
+          <a:prstGeom prst="rect">
+            <a:avLst/>
+          </a:prstGeom>
+          <a:noFill/>
+          <a:ln/>
+        </p:spPr>
+        <p:txBody>
+          <a:bodyPr wrap="square" lIns="0" tIns="0" rIns="0" bIns="0" rtlCol="0" anchor="t"/>
+          <a:lstStyle/>
+          <a:p>
+            <a:pPr marL="342900" indent="-342900">
+              <a:spcAft>
+                <a:spcPts val="800"/>
+              </a:spcAft>
+              <a:buSzPct val="100000"/>
+              <a:buChar char="•"/>
+            </a:pPr>
+            <a:r>
+              <a:rPr lang="en-US" sz="1300" dirty="0">
+                <a:solidFill>
+                  <a:schemeClr val="tx1"/>
+                </a:solidFill>
+              </a:rPr>
+              <a:t>JCE: «Resultado Presidencial por colegios», elecciones del 19 de mayo de 2024, OCLEE Philadelphia (colegios 1253–1336)</a:t>
+            </a:r>
+            <a:endParaRPr lang="en-US" sz="1300" dirty="0"/>
+          </a:p>
+          <a:p>
+            <a:pPr marL="342900" indent="-342900">
+              <a:spcAft>
+                <a:spcPts val="800"/>
+              </a:spcAft>
+              <a:buSzPct val="100000"/>
+              <a:buChar char="•"/>
+            </a:pPr>
+            <a:r>
+              <a:rPr lang="en-US" sz="1300" dirty="0">
+                <a:solidFill>
+                  <a:schemeClr val="tx1"/>
+                </a:solidFill>
+              </a:rPr>
+              <a:t>Seccional PRM Pennsylvania: padrón por recinto y lista de recintos y colegios (47,529 electores, 84 mesas)</a:t>
+            </a:r>
+            <a:endParaRPr lang="en-US" sz="1300" dirty="0"/>
+          </a:p>
+          <a:p>
+            <a:pPr marL="342900" indent="-342900">
+              <a:spcAft>
+                <a:spcPts val="800"/>
+              </a:spcAft>
+              <a:buSzPct val="100000"/>
+              <a:buChar char="•"/>
+            </a:pPr>
+            <a:r>
+              <a:rPr lang="en-US" sz="1300" dirty="0">
+                <a:solidFill>
+                  <a:schemeClr val="tx1"/>
+                </a:solidFill>
+              </a:rPr>
+              <a:t>INDEX: Registro Sociodemográfico de los Dominicanos en el Exterior, 5.ª edición (2026)</a:t>
+            </a:r>
+            <a:endParaRPr lang="en-US" sz="1300" dirty="0"/>
+          </a:p>
+          <a:p>
+            <a:pPr marL="342900" indent="-342900">
+              <a:spcAft>
+                <a:spcPts val="800"/>
+              </a:spcAft>
+              <a:buSzPct val="100000"/>
+              <a:buChar char="•"/>
+            </a:pPr>
+            <a:r>
+              <a:rPr lang="en-US" sz="1300" dirty="0">
+                <a:solidFill>
+                  <a:schemeClr val="tx1"/>
+                </a:solidFill>
+              </a:rPr>
+              <a:t>JCE: calendario de la nueva cédula en el exterior; encuestas internas del PRM (Markestrategia y RD Elige, 2026)</a:t>
+            </a:r>
+            <a:endParaRPr lang="en-US" sz="1300" dirty="0"/>
+          </a:p>
+        </p:txBody>
+      </p:sp>
+      <p:sp>
+        <p:nvSpPr>
+          <p:cNvPr id="6" name="Ficha Método"/>
+          <p:cNvSpPr/>
+          <p:nvPr/>
+        </p:nvSpPr>
+        <p:spPr>
+          <a:xfrm>
+            <a:off x="4334256" y="1600200"/>
+            <a:ext cx="3520440" cy="3703320"/>
+          </a:xfrm>
+          <a:prstGeom prst="roundRect">
+            <a:avLst>
+              <a:gd name="adj" fmla="val 2078"/>
+            </a:avLst>
+          </a:prstGeom>
+          <a:solidFill>
+            <a:schemeClr val="bg2"/>
+          </a:solidFill>
+          <a:ln w="12700">
+            <a:solidFill>
+              <a:schemeClr val="bg2"/>
+            </a:solidFill>
+            <a:prstDash val="solid"/>
+          </a:ln>
+        </p:spPr>
+      </p:sp>
+      <p:sp>
+        <p:nvSpPr>
+          <p:cNvPr id="7" name="Text 5"/>
+          <p:cNvSpPr txBox="1"/>
+          <p:nvPr/>
+        </p:nvSpPr>
+        <p:spPr>
+          <a:xfrm>
+            <a:off x="4562856" y="1737360"/>
+            <a:ext cx="3063240" cy="411480"/>
+          </a:xfrm>
+          <a:prstGeom prst="rect">
+            <a:avLst/>
+          </a:prstGeom>
+          <a:noFill/>
+          <a:ln/>
+        </p:spPr>
+        <p:txBody>
+          <a:bodyPr wrap="square" lIns="0" tIns="0" rIns="0" bIns="0" rtlCol="0" anchor="ctr"/>
+          <a:lstStyle/>
+          <a:p>
+            <a:pPr indent="0" marL="0">
+              <a:buNone/>
+            </a:pPr>
+            <a:r>
+              <a:rPr lang="en-US" sz="1700" b="1" dirty="0">
+                <a:solidFill>
+                  <a:schemeClr val="tx2"/>
+                </a:solidFill>
+              </a:rPr>
+              <a:t>Método</a:t>
+            </a:r>
+            <a:endParaRPr lang="en-US" sz="1700" dirty="0"/>
+          </a:p>
+        </p:txBody>
+      </p:sp>
+      <p:sp>
+        <p:nvSpPr>
+          <p:cNvPr id="8" name="Text 6"/>
+          <p:cNvSpPr txBox="1"/>
+          <p:nvPr/>
+        </p:nvSpPr>
+        <p:spPr>
+          <a:xfrm>
+            <a:off x="4562856" y="2240280"/>
+            <a:ext cx="3063240" cy="2971800"/>
+          </a:xfrm>
+          <a:prstGeom prst="rect">
+            <a:avLst/>
+          </a:prstGeom>
+          <a:noFill/>
+          <a:ln/>
+        </p:spPr>
+        <p:txBody>
+          <a:bodyPr wrap="square" lIns="0" tIns="0" rIns="0" bIns="0" rtlCol="0" anchor="t"/>
+          <a:lstStyle/>
+          <a:p>
+            <a:pPr marL="342900" indent="-342900">
+              <a:spcAft>
+                <a:spcPts val="800"/>
+              </a:spcAft>
+              <a:buSzPct val="100000"/>
+              <a:buChar char="•"/>
+            </a:pPr>
+            <a:r>
+              <a:rPr lang="en-US" sz="1300" dirty="0">
+                <a:solidFill>
+                  <a:schemeClr val="tx1"/>
+                </a:solidFill>
+              </a:rPr>
+              <a:t>Resultados por ciudad y zona: suma de los colegios de cada recinto</a:t>
+            </a:r>
+            <a:endParaRPr lang="en-US" sz="1300" dirty="0"/>
+          </a:p>
+          <a:p>
+            <a:pPr marL="342900" indent="-342900">
+              <a:spcAft>
+                <a:spcPts val="800"/>
+              </a:spcAft>
+              <a:buSzPct val="100000"/>
+              <a:buChar char="•"/>
+            </a:pPr>
+            <a:r>
+              <a:rPr lang="en-US" sz="1300" dirty="0">
+                <a:solidFill>
+                  <a:schemeClr val="tx1"/>
+                </a:solidFill>
+              </a:rPr>
+              <a:t>Participación: votos emitidos entre electores. Apoyo: porcentaje de los votos válidos</a:t>
+            </a:r>
+            <a:endParaRPr lang="en-US" sz="1300" dirty="0"/>
+          </a:p>
+          <a:p>
+            <a:pPr marL="342900" indent="-342900">
+              <a:spcAft>
+                <a:spcPts val="800"/>
+              </a:spcAft>
+              <a:buSzPct val="100000"/>
+              <a:buChar char="•"/>
+            </a:pPr>
+            <a:r>
+              <a:rPr lang="en-US" sz="1300" dirty="0">
+                <a:solidFill>
+                  <a:schemeClr val="tx1"/>
+                </a:solidFill>
+              </a:rPr>
+              <a:t>Meta 2028: votos del PRM y aliados en 2024 (5,581) más un 10 % = 6,140</a:t>
+            </a:r>
+            <a:endParaRPr lang="en-US" sz="1300" dirty="0"/>
+          </a:p>
+          <a:p>
+            <a:pPr marL="342900" indent="-342900">
+              <a:spcAft>
+                <a:spcPts val="800"/>
+              </a:spcAft>
+              <a:buSzPct val="100000"/>
+              <a:buChar char="•"/>
+            </a:pPr>
+            <a:r>
+              <a:rPr lang="en-US" sz="1300" dirty="0">
+                <a:solidFill>
+                  <a:schemeClr val="tx1"/>
+                </a:solidFill>
+              </a:rPr>
+              <a:t>Zonas: agrupación geográfica propuesta de las 13 ciudades; líderes repartidos según los electores</a:t>
+            </a:r>
+            <a:endParaRPr lang="en-US" sz="1300" dirty="0"/>
+          </a:p>
+        </p:txBody>
+      </p:sp>
+      <p:sp>
+        <p:nvSpPr>
+          <p:cNvPr id="9" name="Ficha Supuestos y notas"/>
+          <p:cNvSpPr/>
+          <p:nvPr/>
+        </p:nvSpPr>
+        <p:spPr>
+          <a:xfrm>
+            <a:off x="8119872" y="1600200"/>
+            <a:ext cx="3520440" cy="3703320"/>
+          </a:xfrm>
+          <a:prstGeom prst="roundRect">
+            <a:avLst>
+              <a:gd name="adj" fmla="val 2078"/>
+            </a:avLst>
+          </a:prstGeom>
+          <a:solidFill>
+            <a:schemeClr val="bg2"/>
+          </a:solidFill>
+          <a:ln w="12700">
+            <a:solidFill>
+              <a:schemeClr val="bg2"/>
+            </a:solidFill>
+            <a:prstDash val="solid"/>
+          </a:ln>
+        </p:spPr>
+      </p:sp>
+      <p:sp>
+        <p:nvSpPr>
+          <p:cNvPr id="10" name="Text 8"/>
+          <p:cNvSpPr txBox="1"/>
+          <p:nvPr/>
+        </p:nvSpPr>
+        <p:spPr>
+          <a:xfrm>
+            <a:off x="8348472" y="1737360"/>
+            <a:ext cx="3063240" cy="411480"/>
+          </a:xfrm>
+          <a:prstGeom prst="rect">
+            <a:avLst/>
+          </a:prstGeom>
+          <a:noFill/>
+          <a:ln/>
+        </p:spPr>
+        <p:txBody>
+          <a:bodyPr wrap="square" lIns="0" tIns="0" rIns="0" bIns="0" rtlCol="0" anchor="ctr"/>
+          <a:lstStyle/>
+          <a:p>
+            <a:pPr indent="0" marL="0">
+              <a:buNone/>
+            </a:pPr>
+            <a:r>
+              <a:rPr lang="en-US" sz="1700" b="1" dirty="0">
+                <a:solidFill>
+                  <a:schemeClr val="tx2"/>
+                </a:solidFill>
+              </a:rPr>
+              <a:t>Supuestos y notas</a:t>
+            </a:r>
+            <a:endParaRPr lang="en-US" sz="1700" dirty="0"/>
+          </a:p>
+        </p:txBody>
+      </p:sp>
+      <p:sp>
+        <p:nvSpPr>
+          <p:cNvPr id="11" name="Text 9"/>
+          <p:cNvSpPr txBox="1"/>
+          <p:nvPr/>
+        </p:nvSpPr>
+        <p:spPr>
+          <a:xfrm>
+            <a:off x="8348472" y="2240280"/>
+            <a:ext cx="3063240" cy="2971800"/>
+          </a:xfrm>
+          <a:prstGeom prst="rect">
+            <a:avLst/>
+          </a:prstGeom>
+          <a:noFill/>
+          <a:ln/>
+        </p:spPr>
+        <p:txBody>
+          <a:bodyPr wrap="square" lIns="0" tIns="0" rIns="0" bIns="0" rtlCol="0" anchor="t"/>
+          <a:lstStyle/>
+          <a:p>
+            <a:pPr marL="342900" indent="-342900">
+              <a:spcAft>
+                <a:spcPts val="800"/>
+              </a:spcAft>
+              <a:buSzPct val="100000"/>
+              <a:buChar char="•"/>
+            </a:pPr>
+            <a:r>
+              <a:rPr lang="en-US" sz="1300" dirty="0">
+                <a:solidFill>
+                  <a:schemeClr val="tx1"/>
+                </a:solidFill>
+              </a:rPr>
+              <a:t>Escenarios: proyección propia con supuestos de renovación de cédula, participación y apoyo (63 % como en 2024)</a:t>
+            </a:r>
+            <a:endParaRPr lang="en-US" sz="1300" dirty="0"/>
+          </a:p>
+          <a:p>
+            <a:pPr marL="342900" indent="-342900">
+              <a:spcAft>
+                <a:spcPts val="800"/>
+              </a:spcAft>
+              <a:buSzPct val="100000"/>
+              <a:buChar char="•"/>
+            </a:pPr>
+            <a:r>
+              <a:rPr lang="en-US" sz="1300" dirty="0">
+                <a:solidFill>
+                  <a:schemeClr val="tx1"/>
+                </a:solidFill>
+              </a:rPr>
+              <a:t>Red: 400 líderes con 10 personas cada uno; se estima que vota el 85 %</a:t>
+            </a:r>
+            <a:endParaRPr lang="en-US" sz="1300" dirty="0"/>
+          </a:p>
+          <a:p>
+            <a:pPr marL="342900" indent="-342900">
+              <a:spcAft>
+                <a:spcPts val="800"/>
+              </a:spcAft>
+              <a:buSzPct val="100000"/>
+              <a:buChar char="•"/>
+            </a:pPr>
+            <a:r>
+              <a:rPr lang="en-US" sz="1300" dirty="0">
+                <a:solidFill>
+                  <a:schemeClr val="tx1"/>
+                </a:solidFill>
+              </a:rPr>
+              <a:t>Padrón: 47,529 de la seccional (la JCE divulgó 47,604 en el corte preliminar)</a:t>
+            </a:r>
+            <a:endParaRPr lang="en-US" sz="1300" dirty="0"/>
+          </a:p>
+          <a:p>
+            <a:pPr marL="342900" indent="-342900">
+              <a:spcAft>
+                <a:spcPts val="800"/>
+              </a:spcAft>
+              <a:buSzPct val="100000"/>
+              <a:buChar char="•"/>
+            </a:pPr>
+            <a:r>
+              <a:rPr lang="en-US" sz="1300" dirty="0">
+                <a:solidFill>
+                  <a:schemeClr val="tx1"/>
+                </a:solidFill>
+              </a:rPr>
+              <a:t>El colegio 1259 se asignó a la Asociación de Pennsylvania (Reading) por numeración; pendiente de confirmar</a:t>
+            </a:r>
+            <a:endParaRPr lang="en-US" sz="1300" dirty="0"/>
+          </a:p>
+        </p:txBody>
+      </p:sp>
+      <p:sp>
+        <p:nvSpPr>
+          <p:cNvPr id="12" name="Text 10"/>
+          <p:cNvSpPr txBox="1"/>
+          <p:nvPr/>
+        </p:nvSpPr>
+        <p:spPr>
+          <a:xfrm>
+            <a:off x="548640" y="5486400"/>
+            <a:ext cx="11091672" cy="365760"/>
+          </a:xfrm>
+          <a:prstGeom prst="rect">
+            <a:avLst/>
+          </a:prstGeom>
+          <a:noFill/>
+          <a:ln/>
+        </p:spPr>
+        <p:txBody>
+          <a:bodyPr wrap="square" lIns="0" tIns="0" rIns="0" bIns="0" rtlCol="0" anchor="ctr"/>
+          <a:lstStyle/>
+          <a:p>
+            <a:pPr indent="0" marL="0">
+              <a:buNone/>
+            </a:pPr>
+            <a:r>
+              <a:rPr lang="en-US" sz="1300" b="1" dirty="0">
+                <a:solidFill>
+                  <a:schemeClr val="tx2"/>
+                </a:solidFill>
+              </a:rPr>
+              <a:t>Preparado por: </a:t>
+            </a:r>
+            <a:pPr indent="0" marL="0">
+              <a:buNone/>
+            </a:pPr>
+            <a:r>
+              <a:rPr lang="en-US" sz="1300" dirty="0">
+                <a:solidFill>
+                  <a:schemeClr val="tx1"/>
+                </a:solidFill>
+              </a:rPr>
+              <a:t>Orlando Castillo · Octubre de 2026 · Documento de trabajo para el CAD, Seccional Pennsylvania</a:t>
+            </a:r>
+            <a:endParaRPr lang="en-US" sz="1300" dirty="0"/>
+          </a:p>
+        </p:txBody>
+      </p:sp>
+      <p:sp>
+        <p:nvSpPr>
+          <p:cNvPr id="14" name="Barra de navegación"/>
+          <p:cNvSpPr/>
+          <p:nvPr/>
+        </p:nvSpPr>
+        <p:spPr>
+          <a:xfrm>
+            <a:off x="0" y="0"/>
+            <a:ext cx="12191695" cy="384048"/>
+          </a:xfrm>
+          <a:prstGeom prst="rect">
+            <a:avLst/>
+          </a:prstGeom>
+          <a:solidFill>
+            <a:srgbClr val="F4F7FB"/>
+          </a:solidFill>
+          <a:ln w="12700">
+            <a:solidFill>
+              <a:srgbClr val="F4F7FB"/>
+            </a:solidFill>
+            <a:prstDash val="solid"/>
+          </a:ln>
+        </p:spPr>
+      </p:sp>
+      <p:sp>
+        <p:nvSpPr>
+          <p:cNvPr id="15" name="Shape 12"/>
+          <p:cNvSpPr/>
+          <p:nvPr/>
+        </p:nvSpPr>
+        <p:spPr>
+          <a:xfrm>
+            <a:off x="0" y="384048"/>
+            <a:ext cx="12191695" cy="0"/>
+          </a:xfrm>
+          <a:prstGeom prst="line">
+            <a:avLst/>
+          </a:prstGeom>
+          <a:noFill/>
+          <a:ln w="9525">
+            <a:solidFill>
+              <a:srgbClr val="D6DEEA"/>
+            </a:solidFill>
+            <a:prstDash val="solid"/>
+          </a:ln>
+        </p:spPr>
+      </p:sp>
+      <p:sp>
+        <p:nvSpPr>
+          <p:cNvPr id="16" name="Pestaña Diagnóstico"/>
+          <p:cNvSpPr txBox="1"/>
+          <p:nvPr/>
+        </p:nvSpPr>
+        <p:spPr>
+          <a:xfrm>
+            <a:off x="548640" y="0"/>
+            <a:ext cx="2218334" cy="384048"/>
+          </a:xfrm>
+          <a:prstGeom prst="rect">
+            <a:avLst/>
+          </a:prstGeom>
+          <a:noFill/>
+          <a:ln/>
+        </p:spPr>
+        <p:txBody>
+          <a:bodyPr wrap="square" lIns="0" tIns="0" rIns="0" bIns="0" rtlCol="0" anchor="ctr"/>
+          <a:lstStyle/>
+          <a:p>
+            <a:pPr algn="ctr" indent="0" marL="0">
+              <a:buNone/>
+            </a:pPr>
+            <a:r>
+              <a:rPr lang="en-US" sz="1000" u="none" spc="150" kern="0" dirty="0">
+                <a:solidFill>
+                  <a:srgbClr val="5A6B86"/>
+                </a:solidFill>
+                <a:hlinkClick r:id="rId1" action="ppaction://hlinksldjump" tooltip="Ir a Diagnóstico">
+                  <a:extLst>
+                    <a:ext uri="{A12FA001-AC4F-418D-AE19-62706E023703}">
+                      <ahyp:hlinkClr xmlns:ahyp="http://schemas.microsoft.com/office/drawing/2018/hyperlinkcolor" val="tx"/>
+                    </a:ext>
+                  </a:extLst>
+                </a:hlinkClick>
+              </a:rPr>
+              <a:t>DIAGNÓSTICO</a:t>
+            </a:r>
+            <a:endParaRPr lang="en-US" sz="1000" dirty="0"/>
+          </a:p>
+        </p:txBody>
+      </p:sp>
+      <p:sp>
+        <p:nvSpPr>
+          <p:cNvPr id="17" name="Pestaña Resultados 2024"/>
+          <p:cNvSpPr txBox="1"/>
+          <p:nvPr/>
+        </p:nvSpPr>
+        <p:spPr>
+          <a:xfrm>
+            <a:off x="2766974" y="0"/>
+            <a:ext cx="2218334" cy="384048"/>
+          </a:xfrm>
+          <a:prstGeom prst="rect">
+            <a:avLst/>
+          </a:prstGeom>
+          <a:noFill/>
+          <a:ln/>
+        </p:spPr>
+        <p:txBody>
+          <a:bodyPr wrap="square" lIns="0" tIns="0" rIns="0" bIns="0" rtlCol="0" anchor="ctr"/>
+          <a:lstStyle/>
+          <a:p>
+            <a:pPr algn="ctr" indent="0" marL="0">
+              <a:buNone/>
+            </a:pPr>
+            <a:r>
+              <a:rPr lang="en-US" sz="1000" u="none" spc="150" kern="0" dirty="0">
+                <a:solidFill>
+                  <a:srgbClr val="5A6B86"/>
+                </a:solidFill>
+                <a:hlinkClick r:id="rId2" action="ppaction://hlinksldjump" tooltip="Ir a Resultados 2024">
+                  <a:extLst>
+                    <a:ext uri="{A12FA001-AC4F-418D-AE19-62706E023703}">
+                      <ahyp:hlinkClr xmlns:ahyp="http://schemas.microsoft.com/office/drawing/2018/hyperlinkcolor" val="tx"/>
+                    </a:ext>
+                  </a:extLst>
+                </a:hlinkClick>
+              </a:rPr>
+              <a:t>RESULTADOS 2024</a:t>
+            </a:r>
+            <a:endParaRPr lang="en-US" sz="1000" dirty="0"/>
+          </a:p>
+        </p:txBody>
+      </p:sp>
+      <p:sp>
+        <p:nvSpPr>
+          <p:cNvPr id="18" name="Pestaña Meta"/>
+          <p:cNvSpPr txBox="1"/>
+          <p:nvPr/>
+        </p:nvSpPr>
+        <p:spPr>
+          <a:xfrm>
+            <a:off x="4985309" y="0"/>
+            <a:ext cx="2218334" cy="384048"/>
+          </a:xfrm>
+          <a:prstGeom prst="rect">
+            <a:avLst/>
+          </a:prstGeom>
+          <a:noFill/>
+          <a:ln/>
+        </p:spPr>
+        <p:txBody>
+          <a:bodyPr wrap="square" lIns="0" tIns="0" rIns="0" bIns="0" rtlCol="0" anchor="ctr"/>
+          <a:lstStyle/>
+          <a:p>
+            <a:pPr algn="ctr" indent="0" marL="0">
+              <a:buNone/>
+            </a:pPr>
+            <a:r>
+              <a:rPr lang="en-US" sz="1000" u="none" spc="150" kern="0" dirty="0">
+                <a:solidFill>
+                  <a:srgbClr val="5A6B86"/>
+                </a:solidFill>
+                <a:hlinkClick r:id="rId3" action="ppaction://hlinksldjump" tooltip="Ir a Meta">
+                  <a:extLst>
+                    <a:ext uri="{A12FA001-AC4F-418D-AE19-62706E023703}">
+                      <ahyp:hlinkClr xmlns:ahyp="http://schemas.microsoft.com/office/drawing/2018/hyperlinkcolor" val="tx"/>
+                    </a:ext>
+                  </a:extLst>
+                </a:hlinkClick>
+              </a:rPr>
+              <a:t>META</a:t>
+            </a:r>
+            <a:endParaRPr lang="en-US" sz="1000" dirty="0"/>
+          </a:p>
+        </p:txBody>
+      </p:sp>
+      <p:sp>
+        <p:nvSpPr>
+          <p:cNvPr id="19" name="Pestaña Plan y recomendación"/>
+          <p:cNvSpPr txBox="1"/>
+          <p:nvPr/>
+        </p:nvSpPr>
+        <p:spPr>
+          <a:xfrm>
+            <a:off x="7203643" y="0"/>
+            <a:ext cx="2218334" cy="384048"/>
+          </a:xfrm>
+          <a:prstGeom prst="rect">
+            <a:avLst/>
+          </a:prstGeom>
+          <a:noFill/>
+          <a:ln/>
+        </p:spPr>
+        <p:txBody>
+          <a:bodyPr wrap="square" lIns="0" tIns="0" rIns="0" bIns="0" rtlCol="0" anchor="ctr"/>
+          <a:lstStyle/>
+          <a:p>
+            <a:pPr algn="ctr" indent="0" marL="0">
+              <a:buNone/>
+            </a:pPr>
+            <a:r>
+              <a:rPr lang="en-US" sz="1000" u="none" spc="150" kern="0" dirty="0">
+                <a:solidFill>
+                  <a:srgbClr val="5A6B86"/>
+                </a:solidFill>
+                <a:hlinkClick r:id="rId4" action="ppaction://hlinksldjump" tooltip="Ir a Plan y recomendación">
+                  <a:extLst>
+                    <a:ext uri="{A12FA001-AC4F-418D-AE19-62706E023703}">
+                      <ahyp:hlinkClr xmlns:ahyp="http://schemas.microsoft.com/office/drawing/2018/hyperlinkcolor" val="tx"/>
+                    </a:ext>
+                  </a:extLst>
+                </a:hlinkClick>
+              </a:rPr>
+              <a:t>PLAN Y RECOMENDACIÓN</a:t>
+            </a:r>
+            <a:endParaRPr lang="en-US" sz="1000" dirty="0"/>
+          </a:p>
+        </p:txBody>
+      </p:sp>
+      <p:sp>
+        <p:nvSpPr>
+          <p:cNvPr id="20" name="Pestaña Ficha técnica"/>
+          <p:cNvSpPr txBox="1"/>
+          <p:nvPr/>
+        </p:nvSpPr>
+        <p:spPr>
+          <a:xfrm>
+            <a:off x="9421978" y="0"/>
+            <a:ext cx="2218334" cy="384048"/>
+          </a:xfrm>
+          <a:prstGeom prst="rect">
+            <a:avLst/>
+          </a:prstGeom>
+          <a:noFill/>
+          <a:ln/>
+        </p:spPr>
+        <p:txBody>
+          <a:bodyPr wrap="square" lIns="0" tIns="0" rIns="0" bIns="0" rtlCol="0" anchor="ctr"/>
+          <a:lstStyle/>
+          <a:p>
+            <a:pPr algn="ctr" indent="0" marL="0">
+              <a:buNone/>
+            </a:pPr>
+            <a:r>
+              <a:rPr lang="en-US" sz="1000" b="1" spc="150" kern="0" dirty="0">
+                <a:solidFill>
+                  <a:srgbClr val="002B63"/>
+                </a:solidFill>
+              </a:rPr>
+              <a:t>FICHA TÉCNICA</a:t>
+            </a:r>
+            <a:endParaRPr lang="en-US" sz="1000" dirty="0"/>
+          </a:p>
+        </p:txBody>
+      </p:sp>
+      <p:sp>
+        <p:nvSpPr>
+          <p:cNvPr id="21" name="Sección actual"/>
+          <p:cNvSpPr/>
+          <p:nvPr/>
+        </p:nvSpPr>
+        <p:spPr>
+          <a:xfrm>
+            <a:off x="10087478" y="338328"/>
+            <a:ext cx="887334" cy="45720"/>
+          </a:xfrm>
+          <a:prstGeom prst="rect">
+            <a:avLst/>
+          </a:prstGeom>
+          <a:solidFill>
+            <a:srgbClr val="DA1822"/>
+          </a:solidFill>
+          <a:ln w="12700">
+            <a:solidFill>
+              <a:srgbClr val="DA1822"/>
+            </a:solidFill>
+            <a:prstDash val="solid"/>
+          </a:ln>
+        </p:spPr>
+      </p:sp>
+      <p:sp>
+        <p:nvSpPr>
+          <p:cNvPr id="25" name="Slide Number Placeholder 0"/>
+          <p:cNvSpPr>
+            <a:spLocks noGrp="1"/>
+          </p:cNvSpPr>
+          <p:nvPr>
+            <p:ph type="sldNum" sz="quarter" idx="4294967295"/>
+          </p:nvPr>
+        </p:nvSpPr>
+        <p:spPr>
+          <a:xfrm>
+            <a:off x="11155680" y="6400800"/>
+            <a:ext cx="548640" cy="274320"/>
+          </a:xfrm>
+          <a:prstGeom prst="rect">
+            <a:avLst/>
+          </a:prstGeom>
+          <a:extLst>
+            <a:ext uri="{C572A759-6A51-4108-AA02-DFA0A04FC94B}">
+              <ma14:wrappingTextBoxFlag xmlns:ma14="http://schemas.microsoft.com/office/mac/drawingml/2011/main" val="0"/>
+            </a:ext>
+          </a:extLst>
+        </p:spPr>
+        <p:txBody>
+          <a:bodyPr/>
+          <a:lstStyle>
+            <a:lvl1pPr>
+              <a:defRPr sz="1000">
+                <a:solidFill>
+                  <a:schemeClr val="accent4"/>
+                </a:solidFill>
+              </a:defRPr>
+            </a:lvl1pPr>
+          </a:lstStyle>
+          <a:p>
+            <a:pPr algn="r"/>
+            <a:fld id="{F7021451-1387-4CA6-816F-3879F97B5CBC}" type="slidenum">
+              <a:rPr b="0" lang="en-US"/>
+              <a:t>10</a:t>
             </a:fld>
             <a:endParaRPr lang="en-US"/>
           </a:p>
@@ -4362,7 +5406,7 @@
         <p:spPr>
           <a:xfrm>
             <a:off x="548640" y="0"/>
-            <a:ext cx="2772918" cy="384048"/>
+            <a:ext cx="2218334" cy="384048"/>
           </a:xfrm>
           <a:prstGeom prst="rect">
             <a:avLst/>
@@ -4397,8 +5441,8 @@
         </p:nvSpPr>
         <p:spPr>
           <a:xfrm>
-            <a:off x="1380515" y="338328"/>
-            <a:ext cx="1109167" cy="45720"/>
+            <a:off x="1214140" y="338328"/>
+            <a:ext cx="887334" cy="45720"/>
           </a:xfrm>
           <a:prstGeom prst="rect">
             <a:avLst/>
@@ -4422,8 +5466,8 @@
         </p:nvSpPr>
         <p:spPr>
           <a:xfrm>
-            <a:off x="3321558" y="0"/>
-            <a:ext cx="2772918" cy="384048"/>
+            <a:off x="2766974" y="0"/>
+            <a:ext cx="2218334" cy="384048"/>
           </a:xfrm>
           <a:prstGeom prst="rect">
             <a:avLst/>
@@ -4465,8 +5509,8 @@
         </p:nvSpPr>
         <p:spPr>
           <a:xfrm>
-            <a:off x="6094476" y="0"/>
-            <a:ext cx="2772918" cy="384048"/>
+            <a:off x="4985309" y="0"/>
+            <a:ext cx="2218334" cy="384048"/>
           </a:xfrm>
           <a:prstGeom prst="rect">
             <a:avLst/>
@@ -4508,8 +5552,8 @@
         </p:nvSpPr>
         <p:spPr>
           <a:xfrm>
-            <a:off x="8867394" y="0"/>
-            <a:ext cx="2772918" cy="384048"/>
+            <a:off x="7203643" y="0"/>
+            <a:ext cx="2218334" cy="384048"/>
           </a:xfrm>
           <a:prstGeom prst="rect">
             <a:avLst/>
@@ -4538,6 +5582,49 @@
                 </a:hlinkClick>
               </a:rPr>
               <a:t>PLAN Y RECOMENDACIÓN</a:t>
+            </a:r>
+            <a:endParaRPr lang="en-US" sz="1000" dirty="0"/>
+          </a:p>
+        </p:txBody>
+      </p:sp>
+      <p:sp>
+        <p:nvSpPr>
+          <p:cNvPr id="30" name="Pestaña Ficha técnica"/>
+          <p:cNvSpPr txBox="1"/>
+          <p:nvPr/>
+        </p:nvSpPr>
+        <p:spPr>
+          <a:xfrm>
+            <a:off x="9421978" y="0"/>
+            <a:ext cx="2218334" cy="384048"/>
+          </a:xfrm>
+          <a:prstGeom prst="rect">
+            <a:avLst/>
+          </a:prstGeom>
+          <a:noFill/>
+          <a:ln/>
+        </p:spPr>
+        <p:txBody>
+          <a:bodyPr wrap="square" lIns="0" tIns="0" rIns="0" bIns="0" rtlCol="0" anchor="ctr"/>
+          <a:lstStyle/>
+          <a:p>
+            <a:pPr algn="ctr" indent="0" marL="0">
+              <a:buNone/>
+            </a:pPr>
+            <a:r>
+              <a:rPr lang="en-US" sz="1000" u="none" spc="150" kern="0" dirty="0">
+                <a:solidFill>
+                  <a:srgbClr val="5A6B86"/>
+                </a:solidFill>
+                <a:hlinkClick r:id="rId4" action="ppaction://hlinksldjump" tooltip="Ir a Ficha técnica">
+                  <a:extLst>
+                    <a:ext uri="{A12FA001-AC4F-418D-AE19-62706E023703}">
+                      <ahyp:hlinkClr xmlns:ahyp="http://schemas.microsoft.com/office/drawing/2018/hyperlinkcolor" val="tx"/>
+                    </a:ext>
+                  </a:extLst>
+                </a:hlinkClick>
+              </a:rPr>
+              <a:t>FICHA TÉCNICA</a:t>
             </a:r>
             <a:endParaRPr lang="en-US" sz="1000" dirty="0"/>
           </a:p>
@@ -7504,7 +8591,7 @@
         <p:spPr>
           <a:xfrm>
             <a:off x="548640" y="0"/>
-            <a:ext cx="2772918" cy="384048"/>
+            <a:ext cx="2218334" cy="384048"/>
           </a:xfrm>
           <a:prstGeom prst="rect">
             <a:avLst/>
@@ -7539,8 +8626,8 @@
         </p:nvSpPr>
         <p:spPr>
           <a:xfrm>
-            <a:off x="1380515" y="338328"/>
-            <a:ext cx="1109167" cy="45720"/>
+            <a:off x="1214140" y="338328"/>
+            <a:ext cx="887334" cy="45720"/>
           </a:xfrm>
           <a:prstGeom prst="rect">
             <a:avLst/>
@@ -7564,8 +8651,8 @@
         </p:nvSpPr>
         <p:spPr>
           <a:xfrm>
-            <a:off x="3321558" y="0"/>
-            <a:ext cx="2772918" cy="384048"/>
+            <a:off x="2766974" y="0"/>
+            <a:ext cx="2218334" cy="384048"/>
           </a:xfrm>
           <a:prstGeom prst="rect">
             <a:avLst/>
@@ -7607,8 +8694,8 @@
         </p:nvSpPr>
         <p:spPr>
           <a:xfrm>
-            <a:off x="6094476" y="0"/>
-            <a:ext cx="2772918" cy="384048"/>
+            <a:off x="4985309" y="0"/>
+            <a:ext cx="2218334" cy="384048"/>
           </a:xfrm>
           <a:prstGeom prst="rect">
             <a:avLst/>
@@ -7650,8 +8737,8 @@
         </p:nvSpPr>
         <p:spPr>
           <a:xfrm>
-            <a:off x="8867394" y="0"/>
-            <a:ext cx="2772918" cy="384048"/>
+            <a:off x="7203643" y="0"/>
+            <a:ext cx="2218334" cy="384048"/>
           </a:xfrm>
           <a:prstGeom prst="rect">
             <a:avLst/>
@@ -7680,6 +8767,49 @@
                 </a:hlinkClick>
               </a:rPr>
               <a:t>PLAN Y RECOMENDACIÓN</a:t>
+            </a:r>
+            <a:endParaRPr lang="en-US" sz="1000" dirty="0"/>
+          </a:p>
+        </p:txBody>
+      </p:sp>
+      <p:sp>
+        <p:nvSpPr>
+          <p:cNvPr id="95" name="Pestaña Ficha técnica"/>
+          <p:cNvSpPr txBox="1"/>
+          <p:nvPr/>
+        </p:nvSpPr>
+        <p:spPr>
+          <a:xfrm>
+            <a:off x="9421978" y="0"/>
+            <a:ext cx="2218334" cy="384048"/>
+          </a:xfrm>
+          <a:prstGeom prst="rect">
+            <a:avLst/>
+          </a:prstGeom>
+          <a:noFill/>
+          <a:ln/>
+        </p:spPr>
+        <p:txBody>
+          <a:bodyPr wrap="square" lIns="0" tIns="0" rIns="0" bIns="0" rtlCol="0" anchor="ctr"/>
+          <a:lstStyle/>
+          <a:p>
+            <a:pPr algn="ctr" indent="0" marL="0">
+              <a:buNone/>
+            </a:pPr>
+            <a:r>
+              <a:rPr lang="en-US" sz="1000" u="none" spc="150" kern="0" dirty="0">
+                <a:solidFill>
+                  <a:srgbClr val="5A6B86"/>
+                </a:solidFill>
+                <a:hlinkClick r:id="rId5" action="ppaction://hlinksldjump" tooltip="Ir a Ficha técnica">
+                  <a:extLst>
+                    <a:ext uri="{A12FA001-AC4F-418D-AE19-62706E023703}">
+                      <ahyp:hlinkClr xmlns:ahyp="http://schemas.microsoft.com/office/drawing/2018/hyperlinkcolor" val="tx"/>
+                    </a:ext>
+                  </a:extLst>
+                </a:hlinkClick>
+              </a:rPr>
+              <a:t>FICHA TÉCNICA</a:t>
             </a:r>
             <a:endParaRPr lang="en-US" sz="1000" dirty="0"/>
           </a:p>
@@ -8133,7 +9263,7 @@
         <p:spPr>
           <a:xfrm>
             <a:off x="548640" y="0"/>
-            <a:ext cx="2772918" cy="384048"/>
+            <a:ext cx="2218334" cy="384048"/>
           </a:xfrm>
           <a:prstGeom prst="rect">
             <a:avLst/>
@@ -8168,8 +9298,8 @@
         </p:nvSpPr>
         <p:spPr>
           <a:xfrm>
-            <a:off x="1380515" y="338328"/>
-            <a:ext cx="1109167" cy="45720"/>
+            <a:off x="1214140" y="338328"/>
+            <a:ext cx="887334" cy="45720"/>
           </a:xfrm>
           <a:prstGeom prst="rect">
             <a:avLst/>
@@ -8193,8 +9323,8 @@
         </p:nvSpPr>
         <p:spPr>
           <a:xfrm>
-            <a:off x="3321558" y="0"/>
-            <a:ext cx="2772918" cy="384048"/>
+            <a:off x="2766974" y="0"/>
+            <a:ext cx="2218334" cy="384048"/>
           </a:xfrm>
           <a:prstGeom prst="rect">
             <a:avLst/>
@@ -8236,8 +9366,8 @@
         </p:nvSpPr>
         <p:spPr>
           <a:xfrm>
-            <a:off x="6094476" y="0"/>
-            <a:ext cx="2772918" cy="384048"/>
+            <a:off x="4985309" y="0"/>
+            <a:ext cx="2218334" cy="384048"/>
           </a:xfrm>
           <a:prstGeom prst="rect">
             <a:avLst/>
@@ -8279,8 +9409,8 @@
         </p:nvSpPr>
         <p:spPr>
           <a:xfrm>
-            <a:off x="8867394" y="0"/>
-            <a:ext cx="2772918" cy="384048"/>
+            <a:off x="7203643" y="0"/>
+            <a:ext cx="2218334" cy="384048"/>
           </a:xfrm>
           <a:prstGeom prst="rect">
             <a:avLst/>
@@ -8309,6 +9439,49 @@
                 </a:hlinkClick>
               </a:rPr>
               <a:t>PLAN Y RECOMENDACIÓN</a:t>
+            </a:r>
+            <a:endParaRPr lang="en-US" sz="1000" dirty="0"/>
+          </a:p>
+        </p:txBody>
+      </p:sp>
+      <p:sp>
+        <p:nvSpPr>
+          <p:cNvPr id="19" name="Pestaña Ficha técnica"/>
+          <p:cNvSpPr txBox="1"/>
+          <p:nvPr/>
+        </p:nvSpPr>
+        <p:spPr>
+          <a:xfrm>
+            <a:off x="9421978" y="0"/>
+            <a:ext cx="2218334" cy="384048"/>
+          </a:xfrm>
+          <a:prstGeom prst="rect">
+            <a:avLst/>
+          </a:prstGeom>
+          <a:noFill/>
+          <a:ln/>
+        </p:spPr>
+        <p:txBody>
+          <a:bodyPr wrap="square" lIns="0" tIns="0" rIns="0" bIns="0" rtlCol="0" anchor="ctr"/>
+          <a:lstStyle/>
+          <a:p>
+            <a:pPr algn="ctr" indent="0" marL="0">
+              <a:buNone/>
+            </a:pPr>
+            <a:r>
+              <a:rPr lang="en-US" sz="1000" u="none" spc="150" kern="0" dirty="0">
+                <a:solidFill>
+                  <a:srgbClr val="5A6B86"/>
+                </a:solidFill>
+                <a:hlinkClick r:id="rId5" action="ppaction://hlinksldjump" tooltip="Ir a Ficha técnica">
+                  <a:extLst>
+                    <a:ext uri="{A12FA001-AC4F-418D-AE19-62706E023703}">
+                      <ahyp:hlinkClr xmlns:ahyp="http://schemas.microsoft.com/office/drawing/2018/hyperlinkcolor" val="tx"/>
+                    </a:ext>
+                  </a:extLst>
+                </a:hlinkClick>
+              </a:rPr>
+              <a:t>FICHA TÉCNICA</a:t>
             </a:r>
             <a:endParaRPr lang="en-US" sz="1000" dirty="0"/>
           </a:p>
@@ -13359,7 +14532,7 @@
         <p:spPr>
           <a:xfrm>
             <a:off x="548640" y="0"/>
-            <a:ext cx="2772918" cy="384048"/>
+            <a:ext cx="2218334" cy="384048"/>
           </a:xfrm>
           <a:prstGeom prst="rect">
             <a:avLst/>
@@ -13401,8 +14574,8 @@
         </p:nvSpPr>
         <p:spPr>
           <a:xfrm>
-            <a:off x="3321558" y="0"/>
-            <a:ext cx="2772918" cy="384048"/>
+            <a:off x="2766974" y="0"/>
+            <a:ext cx="2218334" cy="384048"/>
           </a:xfrm>
           <a:prstGeom prst="rect">
             <a:avLst/>
@@ -13437,8 +14610,8 @@
         </p:nvSpPr>
         <p:spPr>
           <a:xfrm>
-            <a:off x="4153433" y="338328"/>
-            <a:ext cx="1109167" cy="45720"/>
+            <a:off x="3432475" y="338328"/>
+            <a:ext cx="887334" cy="45720"/>
           </a:xfrm>
           <a:prstGeom prst="rect">
             <a:avLst/>
@@ -13462,8 +14635,8 @@
         </p:nvSpPr>
         <p:spPr>
           <a:xfrm>
-            <a:off x="6094476" y="0"/>
-            <a:ext cx="2772918" cy="384048"/>
+            <a:off x="4985309" y="0"/>
+            <a:ext cx="2218334" cy="384048"/>
           </a:xfrm>
           <a:prstGeom prst="rect">
             <a:avLst/>
@@ -13505,8 +14678,8 @@
         </p:nvSpPr>
         <p:spPr>
           <a:xfrm>
-            <a:off x="8867394" y="0"/>
-            <a:ext cx="2772918" cy="384048"/>
+            <a:off x="7203643" y="0"/>
+            <a:ext cx="2218334" cy="384048"/>
           </a:xfrm>
           <a:prstGeom prst="rect">
             <a:avLst/>
@@ -13535,6 +14708,49 @@
                 </a:hlinkClick>
               </a:rPr>
               <a:t>PLAN Y RECOMENDACIÓN</a:t>
+            </a:r>
+            <a:endParaRPr lang="en-US" sz="1000" dirty="0"/>
+          </a:p>
+        </p:txBody>
+      </p:sp>
+      <p:sp>
+        <p:nvSpPr>
+          <p:cNvPr id="17" name="Pestaña Ficha técnica"/>
+          <p:cNvSpPr txBox="1"/>
+          <p:nvPr/>
+        </p:nvSpPr>
+        <p:spPr>
+          <a:xfrm>
+            <a:off x="9421978" y="0"/>
+            <a:ext cx="2218334" cy="384048"/>
+          </a:xfrm>
+          <a:prstGeom prst="rect">
+            <a:avLst/>
+          </a:prstGeom>
+          <a:noFill/>
+          <a:ln/>
+        </p:spPr>
+        <p:txBody>
+          <a:bodyPr wrap="square" lIns="0" tIns="0" rIns="0" bIns="0" rtlCol="0" anchor="ctr"/>
+          <a:lstStyle/>
+          <a:p>
+            <a:pPr algn="ctr" indent="0" marL="0">
+              <a:buNone/>
+            </a:pPr>
+            <a:r>
+              <a:rPr lang="en-US" sz="1000" u="none" spc="150" kern="0" dirty="0">
+                <a:solidFill>
+                  <a:srgbClr val="5A6B86"/>
+                </a:solidFill>
+                <a:hlinkClick r:id="rId4" action="ppaction://hlinksldjump" tooltip="Ir a Ficha técnica">
+                  <a:extLst>
+                    <a:ext uri="{A12FA001-AC4F-418D-AE19-62706E023703}">
+                      <ahyp:hlinkClr xmlns:ahyp="http://schemas.microsoft.com/office/drawing/2018/hyperlinkcolor" val="tx"/>
+                    </a:ext>
+                  </a:extLst>
+                </a:hlinkClick>
+              </a:rPr>
+              <a:t>FICHA TÉCNICA</a:t>
             </a:r>
             <a:endParaRPr lang="en-US" sz="1000" dirty="0"/>
           </a:p>
@@ -14395,7 +15611,7 @@
         <p:spPr>
           <a:xfrm>
             <a:off x="548640" y="0"/>
-            <a:ext cx="2772918" cy="384048"/>
+            <a:ext cx="2218334" cy="384048"/>
           </a:xfrm>
           <a:prstGeom prst="rect">
             <a:avLst/>
@@ -14437,8 +15653,8 @@
         </p:nvSpPr>
         <p:spPr>
           <a:xfrm>
-            <a:off x="3321558" y="0"/>
-            <a:ext cx="2772918" cy="384048"/>
+            <a:off x="2766974" y="0"/>
+            <a:ext cx="2218334" cy="384048"/>
           </a:xfrm>
           <a:prstGeom prst="rect">
             <a:avLst/>
@@ -14480,8 +15696,8 @@
         </p:nvSpPr>
         <p:spPr>
           <a:xfrm>
-            <a:off x="6094476" y="0"/>
-            <a:ext cx="2772918" cy="384048"/>
+            <a:off x="4985309" y="0"/>
+            <a:ext cx="2218334" cy="384048"/>
           </a:xfrm>
           <a:prstGeom prst="rect">
             <a:avLst/>
@@ -14516,8 +15732,8 @@
         </p:nvSpPr>
         <p:spPr>
           <a:xfrm>
-            <a:off x="6926351" y="338328"/>
-            <a:ext cx="1109167" cy="45720"/>
+            <a:off x="5650809" y="338328"/>
+            <a:ext cx="887334" cy="45720"/>
           </a:xfrm>
           <a:prstGeom prst="rect">
             <a:avLst/>
@@ -14541,8 +15757,8 @@
         </p:nvSpPr>
         <p:spPr>
           <a:xfrm>
-            <a:off x="8867394" y="0"/>
-            <a:ext cx="2772918" cy="384048"/>
+            <a:off x="7203643" y="0"/>
+            <a:ext cx="2218334" cy="384048"/>
           </a:xfrm>
           <a:prstGeom prst="rect">
             <a:avLst/>
@@ -14571,6 +15787,49 @@
                 </a:hlinkClick>
               </a:rPr>
               <a:t>PLAN Y RECOMENDACIÓN</a:t>
+            </a:r>
+            <a:endParaRPr lang="en-US" sz="1000" dirty="0"/>
+          </a:p>
+        </p:txBody>
+      </p:sp>
+      <p:sp>
+        <p:nvSpPr>
+          <p:cNvPr id="30" name="Pestaña Ficha técnica"/>
+          <p:cNvSpPr txBox="1"/>
+          <p:nvPr/>
+        </p:nvSpPr>
+        <p:spPr>
+          <a:xfrm>
+            <a:off x="9421978" y="0"/>
+            <a:ext cx="2218334" cy="384048"/>
+          </a:xfrm>
+          <a:prstGeom prst="rect">
+            <a:avLst/>
+          </a:prstGeom>
+          <a:noFill/>
+          <a:ln/>
+        </p:spPr>
+        <p:txBody>
+          <a:bodyPr wrap="square" lIns="0" tIns="0" rIns="0" bIns="0" rtlCol="0" anchor="ctr"/>
+          <a:lstStyle/>
+          <a:p>
+            <a:pPr algn="ctr" indent="0" marL="0">
+              <a:buNone/>
+            </a:pPr>
+            <a:r>
+              <a:rPr lang="en-US" sz="1000" u="none" spc="150" kern="0" dirty="0">
+                <a:solidFill>
+                  <a:srgbClr val="5A6B86"/>
+                </a:solidFill>
+                <a:hlinkClick r:id="rId5" action="ppaction://hlinksldjump" tooltip="Ir a Ficha técnica">
+                  <a:extLst>
+                    <a:ext uri="{A12FA001-AC4F-418D-AE19-62706E023703}">
+                      <ahyp:hlinkClr xmlns:ahyp="http://schemas.microsoft.com/office/drawing/2018/hyperlinkcolor" val="tx"/>
+                    </a:ext>
+                  </a:extLst>
+                </a:hlinkClick>
+              </a:rPr>
+              <a:t>FICHA TÉCNICA</a:t>
             </a:r>
             <a:endParaRPr lang="en-US" sz="1000" dirty="0"/>
           </a:p>
@@ -16161,7 +17420,7 @@
         <p:spPr>
           <a:xfrm>
             <a:off x="548640" y="0"/>
-            <a:ext cx="2772918" cy="384048"/>
+            <a:ext cx="2218334" cy="384048"/>
           </a:xfrm>
           <a:prstGeom prst="rect">
             <a:avLst/>
@@ -16203,8 +17462,8 @@
         </p:nvSpPr>
         <p:spPr>
           <a:xfrm>
-            <a:off x="3321558" y="0"/>
-            <a:ext cx="2772918" cy="384048"/>
+            <a:off x="2766974" y="0"/>
+            <a:ext cx="2218334" cy="384048"/>
           </a:xfrm>
           <a:prstGeom prst="rect">
             <a:avLst/>
@@ -16246,8 +17505,8 @@
         </p:nvSpPr>
         <p:spPr>
           <a:xfrm>
-            <a:off x="6094476" y="0"/>
-            <a:ext cx="2772918" cy="384048"/>
+            <a:off x="4985309" y="0"/>
+            <a:ext cx="2218334" cy="384048"/>
           </a:xfrm>
           <a:prstGeom prst="rect">
             <a:avLst/>
@@ -16289,8 +17548,8 @@
         </p:nvSpPr>
         <p:spPr>
           <a:xfrm>
-            <a:off x="8867394" y="0"/>
-            <a:ext cx="2772918" cy="384048"/>
+            <a:off x="7203643" y="0"/>
+            <a:ext cx="2218334" cy="384048"/>
           </a:xfrm>
           <a:prstGeom prst="rect">
             <a:avLst/>
@@ -16325,8 +17584,8 @@
         </p:nvSpPr>
         <p:spPr>
           <a:xfrm>
-            <a:off x="9699269" y="338328"/>
-            <a:ext cx="1109167" cy="45720"/>
+            <a:off x="7869144" y="338328"/>
+            <a:ext cx="887334" cy="45720"/>
           </a:xfrm>
           <a:prstGeom prst="rect">
             <a:avLst/>
@@ -16341,6 +17600,49 @@
             <a:prstDash val="solid"/>
           </a:ln>
         </p:spPr>
+      </p:sp>
+      <p:sp>
+        <p:nvSpPr>
+          <p:cNvPr id="53" name="Pestaña Ficha técnica"/>
+          <p:cNvSpPr txBox="1"/>
+          <p:nvPr/>
+        </p:nvSpPr>
+        <p:spPr>
+          <a:xfrm>
+            <a:off x="9421978" y="0"/>
+            <a:ext cx="2218334" cy="384048"/>
+          </a:xfrm>
+          <a:prstGeom prst="rect">
+            <a:avLst/>
+          </a:prstGeom>
+          <a:noFill/>
+          <a:ln/>
+        </p:spPr>
+        <p:txBody>
+          <a:bodyPr wrap="square" lIns="0" tIns="0" rIns="0" bIns="0" rtlCol="0" anchor="ctr"/>
+          <a:lstStyle/>
+          <a:p>
+            <a:pPr algn="ctr" indent="0" marL="0">
+              <a:buNone/>
+            </a:pPr>
+            <a:r>
+              <a:rPr lang="en-US" sz="1000" u="none" spc="150" kern="0" dirty="0">
+                <a:solidFill>
+                  <a:srgbClr val="5A6B86"/>
+                </a:solidFill>
+                <a:hlinkClick r:id="rId4" action="ppaction://hlinksldjump" tooltip="Ir a Ficha técnica">
+                  <a:extLst>
+                    <a:ext uri="{A12FA001-AC4F-418D-AE19-62706E023703}">
+                      <ahyp:hlinkClr xmlns:ahyp="http://schemas.microsoft.com/office/drawing/2018/hyperlinkcolor" val="tx"/>
+                    </a:ext>
+                  </a:extLst>
+                </a:hlinkClick>
+              </a:rPr>
+              <a:t>FICHA TÉCNICA</a:t>
+            </a:r>
+            <a:endParaRPr lang="en-US" sz="1000" dirty="0"/>
+          </a:p>
+        </p:txBody>
       </p:sp>
       <p:sp>
         <p:nvSpPr>
@@ -17258,7 +18560,7 @@
         <p:spPr>
           <a:xfrm>
             <a:off x="548640" y="0"/>
-            <a:ext cx="2772918" cy="384048"/>
+            <a:ext cx="2218334" cy="384048"/>
           </a:xfrm>
           <a:prstGeom prst="rect">
             <a:avLst/>
@@ -17300,8 +18602,8 @@
         </p:nvSpPr>
         <p:spPr>
           <a:xfrm>
-            <a:off x="3321558" y="0"/>
-            <a:ext cx="2772918" cy="384048"/>
+            <a:off x="2766974" y="0"/>
+            <a:ext cx="2218334" cy="384048"/>
           </a:xfrm>
           <a:prstGeom prst="rect">
             <a:avLst/>
@@ -17343,8 +18645,8 @@
         </p:nvSpPr>
         <p:spPr>
           <a:xfrm>
-            <a:off x="6094476" y="0"/>
-            <a:ext cx="2772918" cy="384048"/>
+            <a:off x="4985309" y="0"/>
+            <a:ext cx="2218334" cy="384048"/>
           </a:xfrm>
           <a:prstGeom prst="rect">
             <a:avLst/>
@@ -17386,8 +18688,8 @@
         </p:nvSpPr>
         <p:spPr>
           <a:xfrm>
-            <a:off x="8867394" y="0"/>
-            <a:ext cx="2772918" cy="384048"/>
+            <a:off x="7203643" y="0"/>
+            <a:ext cx="2218334" cy="384048"/>
           </a:xfrm>
           <a:prstGeom prst="rect">
             <a:avLst/>
@@ -17422,8 +18724,8 @@
         </p:nvSpPr>
         <p:spPr>
           <a:xfrm>
-            <a:off x="9699269" y="338328"/>
-            <a:ext cx="1109167" cy="45720"/>
+            <a:off x="7869144" y="338328"/>
+            <a:ext cx="887334" cy="45720"/>
           </a:xfrm>
           <a:prstGeom prst="rect">
             <a:avLst/>
@@ -17438,6 +18740,49 @@
             <a:prstDash val="solid"/>
           </a:ln>
         </p:spPr>
+      </p:sp>
+      <p:sp>
+        <p:nvSpPr>
+          <p:cNvPr id="29" name="Pestaña Ficha técnica"/>
+          <p:cNvSpPr txBox="1"/>
+          <p:nvPr/>
+        </p:nvSpPr>
+        <p:spPr>
+          <a:xfrm>
+            <a:off x="9421978" y="0"/>
+            <a:ext cx="2218334" cy="384048"/>
+          </a:xfrm>
+          <a:prstGeom prst="rect">
+            <a:avLst/>
+          </a:prstGeom>
+          <a:noFill/>
+          <a:ln/>
+        </p:spPr>
+        <p:txBody>
+          <a:bodyPr wrap="square" lIns="0" tIns="0" rIns="0" bIns="0" rtlCol="0" anchor="ctr"/>
+          <a:lstStyle/>
+          <a:p>
+            <a:pPr algn="ctr" indent="0" marL="0">
+              <a:buNone/>
+            </a:pPr>
+            <a:r>
+              <a:rPr lang="en-US" sz="1000" u="none" spc="150" kern="0" dirty="0">
+                <a:solidFill>
+                  <a:srgbClr val="5A6B86"/>
+                </a:solidFill>
+                <a:hlinkClick r:id="rId4" action="ppaction://hlinksldjump" tooltip="Ir a Ficha técnica">
+                  <a:extLst>
+                    <a:ext uri="{A12FA001-AC4F-418D-AE19-62706E023703}">
+                      <ahyp:hlinkClr xmlns:ahyp="http://schemas.microsoft.com/office/drawing/2018/hyperlinkcolor" val="tx"/>
+                    </a:ext>
+                  </a:extLst>
+                </a:hlinkClick>
+              </a:rPr>
+              <a:t>FICHA TÉCNICA</a:t>
+            </a:r>
+            <a:endParaRPr lang="en-US" sz="1000" dirty="0"/>
+          </a:p>
+        </p:txBody>
       </p:sp>
       <p:sp>
         <p:nvSpPr>
@@ -18334,7 +19679,7 @@
         <p:spPr>
           <a:xfrm>
             <a:off x="548640" y="0"/>
-            <a:ext cx="2772918" cy="384048"/>
+            <a:ext cx="2218334" cy="384048"/>
           </a:xfrm>
           <a:prstGeom prst="rect">
             <a:avLst/>
@@ -18376,8 +19721,8 @@
         </p:nvSpPr>
         <p:spPr>
           <a:xfrm>
-            <a:off x="3321558" y="0"/>
-            <a:ext cx="2772918" cy="384048"/>
+            <a:off x="2766974" y="0"/>
+            <a:ext cx="2218334" cy="384048"/>
           </a:xfrm>
           <a:prstGeom prst="rect">
             <a:avLst/>
@@ -18419,8 +19764,8 @@
         </p:nvSpPr>
         <p:spPr>
           <a:xfrm>
-            <a:off x="6094476" y="0"/>
-            <a:ext cx="2772918" cy="384048"/>
+            <a:off x="4985309" y="0"/>
+            <a:ext cx="2218334" cy="384048"/>
           </a:xfrm>
           <a:prstGeom prst="rect">
             <a:avLst/>
@@ -18462,8 +19807,8 @@
         </p:nvSpPr>
         <p:spPr>
           <a:xfrm>
-            <a:off x="8867394" y="0"/>
-            <a:ext cx="2772918" cy="384048"/>
+            <a:off x="7203643" y="0"/>
+            <a:ext cx="2218334" cy="384048"/>
           </a:xfrm>
           <a:prstGeom prst="rect">
             <a:avLst/>
@@ -18498,8 +19843,8 @@
         </p:nvSpPr>
         <p:spPr>
           <a:xfrm>
-            <a:off x="9699269" y="338328"/>
-            <a:ext cx="1109167" cy="45720"/>
+            <a:off x="7869144" y="338328"/>
+            <a:ext cx="887334" cy="45720"/>
           </a:xfrm>
           <a:prstGeom prst="rect">
             <a:avLst/>
@@ -18514,6 +19859,49 @@
             <a:prstDash val="solid"/>
           </a:ln>
         </p:spPr>
+      </p:sp>
+      <p:sp>
+        <p:nvSpPr>
+          <p:cNvPr id="33" name="Pestaña Ficha técnica"/>
+          <p:cNvSpPr txBox="1"/>
+          <p:nvPr/>
+        </p:nvSpPr>
+        <p:spPr>
+          <a:xfrm>
+            <a:off x="9421978" y="0"/>
+            <a:ext cx="2218334" cy="384048"/>
+          </a:xfrm>
+          <a:prstGeom prst="rect">
+            <a:avLst/>
+          </a:prstGeom>
+          <a:noFill/>
+          <a:ln/>
+        </p:spPr>
+        <p:txBody>
+          <a:bodyPr wrap="square" lIns="0" tIns="0" rIns="0" bIns="0" rtlCol="0" anchor="ctr"/>
+          <a:lstStyle/>
+          <a:p>
+            <a:pPr algn="ctr" indent="0" marL="0">
+              <a:buNone/>
+            </a:pPr>
+            <a:r>
+              <a:rPr lang="en-US" sz="1000" u="none" spc="150" kern="0" dirty="0">
+                <a:solidFill>
+                  <a:srgbClr val="AFC0DA"/>
+                </a:solidFill>
+                <a:hlinkClick r:id="rId11" action="ppaction://hlinksldjump" tooltip="Ir a Ficha técnica">
+                  <a:extLst>
+                    <a:ext uri="{A12FA001-AC4F-418D-AE19-62706E023703}">
+                      <ahyp:hlinkClr xmlns:ahyp="http://schemas.microsoft.com/office/drawing/2018/hyperlinkcolor" val="tx"/>
+                    </a:ext>
+                  </a:extLst>
+                </a:hlinkClick>
+              </a:rPr>
+              <a:t>FICHA TÉCNICA</a:t>
+            </a:r>
+            <a:endParaRPr lang="en-US" sz="1000" dirty="0"/>
+          </a:p>
+        </p:txBody>
       </p:sp>
       <p:sp>
         <p:nvSpPr>

</xml_diff>

<commit_message>
Pie de página sin repetir el autor
Co-Authored-By: Claude Opus 5.5 <noreply@anthropic.com>
Claude-Session: https://claude.ai/code/session_01RrEJtrwRidXxzgveZEVQjf
</commit_message>
<xml_diff>
--- a/presentaciones/Plan_Estrategico_Pennsylvania_2028.pptx
+++ b/presentaciones/Plan_Estrategico_Pennsylvania_2028.pptx
@@ -116,7 +116,7 @@
   <p:extLst>
     <p:ext uri="{521415D9-36F7-43E2-AB2F-B90AF26B5E84}">
       <p14:sectionLst xmlns:p14="http://schemas.microsoft.com/office/powerpoint/2010/main">
-        <p14:section name="Diagnóstico" id="{b6326cce-9be6-66df-06e9-8db0c3e993e9}">
+        <p14:section name="Diagnóstico" id="{62eb4b43-7cff-99f0-0aea-9829d5914911}">
           <p14:sldIdLst>
             <p14:sldId id="256"/>
             <p14:sldId id="257"/>
@@ -124,24 +124,24 @@
             <p14:sldId id="259"/>
           </p14:sldIdLst>
         </p14:section>
-        <p14:section name="Resultados 2024" id="{bb257b73-7b69-22b0-6da3-6acbec614371}">
+        <p14:section name="Resultados 2024" id="{0a7bf63f-2798-abcc-3da6-4d33ba802f3a}">
           <p14:sldIdLst>
             <p14:sldId id="260"/>
           </p14:sldIdLst>
         </p14:section>
-        <p14:section name="Meta" id="{f5d9d351-d8e9-1685-470c-c17839cee27c}">
+        <p14:section name="Meta" id="{3c3b31b7-85a9-4e2e-f725-f4c4c9526f3c}">
           <p14:sldIdLst>
             <p14:sldId id="261"/>
           </p14:sldIdLst>
         </p14:section>
-        <p14:section name="Plan y recomendación" id="{fdb269bf-a2aa-e003-22c3-cfee09074382}">
+        <p14:section name="Plan y recomendación" id="{501b6018-1047-6c94-5cd9-a0d349ac8795}">
           <p14:sldIdLst>
             <p14:sldId id="262"/>
             <p14:sldId id="263"/>
             <p14:sldId id="264"/>
           </p14:sldIdLst>
         </p14:section>
-        <p14:section name="Ficha técnica" id="{ca45b114-b65f-fe28-8feb-f4bd18f41d9a}">
+        <p14:section name="Ficha técnica" id="{7bbff149-039e-871f-489d-ff95cb8a0378}">
           <p14:sldIdLst>
             <p14:sldId id="265"/>
           </p14:sldIdLst>
@@ -2287,7 +2287,7 @@
                   <a:schemeClr val="accent4"/>
                 </a:solidFill>
               </a:rPr>
-              <a:t>Plan Estratégico Pennsylvania 2028 · Preparado por Orlando Castillo</a:t>
+              <a:t>Plan Estratégico Pennsylvania 2028</a:t>
             </a:r>
             <a:endParaRPr lang="en-US" sz="1000" dirty="0"/>
           </a:p>
@@ -2400,7 +2400,7 @@
                   <a:schemeClr val="accent4"/>
                 </a:solidFill>
               </a:rPr>
-              <a:t>Plan Estratégico Pennsylvania 2028 · Preparado por Orlando Castillo</a:t>
+              <a:t>Plan Estratégico Pennsylvania 2028</a:t>
             </a:r>
             <a:endParaRPr lang="en-US" sz="1000" dirty="0"/>
           </a:p>

</xml_diff>

<commit_message>
Foto del autor en la portada y en el encabezado web
Co-Authored-By: Claude Opus 5.5 <noreply@anthropic.com>
Claude-Session: https://claude.ai/code/session_01RrEJtrwRidXxzgveZEVQjf
</commit_message>
<xml_diff>
--- a/presentaciones/Plan_Estrategico_Pennsylvania_2028.pptx
+++ b/presentaciones/Plan_Estrategico_Pennsylvania_2028.pptx
@@ -116,7 +116,7 @@
   <p:extLst>
     <p:ext uri="{521415D9-36F7-43E2-AB2F-B90AF26B5E84}">
       <p14:sectionLst xmlns:p14="http://schemas.microsoft.com/office/powerpoint/2010/main">
-        <p14:section name="Diagnóstico" id="{62eb4b43-7cff-99f0-0aea-9829d5914911}">
+        <p14:section name="Diagnóstico" id="{da9b0343-8fd6-400a-c7fb-4b69437b0366}">
           <p14:sldIdLst>
             <p14:sldId id="256"/>
             <p14:sldId id="257"/>
@@ -124,24 +124,24 @@
             <p14:sldId id="259"/>
           </p14:sldIdLst>
         </p14:section>
-        <p14:section name="Resultados 2024" id="{0a7bf63f-2798-abcc-3da6-4d33ba802f3a}">
+        <p14:section name="Resultados 2024" id="{b774773a-cce1-e1f9-ef22-54232b07966d}">
           <p14:sldIdLst>
             <p14:sldId id="260"/>
           </p14:sldIdLst>
         </p14:section>
-        <p14:section name="Meta" id="{3c3b31b7-85a9-4e2e-f725-f4c4c9526f3c}">
+        <p14:section name="Meta" id="{6b0518f2-be18-8bc1-19fd-bb63312582e1}">
           <p14:sldIdLst>
             <p14:sldId id="261"/>
           </p14:sldIdLst>
         </p14:section>
-        <p14:section name="Plan y recomendación" id="{501b6018-1047-6c94-5cd9-a0d349ac8795}">
+        <p14:section name="Plan y recomendación" id="{80e8500c-b06d-81f5-b132-db3f44972462}">
           <p14:sldIdLst>
             <p14:sldId id="262"/>
             <p14:sldId id="263"/>
             <p14:sldId id="264"/>
           </p14:sldIdLst>
         </p14:section>
-        <p14:section name="Ficha técnica" id="{7bbff149-039e-871f-489d-ff95cb8a0378}">
+        <p14:section name="Ficha técnica" id="{8c2ed107-cf58-e3da-76af-e4a241727a33}">
           <p14:sldIdLst>
             <p14:sldId id="265"/>
           </p14:sldIdLst>
@@ -2847,8 +2847,8 @@
         </p:nvSpPr>
         <p:spPr>
           <a:xfrm>
-            <a:off x="548640" y="685800"/>
-            <a:ext cx="7223760" cy="914400"/>
+            <a:off x="1691640" y="749808"/>
+            <a:ext cx="6080760" cy="822960"/>
           </a:xfrm>
           <a:prstGeom prst="rect">
             <a:avLst/>
@@ -2857,7 +2857,7 @@
           <a:ln/>
         </p:spPr>
         <p:txBody>
-          <a:bodyPr wrap="square" lIns="0" tIns="0" rIns="0" bIns="0" rtlCol="0" anchor="t"/>
+          <a:bodyPr wrap="square" lIns="0" tIns="0" rIns="0" bIns="0" rtlCol="0" anchor="ctr"/>
           <a:lstStyle/>
           <a:p>
             <a:pPr indent="0" marL="0">
@@ -2891,7 +2891,56 @@
       </p:sp>
       <p:sp>
         <p:nvSpPr>
-          <p:cNvPr id="3" name="Text 1"/>
+          <p:cNvPr id="3" name="Marco foto"/>
+          <p:cNvSpPr/>
+          <p:nvPr/>
+        </p:nvSpPr>
+        <p:spPr>
+          <a:xfrm>
+            <a:off x="521208" y="630936"/>
+            <a:ext cx="1060704" cy="1060704"/>
+          </a:xfrm>
+          <a:prstGeom prst="ellipse">
+            <a:avLst/>
+          </a:prstGeom>
+          <a:solidFill>
+            <a:schemeClr val="bg1"/>
+          </a:solidFill>
+          <a:ln w="12700">
+            <a:solidFill>
+              <a:schemeClr val="bg1"/>
+            </a:solidFill>
+            <a:prstDash val="solid"/>
+          </a:ln>
+        </p:spPr>
+      </p:sp>
+      <p:pic>
+        <p:nvPicPr>
+          <p:cNvPr id="4" name="Foto Orlando Castillo" descr="Orlando Castillo">    </p:cNvPr>
+          <p:cNvPicPr>
+            <a:picLocks noChangeAspect="1"/>
+          </p:cNvPicPr>
+          <p:nvPr/>
+        </p:nvPicPr>
+        <p:blipFill>
+          <a:blip r:embed="rId1"/>
+          <a:stretch>
+            <a:fillRect/>
+          </a:stretch>
+        </p:blipFill>
+        <p:spPr>
+          <a:xfrm>
+            <a:off x="548640" y="658368"/>
+            <a:ext cx="1005840" cy="1005840"/>
+          </a:xfrm>
+          <a:prstGeom prst="rect">
+            <a:avLst/>
+          </a:prstGeom>
+        </p:spPr>
+      </p:pic>
+      <p:sp>
+        <p:nvSpPr>
+          <p:cNvPr id="5" name="Text 2"/>
           <p:cNvSpPr txBox="1"/>
           <p:nvPr/>
         </p:nvSpPr>
@@ -2927,7 +2976,7 @@
       </p:sp>
       <p:sp>
         <p:nvSpPr>
-          <p:cNvPr id="4" name="Titulo"/>
+          <p:cNvPr id="6" name="Titulo"/>
           <p:cNvSpPr txBox="1"/>
           <p:nvPr/>
         </p:nvSpPr>
@@ -2966,7 +3015,7 @@
       </p:sp>
       <p:graphicFrame>
         <p:nvGraphicFramePr>
-          <p:cNvPr id="5" name="Participacion" descr=""/>
+          <p:cNvPr id="7" name="Participacion" descr=""/>
           <p:cNvGraphicFramePr/>
           <p:nvPr/>
         </p:nvGraphicFramePr>
@@ -2976,13 +3025,13 @@
         </p:xfrm>
         <a:graphic xmlns:a="http://schemas.openxmlformats.org/drawingml/2006/main">
           <a:graphicData uri="http://schemas.openxmlformats.org/drawingml/2006/chart">
-            <c:chart xmlns:c="http://schemas.openxmlformats.org/drawingml/2006/chart" r:id="rId1"/>
+            <c:chart xmlns:c="http://schemas.openxmlformats.org/drawingml/2006/chart" r:id="rId2"/>
           </a:graphicData>
         </a:graphic>
       </p:graphicFrame>
       <p:sp>
         <p:nvSpPr>
-          <p:cNvPr id="6" name="Text 3"/>
+          <p:cNvPr id="8" name="Text 4"/>
           <p:cNvSpPr txBox="1"/>
           <p:nvPr/>
         </p:nvSpPr>
@@ -3032,7 +3081,7 @@
       </p:sp>
       <p:sp>
         <p:nvSpPr>
-          <p:cNvPr id="7" name="Dato 1"/>
+          <p:cNvPr id="9" name="Dato 1"/>
           <p:cNvSpPr/>
           <p:nvPr/>
         </p:nvSpPr>
@@ -3063,7 +3112,7 @@
       </p:sp>
       <p:sp>
         <p:nvSpPr>
-          <p:cNvPr id="8" name="Text 5"/>
+          <p:cNvPr id="10" name="Text 6"/>
           <p:cNvSpPr txBox="1"/>
           <p:nvPr/>
         </p:nvSpPr>
@@ -3113,7 +3162,7 @@
       </p:sp>
       <p:sp>
         <p:nvSpPr>
-          <p:cNvPr id="9" name="Dato 2"/>
+          <p:cNvPr id="11" name="Dato 2"/>
           <p:cNvSpPr/>
           <p:nvPr/>
         </p:nvSpPr>
@@ -3144,7 +3193,7 @@
       </p:sp>
       <p:sp>
         <p:nvSpPr>
-          <p:cNvPr id="10" name="Text 7"/>
+          <p:cNvPr id="12" name="Text 8"/>
           <p:cNvSpPr txBox="1"/>
           <p:nvPr/>
         </p:nvSpPr>
@@ -3194,7 +3243,7 @@
       </p:sp>
       <p:sp>
         <p:nvSpPr>
-          <p:cNvPr id="11" name="Dato 3"/>
+          <p:cNvPr id="13" name="Dato 3"/>
           <p:cNvSpPr/>
           <p:nvPr/>
         </p:nvSpPr>
@@ -3225,7 +3274,7 @@
       </p:sp>
       <p:sp>
         <p:nvSpPr>
-          <p:cNvPr id="12" name="Text 9"/>
+          <p:cNvPr id="14" name="Text 10"/>
           <p:cNvSpPr txBox="1"/>
           <p:nvPr/>
         </p:nvSpPr>
@@ -3275,7 +3324,7 @@
       </p:sp>
       <p:sp>
         <p:nvSpPr>
-          <p:cNvPr id="13" name="Dato 4"/>
+          <p:cNvPr id="15" name="Dato 4"/>
           <p:cNvSpPr/>
           <p:nvPr/>
         </p:nvSpPr>
@@ -3306,7 +3355,7 @@
       </p:sp>
       <p:sp>
         <p:nvSpPr>
-          <p:cNvPr id="14" name="Text 11"/>
+          <p:cNvPr id="16" name="Text 12"/>
           <p:cNvSpPr txBox="1"/>
           <p:nvPr/>
         </p:nvSpPr>
@@ -3356,7 +3405,7 @@
       </p:sp>
       <p:sp>
         <p:nvSpPr>
-          <p:cNvPr id="15" name="Text 12"/>
+          <p:cNvPr id="17" name="Text 13"/>
           <p:cNvSpPr txBox="1"/>
           <p:nvPr/>
         </p:nvSpPr>
@@ -3392,7 +3441,7 @@
       </p:sp>
       <p:sp>
         <p:nvSpPr>
-          <p:cNvPr id="17" name="Barra de navegación"/>
+          <p:cNvPr id="19" name="Barra de navegación"/>
           <p:cNvSpPr/>
           <p:nvPr/>
         </p:nvSpPr>
@@ -3417,7 +3466,7 @@
       </p:sp>
       <p:sp>
         <p:nvSpPr>
-          <p:cNvPr id="18" name="Shape 14"/>
+          <p:cNvPr id="20" name="Shape 15"/>
           <p:cNvSpPr/>
           <p:nvPr/>
         </p:nvSpPr>
@@ -3440,7 +3489,7 @@
       </p:sp>
       <p:sp>
         <p:nvSpPr>
-          <p:cNvPr id="19" name="Pestaña Diagnóstico"/>
+          <p:cNvPr id="21" name="Pestaña Diagnóstico"/>
           <p:cNvSpPr txBox="1"/>
           <p:nvPr/>
         </p:nvSpPr>
@@ -3476,7 +3525,7 @@
       </p:sp>
       <p:sp>
         <p:nvSpPr>
-          <p:cNvPr id="20" name="Sección actual"/>
+          <p:cNvPr id="22" name="Sección actual"/>
           <p:cNvSpPr/>
           <p:nvPr/>
         </p:nvSpPr>
@@ -3501,7 +3550,7 @@
       </p:sp>
       <p:sp>
         <p:nvSpPr>
-          <p:cNvPr id="21" name="Pestaña Resultados 2024"/>
+          <p:cNvPr id="23" name="Pestaña Resultados 2024"/>
           <p:cNvSpPr txBox="1"/>
           <p:nvPr/>
         </p:nvSpPr>
@@ -3528,7 +3577,7 @@
                 <a:solidFill>
                   <a:srgbClr val="AFC0DA"/>
                 </a:solidFill>
-                <a:hlinkClick r:id="rId2" action="ppaction://hlinksldjump" tooltip="Ir a Resultados 2024">
+                <a:hlinkClick r:id="rId3" action="ppaction://hlinksldjump" tooltip="Ir a Resultados 2024">
                   <a:extLst>
                     <a:ext uri="{A12FA001-AC4F-418D-AE19-62706E023703}">
                       <ahyp:hlinkClr xmlns:ahyp="http://schemas.microsoft.com/office/drawing/2018/hyperlinkcolor" val="tx"/>
@@ -3544,7 +3593,7 @@
       </p:sp>
       <p:sp>
         <p:nvSpPr>
-          <p:cNvPr id="22" name="Pestaña Meta"/>
+          <p:cNvPr id="24" name="Pestaña Meta"/>
           <p:cNvSpPr txBox="1"/>
           <p:nvPr/>
         </p:nvSpPr>
@@ -3571,7 +3620,7 @@
                 <a:solidFill>
                   <a:srgbClr val="AFC0DA"/>
                 </a:solidFill>
-                <a:hlinkClick r:id="rId3" action="ppaction://hlinksldjump" tooltip="Ir a Meta">
+                <a:hlinkClick r:id="rId4" action="ppaction://hlinksldjump" tooltip="Ir a Meta">
                   <a:extLst>
                     <a:ext uri="{A12FA001-AC4F-418D-AE19-62706E023703}">
                       <ahyp:hlinkClr xmlns:ahyp="http://schemas.microsoft.com/office/drawing/2018/hyperlinkcolor" val="tx"/>
@@ -3587,7 +3636,7 @@
       </p:sp>
       <p:sp>
         <p:nvSpPr>
-          <p:cNvPr id="23" name="Pestaña Plan y recomendación"/>
+          <p:cNvPr id="25" name="Pestaña Plan y recomendación"/>
           <p:cNvSpPr txBox="1"/>
           <p:nvPr/>
         </p:nvSpPr>
@@ -3614,7 +3663,7 @@
                 <a:solidFill>
                   <a:srgbClr val="AFC0DA"/>
                 </a:solidFill>
-                <a:hlinkClick r:id="rId4" action="ppaction://hlinksldjump" tooltip="Ir a Plan y recomendación">
+                <a:hlinkClick r:id="rId5" action="ppaction://hlinksldjump" tooltip="Ir a Plan y recomendación">
                   <a:extLst>
                     <a:ext uri="{A12FA001-AC4F-418D-AE19-62706E023703}">
                       <ahyp:hlinkClr xmlns:ahyp="http://schemas.microsoft.com/office/drawing/2018/hyperlinkcolor" val="tx"/>
@@ -3630,7 +3679,7 @@
       </p:sp>
       <p:sp>
         <p:nvSpPr>
-          <p:cNvPr id="24" name="Pestaña Ficha técnica"/>
+          <p:cNvPr id="26" name="Pestaña Ficha técnica"/>
           <p:cNvSpPr txBox="1"/>
           <p:nvPr/>
         </p:nvSpPr>
@@ -3657,7 +3706,7 @@
                 <a:solidFill>
                   <a:srgbClr val="AFC0DA"/>
                 </a:solidFill>
-                <a:hlinkClick r:id="rId5" action="ppaction://hlinksldjump" tooltip="Ir a Ficha técnica">
+                <a:hlinkClick r:id="rId6" action="ppaction://hlinksldjump" tooltip="Ir a Ficha técnica">
                   <a:extLst>
                     <a:ext uri="{A12FA001-AC4F-418D-AE19-62706E023703}">
                       <ahyp:hlinkClr xmlns:ahyp="http://schemas.microsoft.com/office/drawing/2018/hyperlinkcolor" val="tx"/>

</xml_diff>

<commit_message>
Foto del autor en alta resolución; PDF sin reducir imágenes; versión web más nítida
Co-Authored-By: Claude Opus 5.5 <noreply@anthropic.com>
Claude-Session: https://claude.ai/code/session_01RrEJtrwRidXxzgveZEVQjf
</commit_message>
<xml_diff>
--- a/presentaciones/Plan_Estrategico_Pennsylvania_2028.pptx
+++ b/presentaciones/Plan_Estrategico_Pennsylvania_2028.pptx
@@ -116,7 +116,7 @@
   <p:extLst>
     <p:ext uri="{521415D9-36F7-43E2-AB2F-B90AF26B5E84}">
       <p14:sectionLst xmlns:p14="http://schemas.microsoft.com/office/powerpoint/2010/main">
-        <p14:section name="Diagnóstico" id="{da9b0343-8fd6-400a-c7fb-4b69437b0366}">
+        <p14:section name="Diagnóstico" id="{b3de8821-f2b8-f486-f5ad-4e66a626fc50}">
           <p14:sldIdLst>
             <p14:sldId id="256"/>
             <p14:sldId id="257"/>
@@ -124,24 +124,24 @@
             <p14:sldId id="259"/>
           </p14:sldIdLst>
         </p14:section>
-        <p14:section name="Resultados 2024" id="{b774773a-cce1-e1f9-ef22-54232b07966d}">
+        <p14:section name="Resultados 2024" id="{94af91e3-19b2-1b99-f4a7-2fd266cbfc75}">
           <p14:sldIdLst>
             <p14:sldId id="260"/>
           </p14:sldIdLst>
         </p14:section>
-        <p14:section name="Meta" id="{6b0518f2-be18-8bc1-19fd-bb63312582e1}">
+        <p14:section name="Meta" id="{3f9fd04f-3e15-ca81-fdb7-347dac4c9467}">
           <p14:sldIdLst>
             <p14:sldId id="261"/>
           </p14:sldIdLst>
         </p14:section>
-        <p14:section name="Plan y recomendación" id="{80e8500c-b06d-81f5-b132-db3f44972462}">
+        <p14:section name="Plan y recomendación" id="{44d73999-56ae-a2ec-f717-4fb68adc2fd7}">
           <p14:sldIdLst>
             <p14:sldId id="262"/>
             <p14:sldId id="263"/>
             <p14:sldId id="264"/>
           </p14:sldIdLst>
         </p14:section>
-        <p14:section name="Ficha técnica" id="{8c2ed107-cf58-e3da-76af-e4a241727a33}">
+        <p14:section name="Ficha técnica" id="{cb0fb4ef-6b9d-8a66-0035-b0e296af570f}">
           <p14:sldIdLst>
             <p14:sldId id="265"/>
           </p14:sldIdLst>

</xml_diff>